<commit_message>
Show questions before week 5 lecture answer reveals
</commit_message>
<xml_diff>
--- a/lendet/2026-2027/mobile/lectures/ligjerata-05-hyrja-lejet-rideshare-2026.pptx
+++ b/lendet/2026-2027/mobile/lectures/ligjerata-05-hyrja-lejet-rideshare-2026.pptx
@@ -2,28 +2,28 @@
 <file path=ppt/presentation.xml><?xml version="1.0" encoding="utf-8"?>
 <p:presentation xmlns:p="http://schemas.openxmlformats.org/presentationml/2006/main">
   <p:sldMasterIdLst>
-    <p:sldMasterId xmlns:r="http://schemas.openxmlformats.org/officeDocument/2006/relationships" id="2147483648" r:id="R0e510226a2a945b5"/>
+    <p:sldMasterId xmlns:r="http://schemas.openxmlformats.org/officeDocument/2006/relationships" id="2147483648" r:id="Ra426369c7da84d5a"/>
   </p:sldMasterIdLst>
   <p:sldIdLst>
-    <p:sldId xmlns:r="http://schemas.openxmlformats.org/officeDocument/2006/relationships" id="256" r:id="R4988a1bfc8ab406d"/>
-    <p:sldId xmlns:r="http://schemas.openxmlformats.org/officeDocument/2006/relationships" id="257" r:id="R2033f42ad3f54df1"/>
-    <p:sldId xmlns:r="http://schemas.openxmlformats.org/officeDocument/2006/relationships" id="258" r:id="Rbdc40740b2064c9b"/>
-    <p:sldId xmlns:r="http://schemas.openxmlformats.org/officeDocument/2006/relationships" id="259" r:id="Rfe3d39ff2b824d0d"/>
-    <p:sldId xmlns:r="http://schemas.openxmlformats.org/officeDocument/2006/relationships" id="260" r:id="R9937e8d0253340c4"/>
-    <p:sldId xmlns:r="http://schemas.openxmlformats.org/officeDocument/2006/relationships" id="261" r:id="R5bb4642e8daf4ca0"/>
-    <p:sldId xmlns:r="http://schemas.openxmlformats.org/officeDocument/2006/relationships" id="262" r:id="R87504c2952434552"/>
-    <p:sldId xmlns:r="http://schemas.openxmlformats.org/officeDocument/2006/relationships" id="263" r:id="R2618e826a8f34676"/>
-    <p:sldId xmlns:r="http://schemas.openxmlformats.org/officeDocument/2006/relationships" id="264" r:id="R1087d80c7db34a07"/>
-    <p:sldId xmlns:r="http://schemas.openxmlformats.org/officeDocument/2006/relationships" id="265" r:id="Rdada7b2b69f14a66"/>
-    <p:sldId xmlns:r="http://schemas.openxmlformats.org/officeDocument/2006/relationships" id="266" r:id="R6acc14c20e2c4f9f"/>
-    <p:sldId xmlns:r="http://schemas.openxmlformats.org/officeDocument/2006/relationships" id="267" r:id="R6d3b388979fa4b01"/>
-    <p:sldId xmlns:r="http://schemas.openxmlformats.org/officeDocument/2006/relationships" id="268" r:id="R69fbd0971d4342c7"/>
-    <p:sldId xmlns:r="http://schemas.openxmlformats.org/officeDocument/2006/relationships" id="269" r:id="Rb34102e4fcc2482d"/>
-    <p:sldId xmlns:r="http://schemas.openxmlformats.org/officeDocument/2006/relationships" id="270" r:id="R492f5f09d088441e"/>
-    <p:sldId xmlns:r="http://schemas.openxmlformats.org/officeDocument/2006/relationships" id="271" r:id="Rc2a0a32085c240bf"/>
-    <p:sldId xmlns:r="http://schemas.openxmlformats.org/officeDocument/2006/relationships" id="272" r:id="R721bbdf4739a4af2"/>
-    <p:sldId xmlns:r="http://schemas.openxmlformats.org/officeDocument/2006/relationships" id="273" r:id="R967d3bfe606e4968"/>
-    <p:sldId xmlns:r="http://schemas.openxmlformats.org/officeDocument/2006/relationships" id="274" r:id="R69578771321c40ba"/>
+    <p:sldId xmlns:r="http://schemas.openxmlformats.org/officeDocument/2006/relationships" id="256" r:id="R2a8e3bd143c446b2"/>
+    <p:sldId xmlns:r="http://schemas.openxmlformats.org/officeDocument/2006/relationships" id="257" r:id="R02b91bbb06214b13"/>
+    <p:sldId xmlns:r="http://schemas.openxmlformats.org/officeDocument/2006/relationships" id="258" r:id="Rc9e00d0e31744f44"/>
+    <p:sldId xmlns:r="http://schemas.openxmlformats.org/officeDocument/2006/relationships" id="259" r:id="R6d23df6b3bc144c5"/>
+    <p:sldId xmlns:r="http://schemas.openxmlformats.org/officeDocument/2006/relationships" id="260" r:id="R7a3b1c2f58a541a1"/>
+    <p:sldId xmlns:r="http://schemas.openxmlformats.org/officeDocument/2006/relationships" id="261" r:id="Rb9c0228945054bb2"/>
+    <p:sldId xmlns:r="http://schemas.openxmlformats.org/officeDocument/2006/relationships" id="262" r:id="Ra68adaa108544636"/>
+    <p:sldId xmlns:r="http://schemas.openxmlformats.org/officeDocument/2006/relationships" id="263" r:id="Rc4973a53bcfe426a"/>
+    <p:sldId xmlns:r="http://schemas.openxmlformats.org/officeDocument/2006/relationships" id="264" r:id="R26dd1264523e4185"/>
+    <p:sldId xmlns:r="http://schemas.openxmlformats.org/officeDocument/2006/relationships" id="265" r:id="R27040c45003b44b6"/>
+    <p:sldId xmlns:r="http://schemas.openxmlformats.org/officeDocument/2006/relationships" id="266" r:id="R6c54e096fd1f4b5d"/>
+    <p:sldId xmlns:r="http://schemas.openxmlformats.org/officeDocument/2006/relationships" id="267" r:id="R0482c50e48064147"/>
+    <p:sldId xmlns:r="http://schemas.openxmlformats.org/officeDocument/2006/relationships" id="268" r:id="R0dd6b6e5ed6a4b0b"/>
+    <p:sldId xmlns:r="http://schemas.openxmlformats.org/officeDocument/2006/relationships" id="269" r:id="R2cd4dfef9da74b74"/>
+    <p:sldId xmlns:r="http://schemas.openxmlformats.org/officeDocument/2006/relationships" id="270" r:id="R940d315431b5480c"/>
+    <p:sldId xmlns:r="http://schemas.openxmlformats.org/officeDocument/2006/relationships" id="271" r:id="R3d5ffc5941854317"/>
+    <p:sldId xmlns:r="http://schemas.openxmlformats.org/officeDocument/2006/relationships" id="272" r:id="R854f155fbc0246df"/>
+    <p:sldId xmlns:r="http://schemas.openxmlformats.org/officeDocument/2006/relationships" id="273" r:id="R438f772d8c82435c"/>
+    <p:sldId xmlns:r="http://schemas.openxmlformats.org/officeDocument/2006/relationships" id="274" r:id="Rd2474d301dc3490f"/>
   </p:sldIdLst>
   <p:sldSz cx="12192000" cy="6858000"/>
   <p:notesSz cx="6858000" cy="9144000"/>
@@ -47,7 +47,7 @@
           <p:cNvPr id="3" name="Title">
             <a:extLst xmlns:a="http://schemas.openxmlformats.org/drawingml/2006/main">
               <a:ext uri="{FF2B5EF4-FFF2-40B4-BE49-F238E27FC236}">
-                <a16:creationId xmlns:a16="http://schemas.microsoft.com/office/drawing/2014/main" id="{15490EB2-1442-4942-AC02-F30D1C8CA3C3}"/>
+                <a16:creationId xmlns:a16="http://schemas.microsoft.com/office/drawing/2014/main" id="{396B5520-02A7-4950-A1CD-C1B80A6BB0A7}"/>
               </a:ext>
             </a:extLst>
           </p:cNvPr>
@@ -204,7 +204,7 @@
           <p:cNvPr id="2" name="Subtitle">
             <a:extLst xmlns:a="http://schemas.openxmlformats.org/drawingml/2006/main">
               <a:ext uri="{FF2B5EF4-FFF2-40B4-BE49-F238E27FC236}">
-                <a16:creationId xmlns:a16="http://schemas.microsoft.com/office/drawing/2014/main" id="{61E1FEFB-1B77-4ED7-BD59-FB3787A0471B}"/>
+                <a16:creationId xmlns:a16="http://schemas.microsoft.com/office/drawing/2014/main" id="{8B45324E-8910-428B-8CED-969AE48A5C2E}"/>
               </a:ext>
             </a:extLst>
           </p:cNvPr>
@@ -378,7 +378,7 @@
           <p:cNvPr id="2" name="Section title">
             <a:extLst xmlns:a="http://schemas.openxmlformats.org/drawingml/2006/main">
               <a:ext uri="{FF2B5EF4-FFF2-40B4-BE49-F238E27FC236}">
-                <a16:creationId xmlns:a16="http://schemas.microsoft.com/office/drawing/2014/main" id="{81A4CC21-3976-4278-AFC2-E47E4952844E}"/>
+                <a16:creationId xmlns:a16="http://schemas.microsoft.com/office/drawing/2014/main" id="{452F06C6-EAE1-4FC8-98D6-63694A339708}"/>
               </a:ext>
             </a:extLst>
           </p:cNvPr>
@@ -552,7 +552,7 @@
           <p:cNvPr id="3" name="Title">
             <a:extLst xmlns:a="http://schemas.openxmlformats.org/drawingml/2006/main">
               <a:ext uri="{FF2B5EF4-FFF2-40B4-BE49-F238E27FC236}">
-                <a16:creationId xmlns:a16="http://schemas.microsoft.com/office/drawing/2014/main" id="{DDED69E2-2B8A-4D38-B390-A445DC77338B}"/>
+                <a16:creationId xmlns:a16="http://schemas.microsoft.com/office/drawing/2014/main" id="{D226925C-3E2A-481D-850B-982356F7E031}"/>
               </a:ext>
             </a:extLst>
           </p:cNvPr>
@@ -709,7 +709,7 @@
           <p:cNvPr id="2" name="Body">
             <a:extLst xmlns:a="http://schemas.openxmlformats.org/drawingml/2006/main">
               <a:ext uri="{FF2B5EF4-FFF2-40B4-BE49-F238E27FC236}">
-                <a16:creationId xmlns:a16="http://schemas.microsoft.com/office/drawing/2014/main" id="{2EDE087C-5BE2-400C-87C8-72C2281C9EEB}"/>
+                <a16:creationId xmlns:a16="http://schemas.microsoft.com/office/drawing/2014/main" id="{F60C56BA-D168-4FA6-8C52-3D3568618429}"/>
               </a:ext>
             </a:extLst>
           </p:cNvPr>
@@ -883,7 +883,7 @@
           <p:cNvPr id="4" name="Title">
             <a:extLst xmlns:a="http://schemas.openxmlformats.org/drawingml/2006/main">
               <a:ext uri="{FF2B5EF4-FFF2-40B4-BE49-F238E27FC236}">
-                <a16:creationId xmlns:a16="http://schemas.microsoft.com/office/drawing/2014/main" id="{F49B2AAF-5CB9-4B72-AED2-8658F9F4734F}"/>
+                <a16:creationId xmlns:a16="http://schemas.microsoft.com/office/drawing/2014/main" id="{734A069E-1DB6-4228-888B-5E75C81C478F}"/>
               </a:ext>
             </a:extLst>
           </p:cNvPr>
@@ -1040,7 +1040,7 @@
           <p:cNvPr id="2" name="Left column">
             <a:extLst xmlns:a="http://schemas.openxmlformats.org/drawingml/2006/main">
               <a:ext uri="{FF2B5EF4-FFF2-40B4-BE49-F238E27FC236}">
-                <a16:creationId xmlns:a16="http://schemas.microsoft.com/office/drawing/2014/main" id="{6C59D081-DE24-420B-AF10-007DF116F90A}"/>
+                <a16:creationId xmlns:a16="http://schemas.microsoft.com/office/drawing/2014/main" id="{E1977A06-8A77-484C-9961-CFFBF20E0332}"/>
               </a:ext>
             </a:extLst>
           </p:cNvPr>
@@ -1197,7 +1197,7 @@
           <p:cNvPr id="3" name="Right column">
             <a:extLst xmlns:a="http://schemas.openxmlformats.org/drawingml/2006/main">
               <a:ext uri="{FF2B5EF4-FFF2-40B4-BE49-F238E27FC236}">
-                <a16:creationId xmlns:a16="http://schemas.microsoft.com/office/drawing/2014/main" id="{A78FB5F4-0D5B-412E-A28E-EB670FA6549C}"/>
+                <a16:creationId xmlns:a16="http://schemas.microsoft.com/office/drawing/2014/main" id="{E5D16D24-F0F9-4BBA-A451-641A540588CD}"/>
               </a:ext>
             </a:extLst>
           </p:cNvPr>
@@ -1371,7 +1371,7 @@
           <p:cNvPr id="3" name="Title">
             <a:extLst xmlns:a="http://schemas.openxmlformats.org/drawingml/2006/main">
               <a:ext uri="{FF2B5EF4-FFF2-40B4-BE49-F238E27FC236}">
-                <a16:creationId xmlns:a16="http://schemas.microsoft.com/office/drawing/2014/main" id="{714304C7-978C-4658-8F7A-56D953353EBE}"/>
+                <a16:creationId xmlns:a16="http://schemas.microsoft.com/office/drawing/2014/main" id="{1C076A52-5DEA-4A1A-AC25-677FE7AFDDBA}"/>
               </a:ext>
             </a:extLst>
           </p:cNvPr>
@@ -1528,7 +1528,7 @@
           <p:cNvPr id="2" name="Left column">
             <a:extLst xmlns:a="http://schemas.openxmlformats.org/drawingml/2006/main">
               <a:ext uri="{FF2B5EF4-FFF2-40B4-BE49-F238E27FC236}">
-                <a16:creationId xmlns:a16="http://schemas.microsoft.com/office/drawing/2014/main" id="{88FF7632-BE7B-4E4F-A3DF-C146E5399366}"/>
+                <a16:creationId xmlns:a16="http://schemas.microsoft.com/office/drawing/2014/main" id="{B7683960-5A3C-4CAD-A7C7-213205B39AAF}"/>
               </a:ext>
             </a:extLst>
           </p:cNvPr>
@@ -1723,12 +1723,12 @@
   </p:cSld>
   <p:clrMap bg1="lt1" tx1="dk1" bg2="lt2" tx2="dk2" accent1="accent1" accent2="accent2" accent3="accent3" accent4="accent4" accent5="accent5" accent6="accent6" hlink="hlink" folHlink="folHlink"/>
   <p:sldLayoutIdLst>
-    <p:sldLayoutId xmlns:r="http://schemas.openxmlformats.org/officeDocument/2006/relationships" id="2147483649" r:id="Ra61d4cae48bf4350"/>
-    <p:sldLayoutId xmlns:r="http://schemas.openxmlformats.org/officeDocument/2006/relationships" id="2147483650" r:id="Ra13f0ba079f741ac"/>
-    <p:sldLayoutId xmlns:r="http://schemas.openxmlformats.org/officeDocument/2006/relationships" id="2147483651" r:id="R79f94497b4a74fc8"/>
-    <p:sldLayoutId xmlns:r="http://schemas.openxmlformats.org/officeDocument/2006/relationships" id="2147483652" r:id="R1c3d0d2ee99445c3"/>
-    <p:sldLayoutId xmlns:r="http://schemas.openxmlformats.org/officeDocument/2006/relationships" id="2147483653" r:id="R9bbc7ab9ddfa4f9f"/>
-    <p:sldLayoutId xmlns:r="http://schemas.openxmlformats.org/officeDocument/2006/relationships" id="2147483654" r:id="Rd065dfa3f114401b"/>
+    <p:sldLayoutId xmlns:r="http://schemas.openxmlformats.org/officeDocument/2006/relationships" id="2147483649" r:id="R11bf33b4394b44bc"/>
+    <p:sldLayoutId xmlns:r="http://schemas.openxmlformats.org/officeDocument/2006/relationships" id="2147483650" r:id="Rfd3013f586694c60"/>
+    <p:sldLayoutId xmlns:r="http://schemas.openxmlformats.org/officeDocument/2006/relationships" id="2147483651" r:id="R0853952709834c74"/>
+    <p:sldLayoutId xmlns:r="http://schemas.openxmlformats.org/officeDocument/2006/relationships" id="2147483652" r:id="Rc025dde330f841fd"/>
+    <p:sldLayoutId xmlns:r="http://schemas.openxmlformats.org/officeDocument/2006/relationships" id="2147483653" r:id="Ra7113a6590e64e7c"/>
+    <p:sldLayoutId xmlns:r="http://schemas.openxmlformats.org/officeDocument/2006/relationships" id="2147483654" r:id="R1707eef291174c42"/>
   </p:sldLayoutIdLst>
   <p:txStyles>
     <p:titleStyle>
@@ -2279,7 +2279,7 @@
           <p:cNvPr id="9" name="">
             <a:extLst xmlns:a="http://schemas.openxmlformats.org/drawingml/2006/main">
               <a:ext uri="{FF2B5EF4-FFF2-40B4-BE49-F238E27FC236}">
-                <a16:creationId xmlns:a16="http://schemas.microsoft.com/office/drawing/2014/main" id="{956AED7C-DBA2-45FC-8580-B04082FE0942}"/>
+                <a16:creationId xmlns:a16="http://schemas.microsoft.com/office/drawing/2014/main" id="{51230C04-1BCC-4AFC-8E0C-51C7E2B887D3}"/>
               </a:ext>
             </a:extLst>
           </p:cNvPr>
@@ -2347,7 +2347,7 @@
           <p:cNvPr id="2" name="">
             <a:extLst xmlns:a="http://schemas.openxmlformats.org/drawingml/2006/main">
               <a:ext uri="{FF2B5EF4-FFF2-40B4-BE49-F238E27FC236}">
-                <a16:creationId xmlns:a16="http://schemas.microsoft.com/office/drawing/2014/main" id="{15FC7523-55FC-43D4-97C3-7033A195293F}"/>
+                <a16:creationId xmlns:a16="http://schemas.microsoft.com/office/drawing/2014/main" id="{A6E9DBB3-2CDC-4B1D-8F2B-88D34CA3B7C1}"/>
               </a:ext>
             </a:extLst>
           </p:cNvPr>
@@ -2415,7 +2415,7 @@
           <p:cNvPr id="3" name="">
             <a:extLst xmlns:a="http://schemas.openxmlformats.org/drawingml/2006/main">
               <a:ext uri="{FF2B5EF4-FFF2-40B4-BE49-F238E27FC236}">
-                <a16:creationId xmlns:a16="http://schemas.microsoft.com/office/drawing/2014/main" id="{D260D127-325E-433A-B255-F0CC4464E697}"/>
+                <a16:creationId xmlns:a16="http://schemas.microsoft.com/office/drawing/2014/main" id="{D3F4BB72-7EEE-4C33-B7D2-D9B2A4A55EEF}"/>
               </a:ext>
             </a:extLst>
           </p:cNvPr>
@@ -2425,7 +2425,7 @@
           <p:nvPr/>
         </p:nvPicPr>
         <p:blipFill>
-          <a:blip xmlns:r="http://schemas.openxmlformats.org/officeDocument/2006/relationships" xmlns:a="http://schemas.openxmlformats.org/drawingml/2006/main" r:embed="R2bc7b012623f407d"/>
+          <a:blip xmlns:r="http://schemas.openxmlformats.org/officeDocument/2006/relationships" xmlns:a="http://schemas.openxmlformats.org/drawingml/2006/main" r:embed="R3273a7913923400f"/>
           <a:stretch xmlns:a="http://schemas.openxmlformats.org/drawingml/2006/main"/>
         </p:blipFill>
         <p:spPr>
@@ -2443,7 +2443,7 @@
           <p:cNvPr id="4" name="">
             <a:extLst xmlns:a="http://schemas.openxmlformats.org/drawingml/2006/main">
               <a:ext uri="{FF2B5EF4-FFF2-40B4-BE49-F238E27FC236}">
-                <a16:creationId xmlns:a16="http://schemas.microsoft.com/office/drawing/2014/main" id="{57A8FE9E-BF13-4EDF-BFE5-FBB4CB0521B5}"/>
+                <a16:creationId xmlns:a16="http://schemas.microsoft.com/office/drawing/2014/main" id="{4250627D-CB69-4696-92E9-2C6278C271B4}"/>
               </a:ext>
             </a:extLst>
           </p:cNvPr>
@@ -2511,7 +2511,7 @@
           <p:cNvPr id="5" name="">
             <a:extLst xmlns:a="http://schemas.openxmlformats.org/drawingml/2006/main">
               <a:ext uri="{FF2B5EF4-FFF2-40B4-BE49-F238E27FC236}">
-                <a16:creationId xmlns:a16="http://schemas.microsoft.com/office/drawing/2014/main" id="{350C6C8B-7DA6-4EFE-AE81-5915381E466C}"/>
+                <a16:creationId xmlns:a16="http://schemas.microsoft.com/office/drawing/2014/main" id="{43773C39-B97A-4D97-B5D8-87E79F020107}"/>
               </a:ext>
             </a:extLst>
           </p:cNvPr>
@@ -2607,7 +2607,7 @@
           <p:cNvPr id="6" name="">
             <a:extLst xmlns:a="http://schemas.openxmlformats.org/drawingml/2006/main">
               <a:ext uri="{FF2B5EF4-FFF2-40B4-BE49-F238E27FC236}">
-                <a16:creationId xmlns:a16="http://schemas.microsoft.com/office/drawing/2014/main" id="{B4403AE9-22CE-48CD-A53B-C633B514CC52}"/>
+                <a16:creationId xmlns:a16="http://schemas.microsoft.com/office/drawing/2014/main" id="{1F79933B-ED28-44E7-9214-2BCE26107B7A}"/>
               </a:ext>
             </a:extLst>
           </p:cNvPr>
@@ -2675,7 +2675,7 @@
           <p:cNvPr id="7" name="">
             <a:extLst xmlns:a="http://schemas.openxmlformats.org/drawingml/2006/main">
               <a:ext uri="{FF2B5EF4-FFF2-40B4-BE49-F238E27FC236}">
-                <a16:creationId xmlns:a16="http://schemas.microsoft.com/office/drawing/2014/main" id="{CE4DEC73-F9DD-4590-A127-57836D4930A9}"/>
+                <a16:creationId xmlns:a16="http://schemas.microsoft.com/office/drawing/2014/main" id="{A1A13F2B-B057-4637-BB1D-6FBC22380FD3}"/>
               </a:ext>
             </a:extLst>
           </p:cNvPr>
@@ -2799,7 +2799,7 @@
           <p:cNvPr id="8" name="">
             <a:extLst xmlns:a="http://schemas.openxmlformats.org/drawingml/2006/main">
               <a:ext uri="{FF2B5EF4-FFF2-40B4-BE49-F238E27FC236}">
-                <a16:creationId xmlns:a16="http://schemas.microsoft.com/office/drawing/2014/main" id="{3F4299F0-039C-4C70-AE42-EA9155BFAB12}"/>
+                <a16:creationId xmlns:a16="http://schemas.microsoft.com/office/drawing/2014/main" id="{71E58E0C-D15E-4291-9624-6CC01F4CAB29}"/>
               </a:ext>
             </a:extLst>
           </p:cNvPr>
@@ -2865,7 +2865,7 @@
     </p:spTree>
     <p:extLst>
       <p:ext uri="{BB962C8B-B14F-4D97-AF65-F5344CB8AC3E}">
-        <p14:creationId xmlns:p14="http://schemas.microsoft.com/office/powerpoint/2010/main" val="1532829042"/>
+        <p14:creationId xmlns:p14="http://schemas.microsoft.com/office/powerpoint/2010/main" val="967396065"/>
       </p:ext>
     </p:extLst>
   </p:cSld>
@@ -2893,10 +2893,10 @@
       </p:grpSpPr>
       <p:sp>
         <p:nvSpPr>
-          <p:cNvPr id="8" name="">
-            <a:extLst xmlns:a="http://schemas.openxmlformats.org/drawingml/2006/main">
-              <a:ext uri="{FF2B5EF4-FFF2-40B4-BE49-F238E27FC236}">
-                <a16:creationId xmlns:a16="http://schemas.microsoft.com/office/drawing/2014/main" id="{6EE9346B-3687-42DB-AB64-0678AABA2581}"/>
+          <p:cNvPr id="9" name="">
+            <a:extLst xmlns:a="http://schemas.openxmlformats.org/drawingml/2006/main">
+              <a:ext uri="{FF2B5EF4-FFF2-40B4-BE49-F238E27FC236}">
+                <a16:creationId xmlns:a16="http://schemas.microsoft.com/office/drawing/2014/main" id="{1C9CC544-0DB2-4E0A-8FEF-CA82DB4AA9F6}"/>
               </a:ext>
             </a:extLst>
           </p:cNvPr>
@@ -2964,7 +2964,7 @@
           <p:cNvPr id="2" name="">
             <a:extLst xmlns:a="http://schemas.openxmlformats.org/drawingml/2006/main">
               <a:ext uri="{FF2B5EF4-FFF2-40B4-BE49-F238E27FC236}">
-                <a16:creationId xmlns:a16="http://schemas.microsoft.com/office/drawing/2014/main" id="{802DA7AE-01C5-4CF8-9671-F5AE7FA88D5B}"/>
+                <a16:creationId xmlns:a16="http://schemas.microsoft.com/office/drawing/2014/main" id="{82AFB0CE-DA19-43C2-87B6-7F1F7A930DB2}"/>
               </a:ext>
             </a:extLst>
           </p:cNvPr>
@@ -3032,7 +3032,7 @@
           <p:cNvPr id="3" name="">
             <a:extLst xmlns:a="http://schemas.openxmlformats.org/drawingml/2006/main">
               <a:ext uri="{FF2B5EF4-FFF2-40B4-BE49-F238E27FC236}">
-                <a16:creationId xmlns:a16="http://schemas.microsoft.com/office/drawing/2014/main" id="{2DB0776F-E90E-45EB-B5F4-AB7F1202FDC6}"/>
+                <a16:creationId xmlns:a16="http://schemas.microsoft.com/office/drawing/2014/main" id="{0BAFFD90-67BE-4107-87D5-B174133AD317}"/>
               </a:ext>
             </a:extLst>
           </p:cNvPr>
@@ -3100,7 +3100,7 @@
           <p:cNvPr id="4" name="">
             <a:extLst xmlns:a="http://schemas.openxmlformats.org/drawingml/2006/main">
               <a:ext uri="{FF2B5EF4-FFF2-40B4-BE49-F238E27FC236}">
-                <a16:creationId xmlns:a16="http://schemas.microsoft.com/office/drawing/2014/main" id="{96C13AEA-B23F-4940-AAF0-C05E191BA1DC}"/>
+                <a16:creationId xmlns:a16="http://schemas.microsoft.com/office/drawing/2014/main" id="{04E4846A-0760-4635-9B15-F820A89179CA}"/>
               </a:ext>
             </a:extLst>
           </p:cNvPr>
@@ -3196,7 +3196,7 @@
           <p:cNvPr id="5" name="">
             <a:extLst xmlns:a="http://schemas.openxmlformats.org/drawingml/2006/main">
               <a:ext uri="{FF2B5EF4-FFF2-40B4-BE49-F238E27FC236}">
-                <a16:creationId xmlns:a16="http://schemas.microsoft.com/office/drawing/2014/main" id="{51B5C38C-856F-4B2F-8CFB-0DBFCE73F207}"/>
+                <a16:creationId xmlns:a16="http://schemas.microsoft.com/office/drawing/2014/main" id="{F243E558-EC30-4A18-8A73-CB3CCE18E437}"/>
               </a:ext>
             </a:extLst>
           </p:cNvPr>
@@ -3310,35 +3310,103 @@
           <p:cNvPr id="6" name="">
             <a:extLst xmlns:a="http://schemas.openxmlformats.org/drawingml/2006/main">
               <a:ext uri="{FF2B5EF4-FFF2-40B4-BE49-F238E27FC236}">
-                <a16:creationId xmlns:a16="http://schemas.microsoft.com/office/drawing/2014/main" id="{0BC26C9B-668C-4577-8936-1227CB2386E7}"/>
-              </a:ext>
-            </a:extLst>
-          </p:cNvPr>
-          <p:cNvSpPr>
-            <a:spLocks xmlns:a="http://schemas.openxmlformats.org/drawingml/2006/main" noGrp="1"/>
-          </p:cNvSpPr>
-          <p:nvPr/>
-        </p:nvSpPr>
-        <p:spPr>
-          <a:xfrm xmlns:a="http://schemas.openxmlformats.org/drawingml/2006/main">
-            <a:off x="609600" y="5572125"/>
-            <a:ext cx="10953750" cy="666750"/>
-          </a:xfrm>
-          <a:prstGeom xmlns:a="http://schemas.openxmlformats.org/drawingml/2006/main" prst="rect">
-            <a:avLst/>
-          </a:prstGeom>
-          <a:noFill xmlns:a="http://schemas.openxmlformats.org/drawingml/2006/main"/>
-          <a:ln xmlns:a="http://schemas.openxmlformats.org/drawingml/2006/main" w="0">
-            <a:noFill/>
-          </a:ln>
-        </p:spPr>
-        <p:txBody>
-          <a:bodyPr xmlns:a="http://schemas.openxmlformats.org/drawingml/2006/main">
-            <a:noAutofit/>
-          </a:bodyPr>
-          <a:lstStyle xmlns:a="http://schemas.openxmlformats.org/drawingml/2006/main">
-            <a:defPPr>
-              <a:defRPr sz="1650" b="0">
+                <a16:creationId xmlns:a16="http://schemas.microsoft.com/office/drawing/2014/main" id="{AD50EB79-EFD8-477B-B03E-346D6D884B50}"/>
+              </a:ext>
+            </a:extLst>
+          </p:cNvPr>
+          <p:cNvSpPr>
+            <a:spLocks xmlns:a="http://schemas.openxmlformats.org/drawingml/2006/main" noGrp="1"/>
+          </p:cNvSpPr>
+          <p:nvPr/>
+        </p:nvSpPr>
+        <p:spPr>
+          <a:xfrm xmlns:a="http://schemas.openxmlformats.org/drawingml/2006/main">
+            <a:off x="609600" y="5286375"/>
+            <a:ext cx="10953750" cy="381000"/>
+          </a:xfrm>
+          <a:prstGeom xmlns:a="http://schemas.openxmlformats.org/drawingml/2006/main" prst="rect">
+            <a:avLst/>
+          </a:prstGeom>
+          <a:noFill xmlns:a="http://schemas.openxmlformats.org/drawingml/2006/main"/>
+          <a:ln xmlns:a="http://schemas.openxmlformats.org/drawingml/2006/main" w="0">
+            <a:noFill/>
+          </a:ln>
+        </p:spPr>
+        <p:txBody>
+          <a:bodyPr xmlns:a="http://schemas.openxmlformats.org/drawingml/2006/main">
+            <a:noAutofit/>
+          </a:bodyPr>
+          <a:lstStyle xmlns:a="http://schemas.openxmlformats.org/drawingml/2006/main">
+            <a:defPPr>
+              <a:defRPr sz="1725" b="1">
+                <a:solidFill>
+                  <a:srgbClr val="FCD34D"/>
+                </a:solidFill>
+                <a:latin typeface="Arial"/>
+                <a:ea typeface="Arial"/>
+                <a:cs typeface="Arial"/>
+              </a:defRPr>
+            </a:defPPr>
+          </a:lstStyle>
+          <a:p xmlns:a="http://schemas.openxmlformats.org/drawingml/2006/main">
+            <a:pPr>
+              <a:defRPr sz="1725" b="1">
+                <a:solidFill>
+                  <a:srgbClr val="FCD34D"/>
+                </a:solidFill>
+                <a:latin typeface="Arial"/>
+                <a:ea typeface="Arial"/>
+                <a:cs typeface="Arial"/>
+              </a:defRPr>
+            </a:pPr>
+            <a:r>
+              <a:rPr sz="1725" b="1">
+                <a:solidFill>
+                  <a:srgbClr val="FCD34D"/>
+                </a:solidFill>
+                <a:latin typeface="Arial"/>
+                <a:ea typeface="Arial"/>
+                <a:cs typeface="Arial"/>
+              </a:rPr>
+              <a:t>Çfarë e ndalon ndryshimin e udhëtimit të një pronari tjetër?</a:t>
+            </a:r>
+          </a:p>
+        </p:txBody>
+      </p:sp>
+      <p:sp>
+        <p:nvSpPr>
+          <p:cNvPr id="7" name="">
+            <a:extLst xmlns:a="http://schemas.openxmlformats.org/drawingml/2006/main">
+              <a:ext uri="{FF2B5EF4-FFF2-40B4-BE49-F238E27FC236}">
+                <a16:creationId xmlns:a16="http://schemas.microsoft.com/office/drawing/2014/main" id="{47128CA3-66EC-45B6-9D14-19D8F624EB7B}"/>
+              </a:ext>
+            </a:extLst>
+          </p:cNvPr>
+          <p:cNvSpPr>
+            <a:spLocks xmlns:a="http://schemas.openxmlformats.org/drawingml/2006/main" noGrp="1"/>
+          </p:cNvSpPr>
+          <p:nvPr/>
+        </p:nvSpPr>
+        <p:spPr>
+          <a:xfrm xmlns:a="http://schemas.openxmlformats.org/drawingml/2006/main">
+            <a:off x="609600" y="5715000"/>
+            <a:ext cx="10953750" cy="619125"/>
+          </a:xfrm>
+          <a:prstGeom xmlns:a="http://schemas.openxmlformats.org/drawingml/2006/main" prst="rect">
+            <a:avLst/>
+          </a:prstGeom>
+          <a:noFill xmlns:a="http://schemas.openxmlformats.org/drawingml/2006/main"/>
+          <a:ln xmlns:a="http://schemas.openxmlformats.org/drawingml/2006/main" w="0">
+            <a:noFill/>
+          </a:ln>
+        </p:spPr>
+        <p:txBody>
+          <a:bodyPr xmlns:a="http://schemas.openxmlformats.org/drawingml/2006/main">
+            <a:noAutofit/>
+          </a:bodyPr>
+          <a:lstStyle xmlns:a="http://schemas.openxmlformats.org/drawingml/2006/main">
+            <a:defPPr>
+              <a:defRPr sz="1575" b="0">
                 <a:solidFill>
                   <a:srgbClr val="B8EDDB"/>
                 </a:solidFill>
@@ -3350,7 +3418,7 @@
           </a:lstStyle>
           <a:p xmlns:a="http://schemas.openxmlformats.org/drawingml/2006/main">
             <a:pPr>
-              <a:defRPr sz="1650" b="0">
+              <a:defRPr sz="1575" b="0">
                 <a:solidFill>
                   <a:srgbClr val="B8EDDB"/>
                 </a:solidFill>
@@ -3360,7 +3428,7 @@
               </a:defRPr>
             </a:pPr>
             <a:r>
-              <a:rPr sz="1650" b="0">
+              <a:rPr sz="1575" b="0">
                 <a:solidFill>
                   <a:srgbClr val="B8EDDB"/>
                 </a:solidFill>
@@ -3368,17 +3436,17 @@
                 <a:ea typeface="Arial"/>
                 <a:cs typeface="Arial"/>
               </a:rPr>
-              <a:t>Përgjigjja: Në kodin e plotë kontrollojmë edhe rolin. RETURNING tregon nëse u ndryshua një rresht.</a:t>
-            </a:r>
-          </a:p>
-        </p:txBody>
-      </p:sp>
-      <p:sp>
-        <p:nvSpPr>
-          <p:cNvPr id="7" name="">
-            <a:extLst xmlns:a="http://schemas.openxmlformats.org/drawingml/2006/main">
-              <a:ext uri="{FF2B5EF4-FFF2-40B4-BE49-F238E27FC236}">
-                <a16:creationId xmlns:a16="http://schemas.microsoft.com/office/drawing/2014/main" id="{AC2DB94B-0225-4CC4-A298-4FE9100746A9}"/>
+              <a:t>Përgjigjja: Kushti shofer_id = p.id kërkon pronarin e saktë. Në kodin e plotë kontrollojmë edhe rolin. RETURNING tregon nëse u ndryshua një rresht.</a:t>
+            </a:r>
+          </a:p>
+        </p:txBody>
+      </p:sp>
+      <p:sp>
+        <p:nvSpPr>
+          <p:cNvPr id="8" name="">
+            <a:extLst xmlns:a="http://schemas.openxmlformats.org/drawingml/2006/main">
+              <a:ext uri="{FF2B5EF4-FFF2-40B4-BE49-F238E27FC236}">
+                <a16:creationId xmlns:a16="http://schemas.microsoft.com/office/drawing/2014/main" id="{C02AA58C-4B35-4575-A9CD-63BF5CF938D0}"/>
               </a:ext>
             </a:extLst>
           </p:cNvPr>
@@ -3444,7 +3512,7 @@
     </p:spTree>
     <p:extLst>
       <p:ext uri="{BB962C8B-B14F-4D97-AF65-F5344CB8AC3E}">
-        <p14:creationId xmlns:p14="http://schemas.microsoft.com/office/powerpoint/2010/main" val="801795103"/>
+        <p14:creationId xmlns:p14="http://schemas.microsoft.com/office/powerpoint/2010/main" val="1020199114"/>
       </p:ext>
     </p:extLst>
   </p:cSld>
@@ -3472,10 +3540,10 @@
       </p:grpSpPr>
       <p:sp>
         <p:nvSpPr>
-          <p:cNvPr id="11" name="">
-            <a:extLst xmlns:a="http://schemas.openxmlformats.org/drawingml/2006/main">
-              <a:ext uri="{FF2B5EF4-FFF2-40B4-BE49-F238E27FC236}">
-                <a16:creationId xmlns:a16="http://schemas.microsoft.com/office/drawing/2014/main" id="{5C0A2CF3-F793-490F-91B9-27D7F38125FE}"/>
+          <p:cNvPr id="12" name="">
+            <a:extLst xmlns:a="http://schemas.openxmlformats.org/drawingml/2006/main">
+              <a:ext uri="{FF2B5EF4-FFF2-40B4-BE49-F238E27FC236}">
+                <a16:creationId xmlns:a16="http://schemas.microsoft.com/office/drawing/2014/main" id="{D686923C-082B-4175-9AD6-D1E850AD1A09}"/>
               </a:ext>
             </a:extLst>
           </p:cNvPr>
@@ -3543,7 +3611,7 @@
           <p:cNvPr id="2" name="">
             <a:extLst xmlns:a="http://schemas.openxmlformats.org/drawingml/2006/main">
               <a:ext uri="{FF2B5EF4-FFF2-40B4-BE49-F238E27FC236}">
-                <a16:creationId xmlns:a16="http://schemas.microsoft.com/office/drawing/2014/main" id="{A8BE38F8-E083-4B90-A2C4-C90AF2958823}"/>
+                <a16:creationId xmlns:a16="http://schemas.microsoft.com/office/drawing/2014/main" id="{C1BB9A80-3BF3-42AD-A22C-3B04886E10CB}"/>
               </a:ext>
             </a:extLst>
           </p:cNvPr>
@@ -3611,7 +3679,7 @@
           <p:cNvPr id="3" name="">
             <a:extLst xmlns:a="http://schemas.openxmlformats.org/drawingml/2006/main">
               <a:ext uri="{FF2B5EF4-FFF2-40B4-BE49-F238E27FC236}">
-                <a16:creationId xmlns:a16="http://schemas.microsoft.com/office/drawing/2014/main" id="{351A3065-E52B-4737-B309-27415390FCF9}"/>
+                <a16:creationId xmlns:a16="http://schemas.microsoft.com/office/drawing/2014/main" id="{FADA05DE-3083-4184-A3CB-B4165DF65D39}"/>
               </a:ext>
             </a:extLst>
           </p:cNvPr>
@@ -3679,7 +3747,7 @@
           <p:cNvPr id="4" name="">
             <a:extLst xmlns:a="http://schemas.openxmlformats.org/drawingml/2006/main">
               <a:ext uri="{FF2B5EF4-FFF2-40B4-BE49-F238E27FC236}">
-                <a16:creationId xmlns:a16="http://schemas.microsoft.com/office/drawing/2014/main" id="{01B627B2-D0CE-479A-9B74-C59B9B5CD865}"/>
+                <a16:creationId xmlns:a16="http://schemas.microsoft.com/office/drawing/2014/main" id="{9979263D-FF89-4943-8BFC-15916E27AC56}"/>
               </a:ext>
             </a:extLst>
           </p:cNvPr>
@@ -3803,7 +3871,7 @@
           <p:cNvPr id="5" name="">
             <a:extLst xmlns:a="http://schemas.openxmlformats.org/drawingml/2006/main">
               <a:ext uri="{FF2B5EF4-FFF2-40B4-BE49-F238E27FC236}">
-                <a16:creationId xmlns:a16="http://schemas.microsoft.com/office/drawing/2014/main" id="{30D37C80-26B7-47C2-8501-1ECEEB04A4FC}"/>
+                <a16:creationId xmlns:a16="http://schemas.microsoft.com/office/drawing/2014/main" id="{C6553F34-FB81-462E-9993-7CFECBCB6AB9}"/>
               </a:ext>
             </a:extLst>
           </p:cNvPr>
@@ -3871,7 +3939,7 @@
           <p:cNvPr id="6" name="">
             <a:extLst xmlns:a="http://schemas.openxmlformats.org/drawingml/2006/main">
               <a:ext uri="{FF2B5EF4-FFF2-40B4-BE49-F238E27FC236}">
-                <a16:creationId xmlns:a16="http://schemas.microsoft.com/office/drawing/2014/main" id="{16CCD6B5-7F80-4DFA-A6D8-534471A36BB9}"/>
+                <a16:creationId xmlns:a16="http://schemas.microsoft.com/office/drawing/2014/main" id="{98709A41-466C-478D-9820-2A88EBB77C69}"/>
               </a:ext>
             </a:extLst>
           </p:cNvPr>
@@ -3939,7 +4007,7 @@
           <p:cNvPr id="7" name="">
             <a:extLst xmlns:a="http://schemas.openxmlformats.org/drawingml/2006/main">
               <a:ext uri="{FF2B5EF4-FFF2-40B4-BE49-F238E27FC236}">
-                <a16:creationId xmlns:a16="http://schemas.microsoft.com/office/drawing/2014/main" id="{C49FED5D-C8C1-4D91-A4D3-8106D68D2A69}"/>
+                <a16:creationId xmlns:a16="http://schemas.microsoft.com/office/drawing/2014/main" id="{FEEFCEC9-F65A-45AF-8E66-9C6AD9A992CD}"/>
               </a:ext>
             </a:extLst>
           </p:cNvPr>
@@ -4007,7 +4075,7 @@
           <p:cNvPr id="8" name="">
             <a:extLst xmlns:a="http://schemas.openxmlformats.org/drawingml/2006/main">
               <a:ext uri="{FF2B5EF4-FFF2-40B4-BE49-F238E27FC236}">
-                <a16:creationId xmlns:a16="http://schemas.microsoft.com/office/drawing/2014/main" id="{5E0A373A-FD99-453C-96D4-7271DEC31136}"/>
+                <a16:creationId xmlns:a16="http://schemas.microsoft.com/office/drawing/2014/main" id="{3A9CBA78-F932-4163-B859-A89EF26FEA31}"/>
               </a:ext>
             </a:extLst>
           </p:cNvPr>
@@ -4075,35 +4143,103 @@
           <p:cNvPr id="9" name="">
             <a:extLst xmlns:a="http://schemas.openxmlformats.org/drawingml/2006/main">
               <a:ext uri="{FF2B5EF4-FFF2-40B4-BE49-F238E27FC236}">
-                <a16:creationId xmlns:a16="http://schemas.microsoft.com/office/drawing/2014/main" id="{16F010A8-BDDD-4342-8C26-4DB824B1A4EA}"/>
-              </a:ext>
-            </a:extLst>
-          </p:cNvPr>
-          <p:cNvSpPr>
-            <a:spLocks xmlns:a="http://schemas.openxmlformats.org/drawingml/2006/main" noGrp="1"/>
-          </p:cNvSpPr>
-          <p:nvPr/>
-        </p:nvSpPr>
-        <p:spPr>
-          <a:xfrm xmlns:a="http://schemas.openxmlformats.org/drawingml/2006/main">
-            <a:off x="609600" y="5572125"/>
-            <a:ext cx="10953750" cy="666750"/>
-          </a:xfrm>
-          <a:prstGeom xmlns:a="http://schemas.openxmlformats.org/drawingml/2006/main" prst="rect">
-            <a:avLst/>
-          </a:prstGeom>
-          <a:noFill xmlns:a="http://schemas.openxmlformats.org/drawingml/2006/main"/>
-          <a:ln xmlns:a="http://schemas.openxmlformats.org/drawingml/2006/main" w="0">
-            <a:noFill/>
-          </a:ln>
-        </p:spPr>
-        <p:txBody>
-          <a:bodyPr xmlns:a="http://schemas.openxmlformats.org/drawingml/2006/main">
-            <a:noAutofit/>
-          </a:bodyPr>
-          <a:lstStyle xmlns:a="http://schemas.openxmlformats.org/drawingml/2006/main">
-            <a:defPPr>
-              <a:defRPr sz="1650" b="0">
+                <a16:creationId xmlns:a16="http://schemas.microsoft.com/office/drawing/2014/main" id="{48366B05-9CFA-4090-B272-CE6593E92A34}"/>
+              </a:ext>
+            </a:extLst>
+          </p:cNvPr>
+          <p:cNvSpPr>
+            <a:spLocks xmlns:a="http://schemas.openxmlformats.org/drawingml/2006/main" noGrp="1"/>
+          </p:cNvSpPr>
+          <p:nvPr/>
+        </p:nvSpPr>
+        <p:spPr>
+          <a:xfrm xmlns:a="http://schemas.openxmlformats.org/drawingml/2006/main">
+            <a:off x="609600" y="5286375"/>
+            <a:ext cx="10953750" cy="381000"/>
+          </a:xfrm>
+          <a:prstGeom xmlns:a="http://schemas.openxmlformats.org/drawingml/2006/main" prst="rect">
+            <a:avLst/>
+          </a:prstGeom>
+          <a:noFill xmlns:a="http://schemas.openxmlformats.org/drawingml/2006/main"/>
+          <a:ln xmlns:a="http://schemas.openxmlformats.org/drawingml/2006/main" w="0">
+            <a:noFill/>
+          </a:ln>
+        </p:spPr>
+        <p:txBody>
+          <a:bodyPr xmlns:a="http://schemas.openxmlformats.org/drawingml/2006/main">
+            <a:noAutofit/>
+          </a:bodyPr>
+          <a:lstStyle xmlns:a="http://schemas.openxmlformats.org/drawingml/2006/main">
+            <a:defPPr>
+              <a:defRPr sz="1725" b="1">
+                <a:solidFill>
+                  <a:srgbClr val="FCD34D"/>
+                </a:solidFill>
+                <a:latin typeface="Arial"/>
+                <a:ea typeface="Arial"/>
+                <a:cs typeface="Arial"/>
+              </a:defRPr>
+            </a:defPPr>
+          </a:lstStyle>
+          <a:p xmlns:a="http://schemas.openxmlformats.org/drawingml/2006/main">
+            <a:pPr>
+              <a:defRPr sz="1725" b="1">
+                <a:solidFill>
+                  <a:srgbClr val="FCD34D"/>
+                </a:solidFill>
+                <a:latin typeface="Arial"/>
+                <a:ea typeface="Arial"/>
+                <a:cs typeface="Arial"/>
+              </a:defRPr>
+            </a:pPr>
+            <a:r>
+              <a:rPr sz="1725" b="1">
+                <a:solidFill>
+                  <a:srgbClr val="FCD34D"/>
+                </a:solidFill>
+                <a:latin typeface="Arial"/>
+                <a:ea typeface="Arial"/>
+                <a:cs typeface="Arial"/>
+              </a:rPr>
+              <a:t>A mjafton ta fshehim butonin për ta mbrojtur veprimin?</a:t>
+            </a:r>
+          </a:p>
+        </p:txBody>
+      </p:sp>
+      <p:sp>
+        <p:nvSpPr>
+          <p:cNvPr id="10" name="">
+            <a:extLst xmlns:a="http://schemas.openxmlformats.org/drawingml/2006/main">
+              <a:ext uri="{FF2B5EF4-FFF2-40B4-BE49-F238E27FC236}">
+                <a16:creationId xmlns:a16="http://schemas.microsoft.com/office/drawing/2014/main" id="{50D98FE8-01CE-46C7-9971-42392C24BC86}"/>
+              </a:ext>
+            </a:extLst>
+          </p:cNvPr>
+          <p:cNvSpPr>
+            <a:spLocks xmlns:a="http://schemas.openxmlformats.org/drawingml/2006/main" noGrp="1"/>
+          </p:cNvSpPr>
+          <p:nvPr/>
+        </p:nvSpPr>
+        <p:spPr>
+          <a:xfrm xmlns:a="http://schemas.openxmlformats.org/drawingml/2006/main">
+            <a:off x="609600" y="5715000"/>
+            <a:ext cx="10953750" cy="619125"/>
+          </a:xfrm>
+          <a:prstGeom xmlns:a="http://schemas.openxmlformats.org/drawingml/2006/main" prst="rect">
+            <a:avLst/>
+          </a:prstGeom>
+          <a:noFill xmlns:a="http://schemas.openxmlformats.org/drawingml/2006/main"/>
+          <a:ln xmlns:a="http://schemas.openxmlformats.org/drawingml/2006/main" w="0">
+            <a:noFill/>
+          </a:ln>
+        </p:spPr>
+        <p:txBody>
+          <a:bodyPr xmlns:a="http://schemas.openxmlformats.org/drawingml/2006/main">
+            <a:noAutofit/>
+          </a:bodyPr>
+          <a:lstStyle xmlns:a="http://schemas.openxmlformats.org/drawingml/2006/main">
+            <a:defPPr>
+              <a:defRPr sz="1575" b="0">
                 <a:solidFill>
                   <a:srgbClr val="B8EDDB"/>
                 </a:solidFill>
@@ -4115,7 +4251,7 @@
           </a:lstStyle>
           <a:p xmlns:a="http://schemas.openxmlformats.org/drawingml/2006/main">
             <a:pPr>
-              <a:defRPr sz="1650" b="0">
+              <a:defRPr sz="1575" b="0">
                 <a:solidFill>
                   <a:srgbClr val="B8EDDB"/>
                 </a:solidFill>
@@ -4125,7 +4261,7 @@
               </a:defRPr>
             </a:pPr>
             <a:r>
-              <a:rPr sz="1650" b="0">
+              <a:rPr sz="1575" b="0">
                 <a:solidFill>
                   <a:srgbClr val="B8EDDB"/>
                 </a:solidFill>
@@ -4140,10 +4276,10 @@
       </p:sp>
       <p:sp>
         <p:nvSpPr>
-          <p:cNvPr id="10" name="">
-            <a:extLst xmlns:a="http://schemas.openxmlformats.org/drawingml/2006/main">
-              <a:ext uri="{FF2B5EF4-FFF2-40B4-BE49-F238E27FC236}">
-                <a16:creationId xmlns:a16="http://schemas.microsoft.com/office/drawing/2014/main" id="{CBFBEF25-7E0D-459F-A79C-DB3DF937B365}"/>
+          <p:cNvPr id="11" name="">
+            <a:extLst xmlns:a="http://schemas.openxmlformats.org/drawingml/2006/main">
+              <a:ext uri="{FF2B5EF4-FFF2-40B4-BE49-F238E27FC236}">
+                <a16:creationId xmlns:a16="http://schemas.microsoft.com/office/drawing/2014/main" id="{E42C5EFE-63BD-4033-B94C-9558FAF16200}"/>
               </a:ext>
             </a:extLst>
           </p:cNvPr>
@@ -4209,7 +4345,7 @@
     </p:spTree>
     <p:extLst>
       <p:ext uri="{BB962C8B-B14F-4D97-AF65-F5344CB8AC3E}">
-        <p14:creationId xmlns:p14="http://schemas.microsoft.com/office/powerpoint/2010/main" val="1023003877"/>
+        <p14:creationId xmlns:p14="http://schemas.microsoft.com/office/powerpoint/2010/main" val="890542681"/>
       </p:ext>
     </p:extLst>
   </p:cSld>
@@ -4237,10 +4373,10 @@
       </p:grpSpPr>
       <p:sp>
         <p:nvSpPr>
-          <p:cNvPr id="7" name="">
-            <a:extLst xmlns:a="http://schemas.openxmlformats.org/drawingml/2006/main">
-              <a:ext uri="{FF2B5EF4-FFF2-40B4-BE49-F238E27FC236}">
-                <a16:creationId xmlns:a16="http://schemas.microsoft.com/office/drawing/2014/main" id="{59687889-77A0-419C-853F-D084180D8CBB}"/>
+          <p:cNvPr id="8" name="">
+            <a:extLst xmlns:a="http://schemas.openxmlformats.org/drawingml/2006/main">
+              <a:ext uri="{FF2B5EF4-FFF2-40B4-BE49-F238E27FC236}">
+                <a16:creationId xmlns:a16="http://schemas.microsoft.com/office/drawing/2014/main" id="{0B9E16A5-8D9A-44CE-A009-4A0E471F6E39}"/>
               </a:ext>
             </a:extLst>
           </p:cNvPr>
@@ -4308,7 +4444,7 @@
           <p:cNvPr id="2" name="">
             <a:extLst xmlns:a="http://schemas.openxmlformats.org/drawingml/2006/main">
               <a:ext uri="{FF2B5EF4-FFF2-40B4-BE49-F238E27FC236}">
-                <a16:creationId xmlns:a16="http://schemas.microsoft.com/office/drawing/2014/main" id="{F2905524-0F96-41F4-97E4-4982D3FFCFE2}"/>
+                <a16:creationId xmlns:a16="http://schemas.microsoft.com/office/drawing/2014/main" id="{98FB8B0E-D32D-454E-B226-C2B57CD45E35}"/>
               </a:ext>
             </a:extLst>
           </p:cNvPr>
@@ -4376,7 +4512,7 @@
           <p:cNvPr id="3" name="">
             <a:extLst xmlns:a="http://schemas.openxmlformats.org/drawingml/2006/main">
               <a:ext uri="{FF2B5EF4-FFF2-40B4-BE49-F238E27FC236}">
-                <a16:creationId xmlns:a16="http://schemas.microsoft.com/office/drawing/2014/main" id="{B40E233E-7BD9-44A5-A686-BBFF73EA246F}"/>
+                <a16:creationId xmlns:a16="http://schemas.microsoft.com/office/drawing/2014/main" id="{FF32E4A1-BEF3-49C8-A700-0E320DCE4A6A}"/>
               </a:ext>
             </a:extLst>
           </p:cNvPr>
@@ -4444,7 +4580,7 @@
           <p:cNvPr id="4" name="">
             <a:extLst xmlns:a="http://schemas.openxmlformats.org/drawingml/2006/main">
               <a:ext uri="{FF2B5EF4-FFF2-40B4-BE49-F238E27FC236}">
-                <a16:creationId xmlns:a16="http://schemas.microsoft.com/office/drawing/2014/main" id="{7FE09A79-0D80-4E53-9ECA-654D3DB06ECC}"/>
+                <a16:creationId xmlns:a16="http://schemas.microsoft.com/office/drawing/2014/main" id="{097E8B48-2430-4EF0-A85A-7C939826B7C6}"/>
               </a:ext>
             </a:extLst>
           </p:cNvPr>
@@ -4568,35 +4704,103 @@
           <p:cNvPr id="5" name="">
             <a:extLst xmlns:a="http://schemas.openxmlformats.org/drawingml/2006/main">
               <a:ext uri="{FF2B5EF4-FFF2-40B4-BE49-F238E27FC236}">
-                <a16:creationId xmlns:a16="http://schemas.microsoft.com/office/drawing/2014/main" id="{30838EFD-5B3F-4663-8D88-FB41DB3AA2CF}"/>
-              </a:ext>
-            </a:extLst>
-          </p:cNvPr>
-          <p:cNvSpPr>
-            <a:spLocks xmlns:a="http://schemas.openxmlformats.org/drawingml/2006/main" noGrp="1"/>
-          </p:cNvSpPr>
-          <p:nvPr/>
-        </p:nvSpPr>
-        <p:spPr>
-          <a:xfrm xmlns:a="http://schemas.openxmlformats.org/drawingml/2006/main">
-            <a:off x="609600" y="5572125"/>
-            <a:ext cx="10953750" cy="666750"/>
-          </a:xfrm>
-          <a:prstGeom xmlns:a="http://schemas.openxmlformats.org/drawingml/2006/main" prst="rect">
-            <a:avLst/>
-          </a:prstGeom>
-          <a:noFill xmlns:a="http://schemas.openxmlformats.org/drawingml/2006/main"/>
-          <a:ln xmlns:a="http://schemas.openxmlformats.org/drawingml/2006/main" w="0">
-            <a:noFill/>
-          </a:ln>
-        </p:spPr>
-        <p:txBody>
-          <a:bodyPr xmlns:a="http://schemas.openxmlformats.org/drawingml/2006/main">
-            <a:noAutofit/>
-          </a:bodyPr>
-          <a:lstStyle xmlns:a="http://schemas.openxmlformats.org/drawingml/2006/main">
-            <a:defPPr>
-              <a:defRPr sz="1650" b="0">
+                <a16:creationId xmlns:a16="http://schemas.microsoft.com/office/drawing/2014/main" id="{DA2A00D8-7A33-428F-B481-A91F10F55423}"/>
+              </a:ext>
+            </a:extLst>
+          </p:cNvPr>
+          <p:cNvSpPr>
+            <a:spLocks xmlns:a="http://schemas.openxmlformats.org/drawingml/2006/main" noGrp="1"/>
+          </p:cNvSpPr>
+          <p:nvPr/>
+        </p:nvSpPr>
+        <p:spPr>
+          <a:xfrm xmlns:a="http://schemas.openxmlformats.org/drawingml/2006/main">
+            <a:off x="609600" y="5286375"/>
+            <a:ext cx="10953750" cy="381000"/>
+          </a:xfrm>
+          <a:prstGeom xmlns:a="http://schemas.openxmlformats.org/drawingml/2006/main" prst="rect">
+            <a:avLst/>
+          </a:prstGeom>
+          <a:noFill xmlns:a="http://schemas.openxmlformats.org/drawingml/2006/main"/>
+          <a:ln xmlns:a="http://schemas.openxmlformats.org/drawingml/2006/main" w="0">
+            <a:noFill/>
+          </a:ln>
+        </p:spPr>
+        <p:txBody>
+          <a:bodyPr xmlns:a="http://schemas.openxmlformats.org/drawingml/2006/main">
+            <a:noAutofit/>
+          </a:bodyPr>
+          <a:lstStyle xmlns:a="http://schemas.openxmlformats.org/drawingml/2006/main">
+            <a:defPPr>
+              <a:defRPr sz="1725" b="1">
+                <a:solidFill>
+                  <a:srgbClr val="FCD34D"/>
+                </a:solidFill>
+                <a:latin typeface="Arial"/>
+                <a:ea typeface="Arial"/>
+                <a:cs typeface="Arial"/>
+              </a:defRPr>
+            </a:defPPr>
+          </a:lstStyle>
+          <a:p xmlns:a="http://schemas.openxmlformats.org/drawingml/2006/main">
+            <a:pPr>
+              <a:defRPr sz="1725" b="1">
+                <a:solidFill>
+                  <a:srgbClr val="FCD34D"/>
+                </a:solidFill>
+                <a:latin typeface="Arial"/>
+                <a:ea typeface="Arial"/>
+                <a:cs typeface="Arial"/>
+              </a:defRPr>
+            </a:pPr>
+            <a:r>
+              <a:rPr sz="1725" b="1">
+                <a:solidFill>
+                  <a:srgbClr val="FCD34D"/>
+                </a:solidFill>
+                <a:latin typeface="Arial"/>
+                <a:ea typeface="Arial"/>
+                <a:cs typeface="Arial"/>
+              </a:rPr>
+              <a:t>A i revokon dalja edhe kopjet e vjedhura të tokenit?</a:t>
+            </a:r>
+          </a:p>
+        </p:txBody>
+      </p:sp>
+      <p:sp>
+        <p:nvSpPr>
+          <p:cNvPr id="6" name="">
+            <a:extLst xmlns:a="http://schemas.openxmlformats.org/drawingml/2006/main">
+              <a:ext uri="{FF2B5EF4-FFF2-40B4-BE49-F238E27FC236}">
+                <a16:creationId xmlns:a16="http://schemas.microsoft.com/office/drawing/2014/main" id="{FF6CE351-997A-4711-8E6E-8A9AD0B074F0}"/>
+              </a:ext>
+            </a:extLst>
+          </p:cNvPr>
+          <p:cNvSpPr>
+            <a:spLocks xmlns:a="http://schemas.openxmlformats.org/drawingml/2006/main" noGrp="1"/>
+          </p:cNvSpPr>
+          <p:nvPr/>
+        </p:nvSpPr>
+        <p:spPr>
+          <a:xfrm xmlns:a="http://schemas.openxmlformats.org/drawingml/2006/main">
+            <a:off x="609600" y="5715000"/>
+            <a:ext cx="10953750" cy="619125"/>
+          </a:xfrm>
+          <a:prstGeom xmlns:a="http://schemas.openxmlformats.org/drawingml/2006/main" prst="rect">
+            <a:avLst/>
+          </a:prstGeom>
+          <a:noFill xmlns:a="http://schemas.openxmlformats.org/drawingml/2006/main"/>
+          <a:ln xmlns:a="http://schemas.openxmlformats.org/drawingml/2006/main" w="0">
+            <a:noFill/>
+          </a:ln>
+        </p:spPr>
+        <p:txBody>
+          <a:bodyPr xmlns:a="http://schemas.openxmlformats.org/drawingml/2006/main">
+            <a:noAutofit/>
+          </a:bodyPr>
+          <a:lstStyle xmlns:a="http://schemas.openxmlformats.org/drawingml/2006/main">
+            <a:defPPr>
+              <a:defRPr sz="1575" b="0">
                 <a:solidFill>
                   <a:srgbClr val="B8EDDB"/>
                 </a:solidFill>
@@ -4608,7 +4812,7 @@
           </a:lstStyle>
           <a:p xmlns:a="http://schemas.openxmlformats.org/drawingml/2006/main">
             <a:pPr>
-              <a:defRPr sz="1650" b="0">
+              <a:defRPr sz="1575" b="0">
                 <a:solidFill>
                   <a:srgbClr val="B8EDDB"/>
                 </a:solidFill>
@@ -4618,7 +4822,7 @@
               </a:defRPr>
             </a:pPr>
             <a:r>
-              <a:rPr sz="1650" b="0">
+              <a:rPr sz="1575" b="0">
                 <a:solidFill>
                   <a:srgbClr val="B8EDDB"/>
                 </a:solidFill>
@@ -4633,10 +4837,10 @@
       </p:sp>
       <p:sp>
         <p:nvSpPr>
-          <p:cNvPr id="6" name="">
-            <a:extLst xmlns:a="http://schemas.openxmlformats.org/drawingml/2006/main">
-              <a:ext uri="{FF2B5EF4-FFF2-40B4-BE49-F238E27FC236}">
-                <a16:creationId xmlns:a16="http://schemas.microsoft.com/office/drawing/2014/main" id="{D0030D8A-4FEE-4A48-BD4E-214397E989C4}"/>
+          <p:cNvPr id="7" name="">
+            <a:extLst xmlns:a="http://schemas.openxmlformats.org/drawingml/2006/main">
+              <a:ext uri="{FF2B5EF4-FFF2-40B4-BE49-F238E27FC236}">
+                <a16:creationId xmlns:a16="http://schemas.microsoft.com/office/drawing/2014/main" id="{9DEF0353-D2F9-4F81-926D-8BA135ACACF2}"/>
               </a:ext>
             </a:extLst>
           </p:cNvPr>
@@ -4702,7 +4906,7 @@
     </p:spTree>
     <p:extLst>
       <p:ext uri="{BB962C8B-B14F-4D97-AF65-F5344CB8AC3E}">
-        <p14:creationId xmlns:p14="http://schemas.microsoft.com/office/powerpoint/2010/main" val="564412516"/>
+        <p14:creationId xmlns:p14="http://schemas.microsoft.com/office/powerpoint/2010/main" val="1473664443"/>
       </p:ext>
     </p:extLst>
   </p:cSld>
@@ -4730,10 +4934,10 @@
       </p:grpSpPr>
       <p:sp>
         <p:nvSpPr>
-          <p:cNvPr id="10" name="">
-            <a:extLst xmlns:a="http://schemas.openxmlformats.org/drawingml/2006/main">
-              <a:ext uri="{FF2B5EF4-FFF2-40B4-BE49-F238E27FC236}">
-                <a16:creationId xmlns:a16="http://schemas.microsoft.com/office/drawing/2014/main" id="{FA091797-1F59-479D-A7C3-7D25D9A71196}"/>
+          <p:cNvPr id="11" name="">
+            <a:extLst xmlns:a="http://schemas.openxmlformats.org/drawingml/2006/main">
+              <a:ext uri="{FF2B5EF4-FFF2-40B4-BE49-F238E27FC236}">
+                <a16:creationId xmlns:a16="http://schemas.microsoft.com/office/drawing/2014/main" id="{0466A1C8-4870-4ED0-A615-8C2D99C37B2E}"/>
               </a:ext>
             </a:extLst>
           </p:cNvPr>
@@ -4801,7 +5005,7 @@
           <p:cNvPr id="2" name="">
             <a:extLst xmlns:a="http://schemas.openxmlformats.org/drawingml/2006/main">
               <a:ext uri="{FF2B5EF4-FFF2-40B4-BE49-F238E27FC236}">
-                <a16:creationId xmlns:a16="http://schemas.microsoft.com/office/drawing/2014/main" id="{39607547-868D-475F-97EA-54F1FF56EE67}"/>
+                <a16:creationId xmlns:a16="http://schemas.microsoft.com/office/drawing/2014/main" id="{4696BE1C-1BC6-4FFD-BADE-CF296D2C6525}"/>
               </a:ext>
             </a:extLst>
           </p:cNvPr>
@@ -4869,7 +5073,7 @@
           <p:cNvPr id="3" name="">
             <a:extLst xmlns:a="http://schemas.openxmlformats.org/drawingml/2006/main">
               <a:ext uri="{FF2B5EF4-FFF2-40B4-BE49-F238E27FC236}">
-                <a16:creationId xmlns:a16="http://schemas.microsoft.com/office/drawing/2014/main" id="{639A7442-1518-4127-AEBF-29DBAAE55476}"/>
+                <a16:creationId xmlns:a16="http://schemas.microsoft.com/office/drawing/2014/main" id="{0E02D23E-BFB9-42D3-89D4-4E3CBC0031EC}"/>
               </a:ext>
             </a:extLst>
           </p:cNvPr>
@@ -4937,7 +5141,7 @@
           <p:cNvPr id="4" name="">
             <a:extLst xmlns:a="http://schemas.openxmlformats.org/drawingml/2006/main">
               <a:ext uri="{FF2B5EF4-FFF2-40B4-BE49-F238E27FC236}">
-                <a16:creationId xmlns:a16="http://schemas.microsoft.com/office/drawing/2014/main" id="{DA1418FE-F274-417A-BB74-859B6505B92F}"/>
+                <a16:creationId xmlns:a16="http://schemas.microsoft.com/office/drawing/2014/main" id="{0407AED8-BBD7-44CD-AAE7-06C06E2FA50F}"/>
               </a:ext>
             </a:extLst>
           </p:cNvPr>
@@ -5061,7 +5265,7 @@
           <p:cNvPr id="5" name="">
             <a:extLst xmlns:a="http://schemas.openxmlformats.org/drawingml/2006/main">
               <a:ext uri="{FF2B5EF4-FFF2-40B4-BE49-F238E27FC236}">
-                <a16:creationId xmlns:a16="http://schemas.microsoft.com/office/drawing/2014/main" id="{62ADF283-5058-442E-9D5F-9E59361DF98D}"/>
+                <a16:creationId xmlns:a16="http://schemas.microsoft.com/office/drawing/2014/main" id="{A943381B-2074-4181-9B50-73CD564AB4C1}"/>
               </a:ext>
             </a:extLst>
           </p:cNvPr>
@@ -5129,7 +5333,7 @@
           <p:cNvPr id="6" name="">
             <a:extLst xmlns:a="http://schemas.openxmlformats.org/drawingml/2006/main">
               <a:ext uri="{FF2B5EF4-FFF2-40B4-BE49-F238E27FC236}">
-                <a16:creationId xmlns:a16="http://schemas.microsoft.com/office/drawing/2014/main" id="{B728287A-08D6-4C29-B29A-DCF7C3A86C22}"/>
+                <a16:creationId xmlns:a16="http://schemas.microsoft.com/office/drawing/2014/main" id="{76681631-26A0-4727-BEFD-10CA872B8FCB}"/>
               </a:ext>
             </a:extLst>
           </p:cNvPr>
@@ -5197,7 +5401,7 @@
           <p:cNvPr id="7" name="">
             <a:extLst xmlns:a="http://schemas.openxmlformats.org/drawingml/2006/main">
               <a:ext uri="{FF2B5EF4-FFF2-40B4-BE49-F238E27FC236}">
-                <a16:creationId xmlns:a16="http://schemas.microsoft.com/office/drawing/2014/main" id="{8F0A1529-ADAB-42EF-886B-397AF968AA9A}"/>
+                <a16:creationId xmlns:a16="http://schemas.microsoft.com/office/drawing/2014/main" id="{4A8EBAEF-9788-4C5A-B66F-C1A72DE80874}"/>
               </a:ext>
             </a:extLst>
           </p:cNvPr>
@@ -5265,7 +5469,7 @@
           <p:cNvPr id="8" name="">
             <a:extLst xmlns:a="http://schemas.openxmlformats.org/drawingml/2006/main">
               <a:ext uri="{FF2B5EF4-FFF2-40B4-BE49-F238E27FC236}">
-                <a16:creationId xmlns:a16="http://schemas.microsoft.com/office/drawing/2014/main" id="{F48A92DA-9BC3-43E6-9EB2-A92BF14C999A}"/>
+                <a16:creationId xmlns:a16="http://schemas.microsoft.com/office/drawing/2014/main" id="{B23B2742-C54A-44B8-A21F-3A3C0739BA8D}"/>
               </a:ext>
             </a:extLst>
           </p:cNvPr>
@@ -5333,35 +5537,103 @@
           <p:cNvPr id="9" name="">
             <a:extLst xmlns:a="http://schemas.openxmlformats.org/drawingml/2006/main">
               <a:ext uri="{FF2B5EF4-FFF2-40B4-BE49-F238E27FC236}">
-                <a16:creationId xmlns:a16="http://schemas.microsoft.com/office/drawing/2014/main" id="{ACC02546-0767-4EB7-8FB8-3F5C14C83851}"/>
-              </a:ext>
-            </a:extLst>
-          </p:cNvPr>
-          <p:cNvSpPr>
-            <a:spLocks xmlns:a="http://schemas.openxmlformats.org/drawingml/2006/main" noGrp="1"/>
-          </p:cNvSpPr>
-          <p:nvPr/>
-        </p:nvSpPr>
-        <p:spPr>
-          <a:xfrm xmlns:a="http://schemas.openxmlformats.org/drawingml/2006/main">
-            <a:off x="609600" y="5572125"/>
-            <a:ext cx="10953750" cy="666750"/>
-          </a:xfrm>
-          <a:prstGeom xmlns:a="http://schemas.openxmlformats.org/drawingml/2006/main" prst="rect">
-            <a:avLst/>
-          </a:prstGeom>
-          <a:noFill xmlns:a="http://schemas.openxmlformats.org/drawingml/2006/main"/>
-          <a:ln xmlns:a="http://schemas.openxmlformats.org/drawingml/2006/main" w="0">
-            <a:noFill/>
-          </a:ln>
-        </p:spPr>
-        <p:txBody>
-          <a:bodyPr xmlns:a="http://schemas.openxmlformats.org/drawingml/2006/main">
-            <a:noAutofit/>
-          </a:bodyPr>
-          <a:lstStyle xmlns:a="http://schemas.openxmlformats.org/drawingml/2006/main">
-            <a:defPPr>
-              <a:defRPr sz="1650" b="0">
+                <a16:creationId xmlns:a16="http://schemas.microsoft.com/office/drawing/2014/main" id="{A8D2C9E8-7867-4F71-A1EF-AD402E9B2B83}"/>
+              </a:ext>
+            </a:extLst>
+          </p:cNvPr>
+          <p:cNvSpPr>
+            <a:spLocks xmlns:a="http://schemas.openxmlformats.org/drawingml/2006/main" noGrp="1"/>
+          </p:cNvSpPr>
+          <p:nvPr/>
+        </p:nvSpPr>
+        <p:spPr>
+          <a:xfrm xmlns:a="http://schemas.openxmlformats.org/drawingml/2006/main">
+            <a:off x="609600" y="5286375"/>
+            <a:ext cx="10953750" cy="381000"/>
+          </a:xfrm>
+          <a:prstGeom xmlns:a="http://schemas.openxmlformats.org/drawingml/2006/main" prst="rect">
+            <a:avLst/>
+          </a:prstGeom>
+          <a:noFill xmlns:a="http://schemas.openxmlformats.org/drawingml/2006/main"/>
+          <a:ln xmlns:a="http://schemas.openxmlformats.org/drawingml/2006/main" w="0">
+            <a:noFill/>
+          </a:ln>
+        </p:spPr>
+        <p:txBody>
+          <a:bodyPr xmlns:a="http://schemas.openxmlformats.org/drawingml/2006/main">
+            <a:noAutofit/>
+          </a:bodyPr>
+          <a:lstStyle xmlns:a="http://schemas.openxmlformats.org/drawingml/2006/main">
+            <a:defPPr>
+              <a:defRPr sz="1725" b="1">
+                <a:solidFill>
+                  <a:srgbClr val="FCD34D"/>
+                </a:solidFill>
+                <a:latin typeface="Arial"/>
+                <a:ea typeface="Arial"/>
+                <a:cs typeface="Arial"/>
+              </a:defRPr>
+            </a:defPPr>
+          </a:lstStyle>
+          <a:p xmlns:a="http://schemas.openxmlformats.org/drawingml/2006/main">
+            <a:pPr>
+              <a:defRPr sz="1725" b="1">
+                <a:solidFill>
+                  <a:srgbClr val="FCD34D"/>
+                </a:solidFill>
+                <a:latin typeface="Arial"/>
+                <a:ea typeface="Arial"/>
+                <a:cs typeface="Arial"/>
+              </a:defRPr>
+            </a:pPr>
+            <a:r>
+              <a:rPr sz="1725" b="1">
+                <a:solidFill>
+                  <a:srgbClr val="FCD34D"/>
+                </a:solidFill>
+                <a:latin typeface="Arial"/>
+                <a:ea typeface="Arial"/>
+                <a:cs typeface="Arial"/>
+              </a:rPr>
+              <a:t>A është Client ID e OAuth App e njëjtë me ID-në e studentit?</a:t>
+            </a:r>
+          </a:p>
+        </p:txBody>
+      </p:sp>
+      <p:sp>
+        <p:nvSpPr>
+          <p:cNvPr id="10" name="">
+            <a:extLst xmlns:a="http://schemas.openxmlformats.org/drawingml/2006/main">
+              <a:ext uri="{FF2B5EF4-FFF2-40B4-BE49-F238E27FC236}">
+                <a16:creationId xmlns:a16="http://schemas.microsoft.com/office/drawing/2014/main" id="{8913DBBD-2FB0-4B9B-9920-BAF4A693E441}"/>
+              </a:ext>
+            </a:extLst>
+          </p:cNvPr>
+          <p:cNvSpPr>
+            <a:spLocks xmlns:a="http://schemas.openxmlformats.org/drawingml/2006/main" noGrp="1"/>
+          </p:cNvSpPr>
+          <p:nvPr/>
+        </p:nvSpPr>
+        <p:spPr>
+          <a:xfrm xmlns:a="http://schemas.openxmlformats.org/drawingml/2006/main">
+            <a:off x="609600" y="5715000"/>
+            <a:ext cx="10953750" cy="619125"/>
+          </a:xfrm>
+          <a:prstGeom xmlns:a="http://schemas.openxmlformats.org/drawingml/2006/main" prst="rect">
+            <a:avLst/>
+          </a:prstGeom>
+          <a:noFill xmlns:a="http://schemas.openxmlformats.org/drawingml/2006/main"/>
+          <a:ln xmlns:a="http://schemas.openxmlformats.org/drawingml/2006/main" w="0">
+            <a:noFill/>
+          </a:ln>
+        </p:spPr>
+        <p:txBody>
+          <a:bodyPr xmlns:a="http://schemas.openxmlformats.org/drawingml/2006/main">
+            <a:noAutofit/>
+          </a:bodyPr>
+          <a:lstStyle xmlns:a="http://schemas.openxmlformats.org/drawingml/2006/main">
+            <a:defPPr>
+              <a:defRPr sz="1575" b="0">
                 <a:solidFill>
                   <a:srgbClr val="B8EDDB"/>
                 </a:solidFill>
@@ -5373,7 +5645,7 @@
           </a:lstStyle>
           <a:p xmlns:a="http://schemas.openxmlformats.org/drawingml/2006/main">
             <a:pPr>
-              <a:defRPr sz="1650" b="0">
+              <a:defRPr sz="1575" b="0">
                 <a:solidFill>
                   <a:srgbClr val="B8EDDB"/>
                 </a:solidFill>
@@ -5383,7 +5655,7 @@
               </a:defRPr>
             </a:pPr>
             <a:r>
-              <a:rPr sz="1650" b="0">
+              <a:rPr sz="1575" b="0">
                 <a:solidFill>
                   <a:srgbClr val="B8EDDB"/>
                 </a:solidFill>
@@ -5399,7 +5671,7 @@
     </p:spTree>
     <p:extLst>
       <p:ext uri="{BB962C8B-B14F-4D97-AF65-F5344CB8AC3E}">
-        <p14:creationId xmlns:p14="http://schemas.microsoft.com/office/powerpoint/2010/main" val="1692237298"/>
+        <p14:creationId xmlns:p14="http://schemas.microsoft.com/office/powerpoint/2010/main" val="1415735660"/>
       </p:ext>
     </p:extLst>
   </p:cSld>
@@ -5430,7 +5702,7 @@
           <p:cNvPr id="6" name="">
             <a:extLst xmlns:a="http://schemas.openxmlformats.org/drawingml/2006/main">
               <a:ext uri="{FF2B5EF4-FFF2-40B4-BE49-F238E27FC236}">
-                <a16:creationId xmlns:a16="http://schemas.microsoft.com/office/drawing/2014/main" id="{F4D8B6BD-294C-4383-BB1B-800873FC6F4D}"/>
+                <a16:creationId xmlns:a16="http://schemas.microsoft.com/office/drawing/2014/main" id="{B0B8B1E1-E349-4457-AB8F-69E07D480FA4}"/>
               </a:ext>
             </a:extLst>
           </p:cNvPr>
@@ -5498,7 +5770,7 @@
           <p:cNvPr id="2" name="">
             <a:extLst xmlns:a="http://schemas.openxmlformats.org/drawingml/2006/main">
               <a:ext uri="{FF2B5EF4-FFF2-40B4-BE49-F238E27FC236}">
-                <a16:creationId xmlns:a16="http://schemas.microsoft.com/office/drawing/2014/main" id="{94CC26EE-EED3-4CF4-82DE-84B37F5F7C2B}"/>
+                <a16:creationId xmlns:a16="http://schemas.microsoft.com/office/drawing/2014/main" id="{681D885F-49F4-46DD-BCE3-73273A6AFFDD}"/>
               </a:ext>
             </a:extLst>
           </p:cNvPr>
@@ -5566,7 +5838,7 @@
           <p:cNvPr id="3" name="">
             <a:extLst xmlns:a="http://schemas.openxmlformats.org/drawingml/2006/main">
               <a:ext uri="{FF2B5EF4-FFF2-40B4-BE49-F238E27FC236}">
-                <a16:creationId xmlns:a16="http://schemas.microsoft.com/office/drawing/2014/main" id="{16649C6F-B91F-4EE8-9430-71DC226BC46E}"/>
+                <a16:creationId xmlns:a16="http://schemas.microsoft.com/office/drawing/2014/main" id="{BF10FD62-6DC0-4B91-8D1D-37DE59382363}"/>
               </a:ext>
             </a:extLst>
           </p:cNvPr>
@@ -5634,7 +5906,7 @@
           <p:cNvPr id="4" name="">
             <a:extLst xmlns:a="http://schemas.openxmlformats.org/drawingml/2006/main">
               <a:ext uri="{FF2B5EF4-FFF2-40B4-BE49-F238E27FC236}">
-                <a16:creationId xmlns:a16="http://schemas.microsoft.com/office/drawing/2014/main" id="{35FC9443-7068-4787-A6E8-B4EB95FCC154}"/>
+                <a16:creationId xmlns:a16="http://schemas.microsoft.com/office/drawing/2014/main" id="{BF5343A5-315F-4876-B75F-B8025EFD9E36}"/>
               </a:ext>
             </a:extLst>
           </p:cNvPr>
@@ -5758,7 +6030,7 @@
           <p:cNvPr id="5" name="">
             <a:extLst xmlns:a="http://schemas.openxmlformats.org/drawingml/2006/main">
               <a:ext uri="{FF2B5EF4-FFF2-40B4-BE49-F238E27FC236}">
-                <a16:creationId xmlns:a16="http://schemas.microsoft.com/office/drawing/2014/main" id="{097B2CCE-9A3F-4F08-AF51-0DE551F18C0E}"/>
+                <a16:creationId xmlns:a16="http://schemas.microsoft.com/office/drawing/2014/main" id="{8F8C3E87-766E-4FE7-93D3-61A3D94F25D0}"/>
               </a:ext>
             </a:extLst>
           </p:cNvPr>
@@ -5824,7 +6096,7 @@
     </p:spTree>
     <p:extLst>
       <p:ext uri="{BB962C8B-B14F-4D97-AF65-F5344CB8AC3E}">
-        <p14:creationId xmlns:p14="http://schemas.microsoft.com/office/powerpoint/2010/main" val="15559307"/>
+        <p14:creationId xmlns:p14="http://schemas.microsoft.com/office/powerpoint/2010/main" val="1209609110"/>
       </p:ext>
     </p:extLst>
   </p:cSld>
@@ -5855,7 +6127,7 @@
           <p:cNvPr id="8" name="">
             <a:extLst xmlns:a="http://schemas.openxmlformats.org/drawingml/2006/main">
               <a:ext uri="{FF2B5EF4-FFF2-40B4-BE49-F238E27FC236}">
-                <a16:creationId xmlns:a16="http://schemas.microsoft.com/office/drawing/2014/main" id="{435F221A-FE7A-4229-88DB-16222E3A987B}"/>
+                <a16:creationId xmlns:a16="http://schemas.microsoft.com/office/drawing/2014/main" id="{F913994A-9A5C-48C1-9ECB-167E59C05492}"/>
               </a:ext>
             </a:extLst>
           </p:cNvPr>
@@ -5923,7 +6195,7 @@
           <p:cNvPr id="2" name="">
             <a:extLst xmlns:a="http://schemas.openxmlformats.org/drawingml/2006/main">
               <a:ext uri="{FF2B5EF4-FFF2-40B4-BE49-F238E27FC236}">
-                <a16:creationId xmlns:a16="http://schemas.microsoft.com/office/drawing/2014/main" id="{FDF0E47C-4E11-4200-A71F-4E160B891A32}"/>
+                <a16:creationId xmlns:a16="http://schemas.microsoft.com/office/drawing/2014/main" id="{6A256729-9A15-4D94-ABCF-A258967B7F99}"/>
               </a:ext>
             </a:extLst>
           </p:cNvPr>
@@ -5991,7 +6263,7 @@
           <p:cNvPr id="3" name="">
             <a:extLst xmlns:a="http://schemas.openxmlformats.org/drawingml/2006/main">
               <a:ext uri="{FF2B5EF4-FFF2-40B4-BE49-F238E27FC236}">
-                <a16:creationId xmlns:a16="http://schemas.microsoft.com/office/drawing/2014/main" id="{9D566BCF-23C7-4C1A-8490-D0E9779003E4}"/>
+                <a16:creationId xmlns:a16="http://schemas.microsoft.com/office/drawing/2014/main" id="{03389279-1A01-4382-A984-8451742AA7A9}"/>
               </a:ext>
             </a:extLst>
           </p:cNvPr>
@@ -6059,7 +6331,7 @@
           <p:cNvPr id="4" name="">
             <a:extLst xmlns:a="http://schemas.openxmlformats.org/drawingml/2006/main">
               <a:ext uri="{FF2B5EF4-FFF2-40B4-BE49-F238E27FC236}">
-                <a16:creationId xmlns:a16="http://schemas.microsoft.com/office/drawing/2014/main" id="{AF11E5B9-9349-47F6-9F04-922C73F75795}"/>
+                <a16:creationId xmlns:a16="http://schemas.microsoft.com/office/drawing/2014/main" id="{E0C1BF39-D128-43EB-B5DD-5A2121C58F49}"/>
               </a:ext>
             </a:extLst>
           </p:cNvPr>
@@ -6127,7 +6399,7 @@
           <p:cNvPr id="5" name="">
             <a:extLst xmlns:a="http://schemas.openxmlformats.org/drawingml/2006/main">
               <a:ext uri="{FF2B5EF4-FFF2-40B4-BE49-F238E27FC236}">
-                <a16:creationId xmlns:a16="http://schemas.microsoft.com/office/drawing/2014/main" id="{A0FF6E8F-A2AF-4BC9-8D1B-2F9A8AA21A84}"/>
+                <a16:creationId xmlns:a16="http://schemas.microsoft.com/office/drawing/2014/main" id="{D056FCE8-9BB2-41BF-86F1-DA12CAD728CF}"/>
               </a:ext>
             </a:extLst>
           </p:cNvPr>
@@ -6195,7 +6467,7 @@
           <p:cNvPr id="6" name="">
             <a:extLst xmlns:a="http://schemas.openxmlformats.org/drawingml/2006/main">
               <a:ext uri="{FF2B5EF4-FFF2-40B4-BE49-F238E27FC236}">
-                <a16:creationId xmlns:a16="http://schemas.microsoft.com/office/drawing/2014/main" id="{A378450E-E438-44CD-A8D4-5BDD7739DE35}"/>
+                <a16:creationId xmlns:a16="http://schemas.microsoft.com/office/drawing/2014/main" id="{923439CE-4055-428F-848A-82425F8440A1}"/>
               </a:ext>
             </a:extLst>
           </p:cNvPr>
@@ -6319,7 +6591,7 @@
           <p:cNvPr id="7" name="">
             <a:extLst xmlns:a="http://schemas.openxmlformats.org/drawingml/2006/main">
               <a:ext uri="{FF2B5EF4-FFF2-40B4-BE49-F238E27FC236}">
-                <a16:creationId xmlns:a16="http://schemas.microsoft.com/office/drawing/2014/main" id="{44C6D7F4-9D8B-47DC-AE7E-9D3B7E2FC9EB}"/>
+                <a16:creationId xmlns:a16="http://schemas.microsoft.com/office/drawing/2014/main" id="{E57A6BE9-8A16-4ADC-B307-5EC773C10125}"/>
               </a:ext>
             </a:extLst>
           </p:cNvPr>
@@ -6385,7 +6657,7 @@
     </p:spTree>
     <p:extLst>
       <p:ext uri="{BB962C8B-B14F-4D97-AF65-F5344CB8AC3E}">
-        <p14:creationId xmlns:p14="http://schemas.microsoft.com/office/powerpoint/2010/main" val="1249540699"/>
+        <p14:creationId xmlns:p14="http://schemas.microsoft.com/office/powerpoint/2010/main" val="1138089406"/>
       </p:ext>
     </p:extLst>
   </p:cSld>
@@ -6413,10 +6685,10 @@
       </p:grpSpPr>
       <p:sp>
         <p:nvSpPr>
-          <p:cNvPr id="6" name="">
-            <a:extLst xmlns:a="http://schemas.openxmlformats.org/drawingml/2006/main">
-              <a:ext uri="{FF2B5EF4-FFF2-40B4-BE49-F238E27FC236}">
-                <a16:creationId xmlns:a16="http://schemas.microsoft.com/office/drawing/2014/main" id="{95AEE042-2AB1-4FE2-8540-BBCEEB24C2E6}"/>
+          <p:cNvPr id="7" name="">
+            <a:extLst xmlns:a="http://schemas.openxmlformats.org/drawingml/2006/main">
+              <a:ext uri="{FF2B5EF4-FFF2-40B4-BE49-F238E27FC236}">
+                <a16:creationId xmlns:a16="http://schemas.microsoft.com/office/drawing/2014/main" id="{8C24EF9C-F56D-44FD-ACBF-BE072F05C909}"/>
               </a:ext>
             </a:extLst>
           </p:cNvPr>
@@ -6484,7 +6756,7 @@
           <p:cNvPr id="2" name="">
             <a:extLst xmlns:a="http://schemas.openxmlformats.org/drawingml/2006/main">
               <a:ext uri="{FF2B5EF4-FFF2-40B4-BE49-F238E27FC236}">
-                <a16:creationId xmlns:a16="http://schemas.microsoft.com/office/drawing/2014/main" id="{1C265257-5331-40EA-911A-4B919A4EF83F}"/>
+                <a16:creationId xmlns:a16="http://schemas.microsoft.com/office/drawing/2014/main" id="{A76F5D79-6828-4CD2-B715-9FC7E3F23868}"/>
               </a:ext>
             </a:extLst>
           </p:cNvPr>
@@ -6552,7 +6824,7 @@
           <p:cNvPr id="3" name="">
             <a:extLst xmlns:a="http://schemas.openxmlformats.org/drawingml/2006/main">
               <a:ext uri="{FF2B5EF4-FFF2-40B4-BE49-F238E27FC236}">
-                <a16:creationId xmlns:a16="http://schemas.microsoft.com/office/drawing/2014/main" id="{7A03006B-8263-43D6-BBF0-6F342EE53E48}"/>
+                <a16:creationId xmlns:a16="http://schemas.microsoft.com/office/drawing/2014/main" id="{E1567091-EF1C-40FC-9D6E-7D18B8CE7E4A}"/>
               </a:ext>
             </a:extLst>
           </p:cNvPr>
@@ -6620,7 +6892,7 @@
           <p:cNvPr id="4" name="">
             <a:extLst xmlns:a="http://schemas.openxmlformats.org/drawingml/2006/main">
               <a:ext uri="{FF2B5EF4-FFF2-40B4-BE49-F238E27FC236}">
-                <a16:creationId xmlns:a16="http://schemas.microsoft.com/office/drawing/2014/main" id="{03FBD2AE-3EED-4F1F-B4CB-A3DED4D6A423}"/>
+                <a16:creationId xmlns:a16="http://schemas.microsoft.com/office/drawing/2014/main" id="{1B2E7438-EA40-444A-840C-254B2E444E06}"/>
               </a:ext>
             </a:extLst>
           </p:cNvPr>
@@ -6744,35 +7016,103 @@
           <p:cNvPr id="5" name="">
             <a:extLst xmlns:a="http://schemas.openxmlformats.org/drawingml/2006/main">
               <a:ext uri="{FF2B5EF4-FFF2-40B4-BE49-F238E27FC236}">
-                <a16:creationId xmlns:a16="http://schemas.microsoft.com/office/drawing/2014/main" id="{0AFADFCB-9B00-478E-B812-C937158813DB}"/>
-              </a:ext>
-            </a:extLst>
-          </p:cNvPr>
-          <p:cNvSpPr>
-            <a:spLocks xmlns:a="http://schemas.openxmlformats.org/drawingml/2006/main" noGrp="1"/>
-          </p:cNvSpPr>
-          <p:nvPr/>
-        </p:nvSpPr>
-        <p:spPr>
-          <a:xfrm xmlns:a="http://schemas.openxmlformats.org/drawingml/2006/main">
-            <a:off x="609600" y="5572125"/>
-            <a:ext cx="10953750" cy="666750"/>
-          </a:xfrm>
-          <a:prstGeom xmlns:a="http://schemas.openxmlformats.org/drawingml/2006/main" prst="rect">
-            <a:avLst/>
-          </a:prstGeom>
-          <a:noFill xmlns:a="http://schemas.openxmlformats.org/drawingml/2006/main"/>
-          <a:ln xmlns:a="http://schemas.openxmlformats.org/drawingml/2006/main" w="0">
-            <a:noFill/>
-          </a:ln>
-        </p:spPr>
-        <p:txBody>
-          <a:bodyPr xmlns:a="http://schemas.openxmlformats.org/drawingml/2006/main">
-            <a:noAutofit/>
-          </a:bodyPr>
-          <a:lstStyle xmlns:a="http://schemas.openxmlformats.org/drawingml/2006/main">
-            <a:defPPr>
-              <a:defRPr sz="1650" b="0">
+                <a16:creationId xmlns:a16="http://schemas.microsoft.com/office/drawing/2014/main" id="{DD821832-E5B1-4833-B2EB-479265342BFE}"/>
+              </a:ext>
+            </a:extLst>
+          </p:cNvPr>
+          <p:cNvSpPr>
+            <a:spLocks xmlns:a="http://schemas.openxmlformats.org/drawingml/2006/main" noGrp="1"/>
+          </p:cNvSpPr>
+          <p:nvPr/>
+        </p:nvSpPr>
+        <p:spPr>
+          <a:xfrm xmlns:a="http://schemas.openxmlformats.org/drawingml/2006/main">
+            <a:off x="609600" y="5286375"/>
+            <a:ext cx="10953750" cy="381000"/>
+          </a:xfrm>
+          <a:prstGeom xmlns:a="http://schemas.openxmlformats.org/drawingml/2006/main" prst="rect">
+            <a:avLst/>
+          </a:prstGeom>
+          <a:noFill xmlns:a="http://schemas.openxmlformats.org/drawingml/2006/main"/>
+          <a:ln xmlns:a="http://schemas.openxmlformats.org/drawingml/2006/main" w="0">
+            <a:noFill/>
+          </a:ln>
+        </p:spPr>
+        <p:txBody>
+          <a:bodyPr xmlns:a="http://schemas.openxmlformats.org/drawingml/2006/main">
+            <a:noAutofit/>
+          </a:bodyPr>
+          <a:lstStyle xmlns:a="http://schemas.openxmlformats.org/drawingml/2006/main">
+            <a:defPPr>
+              <a:defRPr sz="1725" b="1">
+                <a:solidFill>
+                  <a:srgbClr val="FCD34D"/>
+                </a:solidFill>
+                <a:latin typeface="Arial"/>
+                <a:ea typeface="Arial"/>
+                <a:cs typeface="Arial"/>
+              </a:defRPr>
+            </a:defPPr>
+          </a:lstStyle>
+          <a:p xmlns:a="http://schemas.openxmlformats.org/drawingml/2006/main">
+            <a:pPr>
+              <a:defRPr sz="1725" b="1">
+                <a:solidFill>
+                  <a:srgbClr val="FCD34D"/>
+                </a:solidFill>
+                <a:latin typeface="Arial"/>
+                <a:ea typeface="Arial"/>
+                <a:cs typeface="Arial"/>
+              </a:defRPr>
+            </a:pPr>
+            <a:r>
+              <a:rPr sz="1725" b="1">
+                <a:solidFill>
+                  <a:srgbClr val="FCD34D"/>
+                </a:solidFill>
+                <a:latin typeface="Arial"/>
+                <a:ea typeface="Arial"/>
+                <a:cs typeface="Arial"/>
+              </a:rPr>
+              <a:t>Çfarë dallimi kanë mungesa e identifikimit dhe mungesa e lejes?</a:t>
+            </a:r>
+          </a:p>
+        </p:txBody>
+      </p:sp>
+      <p:sp>
+        <p:nvSpPr>
+          <p:cNvPr id="6" name="">
+            <a:extLst xmlns:a="http://schemas.openxmlformats.org/drawingml/2006/main">
+              <a:ext uri="{FF2B5EF4-FFF2-40B4-BE49-F238E27FC236}">
+                <a16:creationId xmlns:a16="http://schemas.microsoft.com/office/drawing/2014/main" id="{195F6528-3D29-4381-A8FF-7EBDB7573B00}"/>
+              </a:ext>
+            </a:extLst>
+          </p:cNvPr>
+          <p:cNvSpPr>
+            <a:spLocks xmlns:a="http://schemas.openxmlformats.org/drawingml/2006/main" noGrp="1"/>
+          </p:cNvSpPr>
+          <p:nvPr/>
+        </p:nvSpPr>
+        <p:spPr>
+          <a:xfrm xmlns:a="http://schemas.openxmlformats.org/drawingml/2006/main">
+            <a:off x="609600" y="5715000"/>
+            <a:ext cx="10953750" cy="619125"/>
+          </a:xfrm>
+          <a:prstGeom xmlns:a="http://schemas.openxmlformats.org/drawingml/2006/main" prst="rect">
+            <a:avLst/>
+          </a:prstGeom>
+          <a:noFill xmlns:a="http://schemas.openxmlformats.org/drawingml/2006/main"/>
+          <a:ln xmlns:a="http://schemas.openxmlformats.org/drawingml/2006/main" w="0">
+            <a:noFill/>
+          </a:ln>
+        </p:spPr>
+        <p:txBody>
+          <a:bodyPr xmlns:a="http://schemas.openxmlformats.org/drawingml/2006/main">
+            <a:noAutofit/>
+          </a:bodyPr>
+          <a:lstStyle xmlns:a="http://schemas.openxmlformats.org/drawingml/2006/main">
+            <a:defPPr>
+              <a:defRPr sz="1575" b="0">
                 <a:solidFill>
                   <a:srgbClr val="B8EDDB"/>
                 </a:solidFill>
@@ -6784,7 +7124,7 @@
           </a:lstStyle>
           <a:p xmlns:a="http://schemas.openxmlformats.org/drawingml/2006/main">
             <a:pPr>
-              <a:defRPr sz="1650" b="0">
+              <a:defRPr sz="1575" b="0">
                 <a:solidFill>
                   <a:srgbClr val="B8EDDB"/>
                 </a:solidFill>
@@ -6794,7 +7134,7 @@
               </a:defRPr>
             </a:pPr>
             <a:r>
-              <a:rPr sz="1650" b="0">
+              <a:rPr sz="1575" b="0">
                 <a:solidFill>
                   <a:srgbClr val="B8EDDB"/>
                 </a:solidFill>
@@ -6810,7 +7150,7 @@
     </p:spTree>
     <p:extLst>
       <p:ext uri="{BB962C8B-B14F-4D97-AF65-F5344CB8AC3E}">
-        <p14:creationId xmlns:p14="http://schemas.microsoft.com/office/powerpoint/2010/main" val="894270845"/>
+        <p14:creationId xmlns:p14="http://schemas.microsoft.com/office/powerpoint/2010/main" val="2078852313"/>
       </p:ext>
     </p:extLst>
   </p:cSld>
@@ -6841,7 +7181,7 @@
           <p:cNvPr id="6" name="">
             <a:extLst xmlns:a="http://schemas.openxmlformats.org/drawingml/2006/main">
               <a:ext uri="{FF2B5EF4-FFF2-40B4-BE49-F238E27FC236}">
-                <a16:creationId xmlns:a16="http://schemas.microsoft.com/office/drawing/2014/main" id="{F1161FEB-3EC2-4985-ABB6-9BF2C7A39BAE}"/>
+                <a16:creationId xmlns:a16="http://schemas.microsoft.com/office/drawing/2014/main" id="{B3A2D822-B3F5-45B7-B087-68ABF2BF73F0}"/>
               </a:ext>
             </a:extLst>
           </p:cNvPr>
@@ -6909,7 +7249,7 @@
           <p:cNvPr id="2" name="">
             <a:extLst xmlns:a="http://schemas.openxmlformats.org/drawingml/2006/main">
               <a:ext uri="{FF2B5EF4-FFF2-40B4-BE49-F238E27FC236}">
-                <a16:creationId xmlns:a16="http://schemas.microsoft.com/office/drawing/2014/main" id="{1191A453-EA89-49DD-BE5E-6FAD251480B2}"/>
+                <a16:creationId xmlns:a16="http://schemas.microsoft.com/office/drawing/2014/main" id="{4A7C10CC-4576-4C9F-B965-1C84129D2EAE}"/>
               </a:ext>
             </a:extLst>
           </p:cNvPr>
@@ -6977,7 +7317,7 @@
           <p:cNvPr id="3" name="">
             <a:extLst xmlns:a="http://schemas.openxmlformats.org/drawingml/2006/main">
               <a:ext uri="{FF2B5EF4-FFF2-40B4-BE49-F238E27FC236}">
-                <a16:creationId xmlns:a16="http://schemas.microsoft.com/office/drawing/2014/main" id="{17DB00FA-42A0-45BB-8490-30083425C2D2}"/>
+                <a16:creationId xmlns:a16="http://schemas.microsoft.com/office/drawing/2014/main" id="{106B2055-691C-433A-A79A-BB8706E9DD98}"/>
               </a:ext>
             </a:extLst>
           </p:cNvPr>
@@ -7045,7 +7385,7 @@
           <p:cNvPr id="4" name="">
             <a:extLst xmlns:a="http://schemas.openxmlformats.org/drawingml/2006/main">
               <a:ext uri="{FF2B5EF4-FFF2-40B4-BE49-F238E27FC236}">
-                <a16:creationId xmlns:a16="http://schemas.microsoft.com/office/drawing/2014/main" id="{FC27FF9A-6354-4033-97E7-C26020F5EC32}"/>
+                <a16:creationId xmlns:a16="http://schemas.microsoft.com/office/drawing/2014/main" id="{86BB3108-F818-4DDC-B90D-1A27073CE984}"/>
               </a:ext>
             </a:extLst>
           </p:cNvPr>
@@ -7169,7 +7509,7 @@
           <p:cNvPr id="5" name="">
             <a:extLst xmlns:a="http://schemas.openxmlformats.org/drawingml/2006/main">
               <a:ext uri="{FF2B5EF4-FFF2-40B4-BE49-F238E27FC236}">
-                <a16:creationId xmlns:a16="http://schemas.microsoft.com/office/drawing/2014/main" id="{97949D0D-2F58-40FB-9C92-DC0B27BF7077}"/>
+                <a16:creationId xmlns:a16="http://schemas.microsoft.com/office/drawing/2014/main" id="{D459CCBD-C58F-4D9E-9A4F-8107419F5C49}"/>
               </a:ext>
             </a:extLst>
           </p:cNvPr>
@@ -7235,7 +7575,7 @@
     </p:spTree>
     <p:extLst>
       <p:ext uri="{BB962C8B-B14F-4D97-AF65-F5344CB8AC3E}">
-        <p14:creationId xmlns:p14="http://schemas.microsoft.com/office/powerpoint/2010/main" val="1109274683"/>
+        <p14:creationId xmlns:p14="http://schemas.microsoft.com/office/powerpoint/2010/main" val="1538173250"/>
       </p:ext>
     </p:extLst>
   </p:cSld>
@@ -7266,7 +7606,7 @@
           <p:cNvPr id="9" name="">
             <a:extLst xmlns:a="http://schemas.openxmlformats.org/drawingml/2006/main">
               <a:ext uri="{FF2B5EF4-FFF2-40B4-BE49-F238E27FC236}">
-                <a16:creationId xmlns:a16="http://schemas.microsoft.com/office/drawing/2014/main" id="{B16BC36A-8E0A-4F25-AE64-4A9D3FAF1AFE}"/>
+                <a16:creationId xmlns:a16="http://schemas.microsoft.com/office/drawing/2014/main" id="{10A3C018-006D-4769-8F7F-876BB96F61BC}"/>
               </a:ext>
             </a:extLst>
           </p:cNvPr>
@@ -7334,7 +7674,7 @@
           <p:cNvPr id="2" name="">
             <a:extLst xmlns:a="http://schemas.openxmlformats.org/drawingml/2006/main">
               <a:ext uri="{FF2B5EF4-FFF2-40B4-BE49-F238E27FC236}">
-                <a16:creationId xmlns:a16="http://schemas.microsoft.com/office/drawing/2014/main" id="{DC06B9D3-2909-4442-9E6F-398523030730}"/>
+                <a16:creationId xmlns:a16="http://schemas.microsoft.com/office/drawing/2014/main" id="{70734608-FF87-48EA-AE94-3A8B052B86B6}"/>
               </a:ext>
             </a:extLst>
           </p:cNvPr>
@@ -7402,7 +7742,7 @@
           <p:cNvPr id="3" name="">
             <a:extLst xmlns:a="http://schemas.openxmlformats.org/drawingml/2006/main">
               <a:ext uri="{FF2B5EF4-FFF2-40B4-BE49-F238E27FC236}">
-                <a16:creationId xmlns:a16="http://schemas.microsoft.com/office/drawing/2014/main" id="{320BB8EA-A950-48A9-8601-80BA784171DD}"/>
+                <a16:creationId xmlns:a16="http://schemas.microsoft.com/office/drawing/2014/main" id="{787748FC-7390-43B7-9EEE-6AD2BD9B1D2F}"/>
               </a:ext>
             </a:extLst>
           </p:cNvPr>
@@ -7470,7 +7810,7 @@
           <p:cNvPr id="4" name="">
             <a:extLst xmlns:a="http://schemas.openxmlformats.org/drawingml/2006/main">
               <a:ext uri="{FF2B5EF4-FFF2-40B4-BE49-F238E27FC236}">
-                <a16:creationId xmlns:a16="http://schemas.microsoft.com/office/drawing/2014/main" id="{F9F23B38-1926-4CEE-B212-F46DFA6C77D0}"/>
+                <a16:creationId xmlns:a16="http://schemas.microsoft.com/office/drawing/2014/main" id="{B5FAE35D-C20B-44B6-8669-FDDB7B15C802}"/>
               </a:ext>
             </a:extLst>
           </p:cNvPr>
@@ -7594,7 +7934,7 @@
           <p:cNvPr id="5" name="">
             <a:extLst xmlns:a="http://schemas.openxmlformats.org/drawingml/2006/main">
               <a:ext uri="{FF2B5EF4-FFF2-40B4-BE49-F238E27FC236}">
-                <a16:creationId xmlns:a16="http://schemas.microsoft.com/office/drawing/2014/main" id="{464BAA32-A48A-4094-BCA5-D14C5BB0D8CF}"/>
+                <a16:creationId xmlns:a16="http://schemas.microsoft.com/office/drawing/2014/main" id="{EFCE1189-9862-41EA-BD36-CB8B4865A3CF}"/>
               </a:ext>
             </a:extLst>
           </p:cNvPr>
@@ -7662,7 +8002,7 @@
           <p:cNvPr id="6" name="">
             <a:extLst xmlns:a="http://schemas.openxmlformats.org/drawingml/2006/main">
               <a:ext uri="{FF2B5EF4-FFF2-40B4-BE49-F238E27FC236}">
-                <a16:creationId xmlns:a16="http://schemas.microsoft.com/office/drawing/2014/main" id="{A7EF321A-E47D-4A11-ACCC-52D97A002547}"/>
+                <a16:creationId xmlns:a16="http://schemas.microsoft.com/office/drawing/2014/main" id="{BF714F24-1819-44DC-9C53-539AC67E5049}"/>
               </a:ext>
             </a:extLst>
           </p:cNvPr>
@@ -7730,7 +8070,7 @@
           <p:cNvPr id="7" name="">
             <a:extLst xmlns:a="http://schemas.openxmlformats.org/drawingml/2006/main">
               <a:ext uri="{FF2B5EF4-FFF2-40B4-BE49-F238E27FC236}">
-                <a16:creationId xmlns:a16="http://schemas.microsoft.com/office/drawing/2014/main" id="{DFA42537-B635-4171-84AC-4052BE7A3A1F}"/>
+                <a16:creationId xmlns:a16="http://schemas.microsoft.com/office/drawing/2014/main" id="{867560BA-4E22-414A-88CB-5CA30BB3704E}"/>
               </a:ext>
             </a:extLst>
           </p:cNvPr>
@@ -7798,7 +8138,7 @@
           <p:cNvPr id="8" name="">
             <a:extLst xmlns:a="http://schemas.openxmlformats.org/drawingml/2006/main">
               <a:ext uri="{FF2B5EF4-FFF2-40B4-BE49-F238E27FC236}">
-                <a16:creationId xmlns:a16="http://schemas.microsoft.com/office/drawing/2014/main" id="{15239756-1B46-46DB-94D2-3E6EAD2F9E9B}"/>
+                <a16:creationId xmlns:a16="http://schemas.microsoft.com/office/drawing/2014/main" id="{FCDDF138-B716-47E3-8450-E7C302A8FBCF}"/>
               </a:ext>
             </a:extLst>
           </p:cNvPr>
@@ -7864,7 +8204,7 @@
     </p:spTree>
     <p:extLst>
       <p:ext uri="{BB962C8B-B14F-4D97-AF65-F5344CB8AC3E}">
-        <p14:creationId xmlns:p14="http://schemas.microsoft.com/office/powerpoint/2010/main" val="1771805756"/>
+        <p14:creationId xmlns:p14="http://schemas.microsoft.com/office/powerpoint/2010/main" val="765819419"/>
       </p:ext>
     </p:extLst>
   </p:cSld>
@@ -7892,10 +8232,10 @@
       </p:grpSpPr>
       <p:sp>
         <p:nvSpPr>
-          <p:cNvPr id="6" name="">
-            <a:extLst xmlns:a="http://schemas.openxmlformats.org/drawingml/2006/main">
-              <a:ext uri="{FF2B5EF4-FFF2-40B4-BE49-F238E27FC236}">
-                <a16:creationId xmlns:a16="http://schemas.microsoft.com/office/drawing/2014/main" id="{680AD879-9D7F-4D07-89EC-5778F688A028}"/>
+          <p:cNvPr id="7" name="">
+            <a:extLst xmlns:a="http://schemas.openxmlformats.org/drawingml/2006/main">
+              <a:ext uri="{FF2B5EF4-FFF2-40B4-BE49-F238E27FC236}">
+                <a16:creationId xmlns:a16="http://schemas.microsoft.com/office/drawing/2014/main" id="{60775D23-81F9-4D72-B4F8-E2C4C763E983}"/>
               </a:ext>
             </a:extLst>
           </p:cNvPr>
@@ -7963,7 +8303,7 @@
           <p:cNvPr id="2" name="">
             <a:extLst xmlns:a="http://schemas.openxmlformats.org/drawingml/2006/main">
               <a:ext uri="{FF2B5EF4-FFF2-40B4-BE49-F238E27FC236}">
-                <a16:creationId xmlns:a16="http://schemas.microsoft.com/office/drawing/2014/main" id="{A862F58D-6AC3-4E6E-94CB-CADEDA713850}"/>
+                <a16:creationId xmlns:a16="http://schemas.microsoft.com/office/drawing/2014/main" id="{A9FED132-FAE0-4D9F-B598-F2A576F87879}"/>
               </a:ext>
             </a:extLst>
           </p:cNvPr>
@@ -8031,7 +8371,7 @@
           <p:cNvPr id="3" name="">
             <a:extLst xmlns:a="http://schemas.openxmlformats.org/drawingml/2006/main">
               <a:ext uri="{FF2B5EF4-FFF2-40B4-BE49-F238E27FC236}">
-                <a16:creationId xmlns:a16="http://schemas.microsoft.com/office/drawing/2014/main" id="{8CA53901-B401-4D89-B0DA-E1A372B75296}"/>
+                <a16:creationId xmlns:a16="http://schemas.microsoft.com/office/drawing/2014/main" id="{5E047686-B2BB-4EA1-9E44-6D916573146F}"/>
               </a:ext>
             </a:extLst>
           </p:cNvPr>
@@ -8099,7 +8439,7 @@
           <p:cNvPr id="4" name="">
             <a:extLst xmlns:a="http://schemas.openxmlformats.org/drawingml/2006/main">
               <a:ext uri="{FF2B5EF4-FFF2-40B4-BE49-F238E27FC236}">
-                <a16:creationId xmlns:a16="http://schemas.microsoft.com/office/drawing/2014/main" id="{E87FE26B-36F1-4FD8-AFAA-9758EF35E5D8}"/>
+                <a16:creationId xmlns:a16="http://schemas.microsoft.com/office/drawing/2014/main" id="{42818586-4014-4581-B23B-BE1228F8F8E4}"/>
               </a:ext>
             </a:extLst>
           </p:cNvPr>
@@ -8223,35 +8563,103 @@
           <p:cNvPr id="5" name="">
             <a:extLst xmlns:a="http://schemas.openxmlformats.org/drawingml/2006/main">
               <a:ext uri="{FF2B5EF4-FFF2-40B4-BE49-F238E27FC236}">
-                <a16:creationId xmlns:a16="http://schemas.microsoft.com/office/drawing/2014/main" id="{F41B9B38-DFBC-4794-B0C2-AF13B8D6C260}"/>
-              </a:ext>
-            </a:extLst>
-          </p:cNvPr>
-          <p:cNvSpPr>
-            <a:spLocks xmlns:a="http://schemas.openxmlformats.org/drawingml/2006/main" noGrp="1"/>
-          </p:cNvSpPr>
-          <p:nvPr/>
-        </p:nvSpPr>
-        <p:spPr>
-          <a:xfrm xmlns:a="http://schemas.openxmlformats.org/drawingml/2006/main">
-            <a:off x="609600" y="5572125"/>
-            <a:ext cx="10953750" cy="666750"/>
-          </a:xfrm>
-          <a:prstGeom xmlns:a="http://schemas.openxmlformats.org/drawingml/2006/main" prst="rect">
-            <a:avLst/>
-          </a:prstGeom>
-          <a:noFill xmlns:a="http://schemas.openxmlformats.org/drawingml/2006/main"/>
-          <a:ln xmlns:a="http://schemas.openxmlformats.org/drawingml/2006/main" w="0">
-            <a:noFill/>
-          </a:ln>
-        </p:spPr>
-        <p:txBody>
-          <a:bodyPr xmlns:a="http://schemas.openxmlformats.org/drawingml/2006/main">
-            <a:noAutofit/>
-          </a:bodyPr>
-          <a:lstStyle xmlns:a="http://schemas.openxmlformats.org/drawingml/2006/main">
-            <a:defPPr>
-              <a:defRPr sz="1650" b="0">
+                <a16:creationId xmlns:a16="http://schemas.microsoft.com/office/drawing/2014/main" id="{B0A7B426-DABE-4203-8498-1653859F0445}"/>
+              </a:ext>
+            </a:extLst>
+          </p:cNvPr>
+          <p:cNvSpPr>
+            <a:spLocks xmlns:a="http://schemas.openxmlformats.org/drawingml/2006/main" noGrp="1"/>
+          </p:cNvSpPr>
+          <p:nvPr/>
+        </p:nvSpPr>
+        <p:spPr>
+          <a:xfrm xmlns:a="http://schemas.openxmlformats.org/drawingml/2006/main">
+            <a:off x="609600" y="5286375"/>
+            <a:ext cx="10953750" cy="381000"/>
+          </a:xfrm>
+          <a:prstGeom xmlns:a="http://schemas.openxmlformats.org/drawingml/2006/main" prst="rect">
+            <a:avLst/>
+          </a:prstGeom>
+          <a:noFill xmlns:a="http://schemas.openxmlformats.org/drawingml/2006/main"/>
+          <a:ln xmlns:a="http://schemas.openxmlformats.org/drawingml/2006/main" w="0">
+            <a:noFill/>
+          </a:ln>
+        </p:spPr>
+        <p:txBody>
+          <a:bodyPr xmlns:a="http://schemas.openxmlformats.org/drawingml/2006/main">
+            <a:noAutofit/>
+          </a:bodyPr>
+          <a:lstStyle xmlns:a="http://schemas.openxmlformats.org/drawingml/2006/main">
+            <a:defPPr>
+              <a:defRPr sz="1725" b="1">
+                <a:solidFill>
+                  <a:srgbClr val="FCD34D"/>
+                </a:solidFill>
+                <a:latin typeface="Arial"/>
+                <a:ea typeface="Arial"/>
+                <a:cs typeface="Arial"/>
+              </a:defRPr>
+            </a:defPPr>
+          </a:lstStyle>
+          <a:p xmlns:a="http://schemas.openxmlformats.org/drawingml/2006/main">
+            <a:pPr>
+              <a:defRPr sz="1725" b="1">
+                <a:solidFill>
+                  <a:srgbClr val="FCD34D"/>
+                </a:solidFill>
+                <a:latin typeface="Arial"/>
+                <a:ea typeface="Arial"/>
+                <a:cs typeface="Arial"/>
+              </a:defRPr>
+            </a:pPr>
+            <a:r>
+              <a:rPr sz="1725" b="1">
+                <a:solidFill>
+                  <a:srgbClr val="FCD34D"/>
+                </a:solidFill>
+                <a:latin typeface="Arial"/>
+                <a:ea typeface="Arial"/>
+                <a:cs typeface="Arial"/>
+              </a:rPr>
+              <a:t>Kush verifikon identitetin, ku ruhet roli dhe kush vendos për ndryshimin?</a:t>
+            </a:r>
+          </a:p>
+        </p:txBody>
+      </p:sp>
+      <p:sp>
+        <p:nvSpPr>
+          <p:cNvPr id="6" name="">
+            <a:extLst xmlns:a="http://schemas.openxmlformats.org/drawingml/2006/main">
+              <a:ext uri="{FF2B5EF4-FFF2-40B4-BE49-F238E27FC236}">
+                <a16:creationId xmlns:a16="http://schemas.microsoft.com/office/drawing/2014/main" id="{E6AF49E4-C5CE-4CDF-82FC-85CB898E6C82}"/>
+              </a:ext>
+            </a:extLst>
+          </p:cNvPr>
+          <p:cNvSpPr>
+            <a:spLocks xmlns:a="http://schemas.openxmlformats.org/drawingml/2006/main" noGrp="1"/>
+          </p:cNvSpPr>
+          <p:nvPr/>
+        </p:nvSpPr>
+        <p:spPr>
+          <a:xfrm xmlns:a="http://schemas.openxmlformats.org/drawingml/2006/main">
+            <a:off x="609600" y="5715000"/>
+            <a:ext cx="10953750" cy="619125"/>
+          </a:xfrm>
+          <a:prstGeom xmlns:a="http://schemas.openxmlformats.org/drawingml/2006/main" prst="rect">
+            <a:avLst/>
+          </a:prstGeom>
+          <a:noFill xmlns:a="http://schemas.openxmlformats.org/drawingml/2006/main"/>
+          <a:ln xmlns:a="http://schemas.openxmlformats.org/drawingml/2006/main" w="0">
+            <a:noFill/>
+          </a:ln>
+        </p:spPr>
+        <p:txBody>
+          <a:bodyPr xmlns:a="http://schemas.openxmlformats.org/drawingml/2006/main">
+            <a:noAutofit/>
+          </a:bodyPr>
+          <a:lstStyle xmlns:a="http://schemas.openxmlformats.org/drawingml/2006/main">
+            <a:defPPr>
+              <a:defRPr sz="1575" b="0">
                 <a:solidFill>
                   <a:srgbClr val="B8EDDB"/>
                 </a:solidFill>
@@ -8263,7 +8671,7 @@
           </a:lstStyle>
           <a:p xmlns:a="http://schemas.openxmlformats.org/drawingml/2006/main">
             <a:pPr>
-              <a:defRPr sz="1650" b="0">
+              <a:defRPr sz="1575" b="0">
                 <a:solidFill>
                   <a:srgbClr val="B8EDDB"/>
                 </a:solidFill>
@@ -8273,7 +8681,7 @@
               </a:defRPr>
             </a:pPr>
             <a:r>
-              <a:rPr sz="1650" b="0">
+              <a:rPr sz="1575" b="0">
                 <a:solidFill>
                   <a:srgbClr val="B8EDDB"/>
                 </a:solidFill>
@@ -8289,7 +8697,7 @@
     </p:spTree>
     <p:extLst>
       <p:ext uri="{BB962C8B-B14F-4D97-AF65-F5344CB8AC3E}">
-        <p14:creationId xmlns:p14="http://schemas.microsoft.com/office/powerpoint/2010/main" val="2097555884"/>
+        <p14:creationId xmlns:p14="http://schemas.microsoft.com/office/powerpoint/2010/main" val="689370045"/>
       </p:ext>
     </p:extLst>
   </p:cSld>
@@ -8320,7 +8728,7 @@
           <p:cNvPr id="12" name="">
             <a:extLst xmlns:a="http://schemas.openxmlformats.org/drawingml/2006/main">
               <a:ext uri="{FF2B5EF4-FFF2-40B4-BE49-F238E27FC236}">
-                <a16:creationId xmlns:a16="http://schemas.microsoft.com/office/drawing/2014/main" id="{B449E169-908C-4BED-A447-2847655FD5A6}"/>
+                <a16:creationId xmlns:a16="http://schemas.microsoft.com/office/drawing/2014/main" id="{4D3F4095-32FE-40A2-A09F-0E6F3A0E8A36}"/>
               </a:ext>
             </a:extLst>
           </p:cNvPr>
@@ -8388,7 +8796,7 @@
           <p:cNvPr id="2" name="">
             <a:extLst xmlns:a="http://schemas.openxmlformats.org/drawingml/2006/main">
               <a:ext uri="{FF2B5EF4-FFF2-40B4-BE49-F238E27FC236}">
-                <a16:creationId xmlns:a16="http://schemas.microsoft.com/office/drawing/2014/main" id="{11C84C26-8809-4D0B-8605-1601FDBA2DC3}"/>
+                <a16:creationId xmlns:a16="http://schemas.microsoft.com/office/drawing/2014/main" id="{BBAE8CDE-1014-4957-A26C-E4B2842F1585}"/>
               </a:ext>
             </a:extLst>
           </p:cNvPr>
@@ -8456,7 +8864,7 @@
           <p:cNvPr id="3" name="">
             <a:extLst xmlns:a="http://schemas.openxmlformats.org/drawingml/2006/main">
               <a:ext uri="{FF2B5EF4-FFF2-40B4-BE49-F238E27FC236}">
-                <a16:creationId xmlns:a16="http://schemas.microsoft.com/office/drawing/2014/main" id="{C09DC646-3993-495A-BFDB-6E122C90AC3B}"/>
+                <a16:creationId xmlns:a16="http://schemas.microsoft.com/office/drawing/2014/main" id="{60F2F32C-62FB-45E5-A09F-3614FF93E72B}"/>
               </a:ext>
             </a:extLst>
           </p:cNvPr>
@@ -8524,7 +8932,7 @@
           <p:cNvPr id="4" name="">
             <a:extLst xmlns:a="http://schemas.openxmlformats.org/drawingml/2006/main">
               <a:ext uri="{FF2B5EF4-FFF2-40B4-BE49-F238E27FC236}">
-                <a16:creationId xmlns:a16="http://schemas.microsoft.com/office/drawing/2014/main" id="{A2B4177B-8323-47AC-82E0-3A6AE9B63B24}"/>
+                <a16:creationId xmlns:a16="http://schemas.microsoft.com/office/drawing/2014/main" id="{8FA180DF-DF3E-45E4-83BC-C940C82345FB}"/>
               </a:ext>
             </a:extLst>
           </p:cNvPr>
@@ -8648,7 +9056,7 @@
           <p:cNvPr id="5" name="">
             <a:extLst xmlns:a="http://schemas.openxmlformats.org/drawingml/2006/main">
               <a:ext uri="{FF2B5EF4-FFF2-40B4-BE49-F238E27FC236}">
-                <a16:creationId xmlns:a16="http://schemas.microsoft.com/office/drawing/2014/main" id="{C23BFB56-A2F7-4700-A056-C38AD654ECE0}"/>
+                <a16:creationId xmlns:a16="http://schemas.microsoft.com/office/drawing/2014/main" id="{5F0617C7-5AD3-4C80-9657-D851E3E9B6FC}"/>
               </a:ext>
             </a:extLst>
           </p:cNvPr>
@@ -8716,7 +9124,7 @@
           <p:cNvPr id="6" name="">
             <a:extLst xmlns:a="http://schemas.openxmlformats.org/drawingml/2006/main">
               <a:ext uri="{FF2B5EF4-FFF2-40B4-BE49-F238E27FC236}">
-                <a16:creationId xmlns:a16="http://schemas.microsoft.com/office/drawing/2014/main" id="{EAC6D373-F14E-4428-A38D-6A5A52E66366}"/>
+                <a16:creationId xmlns:a16="http://schemas.microsoft.com/office/drawing/2014/main" id="{58AE7180-CD44-4980-A826-81E88EA1705A}"/>
               </a:ext>
             </a:extLst>
           </p:cNvPr>
@@ -8784,7 +9192,7 @@
           <p:cNvPr id="7" name="">
             <a:extLst xmlns:a="http://schemas.openxmlformats.org/drawingml/2006/main">
               <a:ext uri="{FF2B5EF4-FFF2-40B4-BE49-F238E27FC236}">
-                <a16:creationId xmlns:a16="http://schemas.microsoft.com/office/drawing/2014/main" id="{C6A35DB9-0326-4C57-BF28-930E9F7CA9DB}"/>
+                <a16:creationId xmlns:a16="http://schemas.microsoft.com/office/drawing/2014/main" id="{0AA7ACAB-9423-4527-A3AC-F21AB764B66C}"/>
               </a:ext>
             </a:extLst>
           </p:cNvPr>
@@ -8852,7 +9260,7 @@
           <p:cNvPr id="8" name="">
             <a:extLst xmlns:a="http://schemas.openxmlformats.org/drawingml/2006/main">
               <a:ext uri="{FF2B5EF4-FFF2-40B4-BE49-F238E27FC236}">
-                <a16:creationId xmlns:a16="http://schemas.microsoft.com/office/drawing/2014/main" id="{7F7DD53A-0C12-4027-8EED-619DB236A847}"/>
+                <a16:creationId xmlns:a16="http://schemas.microsoft.com/office/drawing/2014/main" id="{20C2B18C-C4CC-4BD8-9B5D-9F7B7B4106CC}"/>
               </a:ext>
             </a:extLst>
           </p:cNvPr>
@@ -8920,7 +9328,7 @@
           <p:cNvPr id="9" name="">
             <a:extLst xmlns:a="http://schemas.openxmlformats.org/drawingml/2006/main">
               <a:ext uri="{FF2B5EF4-FFF2-40B4-BE49-F238E27FC236}">
-                <a16:creationId xmlns:a16="http://schemas.microsoft.com/office/drawing/2014/main" id="{0E656A93-9B12-465D-AA22-D4B309C1D7BF}"/>
+                <a16:creationId xmlns:a16="http://schemas.microsoft.com/office/drawing/2014/main" id="{4AE341F5-B5C2-458A-8EB1-F3F596DF276E}"/>
               </a:ext>
             </a:extLst>
           </p:cNvPr>
@@ -8988,7 +9396,7 @@
           <p:cNvPr id="10" name="">
             <a:extLst xmlns:a="http://schemas.openxmlformats.org/drawingml/2006/main">
               <a:ext uri="{FF2B5EF4-FFF2-40B4-BE49-F238E27FC236}">
-                <a16:creationId xmlns:a16="http://schemas.microsoft.com/office/drawing/2014/main" id="{7EAAF73B-946F-4A7F-A3B6-414E10183E40}"/>
+                <a16:creationId xmlns:a16="http://schemas.microsoft.com/office/drawing/2014/main" id="{25955149-B869-4518-BAEC-AF65BB267F9D}"/>
               </a:ext>
             </a:extLst>
           </p:cNvPr>
@@ -9056,7 +9464,7 @@
           <p:cNvPr id="11" name="">
             <a:extLst xmlns:a="http://schemas.openxmlformats.org/drawingml/2006/main">
               <a:ext uri="{FF2B5EF4-FFF2-40B4-BE49-F238E27FC236}">
-                <a16:creationId xmlns:a16="http://schemas.microsoft.com/office/drawing/2014/main" id="{89A3183C-6F19-4843-9154-F420EE6A0015}"/>
+                <a16:creationId xmlns:a16="http://schemas.microsoft.com/office/drawing/2014/main" id="{B046A4F5-A680-440A-AF4E-6F5E4223F116}"/>
               </a:ext>
             </a:extLst>
           </p:cNvPr>
@@ -9122,7 +9530,7 @@
     </p:spTree>
     <p:extLst>
       <p:ext uri="{BB962C8B-B14F-4D97-AF65-F5344CB8AC3E}">
-        <p14:creationId xmlns:p14="http://schemas.microsoft.com/office/powerpoint/2010/main" val="999941577"/>
+        <p14:creationId xmlns:p14="http://schemas.microsoft.com/office/powerpoint/2010/main" val="1667525983"/>
       </p:ext>
     </p:extLst>
   </p:cSld>
@@ -9150,10 +9558,10 @@
       </p:grpSpPr>
       <p:sp>
         <p:nvSpPr>
-          <p:cNvPr id="12" name="">
-            <a:extLst xmlns:a="http://schemas.openxmlformats.org/drawingml/2006/main">
-              <a:ext uri="{FF2B5EF4-FFF2-40B4-BE49-F238E27FC236}">
-                <a16:creationId xmlns:a16="http://schemas.microsoft.com/office/drawing/2014/main" id="{BA5D4B97-0B97-4A12-9B5B-5D4CDC3FDB88}"/>
+          <p:cNvPr id="13" name="">
+            <a:extLst xmlns:a="http://schemas.openxmlformats.org/drawingml/2006/main">
+              <a:ext uri="{FF2B5EF4-FFF2-40B4-BE49-F238E27FC236}">
+                <a16:creationId xmlns:a16="http://schemas.microsoft.com/office/drawing/2014/main" id="{75184552-F86A-4474-81AE-26B8C7410619}"/>
               </a:ext>
             </a:extLst>
           </p:cNvPr>
@@ -9221,7 +9629,7 @@
           <p:cNvPr id="2" name="">
             <a:extLst xmlns:a="http://schemas.openxmlformats.org/drawingml/2006/main">
               <a:ext uri="{FF2B5EF4-FFF2-40B4-BE49-F238E27FC236}">
-                <a16:creationId xmlns:a16="http://schemas.microsoft.com/office/drawing/2014/main" id="{79A0AC1A-C9C7-4A4E-BF9A-1BC55CBACAF3}"/>
+                <a16:creationId xmlns:a16="http://schemas.microsoft.com/office/drawing/2014/main" id="{F2978391-0B31-4B6B-BFAE-7409B4FDF279}"/>
               </a:ext>
             </a:extLst>
           </p:cNvPr>
@@ -9289,7 +9697,7 @@
           <p:cNvPr id="3" name="">
             <a:extLst xmlns:a="http://schemas.openxmlformats.org/drawingml/2006/main">
               <a:ext uri="{FF2B5EF4-FFF2-40B4-BE49-F238E27FC236}">
-                <a16:creationId xmlns:a16="http://schemas.microsoft.com/office/drawing/2014/main" id="{D527DDBA-99F9-4686-9D44-25D5119565DB}"/>
+                <a16:creationId xmlns:a16="http://schemas.microsoft.com/office/drawing/2014/main" id="{D8FAC943-FDF4-44D4-AA0E-9C3C8F1802A2}"/>
               </a:ext>
             </a:extLst>
           </p:cNvPr>
@@ -9357,7 +9765,7 @@
           <p:cNvPr id="4" name="">
             <a:extLst xmlns:a="http://schemas.openxmlformats.org/drawingml/2006/main">
               <a:ext uri="{FF2B5EF4-FFF2-40B4-BE49-F238E27FC236}">
-                <a16:creationId xmlns:a16="http://schemas.microsoft.com/office/drawing/2014/main" id="{365E33BD-3CA8-4BED-A613-B84070AF8C0A}"/>
+                <a16:creationId xmlns:a16="http://schemas.microsoft.com/office/drawing/2014/main" id="{29E8AC41-ACC0-489B-953B-86A219CCB2E0}"/>
               </a:ext>
             </a:extLst>
           </p:cNvPr>
@@ -9453,7 +9861,7 @@
           <p:cNvPr id="5" name="">
             <a:extLst xmlns:a="http://schemas.openxmlformats.org/drawingml/2006/main">
               <a:ext uri="{FF2B5EF4-FFF2-40B4-BE49-F238E27FC236}">
-                <a16:creationId xmlns:a16="http://schemas.microsoft.com/office/drawing/2014/main" id="{B8CABB73-7882-46FE-94FD-D45963004C87}"/>
+                <a16:creationId xmlns:a16="http://schemas.microsoft.com/office/drawing/2014/main" id="{2976EC68-FFA9-4B7D-8F57-29676229A7F8}"/>
               </a:ext>
             </a:extLst>
           </p:cNvPr>
@@ -9521,7 +9929,7 @@
           <p:cNvPr id="6" name="">
             <a:extLst xmlns:a="http://schemas.openxmlformats.org/drawingml/2006/main">
               <a:ext uri="{FF2B5EF4-FFF2-40B4-BE49-F238E27FC236}">
-                <a16:creationId xmlns:a16="http://schemas.microsoft.com/office/drawing/2014/main" id="{1B374835-F988-44BC-9856-410A9A967358}"/>
+                <a16:creationId xmlns:a16="http://schemas.microsoft.com/office/drawing/2014/main" id="{C4D2E9F9-45E4-4B15-B3F1-E79B617E74F0}"/>
               </a:ext>
             </a:extLst>
           </p:cNvPr>
@@ -9589,7 +9997,7 @@
           <p:cNvPr id="7" name="">
             <a:extLst xmlns:a="http://schemas.openxmlformats.org/drawingml/2006/main">
               <a:ext uri="{FF2B5EF4-FFF2-40B4-BE49-F238E27FC236}">
-                <a16:creationId xmlns:a16="http://schemas.microsoft.com/office/drawing/2014/main" id="{6B3FA6BA-493F-4647-82F4-2AC8073DC852}"/>
+                <a16:creationId xmlns:a16="http://schemas.microsoft.com/office/drawing/2014/main" id="{96C8BA8D-45F4-4A27-B5B8-DD4A206D57CE}"/>
               </a:ext>
             </a:extLst>
           </p:cNvPr>
@@ -9657,7 +10065,7 @@
           <p:cNvPr id="8" name="">
             <a:extLst xmlns:a="http://schemas.openxmlformats.org/drawingml/2006/main">
               <a:ext uri="{FF2B5EF4-FFF2-40B4-BE49-F238E27FC236}">
-                <a16:creationId xmlns:a16="http://schemas.microsoft.com/office/drawing/2014/main" id="{43DE11A1-BAA8-4BA6-922C-983194CE1BF3}"/>
+                <a16:creationId xmlns:a16="http://schemas.microsoft.com/office/drawing/2014/main" id="{2D4289A0-9FCF-4AFC-B9E6-099282C5AD7C}"/>
               </a:ext>
             </a:extLst>
           </p:cNvPr>
@@ -9725,7 +10133,7 @@
           <p:cNvPr id="9" name="">
             <a:extLst xmlns:a="http://schemas.openxmlformats.org/drawingml/2006/main">
               <a:ext uri="{FF2B5EF4-FFF2-40B4-BE49-F238E27FC236}">
-                <a16:creationId xmlns:a16="http://schemas.microsoft.com/office/drawing/2014/main" id="{269377A8-90A8-4E84-90F8-D874706195D8}"/>
+                <a16:creationId xmlns:a16="http://schemas.microsoft.com/office/drawing/2014/main" id="{98FDCCE3-2DB2-44C7-BEF3-10D33041359E}"/>
               </a:ext>
             </a:extLst>
           </p:cNvPr>
@@ -9793,7 +10201,7 @@
           <p:cNvPr id="10" name="">
             <a:extLst xmlns:a="http://schemas.openxmlformats.org/drawingml/2006/main">
               <a:ext uri="{FF2B5EF4-FFF2-40B4-BE49-F238E27FC236}">
-                <a16:creationId xmlns:a16="http://schemas.microsoft.com/office/drawing/2014/main" id="{6F9F4864-5AFE-4E24-96CA-9686F88E0C9B}"/>
+                <a16:creationId xmlns:a16="http://schemas.microsoft.com/office/drawing/2014/main" id="{1F069589-108E-412B-93E6-2D686A9FD8D9}"/>
               </a:ext>
             </a:extLst>
           </p:cNvPr>
@@ -9861,35 +10269,103 @@
           <p:cNvPr id="11" name="">
             <a:extLst xmlns:a="http://schemas.openxmlformats.org/drawingml/2006/main">
               <a:ext uri="{FF2B5EF4-FFF2-40B4-BE49-F238E27FC236}">
-                <a16:creationId xmlns:a16="http://schemas.microsoft.com/office/drawing/2014/main" id="{57E8C543-CA14-4FD0-BCAD-433B011421C8}"/>
-              </a:ext>
-            </a:extLst>
-          </p:cNvPr>
-          <p:cNvSpPr>
-            <a:spLocks xmlns:a="http://schemas.openxmlformats.org/drawingml/2006/main" noGrp="1"/>
-          </p:cNvSpPr>
-          <p:nvPr/>
-        </p:nvSpPr>
-        <p:spPr>
-          <a:xfrm xmlns:a="http://schemas.openxmlformats.org/drawingml/2006/main">
-            <a:off x="609600" y="5572125"/>
-            <a:ext cx="10953750" cy="666750"/>
-          </a:xfrm>
-          <a:prstGeom xmlns:a="http://schemas.openxmlformats.org/drawingml/2006/main" prst="rect">
-            <a:avLst/>
-          </a:prstGeom>
-          <a:noFill xmlns:a="http://schemas.openxmlformats.org/drawingml/2006/main"/>
-          <a:ln xmlns:a="http://schemas.openxmlformats.org/drawingml/2006/main" w="0">
-            <a:noFill/>
-          </a:ln>
-        </p:spPr>
-        <p:txBody>
-          <a:bodyPr xmlns:a="http://schemas.openxmlformats.org/drawingml/2006/main">
-            <a:noAutofit/>
-          </a:bodyPr>
-          <a:lstStyle xmlns:a="http://schemas.openxmlformats.org/drawingml/2006/main">
-            <a:defPPr>
-              <a:defRPr sz="1650" b="0">
+                <a16:creationId xmlns:a16="http://schemas.microsoft.com/office/drawing/2014/main" id="{D809A8E9-612F-42F2-9F00-B8B0631F7681}"/>
+              </a:ext>
+            </a:extLst>
+          </p:cNvPr>
+          <p:cNvSpPr>
+            <a:spLocks xmlns:a="http://schemas.openxmlformats.org/drawingml/2006/main" noGrp="1"/>
+          </p:cNvSpPr>
+          <p:nvPr/>
+        </p:nvSpPr>
+        <p:spPr>
+          <a:xfrm xmlns:a="http://schemas.openxmlformats.org/drawingml/2006/main">
+            <a:off x="609600" y="5286375"/>
+            <a:ext cx="10953750" cy="381000"/>
+          </a:xfrm>
+          <a:prstGeom xmlns:a="http://schemas.openxmlformats.org/drawingml/2006/main" prst="rect">
+            <a:avLst/>
+          </a:prstGeom>
+          <a:noFill xmlns:a="http://schemas.openxmlformats.org/drawingml/2006/main"/>
+          <a:ln xmlns:a="http://schemas.openxmlformats.org/drawingml/2006/main" w="0">
+            <a:noFill/>
+          </a:ln>
+        </p:spPr>
+        <p:txBody>
+          <a:bodyPr xmlns:a="http://schemas.openxmlformats.org/drawingml/2006/main">
+            <a:noAutofit/>
+          </a:bodyPr>
+          <a:lstStyle xmlns:a="http://schemas.openxmlformats.org/drawingml/2006/main">
+            <a:defPPr>
+              <a:defRPr sz="1725" b="1">
+                <a:solidFill>
+                  <a:srgbClr val="FCD34D"/>
+                </a:solidFill>
+                <a:latin typeface="Arial"/>
+                <a:ea typeface="Arial"/>
+                <a:cs typeface="Arial"/>
+              </a:defRPr>
+            </a:defPPr>
+          </a:lstStyle>
+          <a:p xmlns:a="http://schemas.openxmlformats.org/drawingml/2006/main">
+            <a:pPr>
+              <a:defRPr sz="1725" b="1">
+                <a:solidFill>
+                  <a:srgbClr val="FCD34D"/>
+                </a:solidFill>
+                <a:latin typeface="Arial"/>
+                <a:ea typeface="Arial"/>
+                <a:cs typeface="Arial"/>
+              </a:defRPr>
+            </a:pPr>
+            <a:r>
+              <a:rPr sz="1725" b="1">
+                <a:solidFill>
+                  <a:srgbClr val="FCD34D"/>
+                </a:solidFill>
+                <a:latin typeface="Arial"/>
+                <a:ea typeface="Arial"/>
+                <a:cs typeface="Arial"/>
+              </a:rPr>
+              <a:t>A mund ta ndryshojë Arta orën e udhëtimit të Dritonit?</a:t>
+            </a:r>
+          </a:p>
+        </p:txBody>
+      </p:sp>
+      <p:sp>
+        <p:nvSpPr>
+          <p:cNvPr id="12" name="">
+            <a:extLst xmlns:a="http://schemas.openxmlformats.org/drawingml/2006/main">
+              <a:ext uri="{FF2B5EF4-FFF2-40B4-BE49-F238E27FC236}">
+                <a16:creationId xmlns:a16="http://schemas.microsoft.com/office/drawing/2014/main" id="{7BB0ECF8-DFAC-4979-B133-03062FEFCB8A}"/>
+              </a:ext>
+            </a:extLst>
+          </p:cNvPr>
+          <p:cNvSpPr>
+            <a:spLocks xmlns:a="http://schemas.openxmlformats.org/drawingml/2006/main" noGrp="1"/>
+          </p:cNvSpPr>
+          <p:nvPr/>
+        </p:nvSpPr>
+        <p:spPr>
+          <a:xfrm xmlns:a="http://schemas.openxmlformats.org/drawingml/2006/main">
+            <a:off x="609600" y="5715000"/>
+            <a:ext cx="10953750" cy="619125"/>
+          </a:xfrm>
+          <a:prstGeom xmlns:a="http://schemas.openxmlformats.org/drawingml/2006/main" prst="rect">
+            <a:avLst/>
+          </a:prstGeom>
+          <a:noFill xmlns:a="http://schemas.openxmlformats.org/drawingml/2006/main"/>
+          <a:ln xmlns:a="http://schemas.openxmlformats.org/drawingml/2006/main" w="0">
+            <a:noFill/>
+          </a:ln>
+        </p:spPr>
+        <p:txBody>
+          <a:bodyPr xmlns:a="http://schemas.openxmlformats.org/drawingml/2006/main">
+            <a:noAutofit/>
+          </a:bodyPr>
+          <a:lstStyle xmlns:a="http://schemas.openxmlformats.org/drawingml/2006/main">
+            <a:defPPr>
+              <a:defRPr sz="1575" b="0">
                 <a:solidFill>
                   <a:srgbClr val="B8EDDB"/>
                 </a:solidFill>
@@ -9901,7 +10377,7 @@
           </a:lstStyle>
           <a:p xmlns:a="http://schemas.openxmlformats.org/drawingml/2006/main">
             <a:pPr>
-              <a:defRPr sz="1650" b="0">
+              <a:defRPr sz="1575" b="0">
                 <a:solidFill>
                   <a:srgbClr val="B8EDDB"/>
                 </a:solidFill>
@@ -9911,7 +10387,7 @@
               </a:defRPr>
             </a:pPr>
             <a:r>
-              <a:rPr sz="1650" b="0">
+              <a:rPr sz="1575" b="0">
                 <a:solidFill>
                   <a:srgbClr val="B8EDDB"/>
                 </a:solidFill>
@@ -9927,7 +10403,7 @@
     </p:spTree>
     <p:extLst>
       <p:ext uri="{BB962C8B-B14F-4D97-AF65-F5344CB8AC3E}">
-        <p14:creationId xmlns:p14="http://schemas.microsoft.com/office/powerpoint/2010/main" val="608739976"/>
+        <p14:creationId xmlns:p14="http://schemas.microsoft.com/office/powerpoint/2010/main" val="1900589142"/>
       </p:ext>
     </p:extLst>
   </p:cSld>
@@ -9955,10 +10431,10 @@
       </p:grpSpPr>
       <p:sp>
         <p:nvSpPr>
-          <p:cNvPr id="6" name="">
-            <a:extLst xmlns:a="http://schemas.openxmlformats.org/drawingml/2006/main">
-              <a:ext uri="{FF2B5EF4-FFF2-40B4-BE49-F238E27FC236}">
-                <a16:creationId xmlns:a16="http://schemas.microsoft.com/office/drawing/2014/main" id="{6AA2C16B-CD4E-46B3-B0BB-99D98B89F67F}"/>
+          <p:cNvPr id="7" name="">
+            <a:extLst xmlns:a="http://schemas.openxmlformats.org/drawingml/2006/main">
+              <a:ext uri="{FF2B5EF4-FFF2-40B4-BE49-F238E27FC236}">
+                <a16:creationId xmlns:a16="http://schemas.microsoft.com/office/drawing/2014/main" id="{C3D700B7-3C40-4A1E-8DDF-68668ACEDFEB}"/>
               </a:ext>
             </a:extLst>
           </p:cNvPr>
@@ -10026,7 +10502,7 @@
           <p:cNvPr id="2" name="">
             <a:extLst xmlns:a="http://schemas.openxmlformats.org/drawingml/2006/main">
               <a:ext uri="{FF2B5EF4-FFF2-40B4-BE49-F238E27FC236}">
-                <a16:creationId xmlns:a16="http://schemas.microsoft.com/office/drawing/2014/main" id="{0A56AE46-FEAE-40BC-973D-67399F200890}"/>
+                <a16:creationId xmlns:a16="http://schemas.microsoft.com/office/drawing/2014/main" id="{D6F77374-81C6-477A-9DE7-935E3DAC9DE5}"/>
               </a:ext>
             </a:extLst>
           </p:cNvPr>
@@ -10094,7 +10570,7 @@
           <p:cNvPr id="3" name="">
             <a:extLst xmlns:a="http://schemas.openxmlformats.org/drawingml/2006/main">
               <a:ext uri="{FF2B5EF4-FFF2-40B4-BE49-F238E27FC236}">
-                <a16:creationId xmlns:a16="http://schemas.microsoft.com/office/drawing/2014/main" id="{059C1CEF-9252-4696-8C2E-82860E80FF69}"/>
+                <a16:creationId xmlns:a16="http://schemas.microsoft.com/office/drawing/2014/main" id="{5B4BDABC-3103-4DF8-8674-11B5552D7BE0}"/>
               </a:ext>
             </a:extLst>
           </p:cNvPr>
@@ -10162,7 +10638,7 @@
           <p:cNvPr id="4" name="">
             <a:extLst xmlns:a="http://schemas.openxmlformats.org/drawingml/2006/main">
               <a:ext uri="{FF2B5EF4-FFF2-40B4-BE49-F238E27FC236}">
-                <a16:creationId xmlns:a16="http://schemas.microsoft.com/office/drawing/2014/main" id="{1A95F7EC-8FA5-4EB9-92F4-6AD89B4ADBD5}"/>
+                <a16:creationId xmlns:a16="http://schemas.microsoft.com/office/drawing/2014/main" id="{B39A5025-8B54-4C67-97B7-DF25C112B55C}"/>
               </a:ext>
             </a:extLst>
           </p:cNvPr>
@@ -10286,35 +10762,103 @@
           <p:cNvPr id="5" name="">
             <a:extLst xmlns:a="http://schemas.openxmlformats.org/drawingml/2006/main">
               <a:ext uri="{FF2B5EF4-FFF2-40B4-BE49-F238E27FC236}">
-                <a16:creationId xmlns:a16="http://schemas.microsoft.com/office/drawing/2014/main" id="{1E48076C-5D0F-48B3-874A-65281671A144}"/>
-              </a:ext>
-            </a:extLst>
-          </p:cNvPr>
-          <p:cNvSpPr>
-            <a:spLocks xmlns:a="http://schemas.openxmlformats.org/drawingml/2006/main" noGrp="1"/>
-          </p:cNvSpPr>
-          <p:nvPr/>
-        </p:nvSpPr>
-        <p:spPr>
-          <a:xfrm xmlns:a="http://schemas.openxmlformats.org/drawingml/2006/main">
-            <a:off x="609600" y="5572125"/>
-            <a:ext cx="10953750" cy="666750"/>
-          </a:xfrm>
-          <a:prstGeom xmlns:a="http://schemas.openxmlformats.org/drawingml/2006/main" prst="rect">
-            <a:avLst/>
-          </a:prstGeom>
-          <a:noFill xmlns:a="http://schemas.openxmlformats.org/drawingml/2006/main"/>
-          <a:ln xmlns:a="http://schemas.openxmlformats.org/drawingml/2006/main" w="0">
-            <a:noFill/>
-          </a:ln>
-        </p:spPr>
-        <p:txBody>
-          <a:bodyPr xmlns:a="http://schemas.openxmlformats.org/drawingml/2006/main">
-            <a:noAutofit/>
-          </a:bodyPr>
-          <a:lstStyle xmlns:a="http://schemas.openxmlformats.org/drawingml/2006/main">
-            <a:defPPr>
-              <a:defRPr sz="1650" b="0">
+                <a16:creationId xmlns:a16="http://schemas.microsoft.com/office/drawing/2014/main" id="{3B8E4D69-126D-4328-8B26-73633A4A017A}"/>
+              </a:ext>
+            </a:extLst>
+          </p:cNvPr>
+          <p:cNvSpPr>
+            <a:spLocks xmlns:a="http://schemas.openxmlformats.org/drawingml/2006/main" noGrp="1"/>
+          </p:cNvSpPr>
+          <p:nvPr/>
+        </p:nvSpPr>
+        <p:spPr>
+          <a:xfrm xmlns:a="http://schemas.openxmlformats.org/drawingml/2006/main">
+            <a:off x="609600" y="5286375"/>
+            <a:ext cx="10953750" cy="381000"/>
+          </a:xfrm>
+          <a:prstGeom xmlns:a="http://schemas.openxmlformats.org/drawingml/2006/main" prst="rect">
+            <a:avLst/>
+          </a:prstGeom>
+          <a:noFill xmlns:a="http://schemas.openxmlformats.org/drawingml/2006/main"/>
+          <a:ln xmlns:a="http://schemas.openxmlformats.org/drawingml/2006/main" w="0">
+            <a:noFill/>
+          </a:ln>
+        </p:spPr>
+        <p:txBody>
+          <a:bodyPr xmlns:a="http://schemas.openxmlformats.org/drawingml/2006/main">
+            <a:noAutofit/>
+          </a:bodyPr>
+          <a:lstStyle xmlns:a="http://schemas.openxmlformats.org/drawingml/2006/main">
+            <a:defPPr>
+              <a:defRPr sz="1725" b="1">
+                <a:solidFill>
+                  <a:srgbClr val="FCD34D"/>
+                </a:solidFill>
+                <a:latin typeface="Arial"/>
+                <a:ea typeface="Arial"/>
+                <a:cs typeface="Arial"/>
+              </a:defRPr>
+            </a:defPPr>
+          </a:lstStyle>
+          <a:p xmlns:a="http://schemas.openxmlformats.org/drawingml/2006/main">
+            <a:pPr>
+              <a:defRPr sz="1725" b="1">
+                <a:solidFill>
+                  <a:srgbClr val="FCD34D"/>
+                </a:solidFill>
+                <a:latin typeface="Arial"/>
+                <a:ea typeface="Arial"/>
+                <a:cs typeface="Arial"/>
+              </a:defRPr>
+            </a:pPr>
+            <a:r>
+              <a:rPr sz="1725" b="1">
+                <a:solidFill>
+                  <a:srgbClr val="FCD34D"/>
+                </a:solidFill>
+                <a:latin typeface="Arial"/>
+                <a:ea typeface="Arial"/>
+                <a:cs typeface="Arial"/>
+              </a:rPr>
+              <a:t>A të jep karta e studentit leje për të ndryshuar notat?</a:t>
+            </a:r>
+          </a:p>
+        </p:txBody>
+      </p:sp>
+      <p:sp>
+        <p:nvSpPr>
+          <p:cNvPr id="6" name="">
+            <a:extLst xmlns:a="http://schemas.openxmlformats.org/drawingml/2006/main">
+              <a:ext uri="{FF2B5EF4-FFF2-40B4-BE49-F238E27FC236}">
+                <a16:creationId xmlns:a16="http://schemas.microsoft.com/office/drawing/2014/main" id="{F921B9DB-D3C7-4A16-8AC7-CD811F88E4FC}"/>
+              </a:ext>
+            </a:extLst>
+          </p:cNvPr>
+          <p:cNvSpPr>
+            <a:spLocks xmlns:a="http://schemas.openxmlformats.org/drawingml/2006/main" noGrp="1"/>
+          </p:cNvSpPr>
+          <p:nvPr/>
+        </p:nvSpPr>
+        <p:spPr>
+          <a:xfrm xmlns:a="http://schemas.openxmlformats.org/drawingml/2006/main">
+            <a:off x="609600" y="5715000"/>
+            <a:ext cx="10953750" cy="619125"/>
+          </a:xfrm>
+          <a:prstGeom xmlns:a="http://schemas.openxmlformats.org/drawingml/2006/main" prst="rect">
+            <a:avLst/>
+          </a:prstGeom>
+          <a:noFill xmlns:a="http://schemas.openxmlformats.org/drawingml/2006/main"/>
+          <a:ln xmlns:a="http://schemas.openxmlformats.org/drawingml/2006/main" w="0">
+            <a:noFill/>
+          </a:ln>
+        </p:spPr>
+        <p:txBody>
+          <a:bodyPr xmlns:a="http://schemas.openxmlformats.org/drawingml/2006/main">
+            <a:noAutofit/>
+          </a:bodyPr>
+          <a:lstStyle xmlns:a="http://schemas.openxmlformats.org/drawingml/2006/main">
+            <a:defPPr>
+              <a:defRPr sz="1575" b="0">
                 <a:solidFill>
                   <a:srgbClr val="B8EDDB"/>
                 </a:solidFill>
@@ -10326,7 +10870,7 @@
           </a:lstStyle>
           <a:p xmlns:a="http://schemas.openxmlformats.org/drawingml/2006/main">
             <a:pPr>
-              <a:defRPr sz="1650" b="0">
+              <a:defRPr sz="1575" b="0">
                 <a:solidFill>
                   <a:srgbClr val="B8EDDB"/>
                 </a:solidFill>
@@ -10336,7 +10880,7 @@
               </a:defRPr>
             </a:pPr>
             <a:r>
-              <a:rPr sz="1650" b="0">
+              <a:rPr sz="1575" b="0">
                 <a:solidFill>
                   <a:srgbClr val="B8EDDB"/>
                 </a:solidFill>
@@ -10344,7 +10888,7 @@
                 <a:ea typeface="Arial"/>
                 <a:cs typeface="Arial"/>
               </a:rPr>
-              <a:t>Përgjigjja: Përmend një rast tjetër: klienti i lokalit mund të rezervojë, por nuk ndryshon orarin e punonjësit.</a:t>
+              <a:t>Përgjigjja: Jo. Karta identifikon studentin; ndryshimi i notave kërkon rol dhe qasje të autorizuar. Edhe klienti i lokalit mund të rezervojë, por nuk ndryshon orarin e punonjësit.</a:t>
             </a:r>
           </a:p>
         </p:txBody>
@@ -10352,7 +10896,7 @@
     </p:spTree>
     <p:extLst>
       <p:ext uri="{BB962C8B-B14F-4D97-AF65-F5344CB8AC3E}">
-        <p14:creationId xmlns:p14="http://schemas.microsoft.com/office/powerpoint/2010/main" val="1622985470"/>
+        <p14:creationId xmlns:p14="http://schemas.microsoft.com/office/powerpoint/2010/main" val="451642897"/>
       </p:ext>
     </p:extLst>
   </p:cSld>
@@ -10383,7 +10927,7 @@
           <p:cNvPr id="13" name="">
             <a:extLst xmlns:a="http://schemas.openxmlformats.org/drawingml/2006/main">
               <a:ext uri="{FF2B5EF4-FFF2-40B4-BE49-F238E27FC236}">
-                <a16:creationId xmlns:a16="http://schemas.microsoft.com/office/drawing/2014/main" id="{464E5B78-23F9-4CC8-9903-826C99AF0A31}"/>
+                <a16:creationId xmlns:a16="http://schemas.microsoft.com/office/drawing/2014/main" id="{E03285B4-4F73-455C-8F35-0A96594BDA42}"/>
               </a:ext>
             </a:extLst>
           </p:cNvPr>
@@ -10451,7 +10995,7 @@
           <p:cNvPr id="2" name="">
             <a:extLst xmlns:a="http://schemas.openxmlformats.org/drawingml/2006/main">
               <a:ext uri="{FF2B5EF4-FFF2-40B4-BE49-F238E27FC236}">
-                <a16:creationId xmlns:a16="http://schemas.microsoft.com/office/drawing/2014/main" id="{DB2966CC-111C-4673-98E5-7C0D088A6BC0}"/>
+                <a16:creationId xmlns:a16="http://schemas.microsoft.com/office/drawing/2014/main" id="{164AE2DA-0F9C-44DA-933B-FF25655B2548}"/>
               </a:ext>
             </a:extLst>
           </p:cNvPr>
@@ -10519,7 +11063,7 @@
           <p:cNvPr id="3" name="">
             <a:extLst xmlns:a="http://schemas.openxmlformats.org/drawingml/2006/main">
               <a:ext uri="{FF2B5EF4-FFF2-40B4-BE49-F238E27FC236}">
-                <a16:creationId xmlns:a16="http://schemas.microsoft.com/office/drawing/2014/main" id="{4CF0BE80-7CB2-49D7-A9E0-2487144F918F}"/>
+                <a16:creationId xmlns:a16="http://schemas.microsoft.com/office/drawing/2014/main" id="{27BE7A0A-545B-4B2C-8065-36124E056788}"/>
               </a:ext>
             </a:extLst>
           </p:cNvPr>
@@ -10587,7 +11131,7 @@
           <p:cNvPr id="4" name="">
             <a:extLst xmlns:a="http://schemas.openxmlformats.org/drawingml/2006/main">
               <a:ext uri="{FF2B5EF4-FFF2-40B4-BE49-F238E27FC236}">
-                <a16:creationId xmlns:a16="http://schemas.microsoft.com/office/drawing/2014/main" id="{925327C5-90A2-4134-A0E5-B1058BE2A84B}"/>
+                <a16:creationId xmlns:a16="http://schemas.microsoft.com/office/drawing/2014/main" id="{F813961B-A8F4-4690-A256-66961FCF1DD0}"/>
               </a:ext>
             </a:extLst>
           </p:cNvPr>
@@ -10711,7 +11255,7 @@
           <p:cNvPr id="5" name="">
             <a:extLst xmlns:a="http://schemas.openxmlformats.org/drawingml/2006/main">
               <a:ext uri="{FF2B5EF4-FFF2-40B4-BE49-F238E27FC236}">
-                <a16:creationId xmlns:a16="http://schemas.microsoft.com/office/drawing/2014/main" id="{AFFDEAB3-4757-4D42-9923-BBA2C299F1BE}"/>
+                <a16:creationId xmlns:a16="http://schemas.microsoft.com/office/drawing/2014/main" id="{658E00DE-C6DB-4386-BC59-5C132E8971F5}"/>
               </a:ext>
             </a:extLst>
           </p:cNvPr>
@@ -10779,7 +11323,7 @@
           <p:cNvPr id="6" name="">
             <a:extLst xmlns:a="http://schemas.openxmlformats.org/drawingml/2006/main">
               <a:ext uri="{FF2B5EF4-FFF2-40B4-BE49-F238E27FC236}">
-                <a16:creationId xmlns:a16="http://schemas.microsoft.com/office/drawing/2014/main" id="{43778E2C-7110-4979-AE88-29ACA67181B7}"/>
+                <a16:creationId xmlns:a16="http://schemas.microsoft.com/office/drawing/2014/main" id="{B105820C-6C1D-430F-95AD-BB4B337550F7}"/>
               </a:ext>
             </a:extLst>
           </p:cNvPr>
@@ -10847,7 +11391,7 @@
           <p:cNvPr id="7" name="">
             <a:extLst xmlns:a="http://schemas.openxmlformats.org/drawingml/2006/main">
               <a:ext uri="{FF2B5EF4-FFF2-40B4-BE49-F238E27FC236}">
-                <a16:creationId xmlns:a16="http://schemas.microsoft.com/office/drawing/2014/main" id="{D91B8759-2E15-47AB-8EB8-467BE1A16030}"/>
+                <a16:creationId xmlns:a16="http://schemas.microsoft.com/office/drawing/2014/main" id="{AD39F4AC-50D9-49B5-BFDC-30103DBC4449}"/>
               </a:ext>
             </a:extLst>
           </p:cNvPr>
@@ -10915,7 +11459,7 @@
           <p:cNvPr id="8" name="">
             <a:extLst xmlns:a="http://schemas.openxmlformats.org/drawingml/2006/main">
               <a:ext uri="{FF2B5EF4-FFF2-40B4-BE49-F238E27FC236}">
-                <a16:creationId xmlns:a16="http://schemas.microsoft.com/office/drawing/2014/main" id="{514A2D49-C3BA-424F-B782-31BF4300A75B}"/>
+                <a16:creationId xmlns:a16="http://schemas.microsoft.com/office/drawing/2014/main" id="{2B1769BF-FF0D-4D1A-8450-8B7408D50CF7}"/>
               </a:ext>
             </a:extLst>
           </p:cNvPr>
@@ -10983,7 +11527,7 @@
           <p:cNvPr id="9" name="">
             <a:extLst xmlns:a="http://schemas.openxmlformats.org/drawingml/2006/main">
               <a:ext uri="{FF2B5EF4-FFF2-40B4-BE49-F238E27FC236}">
-                <a16:creationId xmlns:a16="http://schemas.microsoft.com/office/drawing/2014/main" id="{F1F81699-7DEE-448C-BE5B-7CD6AEE0FFCE}"/>
+                <a16:creationId xmlns:a16="http://schemas.microsoft.com/office/drawing/2014/main" id="{FC605F3D-432E-4FB9-A4BC-78B04C57DAF6}"/>
               </a:ext>
             </a:extLst>
           </p:cNvPr>
@@ -11051,7 +11595,7 @@
           <p:cNvPr id="10" name="">
             <a:extLst xmlns:a="http://schemas.openxmlformats.org/drawingml/2006/main">
               <a:ext uri="{FF2B5EF4-FFF2-40B4-BE49-F238E27FC236}">
-                <a16:creationId xmlns:a16="http://schemas.microsoft.com/office/drawing/2014/main" id="{6438A56F-6574-4A9F-8B61-AF3EC0911A11}"/>
+                <a16:creationId xmlns:a16="http://schemas.microsoft.com/office/drawing/2014/main" id="{6C6BCD16-3312-4298-9367-7BB28EF73F94}"/>
               </a:ext>
             </a:extLst>
           </p:cNvPr>
@@ -11119,7 +11663,7 @@
           <p:cNvPr id="11" name="">
             <a:extLst xmlns:a="http://schemas.openxmlformats.org/drawingml/2006/main">
               <a:ext uri="{FF2B5EF4-FFF2-40B4-BE49-F238E27FC236}">
-                <a16:creationId xmlns:a16="http://schemas.microsoft.com/office/drawing/2014/main" id="{553A3B44-2B48-4F54-8303-24BF13EC68F2}"/>
+                <a16:creationId xmlns:a16="http://schemas.microsoft.com/office/drawing/2014/main" id="{43B174DC-E1D5-4B00-AF1F-73A0B3068C60}"/>
               </a:ext>
             </a:extLst>
           </p:cNvPr>
@@ -11187,7 +11731,7 @@
           <p:cNvPr id="12" name="">
             <a:extLst xmlns:a="http://schemas.openxmlformats.org/drawingml/2006/main">
               <a:ext uri="{FF2B5EF4-FFF2-40B4-BE49-F238E27FC236}">
-                <a16:creationId xmlns:a16="http://schemas.microsoft.com/office/drawing/2014/main" id="{F63B89CC-AE84-4399-B472-47AFC32CB6BB}"/>
+                <a16:creationId xmlns:a16="http://schemas.microsoft.com/office/drawing/2014/main" id="{860C8431-D933-4786-881C-A814B080FD97}"/>
               </a:ext>
             </a:extLst>
           </p:cNvPr>
@@ -11253,7 +11797,7 @@
     </p:spTree>
     <p:extLst>
       <p:ext uri="{BB962C8B-B14F-4D97-AF65-F5344CB8AC3E}">
-        <p14:creationId xmlns:p14="http://schemas.microsoft.com/office/powerpoint/2010/main" val="1487715896"/>
+        <p14:creationId xmlns:p14="http://schemas.microsoft.com/office/powerpoint/2010/main" val="911851451"/>
       </p:ext>
     </p:extLst>
   </p:cSld>
@@ -11284,7 +11828,7 @@
           <p:cNvPr id="11" name="">
             <a:extLst xmlns:a="http://schemas.openxmlformats.org/drawingml/2006/main">
               <a:ext uri="{FF2B5EF4-FFF2-40B4-BE49-F238E27FC236}">
-                <a16:creationId xmlns:a16="http://schemas.microsoft.com/office/drawing/2014/main" id="{A0E88BBF-B191-4B52-907A-8F9D50B6699F}"/>
+                <a16:creationId xmlns:a16="http://schemas.microsoft.com/office/drawing/2014/main" id="{6B04F63F-0A3D-4702-A6E4-1FF43D1BE85E}"/>
               </a:ext>
             </a:extLst>
           </p:cNvPr>
@@ -11352,7 +11896,7 @@
           <p:cNvPr id="2" name="">
             <a:extLst xmlns:a="http://schemas.openxmlformats.org/drawingml/2006/main">
               <a:ext uri="{FF2B5EF4-FFF2-40B4-BE49-F238E27FC236}">
-                <a16:creationId xmlns:a16="http://schemas.microsoft.com/office/drawing/2014/main" id="{CD05A5CE-35C0-4ED0-9E71-26601FBAD0B3}"/>
+                <a16:creationId xmlns:a16="http://schemas.microsoft.com/office/drawing/2014/main" id="{87F5801E-3A95-48E0-B97E-522504D9BE9A}"/>
               </a:ext>
             </a:extLst>
           </p:cNvPr>
@@ -11420,7 +11964,7 @@
           <p:cNvPr id="3" name="">
             <a:extLst xmlns:a="http://schemas.openxmlformats.org/drawingml/2006/main">
               <a:ext uri="{FF2B5EF4-FFF2-40B4-BE49-F238E27FC236}">
-                <a16:creationId xmlns:a16="http://schemas.microsoft.com/office/drawing/2014/main" id="{6B077FF5-CEDA-46D5-AFDA-55391791A1F3}"/>
+                <a16:creationId xmlns:a16="http://schemas.microsoft.com/office/drawing/2014/main" id="{20940871-C08B-4DB8-8462-198B150B3987}"/>
               </a:ext>
             </a:extLst>
           </p:cNvPr>
@@ -11488,7 +12032,7 @@
           <p:cNvPr id="4" name="">
             <a:extLst xmlns:a="http://schemas.openxmlformats.org/drawingml/2006/main">
               <a:ext uri="{FF2B5EF4-FFF2-40B4-BE49-F238E27FC236}">
-                <a16:creationId xmlns:a16="http://schemas.microsoft.com/office/drawing/2014/main" id="{6304F3CC-EBDE-4BAA-BBBA-425422F9AF24}"/>
+                <a16:creationId xmlns:a16="http://schemas.microsoft.com/office/drawing/2014/main" id="{B3D55597-5C60-4E4B-A942-702018F90727}"/>
               </a:ext>
             </a:extLst>
           </p:cNvPr>
@@ -11612,7 +12156,7 @@
           <p:cNvPr id="5" name="">
             <a:extLst xmlns:a="http://schemas.openxmlformats.org/drawingml/2006/main">
               <a:ext uri="{FF2B5EF4-FFF2-40B4-BE49-F238E27FC236}">
-                <a16:creationId xmlns:a16="http://schemas.microsoft.com/office/drawing/2014/main" id="{65FB9739-971C-4B07-82F0-18097C2F95BA}"/>
+                <a16:creationId xmlns:a16="http://schemas.microsoft.com/office/drawing/2014/main" id="{58941074-64DC-4900-82BF-645FA99269BB}"/>
               </a:ext>
             </a:extLst>
           </p:cNvPr>
@@ -11680,7 +12224,7 @@
           <p:cNvPr id="6" name="">
             <a:extLst xmlns:a="http://schemas.openxmlformats.org/drawingml/2006/main">
               <a:ext uri="{FF2B5EF4-FFF2-40B4-BE49-F238E27FC236}">
-                <a16:creationId xmlns:a16="http://schemas.microsoft.com/office/drawing/2014/main" id="{EDAB745F-0776-4C11-AE6F-EE0D9DA2F4CB}"/>
+                <a16:creationId xmlns:a16="http://schemas.microsoft.com/office/drawing/2014/main" id="{AF08193F-B8F1-4668-B71D-380384664B5A}"/>
               </a:ext>
             </a:extLst>
           </p:cNvPr>
@@ -11748,7 +12292,7 @@
           <p:cNvPr id="7" name="">
             <a:extLst xmlns:a="http://schemas.openxmlformats.org/drawingml/2006/main">
               <a:ext uri="{FF2B5EF4-FFF2-40B4-BE49-F238E27FC236}">
-                <a16:creationId xmlns:a16="http://schemas.microsoft.com/office/drawing/2014/main" id="{11A53928-33C6-4034-9B3B-6604E525704E}"/>
+                <a16:creationId xmlns:a16="http://schemas.microsoft.com/office/drawing/2014/main" id="{93760067-5B32-4C1A-9A66-332AFD53BE36}"/>
               </a:ext>
             </a:extLst>
           </p:cNvPr>
@@ -11816,7 +12360,7 @@
           <p:cNvPr id="8" name="">
             <a:extLst xmlns:a="http://schemas.openxmlformats.org/drawingml/2006/main">
               <a:ext uri="{FF2B5EF4-FFF2-40B4-BE49-F238E27FC236}">
-                <a16:creationId xmlns:a16="http://schemas.microsoft.com/office/drawing/2014/main" id="{07EBF126-CDE1-414D-866F-3EC30EFEEA0D}"/>
+                <a16:creationId xmlns:a16="http://schemas.microsoft.com/office/drawing/2014/main" id="{8358BBE5-8562-4906-99CF-3848EA29C73B}"/>
               </a:ext>
             </a:extLst>
           </p:cNvPr>
@@ -11884,7 +12428,7 @@
           <p:cNvPr id="9" name="">
             <a:extLst xmlns:a="http://schemas.openxmlformats.org/drawingml/2006/main">
               <a:ext uri="{FF2B5EF4-FFF2-40B4-BE49-F238E27FC236}">
-                <a16:creationId xmlns:a16="http://schemas.microsoft.com/office/drawing/2014/main" id="{B7219243-CCBC-48B8-89C7-0C40E67EBB78}"/>
+                <a16:creationId xmlns:a16="http://schemas.microsoft.com/office/drawing/2014/main" id="{CF487A86-94DD-44BD-A279-2A8528A3631F}"/>
               </a:ext>
             </a:extLst>
           </p:cNvPr>
@@ -11952,7 +12496,7 @@
           <p:cNvPr id="10" name="">
             <a:extLst xmlns:a="http://schemas.openxmlformats.org/drawingml/2006/main">
               <a:ext uri="{FF2B5EF4-FFF2-40B4-BE49-F238E27FC236}">
-                <a16:creationId xmlns:a16="http://schemas.microsoft.com/office/drawing/2014/main" id="{7B97AE49-7239-4AC2-8124-0A31B9EA42AB}"/>
+                <a16:creationId xmlns:a16="http://schemas.microsoft.com/office/drawing/2014/main" id="{543A6DB2-A57C-41E1-A6A6-E37DBFC0E741}"/>
               </a:ext>
             </a:extLst>
           </p:cNvPr>
@@ -12018,7 +12562,7 @@
     </p:spTree>
     <p:extLst>
       <p:ext uri="{BB962C8B-B14F-4D97-AF65-F5344CB8AC3E}">
-        <p14:creationId xmlns:p14="http://schemas.microsoft.com/office/powerpoint/2010/main" val="7192432"/>
+        <p14:creationId xmlns:p14="http://schemas.microsoft.com/office/powerpoint/2010/main" val="1946282416"/>
       </p:ext>
     </p:extLst>
   </p:cSld>
@@ -12046,10 +12590,10 @@
       </p:grpSpPr>
       <p:sp>
         <p:nvSpPr>
-          <p:cNvPr id="10" name="">
-            <a:extLst xmlns:a="http://schemas.openxmlformats.org/drawingml/2006/main">
-              <a:ext uri="{FF2B5EF4-FFF2-40B4-BE49-F238E27FC236}">
-                <a16:creationId xmlns:a16="http://schemas.microsoft.com/office/drawing/2014/main" id="{B5D651CC-009C-4686-889B-0B2115750FA5}"/>
+          <p:cNvPr id="11" name="">
+            <a:extLst xmlns:a="http://schemas.openxmlformats.org/drawingml/2006/main">
+              <a:ext uri="{FF2B5EF4-FFF2-40B4-BE49-F238E27FC236}">
+                <a16:creationId xmlns:a16="http://schemas.microsoft.com/office/drawing/2014/main" id="{0BD4B190-FB72-4E30-955B-A606B6367CB5}"/>
               </a:ext>
             </a:extLst>
           </p:cNvPr>
@@ -12117,7 +12661,7 @@
           <p:cNvPr id="2" name="">
             <a:extLst xmlns:a="http://schemas.openxmlformats.org/drawingml/2006/main">
               <a:ext uri="{FF2B5EF4-FFF2-40B4-BE49-F238E27FC236}">
-                <a16:creationId xmlns:a16="http://schemas.microsoft.com/office/drawing/2014/main" id="{A2CC48AA-81E2-4A18-97F7-674C9F575F80}"/>
+                <a16:creationId xmlns:a16="http://schemas.microsoft.com/office/drawing/2014/main" id="{95B5B3EE-49B0-4C91-B649-66AAFF3B5561}"/>
               </a:ext>
             </a:extLst>
           </p:cNvPr>
@@ -12185,7 +12729,7 @@
           <p:cNvPr id="3" name="">
             <a:extLst xmlns:a="http://schemas.openxmlformats.org/drawingml/2006/main">
               <a:ext uri="{FF2B5EF4-FFF2-40B4-BE49-F238E27FC236}">
-                <a16:creationId xmlns:a16="http://schemas.microsoft.com/office/drawing/2014/main" id="{FD95F043-54B6-4980-866C-1E84B3C9387C}"/>
+                <a16:creationId xmlns:a16="http://schemas.microsoft.com/office/drawing/2014/main" id="{2CA46D3F-310A-4CCC-A7F4-DCCBCD13663E}"/>
               </a:ext>
             </a:extLst>
           </p:cNvPr>
@@ -12253,7 +12797,7 @@
           <p:cNvPr id="4" name="">
             <a:extLst xmlns:a="http://schemas.openxmlformats.org/drawingml/2006/main">
               <a:ext uri="{FF2B5EF4-FFF2-40B4-BE49-F238E27FC236}">
-                <a16:creationId xmlns:a16="http://schemas.microsoft.com/office/drawing/2014/main" id="{2DC30D11-D18B-4579-A9B0-4D793F3ADE22}"/>
+                <a16:creationId xmlns:a16="http://schemas.microsoft.com/office/drawing/2014/main" id="{AD796E40-EC24-4EF8-9000-81EF647928A0}"/>
               </a:ext>
             </a:extLst>
           </p:cNvPr>
@@ -12377,7 +12921,7 @@
           <p:cNvPr id="5" name="">
             <a:extLst xmlns:a="http://schemas.openxmlformats.org/drawingml/2006/main">
               <a:ext uri="{FF2B5EF4-FFF2-40B4-BE49-F238E27FC236}">
-                <a16:creationId xmlns:a16="http://schemas.microsoft.com/office/drawing/2014/main" id="{A1D9768C-0925-4841-AB82-D06D5AFC5992}"/>
+                <a16:creationId xmlns:a16="http://schemas.microsoft.com/office/drawing/2014/main" id="{77CB0166-F25B-4833-BD6E-BDE6FC431ADF}"/>
               </a:ext>
             </a:extLst>
           </p:cNvPr>
@@ -12445,7 +12989,7 @@
           <p:cNvPr id="6" name="">
             <a:extLst xmlns:a="http://schemas.openxmlformats.org/drawingml/2006/main">
               <a:ext uri="{FF2B5EF4-FFF2-40B4-BE49-F238E27FC236}">
-                <a16:creationId xmlns:a16="http://schemas.microsoft.com/office/drawing/2014/main" id="{0A7ECFBF-7F81-49F6-BDF8-1296F7DE761A}"/>
+                <a16:creationId xmlns:a16="http://schemas.microsoft.com/office/drawing/2014/main" id="{F10183B8-4706-4FF6-92B3-553E4B0C987B}"/>
               </a:ext>
             </a:extLst>
           </p:cNvPr>
@@ -12513,7 +13057,7 @@
           <p:cNvPr id="7" name="">
             <a:extLst xmlns:a="http://schemas.openxmlformats.org/drawingml/2006/main">
               <a:ext uri="{FF2B5EF4-FFF2-40B4-BE49-F238E27FC236}">
-                <a16:creationId xmlns:a16="http://schemas.microsoft.com/office/drawing/2014/main" id="{BCEA9A18-C165-40F3-9C66-A51EE5A2FC49}"/>
+                <a16:creationId xmlns:a16="http://schemas.microsoft.com/office/drawing/2014/main" id="{C8B99924-659F-4338-BD85-6FEFD3D48566}"/>
               </a:ext>
             </a:extLst>
           </p:cNvPr>
@@ -12581,7 +13125,7 @@
           <p:cNvPr id="8" name="">
             <a:extLst xmlns:a="http://schemas.openxmlformats.org/drawingml/2006/main">
               <a:ext uri="{FF2B5EF4-FFF2-40B4-BE49-F238E27FC236}">
-                <a16:creationId xmlns:a16="http://schemas.microsoft.com/office/drawing/2014/main" id="{3A3089F6-348E-428B-A7DD-421D94AF0CB1}"/>
+                <a16:creationId xmlns:a16="http://schemas.microsoft.com/office/drawing/2014/main" id="{EC291AEE-63BF-4E6E-9926-101ECA23F004}"/>
               </a:ext>
             </a:extLst>
           </p:cNvPr>
@@ -12649,35 +13193,103 @@
           <p:cNvPr id="9" name="">
             <a:extLst xmlns:a="http://schemas.openxmlformats.org/drawingml/2006/main">
               <a:ext uri="{FF2B5EF4-FFF2-40B4-BE49-F238E27FC236}">
-                <a16:creationId xmlns:a16="http://schemas.microsoft.com/office/drawing/2014/main" id="{D0F637DF-CE03-4D32-84E7-8A8897AE10A1}"/>
-              </a:ext>
-            </a:extLst>
-          </p:cNvPr>
-          <p:cNvSpPr>
-            <a:spLocks xmlns:a="http://schemas.openxmlformats.org/drawingml/2006/main" noGrp="1"/>
-          </p:cNvSpPr>
-          <p:nvPr/>
-        </p:nvSpPr>
-        <p:spPr>
-          <a:xfrm xmlns:a="http://schemas.openxmlformats.org/drawingml/2006/main">
-            <a:off x="609600" y="5572125"/>
-            <a:ext cx="10953750" cy="666750"/>
-          </a:xfrm>
-          <a:prstGeom xmlns:a="http://schemas.openxmlformats.org/drawingml/2006/main" prst="rect">
-            <a:avLst/>
-          </a:prstGeom>
-          <a:noFill xmlns:a="http://schemas.openxmlformats.org/drawingml/2006/main"/>
-          <a:ln xmlns:a="http://schemas.openxmlformats.org/drawingml/2006/main" w="0">
-            <a:noFill/>
-          </a:ln>
-        </p:spPr>
-        <p:txBody>
-          <a:bodyPr xmlns:a="http://schemas.openxmlformats.org/drawingml/2006/main">
-            <a:noAutofit/>
-          </a:bodyPr>
-          <a:lstStyle xmlns:a="http://schemas.openxmlformats.org/drawingml/2006/main">
-            <a:defPPr>
-              <a:defRPr sz="1650" b="0">
+                <a16:creationId xmlns:a16="http://schemas.microsoft.com/office/drawing/2014/main" id="{EE8F7976-BD8B-4828-8CA7-F9680C9ABFDE}"/>
+              </a:ext>
+            </a:extLst>
+          </p:cNvPr>
+          <p:cNvSpPr>
+            <a:spLocks xmlns:a="http://schemas.openxmlformats.org/drawingml/2006/main" noGrp="1"/>
+          </p:cNvSpPr>
+          <p:nvPr/>
+        </p:nvSpPr>
+        <p:spPr>
+          <a:xfrm xmlns:a="http://schemas.openxmlformats.org/drawingml/2006/main">
+            <a:off x="609600" y="5286375"/>
+            <a:ext cx="10953750" cy="381000"/>
+          </a:xfrm>
+          <a:prstGeom xmlns:a="http://schemas.openxmlformats.org/drawingml/2006/main" prst="rect">
+            <a:avLst/>
+          </a:prstGeom>
+          <a:noFill xmlns:a="http://schemas.openxmlformats.org/drawingml/2006/main"/>
+          <a:ln xmlns:a="http://schemas.openxmlformats.org/drawingml/2006/main" w="0">
+            <a:noFill/>
+          </a:ln>
+        </p:spPr>
+        <p:txBody>
+          <a:bodyPr xmlns:a="http://schemas.openxmlformats.org/drawingml/2006/main">
+            <a:noAutofit/>
+          </a:bodyPr>
+          <a:lstStyle xmlns:a="http://schemas.openxmlformats.org/drawingml/2006/main">
+            <a:defPPr>
+              <a:defRPr sz="1725" b="1">
+                <a:solidFill>
+                  <a:srgbClr val="FCD34D"/>
+                </a:solidFill>
+                <a:latin typeface="Arial"/>
+                <a:ea typeface="Arial"/>
+                <a:cs typeface="Arial"/>
+              </a:defRPr>
+            </a:defPPr>
+          </a:lstStyle>
+          <a:p xmlns:a="http://schemas.openxmlformats.org/drawingml/2006/main">
+            <a:pPr>
+              <a:defRPr sz="1725" b="1">
+                <a:solidFill>
+                  <a:srgbClr val="FCD34D"/>
+                </a:solidFill>
+                <a:latin typeface="Arial"/>
+                <a:ea typeface="Arial"/>
+                <a:cs typeface="Arial"/>
+              </a:defRPr>
+            </a:pPr>
+            <a:r>
+              <a:rPr sz="1725" b="1">
+                <a:solidFill>
+                  <a:srgbClr val="FCD34D"/>
+                </a:solidFill>
+                <a:latin typeface="Arial"/>
+                <a:ea typeface="Arial"/>
+                <a:cs typeface="Arial"/>
+              </a:rPr>
+              <a:t>Çfarë ndodh nëse Arta dërgon role=shofer nga shfletuesi?</a:t>
+            </a:r>
+          </a:p>
+        </p:txBody>
+      </p:sp>
+      <p:sp>
+        <p:nvSpPr>
+          <p:cNvPr id="10" name="">
+            <a:extLst xmlns:a="http://schemas.openxmlformats.org/drawingml/2006/main">
+              <a:ext uri="{FF2B5EF4-FFF2-40B4-BE49-F238E27FC236}">
+                <a16:creationId xmlns:a16="http://schemas.microsoft.com/office/drawing/2014/main" id="{4218B73A-EDAC-4623-AE6B-B0A1046A7AB5}"/>
+              </a:ext>
+            </a:extLst>
+          </p:cNvPr>
+          <p:cNvSpPr>
+            <a:spLocks xmlns:a="http://schemas.openxmlformats.org/drawingml/2006/main" noGrp="1"/>
+          </p:cNvSpPr>
+          <p:nvPr/>
+        </p:nvSpPr>
+        <p:spPr>
+          <a:xfrm xmlns:a="http://schemas.openxmlformats.org/drawingml/2006/main">
+            <a:off x="609600" y="5715000"/>
+            <a:ext cx="10953750" cy="619125"/>
+          </a:xfrm>
+          <a:prstGeom xmlns:a="http://schemas.openxmlformats.org/drawingml/2006/main" prst="rect">
+            <a:avLst/>
+          </a:prstGeom>
+          <a:noFill xmlns:a="http://schemas.openxmlformats.org/drawingml/2006/main"/>
+          <a:ln xmlns:a="http://schemas.openxmlformats.org/drawingml/2006/main" w="0">
+            <a:noFill/>
+          </a:ln>
+        </p:spPr>
+        <p:txBody>
+          <a:bodyPr xmlns:a="http://schemas.openxmlformats.org/drawingml/2006/main">
+            <a:noAutofit/>
+          </a:bodyPr>
+          <a:lstStyle xmlns:a="http://schemas.openxmlformats.org/drawingml/2006/main">
+            <a:defPPr>
+              <a:defRPr sz="1575" b="0">
                 <a:solidFill>
                   <a:srgbClr val="B8EDDB"/>
                 </a:solidFill>
@@ -12689,7 +13301,7 @@
           </a:lstStyle>
           <a:p xmlns:a="http://schemas.openxmlformats.org/drawingml/2006/main">
             <a:pPr>
-              <a:defRPr sz="1650" b="0">
+              <a:defRPr sz="1575" b="0">
                 <a:solidFill>
                   <a:srgbClr val="B8EDDB"/>
                 </a:solidFill>
@@ -12699,7 +13311,7 @@
               </a:defRPr>
             </a:pPr>
             <a:r>
-              <a:rPr sz="1650" b="0">
+              <a:rPr sz="1575" b="0">
                 <a:solidFill>
                   <a:srgbClr val="B8EDDB"/>
                 </a:solidFill>
@@ -12715,7 +13327,7 @@
     </p:spTree>
     <p:extLst>
       <p:ext uri="{BB962C8B-B14F-4D97-AF65-F5344CB8AC3E}">
-        <p14:creationId xmlns:p14="http://schemas.microsoft.com/office/powerpoint/2010/main" val="1637995377"/>
+        <p14:creationId xmlns:p14="http://schemas.microsoft.com/office/powerpoint/2010/main" val="55828098"/>
       </p:ext>
     </p:extLst>
   </p:cSld>
@@ -12743,10 +13355,10 @@
       </p:grpSpPr>
       <p:sp>
         <p:nvSpPr>
-          <p:cNvPr id="7" name="">
-            <a:extLst xmlns:a="http://schemas.openxmlformats.org/drawingml/2006/main">
-              <a:ext uri="{FF2B5EF4-FFF2-40B4-BE49-F238E27FC236}">
-                <a16:creationId xmlns:a16="http://schemas.microsoft.com/office/drawing/2014/main" id="{EEE84C6C-B5FF-4EE8-AE0C-BDDAC1B6A527}"/>
+          <p:cNvPr id="8" name="">
+            <a:extLst xmlns:a="http://schemas.openxmlformats.org/drawingml/2006/main">
+              <a:ext uri="{FF2B5EF4-FFF2-40B4-BE49-F238E27FC236}">
+                <a16:creationId xmlns:a16="http://schemas.microsoft.com/office/drawing/2014/main" id="{CFF01A86-99A0-4C34-B4D9-0FAF4919F305}"/>
               </a:ext>
             </a:extLst>
           </p:cNvPr>
@@ -12814,7 +13426,7 @@
           <p:cNvPr id="2" name="">
             <a:extLst xmlns:a="http://schemas.openxmlformats.org/drawingml/2006/main">
               <a:ext uri="{FF2B5EF4-FFF2-40B4-BE49-F238E27FC236}">
-                <a16:creationId xmlns:a16="http://schemas.microsoft.com/office/drawing/2014/main" id="{6889A806-52DF-437D-876F-58CAA81BA8A3}"/>
+                <a16:creationId xmlns:a16="http://schemas.microsoft.com/office/drawing/2014/main" id="{E5DAD482-3D80-4BD8-A9A0-D9C6478C4BA0}"/>
               </a:ext>
             </a:extLst>
           </p:cNvPr>
@@ -12882,7 +13494,7 @@
           <p:cNvPr id="3" name="">
             <a:extLst xmlns:a="http://schemas.openxmlformats.org/drawingml/2006/main">
               <a:ext uri="{FF2B5EF4-FFF2-40B4-BE49-F238E27FC236}">
-                <a16:creationId xmlns:a16="http://schemas.microsoft.com/office/drawing/2014/main" id="{54B307D7-F3F9-4000-8C16-BBE6CF7CEC58}"/>
+                <a16:creationId xmlns:a16="http://schemas.microsoft.com/office/drawing/2014/main" id="{810796AB-632B-450B-937B-DB1A867D7962}"/>
               </a:ext>
             </a:extLst>
           </p:cNvPr>
@@ -12950,7 +13562,7 @@
           <p:cNvPr id="4" name="">
             <a:extLst xmlns:a="http://schemas.openxmlformats.org/drawingml/2006/main">
               <a:ext uri="{FF2B5EF4-FFF2-40B4-BE49-F238E27FC236}">
-                <a16:creationId xmlns:a16="http://schemas.microsoft.com/office/drawing/2014/main" id="{E63E9805-9275-4459-87B1-EC097FE0966C}"/>
+                <a16:creationId xmlns:a16="http://schemas.microsoft.com/office/drawing/2014/main" id="{4CB7ACCC-7282-410A-9157-D758ACAA4F9C}"/>
               </a:ext>
             </a:extLst>
           </p:cNvPr>
@@ -13372,7 +13984,7 @@
           <p:cNvPr id="5" name="">
             <a:extLst xmlns:a="http://schemas.openxmlformats.org/drawingml/2006/main">
               <a:ext uri="{FF2B5EF4-FFF2-40B4-BE49-F238E27FC236}">
-                <a16:creationId xmlns:a16="http://schemas.microsoft.com/office/drawing/2014/main" id="{01CA4B66-3CE4-48D2-AEF4-2041C93A1BD7}"/>
+                <a16:creationId xmlns:a16="http://schemas.microsoft.com/office/drawing/2014/main" id="{D8C27B26-9541-4419-88B4-B5003056DEC5}"/>
               </a:ext>
             </a:extLst>
           </p:cNvPr>
@@ -13440,35 +14052,103 @@
           <p:cNvPr id="6" name="">
             <a:extLst xmlns:a="http://schemas.openxmlformats.org/drawingml/2006/main">
               <a:ext uri="{FF2B5EF4-FFF2-40B4-BE49-F238E27FC236}">
-                <a16:creationId xmlns:a16="http://schemas.microsoft.com/office/drawing/2014/main" id="{4236ABDE-7D5C-48A5-A8D3-160EFBD41370}"/>
-              </a:ext>
-            </a:extLst>
-          </p:cNvPr>
-          <p:cNvSpPr>
-            <a:spLocks xmlns:a="http://schemas.openxmlformats.org/drawingml/2006/main" noGrp="1"/>
-          </p:cNvSpPr>
-          <p:nvPr/>
-        </p:nvSpPr>
-        <p:spPr>
-          <a:xfrm xmlns:a="http://schemas.openxmlformats.org/drawingml/2006/main">
-            <a:off x="609600" y="5572125"/>
-            <a:ext cx="10953750" cy="666750"/>
-          </a:xfrm>
-          <a:prstGeom xmlns:a="http://schemas.openxmlformats.org/drawingml/2006/main" prst="rect">
-            <a:avLst/>
-          </a:prstGeom>
-          <a:noFill xmlns:a="http://schemas.openxmlformats.org/drawingml/2006/main"/>
-          <a:ln xmlns:a="http://schemas.openxmlformats.org/drawingml/2006/main" w="0">
-            <a:noFill/>
-          </a:ln>
-        </p:spPr>
-        <p:txBody>
-          <a:bodyPr xmlns:a="http://schemas.openxmlformats.org/drawingml/2006/main">
-            <a:noAutofit/>
-          </a:bodyPr>
-          <a:lstStyle xmlns:a="http://schemas.openxmlformats.org/drawingml/2006/main">
-            <a:defPPr>
-              <a:defRPr sz="1650" b="0">
+                <a16:creationId xmlns:a16="http://schemas.microsoft.com/office/drawing/2014/main" id="{A72018F3-ECD5-48EC-8D58-D3B13465282B}"/>
+              </a:ext>
+            </a:extLst>
+          </p:cNvPr>
+          <p:cNvSpPr>
+            <a:spLocks xmlns:a="http://schemas.openxmlformats.org/drawingml/2006/main" noGrp="1"/>
+          </p:cNvSpPr>
+          <p:nvPr/>
+        </p:nvSpPr>
+        <p:spPr>
+          <a:xfrm xmlns:a="http://schemas.openxmlformats.org/drawingml/2006/main">
+            <a:off x="609600" y="5286375"/>
+            <a:ext cx="10953750" cy="381000"/>
+          </a:xfrm>
+          <a:prstGeom xmlns:a="http://schemas.openxmlformats.org/drawingml/2006/main" prst="rect">
+            <a:avLst/>
+          </a:prstGeom>
+          <a:noFill xmlns:a="http://schemas.openxmlformats.org/drawingml/2006/main"/>
+          <a:ln xmlns:a="http://schemas.openxmlformats.org/drawingml/2006/main" w="0">
+            <a:noFill/>
+          </a:ln>
+        </p:spPr>
+        <p:txBody>
+          <a:bodyPr xmlns:a="http://schemas.openxmlformats.org/drawingml/2006/main">
+            <a:noAutofit/>
+          </a:bodyPr>
+          <a:lstStyle xmlns:a="http://schemas.openxmlformats.org/drawingml/2006/main">
+            <a:defPPr>
+              <a:defRPr sz="1725" b="1">
+                <a:solidFill>
+                  <a:srgbClr val="FCD34D"/>
+                </a:solidFill>
+                <a:latin typeface="Arial"/>
+                <a:ea typeface="Arial"/>
+                <a:cs typeface="Arial"/>
+              </a:defRPr>
+            </a:defPPr>
+          </a:lstStyle>
+          <a:p xmlns:a="http://schemas.openxmlformats.org/drawingml/2006/main">
+            <a:pPr>
+              <a:defRPr sz="1725" b="1">
+                <a:solidFill>
+                  <a:srgbClr val="FCD34D"/>
+                </a:solidFill>
+                <a:latin typeface="Arial"/>
+                <a:ea typeface="Arial"/>
+                <a:cs typeface="Arial"/>
+              </a:defRPr>
+            </a:pPr>
+            <a:r>
+              <a:rPr sz="1725" b="1">
+                <a:solidFill>
+                  <a:srgbClr val="FCD34D"/>
+                </a:solidFill>
+                <a:latin typeface="Arial"/>
+                <a:ea typeface="Arial"/>
+                <a:cs typeface="Arial"/>
+              </a:rPr>
+              <a:t>A mund ta ndryshojë Dritoni udhëtimin e një shoferi tjetër?</a:t>
+            </a:r>
+          </a:p>
+        </p:txBody>
+      </p:sp>
+      <p:sp>
+        <p:nvSpPr>
+          <p:cNvPr id="7" name="">
+            <a:extLst xmlns:a="http://schemas.openxmlformats.org/drawingml/2006/main">
+              <a:ext uri="{FF2B5EF4-FFF2-40B4-BE49-F238E27FC236}">
+                <a16:creationId xmlns:a16="http://schemas.microsoft.com/office/drawing/2014/main" id="{0D218553-E35D-4437-99D5-D63186CF727C}"/>
+              </a:ext>
+            </a:extLst>
+          </p:cNvPr>
+          <p:cNvSpPr>
+            <a:spLocks xmlns:a="http://schemas.openxmlformats.org/drawingml/2006/main" noGrp="1"/>
+          </p:cNvSpPr>
+          <p:nvPr/>
+        </p:nvSpPr>
+        <p:spPr>
+          <a:xfrm xmlns:a="http://schemas.openxmlformats.org/drawingml/2006/main">
+            <a:off x="609600" y="5715000"/>
+            <a:ext cx="10953750" cy="619125"/>
+          </a:xfrm>
+          <a:prstGeom xmlns:a="http://schemas.openxmlformats.org/drawingml/2006/main" prst="rect">
+            <a:avLst/>
+          </a:prstGeom>
+          <a:noFill xmlns:a="http://schemas.openxmlformats.org/drawingml/2006/main"/>
+          <a:ln xmlns:a="http://schemas.openxmlformats.org/drawingml/2006/main" w="0">
+            <a:noFill/>
+          </a:ln>
+        </p:spPr>
+        <p:txBody>
+          <a:bodyPr xmlns:a="http://schemas.openxmlformats.org/drawingml/2006/main">
+            <a:noAutofit/>
+          </a:bodyPr>
+          <a:lstStyle xmlns:a="http://schemas.openxmlformats.org/drawingml/2006/main">
+            <a:defPPr>
+              <a:defRPr sz="1575" b="0">
                 <a:solidFill>
                   <a:srgbClr val="B8EDDB"/>
                 </a:solidFill>
@@ -13480,7 +14160,7 @@
           </a:lstStyle>
           <a:p xmlns:a="http://schemas.openxmlformats.org/drawingml/2006/main">
             <a:pPr>
-              <a:defRPr sz="1650" b="0">
+              <a:defRPr sz="1575" b="0">
                 <a:solidFill>
                   <a:srgbClr val="B8EDDB"/>
                 </a:solidFill>
@@ -13490,7 +14170,7 @@
               </a:defRPr>
             </a:pPr>
             <a:r>
-              <a:rPr sz="1650" b="0">
+              <a:rPr sz="1575" b="0">
                 <a:solidFill>
                   <a:srgbClr val="B8EDDB"/>
                 </a:solidFill>
@@ -13506,7 +14186,7 @@
     </p:spTree>
     <p:extLst>
       <p:ext uri="{BB962C8B-B14F-4D97-AF65-F5344CB8AC3E}">
-        <p14:creationId xmlns:p14="http://schemas.microsoft.com/office/powerpoint/2010/main" val="1578201214"/>
+        <p14:creationId xmlns:p14="http://schemas.microsoft.com/office/powerpoint/2010/main" val="2105490963"/>
       </p:ext>
     </p:extLst>
   </p:cSld>
@@ -13534,10 +14214,10 @@
       </p:grpSpPr>
       <p:sp>
         <p:nvSpPr>
-          <p:cNvPr id="14" name="">
-            <a:extLst xmlns:a="http://schemas.openxmlformats.org/drawingml/2006/main">
-              <a:ext uri="{FF2B5EF4-FFF2-40B4-BE49-F238E27FC236}">
-                <a16:creationId xmlns:a16="http://schemas.microsoft.com/office/drawing/2014/main" id="{1DA067FB-1C16-4EC9-ACCE-2DC93B98BF87}"/>
+          <p:cNvPr id="15" name="">
+            <a:extLst xmlns:a="http://schemas.openxmlformats.org/drawingml/2006/main">
+              <a:ext uri="{FF2B5EF4-FFF2-40B4-BE49-F238E27FC236}">
+                <a16:creationId xmlns:a16="http://schemas.microsoft.com/office/drawing/2014/main" id="{CF89DEC0-7937-407F-B911-B52CEF368F1F}"/>
               </a:ext>
             </a:extLst>
           </p:cNvPr>
@@ -13605,7 +14285,7 @@
           <p:cNvPr id="2" name="">
             <a:extLst xmlns:a="http://schemas.openxmlformats.org/drawingml/2006/main">
               <a:ext uri="{FF2B5EF4-FFF2-40B4-BE49-F238E27FC236}">
-                <a16:creationId xmlns:a16="http://schemas.microsoft.com/office/drawing/2014/main" id="{F3831372-8268-47AD-B77E-3EF7296FEAE5}"/>
+                <a16:creationId xmlns:a16="http://schemas.microsoft.com/office/drawing/2014/main" id="{3F65AD67-B220-414C-A83C-9642F53F293D}"/>
               </a:ext>
             </a:extLst>
           </p:cNvPr>
@@ -13673,7 +14353,7 @@
           <p:cNvPr id="3" name="">
             <a:extLst xmlns:a="http://schemas.openxmlformats.org/drawingml/2006/main">
               <a:ext uri="{FF2B5EF4-FFF2-40B4-BE49-F238E27FC236}">
-                <a16:creationId xmlns:a16="http://schemas.microsoft.com/office/drawing/2014/main" id="{6E692CC6-E355-4E18-9795-53F9593303E1}"/>
+                <a16:creationId xmlns:a16="http://schemas.microsoft.com/office/drawing/2014/main" id="{B29D4D06-03D8-49B8-AFB8-5CB3A28E2687}"/>
               </a:ext>
             </a:extLst>
           </p:cNvPr>
@@ -13741,7 +14421,7 @@
           <p:cNvPr id="4" name="">
             <a:extLst xmlns:a="http://schemas.openxmlformats.org/drawingml/2006/main">
               <a:ext uri="{FF2B5EF4-FFF2-40B4-BE49-F238E27FC236}">
-                <a16:creationId xmlns:a16="http://schemas.microsoft.com/office/drawing/2014/main" id="{40DA9886-ECCC-45FA-80F0-666AF62AF26E}"/>
+                <a16:creationId xmlns:a16="http://schemas.microsoft.com/office/drawing/2014/main" id="{A1A3B3D5-78A7-484F-B04C-865C19F4825A}"/>
               </a:ext>
             </a:extLst>
           </p:cNvPr>
@@ -13809,7 +14489,7 @@
           <p:cNvPr id="5" name="">
             <a:extLst xmlns:a="http://schemas.openxmlformats.org/drawingml/2006/main">
               <a:ext uri="{FF2B5EF4-FFF2-40B4-BE49-F238E27FC236}">
-                <a16:creationId xmlns:a16="http://schemas.microsoft.com/office/drawing/2014/main" id="{0EDE6818-D00C-441E-ACCD-19887C23FDE3}"/>
+                <a16:creationId xmlns:a16="http://schemas.microsoft.com/office/drawing/2014/main" id="{33489CBD-E63A-408F-8E4A-F9C96272DCFA}"/>
               </a:ext>
             </a:extLst>
           </p:cNvPr>
@@ -13877,7 +14557,7 @@
           <p:cNvPr id="6" name="">
             <a:extLst xmlns:a="http://schemas.openxmlformats.org/drawingml/2006/main">
               <a:ext uri="{FF2B5EF4-FFF2-40B4-BE49-F238E27FC236}">
-                <a16:creationId xmlns:a16="http://schemas.microsoft.com/office/drawing/2014/main" id="{3BDBF9FC-61C8-4935-9BA0-7B68AD8DB95B}"/>
+                <a16:creationId xmlns:a16="http://schemas.microsoft.com/office/drawing/2014/main" id="{E51E651C-E1B8-4668-BEA7-5ED6A2830F11}"/>
               </a:ext>
             </a:extLst>
           </p:cNvPr>
@@ -13945,7 +14625,7 @@
           <p:cNvPr id="7" name="">
             <a:extLst xmlns:a="http://schemas.openxmlformats.org/drawingml/2006/main">
               <a:ext uri="{FF2B5EF4-FFF2-40B4-BE49-F238E27FC236}">
-                <a16:creationId xmlns:a16="http://schemas.microsoft.com/office/drawing/2014/main" id="{C33B1236-5302-45EB-8731-51B68D4A366B}"/>
+                <a16:creationId xmlns:a16="http://schemas.microsoft.com/office/drawing/2014/main" id="{1CA6713A-736E-4BD4-B53C-116A05DC2D5F}"/>
               </a:ext>
             </a:extLst>
           </p:cNvPr>
@@ -14013,7 +14693,7 @@
           <p:cNvPr id="8" name="">
             <a:extLst xmlns:a="http://schemas.openxmlformats.org/drawingml/2006/main">
               <a:ext uri="{FF2B5EF4-FFF2-40B4-BE49-F238E27FC236}">
-                <a16:creationId xmlns:a16="http://schemas.microsoft.com/office/drawing/2014/main" id="{358B1722-E07E-487A-89F1-A88F634C1F6A}"/>
+                <a16:creationId xmlns:a16="http://schemas.microsoft.com/office/drawing/2014/main" id="{451556AA-52D8-4E67-8186-F25F1F87088B}"/>
               </a:ext>
             </a:extLst>
           </p:cNvPr>
@@ -14081,7 +14761,7 @@
           <p:cNvPr id="9" name="">
             <a:extLst xmlns:a="http://schemas.openxmlformats.org/drawingml/2006/main">
               <a:ext uri="{FF2B5EF4-FFF2-40B4-BE49-F238E27FC236}">
-                <a16:creationId xmlns:a16="http://schemas.microsoft.com/office/drawing/2014/main" id="{D3E7311D-6BC0-4897-BA29-2093956D03C1}"/>
+                <a16:creationId xmlns:a16="http://schemas.microsoft.com/office/drawing/2014/main" id="{EE7B2B4C-11CE-4F02-AA71-F51791DBD956}"/>
               </a:ext>
             </a:extLst>
           </p:cNvPr>
@@ -14149,7 +14829,7 @@
           <p:cNvPr id="10" name="">
             <a:extLst xmlns:a="http://schemas.openxmlformats.org/drawingml/2006/main">
               <a:ext uri="{FF2B5EF4-FFF2-40B4-BE49-F238E27FC236}">
-                <a16:creationId xmlns:a16="http://schemas.microsoft.com/office/drawing/2014/main" id="{40C0FB7B-4F12-498F-A3A1-59DB4642FDB1}"/>
+                <a16:creationId xmlns:a16="http://schemas.microsoft.com/office/drawing/2014/main" id="{19B86874-9D6B-4EEB-AD22-6AEF110B56B1}"/>
               </a:ext>
             </a:extLst>
           </p:cNvPr>
@@ -14217,7 +14897,7 @@
           <p:cNvPr id="11" name="">
             <a:extLst xmlns:a="http://schemas.openxmlformats.org/drawingml/2006/main">
               <a:ext uri="{FF2B5EF4-FFF2-40B4-BE49-F238E27FC236}">
-                <a16:creationId xmlns:a16="http://schemas.microsoft.com/office/drawing/2014/main" id="{27615728-5D0D-422A-BDA1-3662E86BD6D0}"/>
+                <a16:creationId xmlns:a16="http://schemas.microsoft.com/office/drawing/2014/main" id="{5D74EE5A-D003-4D5E-8BB0-92512D7E6652}"/>
               </a:ext>
             </a:extLst>
           </p:cNvPr>
@@ -14285,35 +14965,103 @@
           <p:cNvPr id="12" name="">
             <a:extLst xmlns:a="http://schemas.openxmlformats.org/drawingml/2006/main">
               <a:ext uri="{FF2B5EF4-FFF2-40B4-BE49-F238E27FC236}">
-                <a16:creationId xmlns:a16="http://schemas.microsoft.com/office/drawing/2014/main" id="{8195FA72-44E7-4053-80C7-91C79EE3BBC3}"/>
-              </a:ext>
-            </a:extLst>
-          </p:cNvPr>
-          <p:cNvSpPr>
-            <a:spLocks xmlns:a="http://schemas.openxmlformats.org/drawingml/2006/main" noGrp="1"/>
-          </p:cNvSpPr>
-          <p:nvPr/>
-        </p:nvSpPr>
-        <p:spPr>
-          <a:xfrm xmlns:a="http://schemas.openxmlformats.org/drawingml/2006/main">
-            <a:off x="609600" y="5572125"/>
-            <a:ext cx="10953750" cy="666750"/>
-          </a:xfrm>
-          <a:prstGeom xmlns:a="http://schemas.openxmlformats.org/drawingml/2006/main" prst="rect">
-            <a:avLst/>
-          </a:prstGeom>
-          <a:noFill xmlns:a="http://schemas.openxmlformats.org/drawingml/2006/main"/>
-          <a:ln xmlns:a="http://schemas.openxmlformats.org/drawingml/2006/main" w="0">
-            <a:noFill/>
-          </a:ln>
-        </p:spPr>
-        <p:txBody>
-          <a:bodyPr xmlns:a="http://schemas.openxmlformats.org/drawingml/2006/main">
-            <a:noAutofit/>
-          </a:bodyPr>
-          <a:lstStyle xmlns:a="http://schemas.openxmlformats.org/drawingml/2006/main">
-            <a:defPPr>
-              <a:defRPr sz="1650" b="0">
+                <a16:creationId xmlns:a16="http://schemas.microsoft.com/office/drawing/2014/main" id="{E50A0A20-C167-43F5-911E-E0FCEA8B6FBE}"/>
+              </a:ext>
+            </a:extLst>
+          </p:cNvPr>
+          <p:cNvSpPr>
+            <a:spLocks xmlns:a="http://schemas.openxmlformats.org/drawingml/2006/main" noGrp="1"/>
+          </p:cNvSpPr>
+          <p:nvPr/>
+        </p:nvSpPr>
+        <p:spPr>
+          <a:xfrm xmlns:a="http://schemas.openxmlformats.org/drawingml/2006/main">
+            <a:off x="609600" y="5286375"/>
+            <a:ext cx="10953750" cy="381000"/>
+          </a:xfrm>
+          <a:prstGeom xmlns:a="http://schemas.openxmlformats.org/drawingml/2006/main" prst="rect">
+            <a:avLst/>
+          </a:prstGeom>
+          <a:noFill xmlns:a="http://schemas.openxmlformats.org/drawingml/2006/main"/>
+          <a:ln xmlns:a="http://schemas.openxmlformats.org/drawingml/2006/main" w="0">
+            <a:noFill/>
+          </a:ln>
+        </p:spPr>
+        <p:txBody>
+          <a:bodyPr xmlns:a="http://schemas.openxmlformats.org/drawingml/2006/main">
+            <a:noAutofit/>
+          </a:bodyPr>
+          <a:lstStyle xmlns:a="http://schemas.openxmlformats.org/drawingml/2006/main">
+            <a:defPPr>
+              <a:defRPr sz="1725" b="1">
+                <a:solidFill>
+                  <a:srgbClr val="FCD34D"/>
+                </a:solidFill>
+                <a:latin typeface="Arial"/>
+                <a:ea typeface="Arial"/>
+                <a:cs typeface="Arial"/>
+              </a:defRPr>
+            </a:defPPr>
+          </a:lstStyle>
+          <a:p xmlns:a="http://schemas.openxmlformats.org/drawingml/2006/main">
+            <a:pPr>
+              <a:defRPr sz="1725" b="1">
+                <a:solidFill>
+                  <a:srgbClr val="FCD34D"/>
+                </a:solidFill>
+                <a:latin typeface="Arial"/>
+                <a:ea typeface="Arial"/>
+                <a:cs typeface="Arial"/>
+              </a:defRPr>
+            </a:pPr>
+            <a:r>
+              <a:rPr sz="1725" b="1">
+                <a:solidFill>
+                  <a:srgbClr val="FCD34D"/>
+                </a:solidFill>
+                <a:latin typeface="Arial"/>
+                <a:ea typeface="Arial"/>
+                <a:cs typeface="Arial"/>
+              </a:rPr>
+              <a:t>Çfarë ndodh nëse një nga kontrollet dështon?</a:t>
+            </a:r>
+          </a:p>
+        </p:txBody>
+      </p:sp>
+      <p:sp>
+        <p:nvSpPr>
+          <p:cNvPr id="13" name="">
+            <a:extLst xmlns:a="http://schemas.openxmlformats.org/drawingml/2006/main">
+              <a:ext uri="{FF2B5EF4-FFF2-40B4-BE49-F238E27FC236}">
+                <a16:creationId xmlns:a16="http://schemas.microsoft.com/office/drawing/2014/main" id="{D0B08C03-EFA4-4840-AAB5-DC8D2DE2999E}"/>
+              </a:ext>
+            </a:extLst>
+          </p:cNvPr>
+          <p:cNvSpPr>
+            <a:spLocks xmlns:a="http://schemas.openxmlformats.org/drawingml/2006/main" noGrp="1"/>
+          </p:cNvSpPr>
+          <p:nvPr/>
+        </p:nvSpPr>
+        <p:spPr>
+          <a:xfrm xmlns:a="http://schemas.openxmlformats.org/drawingml/2006/main">
+            <a:off x="609600" y="5715000"/>
+            <a:ext cx="10953750" cy="619125"/>
+          </a:xfrm>
+          <a:prstGeom xmlns:a="http://schemas.openxmlformats.org/drawingml/2006/main" prst="rect">
+            <a:avLst/>
+          </a:prstGeom>
+          <a:noFill xmlns:a="http://schemas.openxmlformats.org/drawingml/2006/main"/>
+          <a:ln xmlns:a="http://schemas.openxmlformats.org/drawingml/2006/main" w="0">
+            <a:noFill/>
+          </a:ln>
+        </p:spPr>
+        <p:txBody>
+          <a:bodyPr xmlns:a="http://schemas.openxmlformats.org/drawingml/2006/main">
+            <a:noAutofit/>
+          </a:bodyPr>
+          <a:lstStyle xmlns:a="http://schemas.openxmlformats.org/drawingml/2006/main">
+            <a:defPPr>
+              <a:defRPr sz="1575" b="0">
                 <a:solidFill>
                   <a:srgbClr val="B8EDDB"/>
                 </a:solidFill>
@@ -14325,7 +15073,7 @@
           </a:lstStyle>
           <a:p xmlns:a="http://schemas.openxmlformats.org/drawingml/2006/main">
             <a:pPr>
-              <a:defRPr sz="1650" b="0">
+              <a:defRPr sz="1575" b="0">
                 <a:solidFill>
                   <a:srgbClr val="B8EDDB"/>
                 </a:solidFill>
@@ -14335,7 +15083,7 @@
               </a:defRPr>
             </a:pPr>
             <a:r>
-              <a:rPr sz="1650" b="0">
+              <a:rPr sz="1575" b="0">
                 <a:solidFill>
                   <a:srgbClr val="B8EDDB"/>
                 </a:solidFill>
@@ -14350,10 +15098,10 @@
       </p:sp>
       <p:sp>
         <p:nvSpPr>
-          <p:cNvPr id="13" name="">
-            <a:extLst xmlns:a="http://schemas.openxmlformats.org/drawingml/2006/main">
-              <a:ext uri="{FF2B5EF4-FFF2-40B4-BE49-F238E27FC236}">
-                <a16:creationId xmlns:a16="http://schemas.microsoft.com/office/drawing/2014/main" id="{3622562D-77FC-465F-AE04-5BDDE98A7AC1}"/>
+          <p:cNvPr id="14" name="">
+            <a:extLst xmlns:a="http://schemas.openxmlformats.org/drawingml/2006/main">
+              <a:ext uri="{FF2B5EF4-FFF2-40B4-BE49-F238E27FC236}">
+                <a16:creationId xmlns:a16="http://schemas.microsoft.com/office/drawing/2014/main" id="{E6E61121-4ADB-40AE-AE0E-9A59AF9BABFA}"/>
               </a:ext>
             </a:extLst>
           </p:cNvPr>
@@ -14419,7 +15167,7 @@
     </p:spTree>
     <p:extLst>
       <p:ext uri="{BB962C8B-B14F-4D97-AF65-F5344CB8AC3E}">
-        <p14:creationId xmlns:p14="http://schemas.microsoft.com/office/powerpoint/2010/main" val="1640558780"/>
+        <p14:creationId xmlns:p14="http://schemas.microsoft.com/office/powerpoint/2010/main" val="617743541"/>
       </p:ext>
     </p:extLst>
   </p:cSld>

</xml_diff>

<commit_message>
Show questions before week 5 lecture answer reveals (#47)
</commit_message>
<xml_diff>
--- a/lendet/2026-2027/mobile/lectures/ligjerata-05-hyrja-lejet-rideshare-2026.pptx
+++ b/lendet/2026-2027/mobile/lectures/ligjerata-05-hyrja-lejet-rideshare-2026.pptx
@@ -2,28 +2,28 @@
 <file path=ppt/presentation.xml><?xml version="1.0" encoding="utf-8"?>
 <p:presentation xmlns:p="http://schemas.openxmlformats.org/presentationml/2006/main">
   <p:sldMasterIdLst>
-    <p:sldMasterId xmlns:r="http://schemas.openxmlformats.org/officeDocument/2006/relationships" id="2147483648" r:id="R0e510226a2a945b5"/>
+    <p:sldMasterId xmlns:r="http://schemas.openxmlformats.org/officeDocument/2006/relationships" id="2147483648" r:id="Ra426369c7da84d5a"/>
   </p:sldMasterIdLst>
   <p:sldIdLst>
-    <p:sldId xmlns:r="http://schemas.openxmlformats.org/officeDocument/2006/relationships" id="256" r:id="R4988a1bfc8ab406d"/>
-    <p:sldId xmlns:r="http://schemas.openxmlformats.org/officeDocument/2006/relationships" id="257" r:id="R2033f42ad3f54df1"/>
-    <p:sldId xmlns:r="http://schemas.openxmlformats.org/officeDocument/2006/relationships" id="258" r:id="Rbdc40740b2064c9b"/>
-    <p:sldId xmlns:r="http://schemas.openxmlformats.org/officeDocument/2006/relationships" id="259" r:id="Rfe3d39ff2b824d0d"/>
-    <p:sldId xmlns:r="http://schemas.openxmlformats.org/officeDocument/2006/relationships" id="260" r:id="R9937e8d0253340c4"/>
-    <p:sldId xmlns:r="http://schemas.openxmlformats.org/officeDocument/2006/relationships" id="261" r:id="R5bb4642e8daf4ca0"/>
-    <p:sldId xmlns:r="http://schemas.openxmlformats.org/officeDocument/2006/relationships" id="262" r:id="R87504c2952434552"/>
-    <p:sldId xmlns:r="http://schemas.openxmlformats.org/officeDocument/2006/relationships" id="263" r:id="R2618e826a8f34676"/>
-    <p:sldId xmlns:r="http://schemas.openxmlformats.org/officeDocument/2006/relationships" id="264" r:id="R1087d80c7db34a07"/>
-    <p:sldId xmlns:r="http://schemas.openxmlformats.org/officeDocument/2006/relationships" id="265" r:id="Rdada7b2b69f14a66"/>
-    <p:sldId xmlns:r="http://schemas.openxmlformats.org/officeDocument/2006/relationships" id="266" r:id="R6acc14c20e2c4f9f"/>
-    <p:sldId xmlns:r="http://schemas.openxmlformats.org/officeDocument/2006/relationships" id="267" r:id="R6d3b388979fa4b01"/>
-    <p:sldId xmlns:r="http://schemas.openxmlformats.org/officeDocument/2006/relationships" id="268" r:id="R69fbd0971d4342c7"/>
-    <p:sldId xmlns:r="http://schemas.openxmlformats.org/officeDocument/2006/relationships" id="269" r:id="Rb34102e4fcc2482d"/>
-    <p:sldId xmlns:r="http://schemas.openxmlformats.org/officeDocument/2006/relationships" id="270" r:id="R492f5f09d088441e"/>
-    <p:sldId xmlns:r="http://schemas.openxmlformats.org/officeDocument/2006/relationships" id="271" r:id="Rc2a0a32085c240bf"/>
-    <p:sldId xmlns:r="http://schemas.openxmlformats.org/officeDocument/2006/relationships" id="272" r:id="R721bbdf4739a4af2"/>
-    <p:sldId xmlns:r="http://schemas.openxmlformats.org/officeDocument/2006/relationships" id="273" r:id="R967d3bfe606e4968"/>
-    <p:sldId xmlns:r="http://schemas.openxmlformats.org/officeDocument/2006/relationships" id="274" r:id="R69578771321c40ba"/>
+    <p:sldId xmlns:r="http://schemas.openxmlformats.org/officeDocument/2006/relationships" id="256" r:id="R2a8e3bd143c446b2"/>
+    <p:sldId xmlns:r="http://schemas.openxmlformats.org/officeDocument/2006/relationships" id="257" r:id="R02b91bbb06214b13"/>
+    <p:sldId xmlns:r="http://schemas.openxmlformats.org/officeDocument/2006/relationships" id="258" r:id="Rc9e00d0e31744f44"/>
+    <p:sldId xmlns:r="http://schemas.openxmlformats.org/officeDocument/2006/relationships" id="259" r:id="R6d23df6b3bc144c5"/>
+    <p:sldId xmlns:r="http://schemas.openxmlformats.org/officeDocument/2006/relationships" id="260" r:id="R7a3b1c2f58a541a1"/>
+    <p:sldId xmlns:r="http://schemas.openxmlformats.org/officeDocument/2006/relationships" id="261" r:id="Rb9c0228945054bb2"/>
+    <p:sldId xmlns:r="http://schemas.openxmlformats.org/officeDocument/2006/relationships" id="262" r:id="Ra68adaa108544636"/>
+    <p:sldId xmlns:r="http://schemas.openxmlformats.org/officeDocument/2006/relationships" id="263" r:id="Rc4973a53bcfe426a"/>
+    <p:sldId xmlns:r="http://schemas.openxmlformats.org/officeDocument/2006/relationships" id="264" r:id="R26dd1264523e4185"/>
+    <p:sldId xmlns:r="http://schemas.openxmlformats.org/officeDocument/2006/relationships" id="265" r:id="R27040c45003b44b6"/>
+    <p:sldId xmlns:r="http://schemas.openxmlformats.org/officeDocument/2006/relationships" id="266" r:id="R6c54e096fd1f4b5d"/>
+    <p:sldId xmlns:r="http://schemas.openxmlformats.org/officeDocument/2006/relationships" id="267" r:id="R0482c50e48064147"/>
+    <p:sldId xmlns:r="http://schemas.openxmlformats.org/officeDocument/2006/relationships" id="268" r:id="R0dd6b6e5ed6a4b0b"/>
+    <p:sldId xmlns:r="http://schemas.openxmlformats.org/officeDocument/2006/relationships" id="269" r:id="R2cd4dfef9da74b74"/>
+    <p:sldId xmlns:r="http://schemas.openxmlformats.org/officeDocument/2006/relationships" id="270" r:id="R940d315431b5480c"/>
+    <p:sldId xmlns:r="http://schemas.openxmlformats.org/officeDocument/2006/relationships" id="271" r:id="R3d5ffc5941854317"/>
+    <p:sldId xmlns:r="http://schemas.openxmlformats.org/officeDocument/2006/relationships" id="272" r:id="R854f155fbc0246df"/>
+    <p:sldId xmlns:r="http://schemas.openxmlformats.org/officeDocument/2006/relationships" id="273" r:id="R438f772d8c82435c"/>
+    <p:sldId xmlns:r="http://schemas.openxmlformats.org/officeDocument/2006/relationships" id="274" r:id="Rd2474d301dc3490f"/>
   </p:sldIdLst>
   <p:sldSz cx="12192000" cy="6858000"/>
   <p:notesSz cx="6858000" cy="9144000"/>
@@ -47,7 +47,7 @@
           <p:cNvPr id="3" name="Title">
             <a:extLst xmlns:a="http://schemas.openxmlformats.org/drawingml/2006/main">
               <a:ext uri="{FF2B5EF4-FFF2-40B4-BE49-F238E27FC236}">
-                <a16:creationId xmlns:a16="http://schemas.microsoft.com/office/drawing/2014/main" id="{15490EB2-1442-4942-AC02-F30D1C8CA3C3}"/>
+                <a16:creationId xmlns:a16="http://schemas.microsoft.com/office/drawing/2014/main" id="{396B5520-02A7-4950-A1CD-C1B80A6BB0A7}"/>
               </a:ext>
             </a:extLst>
           </p:cNvPr>
@@ -204,7 +204,7 @@
           <p:cNvPr id="2" name="Subtitle">
             <a:extLst xmlns:a="http://schemas.openxmlformats.org/drawingml/2006/main">
               <a:ext uri="{FF2B5EF4-FFF2-40B4-BE49-F238E27FC236}">
-                <a16:creationId xmlns:a16="http://schemas.microsoft.com/office/drawing/2014/main" id="{61E1FEFB-1B77-4ED7-BD59-FB3787A0471B}"/>
+                <a16:creationId xmlns:a16="http://schemas.microsoft.com/office/drawing/2014/main" id="{8B45324E-8910-428B-8CED-969AE48A5C2E}"/>
               </a:ext>
             </a:extLst>
           </p:cNvPr>
@@ -378,7 +378,7 @@
           <p:cNvPr id="2" name="Section title">
             <a:extLst xmlns:a="http://schemas.openxmlformats.org/drawingml/2006/main">
               <a:ext uri="{FF2B5EF4-FFF2-40B4-BE49-F238E27FC236}">
-                <a16:creationId xmlns:a16="http://schemas.microsoft.com/office/drawing/2014/main" id="{81A4CC21-3976-4278-AFC2-E47E4952844E}"/>
+                <a16:creationId xmlns:a16="http://schemas.microsoft.com/office/drawing/2014/main" id="{452F06C6-EAE1-4FC8-98D6-63694A339708}"/>
               </a:ext>
             </a:extLst>
           </p:cNvPr>
@@ -552,7 +552,7 @@
           <p:cNvPr id="3" name="Title">
             <a:extLst xmlns:a="http://schemas.openxmlformats.org/drawingml/2006/main">
               <a:ext uri="{FF2B5EF4-FFF2-40B4-BE49-F238E27FC236}">
-                <a16:creationId xmlns:a16="http://schemas.microsoft.com/office/drawing/2014/main" id="{DDED69E2-2B8A-4D38-B390-A445DC77338B}"/>
+                <a16:creationId xmlns:a16="http://schemas.microsoft.com/office/drawing/2014/main" id="{D226925C-3E2A-481D-850B-982356F7E031}"/>
               </a:ext>
             </a:extLst>
           </p:cNvPr>
@@ -709,7 +709,7 @@
           <p:cNvPr id="2" name="Body">
             <a:extLst xmlns:a="http://schemas.openxmlformats.org/drawingml/2006/main">
               <a:ext uri="{FF2B5EF4-FFF2-40B4-BE49-F238E27FC236}">
-                <a16:creationId xmlns:a16="http://schemas.microsoft.com/office/drawing/2014/main" id="{2EDE087C-5BE2-400C-87C8-72C2281C9EEB}"/>
+                <a16:creationId xmlns:a16="http://schemas.microsoft.com/office/drawing/2014/main" id="{F60C56BA-D168-4FA6-8C52-3D3568618429}"/>
               </a:ext>
             </a:extLst>
           </p:cNvPr>
@@ -883,7 +883,7 @@
           <p:cNvPr id="4" name="Title">
             <a:extLst xmlns:a="http://schemas.openxmlformats.org/drawingml/2006/main">
               <a:ext uri="{FF2B5EF4-FFF2-40B4-BE49-F238E27FC236}">
-                <a16:creationId xmlns:a16="http://schemas.microsoft.com/office/drawing/2014/main" id="{F49B2AAF-5CB9-4B72-AED2-8658F9F4734F}"/>
+                <a16:creationId xmlns:a16="http://schemas.microsoft.com/office/drawing/2014/main" id="{734A069E-1DB6-4228-888B-5E75C81C478F}"/>
               </a:ext>
             </a:extLst>
           </p:cNvPr>
@@ -1040,7 +1040,7 @@
           <p:cNvPr id="2" name="Left column">
             <a:extLst xmlns:a="http://schemas.openxmlformats.org/drawingml/2006/main">
               <a:ext uri="{FF2B5EF4-FFF2-40B4-BE49-F238E27FC236}">
-                <a16:creationId xmlns:a16="http://schemas.microsoft.com/office/drawing/2014/main" id="{6C59D081-DE24-420B-AF10-007DF116F90A}"/>
+                <a16:creationId xmlns:a16="http://schemas.microsoft.com/office/drawing/2014/main" id="{E1977A06-8A77-484C-9961-CFFBF20E0332}"/>
               </a:ext>
             </a:extLst>
           </p:cNvPr>
@@ -1197,7 +1197,7 @@
           <p:cNvPr id="3" name="Right column">
             <a:extLst xmlns:a="http://schemas.openxmlformats.org/drawingml/2006/main">
               <a:ext uri="{FF2B5EF4-FFF2-40B4-BE49-F238E27FC236}">
-                <a16:creationId xmlns:a16="http://schemas.microsoft.com/office/drawing/2014/main" id="{A78FB5F4-0D5B-412E-A28E-EB670FA6549C}"/>
+                <a16:creationId xmlns:a16="http://schemas.microsoft.com/office/drawing/2014/main" id="{E5D16D24-F0F9-4BBA-A451-641A540588CD}"/>
               </a:ext>
             </a:extLst>
           </p:cNvPr>
@@ -1371,7 +1371,7 @@
           <p:cNvPr id="3" name="Title">
             <a:extLst xmlns:a="http://schemas.openxmlformats.org/drawingml/2006/main">
               <a:ext uri="{FF2B5EF4-FFF2-40B4-BE49-F238E27FC236}">
-                <a16:creationId xmlns:a16="http://schemas.microsoft.com/office/drawing/2014/main" id="{714304C7-978C-4658-8F7A-56D953353EBE}"/>
+                <a16:creationId xmlns:a16="http://schemas.microsoft.com/office/drawing/2014/main" id="{1C076A52-5DEA-4A1A-AC25-677FE7AFDDBA}"/>
               </a:ext>
             </a:extLst>
           </p:cNvPr>
@@ -1528,7 +1528,7 @@
           <p:cNvPr id="2" name="Left column">
             <a:extLst xmlns:a="http://schemas.openxmlformats.org/drawingml/2006/main">
               <a:ext uri="{FF2B5EF4-FFF2-40B4-BE49-F238E27FC236}">
-                <a16:creationId xmlns:a16="http://schemas.microsoft.com/office/drawing/2014/main" id="{88FF7632-BE7B-4E4F-A3DF-C146E5399366}"/>
+                <a16:creationId xmlns:a16="http://schemas.microsoft.com/office/drawing/2014/main" id="{B7683960-5A3C-4CAD-A7C7-213205B39AAF}"/>
               </a:ext>
             </a:extLst>
           </p:cNvPr>
@@ -1723,12 +1723,12 @@
   </p:cSld>
   <p:clrMap bg1="lt1" tx1="dk1" bg2="lt2" tx2="dk2" accent1="accent1" accent2="accent2" accent3="accent3" accent4="accent4" accent5="accent5" accent6="accent6" hlink="hlink" folHlink="folHlink"/>
   <p:sldLayoutIdLst>
-    <p:sldLayoutId xmlns:r="http://schemas.openxmlformats.org/officeDocument/2006/relationships" id="2147483649" r:id="Ra61d4cae48bf4350"/>
-    <p:sldLayoutId xmlns:r="http://schemas.openxmlformats.org/officeDocument/2006/relationships" id="2147483650" r:id="Ra13f0ba079f741ac"/>
-    <p:sldLayoutId xmlns:r="http://schemas.openxmlformats.org/officeDocument/2006/relationships" id="2147483651" r:id="R79f94497b4a74fc8"/>
-    <p:sldLayoutId xmlns:r="http://schemas.openxmlformats.org/officeDocument/2006/relationships" id="2147483652" r:id="R1c3d0d2ee99445c3"/>
-    <p:sldLayoutId xmlns:r="http://schemas.openxmlformats.org/officeDocument/2006/relationships" id="2147483653" r:id="R9bbc7ab9ddfa4f9f"/>
-    <p:sldLayoutId xmlns:r="http://schemas.openxmlformats.org/officeDocument/2006/relationships" id="2147483654" r:id="Rd065dfa3f114401b"/>
+    <p:sldLayoutId xmlns:r="http://schemas.openxmlformats.org/officeDocument/2006/relationships" id="2147483649" r:id="R11bf33b4394b44bc"/>
+    <p:sldLayoutId xmlns:r="http://schemas.openxmlformats.org/officeDocument/2006/relationships" id="2147483650" r:id="Rfd3013f586694c60"/>
+    <p:sldLayoutId xmlns:r="http://schemas.openxmlformats.org/officeDocument/2006/relationships" id="2147483651" r:id="R0853952709834c74"/>
+    <p:sldLayoutId xmlns:r="http://schemas.openxmlformats.org/officeDocument/2006/relationships" id="2147483652" r:id="Rc025dde330f841fd"/>
+    <p:sldLayoutId xmlns:r="http://schemas.openxmlformats.org/officeDocument/2006/relationships" id="2147483653" r:id="Ra7113a6590e64e7c"/>
+    <p:sldLayoutId xmlns:r="http://schemas.openxmlformats.org/officeDocument/2006/relationships" id="2147483654" r:id="R1707eef291174c42"/>
   </p:sldLayoutIdLst>
   <p:txStyles>
     <p:titleStyle>
@@ -2279,7 +2279,7 @@
           <p:cNvPr id="9" name="">
             <a:extLst xmlns:a="http://schemas.openxmlformats.org/drawingml/2006/main">
               <a:ext uri="{FF2B5EF4-FFF2-40B4-BE49-F238E27FC236}">
-                <a16:creationId xmlns:a16="http://schemas.microsoft.com/office/drawing/2014/main" id="{956AED7C-DBA2-45FC-8580-B04082FE0942}"/>
+                <a16:creationId xmlns:a16="http://schemas.microsoft.com/office/drawing/2014/main" id="{51230C04-1BCC-4AFC-8E0C-51C7E2B887D3}"/>
               </a:ext>
             </a:extLst>
           </p:cNvPr>
@@ -2347,7 +2347,7 @@
           <p:cNvPr id="2" name="">
             <a:extLst xmlns:a="http://schemas.openxmlformats.org/drawingml/2006/main">
               <a:ext uri="{FF2B5EF4-FFF2-40B4-BE49-F238E27FC236}">
-                <a16:creationId xmlns:a16="http://schemas.microsoft.com/office/drawing/2014/main" id="{15FC7523-55FC-43D4-97C3-7033A195293F}"/>
+                <a16:creationId xmlns:a16="http://schemas.microsoft.com/office/drawing/2014/main" id="{A6E9DBB3-2CDC-4B1D-8F2B-88D34CA3B7C1}"/>
               </a:ext>
             </a:extLst>
           </p:cNvPr>
@@ -2415,7 +2415,7 @@
           <p:cNvPr id="3" name="">
             <a:extLst xmlns:a="http://schemas.openxmlformats.org/drawingml/2006/main">
               <a:ext uri="{FF2B5EF4-FFF2-40B4-BE49-F238E27FC236}">
-                <a16:creationId xmlns:a16="http://schemas.microsoft.com/office/drawing/2014/main" id="{D260D127-325E-433A-B255-F0CC4464E697}"/>
+                <a16:creationId xmlns:a16="http://schemas.microsoft.com/office/drawing/2014/main" id="{D3F4BB72-7EEE-4C33-B7D2-D9B2A4A55EEF}"/>
               </a:ext>
             </a:extLst>
           </p:cNvPr>
@@ -2425,7 +2425,7 @@
           <p:nvPr/>
         </p:nvPicPr>
         <p:blipFill>
-          <a:blip xmlns:r="http://schemas.openxmlformats.org/officeDocument/2006/relationships" xmlns:a="http://schemas.openxmlformats.org/drawingml/2006/main" r:embed="R2bc7b012623f407d"/>
+          <a:blip xmlns:r="http://schemas.openxmlformats.org/officeDocument/2006/relationships" xmlns:a="http://schemas.openxmlformats.org/drawingml/2006/main" r:embed="R3273a7913923400f"/>
           <a:stretch xmlns:a="http://schemas.openxmlformats.org/drawingml/2006/main"/>
         </p:blipFill>
         <p:spPr>
@@ -2443,7 +2443,7 @@
           <p:cNvPr id="4" name="">
             <a:extLst xmlns:a="http://schemas.openxmlformats.org/drawingml/2006/main">
               <a:ext uri="{FF2B5EF4-FFF2-40B4-BE49-F238E27FC236}">
-                <a16:creationId xmlns:a16="http://schemas.microsoft.com/office/drawing/2014/main" id="{57A8FE9E-BF13-4EDF-BFE5-FBB4CB0521B5}"/>
+                <a16:creationId xmlns:a16="http://schemas.microsoft.com/office/drawing/2014/main" id="{4250627D-CB69-4696-92E9-2C6278C271B4}"/>
               </a:ext>
             </a:extLst>
           </p:cNvPr>
@@ -2511,7 +2511,7 @@
           <p:cNvPr id="5" name="">
             <a:extLst xmlns:a="http://schemas.openxmlformats.org/drawingml/2006/main">
               <a:ext uri="{FF2B5EF4-FFF2-40B4-BE49-F238E27FC236}">
-                <a16:creationId xmlns:a16="http://schemas.microsoft.com/office/drawing/2014/main" id="{350C6C8B-7DA6-4EFE-AE81-5915381E466C}"/>
+                <a16:creationId xmlns:a16="http://schemas.microsoft.com/office/drawing/2014/main" id="{43773C39-B97A-4D97-B5D8-87E79F020107}"/>
               </a:ext>
             </a:extLst>
           </p:cNvPr>
@@ -2607,7 +2607,7 @@
           <p:cNvPr id="6" name="">
             <a:extLst xmlns:a="http://schemas.openxmlformats.org/drawingml/2006/main">
               <a:ext uri="{FF2B5EF4-FFF2-40B4-BE49-F238E27FC236}">
-                <a16:creationId xmlns:a16="http://schemas.microsoft.com/office/drawing/2014/main" id="{B4403AE9-22CE-48CD-A53B-C633B514CC52}"/>
+                <a16:creationId xmlns:a16="http://schemas.microsoft.com/office/drawing/2014/main" id="{1F79933B-ED28-44E7-9214-2BCE26107B7A}"/>
               </a:ext>
             </a:extLst>
           </p:cNvPr>
@@ -2675,7 +2675,7 @@
           <p:cNvPr id="7" name="">
             <a:extLst xmlns:a="http://schemas.openxmlformats.org/drawingml/2006/main">
               <a:ext uri="{FF2B5EF4-FFF2-40B4-BE49-F238E27FC236}">
-                <a16:creationId xmlns:a16="http://schemas.microsoft.com/office/drawing/2014/main" id="{CE4DEC73-F9DD-4590-A127-57836D4930A9}"/>
+                <a16:creationId xmlns:a16="http://schemas.microsoft.com/office/drawing/2014/main" id="{A1A13F2B-B057-4637-BB1D-6FBC22380FD3}"/>
               </a:ext>
             </a:extLst>
           </p:cNvPr>
@@ -2799,7 +2799,7 @@
           <p:cNvPr id="8" name="">
             <a:extLst xmlns:a="http://schemas.openxmlformats.org/drawingml/2006/main">
               <a:ext uri="{FF2B5EF4-FFF2-40B4-BE49-F238E27FC236}">
-                <a16:creationId xmlns:a16="http://schemas.microsoft.com/office/drawing/2014/main" id="{3F4299F0-039C-4C70-AE42-EA9155BFAB12}"/>
+                <a16:creationId xmlns:a16="http://schemas.microsoft.com/office/drawing/2014/main" id="{71E58E0C-D15E-4291-9624-6CC01F4CAB29}"/>
               </a:ext>
             </a:extLst>
           </p:cNvPr>
@@ -2865,7 +2865,7 @@
     </p:spTree>
     <p:extLst>
       <p:ext uri="{BB962C8B-B14F-4D97-AF65-F5344CB8AC3E}">
-        <p14:creationId xmlns:p14="http://schemas.microsoft.com/office/powerpoint/2010/main" val="1532829042"/>
+        <p14:creationId xmlns:p14="http://schemas.microsoft.com/office/powerpoint/2010/main" val="967396065"/>
       </p:ext>
     </p:extLst>
   </p:cSld>
@@ -2893,10 +2893,10 @@
       </p:grpSpPr>
       <p:sp>
         <p:nvSpPr>
-          <p:cNvPr id="8" name="">
-            <a:extLst xmlns:a="http://schemas.openxmlformats.org/drawingml/2006/main">
-              <a:ext uri="{FF2B5EF4-FFF2-40B4-BE49-F238E27FC236}">
-                <a16:creationId xmlns:a16="http://schemas.microsoft.com/office/drawing/2014/main" id="{6EE9346B-3687-42DB-AB64-0678AABA2581}"/>
+          <p:cNvPr id="9" name="">
+            <a:extLst xmlns:a="http://schemas.openxmlformats.org/drawingml/2006/main">
+              <a:ext uri="{FF2B5EF4-FFF2-40B4-BE49-F238E27FC236}">
+                <a16:creationId xmlns:a16="http://schemas.microsoft.com/office/drawing/2014/main" id="{1C9CC544-0DB2-4E0A-8FEF-CA82DB4AA9F6}"/>
               </a:ext>
             </a:extLst>
           </p:cNvPr>
@@ -2964,7 +2964,7 @@
           <p:cNvPr id="2" name="">
             <a:extLst xmlns:a="http://schemas.openxmlformats.org/drawingml/2006/main">
               <a:ext uri="{FF2B5EF4-FFF2-40B4-BE49-F238E27FC236}">
-                <a16:creationId xmlns:a16="http://schemas.microsoft.com/office/drawing/2014/main" id="{802DA7AE-01C5-4CF8-9671-F5AE7FA88D5B}"/>
+                <a16:creationId xmlns:a16="http://schemas.microsoft.com/office/drawing/2014/main" id="{82AFB0CE-DA19-43C2-87B6-7F1F7A930DB2}"/>
               </a:ext>
             </a:extLst>
           </p:cNvPr>
@@ -3032,7 +3032,7 @@
           <p:cNvPr id="3" name="">
             <a:extLst xmlns:a="http://schemas.openxmlformats.org/drawingml/2006/main">
               <a:ext uri="{FF2B5EF4-FFF2-40B4-BE49-F238E27FC236}">
-                <a16:creationId xmlns:a16="http://schemas.microsoft.com/office/drawing/2014/main" id="{2DB0776F-E90E-45EB-B5F4-AB7F1202FDC6}"/>
+                <a16:creationId xmlns:a16="http://schemas.microsoft.com/office/drawing/2014/main" id="{0BAFFD90-67BE-4107-87D5-B174133AD317}"/>
               </a:ext>
             </a:extLst>
           </p:cNvPr>
@@ -3100,7 +3100,7 @@
           <p:cNvPr id="4" name="">
             <a:extLst xmlns:a="http://schemas.openxmlformats.org/drawingml/2006/main">
               <a:ext uri="{FF2B5EF4-FFF2-40B4-BE49-F238E27FC236}">
-                <a16:creationId xmlns:a16="http://schemas.microsoft.com/office/drawing/2014/main" id="{96C13AEA-B23F-4940-AAF0-C05E191BA1DC}"/>
+                <a16:creationId xmlns:a16="http://schemas.microsoft.com/office/drawing/2014/main" id="{04E4846A-0760-4635-9B15-F820A89179CA}"/>
               </a:ext>
             </a:extLst>
           </p:cNvPr>
@@ -3196,7 +3196,7 @@
           <p:cNvPr id="5" name="">
             <a:extLst xmlns:a="http://schemas.openxmlformats.org/drawingml/2006/main">
               <a:ext uri="{FF2B5EF4-FFF2-40B4-BE49-F238E27FC236}">
-                <a16:creationId xmlns:a16="http://schemas.microsoft.com/office/drawing/2014/main" id="{51B5C38C-856F-4B2F-8CFB-0DBFCE73F207}"/>
+                <a16:creationId xmlns:a16="http://schemas.microsoft.com/office/drawing/2014/main" id="{F243E558-EC30-4A18-8A73-CB3CCE18E437}"/>
               </a:ext>
             </a:extLst>
           </p:cNvPr>
@@ -3310,35 +3310,103 @@
           <p:cNvPr id="6" name="">
             <a:extLst xmlns:a="http://schemas.openxmlformats.org/drawingml/2006/main">
               <a:ext uri="{FF2B5EF4-FFF2-40B4-BE49-F238E27FC236}">
-                <a16:creationId xmlns:a16="http://schemas.microsoft.com/office/drawing/2014/main" id="{0BC26C9B-668C-4577-8936-1227CB2386E7}"/>
-              </a:ext>
-            </a:extLst>
-          </p:cNvPr>
-          <p:cNvSpPr>
-            <a:spLocks xmlns:a="http://schemas.openxmlformats.org/drawingml/2006/main" noGrp="1"/>
-          </p:cNvSpPr>
-          <p:nvPr/>
-        </p:nvSpPr>
-        <p:spPr>
-          <a:xfrm xmlns:a="http://schemas.openxmlformats.org/drawingml/2006/main">
-            <a:off x="609600" y="5572125"/>
-            <a:ext cx="10953750" cy="666750"/>
-          </a:xfrm>
-          <a:prstGeom xmlns:a="http://schemas.openxmlformats.org/drawingml/2006/main" prst="rect">
-            <a:avLst/>
-          </a:prstGeom>
-          <a:noFill xmlns:a="http://schemas.openxmlformats.org/drawingml/2006/main"/>
-          <a:ln xmlns:a="http://schemas.openxmlformats.org/drawingml/2006/main" w="0">
-            <a:noFill/>
-          </a:ln>
-        </p:spPr>
-        <p:txBody>
-          <a:bodyPr xmlns:a="http://schemas.openxmlformats.org/drawingml/2006/main">
-            <a:noAutofit/>
-          </a:bodyPr>
-          <a:lstStyle xmlns:a="http://schemas.openxmlformats.org/drawingml/2006/main">
-            <a:defPPr>
-              <a:defRPr sz="1650" b="0">
+                <a16:creationId xmlns:a16="http://schemas.microsoft.com/office/drawing/2014/main" id="{AD50EB79-EFD8-477B-B03E-346D6D884B50}"/>
+              </a:ext>
+            </a:extLst>
+          </p:cNvPr>
+          <p:cNvSpPr>
+            <a:spLocks xmlns:a="http://schemas.openxmlformats.org/drawingml/2006/main" noGrp="1"/>
+          </p:cNvSpPr>
+          <p:nvPr/>
+        </p:nvSpPr>
+        <p:spPr>
+          <a:xfrm xmlns:a="http://schemas.openxmlformats.org/drawingml/2006/main">
+            <a:off x="609600" y="5286375"/>
+            <a:ext cx="10953750" cy="381000"/>
+          </a:xfrm>
+          <a:prstGeom xmlns:a="http://schemas.openxmlformats.org/drawingml/2006/main" prst="rect">
+            <a:avLst/>
+          </a:prstGeom>
+          <a:noFill xmlns:a="http://schemas.openxmlformats.org/drawingml/2006/main"/>
+          <a:ln xmlns:a="http://schemas.openxmlformats.org/drawingml/2006/main" w="0">
+            <a:noFill/>
+          </a:ln>
+        </p:spPr>
+        <p:txBody>
+          <a:bodyPr xmlns:a="http://schemas.openxmlformats.org/drawingml/2006/main">
+            <a:noAutofit/>
+          </a:bodyPr>
+          <a:lstStyle xmlns:a="http://schemas.openxmlformats.org/drawingml/2006/main">
+            <a:defPPr>
+              <a:defRPr sz="1725" b="1">
+                <a:solidFill>
+                  <a:srgbClr val="FCD34D"/>
+                </a:solidFill>
+                <a:latin typeface="Arial"/>
+                <a:ea typeface="Arial"/>
+                <a:cs typeface="Arial"/>
+              </a:defRPr>
+            </a:defPPr>
+          </a:lstStyle>
+          <a:p xmlns:a="http://schemas.openxmlformats.org/drawingml/2006/main">
+            <a:pPr>
+              <a:defRPr sz="1725" b="1">
+                <a:solidFill>
+                  <a:srgbClr val="FCD34D"/>
+                </a:solidFill>
+                <a:latin typeface="Arial"/>
+                <a:ea typeface="Arial"/>
+                <a:cs typeface="Arial"/>
+              </a:defRPr>
+            </a:pPr>
+            <a:r>
+              <a:rPr sz="1725" b="1">
+                <a:solidFill>
+                  <a:srgbClr val="FCD34D"/>
+                </a:solidFill>
+                <a:latin typeface="Arial"/>
+                <a:ea typeface="Arial"/>
+                <a:cs typeface="Arial"/>
+              </a:rPr>
+              <a:t>Çfarë e ndalon ndryshimin e udhëtimit të një pronari tjetër?</a:t>
+            </a:r>
+          </a:p>
+        </p:txBody>
+      </p:sp>
+      <p:sp>
+        <p:nvSpPr>
+          <p:cNvPr id="7" name="">
+            <a:extLst xmlns:a="http://schemas.openxmlformats.org/drawingml/2006/main">
+              <a:ext uri="{FF2B5EF4-FFF2-40B4-BE49-F238E27FC236}">
+                <a16:creationId xmlns:a16="http://schemas.microsoft.com/office/drawing/2014/main" id="{47128CA3-66EC-45B6-9D14-19D8F624EB7B}"/>
+              </a:ext>
+            </a:extLst>
+          </p:cNvPr>
+          <p:cNvSpPr>
+            <a:spLocks xmlns:a="http://schemas.openxmlformats.org/drawingml/2006/main" noGrp="1"/>
+          </p:cNvSpPr>
+          <p:nvPr/>
+        </p:nvSpPr>
+        <p:spPr>
+          <a:xfrm xmlns:a="http://schemas.openxmlformats.org/drawingml/2006/main">
+            <a:off x="609600" y="5715000"/>
+            <a:ext cx="10953750" cy="619125"/>
+          </a:xfrm>
+          <a:prstGeom xmlns:a="http://schemas.openxmlformats.org/drawingml/2006/main" prst="rect">
+            <a:avLst/>
+          </a:prstGeom>
+          <a:noFill xmlns:a="http://schemas.openxmlformats.org/drawingml/2006/main"/>
+          <a:ln xmlns:a="http://schemas.openxmlformats.org/drawingml/2006/main" w="0">
+            <a:noFill/>
+          </a:ln>
+        </p:spPr>
+        <p:txBody>
+          <a:bodyPr xmlns:a="http://schemas.openxmlformats.org/drawingml/2006/main">
+            <a:noAutofit/>
+          </a:bodyPr>
+          <a:lstStyle xmlns:a="http://schemas.openxmlformats.org/drawingml/2006/main">
+            <a:defPPr>
+              <a:defRPr sz="1575" b="0">
                 <a:solidFill>
                   <a:srgbClr val="B8EDDB"/>
                 </a:solidFill>
@@ -3350,7 +3418,7 @@
           </a:lstStyle>
           <a:p xmlns:a="http://schemas.openxmlformats.org/drawingml/2006/main">
             <a:pPr>
-              <a:defRPr sz="1650" b="0">
+              <a:defRPr sz="1575" b="0">
                 <a:solidFill>
                   <a:srgbClr val="B8EDDB"/>
                 </a:solidFill>
@@ -3360,7 +3428,7 @@
               </a:defRPr>
             </a:pPr>
             <a:r>
-              <a:rPr sz="1650" b="0">
+              <a:rPr sz="1575" b="0">
                 <a:solidFill>
                   <a:srgbClr val="B8EDDB"/>
                 </a:solidFill>
@@ -3368,17 +3436,17 @@
                 <a:ea typeface="Arial"/>
                 <a:cs typeface="Arial"/>
               </a:rPr>
-              <a:t>Përgjigjja: Në kodin e plotë kontrollojmë edhe rolin. RETURNING tregon nëse u ndryshua një rresht.</a:t>
-            </a:r>
-          </a:p>
-        </p:txBody>
-      </p:sp>
-      <p:sp>
-        <p:nvSpPr>
-          <p:cNvPr id="7" name="">
-            <a:extLst xmlns:a="http://schemas.openxmlformats.org/drawingml/2006/main">
-              <a:ext uri="{FF2B5EF4-FFF2-40B4-BE49-F238E27FC236}">
-                <a16:creationId xmlns:a16="http://schemas.microsoft.com/office/drawing/2014/main" id="{AC2DB94B-0225-4CC4-A298-4FE9100746A9}"/>
+              <a:t>Përgjigjja: Kushti shofer_id = p.id kërkon pronarin e saktë. Në kodin e plotë kontrollojmë edhe rolin. RETURNING tregon nëse u ndryshua një rresht.</a:t>
+            </a:r>
+          </a:p>
+        </p:txBody>
+      </p:sp>
+      <p:sp>
+        <p:nvSpPr>
+          <p:cNvPr id="8" name="">
+            <a:extLst xmlns:a="http://schemas.openxmlformats.org/drawingml/2006/main">
+              <a:ext uri="{FF2B5EF4-FFF2-40B4-BE49-F238E27FC236}">
+                <a16:creationId xmlns:a16="http://schemas.microsoft.com/office/drawing/2014/main" id="{C02AA58C-4B35-4575-A9CD-63BF5CF938D0}"/>
               </a:ext>
             </a:extLst>
           </p:cNvPr>
@@ -3444,7 +3512,7 @@
     </p:spTree>
     <p:extLst>
       <p:ext uri="{BB962C8B-B14F-4D97-AF65-F5344CB8AC3E}">
-        <p14:creationId xmlns:p14="http://schemas.microsoft.com/office/powerpoint/2010/main" val="801795103"/>
+        <p14:creationId xmlns:p14="http://schemas.microsoft.com/office/powerpoint/2010/main" val="1020199114"/>
       </p:ext>
     </p:extLst>
   </p:cSld>
@@ -3472,10 +3540,10 @@
       </p:grpSpPr>
       <p:sp>
         <p:nvSpPr>
-          <p:cNvPr id="11" name="">
-            <a:extLst xmlns:a="http://schemas.openxmlformats.org/drawingml/2006/main">
-              <a:ext uri="{FF2B5EF4-FFF2-40B4-BE49-F238E27FC236}">
-                <a16:creationId xmlns:a16="http://schemas.microsoft.com/office/drawing/2014/main" id="{5C0A2CF3-F793-490F-91B9-27D7F38125FE}"/>
+          <p:cNvPr id="12" name="">
+            <a:extLst xmlns:a="http://schemas.openxmlformats.org/drawingml/2006/main">
+              <a:ext uri="{FF2B5EF4-FFF2-40B4-BE49-F238E27FC236}">
+                <a16:creationId xmlns:a16="http://schemas.microsoft.com/office/drawing/2014/main" id="{D686923C-082B-4175-9AD6-D1E850AD1A09}"/>
               </a:ext>
             </a:extLst>
           </p:cNvPr>
@@ -3543,7 +3611,7 @@
           <p:cNvPr id="2" name="">
             <a:extLst xmlns:a="http://schemas.openxmlformats.org/drawingml/2006/main">
               <a:ext uri="{FF2B5EF4-FFF2-40B4-BE49-F238E27FC236}">
-                <a16:creationId xmlns:a16="http://schemas.microsoft.com/office/drawing/2014/main" id="{A8BE38F8-E083-4B90-A2C4-C90AF2958823}"/>
+                <a16:creationId xmlns:a16="http://schemas.microsoft.com/office/drawing/2014/main" id="{C1BB9A80-3BF3-42AD-A22C-3B04886E10CB}"/>
               </a:ext>
             </a:extLst>
           </p:cNvPr>
@@ -3611,7 +3679,7 @@
           <p:cNvPr id="3" name="">
             <a:extLst xmlns:a="http://schemas.openxmlformats.org/drawingml/2006/main">
               <a:ext uri="{FF2B5EF4-FFF2-40B4-BE49-F238E27FC236}">
-                <a16:creationId xmlns:a16="http://schemas.microsoft.com/office/drawing/2014/main" id="{351A3065-E52B-4737-B309-27415390FCF9}"/>
+                <a16:creationId xmlns:a16="http://schemas.microsoft.com/office/drawing/2014/main" id="{FADA05DE-3083-4184-A3CB-B4165DF65D39}"/>
               </a:ext>
             </a:extLst>
           </p:cNvPr>
@@ -3679,7 +3747,7 @@
           <p:cNvPr id="4" name="">
             <a:extLst xmlns:a="http://schemas.openxmlformats.org/drawingml/2006/main">
               <a:ext uri="{FF2B5EF4-FFF2-40B4-BE49-F238E27FC236}">
-                <a16:creationId xmlns:a16="http://schemas.microsoft.com/office/drawing/2014/main" id="{01B627B2-D0CE-479A-9B74-C59B9B5CD865}"/>
+                <a16:creationId xmlns:a16="http://schemas.microsoft.com/office/drawing/2014/main" id="{9979263D-FF89-4943-8BFC-15916E27AC56}"/>
               </a:ext>
             </a:extLst>
           </p:cNvPr>
@@ -3803,7 +3871,7 @@
           <p:cNvPr id="5" name="">
             <a:extLst xmlns:a="http://schemas.openxmlformats.org/drawingml/2006/main">
               <a:ext uri="{FF2B5EF4-FFF2-40B4-BE49-F238E27FC236}">
-                <a16:creationId xmlns:a16="http://schemas.microsoft.com/office/drawing/2014/main" id="{30D37C80-26B7-47C2-8501-1ECEEB04A4FC}"/>
+                <a16:creationId xmlns:a16="http://schemas.microsoft.com/office/drawing/2014/main" id="{C6553F34-FB81-462E-9993-7CFECBCB6AB9}"/>
               </a:ext>
             </a:extLst>
           </p:cNvPr>
@@ -3871,7 +3939,7 @@
           <p:cNvPr id="6" name="">
             <a:extLst xmlns:a="http://schemas.openxmlformats.org/drawingml/2006/main">
               <a:ext uri="{FF2B5EF4-FFF2-40B4-BE49-F238E27FC236}">
-                <a16:creationId xmlns:a16="http://schemas.microsoft.com/office/drawing/2014/main" id="{16CCD6B5-7F80-4DFA-A6D8-534471A36BB9}"/>
+                <a16:creationId xmlns:a16="http://schemas.microsoft.com/office/drawing/2014/main" id="{98709A41-466C-478D-9820-2A88EBB77C69}"/>
               </a:ext>
             </a:extLst>
           </p:cNvPr>
@@ -3939,7 +4007,7 @@
           <p:cNvPr id="7" name="">
             <a:extLst xmlns:a="http://schemas.openxmlformats.org/drawingml/2006/main">
               <a:ext uri="{FF2B5EF4-FFF2-40B4-BE49-F238E27FC236}">
-                <a16:creationId xmlns:a16="http://schemas.microsoft.com/office/drawing/2014/main" id="{C49FED5D-C8C1-4D91-A4D3-8106D68D2A69}"/>
+                <a16:creationId xmlns:a16="http://schemas.microsoft.com/office/drawing/2014/main" id="{FEEFCEC9-F65A-45AF-8E66-9C6AD9A992CD}"/>
               </a:ext>
             </a:extLst>
           </p:cNvPr>
@@ -4007,7 +4075,7 @@
           <p:cNvPr id="8" name="">
             <a:extLst xmlns:a="http://schemas.openxmlformats.org/drawingml/2006/main">
               <a:ext uri="{FF2B5EF4-FFF2-40B4-BE49-F238E27FC236}">
-                <a16:creationId xmlns:a16="http://schemas.microsoft.com/office/drawing/2014/main" id="{5E0A373A-FD99-453C-96D4-7271DEC31136}"/>
+                <a16:creationId xmlns:a16="http://schemas.microsoft.com/office/drawing/2014/main" id="{3A9CBA78-F932-4163-B859-A89EF26FEA31}"/>
               </a:ext>
             </a:extLst>
           </p:cNvPr>
@@ -4075,35 +4143,103 @@
           <p:cNvPr id="9" name="">
             <a:extLst xmlns:a="http://schemas.openxmlformats.org/drawingml/2006/main">
               <a:ext uri="{FF2B5EF4-FFF2-40B4-BE49-F238E27FC236}">
-                <a16:creationId xmlns:a16="http://schemas.microsoft.com/office/drawing/2014/main" id="{16F010A8-BDDD-4342-8C26-4DB824B1A4EA}"/>
-              </a:ext>
-            </a:extLst>
-          </p:cNvPr>
-          <p:cNvSpPr>
-            <a:spLocks xmlns:a="http://schemas.openxmlformats.org/drawingml/2006/main" noGrp="1"/>
-          </p:cNvSpPr>
-          <p:nvPr/>
-        </p:nvSpPr>
-        <p:spPr>
-          <a:xfrm xmlns:a="http://schemas.openxmlformats.org/drawingml/2006/main">
-            <a:off x="609600" y="5572125"/>
-            <a:ext cx="10953750" cy="666750"/>
-          </a:xfrm>
-          <a:prstGeom xmlns:a="http://schemas.openxmlformats.org/drawingml/2006/main" prst="rect">
-            <a:avLst/>
-          </a:prstGeom>
-          <a:noFill xmlns:a="http://schemas.openxmlformats.org/drawingml/2006/main"/>
-          <a:ln xmlns:a="http://schemas.openxmlformats.org/drawingml/2006/main" w="0">
-            <a:noFill/>
-          </a:ln>
-        </p:spPr>
-        <p:txBody>
-          <a:bodyPr xmlns:a="http://schemas.openxmlformats.org/drawingml/2006/main">
-            <a:noAutofit/>
-          </a:bodyPr>
-          <a:lstStyle xmlns:a="http://schemas.openxmlformats.org/drawingml/2006/main">
-            <a:defPPr>
-              <a:defRPr sz="1650" b="0">
+                <a16:creationId xmlns:a16="http://schemas.microsoft.com/office/drawing/2014/main" id="{48366B05-9CFA-4090-B272-CE6593E92A34}"/>
+              </a:ext>
+            </a:extLst>
+          </p:cNvPr>
+          <p:cNvSpPr>
+            <a:spLocks xmlns:a="http://schemas.openxmlformats.org/drawingml/2006/main" noGrp="1"/>
+          </p:cNvSpPr>
+          <p:nvPr/>
+        </p:nvSpPr>
+        <p:spPr>
+          <a:xfrm xmlns:a="http://schemas.openxmlformats.org/drawingml/2006/main">
+            <a:off x="609600" y="5286375"/>
+            <a:ext cx="10953750" cy="381000"/>
+          </a:xfrm>
+          <a:prstGeom xmlns:a="http://schemas.openxmlformats.org/drawingml/2006/main" prst="rect">
+            <a:avLst/>
+          </a:prstGeom>
+          <a:noFill xmlns:a="http://schemas.openxmlformats.org/drawingml/2006/main"/>
+          <a:ln xmlns:a="http://schemas.openxmlformats.org/drawingml/2006/main" w="0">
+            <a:noFill/>
+          </a:ln>
+        </p:spPr>
+        <p:txBody>
+          <a:bodyPr xmlns:a="http://schemas.openxmlformats.org/drawingml/2006/main">
+            <a:noAutofit/>
+          </a:bodyPr>
+          <a:lstStyle xmlns:a="http://schemas.openxmlformats.org/drawingml/2006/main">
+            <a:defPPr>
+              <a:defRPr sz="1725" b="1">
+                <a:solidFill>
+                  <a:srgbClr val="FCD34D"/>
+                </a:solidFill>
+                <a:latin typeface="Arial"/>
+                <a:ea typeface="Arial"/>
+                <a:cs typeface="Arial"/>
+              </a:defRPr>
+            </a:defPPr>
+          </a:lstStyle>
+          <a:p xmlns:a="http://schemas.openxmlformats.org/drawingml/2006/main">
+            <a:pPr>
+              <a:defRPr sz="1725" b="1">
+                <a:solidFill>
+                  <a:srgbClr val="FCD34D"/>
+                </a:solidFill>
+                <a:latin typeface="Arial"/>
+                <a:ea typeface="Arial"/>
+                <a:cs typeface="Arial"/>
+              </a:defRPr>
+            </a:pPr>
+            <a:r>
+              <a:rPr sz="1725" b="1">
+                <a:solidFill>
+                  <a:srgbClr val="FCD34D"/>
+                </a:solidFill>
+                <a:latin typeface="Arial"/>
+                <a:ea typeface="Arial"/>
+                <a:cs typeface="Arial"/>
+              </a:rPr>
+              <a:t>A mjafton ta fshehim butonin për ta mbrojtur veprimin?</a:t>
+            </a:r>
+          </a:p>
+        </p:txBody>
+      </p:sp>
+      <p:sp>
+        <p:nvSpPr>
+          <p:cNvPr id="10" name="">
+            <a:extLst xmlns:a="http://schemas.openxmlformats.org/drawingml/2006/main">
+              <a:ext uri="{FF2B5EF4-FFF2-40B4-BE49-F238E27FC236}">
+                <a16:creationId xmlns:a16="http://schemas.microsoft.com/office/drawing/2014/main" id="{50D98FE8-01CE-46C7-9971-42392C24BC86}"/>
+              </a:ext>
+            </a:extLst>
+          </p:cNvPr>
+          <p:cNvSpPr>
+            <a:spLocks xmlns:a="http://schemas.openxmlformats.org/drawingml/2006/main" noGrp="1"/>
+          </p:cNvSpPr>
+          <p:nvPr/>
+        </p:nvSpPr>
+        <p:spPr>
+          <a:xfrm xmlns:a="http://schemas.openxmlformats.org/drawingml/2006/main">
+            <a:off x="609600" y="5715000"/>
+            <a:ext cx="10953750" cy="619125"/>
+          </a:xfrm>
+          <a:prstGeom xmlns:a="http://schemas.openxmlformats.org/drawingml/2006/main" prst="rect">
+            <a:avLst/>
+          </a:prstGeom>
+          <a:noFill xmlns:a="http://schemas.openxmlformats.org/drawingml/2006/main"/>
+          <a:ln xmlns:a="http://schemas.openxmlformats.org/drawingml/2006/main" w="0">
+            <a:noFill/>
+          </a:ln>
+        </p:spPr>
+        <p:txBody>
+          <a:bodyPr xmlns:a="http://schemas.openxmlformats.org/drawingml/2006/main">
+            <a:noAutofit/>
+          </a:bodyPr>
+          <a:lstStyle xmlns:a="http://schemas.openxmlformats.org/drawingml/2006/main">
+            <a:defPPr>
+              <a:defRPr sz="1575" b="0">
                 <a:solidFill>
                   <a:srgbClr val="B8EDDB"/>
                 </a:solidFill>
@@ -4115,7 +4251,7 @@
           </a:lstStyle>
           <a:p xmlns:a="http://schemas.openxmlformats.org/drawingml/2006/main">
             <a:pPr>
-              <a:defRPr sz="1650" b="0">
+              <a:defRPr sz="1575" b="0">
                 <a:solidFill>
                   <a:srgbClr val="B8EDDB"/>
                 </a:solidFill>
@@ -4125,7 +4261,7 @@
               </a:defRPr>
             </a:pPr>
             <a:r>
-              <a:rPr sz="1650" b="0">
+              <a:rPr sz="1575" b="0">
                 <a:solidFill>
                   <a:srgbClr val="B8EDDB"/>
                 </a:solidFill>
@@ -4140,10 +4276,10 @@
       </p:sp>
       <p:sp>
         <p:nvSpPr>
-          <p:cNvPr id="10" name="">
-            <a:extLst xmlns:a="http://schemas.openxmlformats.org/drawingml/2006/main">
-              <a:ext uri="{FF2B5EF4-FFF2-40B4-BE49-F238E27FC236}">
-                <a16:creationId xmlns:a16="http://schemas.microsoft.com/office/drawing/2014/main" id="{CBFBEF25-7E0D-459F-A79C-DB3DF937B365}"/>
+          <p:cNvPr id="11" name="">
+            <a:extLst xmlns:a="http://schemas.openxmlformats.org/drawingml/2006/main">
+              <a:ext uri="{FF2B5EF4-FFF2-40B4-BE49-F238E27FC236}">
+                <a16:creationId xmlns:a16="http://schemas.microsoft.com/office/drawing/2014/main" id="{E42C5EFE-63BD-4033-B94C-9558FAF16200}"/>
               </a:ext>
             </a:extLst>
           </p:cNvPr>
@@ -4209,7 +4345,7 @@
     </p:spTree>
     <p:extLst>
       <p:ext uri="{BB962C8B-B14F-4D97-AF65-F5344CB8AC3E}">
-        <p14:creationId xmlns:p14="http://schemas.microsoft.com/office/powerpoint/2010/main" val="1023003877"/>
+        <p14:creationId xmlns:p14="http://schemas.microsoft.com/office/powerpoint/2010/main" val="890542681"/>
       </p:ext>
     </p:extLst>
   </p:cSld>
@@ -4237,10 +4373,10 @@
       </p:grpSpPr>
       <p:sp>
         <p:nvSpPr>
-          <p:cNvPr id="7" name="">
-            <a:extLst xmlns:a="http://schemas.openxmlformats.org/drawingml/2006/main">
-              <a:ext uri="{FF2B5EF4-FFF2-40B4-BE49-F238E27FC236}">
-                <a16:creationId xmlns:a16="http://schemas.microsoft.com/office/drawing/2014/main" id="{59687889-77A0-419C-853F-D084180D8CBB}"/>
+          <p:cNvPr id="8" name="">
+            <a:extLst xmlns:a="http://schemas.openxmlformats.org/drawingml/2006/main">
+              <a:ext uri="{FF2B5EF4-FFF2-40B4-BE49-F238E27FC236}">
+                <a16:creationId xmlns:a16="http://schemas.microsoft.com/office/drawing/2014/main" id="{0B9E16A5-8D9A-44CE-A009-4A0E471F6E39}"/>
               </a:ext>
             </a:extLst>
           </p:cNvPr>
@@ -4308,7 +4444,7 @@
           <p:cNvPr id="2" name="">
             <a:extLst xmlns:a="http://schemas.openxmlformats.org/drawingml/2006/main">
               <a:ext uri="{FF2B5EF4-FFF2-40B4-BE49-F238E27FC236}">
-                <a16:creationId xmlns:a16="http://schemas.microsoft.com/office/drawing/2014/main" id="{F2905524-0F96-41F4-97E4-4982D3FFCFE2}"/>
+                <a16:creationId xmlns:a16="http://schemas.microsoft.com/office/drawing/2014/main" id="{98FB8B0E-D32D-454E-B226-C2B57CD45E35}"/>
               </a:ext>
             </a:extLst>
           </p:cNvPr>
@@ -4376,7 +4512,7 @@
           <p:cNvPr id="3" name="">
             <a:extLst xmlns:a="http://schemas.openxmlformats.org/drawingml/2006/main">
               <a:ext uri="{FF2B5EF4-FFF2-40B4-BE49-F238E27FC236}">
-                <a16:creationId xmlns:a16="http://schemas.microsoft.com/office/drawing/2014/main" id="{B40E233E-7BD9-44A5-A686-BBFF73EA246F}"/>
+                <a16:creationId xmlns:a16="http://schemas.microsoft.com/office/drawing/2014/main" id="{FF32E4A1-BEF3-49C8-A700-0E320DCE4A6A}"/>
               </a:ext>
             </a:extLst>
           </p:cNvPr>
@@ -4444,7 +4580,7 @@
           <p:cNvPr id="4" name="">
             <a:extLst xmlns:a="http://schemas.openxmlformats.org/drawingml/2006/main">
               <a:ext uri="{FF2B5EF4-FFF2-40B4-BE49-F238E27FC236}">
-                <a16:creationId xmlns:a16="http://schemas.microsoft.com/office/drawing/2014/main" id="{7FE09A79-0D80-4E53-9ECA-654D3DB06ECC}"/>
+                <a16:creationId xmlns:a16="http://schemas.microsoft.com/office/drawing/2014/main" id="{097E8B48-2430-4EF0-A85A-7C939826B7C6}"/>
               </a:ext>
             </a:extLst>
           </p:cNvPr>
@@ -4568,35 +4704,103 @@
           <p:cNvPr id="5" name="">
             <a:extLst xmlns:a="http://schemas.openxmlformats.org/drawingml/2006/main">
               <a:ext uri="{FF2B5EF4-FFF2-40B4-BE49-F238E27FC236}">
-                <a16:creationId xmlns:a16="http://schemas.microsoft.com/office/drawing/2014/main" id="{30838EFD-5B3F-4663-8D88-FB41DB3AA2CF}"/>
-              </a:ext>
-            </a:extLst>
-          </p:cNvPr>
-          <p:cNvSpPr>
-            <a:spLocks xmlns:a="http://schemas.openxmlformats.org/drawingml/2006/main" noGrp="1"/>
-          </p:cNvSpPr>
-          <p:nvPr/>
-        </p:nvSpPr>
-        <p:spPr>
-          <a:xfrm xmlns:a="http://schemas.openxmlformats.org/drawingml/2006/main">
-            <a:off x="609600" y="5572125"/>
-            <a:ext cx="10953750" cy="666750"/>
-          </a:xfrm>
-          <a:prstGeom xmlns:a="http://schemas.openxmlformats.org/drawingml/2006/main" prst="rect">
-            <a:avLst/>
-          </a:prstGeom>
-          <a:noFill xmlns:a="http://schemas.openxmlformats.org/drawingml/2006/main"/>
-          <a:ln xmlns:a="http://schemas.openxmlformats.org/drawingml/2006/main" w="0">
-            <a:noFill/>
-          </a:ln>
-        </p:spPr>
-        <p:txBody>
-          <a:bodyPr xmlns:a="http://schemas.openxmlformats.org/drawingml/2006/main">
-            <a:noAutofit/>
-          </a:bodyPr>
-          <a:lstStyle xmlns:a="http://schemas.openxmlformats.org/drawingml/2006/main">
-            <a:defPPr>
-              <a:defRPr sz="1650" b="0">
+                <a16:creationId xmlns:a16="http://schemas.microsoft.com/office/drawing/2014/main" id="{DA2A00D8-7A33-428F-B481-A91F10F55423}"/>
+              </a:ext>
+            </a:extLst>
+          </p:cNvPr>
+          <p:cNvSpPr>
+            <a:spLocks xmlns:a="http://schemas.openxmlformats.org/drawingml/2006/main" noGrp="1"/>
+          </p:cNvSpPr>
+          <p:nvPr/>
+        </p:nvSpPr>
+        <p:spPr>
+          <a:xfrm xmlns:a="http://schemas.openxmlformats.org/drawingml/2006/main">
+            <a:off x="609600" y="5286375"/>
+            <a:ext cx="10953750" cy="381000"/>
+          </a:xfrm>
+          <a:prstGeom xmlns:a="http://schemas.openxmlformats.org/drawingml/2006/main" prst="rect">
+            <a:avLst/>
+          </a:prstGeom>
+          <a:noFill xmlns:a="http://schemas.openxmlformats.org/drawingml/2006/main"/>
+          <a:ln xmlns:a="http://schemas.openxmlformats.org/drawingml/2006/main" w="0">
+            <a:noFill/>
+          </a:ln>
+        </p:spPr>
+        <p:txBody>
+          <a:bodyPr xmlns:a="http://schemas.openxmlformats.org/drawingml/2006/main">
+            <a:noAutofit/>
+          </a:bodyPr>
+          <a:lstStyle xmlns:a="http://schemas.openxmlformats.org/drawingml/2006/main">
+            <a:defPPr>
+              <a:defRPr sz="1725" b="1">
+                <a:solidFill>
+                  <a:srgbClr val="FCD34D"/>
+                </a:solidFill>
+                <a:latin typeface="Arial"/>
+                <a:ea typeface="Arial"/>
+                <a:cs typeface="Arial"/>
+              </a:defRPr>
+            </a:defPPr>
+          </a:lstStyle>
+          <a:p xmlns:a="http://schemas.openxmlformats.org/drawingml/2006/main">
+            <a:pPr>
+              <a:defRPr sz="1725" b="1">
+                <a:solidFill>
+                  <a:srgbClr val="FCD34D"/>
+                </a:solidFill>
+                <a:latin typeface="Arial"/>
+                <a:ea typeface="Arial"/>
+                <a:cs typeface="Arial"/>
+              </a:defRPr>
+            </a:pPr>
+            <a:r>
+              <a:rPr sz="1725" b="1">
+                <a:solidFill>
+                  <a:srgbClr val="FCD34D"/>
+                </a:solidFill>
+                <a:latin typeface="Arial"/>
+                <a:ea typeface="Arial"/>
+                <a:cs typeface="Arial"/>
+              </a:rPr>
+              <a:t>A i revokon dalja edhe kopjet e vjedhura të tokenit?</a:t>
+            </a:r>
+          </a:p>
+        </p:txBody>
+      </p:sp>
+      <p:sp>
+        <p:nvSpPr>
+          <p:cNvPr id="6" name="">
+            <a:extLst xmlns:a="http://schemas.openxmlformats.org/drawingml/2006/main">
+              <a:ext uri="{FF2B5EF4-FFF2-40B4-BE49-F238E27FC236}">
+                <a16:creationId xmlns:a16="http://schemas.microsoft.com/office/drawing/2014/main" id="{FF6CE351-997A-4711-8E6E-8A9AD0B074F0}"/>
+              </a:ext>
+            </a:extLst>
+          </p:cNvPr>
+          <p:cNvSpPr>
+            <a:spLocks xmlns:a="http://schemas.openxmlformats.org/drawingml/2006/main" noGrp="1"/>
+          </p:cNvSpPr>
+          <p:nvPr/>
+        </p:nvSpPr>
+        <p:spPr>
+          <a:xfrm xmlns:a="http://schemas.openxmlformats.org/drawingml/2006/main">
+            <a:off x="609600" y="5715000"/>
+            <a:ext cx="10953750" cy="619125"/>
+          </a:xfrm>
+          <a:prstGeom xmlns:a="http://schemas.openxmlformats.org/drawingml/2006/main" prst="rect">
+            <a:avLst/>
+          </a:prstGeom>
+          <a:noFill xmlns:a="http://schemas.openxmlformats.org/drawingml/2006/main"/>
+          <a:ln xmlns:a="http://schemas.openxmlformats.org/drawingml/2006/main" w="0">
+            <a:noFill/>
+          </a:ln>
+        </p:spPr>
+        <p:txBody>
+          <a:bodyPr xmlns:a="http://schemas.openxmlformats.org/drawingml/2006/main">
+            <a:noAutofit/>
+          </a:bodyPr>
+          <a:lstStyle xmlns:a="http://schemas.openxmlformats.org/drawingml/2006/main">
+            <a:defPPr>
+              <a:defRPr sz="1575" b="0">
                 <a:solidFill>
                   <a:srgbClr val="B8EDDB"/>
                 </a:solidFill>
@@ -4608,7 +4812,7 @@
           </a:lstStyle>
           <a:p xmlns:a="http://schemas.openxmlformats.org/drawingml/2006/main">
             <a:pPr>
-              <a:defRPr sz="1650" b="0">
+              <a:defRPr sz="1575" b="0">
                 <a:solidFill>
                   <a:srgbClr val="B8EDDB"/>
                 </a:solidFill>
@@ -4618,7 +4822,7 @@
               </a:defRPr>
             </a:pPr>
             <a:r>
-              <a:rPr sz="1650" b="0">
+              <a:rPr sz="1575" b="0">
                 <a:solidFill>
                   <a:srgbClr val="B8EDDB"/>
                 </a:solidFill>
@@ -4633,10 +4837,10 @@
       </p:sp>
       <p:sp>
         <p:nvSpPr>
-          <p:cNvPr id="6" name="">
-            <a:extLst xmlns:a="http://schemas.openxmlformats.org/drawingml/2006/main">
-              <a:ext uri="{FF2B5EF4-FFF2-40B4-BE49-F238E27FC236}">
-                <a16:creationId xmlns:a16="http://schemas.microsoft.com/office/drawing/2014/main" id="{D0030D8A-4FEE-4A48-BD4E-214397E989C4}"/>
+          <p:cNvPr id="7" name="">
+            <a:extLst xmlns:a="http://schemas.openxmlformats.org/drawingml/2006/main">
+              <a:ext uri="{FF2B5EF4-FFF2-40B4-BE49-F238E27FC236}">
+                <a16:creationId xmlns:a16="http://schemas.microsoft.com/office/drawing/2014/main" id="{9DEF0353-D2F9-4F81-926D-8BA135ACACF2}"/>
               </a:ext>
             </a:extLst>
           </p:cNvPr>
@@ -4702,7 +4906,7 @@
     </p:spTree>
     <p:extLst>
       <p:ext uri="{BB962C8B-B14F-4D97-AF65-F5344CB8AC3E}">
-        <p14:creationId xmlns:p14="http://schemas.microsoft.com/office/powerpoint/2010/main" val="564412516"/>
+        <p14:creationId xmlns:p14="http://schemas.microsoft.com/office/powerpoint/2010/main" val="1473664443"/>
       </p:ext>
     </p:extLst>
   </p:cSld>
@@ -4730,10 +4934,10 @@
       </p:grpSpPr>
       <p:sp>
         <p:nvSpPr>
-          <p:cNvPr id="10" name="">
-            <a:extLst xmlns:a="http://schemas.openxmlformats.org/drawingml/2006/main">
-              <a:ext uri="{FF2B5EF4-FFF2-40B4-BE49-F238E27FC236}">
-                <a16:creationId xmlns:a16="http://schemas.microsoft.com/office/drawing/2014/main" id="{FA091797-1F59-479D-A7C3-7D25D9A71196}"/>
+          <p:cNvPr id="11" name="">
+            <a:extLst xmlns:a="http://schemas.openxmlformats.org/drawingml/2006/main">
+              <a:ext uri="{FF2B5EF4-FFF2-40B4-BE49-F238E27FC236}">
+                <a16:creationId xmlns:a16="http://schemas.microsoft.com/office/drawing/2014/main" id="{0466A1C8-4870-4ED0-A615-8C2D99C37B2E}"/>
               </a:ext>
             </a:extLst>
           </p:cNvPr>
@@ -4801,7 +5005,7 @@
           <p:cNvPr id="2" name="">
             <a:extLst xmlns:a="http://schemas.openxmlformats.org/drawingml/2006/main">
               <a:ext uri="{FF2B5EF4-FFF2-40B4-BE49-F238E27FC236}">
-                <a16:creationId xmlns:a16="http://schemas.microsoft.com/office/drawing/2014/main" id="{39607547-868D-475F-97EA-54F1FF56EE67}"/>
+                <a16:creationId xmlns:a16="http://schemas.microsoft.com/office/drawing/2014/main" id="{4696BE1C-1BC6-4FFD-BADE-CF296D2C6525}"/>
               </a:ext>
             </a:extLst>
           </p:cNvPr>
@@ -4869,7 +5073,7 @@
           <p:cNvPr id="3" name="">
             <a:extLst xmlns:a="http://schemas.openxmlformats.org/drawingml/2006/main">
               <a:ext uri="{FF2B5EF4-FFF2-40B4-BE49-F238E27FC236}">
-                <a16:creationId xmlns:a16="http://schemas.microsoft.com/office/drawing/2014/main" id="{639A7442-1518-4127-AEBF-29DBAAE55476}"/>
+                <a16:creationId xmlns:a16="http://schemas.microsoft.com/office/drawing/2014/main" id="{0E02D23E-BFB9-42D3-89D4-4E3CBC0031EC}"/>
               </a:ext>
             </a:extLst>
           </p:cNvPr>
@@ -4937,7 +5141,7 @@
           <p:cNvPr id="4" name="">
             <a:extLst xmlns:a="http://schemas.openxmlformats.org/drawingml/2006/main">
               <a:ext uri="{FF2B5EF4-FFF2-40B4-BE49-F238E27FC236}">
-                <a16:creationId xmlns:a16="http://schemas.microsoft.com/office/drawing/2014/main" id="{DA1418FE-F274-417A-BB74-859B6505B92F}"/>
+                <a16:creationId xmlns:a16="http://schemas.microsoft.com/office/drawing/2014/main" id="{0407AED8-BBD7-44CD-AAE7-06C06E2FA50F}"/>
               </a:ext>
             </a:extLst>
           </p:cNvPr>
@@ -5061,7 +5265,7 @@
           <p:cNvPr id="5" name="">
             <a:extLst xmlns:a="http://schemas.openxmlformats.org/drawingml/2006/main">
               <a:ext uri="{FF2B5EF4-FFF2-40B4-BE49-F238E27FC236}">
-                <a16:creationId xmlns:a16="http://schemas.microsoft.com/office/drawing/2014/main" id="{62ADF283-5058-442E-9D5F-9E59361DF98D}"/>
+                <a16:creationId xmlns:a16="http://schemas.microsoft.com/office/drawing/2014/main" id="{A943381B-2074-4181-9B50-73CD564AB4C1}"/>
               </a:ext>
             </a:extLst>
           </p:cNvPr>
@@ -5129,7 +5333,7 @@
           <p:cNvPr id="6" name="">
             <a:extLst xmlns:a="http://schemas.openxmlformats.org/drawingml/2006/main">
               <a:ext uri="{FF2B5EF4-FFF2-40B4-BE49-F238E27FC236}">
-                <a16:creationId xmlns:a16="http://schemas.microsoft.com/office/drawing/2014/main" id="{B728287A-08D6-4C29-B29A-DCF7C3A86C22}"/>
+                <a16:creationId xmlns:a16="http://schemas.microsoft.com/office/drawing/2014/main" id="{76681631-26A0-4727-BEFD-10CA872B8FCB}"/>
               </a:ext>
             </a:extLst>
           </p:cNvPr>
@@ -5197,7 +5401,7 @@
           <p:cNvPr id="7" name="">
             <a:extLst xmlns:a="http://schemas.openxmlformats.org/drawingml/2006/main">
               <a:ext uri="{FF2B5EF4-FFF2-40B4-BE49-F238E27FC236}">
-                <a16:creationId xmlns:a16="http://schemas.microsoft.com/office/drawing/2014/main" id="{8F0A1529-ADAB-42EF-886B-397AF968AA9A}"/>
+                <a16:creationId xmlns:a16="http://schemas.microsoft.com/office/drawing/2014/main" id="{4A8EBAEF-9788-4C5A-B66F-C1A72DE80874}"/>
               </a:ext>
             </a:extLst>
           </p:cNvPr>
@@ -5265,7 +5469,7 @@
           <p:cNvPr id="8" name="">
             <a:extLst xmlns:a="http://schemas.openxmlformats.org/drawingml/2006/main">
               <a:ext uri="{FF2B5EF4-FFF2-40B4-BE49-F238E27FC236}">
-                <a16:creationId xmlns:a16="http://schemas.microsoft.com/office/drawing/2014/main" id="{F48A92DA-9BC3-43E6-9EB2-A92BF14C999A}"/>
+                <a16:creationId xmlns:a16="http://schemas.microsoft.com/office/drawing/2014/main" id="{B23B2742-C54A-44B8-A21F-3A3C0739BA8D}"/>
               </a:ext>
             </a:extLst>
           </p:cNvPr>
@@ -5333,35 +5537,103 @@
           <p:cNvPr id="9" name="">
             <a:extLst xmlns:a="http://schemas.openxmlformats.org/drawingml/2006/main">
               <a:ext uri="{FF2B5EF4-FFF2-40B4-BE49-F238E27FC236}">
-                <a16:creationId xmlns:a16="http://schemas.microsoft.com/office/drawing/2014/main" id="{ACC02546-0767-4EB7-8FB8-3F5C14C83851}"/>
-              </a:ext>
-            </a:extLst>
-          </p:cNvPr>
-          <p:cNvSpPr>
-            <a:spLocks xmlns:a="http://schemas.openxmlformats.org/drawingml/2006/main" noGrp="1"/>
-          </p:cNvSpPr>
-          <p:nvPr/>
-        </p:nvSpPr>
-        <p:spPr>
-          <a:xfrm xmlns:a="http://schemas.openxmlformats.org/drawingml/2006/main">
-            <a:off x="609600" y="5572125"/>
-            <a:ext cx="10953750" cy="666750"/>
-          </a:xfrm>
-          <a:prstGeom xmlns:a="http://schemas.openxmlformats.org/drawingml/2006/main" prst="rect">
-            <a:avLst/>
-          </a:prstGeom>
-          <a:noFill xmlns:a="http://schemas.openxmlformats.org/drawingml/2006/main"/>
-          <a:ln xmlns:a="http://schemas.openxmlformats.org/drawingml/2006/main" w="0">
-            <a:noFill/>
-          </a:ln>
-        </p:spPr>
-        <p:txBody>
-          <a:bodyPr xmlns:a="http://schemas.openxmlformats.org/drawingml/2006/main">
-            <a:noAutofit/>
-          </a:bodyPr>
-          <a:lstStyle xmlns:a="http://schemas.openxmlformats.org/drawingml/2006/main">
-            <a:defPPr>
-              <a:defRPr sz="1650" b="0">
+                <a16:creationId xmlns:a16="http://schemas.microsoft.com/office/drawing/2014/main" id="{A8D2C9E8-7867-4F71-A1EF-AD402E9B2B83}"/>
+              </a:ext>
+            </a:extLst>
+          </p:cNvPr>
+          <p:cNvSpPr>
+            <a:spLocks xmlns:a="http://schemas.openxmlformats.org/drawingml/2006/main" noGrp="1"/>
+          </p:cNvSpPr>
+          <p:nvPr/>
+        </p:nvSpPr>
+        <p:spPr>
+          <a:xfrm xmlns:a="http://schemas.openxmlformats.org/drawingml/2006/main">
+            <a:off x="609600" y="5286375"/>
+            <a:ext cx="10953750" cy="381000"/>
+          </a:xfrm>
+          <a:prstGeom xmlns:a="http://schemas.openxmlformats.org/drawingml/2006/main" prst="rect">
+            <a:avLst/>
+          </a:prstGeom>
+          <a:noFill xmlns:a="http://schemas.openxmlformats.org/drawingml/2006/main"/>
+          <a:ln xmlns:a="http://schemas.openxmlformats.org/drawingml/2006/main" w="0">
+            <a:noFill/>
+          </a:ln>
+        </p:spPr>
+        <p:txBody>
+          <a:bodyPr xmlns:a="http://schemas.openxmlformats.org/drawingml/2006/main">
+            <a:noAutofit/>
+          </a:bodyPr>
+          <a:lstStyle xmlns:a="http://schemas.openxmlformats.org/drawingml/2006/main">
+            <a:defPPr>
+              <a:defRPr sz="1725" b="1">
+                <a:solidFill>
+                  <a:srgbClr val="FCD34D"/>
+                </a:solidFill>
+                <a:latin typeface="Arial"/>
+                <a:ea typeface="Arial"/>
+                <a:cs typeface="Arial"/>
+              </a:defRPr>
+            </a:defPPr>
+          </a:lstStyle>
+          <a:p xmlns:a="http://schemas.openxmlformats.org/drawingml/2006/main">
+            <a:pPr>
+              <a:defRPr sz="1725" b="1">
+                <a:solidFill>
+                  <a:srgbClr val="FCD34D"/>
+                </a:solidFill>
+                <a:latin typeface="Arial"/>
+                <a:ea typeface="Arial"/>
+                <a:cs typeface="Arial"/>
+              </a:defRPr>
+            </a:pPr>
+            <a:r>
+              <a:rPr sz="1725" b="1">
+                <a:solidFill>
+                  <a:srgbClr val="FCD34D"/>
+                </a:solidFill>
+                <a:latin typeface="Arial"/>
+                <a:ea typeface="Arial"/>
+                <a:cs typeface="Arial"/>
+              </a:rPr>
+              <a:t>A është Client ID e OAuth App e njëjtë me ID-në e studentit?</a:t>
+            </a:r>
+          </a:p>
+        </p:txBody>
+      </p:sp>
+      <p:sp>
+        <p:nvSpPr>
+          <p:cNvPr id="10" name="">
+            <a:extLst xmlns:a="http://schemas.openxmlformats.org/drawingml/2006/main">
+              <a:ext uri="{FF2B5EF4-FFF2-40B4-BE49-F238E27FC236}">
+                <a16:creationId xmlns:a16="http://schemas.microsoft.com/office/drawing/2014/main" id="{8913DBBD-2FB0-4B9B-9920-BAF4A693E441}"/>
+              </a:ext>
+            </a:extLst>
+          </p:cNvPr>
+          <p:cNvSpPr>
+            <a:spLocks xmlns:a="http://schemas.openxmlformats.org/drawingml/2006/main" noGrp="1"/>
+          </p:cNvSpPr>
+          <p:nvPr/>
+        </p:nvSpPr>
+        <p:spPr>
+          <a:xfrm xmlns:a="http://schemas.openxmlformats.org/drawingml/2006/main">
+            <a:off x="609600" y="5715000"/>
+            <a:ext cx="10953750" cy="619125"/>
+          </a:xfrm>
+          <a:prstGeom xmlns:a="http://schemas.openxmlformats.org/drawingml/2006/main" prst="rect">
+            <a:avLst/>
+          </a:prstGeom>
+          <a:noFill xmlns:a="http://schemas.openxmlformats.org/drawingml/2006/main"/>
+          <a:ln xmlns:a="http://schemas.openxmlformats.org/drawingml/2006/main" w="0">
+            <a:noFill/>
+          </a:ln>
+        </p:spPr>
+        <p:txBody>
+          <a:bodyPr xmlns:a="http://schemas.openxmlformats.org/drawingml/2006/main">
+            <a:noAutofit/>
+          </a:bodyPr>
+          <a:lstStyle xmlns:a="http://schemas.openxmlformats.org/drawingml/2006/main">
+            <a:defPPr>
+              <a:defRPr sz="1575" b="0">
                 <a:solidFill>
                   <a:srgbClr val="B8EDDB"/>
                 </a:solidFill>
@@ -5373,7 +5645,7 @@
           </a:lstStyle>
           <a:p xmlns:a="http://schemas.openxmlformats.org/drawingml/2006/main">
             <a:pPr>
-              <a:defRPr sz="1650" b="0">
+              <a:defRPr sz="1575" b="0">
                 <a:solidFill>
                   <a:srgbClr val="B8EDDB"/>
                 </a:solidFill>
@@ -5383,7 +5655,7 @@
               </a:defRPr>
             </a:pPr>
             <a:r>
-              <a:rPr sz="1650" b="0">
+              <a:rPr sz="1575" b="0">
                 <a:solidFill>
                   <a:srgbClr val="B8EDDB"/>
                 </a:solidFill>
@@ -5399,7 +5671,7 @@
     </p:spTree>
     <p:extLst>
       <p:ext uri="{BB962C8B-B14F-4D97-AF65-F5344CB8AC3E}">
-        <p14:creationId xmlns:p14="http://schemas.microsoft.com/office/powerpoint/2010/main" val="1692237298"/>
+        <p14:creationId xmlns:p14="http://schemas.microsoft.com/office/powerpoint/2010/main" val="1415735660"/>
       </p:ext>
     </p:extLst>
   </p:cSld>
@@ -5430,7 +5702,7 @@
           <p:cNvPr id="6" name="">
             <a:extLst xmlns:a="http://schemas.openxmlformats.org/drawingml/2006/main">
               <a:ext uri="{FF2B5EF4-FFF2-40B4-BE49-F238E27FC236}">
-                <a16:creationId xmlns:a16="http://schemas.microsoft.com/office/drawing/2014/main" id="{F4D8B6BD-294C-4383-BB1B-800873FC6F4D}"/>
+                <a16:creationId xmlns:a16="http://schemas.microsoft.com/office/drawing/2014/main" id="{B0B8B1E1-E349-4457-AB8F-69E07D480FA4}"/>
               </a:ext>
             </a:extLst>
           </p:cNvPr>
@@ -5498,7 +5770,7 @@
           <p:cNvPr id="2" name="">
             <a:extLst xmlns:a="http://schemas.openxmlformats.org/drawingml/2006/main">
               <a:ext uri="{FF2B5EF4-FFF2-40B4-BE49-F238E27FC236}">
-                <a16:creationId xmlns:a16="http://schemas.microsoft.com/office/drawing/2014/main" id="{94CC26EE-EED3-4CF4-82DE-84B37F5F7C2B}"/>
+                <a16:creationId xmlns:a16="http://schemas.microsoft.com/office/drawing/2014/main" id="{681D885F-49F4-46DD-BCE3-73273A6AFFDD}"/>
               </a:ext>
             </a:extLst>
           </p:cNvPr>
@@ -5566,7 +5838,7 @@
           <p:cNvPr id="3" name="">
             <a:extLst xmlns:a="http://schemas.openxmlformats.org/drawingml/2006/main">
               <a:ext uri="{FF2B5EF4-FFF2-40B4-BE49-F238E27FC236}">
-                <a16:creationId xmlns:a16="http://schemas.microsoft.com/office/drawing/2014/main" id="{16649C6F-B91F-4EE8-9430-71DC226BC46E}"/>
+                <a16:creationId xmlns:a16="http://schemas.microsoft.com/office/drawing/2014/main" id="{BF10FD62-6DC0-4B91-8D1D-37DE59382363}"/>
               </a:ext>
             </a:extLst>
           </p:cNvPr>
@@ -5634,7 +5906,7 @@
           <p:cNvPr id="4" name="">
             <a:extLst xmlns:a="http://schemas.openxmlformats.org/drawingml/2006/main">
               <a:ext uri="{FF2B5EF4-FFF2-40B4-BE49-F238E27FC236}">
-                <a16:creationId xmlns:a16="http://schemas.microsoft.com/office/drawing/2014/main" id="{35FC9443-7068-4787-A6E8-B4EB95FCC154}"/>
+                <a16:creationId xmlns:a16="http://schemas.microsoft.com/office/drawing/2014/main" id="{BF5343A5-315F-4876-B75F-B8025EFD9E36}"/>
               </a:ext>
             </a:extLst>
           </p:cNvPr>
@@ -5758,7 +6030,7 @@
           <p:cNvPr id="5" name="">
             <a:extLst xmlns:a="http://schemas.openxmlformats.org/drawingml/2006/main">
               <a:ext uri="{FF2B5EF4-FFF2-40B4-BE49-F238E27FC236}">
-                <a16:creationId xmlns:a16="http://schemas.microsoft.com/office/drawing/2014/main" id="{097B2CCE-9A3F-4F08-AF51-0DE551F18C0E}"/>
+                <a16:creationId xmlns:a16="http://schemas.microsoft.com/office/drawing/2014/main" id="{8F8C3E87-766E-4FE7-93D3-61A3D94F25D0}"/>
               </a:ext>
             </a:extLst>
           </p:cNvPr>
@@ -5824,7 +6096,7 @@
     </p:spTree>
     <p:extLst>
       <p:ext uri="{BB962C8B-B14F-4D97-AF65-F5344CB8AC3E}">
-        <p14:creationId xmlns:p14="http://schemas.microsoft.com/office/powerpoint/2010/main" val="15559307"/>
+        <p14:creationId xmlns:p14="http://schemas.microsoft.com/office/powerpoint/2010/main" val="1209609110"/>
       </p:ext>
     </p:extLst>
   </p:cSld>
@@ -5855,7 +6127,7 @@
           <p:cNvPr id="8" name="">
             <a:extLst xmlns:a="http://schemas.openxmlformats.org/drawingml/2006/main">
               <a:ext uri="{FF2B5EF4-FFF2-40B4-BE49-F238E27FC236}">
-                <a16:creationId xmlns:a16="http://schemas.microsoft.com/office/drawing/2014/main" id="{435F221A-FE7A-4229-88DB-16222E3A987B}"/>
+                <a16:creationId xmlns:a16="http://schemas.microsoft.com/office/drawing/2014/main" id="{F913994A-9A5C-48C1-9ECB-167E59C05492}"/>
               </a:ext>
             </a:extLst>
           </p:cNvPr>
@@ -5923,7 +6195,7 @@
           <p:cNvPr id="2" name="">
             <a:extLst xmlns:a="http://schemas.openxmlformats.org/drawingml/2006/main">
               <a:ext uri="{FF2B5EF4-FFF2-40B4-BE49-F238E27FC236}">
-                <a16:creationId xmlns:a16="http://schemas.microsoft.com/office/drawing/2014/main" id="{FDF0E47C-4E11-4200-A71F-4E160B891A32}"/>
+                <a16:creationId xmlns:a16="http://schemas.microsoft.com/office/drawing/2014/main" id="{6A256729-9A15-4D94-ABCF-A258967B7F99}"/>
               </a:ext>
             </a:extLst>
           </p:cNvPr>
@@ -5991,7 +6263,7 @@
           <p:cNvPr id="3" name="">
             <a:extLst xmlns:a="http://schemas.openxmlformats.org/drawingml/2006/main">
               <a:ext uri="{FF2B5EF4-FFF2-40B4-BE49-F238E27FC236}">
-                <a16:creationId xmlns:a16="http://schemas.microsoft.com/office/drawing/2014/main" id="{9D566BCF-23C7-4C1A-8490-D0E9779003E4}"/>
+                <a16:creationId xmlns:a16="http://schemas.microsoft.com/office/drawing/2014/main" id="{03389279-1A01-4382-A984-8451742AA7A9}"/>
               </a:ext>
             </a:extLst>
           </p:cNvPr>
@@ -6059,7 +6331,7 @@
           <p:cNvPr id="4" name="">
             <a:extLst xmlns:a="http://schemas.openxmlformats.org/drawingml/2006/main">
               <a:ext uri="{FF2B5EF4-FFF2-40B4-BE49-F238E27FC236}">
-                <a16:creationId xmlns:a16="http://schemas.microsoft.com/office/drawing/2014/main" id="{AF11E5B9-9349-47F6-9F04-922C73F75795}"/>
+                <a16:creationId xmlns:a16="http://schemas.microsoft.com/office/drawing/2014/main" id="{E0C1BF39-D128-43EB-B5DD-5A2121C58F49}"/>
               </a:ext>
             </a:extLst>
           </p:cNvPr>
@@ -6127,7 +6399,7 @@
           <p:cNvPr id="5" name="">
             <a:extLst xmlns:a="http://schemas.openxmlformats.org/drawingml/2006/main">
               <a:ext uri="{FF2B5EF4-FFF2-40B4-BE49-F238E27FC236}">
-                <a16:creationId xmlns:a16="http://schemas.microsoft.com/office/drawing/2014/main" id="{A0FF6E8F-A2AF-4BC9-8D1B-2F9A8AA21A84}"/>
+                <a16:creationId xmlns:a16="http://schemas.microsoft.com/office/drawing/2014/main" id="{D056FCE8-9BB2-41BF-86F1-DA12CAD728CF}"/>
               </a:ext>
             </a:extLst>
           </p:cNvPr>
@@ -6195,7 +6467,7 @@
           <p:cNvPr id="6" name="">
             <a:extLst xmlns:a="http://schemas.openxmlformats.org/drawingml/2006/main">
               <a:ext uri="{FF2B5EF4-FFF2-40B4-BE49-F238E27FC236}">
-                <a16:creationId xmlns:a16="http://schemas.microsoft.com/office/drawing/2014/main" id="{A378450E-E438-44CD-A8D4-5BDD7739DE35}"/>
+                <a16:creationId xmlns:a16="http://schemas.microsoft.com/office/drawing/2014/main" id="{923439CE-4055-428F-848A-82425F8440A1}"/>
               </a:ext>
             </a:extLst>
           </p:cNvPr>
@@ -6319,7 +6591,7 @@
           <p:cNvPr id="7" name="">
             <a:extLst xmlns:a="http://schemas.openxmlformats.org/drawingml/2006/main">
               <a:ext uri="{FF2B5EF4-FFF2-40B4-BE49-F238E27FC236}">
-                <a16:creationId xmlns:a16="http://schemas.microsoft.com/office/drawing/2014/main" id="{44C6D7F4-9D8B-47DC-AE7E-9D3B7E2FC9EB}"/>
+                <a16:creationId xmlns:a16="http://schemas.microsoft.com/office/drawing/2014/main" id="{E57A6BE9-8A16-4ADC-B307-5EC773C10125}"/>
               </a:ext>
             </a:extLst>
           </p:cNvPr>
@@ -6385,7 +6657,7 @@
     </p:spTree>
     <p:extLst>
       <p:ext uri="{BB962C8B-B14F-4D97-AF65-F5344CB8AC3E}">
-        <p14:creationId xmlns:p14="http://schemas.microsoft.com/office/powerpoint/2010/main" val="1249540699"/>
+        <p14:creationId xmlns:p14="http://schemas.microsoft.com/office/powerpoint/2010/main" val="1138089406"/>
       </p:ext>
     </p:extLst>
   </p:cSld>
@@ -6413,10 +6685,10 @@
       </p:grpSpPr>
       <p:sp>
         <p:nvSpPr>
-          <p:cNvPr id="6" name="">
-            <a:extLst xmlns:a="http://schemas.openxmlformats.org/drawingml/2006/main">
-              <a:ext uri="{FF2B5EF4-FFF2-40B4-BE49-F238E27FC236}">
-                <a16:creationId xmlns:a16="http://schemas.microsoft.com/office/drawing/2014/main" id="{95AEE042-2AB1-4FE2-8540-BBCEEB24C2E6}"/>
+          <p:cNvPr id="7" name="">
+            <a:extLst xmlns:a="http://schemas.openxmlformats.org/drawingml/2006/main">
+              <a:ext uri="{FF2B5EF4-FFF2-40B4-BE49-F238E27FC236}">
+                <a16:creationId xmlns:a16="http://schemas.microsoft.com/office/drawing/2014/main" id="{8C24EF9C-F56D-44FD-ACBF-BE072F05C909}"/>
               </a:ext>
             </a:extLst>
           </p:cNvPr>
@@ -6484,7 +6756,7 @@
           <p:cNvPr id="2" name="">
             <a:extLst xmlns:a="http://schemas.openxmlformats.org/drawingml/2006/main">
               <a:ext uri="{FF2B5EF4-FFF2-40B4-BE49-F238E27FC236}">
-                <a16:creationId xmlns:a16="http://schemas.microsoft.com/office/drawing/2014/main" id="{1C265257-5331-40EA-911A-4B919A4EF83F}"/>
+                <a16:creationId xmlns:a16="http://schemas.microsoft.com/office/drawing/2014/main" id="{A76F5D79-6828-4CD2-B715-9FC7E3F23868}"/>
               </a:ext>
             </a:extLst>
           </p:cNvPr>
@@ -6552,7 +6824,7 @@
           <p:cNvPr id="3" name="">
             <a:extLst xmlns:a="http://schemas.openxmlformats.org/drawingml/2006/main">
               <a:ext uri="{FF2B5EF4-FFF2-40B4-BE49-F238E27FC236}">
-                <a16:creationId xmlns:a16="http://schemas.microsoft.com/office/drawing/2014/main" id="{7A03006B-8263-43D6-BBF0-6F342EE53E48}"/>
+                <a16:creationId xmlns:a16="http://schemas.microsoft.com/office/drawing/2014/main" id="{E1567091-EF1C-40FC-9D6E-7D18B8CE7E4A}"/>
               </a:ext>
             </a:extLst>
           </p:cNvPr>
@@ -6620,7 +6892,7 @@
           <p:cNvPr id="4" name="">
             <a:extLst xmlns:a="http://schemas.openxmlformats.org/drawingml/2006/main">
               <a:ext uri="{FF2B5EF4-FFF2-40B4-BE49-F238E27FC236}">
-                <a16:creationId xmlns:a16="http://schemas.microsoft.com/office/drawing/2014/main" id="{03FBD2AE-3EED-4F1F-B4CB-A3DED4D6A423}"/>
+                <a16:creationId xmlns:a16="http://schemas.microsoft.com/office/drawing/2014/main" id="{1B2E7438-EA40-444A-840C-254B2E444E06}"/>
               </a:ext>
             </a:extLst>
           </p:cNvPr>
@@ -6744,35 +7016,103 @@
           <p:cNvPr id="5" name="">
             <a:extLst xmlns:a="http://schemas.openxmlformats.org/drawingml/2006/main">
               <a:ext uri="{FF2B5EF4-FFF2-40B4-BE49-F238E27FC236}">
-                <a16:creationId xmlns:a16="http://schemas.microsoft.com/office/drawing/2014/main" id="{0AFADFCB-9B00-478E-B812-C937158813DB}"/>
-              </a:ext>
-            </a:extLst>
-          </p:cNvPr>
-          <p:cNvSpPr>
-            <a:spLocks xmlns:a="http://schemas.openxmlformats.org/drawingml/2006/main" noGrp="1"/>
-          </p:cNvSpPr>
-          <p:nvPr/>
-        </p:nvSpPr>
-        <p:spPr>
-          <a:xfrm xmlns:a="http://schemas.openxmlformats.org/drawingml/2006/main">
-            <a:off x="609600" y="5572125"/>
-            <a:ext cx="10953750" cy="666750"/>
-          </a:xfrm>
-          <a:prstGeom xmlns:a="http://schemas.openxmlformats.org/drawingml/2006/main" prst="rect">
-            <a:avLst/>
-          </a:prstGeom>
-          <a:noFill xmlns:a="http://schemas.openxmlformats.org/drawingml/2006/main"/>
-          <a:ln xmlns:a="http://schemas.openxmlformats.org/drawingml/2006/main" w="0">
-            <a:noFill/>
-          </a:ln>
-        </p:spPr>
-        <p:txBody>
-          <a:bodyPr xmlns:a="http://schemas.openxmlformats.org/drawingml/2006/main">
-            <a:noAutofit/>
-          </a:bodyPr>
-          <a:lstStyle xmlns:a="http://schemas.openxmlformats.org/drawingml/2006/main">
-            <a:defPPr>
-              <a:defRPr sz="1650" b="0">
+                <a16:creationId xmlns:a16="http://schemas.microsoft.com/office/drawing/2014/main" id="{DD821832-E5B1-4833-B2EB-479265342BFE}"/>
+              </a:ext>
+            </a:extLst>
+          </p:cNvPr>
+          <p:cNvSpPr>
+            <a:spLocks xmlns:a="http://schemas.openxmlformats.org/drawingml/2006/main" noGrp="1"/>
+          </p:cNvSpPr>
+          <p:nvPr/>
+        </p:nvSpPr>
+        <p:spPr>
+          <a:xfrm xmlns:a="http://schemas.openxmlformats.org/drawingml/2006/main">
+            <a:off x="609600" y="5286375"/>
+            <a:ext cx="10953750" cy="381000"/>
+          </a:xfrm>
+          <a:prstGeom xmlns:a="http://schemas.openxmlformats.org/drawingml/2006/main" prst="rect">
+            <a:avLst/>
+          </a:prstGeom>
+          <a:noFill xmlns:a="http://schemas.openxmlformats.org/drawingml/2006/main"/>
+          <a:ln xmlns:a="http://schemas.openxmlformats.org/drawingml/2006/main" w="0">
+            <a:noFill/>
+          </a:ln>
+        </p:spPr>
+        <p:txBody>
+          <a:bodyPr xmlns:a="http://schemas.openxmlformats.org/drawingml/2006/main">
+            <a:noAutofit/>
+          </a:bodyPr>
+          <a:lstStyle xmlns:a="http://schemas.openxmlformats.org/drawingml/2006/main">
+            <a:defPPr>
+              <a:defRPr sz="1725" b="1">
+                <a:solidFill>
+                  <a:srgbClr val="FCD34D"/>
+                </a:solidFill>
+                <a:latin typeface="Arial"/>
+                <a:ea typeface="Arial"/>
+                <a:cs typeface="Arial"/>
+              </a:defRPr>
+            </a:defPPr>
+          </a:lstStyle>
+          <a:p xmlns:a="http://schemas.openxmlformats.org/drawingml/2006/main">
+            <a:pPr>
+              <a:defRPr sz="1725" b="1">
+                <a:solidFill>
+                  <a:srgbClr val="FCD34D"/>
+                </a:solidFill>
+                <a:latin typeface="Arial"/>
+                <a:ea typeface="Arial"/>
+                <a:cs typeface="Arial"/>
+              </a:defRPr>
+            </a:pPr>
+            <a:r>
+              <a:rPr sz="1725" b="1">
+                <a:solidFill>
+                  <a:srgbClr val="FCD34D"/>
+                </a:solidFill>
+                <a:latin typeface="Arial"/>
+                <a:ea typeface="Arial"/>
+                <a:cs typeface="Arial"/>
+              </a:rPr>
+              <a:t>Çfarë dallimi kanë mungesa e identifikimit dhe mungesa e lejes?</a:t>
+            </a:r>
+          </a:p>
+        </p:txBody>
+      </p:sp>
+      <p:sp>
+        <p:nvSpPr>
+          <p:cNvPr id="6" name="">
+            <a:extLst xmlns:a="http://schemas.openxmlformats.org/drawingml/2006/main">
+              <a:ext uri="{FF2B5EF4-FFF2-40B4-BE49-F238E27FC236}">
+                <a16:creationId xmlns:a16="http://schemas.microsoft.com/office/drawing/2014/main" id="{195F6528-3D29-4381-A8FF-7EBDB7573B00}"/>
+              </a:ext>
+            </a:extLst>
+          </p:cNvPr>
+          <p:cNvSpPr>
+            <a:spLocks xmlns:a="http://schemas.openxmlformats.org/drawingml/2006/main" noGrp="1"/>
+          </p:cNvSpPr>
+          <p:nvPr/>
+        </p:nvSpPr>
+        <p:spPr>
+          <a:xfrm xmlns:a="http://schemas.openxmlformats.org/drawingml/2006/main">
+            <a:off x="609600" y="5715000"/>
+            <a:ext cx="10953750" cy="619125"/>
+          </a:xfrm>
+          <a:prstGeom xmlns:a="http://schemas.openxmlformats.org/drawingml/2006/main" prst="rect">
+            <a:avLst/>
+          </a:prstGeom>
+          <a:noFill xmlns:a="http://schemas.openxmlformats.org/drawingml/2006/main"/>
+          <a:ln xmlns:a="http://schemas.openxmlformats.org/drawingml/2006/main" w="0">
+            <a:noFill/>
+          </a:ln>
+        </p:spPr>
+        <p:txBody>
+          <a:bodyPr xmlns:a="http://schemas.openxmlformats.org/drawingml/2006/main">
+            <a:noAutofit/>
+          </a:bodyPr>
+          <a:lstStyle xmlns:a="http://schemas.openxmlformats.org/drawingml/2006/main">
+            <a:defPPr>
+              <a:defRPr sz="1575" b="0">
                 <a:solidFill>
                   <a:srgbClr val="B8EDDB"/>
                 </a:solidFill>
@@ -6784,7 +7124,7 @@
           </a:lstStyle>
           <a:p xmlns:a="http://schemas.openxmlformats.org/drawingml/2006/main">
             <a:pPr>
-              <a:defRPr sz="1650" b="0">
+              <a:defRPr sz="1575" b="0">
                 <a:solidFill>
                   <a:srgbClr val="B8EDDB"/>
                 </a:solidFill>
@@ -6794,7 +7134,7 @@
               </a:defRPr>
             </a:pPr>
             <a:r>
-              <a:rPr sz="1650" b="0">
+              <a:rPr sz="1575" b="0">
                 <a:solidFill>
                   <a:srgbClr val="B8EDDB"/>
                 </a:solidFill>
@@ -6810,7 +7150,7 @@
     </p:spTree>
     <p:extLst>
       <p:ext uri="{BB962C8B-B14F-4D97-AF65-F5344CB8AC3E}">
-        <p14:creationId xmlns:p14="http://schemas.microsoft.com/office/powerpoint/2010/main" val="894270845"/>
+        <p14:creationId xmlns:p14="http://schemas.microsoft.com/office/powerpoint/2010/main" val="2078852313"/>
       </p:ext>
     </p:extLst>
   </p:cSld>
@@ -6841,7 +7181,7 @@
           <p:cNvPr id="6" name="">
             <a:extLst xmlns:a="http://schemas.openxmlformats.org/drawingml/2006/main">
               <a:ext uri="{FF2B5EF4-FFF2-40B4-BE49-F238E27FC236}">
-                <a16:creationId xmlns:a16="http://schemas.microsoft.com/office/drawing/2014/main" id="{F1161FEB-3EC2-4985-ABB6-9BF2C7A39BAE}"/>
+                <a16:creationId xmlns:a16="http://schemas.microsoft.com/office/drawing/2014/main" id="{B3A2D822-B3F5-45B7-B087-68ABF2BF73F0}"/>
               </a:ext>
             </a:extLst>
           </p:cNvPr>
@@ -6909,7 +7249,7 @@
           <p:cNvPr id="2" name="">
             <a:extLst xmlns:a="http://schemas.openxmlformats.org/drawingml/2006/main">
               <a:ext uri="{FF2B5EF4-FFF2-40B4-BE49-F238E27FC236}">
-                <a16:creationId xmlns:a16="http://schemas.microsoft.com/office/drawing/2014/main" id="{1191A453-EA89-49DD-BE5E-6FAD251480B2}"/>
+                <a16:creationId xmlns:a16="http://schemas.microsoft.com/office/drawing/2014/main" id="{4A7C10CC-4576-4C9F-B965-1C84129D2EAE}"/>
               </a:ext>
             </a:extLst>
           </p:cNvPr>
@@ -6977,7 +7317,7 @@
           <p:cNvPr id="3" name="">
             <a:extLst xmlns:a="http://schemas.openxmlformats.org/drawingml/2006/main">
               <a:ext uri="{FF2B5EF4-FFF2-40B4-BE49-F238E27FC236}">
-                <a16:creationId xmlns:a16="http://schemas.microsoft.com/office/drawing/2014/main" id="{17DB00FA-42A0-45BB-8490-30083425C2D2}"/>
+                <a16:creationId xmlns:a16="http://schemas.microsoft.com/office/drawing/2014/main" id="{106B2055-691C-433A-A79A-BB8706E9DD98}"/>
               </a:ext>
             </a:extLst>
           </p:cNvPr>
@@ -7045,7 +7385,7 @@
           <p:cNvPr id="4" name="">
             <a:extLst xmlns:a="http://schemas.openxmlformats.org/drawingml/2006/main">
               <a:ext uri="{FF2B5EF4-FFF2-40B4-BE49-F238E27FC236}">
-                <a16:creationId xmlns:a16="http://schemas.microsoft.com/office/drawing/2014/main" id="{FC27FF9A-6354-4033-97E7-C26020F5EC32}"/>
+                <a16:creationId xmlns:a16="http://schemas.microsoft.com/office/drawing/2014/main" id="{86BB3108-F818-4DDC-B90D-1A27073CE984}"/>
               </a:ext>
             </a:extLst>
           </p:cNvPr>
@@ -7169,7 +7509,7 @@
           <p:cNvPr id="5" name="">
             <a:extLst xmlns:a="http://schemas.openxmlformats.org/drawingml/2006/main">
               <a:ext uri="{FF2B5EF4-FFF2-40B4-BE49-F238E27FC236}">
-                <a16:creationId xmlns:a16="http://schemas.microsoft.com/office/drawing/2014/main" id="{97949D0D-2F58-40FB-9C92-DC0B27BF7077}"/>
+                <a16:creationId xmlns:a16="http://schemas.microsoft.com/office/drawing/2014/main" id="{D459CCBD-C58F-4D9E-9A4F-8107419F5C49}"/>
               </a:ext>
             </a:extLst>
           </p:cNvPr>
@@ -7235,7 +7575,7 @@
     </p:spTree>
     <p:extLst>
       <p:ext uri="{BB962C8B-B14F-4D97-AF65-F5344CB8AC3E}">
-        <p14:creationId xmlns:p14="http://schemas.microsoft.com/office/powerpoint/2010/main" val="1109274683"/>
+        <p14:creationId xmlns:p14="http://schemas.microsoft.com/office/powerpoint/2010/main" val="1538173250"/>
       </p:ext>
     </p:extLst>
   </p:cSld>
@@ -7266,7 +7606,7 @@
           <p:cNvPr id="9" name="">
             <a:extLst xmlns:a="http://schemas.openxmlformats.org/drawingml/2006/main">
               <a:ext uri="{FF2B5EF4-FFF2-40B4-BE49-F238E27FC236}">
-                <a16:creationId xmlns:a16="http://schemas.microsoft.com/office/drawing/2014/main" id="{B16BC36A-8E0A-4F25-AE64-4A9D3FAF1AFE}"/>
+                <a16:creationId xmlns:a16="http://schemas.microsoft.com/office/drawing/2014/main" id="{10A3C018-006D-4769-8F7F-876BB96F61BC}"/>
               </a:ext>
             </a:extLst>
           </p:cNvPr>
@@ -7334,7 +7674,7 @@
           <p:cNvPr id="2" name="">
             <a:extLst xmlns:a="http://schemas.openxmlformats.org/drawingml/2006/main">
               <a:ext uri="{FF2B5EF4-FFF2-40B4-BE49-F238E27FC236}">
-                <a16:creationId xmlns:a16="http://schemas.microsoft.com/office/drawing/2014/main" id="{DC06B9D3-2909-4442-9E6F-398523030730}"/>
+                <a16:creationId xmlns:a16="http://schemas.microsoft.com/office/drawing/2014/main" id="{70734608-FF87-48EA-AE94-3A8B052B86B6}"/>
               </a:ext>
             </a:extLst>
           </p:cNvPr>
@@ -7402,7 +7742,7 @@
           <p:cNvPr id="3" name="">
             <a:extLst xmlns:a="http://schemas.openxmlformats.org/drawingml/2006/main">
               <a:ext uri="{FF2B5EF4-FFF2-40B4-BE49-F238E27FC236}">
-                <a16:creationId xmlns:a16="http://schemas.microsoft.com/office/drawing/2014/main" id="{320BB8EA-A950-48A9-8601-80BA784171DD}"/>
+                <a16:creationId xmlns:a16="http://schemas.microsoft.com/office/drawing/2014/main" id="{787748FC-7390-43B7-9EEE-6AD2BD9B1D2F}"/>
               </a:ext>
             </a:extLst>
           </p:cNvPr>
@@ -7470,7 +7810,7 @@
           <p:cNvPr id="4" name="">
             <a:extLst xmlns:a="http://schemas.openxmlformats.org/drawingml/2006/main">
               <a:ext uri="{FF2B5EF4-FFF2-40B4-BE49-F238E27FC236}">
-                <a16:creationId xmlns:a16="http://schemas.microsoft.com/office/drawing/2014/main" id="{F9F23B38-1926-4CEE-B212-F46DFA6C77D0}"/>
+                <a16:creationId xmlns:a16="http://schemas.microsoft.com/office/drawing/2014/main" id="{B5FAE35D-C20B-44B6-8669-FDDB7B15C802}"/>
               </a:ext>
             </a:extLst>
           </p:cNvPr>
@@ -7594,7 +7934,7 @@
           <p:cNvPr id="5" name="">
             <a:extLst xmlns:a="http://schemas.openxmlformats.org/drawingml/2006/main">
               <a:ext uri="{FF2B5EF4-FFF2-40B4-BE49-F238E27FC236}">
-                <a16:creationId xmlns:a16="http://schemas.microsoft.com/office/drawing/2014/main" id="{464BAA32-A48A-4094-BCA5-D14C5BB0D8CF}"/>
+                <a16:creationId xmlns:a16="http://schemas.microsoft.com/office/drawing/2014/main" id="{EFCE1189-9862-41EA-BD36-CB8B4865A3CF}"/>
               </a:ext>
             </a:extLst>
           </p:cNvPr>
@@ -7662,7 +8002,7 @@
           <p:cNvPr id="6" name="">
             <a:extLst xmlns:a="http://schemas.openxmlformats.org/drawingml/2006/main">
               <a:ext uri="{FF2B5EF4-FFF2-40B4-BE49-F238E27FC236}">
-                <a16:creationId xmlns:a16="http://schemas.microsoft.com/office/drawing/2014/main" id="{A7EF321A-E47D-4A11-ACCC-52D97A002547}"/>
+                <a16:creationId xmlns:a16="http://schemas.microsoft.com/office/drawing/2014/main" id="{BF714F24-1819-44DC-9C53-539AC67E5049}"/>
               </a:ext>
             </a:extLst>
           </p:cNvPr>
@@ -7730,7 +8070,7 @@
           <p:cNvPr id="7" name="">
             <a:extLst xmlns:a="http://schemas.openxmlformats.org/drawingml/2006/main">
               <a:ext uri="{FF2B5EF4-FFF2-40B4-BE49-F238E27FC236}">
-                <a16:creationId xmlns:a16="http://schemas.microsoft.com/office/drawing/2014/main" id="{DFA42537-B635-4171-84AC-4052BE7A3A1F}"/>
+                <a16:creationId xmlns:a16="http://schemas.microsoft.com/office/drawing/2014/main" id="{867560BA-4E22-414A-88CB-5CA30BB3704E}"/>
               </a:ext>
             </a:extLst>
           </p:cNvPr>
@@ -7798,7 +8138,7 @@
           <p:cNvPr id="8" name="">
             <a:extLst xmlns:a="http://schemas.openxmlformats.org/drawingml/2006/main">
               <a:ext uri="{FF2B5EF4-FFF2-40B4-BE49-F238E27FC236}">
-                <a16:creationId xmlns:a16="http://schemas.microsoft.com/office/drawing/2014/main" id="{15239756-1B46-46DB-94D2-3E6EAD2F9E9B}"/>
+                <a16:creationId xmlns:a16="http://schemas.microsoft.com/office/drawing/2014/main" id="{FCDDF138-B716-47E3-8450-E7C302A8FBCF}"/>
               </a:ext>
             </a:extLst>
           </p:cNvPr>
@@ -7864,7 +8204,7 @@
     </p:spTree>
     <p:extLst>
       <p:ext uri="{BB962C8B-B14F-4D97-AF65-F5344CB8AC3E}">
-        <p14:creationId xmlns:p14="http://schemas.microsoft.com/office/powerpoint/2010/main" val="1771805756"/>
+        <p14:creationId xmlns:p14="http://schemas.microsoft.com/office/powerpoint/2010/main" val="765819419"/>
       </p:ext>
     </p:extLst>
   </p:cSld>
@@ -7892,10 +8232,10 @@
       </p:grpSpPr>
       <p:sp>
         <p:nvSpPr>
-          <p:cNvPr id="6" name="">
-            <a:extLst xmlns:a="http://schemas.openxmlformats.org/drawingml/2006/main">
-              <a:ext uri="{FF2B5EF4-FFF2-40B4-BE49-F238E27FC236}">
-                <a16:creationId xmlns:a16="http://schemas.microsoft.com/office/drawing/2014/main" id="{680AD879-9D7F-4D07-89EC-5778F688A028}"/>
+          <p:cNvPr id="7" name="">
+            <a:extLst xmlns:a="http://schemas.openxmlformats.org/drawingml/2006/main">
+              <a:ext uri="{FF2B5EF4-FFF2-40B4-BE49-F238E27FC236}">
+                <a16:creationId xmlns:a16="http://schemas.microsoft.com/office/drawing/2014/main" id="{60775D23-81F9-4D72-B4F8-E2C4C763E983}"/>
               </a:ext>
             </a:extLst>
           </p:cNvPr>
@@ -7963,7 +8303,7 @@
           <p:cNvPr id="2" name="">
             <a:extLst xmlns:a="http://schemas.openxmlformats.org/drawingml/2006/main">
               <a:ext uri="{FF2B5EF4-FFF2-40B4-BE49-F238E27FC236}">
-                <a16:creationId xmlns:a16="http://schemas.microsoft.com/office/drawing/2014/main" id="{A862F58D-6AC3-4E6E-94CB-CADEDA713850}"/>
+                <a16:creationId xmlns:a16="http://schemas.microsoft.com/office/drawing/2014/main" id="{A9FED132-FAE0-4D9F-B598-F2A576F87879}"/>
               </a:ext>
             </a:extLst>
           </p:cNvPr>
@@ -8031,7 +8371,7 @@
           <p:cNvPr id="3" name="">
             <a:extLst xmlns:a="http://schemas.openxmlformats.org/drawingml/2006/main">
               <a:ext uri="{FF2B5EF4-FFF2-40B4-BE49-F238E27FC236}">
-                <a16:creationId xmlns:a16="http://schemas.microsoft.com/office/drawing/2014/main" id="{8CA53901-B401-4D89-B0DA-E1A372B75296}"/>
+                <a16:creationId xmlns:a16="http://schemas.microsoft.com/office/drawing/2014/main" id="{5E047686-B2BB-4EA1-9E44-6D916573146F}"/>
               </a:ext>
             </a:extLst>
           </p:cNvPr>
@@ -8099,7 +8439,7 @@
           <p:cNvPr id="4" name="">
             <a:extLst xmlns:a="http://schemas.openxmlformats.org/drawingml/2006/main">
               <a:ext uri="{FF2B5EF4-FFF2-40B4-BE49-F238E27FC236}">
-                <a16:creationId xmlns:a16="http://schemas.microsoft.com/office/drawing/2014/main" id="{E87FE26B-36F1-4FD8-AFAA-9758EF35E5D8}"/>
+                <a16:creationId xmlns:a16="http://schemas.microsoft.com/office/drawing/2014/main" id="{42818586-4014-4581-B23B-BE1228F8F8E4}"/>
               </a:ext>
             </a:extLst>
           </p:cNvPr>
@@ -8223,35 +8563,103 @@
           <p:cNvPr id="5" name="">
             <a:extLst xmlns:a="http://schemas.openxmlformats.org/drawingml/2006/main">
               <a:ext uri="{FF2B5EF4-FFF2-40B4-BE49-F238E27FC236}">
-                <a16:creationId xmlns:a16="http://schemas.microsoft.com/office/drawing/2014/main" id="{F41B9B38-DFBC-4794-B0C2-AF13B8D6C260}"/>
-              </a:ext>
-            </a:extLst>
-          </p:cNvPr>
-          <p:cNvSpPr>
-            <a:spLocks xmlns:a="http://schemas.openxmlformats.org/drawingml/2006/main" noGrp="1"/>
-          </p:cNvSpPr>
-          <p:nvPr/>
-        </p:nvSpPr>
-        <p:spPr>
-          <a:xfrm xmlns:a="http://schemas.openxmlformats.org/drawingml/2006/main">
-            <a:off x="609600" y="5572125"/>
-            <a:ext cx="10953750" cy="666750"/>
-          </a:xfrm>
-          <a:prstGeom xmlns:a="http://schemas.openxmlformats.org/drawingml/2006/main" prst="rect">
-            <a:avLst/>
-          </a:prstGeom>
-          <a:noFill xmlns:a="http://schemas.openxmlformats.org/drawingml/2006/main"/>
-          <a:ln xmlns:a="http://schemas.openxmlformats.org/drawingml/2006/main" w="0">
-            <a:noFill/>
-          </a:ln>
-        </p:spPr>
-        <p:txBody>
-          <a:bodyPr xmlns:a="http://schemas.openxmlformats.org/drawingml/2006/main">
-            <a:noAutofit/>
-          </a:bodyPr>
-          <a:lstStyle xmlns:a="http://schemas.openxmlformats.org/drawingml/2006/main">
-            <a:defPPr>
-              <a:defRPr sz="1650" b="0">
+                <a16:creationId xmlns:a16="http://schemas.microsoft.com/office/drawing/2014/main" id="{B0A7B426-DABE-4203-8498-1653859F0445}"/>
+              </a:ext>
+            </a:extLst>
+          </p:cNvPr>
+          <p:cNvSpPr>
+            <a:spLocks xmlns:a="http://schemas.openxmlformats.org/drawingml/2006/main" noGrp="1"/>
+          </p:cNvSpPr>
+          <p:nvPr/>
+        </p:nvSpPr>
+        <p:spPr>
+          <a:xfrm xmlns:a="http://schemas.openxmlformats.org/drawingml/2006/main">
+            <a:off x="609600" y="5286375"/>
+            <a:ext cx="10953750" cy="381000"/>
+          </a:xfrm>
+          <a:prstGeom xmlns:a="http://schemas.openxmlformats.org/drawingml/2006/main" prst="rect">
+            <a:avLst/>
+          </a:prstGeom>
+          <a:noFill xmlns:a="http://schemas.openxmlformats.org/drawingml/2006/main"/>
+          <a:ln xmlns:a="http://schemas.openxmlformats.org/drawingml/2006/main" w="0">
+            <a:noFill/>
+          </a:ln>
+        </p:spPr>
+        <p:txBody>
+          <a:bodyPr xmlns:a="http://schemas.openxmlformats.org/drawingml/2006/main">
+            <a:noAutofit/>
+          </a:bodyPr>
+          <a:lstStyle xmlns:a="http://schemas.openxmlformats.org/drawingml/2006/main">
+            <a:defPPr>
+              <a:defRPr sz="1725" b="1">
+                <a:solidFill>
+                  <a:srgbClr val="FCD34D"/>
+                </a:solidFill>
+                <a:latin typeface="Arial"/>
+                <a:ea typeface="Arial"/>
+                <a:cs typeface="Arial"/>
+              </a:defRPr>
+            </a:defPPr>
+          </a:lstStyle>
+          <a:p xmlns:a="http://schemas.openxmlformats.org/drawingml/2006/main">
+            <a:pPr>
+              <a:defRPr sz="1725" b="1">
+                <a:solidFill>
+                  <a:srgbClr val="FCD34D"/>
+                </a:solidFill>
+                <a:latin typeface="Arial"/>
+                <a:ea typeface="Arial"/>
+                <a:cs typeface="Arial"/>
+              </a:defRPr>
+            </a:pPr>
+            <a:r>
+              <a:rPr sz="1725" b="1">
+                <a:solidFill>
+                  <a:srgbClr val="FCD34D"/>
+                </a:solidFill>
+                <a:latin typeface="Arial"/>
+                <a:ea typeface="Arial"/>
+                <a:cs typeface="Arial"/>
+              </a:rPr>
+              <a:t>Kush verifikon identitetin, ku ruhet roli dhe kush vendos për ndryshimin?</a:t>
+            </a:r>
+          </a:p>
+        </p:txBody>
+      </p:sp>
+      <p:sp>
+        <p:nvSpPr>
+          <p:cNvPr id="6" name="">
+            <a:extLst xmlns:a="http://schemas.openxmlformats.org/drawingml/2006/main">
+              <a:ext uri="{FF2B5EF4-FFF2-40B4-BE49-F238E27FC236}">
+                <a16:creationId xmlns:a16="http://schemas.microsoft.com/office/drawing/2014/main" id="{E6AF49E4-C5CE-4CDF-82FC-85CB898E6C82}"/>
+              </a:ext>
+            </a:extLst>
+          </p:cNvPr>
+          <p:cNvSpPr>
+            <a:spLocks xmlns:a="http://schemas.openxmlformats.org/drawingml/2006/main" noGrp="1"/>
+          </p:cNvSpPr>
+          <p:nvPr/>
+        </p:nvSpPr>
+        <p:spPr>
+          <a:xfrm xmlns:a="http://schemas.openxmlformats.org/drawingml/2006/main">
+            <a:off x="609600" y="5715000"/>
+            <a:ext cx="10953750" cy="619125"/>
+          </a:xfrm>
+          <a:prstGeom xmlns:a="http://schemas.openxmlformats.org/drawingml/2006/main" prst="rect">
+            <a:avLst/>
+          </a:prstGeom>
+          <a:noFill xmlns:a="http://schemas.openxmlformats.org/drawingml/2006/main"/>
+          <a:ln xmlns:a="http://schemas.openxmlformats.org/drawingml/2006/main" w="0">
+            <a:noFill/>
+          </a:ln>
+        </p:spPr>
+        <p:txBody>
+          <a:bodyPr xmlns:a="http://schemas.openxmlformats.org/drawingml/2006/main">
+            <a:noAutofit/>
+          </a:bodyPr>
+          <a:lstStyle xmlns:a="http://schemas.openxmlformats.org/drawingml/2006/main">
+            <a:defPPr>
+              <a:defRPr sz="1575" b="0">
                 <a:solidFill>
                   <a:srgbClr val="B8EDDB"/>
                 </a:solidFill>
@@ -8263,7 +8671,7 @@
           </a:lstStyle>
           <a:p xmlns:a="http://schemas.openxmlformats.org/drawingml/2006/main">
             <a:pPr>
-              <a:defRPr sz="1650" b="0">
+              <a:defRPr sz="1575" b="0">
                 <a:solidFill>
                   <a:srgbClr val="B8EDDB"/>
                 </a:solidFill>
@@ -8273,7 +8681,7 @@
               </a:defRPr>
             </a:pPr>
             <a:r>
-              <a:rPr sz="1650" b="0">
+              <a:rPr sz="1575" b="0">
                 <a:solidFill>
                   <a:srgbClr val="B8EDDB"/>
                 </a:solidFill>
@@ -8289,7 +8697,7 @@
     </p:spTree>
     <p:extLst>
       <p:ext uri="{BB962C8B-B14F-4D97-AF65-F5344CB8AC3E}">
-        <p14:creationId xmlns:p14="http://schemas.microsoft.com/office/powerpoint/2010/main" val="2097555884"/>
+        <p14:creationId xmlns:p14="http://schemas.microsoft.com/office/powerpoint/2010/main" val="689370045"/>
       </p:ext>
     </p:extLst>
   </p:cSld>
@@ -8320,7 +8728,7 @@
           <p:cNvPr id="12" name="">
             <a:extLst xmlns:a="http://schemas.openxmlformats.org/drawingml/2006/main">
               <a:ext uri="{FF2B5EF4-FFF2-40B4-BE49-F238E27FC236}">
-                <a16:creationId xmlns:a16="http://schemas.microsoft.com/office/drawing/2014/main" id="{B449E169-908C-4BED-A447-2847655FD5A6}"/>
+                <a16:creationId xmlns:a16="http://schemas.microsoft.com/office/drawing/2014/main" id="{4D3F4095-32FE-40A2-A09F-0E6F3A0E8A36}"/>
               </a:ext>
             </a:extLst>
           </p:cNvPr>
@@ -8388,7 +8796,7 @@
           <p:cNvPr id="2" name="">
             <a:extLst xmlns:a="http://schemas.openxmlformats.org/drawingml/2006/main">
               <a:ext uri="{FF2B5EF4-FFF2-40B4-BE49-F238E27FC236}">
-                <a16:creationId xmlns:a16="http://schemas.microsoft.com/office/drawing/2014/main" id="{11C84C26-8809-4D0B-8605-1601FDBA2DC3}"/>
+                <a16:creationId xmlns:a16="http://schemas.microsoft.com/office/drawing/2014/main" id="{BBAE8CDE-1014-4957-A26C-E4B2842F1585}"/>
               </a:ext>
             </a:extLst>
           </p:cNvPr>
@@ -8456,7 +8864,7 @@
           <p:cNvPr id="3" name="">
             <a:extLst xmlns:a="http://schemas.openxmlformats.org/drawingml/2006/main">
               <a:ext uri="{FF2B5EF4-FFF2-40B4-BE49-F238E27FC236}">
-                <a16:creationId xmlns:a16="http://schemas.microsoft.com/office/drawing/2014/main" id="{C09DC646-3993-495A-BFDB-6E122C90AC3B}"/>
+                <a16:creationId xmlns:a16="http://schemas.microsoft.com/office/drawing/2014/main" id="{60F2F32C-62FB-45E5-A09F-3614FF93E72B}"/>
               </a:ext>
             </a:extLst>
           </p:cNvPr>
@@ -8524,7 +8932,7 @@
           <p:cNvPr id="4" name="">
             <a:extLst xmlns:a="http://schemas.openxmlformats.org/drawingml/2006/main">
               <a:ext uri="{FF2B5EF4-FFF2-40B4-BE49-F238E27FC236}">
-                <a16:creationId xmlns:a16="http://schemas.microsoft.com/office/drawing/2014/main" id="{A2B4177B-8323-47AC-82E0-3A6AE9B63B24}"/>
+                <a16:creationId xmlns:a16="http://schemas.microsoft.com/office/drawing/2014/main" id="{8FA180DF-DF3E-45E4-83BC-C940C82345FB}"/>
               </a:ext>
             </a:extLst>
           </p:cNvPr>
@@ -8648,7 +9056,7 @@
           <p:cNvPr id="5" name="">
             <a:extLst xmlns:a="http://schemas.openxmlformats.org/drawingml/2006/main">
               <a:ext uri="{FF2B5EF4-FFF2-40B4-BE49-F238E27FC236}">
-                <a16:creationId xmlns:a16="http://schemas.microsoft.com/office/drawing/2014/main" id="{C23BFB56-A2F7-4700-A056-C38AD654ECE0}"/>
+                <a16:creationId xmlns:a16="http://schemas.microsoft.com/office/drawing/2014/main" id="{5F0617C7-5AD3-4C80-9657-D851E3E9B6FC}"/>
               </a:ext>
             </a:extLst>
           </p:cNvPr>
@@ -8716,7 +9124,7 @@
           <p:cNvPr id="6" name="">
             <a:extLst xmlns:a="http://schemas.openxmlformats.org/drawingml/2006/main">
               <a:ext uri="{FF2B5EF4-FFF2-40B4-BE49-F238E27FC236}">
-                <a16:creationId xmlns:a16="http://schemas.microsoft.com/office/drawing/2014/main" id="{EAC6D373-F14E-4428-A38D-6A5A52E66366}"/>
+                <a16:creationId xmlns:a16="http://schemas.microsoft.com/office/drawing/2014/main" id="{58AE7180-CD44-4980-A826-81E88EA1705A}"/>
               </a:ext>
             </a:extLst>
           </p:cNvPr>
@@ -8784,7 +9192,7 @@
           <p:cNvPr id="7" name="">
             <a:extLst xmlns:a="http://schemas.openxmlformats.org/drawingml/2006/main">
               <a:ext uri="{FF2B5EF4-FFF2-40B4-BE49-F238E27FC236}">
-                <a16:creationId xmlns:a16="http://schemas.microsoft.com/office/drawing/2014/main" id="{C6A35DB9-0326-4C57-BF28-930E9F7CA9DB}"/>
+                <a16:creationId xmlns:a16="http://schemas.microsoft.com/office/drawing/2014/main" id="{0AA7ACAB-9423-4527-A3AC-F21AB764B66C}"/>
               </a:ext>
             </a:extLst>
           </p:cNvPr>
@@ -8852,7 +9260,7 @@
           <p:cNvPr id="8" name="">
             <a:extLst xmlns:a="http://schemas.openxmlformats.org/drawingml/2006/main">
               <a:ext uri="{FF2B5EF4-FFF2-40B4-BE49-F238E27FC236}">
-                <a16:creationId xmlns:a16="http://schemas.microsoft.com/office/drawing/2014/main" id="{7F7DD53A-0C12-4027-8EED-619DB236A847}"/>
+                <a16:creationId xmlns:a16="http://schemas.microsoft.com/office/drawing/2014/main" id="{20C2B18C-C4CC-4BD8-9B5D-9F7B7B4106CC}"/>
               </a:ext>
             </a:extLst>
           </p:cNvPr>
@@ -8920,7 +9328,7 @@
           <p:cNvPr id="9" name="">
             <a:extLst xmlns:a="http://schemas.openxmlformats.org/drawingml/2006/main">
               <a:ext uri="{FF2B5EF4-FFF2-40B4-BE49-F238E27FC236}">
-                <a16:creationId xmlns:a16="http://schemas.microsoft.com/office/drawing/2014/main" id="{0E656A93-9B12-465D-AA22-D4B309C1D7BF}"/>
+                <a16:creationId xmlns:a16="http://schemas.microsoft.com/office/drawing/2014/main" id="{4AE341F5-B5C2-458A-8EB1-F3F596DF276E}"/>
               </a:ext>
             </a:extLst>
           </p:cNvPr>
@@ -8988,7 +9396,7 @@
           <p:cNvPr id="10" name="">
             <a:extLst xmlns:a="http://schemas.openxmlformats.org/drawingml/2006/main">
               <a:ext uri="{FF2B5EF4-FFF2-40B4-BE49-F238E27FC236}">
-                <a16:creationId xmlns:a16="http://schemas.microsoft.com/office/drawing/2014/main" id="{7EAAF73B-946F-4A7F-A3B6-414E10183E40}"/>
+                <a16:creationId xmlns:a16="http://schemas.microsoft.com/office/drawing/2014/main" id="{25955149-B869-4518-BAEC-AF65BB267F9D}"/>
               </a:ext>
             </a:extLst>
           </p:cNvPr>
@@ -9056,7 +9464,7 @@
           <p:cNvPr id="11" name="">
             <a:extLst xmlns:a="http://schemas.openxmlformats.org/drawingml/2006/main">
               <a:ext uri="{FF2B5EF4-FFF2-40B4-BE49-F238E27FC236}">
-                <a16:creationId xmlns:a16="http://schemas.microsoft.com/office/drawing/2014/main" id="{89A3183C-6F19-4843-9154-F420EE6A0015}"/>
+                <a16:creationId xmlns:a16="http://schemas.microsoft.com/office/drawing/2014/main" id="{B046A4F5-A680-440A-AF4E-6F5E4223F116}"/>
               </a:ext>
             </a:extLst>
           </p:cNvPr>
@@ -9122,7 +9530,7 @@
     </p:spTree>
     <p:extLst>
       <p:ext uri="{BB962C8B-B14F-4D97-AF65-F5344CB8AC3E}">
-        <p14:creationId xmlns:p14="http://schemas.microsoft.com/office/powerpoint/2010/main" val="999941577"/>
+        <p14:creationId xmlns:p14="http://schemas.microsoft.com/office/powerpoint/2010/main" val="1667525983"/>
       </p:ext>
     </p:extLst>
   </p:cSld>
@@ -9150,10 +9558,10 @@
       </p:grpSpPr>
       <p:sp>
         <p:nvSpPr>
-          <p:cNvPr id="12" name="">
-            <a:extLst xmlns:a="http://schemas.openxmlformats.org/drawingml/2006/main">
-              <a:ext uri="{FF2B5EF4-FFF2-40B4-BE49-F238E27FC236}">
-                <a16:creationId xmlns:a16="http://schemas.microsoft.com/office/drawing/2014/main" id="{BA5D4B97-0B97-4A12-9B5B-5D4CDC3FDB88}"/>
+          <p:cNvPr id="13" name="">
+            <a:extLst xmlns:a="http://schemas.openxmlformats.org/drawingml/2006/main">
+              <a:ext uri="{FF2B5EF4-FFF2-40B4-BE49-F238E27FC236}">
+                <a16:creationId xmlns:a16="http://schemas.microsoft.com/office/drawing/2014/main" id="{75184552-F86A-4474-81AE-26B8C7410619}"/>
               </a:ext>
             </a:extLst>
           </p:cNvPr>
@@ -9221,7 +9629,7 @@
           <p:cNvPr id="2" name="">
             <a:extLst xmlns:a="http://schemas.openxmlformats.org/drawingml/2006/main">
               <a:ext uri="{FF2B5EF4-FFF2-40B4-BE49-F238E27FC236}">
-                <a16:creationId xmlns:a16="http://schemas.microsoft.com/office/drawing/2014/main" id="{79A0AC1A-C9C7-4A4E-BF9A-1BC55CBACAF3}"/>
+                <a16:creationId xmlns:a16="http://schemas.microsoft.com/office/drawing/2014/main" id="{F2978391-0B31-4B6B-BFAE-7409B4FDF279}"/>
               </a:ext>
             </a:extLst>
           </p:cNvPr>
@@ -9289,7 +9697,7 @@
           <p:cNvPr id="3" name="">
             <a:extLst xmlns:a="http://schemas.openxmlformats.org/drawingml/2006/main">
               <a:ext uri="{FF2B5EF4-FFF2-40B4-BE49-F238E27FC236}">
-                <a16:creationId xmlns:a16="http://schemas.microsoft.com/office/drawing/2014/main" id="{D527DDBA-99F9-4686-9D44-25D5119565DB}"/>
+                <a16:creationId xmlns:a16="http://schemas.microsoft.com/office/drawing/2014/main" id="{D8FAC943-FDF4-44D4-AA0E-9C3C8F1802A2}"/>
               </a:ext>
             </a:extLst>
           </p:cNvPr>
@@ -9357,7 +9765,7 @@
           <p:cNvPr id="4" name="">
             <a:extLst xmlns:a="http://schemas.openxmlformats.org/drawingml/2006/main">
               <a:ext uri="{FF2B5EF4-FFF2-40B4-BE49-F238E27FC236}">
-                <a16:creationId xmlns:a16="http://schemas.microsoft.com/office/drawing/2014/main" id="{365E33BD-3CA8-4BED-A613-B84070AF8C0A}"/>
+                <a16:creationId xmlns:a16="http://schemas.microsoft.com/office/drawing/2014/main" id="{29E8AC41-ACC0-489B-953B-86A219CCB2E0}"/>
               </a:ext>
             </a:extLst>
           </p:cNvPr>
@@ -9453,7 +9861,7 @@
           <p:cNvPr id="5" name="">
             <a:extLst xmlns:a="http://schemas.openxmlformats.org/drawingml/2006/main">
               <a:ext uri="{FF2B5EF4-FFF2-40B4-BE49-F238E27FC236}">
-                <a16:creationId xmlns:a16="http://schemas.microsoft.com/office/drawing/2014/main" id="{B8CABB73-7882-46FE-94FD-D45963004C87}"/>
+                <a16:creationId xmlns:a16="http://schemas.microsoft.com/office/drawing/2014/main" id="{2976EC68-FFA9-4B7D-8F57-29676229A7F8}"/>
               </a:ext>
             </a:extLst>
           </p:cNvPr>
@@ -9521,7 +9929,7 @@
           <p:cNvPr id="6" name="">
             <a:extLst xmlns:a="http://schemas.openxmlformats.org/drawingml/2006/main">
               <a:ext uri="{FF2B5EF4-FFF2-40B4-BE49-F238E27FC236}">
-                <a16:creationId xmlns:a16="http://schemas.microsoft.com/office/drawing/2014/main" id="{1B374835-F988-44BC-9856-410A9A967358}"/>
+                <a16:creationId xmlns:a16="http://schemas.microsoft.com/office/drawing/2014/main" id="{C4D2E9F9-45E4-4B15-B3F1-E79B617E74F0}"/>
               </a:ext>
             </a:extLst>
           </p:cNvPr>
@@ -9589,7 +9997,7 @@
           <p:cNvPr id="7" name="">
             <a:extLst xmlns:a="http://schemas.openxmlformats.org/drawingml/2006/main">
               <a:ext uri="{FF2B5EF4-FFF2-40B4-BE49-F238E27FC236}">
-                <a16:creationId xmlns:a16="http://schemas.microsoft.com/office/drawing/2014/main" id="{6B3FA6BA-493F-4647-82F4-2AC8073DC852}"/>
+                <a16:creationId xmlns:a16="http://schemas.microsoft.com/office/drawing/2014/main" id="{96C8BA8D-45F4-4A27-B5B8-DD4A206D57CE}"/>
               </a:ext>
             </a:extLst>
           </p:cNvPr>
@@ -9657,7 +10065,7 @@
           <p:cNvPr id="8" name="">
             <a:extLst xmlns:a="http://schemas.openxmlformats.org/drawingml/2006/main">
               <a:ext uri="{FF2B5EF4-FFF2-40B4-BE49-F238E27FC236}">
-                <a16:creationId xmlns:a16="http://schemas.microsoft.com/office/drawing/2014/main" id="{43DE11A1-BAA8-4BA6-922C-983194CE1BF3}"/>
+                <a16:creationId xmlns:a16="http://schemas.microsoft.com/office/drawing/2014/main" id="{2D4289A0-9FCF-4AFC-B9E6-099282C5AD7C}"/>
               </a:ext>
             </a:extLst>
           </p:cNvPr>
@@ -9725,7 +10133,7 @@
           <p:cNvPr id="9" name="">
             <a:extLst xmlns:a="http://schemas.openxmlformats.org/drawingml/2006/main">
               <a:ext uri="{FF2B5EF4-FFF2-40B4-BE49-F238E27FC236}">
-                <a16:creationId xmlns:a16="http://schemas.microsoft.com/office/drawing/2014/main" id="{269377A8-90A8-4E84-90F8-D874706195D8}"/>
+                <a16:creationId xmlns:a16="http://schemas.microsoft.com/office/drawing/2014/main" id="{98FDCCE3-2DB2-44C7-BEF3-10D33041359E}"/>
               </a:ext>
             </a:extLst>
           </p:cNvPr>
@@ -9793,7 +10201,7 @@
           <p:cNvPr id="10" name="">
             <a:extLst xmlns:a="http://schemas.openxmlformats.org/drawingml/2006/main">
               <a:ext uri="{FF2B5EF4-FFF2-40B4-BE49-F238E27FC236}">
-                <a16:creationId xmlns:a16="http://schemas.microsoft.com/office/drawing/2014/main" id="{6F9F4864-5AFE-4E24-96CA-9686F88E0C9B}"/>
+                <a16:creationId xmlns:a16="http://schemas.microsoft.com/office/drawing/2014/main" id="{1F069589-108E-412B-93E6-2D686A9FD8D9}"/>
               </a:ext>
             </a:extLst>
           </p:cNvPr>
@@ -9861,35 +10269,103 @@
           <p:cNvPr id="11" name="">
             <a:extLst xmlns:a="http://schemas.openxmlformats.org/drawingml/2006/main">
               <a:ext uri="{FF2B5EF4-FFF2-40B4-BE49-F238E27FC236}">
-                <a16:creationId xmlns:a16="http://schemas.microsoft.com/office/drawing/2014/main" id="{57E8C543-CA14-4FD0-BCAD-433B011421C8}"/>
-              </a:ext>
-            </a:extLst>
-          </p:cNvPr>
-          <p:cNvSpPr>
-            <a:spLocks xmlns:a="http://schemas.openxmlformats.org/drawingml/2006/main" noGrp="1"/>
-          </p:cNvSpPr>
-          <p:nvPr/>
-        </p:nvSpPr>
-        <p:spPr>
-          <a:xfrm xmlns:a="http://schemas.openxmlformats.org/drawingml/2006/main">
-            <a:off x="609600" y="5572125"/>
-            <a:ext cx="10953750" cy="666750"/>
-          </a:xfrm>
-          <a:prstGeom xmlns:a="http://schemas.openxmlformats.org/drawingml/2006/main" prst="rect">
-            <a:avLst/>
-          </a:prstGeom>
-          <a:noFill xmlns:a="http://schemas.openxmlformats.org/drawingml/2006/main"/>
-          <a:ln xmlns:a="http://schemas.openxmlformats.org/drawingml/2006/main" w="0">
-            <a:noFill/>
-          </a:ln>
-        </p:spPr>
-        <p:txBody>
-          <a:bodyPr xmlns:a="http://schemas.openxmlformats.org/drawingml/2006/main">
-            <a:noAutofit/>
-          </a:bodyPr>
-          <a:lstStyle xmlns:a="http://schemas.openxmlformats.org/drawingml/2006/main">
-            <a:defPPr>
-              <a:defRPr sz="1650" b="0">
+                <a16:creationId xmlns:a16="http://schemas.microsoft.com/office/drawing/2014/main" id="{D809A8E9-612F-42F2-9F00-B8B0631F7681}"/>
+              </a:ext>
+            </a:extLst>
+          </p:cNvPr>
+          <p:cNvSpPr>
+            <a:spLocks xmlns:a="http://schemas.openxmlformats.org/drawingml/2006/main" noGrp="1"/>
+          </p:cNvSpPr>
+          <p:nvPr/>
+        </p:nvSpPr>
+        <p:spPr>
+          <a:xfrm xmlns:a="http://schemas.openxmlformats.org/drawingml/2006/main">
+            <a:off x="609600" y="5286375"/>
+            <a:ext cx="10953750" cy="381000"/>
+          </a:xfrm>
+          <a:prstGeom xmlns:a="http://schemas.openxmlformats.org/drawingml/2006/main" prst="rect">
+            <a:avLst/>
+          </a:prstGeom>
+          <a:noFill xmlns:a="http://schemas.openxmlformats.org/drawingml/2006/main"/>
+          <a:ln xmlns:a="http://schemas.openxmlformats.org/drawingml/2006/main" w="0">
+            <a:noFill/>
+          </a:ln>
+        </p:spPr>
+        <p:txBody>
+          <a:bodyPr xmlns:a="http://schemas.openxmlformats.org/drawingml/2006/main">
+            <a:noAutofit/>
+          </a:bodyPr>
+          <a:lstStyle xmlns:a="http://schemas.openxmlformats.org/drawingml/2006/main">
+            <a:defPPr>
+              <a:defRPr sz="1725" b="1">
+                <a:solidFill>
+                  <a:srgbClr val="FCD34D"/>
+                </a:solidFill>
+                <a:latin typeface="Arial"/>
+                <a:ea typeface="Arial"/>
+                <a:cs typeface="Arial"/>
+              </a:defRPr>
+            </a:defPPr>
+          </a:lstStyle>
+          <a:p xmlns:a="http://schemas.openxmlformats.org/drawingml/2006/main">
+            <a:pPr>
+              <a:defRPr sz="1725" b="1">
+                <a:solidFill>
+                  <a:srgbClr val="FCD34D"/>
+                </a:solidFill>
+                <a:latin typeface="Arial"/>
+                <a:ea typeface="Arial"/>
+                <a:cs typeface="Arial"/>
+              </a:defRPr>
+            </a:pPr>
+            <a:r>
+              <a:rPr sz="1725" b="1">
+                <a:solidFill>
+                  <a:srgbClr val="FCD34D"/>
+                </a:solidFill>
+                <a:latin typeface="Arial"/>
+                <a:ea typeface="Arial"/>
+                <a:cs typeface="Arial"/>
+              </a:rPr>
+              <a:t>A mund ta ndryshojë Arta orën e udhëtimit të Dritonit?</a:t>
+            </a:r>
+          </a:p>
+        </p:txBody>
+      </p:sp>
+      <p:sp>
+        <p:nvSpPr>
+          <p:cNvPr id="12" name="">
+            <a:extLst xmlns:a="http://schemas.openxmlformats.org/drawingml/2006/main">
+              <a:ext uri="{FF2B5EF4-FFF2-40B4-BE49-F238E27FC236}">
+                <a16:creationId xmlns:a16="http://schemas.microsoft.com/office/drawing/2014/main" id="{7BB0ECF8-DFAC-4979-B133-03062FEFCB8A}"/>
+              </a:ext>
+            </a:extLst>
+          </p:cNvPr>
+          <p:cNvSpPr>
+            <a:spLocks xmlns:a="http://schemas.openxmlformats.org/drawingml/2006/main" noGrp="1"/>
+          </p:cNvSpPr>
+          <p:nvPr/>
+        </p:nvSpPr>
+        <p:spPr>
+          <a:xfrm xmlns:a="http://schemas.openxmlformats.org/drawingml/2006/main">
+            <a:off x="609600" y="5715000"/>
+            <a:ext cx="10953750" cy="619125"/>
+          </a:xfrm>
+          <a:prstGeom xmlns:a="http://schemas.openxmlformats.org/drawingml/2006/main" prst="rect">
+            <a:avLst/>
+          </a:prstGeom>
+          <a:noFill xmlns:a="http://schemas.openxmlformats.org/drawingml/2006/main"/>
+          <a:ln xmlns:a="http://schemas.openxmlformats.org/drawingml/2006/main" w="0">
+            <a:noFill/>
+          </a:ln>
+        </p:spPr>
+        <p:txBody>
+          <a:bodyPr xmlns:a="http://schemas.openxmlformats.org/drawingml/2006/main">
+            <a:noAutofit/>
+          </a:bodyPr>
+          <a:lstStyle xmlns:a="http://schemas.openxmlformats.org/drawingml/2006/main">
+            <a:defPPr>
+              <a:defRPr sz="1575" b="0">
                 <a:solidFill>
                   <a:srgbClr val="B8EDDB"/>
                 </a:solidFill>
@@ -9901,7 +10377,7 @@
           </a:lstStyle>
           <a:p xmlns:a="http://schemas.openxmlformats.org/drawingml/2006/main">
             <a:pPr>
-              <a:defRPr sz="1650" b="0">
+              <a:defRPr sz="1575" b="0">
                 <a:solidFill>
                   <a:srgbClr val="B8EDDB"/>
                 </a:solidFill>
@@ -9911,7 +10387,7 @@
               </a:defRPr>
             </a:pPr>
             <a:r>
-              <a:rPr sz="1650" b="0">
+              <a:rPr sz="1575" b="0">
                 <a:solidFill>
                   <a:srgbClr val="B8EDDB"/>
                 </a:solidFill>
@@ -9927,7 +10403,7 @@
     </p:spTree>
     <p:extLst>
       <p:ext uri="{BB962C8B-B14F-4D97-AF65-F5344CB8AC3E}">
-        <p14:creationId xmlns:p14="http://schemas.microsoft.com/office/powerpoint/2010/main" val="608739976"/>
+        <p14:creationId xmlns:p14="http://schemas.microsoft.com/office/powerpoint/2010/main" val="1900589142"/>
       </p:ext>
     </p:extLst>
   </p:cSld>
@@ -9955,10 +10431,10 @@
       </p:grpSpPr>
       <p:sp>
         <p:nvSpPr>
-          <p:cNvPr id="6" name="">
-            <a:extLst xmlns:a="http://schemas.openxmlformats.org/drawingml/2006/main">
-              <a:ext uri="{FF2B5EF4-FFF2-40B4-BE49-F238E27FC236}">
-                <a16:creationId xmlns:a16="http://schemas.microsoft.com/office/drawing/2014/main" id="{6AA2C16B-CD4E-46B3-B0BB-99D98B89F67F}"/>
+          <p:cNvPr id="7" name="">
+            <a:extLst xmlns:a="http://schemas.openxmlformats.org/drawingml/2006/main">
+              <a:ext uri="{FF2B5EF4-FFF2-40B4-BE49-F238E27FC236}">
+                <a16:creationId xmlns:a16="http://schemas.microsoft.com/office/drawing/2014/main" id="{C3D700B7-3C40-4A1E-8DDF-68668ACEDFEB}"/>
               </a:ext>
             </a:extLst>
           </p:cNvPr>
@@ -10026,7 +10502,7 @@
           <p:cNvPr id="2" name="">
             <a:extLst xmlns:a="http://schemas.openxmlformats.org/drawingml/2006/main">
               <a:ext uri="{FF2B5EF4-FFF2-40B4-BE49-F238E27FC236}">
-                <a16:creationId xmlns:a16="http://schemas.microsoft.com/office/drawing/2014/main" id="{0A56AE46-FEAE-40BC-973D-67399F200890}"/>
+                <a16:creationId xmlns:a16="http://schemas.microsoft.com/office/drawing/2014/main" id="{D6F77374-81C6-477A-9DE7-935E3DAC9DE5}"/>
               </a:ext>
             </a:extLst>
           </p:cNvPr>
@@ -10094,7 +10570,7 @@
           <p:cNvPr id="3" name="">
             <a:extLst xmlns:a="http://schemas.openxmlformats.org/drawingml/2006/main">
               <a:ext uri="{FF2B5EF4-FFF2-40B4-BE49-F238E27FC236}">
-                <a16:creationId xmlns:a16="http://schemas.microsoft.com/office/drawing/2014/main" id="{059C1CEF-9252-4696-8C2E-82860E80FF69}"/>
+                <a16:creationId xmlns:a16="http://schemas.microsoft.com/office/drawing/2014/main" id="{5B4BDABC-3103-4DF8-8674-11B5552D7BE0}"/>
               </a:ext>
             </a:extLst>
           </p:cNvPr>
@@ -10162,7 +10638,7 @@
           <p:cNvPr id="4" name="">
             <a:extLst xmlns:a="http://schemas.openxmlformats.org/drawingml/2006/main">
               <a:ext uri="{FF2B5EF4-FFF2-40B4-BE49-F238E27FC236}">
-                <a16:creationId xmlns:a16="http://schemas.microsoft.com/office/drawing/2014/main" id="{1A95F7EC-8FA5-4EB9-92F4-6AD89B4ADBD5}"/>
+                <a16:creationId xmlns:a16="http://schemas.microsoft.com/office/drawing/2014/main" id="{B39A5025-8B54-4C67-97B7-DF25C112B55C}"/>
               </a:ext>
             </a:extLst>
           </p:cNvPr>
@@ -10286,35 +10762,103 @@
           <p:cNvPr id="5" name="">
             <a:extLst xmlns:a="http://schemas.openxmlformats.org/drawingml/2006/main">
               <a:ext uri="{FF2B5EF4-FFF2-40B4-BE49-F238E27FC236}">
-                <a16:creationId xmlns:a16="http://schemas.microsoft.com/office/drawing/2014/main" id="{1E48076C-5D0F-48B3-874A-65281671A144}"/>
-              </a:ext>
-            </a:extLst>
-          </p:cNvPr>
-          <p:cNvSpPr>
-            <a:spLocks xmlns:a="http://schemas.openxmlformats.org/drawingml/2006/main" noGrp="1"/>
-          </p:cNvSpPr>
-          <p:nvPr/>
-        </p:nvSpPr>
-        <p:spPr>
-          <a:xfrm xmlns:a="http://schemas.openxmlformats.org/drawingml/2006/main">
-            <a:off x="609600" y="5572125"/>
-            <a:ext cx="10953750" cy="666750"/>
-          </a:xfrm>
-          <a:prstGeom xmlns:a="http://schemas.openxmlformats.org/drawingml/2006/main" prst="rect">
-            <a:avLst/>
-          </a:prstGeom>
-          <a:noFill xmlns:a="http://schemas.openxmlformats.org/drawingml/2006/main"/>
-          <a:ln xmlns:a="http://schemas.openxmlformats.org/drawingml/2006/main" w="0">
-            <a:noFill/>
-          </a:ln>
-        </p:spPr>
-        <p:txBody>
-          <a:bodyPr xmlns:a="http://schemas.openxmlformats.org/drawingml/2006/main">
-            <a:noAutofit/>
-          </a:bodyPr>
-          <a:lstStyle xmlns:a="http://schemas.openxmlformats.org/drawingml/2006/main">
-            <a:defPPr>
-              <a:defRPr sz="1650" b="0">
+                <a16:creationId xmlns:a16="http://schemas.microsoft.com/office/drawing/2014/main" id="{3B8E4D69-126D-4328-8B26-73633A4A017A}"/>
+              </a:ext>
+            </a:extLst>
+          </p:cNvPr>
+          <p:cNvSpPr>
+            <a:spLocks xmlns:a="http://schemas.openxmlformats.org/drawingml/2006/main" noGrp="1"/>
+          </p:cNvSpPr>
+          <p:nvPr/>
+        </p:nvSpPr>
+        <p:spPr>
+          <a:xfrm xmlns:a="http://schemas.openxmlformats.org/drawingml/2006/main">
+            <a:off x="609600" y="5286375"/>
+            <a:ext cx="10953750" cy="381000"/>
+          </a:xfrm>
+          <a:prstGeom xmlns:a="http://schemas.openxmlformats.org/drawingml/2006/main" prst="rect">
+            <a:avLst/>
+          </a:prstGeom>
+          <a:noFill xmlns:a="http://schemas.openxmlformats.org/drawingml/2006/main"/>
+          <a:ln xmlns:a="http://schemas.openxmlformats.org/drawingml/2006/main" w="0">
+            <a:noFill/>
+          </a:ln>
+        </p:spPr>
+        <p:txBody>
+          <a:bodyPr xmlns:a="http://schemas.openxmlformats.org/drawingml/2006/main">
+            <a:noAutofit/>
+          </a:bodyPr>
+          <a:lstStyle xmlns:a="http://schemas.openxmlformats.org/drawingml/2006/main">
+            <a:defPPr>
+              <a:defRPr sz="1725" b="1">
+                <a:solidFill>
+                  <a:srgbClr val="FCD34D"/>
+                </a:solidFill>
+                <a:latin typeface="Arial"/>
+                <a:ea typeface="Arial"/>
+                <a:cs typeface="Arial"/>
+              </a:defRPr>
+            </a:defPPr>
+          </a:lstStyle>
+          <a:p xmlns:a="http://schemas.openxmlformats.org/drawingml/2006/main">
+            <a:pPr>
+              <a:defRPr sz="1725" b="1">
+                <a:solidFill>
+                  <a:srgbClr val="FCD34D"/>
+                </a:solidFill>
+                <a:latin typeface="Arial"/>
+                <a:ea typeface="Arial"/>
+                <a:cs typeface="Arial"/>
+              </a:defRPr>
+            </a:pPr>
+            <a:r>
+              <a:rPr sz="1725" b="1">
+                <a:solidFill>
+                  <a:srgbClr val="FCD34D"/>
+                </a:solidFill>
+                <a:latin typeface="Arial"/>
+                <a:ea typeface="Arial"/>
+                <a:cs typeface="Arial"/>
+              </a:rPr>
+              <a:t>A të jep karta e studentit leje për të ndryshuar notat?</a:t>
+            </a:r>
+          </a:p>
+        </p:txBody>
+      </p:sp>
+      <p:sp>
+        <p:nvSpPr>
+          <p:cNvPr id="6" name="">
+            <a:extLst xmlns:a="http://schemas.openxmlformats.org/drawingml/2006/main">
+              <a:ext uri="{FF2B5EF4-FFF2-40B4-BE49-F238E27FC236}">
+                <a16:creationId xmlns:a16="http://schemas.microsoft.com/office/drawing/2014/main" id="{F921B9DB-D3C7-4A16-8AC7-CD811F88E4FC}"/>
+              </a:ext>
+            </a:extLst>
+          </p:cNvPr>
+          <p:cNvSpPr>
+            <a:spLocks xmlns:a="http://schemas.openxmlformats.org/drawingml/2006/main" noGrp="1"/>
+          </p:cNvSpPr>
+          <p:nvPr/>
+        </p:nvSpPr>
+        <p:spPr>
+          <a:xfrm xmlns:a="http://schemas.openxmlformats.org/drawingml/2006/main">
+            <a:off x="609600" y="5715000"/>
+            <a:ext cx="10953750" cy="619125"/>
+          </a:xfrm>
+          <a:prstGeom xmlns:a="http://schemas.openxmlformats.org/drawingml/2006/main" prst="rect">
+            <a:avLst/>
+          </a:prstGeom>
+          <a:noFill xmlns:a="http://schemas.openxmlformats.org/drawingml/2006/main"/>
+          <a:ln xmlns:a="http://schemas.openxmlformats.org/drawingml/2006/main" w="0">
+            <a:noFill/>
+          </a:ln>
+        </p:spPr>
+        <p:txBody>
+          <a:bodyPr xmlns:a="http://schemas.openxmlformats.org/drawingml/2006/main">
+            <a:noAutofit/>
+          </a:bodyPr>
+          <a:lstStyle xmlns:a="http://schemas.openxmlformats.org/drawingml/2006/main">
+            <a:defPPr>
+              <a:defRPr sz="1575" b="0">
                 <a:solidFill>
                   <a:srgbClr val="B8EDDB"/>
                 </a:solidFill>
@@ -10326,7 +10870,7 @@
           </a:lstStyle>
           <a:p xmlns:a="http://schemas.openxmlformats.org/drawingml/2006/main">
             <a:pPr>
-              <a:defRPr sz="1650" b="0">
+              <a:defRPr sz="1575" b="0">
                 <a:solidFill>
                   <a:srgbClr val="B8EDDB"/>
                 </a:solidFill>
@@ -10336,7 +10880,7 @@
               </a:defRPr>
             </a:pPr>
             <a:r>
-              <a:rPr sz="1650" b="0">
+              <a:rPr sz="1575" b="0">
                 <a:solidFill>
                   <a:srgbClr val="B8EDDB"/>
                 </a:solidFill>
@@ -10344,7 +10888,7 @@
                 <a:ea typeface="Arial"/>
                 <a:cs typeface="Arial"/>
               </a:rPr>
-              <a:t>Përgjigjja: Përmend një rast tjetër: klienti i lokalit mund të rezervojë, por nuk ndryshon orarin e punonjësit.</a:t>
+              <a:t>Përgjigjja: Jo. Karta identifikon studentin; ndryshimi i notave kërkon rol dhe qasje të autorizuar. Edhe klienti i lokalit mund të rezervojë, por nuk ndryshon orarin e punonjësit.</a:t>
             </a:r>
           </a:p>
         </p:txBody>
@@ -10352,7 +10896,7 @@
     </p:spTree>
     <p:extLst>
       <p:ext uri="{BB962C8B-B14F-4D97-AF65-F5344CB8AC3E}">
-        <p14:creationId xmlns:p14="http://schemas.microsoft.com/office/powerpoint/2010/main" val="1622985470"/>
+        <p14:creationId xmlns:p14="http://schemas.microsoft.com/office/powerpoint/2010/main" val="451642897"/>
       </p:ext>
     </p:extLst>
   </p:cSld>
@@ -10383,7 +10927,7 @@
           <p:cNvPr id="13" name="">
             <a:extLst xmlns:a="http://schemas.openxmlformats.org/drawingml/2006/main">
               <a:ext uri="{FF2B5EF4-FFF2-40B4-BE49-F238E27FC236}">
-                <a16:creationId xmlns:a16="http://schemas.microsoft.com/office/drawing/2014/main" id="{464E5B78-23F9-4CC8-9903-826C99AF0A31}"/>
+                <a16:creationId xmlns:a16="http://schemas.microsoft.com/office/drawing/2014/main" id="{E03285B4-4F73-455C-8F35-0A96594BDA42}"/>
               </a:ext>
             </a:extLst>
           </p:cNvPr>
@@ -10451,7 +10995,7 @@
           <p:cNvPr id="2" name="">
             <a:extLst xmlns:a="http://schemas.openxmlformats.org/drawingml/2006/main">
               <a:ext uri="{FF2B5EF4-FFF2-40B4-BE49-F238E27FC236}">
-                <a16:creationId xmlns:a16="http://schemas.microsoft.com/office/drawing/2014/main" id="{DB2966CC-111C-4673-98E5-7C0D088A6BC0}"/>
+                <a16:creationId xmlns:a16="http://schemas.microsoft.com/office/drawing/2014/main" id="{164AE2DA-0F9C-44DA-933B-FF25655B2548}"/>
               </a:ext>
             </a:extLst>
           </p:cNvPr>
@@ -10519,7 +11063,7 @@
           <p:cNvPr id="3" name="">
             <a:extLst xmlns:a="http://schemas.openxmlformats.org/drawingml/2006/main">
               <a:ext uri="{FF2B5EF4-FFF2-40B4-BE49-F238E27FC236}">
-                <a16:creationId xmlns:a16="http://schemas.microsoft.com/office/drawing/2014/main" id="{4CF0BE80-7CB2-49D7-A9E0-2487144F918F}"/>
+                <a16:creationId xmlns:a16="http://schemas.microsoft.com/office/drawing/2014/main" id="{27BE7A0A-545B-4B2C-8065-36124E056788}"/>
               </a:ext>
             </a:extLst>
           </p:cNvPr>
@@ -10587,7 +11131,7 @@
           <p:cNvPr id="4" name="">
             <a:extLst xmlns:a="http://schemas.openxmlformats.org/drawingml/2006/main">
               <a:ext uri="{FF2B5EF4-FFF2-40B4-BE49-F238E27FC236}">
-                <a16:creationId xmlns:a16="http://schemas.microsoft.com/office/drawing/2014/main" id="{925327C5-90A2-4134-A0E5-B1058BE2A84B}"/>
+                <a16:creationId xmlns:a16="http://schemas.microsoft.com/office/drawing/2014/main" id="{F813961B-A8F4-4690-A256-66961FCF1DD0}"/>
               </a:ext>
             </a:extLst>
           </p:cNvPr>
@@ -10711,7 +11255,7 @@
           <p:cNvPr id="5" name="">
             <a:extLst xmlns:a="http://schemas.openxmlformats.org/drawingml/2006/main">
               <a:ext uri="{FF2B5EF4-FFF2-40B4-BE49-F238E27FC236}">
-                <a16:creationId xmlns:a16="http://schemas.microsoft.com/office/drawing/2014/main" id="{AFFDEAB3-4757-4D42-9923-BBA2C299F1BE}"/>
+                <a16:creationId xmlns:a16="http://schemas.microsoft.com/office/drawing/2014/main" id="{658E00DE-C6DB-4386-BC59-5C132E8971F5}"/>
               </a:ext>
             </a:extLst>
           </p:cNvPr>
@@ -10779,7 +11323,7 @@
           <p:cNvPr id="6" name="">
             <a:extLst xmlns:a="http://schemas.openxmlformats.org/drawingml/2006/main">
               <a:ext uri="{FF2B5EF4-FFF2-40B4-BE49-F238E27FC236}">
-                <a16:creationId xmlns:a16="http://schemas.microsoft.com/office/drawing/2014/main" id="{43778E2C-7110-4979-AE88-29ACA67181B7}"/>
+                <a16:creationId xmlns:a16="http://schemas.microsoft.com/office/drawing/2014/main" id="{B105820C-6C1D-430F-95AD-BB4B337550F7}"/>
               </a:ext>
             </a:extLst>
           </p:cNvPr>
@@ -10847,7 +11391,7 @@
           <p:cNvPr id="7" name="">
             <a:extLst xmlns:a="http://schemas.openxmlformats.org/drawingml/2006/main">
               <a:ext uri="{FF2B5EF4-FFF2-40B4-BE49-F238E27FC236}">
-                <a16:creationId xmlns:a16="http://schemas.microsoft.com/office/drawing/2014/main" id="{D91B8759-2E15-47AB-8EB8-467BE1A16030}"/>
+                <a16:creationId xmlns:a16="http://schemas.microsoft.com/office/drawing/2014/main" id="{AD39F4AC-50D9-49B5-BFDC-30103DBC4449}"/>
               </a:ext>
             </a:extLst>
           </p:cNvPr>
@@ -10915,7 +11459,7 @@
           <p:cNvPr id="8" name="">
             <a:extLst xmlns:a="http://schemas.openxmlformats.org/drawingml/2006/main">
               <a:ext uri="{FF2B5EF4-FFF2-40B4-BE49-F238E27FC236}">
-                <a16:creationId xmlns:a16="http://schemas.microsoft.com/office/drawing/2014/main" id="{514A2D49-C3BA-424F-B782-31BF4300A75B}"/>
+                <a16:creationId xmlns:a16="http://schemas.microsoft.com/office/drawing/2014/main" id="{2B1769BF-FF0D-4D1A-8450-8B7408D50CF7}"/>
               </a:ext>
             </a:extLst>
           </p:cNvPr>
@@ -10983,7 +11527,7 @@
           <p:cNvPr id="9" name="">
             <a:extLst xmlns:a="http://schemas.openxmlformats.org/drawingml/2006/main">
               <a:ext uri="{FF2B5EF4-FFF2-40B4-BE49-F238E27FC236}">
-                <a16:creationId xmlns:a16="http://schemas.microsoft.com/office/drawing/2014/main" id="{F1F81699-7DEE-448C-BE5B-7CD6AEE0FFCE}"/>
+                <a16:creationId xmlns:a16="http://schemas.microsoft.com/office/drawing/2014/main" id="{FC605F3D-432E-4FB9-A4BC-78B04C57DAF6}"/>
               </a:ext>
             </a:extLst>
           </p:cNvPr>
@@ -11051,7 +11595,7 @@
           <p:cNvPr id="10" name="">
             <a:extLst xmlns:a="http://schemas.openxmlformats.org/drawingml/2006/main">
               <a:ext uri="{FF2B5EF4-FFF2-40B4-BE49-F238E27FC236}">
-                <a16:creationId xmlns:a16="http://schemas.microsoft.com/office/drawing/2014/main" id="{6438A56F-6574-4A9F-8B61-AF3EC0911A11}"/>
+                <a16:creationId xmlns:a16="http://schemas.microsoft.com/office/drawing/2014/main" id="{6C6BCD16-3312-4298-9367-7BB28EF73F94}"/>
               </a:ext>
             </a:extLst>
           </p:cNvPr>
@@ -11119,7 +11663,7 @@
           <p:cNvPr id="11" name="">
             <a:extLst xmlns:a="http://schemas.openxmlformats.org/drawingml/2006/main">
               <a:ext uri="{FF2B5EF4-FFF2-40B4-BE49-F238E27FC236}">
-                <a16:creationId xmlns:a16="http://schemas.microsoft.com/office/drawing/2014/main" id="{553A3B44-2B48-4F54-8303-24BF13EC68F2}"/>
+                <a16:creationId xmlns:a16="http://schemas.microsoft.com/office/drawing/2014/main" id="{43B174DC-E1D5-4B00-AF1F-73A0B3068C60}"/>
               </a:ext>
             </a:extLst>
           </p:cNvPr>
@@ -11187,7 +11731,7 @@
           <p:cNvPr id="12" name="">
             <a:extLst xmlns:a="http://schemas.openxmlformats.org/drawingml/2006/main">
               <a:ext uri="{FF2B5EF4-FFF2-40B4-BE49-F238E27FC236}">
-                <a16:creationId xmlns:a16="http://schemas.microsoft.com/office/drawing/2014/main" id="{F63B89CC-AE84-4399-B472-47AFC32CB6BB}"/>
+                <a16:creationId xmlns:a16="http://schemas.microsoft.com/office/drawing/2014/main" id="{860C8431-D933-4786-881C-A814B080FD97}"/>
               </a:ext>
             </a:extLst>
           </p:cNvPr>
@@ -11253,7 +11797,7 @@
     </p:spTree>
     <p:extLst>
       <p:ext uri="{BB962C8B-B14F-4D97-AF65-F5344CB8AC3E}">
-        <p14:creationId xmlns:p14="http://schemas.microsoft.com/office/powerpoint/2010/main" val="1487715896"/>
+        <p14:creationId xmlns:p14="http://schemas.microsoft.com/office/powerpoint/2010/main" val="911851451"/>
       </p:ext>
     </p:extLst>
   </p:cSld>
@@ -11284,7 +11828,7 @@
           <p:cNvPr id="11" name="">
             <a:extLst xmlns:a="http://schemas.openxmlformats.org/drawingml/2006/main">
               <a:ext uri="{FF2B5EF4-FFF2-40B4-BE49-F238E27FC236}">
-                <a16:creationId xmlns:a16="http://schemas.microsoft.com/office/drawing/2014/main" id="{A0E88BBF-B191-4B52-907A-8F9D50B6699F}"/>
+                <a16:creationId xmlns:a16="http://schemas.microsoft.com/office/drawing/2014/main" id="{6B04F63F-0A3D-4702-A6E4-1FF43D1BE85E}"/>
               </a:ext>
             </a:extLst>
           </p:cNvPr>
@@ -11352,7 +11896,7 @@
           <p:cNvPr id="2" name="">
             <a:extLst xmlns:a="http://schemas.openxmlformats.org/drawingml/2006/main">
               <a:ext uri="{FF2B5EF4-FFF2-40B4-BE49-F238E27FC236}">
-                <a16:creationId xmlns:a16="http://schemas.microsoft.com/office/drawing/2014/main" id="{CD05A5CE-35C0-4ED0-9E71-26601FBAD0B3}"/>
+                <a16:creationId xmlns:a16="http://schemas.microsoft.com/office/drawing/2014/main" id="{87F5801E-3A95-48E0-B97E-522504D9BE9A}"/>
               </a:ext>
             </a:extLst>
           </p:cNvPr>
@@ -11420,7 +11964,7 @@
           <p:cNvPr id="3" name="">
             <a:extLst xmlns:a="http://schemas.openxmlformats.org/drawingml/2006/main">
               <a:ext uri="{FF2B5EF4-FFF2-40B4-BE49-F238E27FC236}">
-                <a16:creationId xmlns:a16="http://schemas.microsoft.com/office/drawing/2014/main" id="{6B077FF5-CEDA-46D5-AFDA-55391791A1F3}"/>
+                <a16:creationId xmlns:a16="http://schemas.microsoft.com/office/drawing/2014/main" id="{20940871-C08B-4DB8-8462-198B150B3987}"/>
               </a:ext>
             </a:extLst>
           </p:cNvPr>
@@ -11488,7 +12032,7 @@
           <p:cNvPr id="4" name="">
             <a:extLst xmlns:a="http://schemas.openxmlformats.org/drawingml/2006/main">
               <a:ext uri="{FF2B5EF4-FFF2-40B4-BE49-F238E27FC236}">
-                <a16:creationId xmlns:a16="http://schemas.microsoft.com/office/drawing/2014/main" id="{6304F3CC-EBDE-4BAA-BBBA-425422F9AF24}"/>
+                <a16:creationId xmlns:a16="http://schemas.microsoft.com/office/drawing/2014/main" id="{B3D55597-5C60-4E4B-A942-702018F90727}"/>
               </a:ext>
             </a:extLst>
           </p:cNvPr>
@@ -11612,7 +12156,7 @@
           <p:cNvPr id="5" name="">
             <a:extLst xmlns:a="http://schemas.openxmlformats.org/drawingml/2006/main">
               <a:ext uri="{FF2B5EF4-FFF2-40B4-BE49-F238E27FC236}">
-                <a16:creationId xmlns:a16="http://schemas.microsoft.com/office/drawing/2014/main" id="{65FB9739-971C-4B07-82F0-18097C2F95BA}"/>
+                <a16:creationId xmlns:a16="http://schemas.microsoft.com/office/drawing/2014/main" id="{58941074-64DC-4900-82BF-645FA99269BB}"/>
               </a:ext>
             </a:extLst>
           </p:cNvPr>
@@ -11680,7 +12224,7 @@
           <p:cNvPr id="6" name="">
             <a:extLst xmlns:a="http://schemas.openxmlformats.org/drawingml/2006/main">
               <a:ext uri="{FF2B5EF4-FFF2-40B4-BE49-F238E27FC236}">
-                <a16:creationId xmlns:a16="http://schemas.microsoft.com/office/drawing/2014/main" id="{EDAB745F-0776-4C11-AE6F-EE0D9DA2F4CB}"/>
+                <a16:creationId xmlns:a16="http://schemas.microsoft.com/office/drawing/2014/main" id="{AF08193F-B8F1-4668-B71D-380384664B5A}"/>
               </a:ext>
             </a:extLst>
           </p:cNvPr>
@@ -11748,7 +12292,7 @@
           <p:cNvPr id="7" name="">
             <a:extLst xmlns:a="http://schemas.openxmlformats.org/drawingml/2006/main">
               <a:ext uri="{FF2B5EF4-FFF2-40B4-BE49-F238E27FC236}">
-                <a16:creationId xmlns:a16="http://schemas.microsoft.com/office/drawing/2014/main" id="{11A53928-33C6-4034-9B3B-6604E525704E}"/>
+                <a16:creationId xmlns:a16="http://schemas.microsoft.com/office/drawing/2014/main" id="{93760067-5B32-4C1A-9A66-332AFD53BE36}"/>
               </a:ext>
             </a:extLst>
           </p:cNvPr>
@@ -11816,7 +12360,7 @@
           <p:cNvPr id="8" name="">
             <a:extLst xmlns:a="http://schemas.openxmlformats.org/drawingml/2006/main">
               <a:ext uri="{FF2B5EF4-FFF2-40B4-BE49-F238E27FC236}">
-                <a16:creationId xmlns:a16="http://schemas.microsoft.com/office/drawing/2014/main" id="{07EBF126-CDE1-414D-866F-3EC30EFEEA0D}"/>
+                <a16:creationId xmlns:a16="http://schemas.microsoft.com/office/drawing/2014/main" id="{8358BBE5-8562-4906-99CF-3848EA29C73B}"/>
               </a:ext>
             </a:extLst>
           </p:cNvPr>
@@ -11884,7 +12428,7 @@
           <p:cNvPr id="9" name="">
             <a:extLst xmlns:a="http://schemas.openxmlformats.org/drawingml/2006/main">
               <a:ext uri="{FF2B5EF4-FFF2-40B4-BE49-F238E27FC236}">
-                <a16:creationId xmlns:a16="http://schemas.microsoft.com/office/drawing/2014/main" id="{B7219243-CCBC-48B8-89C7-0C40E67EBB78}"/>
+                <a16:creationId xmlns:a16="http://schemas.microsoft.com/office/drawing/2014/main" id="{CF487A86-94DD-44BD-A279-2A8528A3631F}"/>
               </a:ext>
             </a:extLst>
           </p:cNvPr>
@@ -11952,7 +12496,7 @@
           <p:cNvPr id="10" name="">
             <a:extLst xmlns:a="http://schemas.openxmlformats.org/drawingml/2006/main">
               <a:ext uri="{FF2B5EF4-FFF2-40B4-BE49-F238E27FC236}">
-                <a16:creationId xmlns:a16="http://schemas.microsoft.com/office/drawing/2014/main" id="{7B97AE49-7239-4AC2-8124-0A31B9EA42AB}"/>
+                <a16:creationId xmlns:a16="http://schemas.microsoft.com/office/drawing/2014/main" id="{543A6DB2-A57C-41E1-A6A6-E37DBFC0E741}"/>
               </a:ext>
             </a:extLst>
           </p:cNvPr>
@@ -12018,7 +12562,7 @@
     </p:spTree>
     <p:extLst>
       <p:ext uri="{BB962C8B-B14F-4D97-AF65-F5344CB8AC3E}">
-        <p14:creationId xmlns:p14="http://schemas.microsoft.com/office/powerpoint/2010/main" val="7192432"/>
+        <p14:creationId xmlns:p14="http://schemas.microsoft.com/office/powerpoint/2010/main" val="1946282416"/>
       </p:ext>
     </p:extLst>
   </p:cSld>
@@ -12046,10 +12590,10 @@
       </p:grpSpPr>
       <p:sp>
         <p:nvSpPr>
-          <p:cNvPr id="10" name="">
-            <a:extLst xmlns:a="http://schemas.openxmlformats.org/drawingml/2006/main">
-              <a:ext uri="{FF2B5EF4-FFF2-40B4-BE49-F238E27FC236}">
-                <a16:creationId xmlns:a16="http://schemas.microsoft.com/office/drawing/2014/main" id="{B5D651CC-009C-4686-889B-0B2115750FA5}"/>
+          <p:cNvPr id="11" name="">
+            <a:extLst xmlns:a="http://schemas.openxmlformats.org/drawingml/2006/main">
+              <a:ext uri="{FF2B5EF4-FFF2-40B4-BE49-F238E27FC236}">
+                <a16:creationId xmlns:a16="http://schemas.microsoft.com/office/drawing/2014/main" id="{0BD4B190-FB72-4E30-955B-A606B6367CB5}"/>
               </a:ext>
             </a:extLst>
           </p:cNvPr>
@@ -12117,7 +12661,7 @@
           <p:cNvPr id="2" name="">
             <a:extLst xmlns:a="http://schemas.openxmlformats.org/drawingml/2006/main">
               <a:ext uri="{FF2B5EF4-FFF2-40B4-BE49-F238E27FC236}">
-                <a16:creationId xmlns:a16="http://schemas.microsoft.com/office/drawing/2014/main" id="{A2CC48AA-81E2-4A18-97F7-674C9F575F80}"/>
+                <a16:creationId xmlns:a16="http://schemas.microsoft.com/office/drawing/2014/main" id="{95B5B3EE-49B0-4C91-B649-66AAFF3B5561}"/>
               </a:ext>
             </a:extLst>
           </p:cNvPr>
@@ -12185,7 +12729,7 @@
           <p:cNvPr id="3" name="">
             <a:extLst xmlns:a="http://schemas.openxmlformats.org/drawingml/2006/main">
               <a:ext uri="{FF2B5EF4-FFF2-40B4-BE49-F238E27FC236}">
-                <a16:creationId xmlns:a16="http://schemas.microsoft.com/office/drawing/2014/main" id="{FD95F043-54B6-4980-866C-1E84B3C9387C}"/>
+                <a16:creationId xmlns:a16="http://schemas.microsoft.com/office/drawing/2014/main" id="{2CA46D3F-310A-4CCC-A7F4-DCCBCD13663E}"/>
               </a:ext>
             </a:extLst>
           </p:cNvPr>
@@ -12253,7 +12797,7 @@
           <p:cNvPr id="4" name="">
             <a:extLst xmlns:a="http://schemas.openxmlformats.org/drawingml/2006/main">
               <a:ext uri="{FF2B5EF4-FFF2-40B4-BE49-F238E27FC236}">
-                <a16:creationId xmlns:a16="http://schemas.microsoft.com/office/drawing/2014/main" id="{2DC30D11-D18B-4579-A9B0-4D793F3ADE22}"/>
+                <a16:creationId xmlns:a16="http://schemas.microsoft.com/office/drawing/2014/main" id="{AD796E40-EC24-4EF8-9000-81EF647928A0}"/>
               </a:ext>
             </a:extLst>
           </p:cNvPr>
@@ -12377,7 +12921,7 @@
           <p:cNvPr id="5" name="">
             <a:extLst xmlns:a="http://schemas.openxmlformats.org/drawingml/2006/main">
               <a:ext uri="{FF2B5EF4-FFF2-40B4-BE49-F238E27FC236}">
-                <a16:creationId xmlns:a16="http://schemas.microsoft.com/office/drawing/2014/main" id="{A1D9768C-0925-4841-AB82-D06D5AFC5992}"/>
+                <a16:creationId xmlns:a16="http://schemas.microsoft.com/office/drawing/2014/main" id="{77CB0166-F25B-4833-BD6E-BDE6FC431ADF}"/>
               </a:ext>
             </a:extLst>
           </p:cNvPr>
@@ -12445,7 +12989,7 @@
           <p:cNvPr id="6" name="">
             <a:extLst xmlns:a="http://schemas.openxmlformats.org/drawingml/2006/main">
               <a:ext uri="{FF2B5EF4-FFF2-40B4-BE49-F238E27FC236}">
-                <a16:creationId xmlns:a16="http://schemas.microsoft.com/office/drawing/2014/main" id="{0A7ECFBF-7F81-49F6-BDF8-1296F7DE761A}"/>
+                <a16:creationId xmlns:a16="http://schemas.microsoft.com/office/drawing/2014/main" id="{F10183B8-4706-4FF6-92B3-553E4B0C987B}"/>
               </a:ext>
             </a:extLst>
           </p:cNvPr>
@@ -12513,7 +13057,7 @@
           <p:cNvPr id="7" name="">
             <a:extLst xmlns:a="http://schemas.openxmlformats.org/drawingml/2006/main">
               <a:ext uri="{FF2B5EF4-FFF2-40B4-BE49-F238E27FC236}">
-                <a16:creationId xmlns:a16="http://schemas.microsoft.com/office/drawing/2014/main" id="{BCEA9A18-C165-40F3-9C66-A51EE5A2FC49}"/>
+                <a16:creationId xmlns:a16="http://schemas.microsoft.com/office/drawing/2014/main" id="{C8B99924-659F-4338-BD85-6FEFD3D48566}"/>
               </a:ext>
             </a:extLst>
           </p:cNvPr>
@@ -12581,7 +13125,7 @@
           <p:cNvPr id="8" name="">
             <a:extLst xmlns:a="http://schemas.openxmlformats.org/drawingml/2006/main">
               <a:ext uri="{FF2B5EF4-FFF2-40B4-BE49-F238E27FC236}">
-                <a16:creationId xmlns:a16="http://schemas.microsoft.com/office/drawing/2014/main" id="{3A3089F6-348E-428B-A7DD-421D94AF0CB1}"/>
+                <a16:creationId xmlns:a16="http://schemas.microsoft.com/office/drawing/2014/main" id="{EC291AEE-63BF-4E6E-9926-101ECA23F004}"/>
               </a:ext>
             </a:extLst>
           </p:cNvPr>
@@ -12649,35 +13193,103 @@
           <p:cNvPr id="9" name="">
             <a:extLst xmlns:a="http://schemas.openxmlformats.org/drawingml/2006/main">
               <a:ext uri="{FF2B5EF4-FFF2-40B4-BE49-F238E27FC236}">
-                <a16:creationId xmlns:a16="http://schemas.microsoft.com/office/drawing/2014/main" id="{D0F637DF-CE03-4D32-84E7-8A8897AE10A1}"/>
-              </a:ext>
-            </a:extLst>
-          </p:cNvPr>
-          <p:cNvSpPr>
-            <a:spLocks xmlns:a="http://schemas.openxmlformats.org/drawingml/2006/main" noGrp="1"/>
-          </p:cNvSpPr>
-          <p:nvPr/>
-        </p:nvSpPr>
-        <p:spPr>
-          <a:xfrm xmlns:a="http://schemas.openxmlformats.org/drawingml/2006/main">
-            <a:off x="609600" y="5572125"/>
-            <a:ext cx="10953750" cy="666750"/>
-          </a:xfrm>
-          <a:prstGeom xmlns:a="http://schemas.openxmlformats.org/drawingml/2006/main" prst="rect">
-            <a:avLst/>
-          </a:prstGeom>
-          <a:noFill xmlns:a="http://schemas.openxmlformats.org/drawingml/2006/main"/>
-          <a:ln xmlns:a="http://schemas.openxmlformats.org/drawingml/2006/main" w="0">
-            <a:noFill/>
-          </a:ln>
-        </p:spPr>
-        <p:txBody>
-          <a:bodyPr xmlns:a="http://schemas.openxmlformats.org/drawingml/2006/main">
-            <a:noAutofit/>
-          </a:bodyPr>
-          <a:lstStyle xmlns:a="http://schemas.openxmlformats.org/drawingml/2006/main">
-            <a:defPPr>
-              <a:defRPr sz="1650" b="0">
+                <a16:creationId xmlns:a16="http://schemas.microsoft.com/office/drawing/2014/main" id="{EE8F7976-BD8B-4828-8CA7-F9680C9ABFDE}"/>
+              </a:ext>
+            </a:extLst>
+          </p:cNvPr>
+          <p:cNvSpPr>
+            <a:spLocks xmlns:a="http://schemas.openxmlformats.org/drawingml/2006/main" noGrp="1"/>
+          </p:cNvSpPr>
+          <p:nvPr/>
+        </p:nvSpPr>
+        <p:spPr>
+          <a:xfrm xmlns:a="http://schemas.openxmlformats.org/drawingml/2006/main">
+            <a:off x="609600" y="5286375"/>
+            <a:ext cx="10953750" cy="381000"/>
+          </a:xfrm>
+          <a:prstGeom xmlns:a="http://schemas.openxmlformats.org/drawingml/2006/main" prst="rect">
+            <a:avLst/>
+          </a:prstGeom>
+          <a:noFill xmlns:a="http://schemas.openxmlformats.org/drawingml/2006/main"/>
+          <a:ln xmlns:a="http://schemas.openxmlformats.org/drawingml/2006/main" w="0">
+            <a:noFill/>
+          </a:ln>
+        </p:spPr>
+        <p:txBody>
+          <a:bodyPr xmlns:a="http://schemas.openxmlformats.org/drawingml/2006/main">
+            <a:noAutofit/>
+          </a:bodyPr>
+          <a:lstStyle xmlns:a="http://schemas.openxmlformats.org/drawingml/2006/main">
+            <a:defPPr>
+              <a:defRPr sz="1725" b="1">
+                <a:solidFill>
+                  <a:srgbClr val="FCD34D"/>
+                </a:solidFill>
+                <a:latin typeface="Arial"/>
+                <a:ea typeface="Arial"/>
+                <a:cs typeface="Arial"/>
+              </a:defRPr>
+            </a:defPPr>
+          </a:lstStyle>
+          <a:p xmlns:a="http://schemas.openxmlformats.org/drawingml/2006/main">
+            <a:pPr>
+              <a:defRPr sz="1725" b="1">
+                <a:solidFill>
+                  <a:srgbClr val="FCD34D"/>
+                </a:solidFill>
+                <a:latin typeface="Arial"/>
+                <a:ea typeface="Arial"/>
+                <a:cs typeface="Arial"/>
+              </a:defRPr>
+            </a:pPr>
+            <a:r>
+              <a:rPr sz="1725" b="1">
+                <a:solidFill>
+                  <a:srgbClr val="FCD34D"/>
+                </a:solidFill>
+                <a:latin typeface="Arial"/>
+                <a:ea typeface="Arial"/>
+                <a:cs typeface="Arial"/>
+              </a:rPr>
+              <a:t>Çfarë ndodh nëse Arta dërgon role=shofer nga shfletuesi?</a:t>
+            </a:r>
+          </a:p>
+        </p:txBody>
+      </p:sp>
+      <p:sp>
+        <p:nvSpPr>
+          <p:cNvPr id="10" name="">
+            <a:extLst xmlns:a="http://schemas.openxmlformats.org/drawingml/2006/main">
+              <a:ext uri="{FF2B5EF4-FFF2-40B4-BE49-F238E27FC236}">
+                <a16:creationId xmlns:a16="http://schemas.microsoft.com/office/drawing/2014/main" id="{4218B73A-EDAC-4623-AE6B-B0A1046A7AB5}"/>
+              </a:ext>
+            </a:extLst>
+          </p:cNvPr>
+          <p:cNvSpPr>
+            <a:spLocks xmlns:a="http://schemas.openxmlformats.org/drawingml/2006/main" noGrp="1"/>
+          </p:cNvSpPr>
+          <p:nvPr/>
+        </p:nvSpPr>
+        <p:spPr>
+          <a:xfrm xmlns:a="http://schemas.openxmlformats.org/drawingml/2006/main">
+            <a:off x="609600" y="5715000"/>
+            <a:ext cx="10953750" cy="619125"/>
+          </a:xfrm>
+          <a:prstGeom xmlns:a="http://schemas.openxmlformats.org/drawingml/2006/main" prst="rect">
+            <a:avLst/>
+          </a:prstGeom>
+          <a:noFill xmlns:a="http://schemas.openxmlformats.org/drawingml/2006/main"/>
+          <a:ln xmlns:a="http://schemas.openxmlformats.org/drawingml/2006/main" w="0">
+            <a:noFill/>
+          </a:ln>
+        </p:spPr>
+        <p:txBody>
+          <a:bodyPr xmlns:a="http://schemas.openxmlformats.org/drawingml/2006/main">
+            <a:noAutofit/>
+          </a:bodyPr>
+          <a:lstStyle xmlns:a="http://schemas.openxmlformats.org/drawingml/2006/main">
+            <a:defPPr>
+              <a:defRPr sz="1575" b="0">
                 <a:solidFill>
                   <a:srgbClr val="B8EDDB"/>
                 </a:solidFill>
@@ -12689,7 +13301,7 @@
           </a:lstStyle>
           <a:p xmlns:a="http://schemas.openxmlformats.org/drawingml/2006/main">
             <a:pPr>
-              <a:defRPr sz="1650" b="0">
+              <a:defRPr sz="1575" b="0">
                 <a:solidFill>
                   <a:srgbClr val="B8EDDB"/>
                 </a:solidFill>
@@ -12699,7 +13311,7 @@
               </a:defRPr>
             </a:pPr>
             <a:r>
-              <a:rPr sz="1650" b="0">
+              <a:rPr sz="1575" b="0">
                 <a:solidFill>
                   <a:srgbClr val="B8EDDB"/>
                 </a:solidFill>
@@ -12715,7 +13327,7 @@
     </p:spTree>
     <p:extLst>
       <p:ext uri="{BB962C8B-B14F-4D97-AF65-F5344CB8AC3E}">
-        <p14:creationId xmlns:p14="http://schemas.microsoft.com/office/powerpoint/2010/main" val="1637995377"/>
+        <p14:creationId xmlns:p14="http://schemas.microsoft.com/office/powerpoint/2010/main" val="55828098"/>
       </p:ext>
     </p:extLst>
   </p:cSld>
@@ -12743,10 +13355,10 @@
       </p:grpSpPr>
       <p:sp>
         <p:nvSpPr>
-          <p:cNvPr id="7" name="">
-            <a:extLst xmlns:a="http://schemas.openxmlformats.org/drawingml/2006/main">
-              <a:ext uri="{FF2B5EF4-FFF2-40B4-BE49-F238E27FC236}">
-                <a16:creationId xmlns:a16="http://schemas.microsoft.com/office/drawing/2014/main" id="{EEE84C6C-B5FF-4EE8-AE0C-BDDAC1B6A527}"/>
+          <p:cNvPr id="8" name="">
+            <a:extLst xmlns:a="http://schemas.openxmlformats.org/drawingml/2006/main">
+              <a:ext uri="{FF2B5EF4-FFF2-40B4-BE49-F238E27FC236}">
+                <a16:creationId xmlns:a16="http://schemas.microsoft.com/office/drawing/2014/main" id="{CFF01A86-99A0-4C34-B4D9-0FAF4919F305}"/>
               </a:ext>
             </a:extLst>
           </p:cNvPr>
@@ -12814,7 +13426,7 @@
           <p:cNvPr id="2" name="">
             <a:extLst xmlns:a="http://schemas.openxmlformats.org/drawingml/2006/main">
               <a:ext uri="{FF2B5EF4-FFF2-40B4-BE49-F238E27FC236}">
-                <a16:creationId xmlns:a16="http://schemas.microsoft.com/office/drawing/2014/main" id="{6889A806-52DF-437D-876F-58CAA81BA8A3}"/>
+                <a16:creationId xmlns:a16="http://schemas.microsoft.com/office/drawing/2014/main" id="{E5DAD482-3D80-4BD8-A9A0-D9C6478C4BA0}"/>
               </a:ext>
             </a:extLst>
           </p:cNvPr>
@@ -12882,7 +13494,7 @@
           <p:cNvPr id="3" name="">
             <a:extLst xmlns:a="http://schemas.openxmlformats.org/drawingml/2006/main">
               <a:ext uri="{FF2B5EF4-FFF2-40B4-BE49-F238E27FC236}">
-                <a16:creationId xmlns:a16="http://schemas.microsoft.com/office/drawing/2014/main" id="{54B307D7-F3F9-4000-8C16-BBE6CF7CEC58}"/>
+                <a16:creationId xmlns:a16="http://schemas.microsoft.com/office/drawing/2014/main" id="{810796AB-632B-450B-937B-DB1A867D7962}"/>
               </a:ext>
             </a:extLst>
           </p:cNvPr>
@@ -12950,7 +13562,7 @@
           <p:cNvPr id="4" name="">
             <a:extLst xmlns:a="http://schemas.openxmlformats.org/drawingml/2006/main">
               <a:ext uri="{FF2B5EF4-FFF2-40B4-BE49-F238E27FC236}">
-                <a16:creationId xmlns:a16="http://schemas.microsoft.com/office/drawing/2014/main" id="{E63E9805-9275-4459-87B1-EC097FE0966C}"/>
+                <a16:creationId xmlns:a16="http://schemas.microsoft.com/office/drawing/2014/main" id="{4CB7ACCC-7282-410A-9157-D758ACAA4F9C}"/>
               </a:ext>
             </a:extLst>
           </p:cNvPr>
@@ -13372,7 +13984,7 @@
           <p:cNvPr id="5" name="">
             <a:extLst xmlns:a="http://schemas.openxmlformats.org/drawingml/2006/main">
               <a:ext uri="{FF2B5EF4-FFF2-40B4-BE49-F238E27FC236}">
-                <a16:creationId xmlns:a16="http://schemas.microsoft.com/office/drawing/2014/main" id="{01CA4B66-3CE4-48D2-AEF4-2041C93A1BD7}"/>
+                <a16:creationId xmlns:a16="http://schemas.microsoft.com/office/drawing/2014/main" id="{D8C27B26-9541-4419-88B4-B5003056DEC5}"/>
               </a:ext>
             </a:extLst>
           </p:cNvPr>
@@ -13440,35 +14052,103 @@
           <p:cNvPr id="6" name="">
             <a:extLst xmlns:a="http://schemas.openxmlformats.org/drawingml/2006/main">
               <a:ext uri="{FF2B5EF4-FFF2-40B4-BE49-F238E27FC236}">
-                <a16:creationId xmlns:a16="http://schemas.microsoft.com/office/drawing/2014/main" id="{4236ABDE-7D5C-48A5-A8D3-160EFBD41370}"/>
-              </a:ext>
-            </a:extLst>
-          </p:cNvPr>
-          <p:cNvSpPr>
-            <a:spLocks xmlns:a="http://schemas.openxmlformats.org/drawingml/2006/main" noGrp="1"/>
-          </p:cNvSpPr>
-          <p:nvPr/>
-        </p:nvSpPr>
-        <p:spPr>
-          <a:xfrm xmlns:a="http://schemas.openxmlformats.org/drawingml/2006/main">
-            <a:off x="609600" y="5572125"/>
-            <a:ext cx="10953750" cy="666750"/>
-          </a:xfrm>
-          <a:prstGeom xmlns:a="http://schemas.openxmlformats.org/drawingml/2006/main" prst="rect">
-            <a:avLst/>
-          </a:prstGeom>
-          <a:noFill xmlns:a="http://schemas.openxmlformats.org/drawingml/2006/main"/>
-          <a:ln xmlns:a="http://schemas.openxmlformats.org/drawingml/2006/main" w="0">
-            <a:noFill/>
-          </a:ln>
-        </p:spPr>
-        <p:txBody>
-          <a:bodyPr xmlns:a="http://schemas.openxmlformats.org/drawingml/2006/main">
-            <a:noAutofit/>
-          </a:bodyPr>
-          <a:lstStyle xmlns:a="http://schemas.openxmlformats.org/drawingml/2006/main">
-            <a:defPPr>
-              <a:defRPr sz="1650" b="0">
+                <a16:creationId xmlns:a16="http://schemas.microsoft.com/office/drawing/2014/main" id="{A72018F3-ECD5-48EC-8D58-D3B13465282B}"/>
+              </a:ext>
+            </a:extLst>
+          </p:cNvPr>
+          <p:cNvSpPr>
+            <a:spLocks xmlns:a="http://schemas.openxmlformats.org/drawingml/2006/main" noGrp="1"/>
+          </p:cNvSpPr>
+          <p:nvPr/>
+        </p:nvSpPr>
+        <p:spPr>
+          <a:xfrm xmlns:a="http://schemas.openxmlformats.org/drawingml/2006/main">
+            <a:off x="609600" y="5286375"/>
+            <a:ext cx="10953750" cy="381000"/>
+          </a:xfrm>
+          <a:prstGeom xmlns:a="http://schemas.openxmlformats.org/drawingml/2006/main" prst="rect">
+            <a:avLst/>
+          </a:prstGeom>
+          <a:noFill xmlns:a="http://schemas.openxmlformats.org/drawingml/2006/main"/>
+          <a:ln xmlns:a="http://schemas.openxmlformats.org/drawingml/2006/main" w="0">
+            <a:noFill/>
+          </a:ln>
+        </p:spPr>
+        <p:txBody>
+          <a:bodyPr xmlns:a="http://schemas.openxmlformats.org/drawingml/2006/main">
+            <a:noAutofit/>
+          </a:bodyPr>
+          <a:lstStyle xmlns:a="http://schemas.openxmlformats.org/drawingml/2006/main">
+            <a:defPPr>
+              <a:defRPr sz="1725" b="1">
+                <a:solidFill>
+                  <a:srgbClr val="FCD34D"/>
+                </a:solidFill>
+                <a:latin typeface="Arial"/>
+                <a:ea typeface="Arial"/>
+                <a:cs typeface="Arial"/>
+              </a:defRPr>
+            </a:defPPr>
+          </a:lstStyle>
+          <a:p xmlns:a="http://schemas.openxmlformats.org/drawingml/2006/main">
+            <a:pPr>
+              <a:defRPr sz="1725" b="1">
+                <a:solidFill>
+                  <a:srgbClr val="FCD34D"/>
+                </a:solidFill>
+                <a:latin typeface="Arial"/>
+                <a:ea typeface="Arial"/>
+                <a:cs typeface="Arial"/>
+              </a:defRPr>
+            </a:pPr>
+            <a:r>
+              <a:rPr sz="1725" b="1">
+                <a:solidFill>
+                  <a:srgbClr val="FCD34D"/>
+                </a:solidFill>
+                <a:latin typeface="Arial"/>
+                <a:ea typeface="Arial"/>
+                <a:cs typeface="Arial"/>
+              </a:rPr>
+              <a:t>A mund ta ndryshojë Dritoni udhëtimin e një shoferi tjetër?</a:t>
+            </a:r>
+          </a:p>
+        </p:txBody>
+      </p:sp>
+      <p:sp>
+        <p:nvSpPr>
+          <p:cNvPr id="7" name="">
+            <a:extLst xmlns:a="http://schemas.openxmlformats.org/drawingml/2006/main">
+              <a:ext uri="{FF2B5EF4-FFF2-40B4-BE49-F238E27FC236}">
+                <a16:creationId xmlns:a16="http://schemas.microsoft.com/office/drawing/2014/main" id="{0D218553-E35D-4437-99D5-D63186CF727C}"/>
+              </a:ext>
+            </a:extLst>
+          </p:cNvPr>
+          <p:cNvSpPr>
+            <a:spLocks xmlns:a="http://schemas.openxmlformats.org/drawingml/2006/main" noGrp="1"/>
+          </p:cNvSpPr>
+          <p:nvPr/>
+        </p:nvSpPr>
+        <p:spPr>
+          <a:xfrm xmlns:a="http://schemas.openxmlformats.org/drawingml/2006/main">
+            <a:off x="609600" y="5715000"/>
+            <a:ext cx="10953750" cy="619125"/>
+          </a:xfrm>
+          <a:prstGeom xmlns:a="http://schemas.openxmlformats.org/drawingml/2006/main" prst="rect">
+            <a:avLst/>
+          </a:prstGeom>
+          <a:noFill xmlns:a="http://schemas.openxmlformats.org/drawingml/2006/main"/>
+          <a:ln xmlns:a="http://schemas.openxmlformats.org/drawingml/2006/main" w="0">
+            <a:noFill/>
+          </a:ln>
+        </p:spPr>
+        <p:txBody>
+          <a:bodyPr xmlns:a="http://schemas.openxmlformats.org/drawingml/2006/main">
+            <a:noAutofit/>
+          </a:bodyPr>
+          <a:lstStyle xmlns:a="http://schemas.openxmlformats.org/drawingml/2006/main">
+            <a:defPPr>
+              <a:defRPr sz="1575" b="0">
                 <a:solidFill>
                   <a:srgbClr val="B8EDDB"/>
                 </a:solidFill>
@@ -13480,7 +14160,7 @@
           </a:lstStyle>
           <a:p xmlns:a="http://schemas.openxmlformats.org/drawingml/2006/main">
             <a:pPr>
-              <a:defRPr sz="1650" b="0">
+              <a:defRPr sz="1575" b="0">
                 <a:solidFill>
                   <a:srgbClr val="B8EDDB"/>
                 </a:solidFill>
@@ -13490,7 +14170,7 @@
               </a:defRPr>
             </a:pPr>
             <a:r>
-              <a:rPr sz="1650" b="0">
+              <a:rPr sz="1575" b="0">
                 <a:solidFill>
                   <a:srgbClr val="B8EDDB"/>
                 </a:solidFill>
@@ -13506,7 +14186,7 @@
     </p:spTree>
     <p:extLst>
       <p:ext uri="{BB962C8B-B14F-4D97-AF65-F5344CB8AC3E}">
-        <p14:creationId xmlns:p14="http://schemas.microsoft.com/office/powerpoint/2010/main" val="1578201214"/>
+        <p14:creationId xmlns:p14="http://schemas.microsoft.com/office/powerpoint/2010/main" val="2105490963"/>
       </p:ext>
     </p:extLst>
   </p:cSld>
@@ -13534,10 +14214,10 @@
       </p:grpSpPr>
       <p:sp>
         <p:nvSpPr>
-          <p:cNvPr id="14" name="">
-            <a:extLst xmlns:a="http://schemas.openxmlformats.org/drawingml/2006/main">
-              <a:ext uri="{FF2B5EF4-FFF2-40B4-BE49-F238E27FC236}">
-                <a16:creationId xmlns:a16="http://schemas.microsoft.com/office/drawing/2014/main" id="{1DA067FB-1C16-4EC9-ACCE-2DC93B98BF87}"/>
+          <p:cNvPr id="15" name="">
+            <a:extLst xmlns:a="http://schemas.openxmlformats.org/drawingml/2006/main">
+              <a:ext uri="{FF2B5EF4-FFF2-40B4-BE49-F238E27FC236}">
+                <a16:creationId xmlns:a16="http://schemas.microsoft.com/office/drawing/2014/main" id="{CF89DEC0-7937-407F-B911-B52CEF368F1F}"/>
               </a:ext>
             </a:extLst>
           </p:cNvPr>
@@ -13605,7 +14285,7 @@
           <p:cNvPr id="2" name="">
             <a:extLst xmlns:a="http://schemas.openxmlformats.org/drawingml/2006/main">
               <a:ext uri="{FF2B5EF4-FFF2-40B4-BE49-F238E27FC236}">
-                <a16:creationId xmlns:a16="http://schemas.microsoft.com/office/drawing/2014/main" id="{F3831372-8268-47AD-B77E-3EF7296FEAE5}"/>
+                <a16:creationId xmlns:a16="http://schemas.microsoft.com/office/drawing/2014/main" id="{3F65AD67-B220-414C-A83C-9642F53F293D}"/>
               </a:ext>
             </a:extLst>
           </p:cNvPr>
@@ -13673,7 +14353,7 @@
           <p:cNvPr id="3" name="">
             <a:extLst xmlns:a="http://schemas.openxmlformats.org/drawingml/2006/main">
               <a:ext uri="{FF2B5EF4-FFF2-40B4-BE49-F238E27FC236}">
-                <a16:creationId xmlns:a16="http://schemas.microsoft.com/office/drawing/2014/main" id="{6E692CC6-E355-4E18-9795-53F9593303E1}"/>
+                <a16:creationId xmlns:a16="http://schemas.microsoft.com/office/drawing/2014/main" id="{B29D4D06-03D8-49B8-AFB8-5CB3A28E2687}"/>
               </a:ext>
             </a:extLst>
           </p:cNvPr>
@@ -13741,7 +14421,7 @@
           <p:cNvPr id="4" name="">
             <a:extLst xmlns:a="http://schemas.openxmlformats.org/drawingml/2006/main">
               <a:ext uri="{FF2B5EF4-FFF2-40B4-BE49-F238E27FC236}">
-                <a16:creationId xmlns:a16="http://schemas.microsoft.com/office/drawing/2014/main" id="{40DA9886-ECCC-45FA-80F0-666AF62AF26E}"/>
+                <a16:creationId xmlns:a16="http://schemas.microsoft.com/office/drawing/2014/main" id="{A1A3B3D5-78A7-484F-B04C-865C19F4825A}"/>
               </a:ext>
             </a:extLst>
           </p:cNvPr>
@@ -13809,7 +14489,7 @@
           <p:cNvPr id="5" name="">
             <a:extLst xmlns:a="http://schemas.openxmlformats.org/drawingml/2006/main">
               <a:ext uri="{FF2B5EF4-FFF2-40B4-BE49-F238E27FC236}">
-                <a16:creationId xmlns:a16="http://schemas.microsoft.com/office/drawing/2014/main" id="{0EDE6818-D00C-441E-ACCD-19887C23FDE3}"/>
+                <a16:creationId xmlns:a16="http://schemas.microsoft.com/office/drawing/2014/main" id="{33489CBD-E63A-408F-8E4A-F9C96272DCFA}"/>
               </a:ext>
             </a:extLst>
           </p:cNvPr>
@@ -13877,7 +14557,7 @@
           <p:cNvPr id="6" name="">
             <a:extLst xmlns:a="http://schemas.openxmlformats.org/drawingml/2006/main">
               <a:ext uri="{FF2B5EF4-FFF2-40B4-BE49-F238E27FC236}">
-                <a16:creationId xmlns:a16="http://schemas.microsoft.com/office/drawing/2014/main" id="{3BDBF9FC-61C8-4935-9BA0-7B68AD8DB95B}"/>
+                <a16:creationId xmlns:a16="http://schemas.microsoft.com/office/drawing/2014/main" id="{E51E651C-E1B8-4668-BEA7-5ED6A2830F11}"/>
               </a:ext>
             </a:extLst>
           </p:cNvPr>
@@ -13945,7 +14625,7 @@
           <p:cNvPr id="7" name="">
             <a:extLst xmlns:a="http://schemas.openxmlformats.org/drawingml/2006/main">
               <a:ext uri="{FF2B5EF4-FFF2-40B4-BE49-F238E27FC236}">
-                <a16:creationId xmlns:a16="http://schemas.microsoft.com/office/drawing/2014/main" id="{C33B1236-5302-45EB-8731-51B68D4A366B}"/>
+                <a16:creationId xmlns:a16="http://schemas.microsoft.com/office/drawing/2014/main" id="{1CA6713A-736E-4BD4-B53C-116A05DC2D5F}"/>
               </a:ext>
             </a:extLst>
           </p:cNvPr>
@@ -14013,7 +14693,7 @@
           <p:cNvPr id="8" name="">
             <a:extLst xmlns:a="http://schemas.openxmlformats.org/drawingml/2006/main">
               <a:ext uri="{FF2B5EF4-FFF2-40B4-BE49-F238E27FC236}">
-                <a16:creationId xmlns:a16="http://schemas.microsoft.com/office/drawing/2014/main" id="{358B1722-E07E-487A-89F1-A88F634C1F6A}"/>
+                <a16:creationId xmlns:a16="http://schemas.microsoft.com/office/drawing/2014/main" id="{451556AA-52D8-4E67-8186-F25F1F87088B}"/>
               </a:ext>
             </a:extLst>
           </p:cNvPr>
@@ -14081,7 +14761,7 @@
           <p:cNvPr id="9" name="">
             <a:extLst xmlns:a="http://schemas.openxmlformats.org/drawingml/2006/main">
               <a:ext uri="{FF2B5EF4-FFF2-40B4-BE49-F238E27FC236}">
-                <a16:creationId xmlns:a16="http://schemas.microsoft.com/office/drawing/2014/main" id="{D3E7311D-6BC0-4897-BA29-2093956D03C1}"/>
+                <a16:creationId xmlns:a16="http://schemas.microsoft.com/office/drawing/2014/main" id="{EE7B2B4C-11CE-4F02-AA71-F51791DBD956}"/>
               </a:ext>
             </a:extLst>
           </p:cNvPr>
@@ -14149,7 +14829,7 @@
           <p:cNvPr id="10" name="">
             <a:extLst xmlns:a="http://schemas.openxmlformats.org/drawingml/2006/main">
               <a:ext uri="{FF2B5EF4-FFF2-40B4-BE49-F238E27FC236}">
-                <a16:creationId xmlns:a16="http://schemas.microsoft.com/office/drawing/2014/main" id="{40C0FB7B-4F12-498F-A3A1-59DB4642FDB1}"/>
+                <a16:creationId xmlns:a16="http://schemas.microsoft.com/office/drawing/2014/main" id="{19B86874-9D6B-4EEB-AD22-6AEF110B56B1}"/>
               </a:ext>
             </a:extLst>
           </p:cNvPr>
@@ -14217,7 +14897,7 @@
           <p:cNvPr id="11" name="">
             <a:extLst xmlns:a="http://schemas.openxmlformats.org/drawingml/2006/main">
               <a:ext uri="{FF2B5EF4-FFF2-40B4-BE49-F238E27FC236}">
-                <a16:creationId xmlns:a16="http://schemas.microsoft.com/office/drawing/2014/main" id="{27615728-5D0D-422A-BDA1-3662E86BD6D0}"/>
+                <a16:creationId xmlns:a16="http://schemas.microsoft.com/office/drawing/2014/main" id="{5D74EE5A-D003-4D5E-8BB0-92512D7E6652}"/>
               </a:ext>
             </a:extLst>
           </p:cNvPr>
@@ -14285,35 +14965,103 @@
           <p:cNvPr id="12" name="">
             <a:extLst xmlns:a="http://schemas.openxmlformats.org/drawingml/2006/main">
               <a:ext uri="{FF2B5EF4-FFF2-40B4-BE49-F238E27FC236}">
-                <a16:creationId xmlns:a16="http://schemas.microsoft.com/office/drawing/2014/main" id="{8195FA72-44E7-4053-80C7-91C79EE3BBC3}"/>
-              </a:ext>
-            </a:extLst>
-          </p:cNvPr>
-          <p:cNvSpPr>
-            <a:spLocks xmlns:a="http://schemas.openxmlformats.org/drawingml/2006/main" noGrp="1"/>
-          </p:cNvSpPr>
-          <p:nvPr/>
-        </p:nvSpPr>
-        <p:spPr>
-          <a:xfrm xmlns:a="http://schemas.openxmlformats.org/drawingml/2006/main">
-            <a:off x="609600" y="5572125"/>
-            <a:ext cx="10953750" cy="666750"/>
-          </a:xfrm>
-          <a:prstGeom xmlns:a="http://schemas.openxmlformats.org/drawingml/2006/main" prst="rect">
-            <a:avLst/>
-          </a:prstGeom>
-          <a:noFill xmlns:a="http://schemas.openxmlformats.org/drawingml/2006/main"/>
-          <a:ln xmlns:a="http://schemas.openxmlformats.org/drawingml/2006/main" w="0">
-            <a:noFill/>
-          </a:ln>
-        </p:spPr>
-        <p:txBody>
-          <a:bodyPr xmlns:a="http://schemas.openxmlformats.org/drawingml/2006/main">
-            <a:noAutofit/>
-          </a:bodyPr>
-          <a:lstStyle xmlns:a="http://schemas.openxmlformats.org/drawingml/2006/main">
-            <a:defPPr>
-              <a:defRPr sz="1650" b="0">
+                <a16:creationId xmlns:a16="http://schemas.microsoft.com/office/drawing/2014/main" id="{E50A0A20-C167-43F5-911E-E0FCEA8B6FBE}"/>
+              </a:ext>
+            </a:extLst>
+          </p:cNvPr>
+          <p:cNvSpPr>
+            <a:spLocks xmlns:a="http://schemas.openxmlformats.org/drawingml/2006/main" noGrp="1"/>
+          </p:cNvSpPr>
+          <p:nvPr/>
+        </p:nvSpPr>
+        <p:spPr>
+          <a:xfrm xmlns:a="http://schemas.openxmlformats.org/drawingml/2006/main">
+            <a:off x="609600" y="5286375"/>
+            <a:ext cx="10953750" cy="381000"/>
+          </a:xfrm>
+          <a:prstGeom xmlns:a="http://schemas.openxmlformats.org/drawingml/2006/main" prst="rect">
+            <a:avLst/>
+          </a:prstGeom>
+          <a:noFill xmlns:a="http://schemas.openxmlformats.org/drawingml/2006/main"/>
+          <a:ln xmlns:a="http://schemas.openxmlformats.org/drawingml/2006/main" w="0">
+            <a:noFill/>
+          </a:ln>
+        </p:spPr>
+        <p:txBody>
+          <a:bodyPr xmlns:a="http://schemas.openxmlformats.org/drawingml/2006/main">
+            <a:noAutofit/>
+          </a:bodyPr>
+          <a:lstStyle xmlns:a="http://schemas.openxmlformats.org/drawingml/2006/main">
+            <a:defPPr>
+              <a:defRPr sz="1725" b="1">
+                <a:solidFill>
+                  <a:srgbClr val="FCD34D"/>
+                </a:solidFill>
+                <a:latin typeface="Arial"/>
+                <a:ea typeface="Arial"/>
+                <a:cs typeface="Arial"/>
+              </a:defRPr>
+            </a:defPPr>
+          </a:lstStyle>
+          <a:p xmlns:a="http://schemas.openxmlformats.org/drawingml/2006/main">
+            <a:pPr>
+              <a:defRPr sz="1725" b="1">
+                <a:solidFill>
+                  <a:srgbClr val="FCD34D"/>
+                </a:solidFill>
+                <a:latin typeface="Arial"/>
+                <a:ea typeface="Arial"/>
+                <a:cs typeface="Arial"/>
+              </a:defRPr>
+            </a:pPr>
+            <a:r>
+              <a:rPr sz="1725" b="1">
+                <a:solidFill>
+                  <a:srgbClr val="FCD34D"/>
+                </a:solidFill>
+                <a:latin typeface="Arial"/>
+                <a:ea typeface="Arial"/>
+                <a:cs typeface="Arial"/>
+              </a:rPr>
+              <a:t>Çfarë ndodh nëse një nga kontrollet dështon?</a:t>
+            </a:r>
+          </a:p>
+        </p:txBody>
+      </p:sp>
+      <p:sp>
+        <p:nvSpPr>
+          <p:cNvPr id="13" name="">
+            <a:extLst xmlns:a="http://schemas.openxmlformats.org/drawingml/2006/main">
+              <a:ext uri="{FF2B5EF4-FFF2-40B4-BE49-F238E27FC236}">
+                <a16:creationId xmlns:a16="http://schemas.microsoft.com/office/drawing/2014/main" id="{D0B08C03-EFA4-4840-AAB5-DC8D2DE2999E}"/>
+              </a:ext>
+            </a:extLst>
+          </p:cNvPr>
+          <p:cNvSpPr>
+            <a:spLocks xmlns:a="http://schemas.openxmlformats.org/drawingml/2006/main" noGrp="1"/>
+          </p:cNvSpPr>
+          <p:nvPr/>
+        </p:nvSpPr>
+        <p:spPr>
+          <a:xfrm xmlns:a="http://schemas.openxmlformats.org/drawingml/2006/main">
+            <a:off x="609600" y="5715000"/>
+            <a:ext cx="10953750" cy="619125"/>
+          </a:xfrm>
+          <a:prstGeom xmlns:a="http://schemas.openxmlformats.org/drawingml/2006/main" prst="rect">
+            <a:avLst/>
+          </a:prstGeom>
+          <a:noFill xmlns:a="http://schemas.openxmlformats.org/drawingml/2006/main"/>
+          <a:ln xmlns:a="http://schemas.openxmlformats.org/drawingml/2006/main" w="0">
+            <a:noFill/>
+          </a:ln>
+        </p:spPr>
+        <p:txBody>
+          <a:bodyPr xmlns:a="http://schemas.openxmlformats.org/drawingml/2006/main">
+            <a:noAutofit/>
+          </a:bodyPr>
+          <a:lstStyle xmlns:a="http://schemas.openxmlformats.org/drawingml/2006/main">
+            <a:defPPr>
+              <a:defRPr sz="1575" b="0">
                 <a:solidFill>
                   <a:srgbClr val="B8EDDB"/>
                 </a:solidFill>
@@ -14325,7 +15073,7 @@
           </a:lstStyle>
           <a:p xmlns:a="http://schemas.openxmlformats.org/drawingml/2006/main">
             <a:pPr>
-              <a:defRPr sz="1650" b="0">
+              <a:defRPr sz="1575" b="0">
                 <a:solidFill>
                   <a:srgbClr val="B8EDDB"/>
                 </a:solidFill>
@@ -14335,7 +15083,7 @@
               </a:defRPr>
             </a:pPr>
             <a:r>
-              <a:rPr sz="1650" b="0">
+              <a:rPr sz="1575" b="0">
                 <a:solidFill>
                   <a:srgbClr val="B8EDDB"/>
                 </a:solidFill>
@@ -14350,10 +15098,10 @@
       </p:sp>
       <p:sp>
         <p:nvSpPr>
-          <p:cNvPr id="13" name="">
-            <a:extLst xmlns:a="http://schemas.openxmlformats.org/drawingml/2006/main">
-              <a:ext uri="{FF2B5EF4-FFF2-40B4-BE49-F238E27FC236}">
-                <a16:creationId xmlns:a16="http://schemas.microsoft.com/office/drawing/2014/main" id="{3622562D-77FC-465F-AE04-5BDDE98A7AC1}"/>
+          <p:cNvPr id="14" name="">
+            <a:extLst xmlns:a="http://schemas.openxmlformats.org/drawingml/2006/main">
+              <a:ext uri="{FF2B5EF4-FFF2-40B4-BE49-F238E27FC236}">
+                <a16:creationId xmlns:a16="http://schemas.microsoft.com/office/drawing/2014/main" id="{E6E61121-4ADB-40AE-AE0E-9A59AF9BABFA}"/>
               </a:ext>
             </a:extLst>
           </p:cNvPr>
@@ -14419,7 +15167,7 @@
     </p:spTree>
     <p:extLst>
       <p:ext uri="{BB962C8B-B14F-4D97-AF65-F5344CB8AC3E}">
-        <p14:creationId xmlns:p14="http://schemas.microsoft.com/office/powerpoint/2010/main" val="1640558780"/>
+        <p14:creationId xmlns:p14="http://schemas.microsoft.com/office/powerpoint/2010/main" val="617743541"/>
       </p:ext>
     </p:extLst>
   </p:cSld>

</xml_diff>

<commit_message>
Illustrate week 5 lab and require questions before answers
</commit_message>
<xml_diff>
--- a/lendet/2026-2027/mobile/lectures/ligjerata-05-hyrja-lejet-rideshare-2026.pptx
+++ b/lendet/2026-2027/mobile/lectures/ligjerata-05-hyrja-lejet-rideshare-2026.pptx
@@ -2,29 +2,29 @@
 <file path=ppt/presentation.xml><?xml version="1.0" encoding="utf-8"?>
 <p:presentation xmlns:p="http://schemas.openxmlformats.org/presentationml/2006/main">
   <p:sldMasterIdLst>
-    <p:sldMasterId xmlns:r="http://schemas.openxmlformats.org/officeDocument/2006/relationships" id="2147483648" r:id="R3824b92e73c74d38"/>
+    <p:sldMasterId xmlns:r="http://schemas.openxmlformats.org/officeDocument/2006/relationships" id="2147483648" r:id="Re6c0461688854029"/>
   </p:sldMasterIdLst>
   <p:sldIdLst>
-    <p:sldId xmlns:r="http://schemas.openxmlformats.org/officeDocument/2006/relationships" id="256" r:id="R5aeb9361a7744bae"/>
-    <p:sldId xmlns:r="http://schemas.openxmlformats.org/officeDocument/2006/relationships" id="257" r:id="R37856cd12ce84310"/>
-    <p:sldId xmlns:r="http://schemas.openxmlformats.org/officeDocument/2006/relationships" id="258" r:id="Rdbe8b0c7b2cf4ce8"/>
-    <p:sldId xmlns:r="http://schemas.openxmlformats.org/officeDocument/2006/relationships" id="259" r:id="R92370f7143204ac4"/>
-    <p:sldId xmlns:r="http://schemas.openxmlformats.org/officeDocument/2006/relationships" id="260" r:id="Rcb8c9e9110f6473b"/>
-    <p:sldId xmlns:r="http://schemas.openxmlformats.org/officeDocument/2006/relationships" id="261" r:id="R7c6766d6b8834c27"/>
-    <p:sldId xmlns:r="http://schemas.openxmlformats.org/officeDocument/2006/relationships" id="262" r:id="Rd0de3b64c82343bf"/>
-    <p:sldId xmlns:r="http://schemas.openxmlformats.org/officeDocument/2006/relationships" id="263" r:id="R2806beedc8814023"/>
-    <p:sldId xmlns:r="http://schemas.openxmlformats.org/officeDocument/2006/relationships" id="264" r:id="R1edcd3bbaa014ead"/>
-    <p:sldId xmlns:r="http://schemas.openxmlformats.org/officeDocument/2006/relationships" id="265" r:id="Rfdfe8ab1d65e4d2f"/>
-    <p:sldId xmlns:r="http://schemas.openxmlformats.org/officeDocument/2006/relationships" id="266" r:id="R7c0e9807e5b94a0c"/>
-    <p:sldId xmlns:r="http://schemas.openxmlformats.org/officeDocument/2006/relationships" id="267" r:id="R701df630cf7846b2"/>
-    <p:sldId xmlns:r="http://schemas.openxmlformats.org/officeDocument/2006/relationships" id="268" r:id="Rdb3554a159834d64"/>
-    <p:sldId xmlns:r="http://schemas.openxmlformats.org/officeDocument/2006/relationships" id="269" r:id="R9badbbc92e1f4910"/>
-    <p:sldId xmlns:r="http://schemas.openxmlformats.org/officeDocument/2006/relationships" id="270" r:id="Rbddf241b16164ce9"/>
-    <p:sldId xmlns:r="http://schemas.openxmlformats.org/officeDocument/2006/relationships" id="271" r:id="R924f6b720c5b460d"/>
-    <p:sldId xmlns:r="http://schemas.openxmlformats.org/officeDocument/2006/relationships" id="272" r:id="Ra7f50215da1e41eb"/>
-    <p:sldId xmlns:r="http://schemas.openxmlformats.org/officeDocument/2006/relationships" id="273" r:id="Raf8826742efb4821"/>
-    <p:sldId xmlns:r="http://schemas.openxmlformats.org/officeDocument/2006/relationships" id="274" r:id="Rb0e0e80c3e494609"/>
-    <p:sldId xmlns:r="http://schemas.openxmlformats.org/officeDocument/2006/relationships" id="275" r:id="R7f49de06340d45c4"/>
+    <p:sldId xmlns:r="http://schemas.openxmlformats.org/officeDocument/2006/relationships" id="256" r:id="R07da8900fdbd436d"/>
+    <p:sldId xmlns:r="http://schemas.openxmlformats.org/officeDocument/2006/relationships" id="257" r:id="R9affa4b292c34e47"/>
+    <p:sldId xmlns:r="http://schemas.openxmlformats.org/officeDocument/2006/relationships" id="258" r:id="R028e769b095d458d"/>
+    <p:sldId xmlns:r="http://schemas.openxmlformats.org/officeDocument/2006/relationships" id="259" r:id="Rb2fa812846094158"/>
+    <p:sldId xmlns:r="http://schemas.openxmlformats.org/officeDocument/2006/relationships" id="260" r:id="R96f5cfe992d44a52"/>
+    <p:sldId xmlns:r="http://schemas.openxmlformats.org/officeDocument/2006/relationships" id="261" r:id="R367f7d4167dc4299"/>
+    <p:sldId xmlns:r="http://schemas.openxmlformats.org/officeDocument/2006/relationships" id="262" r:id="Rfc6f0dc542c84f00"/>
+    <p:sldId xmlns:r="http://schemas.openxmlformats.org/officeDocument/2006/relationships" id="263" r:id="R5bb25875755d4a37"/>
+    <p:sldId xmlns:r="http://schemas.openxmlformats.org/officeDocument/2006/relationships" id="264" r:id="Rd259049c2c91400f"/>
+    <p:sldId xmlns:r="http://schemas.openxmlformats.org/officeDocument/2006/relationships" id="265" r:id="Rfec50c535a0a438b"/>
+    <p:sldId xmlns:r="http://schemas.openxmlformats.org/officeDocument/2006/relationships" id="266" r:id="R1278c3d84c40424e"/>
+    <p:sldId xmlns:r="http://schemas.openxmlformats.org/officeDocument/2006/relationships" id="267" r:id="R7da3158362434e8d"/>
+    <p:sldId xmlns:r="http://schemas.openxmlformats.org/officeDocument/2006/relationships" id="268" r:id="R93ed994579ff41a6"/>
+    <p:sldId xmlns:r="http://schemas.openxmlformats.org/officeDocument/2006/relationships" id="269" r:id="Rde186ae04867440b"/>
+    <p:sldId xmlns:r="http://schemas.openxmlformats.org/officeDocument/2006/relationships" id="270" r:id="R6e587f706f874a62"/>
+    <p:sldId xmlns:r="http://schemas.openxmlformats.org/officeDocument/2006/relationships" id="271" r:id="R1280b6c64a334d69"/>
+    <p:sldId xmlns:r="http://schemas.openxmlformats.org/officeDocument/2006/relationships" id="272" r:id="R88a714e39eba41ab"/>
+    <p:sldId xmlns:r="http://schemas.openxmlformats.org/officeDocument/2006/relationships" id="273" r:id="Rd5e52cb76bf74398"/>
+    <p:sldId xmlns:r="http://schemas.openxmlformats.org/officeDocument/2006/relationships" id="274" r:id="Rb7dbde05e3c0454e"/>
+    <p:sldId xmlns:r="http://schemas.openxmlformats.org/officeDocument/2006/relationships" id="275" r:id="R68851af7ea964f0d"/>
   </p:sldIdLst>
   <p:sldSz cx="12192000" cy="6858000"/>
   <p:notesSz cx="6858000" cy="9144000"/>
@@ -48,7 +48,7 @@
           <p:cNvPr id="3" name="Title">
             <a:extLst xmlns:a="http://schemas.openxmlformats.org/drawingml/2006/main">
               <a:ext uri="{FF2B5EF4-FFF2-40B4-BE49-F238E27FC236}">
-                <a16:creationId xmlns:a16="http://schemas.microsoft.com/office/drawing/2014/main" id="{CD110574-50CA-4AFB-A783-FBB57A260829}"/>
+                <a16:creationId xmlns:a16="http://schemas.microsoft.com/office/drawing/2014/main" id="{29B51D88-EED4-45C6-B81C-0393C6A51168}"/>
               </a:ext>
             </a:extLst>
           </p:cNvPr>
@@ -205,7 +205,7 @@
           <p:cNvPr id="2" name="Subtitle">
             <a:extLst xmlns:a="http://schemas.openxmlformats.org/drawingml/2006/main">
               <a:ext uri="{FF2B5EF4-FFF2-40B4-BE49-F238E27FC236}">
-                <a16:creationId xmlns:a16="http://schemas.microsoft.com/office/drawing/2014/main" id="{C13BAC9B-E722-45DA-9EB8-6F3F4C5ADC51}"/>
+                <a16:creationId xmlns:a16="http://schemas.microsoft.com/office/drawing/2014/main" id="{408FCA49-D2E2-43A3-A188-15A256324869}"/>
               </a:ext>
             </a:extLst>
           </p:cNvPr>
@@ -379,7 +379,7 @@
           <p:cNvPr id="2" name="Section title">
             <a:extLst xmlns:a="http://schemas.openxmlformats.org/drawingml/2006/main">
               <a:ext uri="{FF2B5EF4-FFF2-40B4-BE49-F238E27FC236}">
-                <a16:creationId xmlns:a16="http://schemas.microsoft.com/office/drawing/2014/main" id="{C114AB8B-8564-44E7-8993-1B24894E7186}"/>
+                <a16:creationId xmlns:a16="http://schemas.microsoft.com/office/drawing/2014/main" id="{74B70489-5E4C-4922-85E4-0E590D405378}"/>
               </a:ext>
             </a:extLst>
           </p:cNvPr>
@@ -553,7 +553,7 @@
           <p:cNvPr id="3" name="Title">
             <a:extLst xmlns:a="http://schemas.openxmlformats.org/drawingml/2006/main">
               <a:ext uri="{FF2B5EF4-FFF2-40B4-BE49-F238E27FC236}">
-                <a16:creationId xmlns:a16="http://schemas.microsoft.com/office/drawing/2014/main" id="{9B16612E-F743-43EE-9597-1B3596E4FE94}"/>
+                <a16:creationId xmlns:a16="http://schemas.microsoft.com/office/drawing/2014/main" id="{5D9DB8E1-FBE8-45E2-A9AE-C2EA4A3B20D8}"/>
               </a:ext>
             </a:extLst>
           </p:cNvPr>
@@ -710,7 +710,7 @@
           <p:cNvPr id="2" name="Body">
             <a:extLst xmlns:a="http://schemas.openxmlformats.org/drawingml/2006/main">
               <a:ext uri="{FF2B5EF4-FFF2-40B4-BE49-F238E27FC236}">
-                <a16:creationId xmlns:a16="http://schemas.microsoft.com/office/drawing/2014/main" id="{B5FA6B68-5181-4311-A1C7-897D602176F3}"/>
+                <a16:creationId xmlns:a16="http://schemas.microsoft.com/office/drawing/2014/main" id="{C35BB0BA-036D-485C-B418-8ED25506B259}"/>
               </a:ext>
             </a:extLst>
           </p:cNvPr>
@@ -884,7 +884,7 @@
           <p:cNvPr id="4" name="Title">
             <a:extLst xmlns:a="http://schemas.openxmlformats.org/drawingml/2006/main">
               <a:ext uri="{FF2B5EF4-FFF2-40B4-BE49-F238E27FC236}">
-                <a16:creationId xmlns:a16="http://schemas.microsoft.com/office/drawing/2014/main" id="{695182B6-0DAE-4208-9DBE-C7AF65DD73D6}"/>
+                <a16:creationId xmlns:a16="http://schemas.microsoft.com/office/drawing/2014/main" id="{C5A7F206-87B0-4110-A32D-FC039F09F26D}"/>
               </a:ext>
             </a:extLst>
           </p:cNvPr>
@@ -1041,7 +1041,7 @@
           <p:cNvPr id="2" name="Left column">
             <a:extLst xmlns:a="http://schemas.openxmlformats.org/drawingml/2006/main">
               <a:ext uri="{FF2B5EF4-FFF2-40B4-BE49-F238E27FC236}">
-                <a16:creationId xmlns:a16="http://schemas.microsoft.com/office/drawing/2014/main" id="{8FCF9555-5051-4249-9E0F-6A550D82159F}"/>
+                <a16:creationId xmlns:a16="http://schemas.microsoft.com/office/drawing/2014/main" id="{C11BCAFC-2FB1-4042-8C3B-BCF07742B16F}"/>
               </a:ext>
             </a:extLst>
           </p:cNvPr>
@@ -1198,7 +1198,7 @@
           <p:cNvPr id="3" name="Right column">
             <a:extLst xmlns:a="http://schemas.openxmlformats.org/drawingml/2006/main">
               <a:ext uri="{FF2B5EF4-FFF2-40B4-BE49-F238E27FC236}">
-                <a16:creationId xmlns:a16="http://schemas.microsoft.com/office/drawing/2014/main" id="{931124EA-B5EA-4CD8-B8E1-CE2D6FEDC133}"/>
+                <a16:creationId xmlns:a16="http://schemas.microsoft.com/office/drawing/2014/main" id="{F0D058A2-5EB0-4D0D-BC6A-75F455BD1010}"/>
               </a:ext>
             </a:extLst>
           </p:cNvPr>
@@ -1372,7 +1372,7 @@
           <p:cNvPr id="3" name="Title">
             <a:extLst xmlns:a="http://schemas.openxmlformats.org/drawingml/2006/main">
               <a:ext uri="{FF2B5EF4-FFF2-40B4-BE49-F238E27FC236}">
-                <a16:creationId xmlns:a16="http://schemas.microsoft.com/office/drawing/2014/main" id="{9BDB61CF-28A8-4429-8935-26ABCD977AF1}"/>
+                <a16:creationId xmlns:a16="http://schemas.microsoft.com/office/drawing/2014/main" id="{3DDDB6B8-6E1B-436D-8C71-E75B5B4B1C13}"/>
               </a:ext>
             </a:extLst>
           </p:cNvPr>
@@ -1529,7 +1529,7 @@
           <p:cNvPr id="2" name="Left column">
             <a:extLst xmlns:a="http://schemas.openxmlformats.org/drawingml/2006/main">
               <a:ext uri="{FF2B5EF4-FFF2-40B4-BE49-F238E27FC236}">
-                <a16:creationId xmlns:a16="http://schemas.microsoft.com/office/drawing/2014/main" id="{F6AF6C09-DF4A-442C-BDAC-F9C35B8C1E98}"/>
+                <a16:creationId xmlns:a16="http://schemas.microsoft.com/office/drawing/2014/main" id="{58DE0553-1398-4F53-854E-378733AD6EA9}"/>
               </a:ext>
             </a:extLst>
           </p:cNvPr>
@@ -1724,12 +1724,12 @@
   </p:cSld>
   <p:clrMap bg1="lt1" tx1="dk1" bg2="lt2" tx2="dk2" accent1="accent1" accent2="accent2" accent3="accent3" accent4="accent4" accent5="accent5" accent6="accent6" hlink="hlink" folHlink="folHlink"/>
   <p:sldLayoutIdLst>
-    <p:sldLayoutId xmlns:r="http://schemas.openxmlformats.org/officeDocument/2006/relationships" id="2147483649" r:id="Rdd3280250b85454d"/>
-    <p:sldLayoutId xmlns:r="http://schemas.openxmlformats.org/officeDocument/2006/relationships" id="2147483650" r:id="R434c3da4c8234310"/>
-    <p:sldLayoutId xmlns:r="http://schemas.openxmlformats.org/officeDocument/2006/relationships" id="2147483651" r:id="R56f3d5167ccd47b4"/>
-    <p:sldLayoutId xmlns:r="http://schemas.openxmlformats.org/officeDocument/2006/relationships" id="2147483652" r:id="R4b3c14d6b62a4e78"/>
-    <p:sldLayoutId xmlns:r="http://schemas.openxmlformats.org/officeDocument/2006/relationships" id="2147483653" r:id="R4d1669741fc14f7c"/>
-    <p:sldLayoutId xmlns:r="http://schemas.openxmlformats.org/officeDocument/2006/relationships" id="2147483654" r:id="R8223010e007143f1"/>
+    <p:sldLayoutId xmlns:r="http://schemas.openxmlformats.org/officeDocument/2006/relationships" id="2147483649" r:id="R988b826a36d14ac5"/>
+    <p:sldLayoutId xmlns:r="http://schemas.openxmlformats.org/officeDocument/2006/relationships" id="2147483650" r:id="R911df8b2aeb047c7"/>
+    <p:sldLayoutId xmlns:r="http://schemas.openxmlformats.org/officeDocument/2006/relationships" id="2147483651" r:id="R69ee2c8a129f4983"/>
+    <p:sldLayoutId xmlns:r="http://schemas.openxmlformats.org/officeDocument/2006/relationships" id="2147483652" r:id="R01c46ec46d8d4845"/>
+    <p:sldLayoutId xmlns:r="http://schemas.openxmlformats.org/officeDocument/2006/relationships" id="2147483653" r:id="R0f3c48cf3e004c6a"/>
+    <p:sldLayoutId xmlns:r="http://schemas.openxmlformats.org/officeDocument/2006/relationships" id="2147483654" r:id="R39437dc9bb0448c4"/>
   </p:sldLayoutIdLst>
   <p:txStyles>
     <p:titleStyle>
@@ -2280,7 +2280,7 @@
           <p:cNvPr id="9" name="">
             <a:extLst xmlns:a="http://schemas.openxmlformats.org/drawingml/2006/main">
               <a:ext uri="{FF2B5EF4-FFF2-40B4-BE49-F238E27FC236}">
-                <a16:creationId xmlns:a16="http://schemas.microsoft.com/office/drawing/2014/main" id="{73F71B9D-3E4B-4A1F-ADC1-4B4FDFABAA8C}"/>
+                <a16:creationId xmlns:a16="http://schemas.microsoft.com/office/drawing/2014/main" id="{B5638046-A4F6-48B3-8713-4D2DC4C1E533}"/>
               </a:ext>
             </a:extLst>
           </p:cNvPr>
@@ -2348,7 +2348,7 @@
           <p:cNvPr id="2" name="">
             <a:extLst xmlns:a="http://schemas.openxmlformats.org/drawingml/2006/main">
               <a:ext uri="{FF2B5EF4-FFF2-40B4-BE49-F238E27FC236}">
-                <a16:creationId xmlns:a16="http://schemas.microsoft.com/office/drawing/2014/main" id="{A69426D2-8B26-40BC-9707-FE7DB41F23FA}"/>
+                <a16:creationId xmlns:a16="http://schemas.microsoft.com/office/drawing/2014/main" id="{E6B150A4-5CEA-4BEC-96EC-1E0163391DF4}"/>
               </a:ext>
             </a:extLst>
           </p:cNvPr>
@@ -2416,7 +2416,7 @@
           <p:cNvPr id="3" name="">
             <a:extLst xmlns:a="http://schemas.openxmlformats.org/drawingml/2006/main">
               <a:ext uri="{FF2B5EF4-FFF2-40B4-BE49-F238E27FC236}">
-                <a16:creationId xmlns:a16="http://schemas.microsoft.com/office/drawing/2014/main" id="{B64E0458-317D-4DD9-A85B-E61E6DB0F421}"/>
+                <a16:creationId xmlns:a16="http://schemas.microsoft.com/office/drawing/2014/main" id="{DF84C3EE-B2B1-406A-B8D3-82658FEACC6A}"/>
               </a:ext>
             </a:extLst>
           </p:cNvPr>
@@ -2426,7 +2426,7 @@
           <p:nvPr/>
         </p:nvPicPr>
         <p:blipFill>
-          <a:blip xmlns:r="http://schemas.openxmlformats.org/officeDocument/2006/relationships" xmlns:a="http://schemas.openxmlformats.org/drawingml/2006/main" r:embed="R825d9c756e514b54"/>
+          <a:blip xmlns:r="http://schemas.openxmlformats.org/officeDocument/2006/relationships" xmlns:a="http://schemas.openxmlformats.org/drawingml/2006/main" r:embed="R742b510e16f94417"/>
           <a:stretch xmlns:a="http://schemas.openxmlformats.org/drawingml/2006/main"/>
         </p:blipFill>
         <p:spPr>
@@ -2444,7 +2444,7 @@
           <p:cNvPr id="4" name="">
             <a:extLst xmlns:a="http://schemas.openxmlformats.org/drawingml/2006/main">
               <a:ext uri="{FF2B5EF4-FFF2-40B4-BE49-F238E27FC236}">
-                <a16:creationId xmlns:a16="http://schemas.microsoft.com/office/drawing/2014/main" id="{CED6993B-5605-48FF-A003-D6D71671366D}"/>
+                <a16:creationId xmlns:a16="http://schemas.microsoft.com/office/drawing/2014/main" id="{2E616C75-08DF-42FD-888F-88FEE1AB7B79}"/>
               </a:ext>
             </a:extLst>
           </p:cNvPr>
@@ -2512,7 +2512,7 @@
           <p:cNvPr id="5" name="">
             <a:extLst xmlns:a="http://schemas.openxmlformats.org/drawingml/2006/main">
               <a:ext uri="{FF2B5EF4-FFF2-40B4-BE49-F238E27FC236}">
-                <a16:creationId xmlns:a16="http://schemas.microsoft.com/office/drawing/2014/main" id="{5D877D8F-048D-486D-9E27-B765069E7F06}"/>
+                <a16:creationId xmlns:a16="http://schemas.microsoft.com/office/drawing/2014/main" id="{F04C2224-8926-4962-9C6E-787119A68EC2}"/>
               </a:ext>
             </a:extLst>
           </p:cNvPr>
@@ -2608,7 +2608,7 @@
           <p:cNvPr id="6" name="">
             <a:extLst xmlns:a="http://schemas.openxmlformats.org/drawingml/2006/main">
               <a:ext uri="{FF2B5EF4-FFF2-40B4-BE49-F238E27FC236}">
-                <a16:creationId xmlns:a16="http://schemas.microsoft.com/office/drawing/2014/main" id="{8E91072E-1889-4B0A-9180-0446D62135DB}"/>
+                <a16:creationId xmlns:a16="http://schemas.microsoft.com/office/drawing/2014/main" id="{7D9AB602-DC2C-405F-9ECC-B1941F718278}"/>
               </a:ext>
             </a:extLst>
           </p:cNvPr>
@@ -2666,7 +2666,7 @@
                 <a:ea typeface="Arial"/>
                 <a:cs typeface="Arial"/>
               </a:rPr>
-              <a:t>Parashiko para demonstrimit</a:t>
+              <a:t>A mjafton hyrja me GitHub për ta ndryshuar orën?</a:t>
             </a:r>
           </a:p>
         </p:txBody>
@@ -2676,7 +2676,7 @@
           <p:cNvPr id="7" name="">
             <a:extLst xmlns:a="http://schemas.openxmlformats.org/drawingml/2006/main">
               <a:ext uri="{FF2B5EF4-FFF2-40B4-BE49-F238E27FC236}">
-                <a16:creationId xmlns:a16="http://schemas.microsoft.com/office/drawing/2014/main" id="{A5FB5E82-9946-47F8-B707-EA3E6F9F8819}"/>
+                <a16:creationId xmlns:a16="http://schemas.microsoft.com/office/drawing/2014/main" id="{E1B613FA-3BE0-42E0-8555-E8C76CBB7D75}"/>
               </a:ext>
             </a:extLst>
           </p:cNvPr>
@@ -2800,7 +2800,7 @@
           <p:cNvPr id="8" name="">
             <a:extLst xmlns:a="http://schemas.openxmlformats.org/drawingml/2006/main">
               <a:ext uri="{FF2B5EF4-FFF2-40B4-BE49-F238E27FC236}">
-                <a16:creationId xmlns:a16="http://schemas.microsoft.com/office/drawing/2014/main" id="{A013FC96-39C8-4491-A5D1-0C472616F8F0}"/>
+                <a16:creationId xmlns:a16="http://schemas.microsoft.com/office/drawing/2014/main" id="{D5DABB34-5C9A-4783-AD16-4297E852CFC0}"/>
               </a:ext>
             </a:extLst>
           </p:cNvPr>
@@ -2866,7 +2866,7 @@
     </p:spTree>
     <p:extLst>
       <p:ext uri="{BB962C8B-B14F-4D97-AF65-F5344CB8AC3E}">
-        <p14:creationId xmlns:p14="http://schemas.microsoft.com/office/powerpoint/2010/main" val="559278306"/>
+        <p14:creationId xmlns:p14="http://schemas.microsoft.com/office/powerpoint/2010/main" val="337439799"/>
       </p:ext>
     </p:extLst>
   </p:cSld>
@@ -2897,7 +2897,7 @@
           <p:cNvPr id="15" name="">
             <a:extLst xmlns:a="http://schemas.openxmlformats.org/drawingml/2006/main">
               <a:ext uri="{FF2B5EF4-FFF2-40B4-BE49-F238E27FC236}">
-                <a16:creationId xmlns:a16="http://schemas.microsoft.com/office/drawing/2014/main" id="{C4B50364-9408-470E-B7C9-22E97FC4F4F8}"/>
+                <a16:creationId xmlns:a16="http://schemas.microsoft.com/office/drawing/2014/main" id="{91BECA9E-4F12-4258-984F-F4C8060669AA}"/>
               </a:ext>
             </a:extLst>
           </p:cNvPr>
@@ -2965,7 +2965,7 @@
           <p:cNvPr id="2" name="">
             <a:extLst xmlns:a="http://schemas.openxmlformats.org/drawingml/2006/main">
               <a:ext uri="{FF2B5EF4-FFF2-40B4-BE49-F238E27FC236}">
-                <a16:creationId xmlns:a16="http://schemas.microsoft.com/office/drawing/2014/main" id="{B343983E-61D0-404F-916D-9968F969DB02}"/>
+                <a16:creationId xmlns:a16="http://schemas.microsoft.com/office/drawing/2014/main" id="{970F33CD-19C1-4E93-BB0E-8429B4E165C7}"/>
               </a:ext>
             </a:extLst>
           </p:cNvPr>
@@ -3033,7 +3033,7 @@
           <p:cNvPr id="3" name="">
             <a:extLst xmlns:a="http://schemas.openxmlformats.org/drawingml/2006/main">
               <a:ext uri="{FF2B5EF4-FFF2-40B4-BE49-F238E27FC236}">
-                <a16:creationId xmlns:a16="http://schemas.microsoft.com/office/drawing/2014/main" id="{A97FD746-5240-4BC7-973B-56995632D0ED}"/>
+                <a16:creationId xmlns:a16="http://schemas.microsoft.com/office/drawing/2014/main" id="{70662C05-E509-44EB-921C-B8BF4C3EDB26}"/>
               </a:ext>
             </a:extLst>
           </p:cNvPr>
@@ -3101,7 +3101,7 @@
           <p:cNvPr id="4" name="">
             <a:extLst xmlns:a="http://schemas.openxmlformats.org/drawingml/2006/main">
               <a:ext uri="{FF2B5EF4-FFF2-40B4-BE49-F238E27FC236}">
-                <a16:creationId xmlns:a16="http://schemas.microsoft.com/office/drawing/2014/main" id="{ECD6D15B-032B-47C8-A91E-BF6EB741F7D9}"/>
+                <a16:creationId xmlns:a16="http://schemas.microsoft.com/office/drawing/2014/main" id="{D71D037E-CB67-4E11-9C20-2FDCFF6015FC}"/>
               </a:ext>
             </a:extLst>
           </p:cNvPr>
@@ -3169,7 +3169,7 @@
           <p:cNvPr id="5" name="">
             <a:extLst xmlns:a="http://schemas.openxmlformats.org/drawingml/2006/main">
               <a:ext uri="{FF2B5EF4-FFF2-40B4-BE49-F238E27FC236}">
-                <a16:creationId xmlns:a16="http://schemas.microsoft.com/office/drawing/2014/main" id="{A65F5A87-0692-4D2B-8A61-769D0C61509F}"/>
+                <a16:creationId xmlns:a16="http://schemas.microsoft.com/office/drawing/2014/main" id="{03F251A9-1BCE-43B0-BD0F-E1C055FC3D3F}"/>
               </a:ext>
             </a:extLst>
           </p:cNvPr>
@@ -3237,7 +3237,7 @@
           <p:cNvPr id="6" name="">
             <a:extLst xmlns:a="http://schemas.openxmlformats.org/drawingml/2006/main">
               <a:ext uri="{FF2B5EF4-FFF2-40B4-BE49-F238E27FC236}">
-                <a16:creationId xmlns:a16="http://schemas.microsoft.com/office/drawing/2014/main" id="{20A872B2-AB07-4104-A6CD-700F4663CF37}"/>
+                <a16:creationId xmlns:a16="http://schemas.microsoft.com/office/drawing/2014/main" id="{523D9A20-232F-492C-9853-BBCEC1DC2AD4}"/>
               </a:ext>
             </a:extLst>
           </p:cNvPr>
@@ -3305,7 +3305,7 @@
           <p:cNvPr id="7" name="">
             <a:extLst xmlns:a="http://schemas.openxmlformats.org/drawingml/2006/main">
               <a:ext uri="{FF2B5EF4-FFF2-40B4-BE49-F238E27FC236}">
-                <a16:creationId xmlns:a16="http://schemas.microsoft.com/office/drawing/2014/main" id="{F32E3BBA-09B3-4572-ADFD-AF9FB45D2306}"/>
+                <a16:creationId xmlns:a16="http://schemas.microsoft.com/office/drawing/2014/main" id="{2F516993-E14E-45BB-8D7C-473DA3E8A46A}"/>
               </a:ext>
             </a:extLst>
           </p:cNvPr>
@@ -3373,7 +3373,7 @@
           <p:cNvPr id="8" name="">
             <a:extLst xmlns:a="http://schemas.openxmlformats.org/drawingml/2006/main">
               <a:ext uri="{FF2B5EF4-FFF2-40B4-BE49-F238E27FC236}">
-                <a16:creationId xmlns:a16="http://schemas.microsoft.com/office/drawing/2014/main" id="{3EE41DA5-6F8E-421C-A085-72BE87081D48}"/>
+                <a16:creationId xmlns:a16="http://schemas.microsoft.com/office/drawing/2014/main" id="{3E5B3A96-F171-49FD-A536-05D14BCF7473}"/>
               </a:ext>
             </a:extLst>
           </p:cNvPr>
@@ -3441,7 +3441,7 @@
           <p:cNvPr id="9" name="">
             <a:extLst xmlns:a="http://schemas.openxmlformats.org/drawingml/2006/main">
               <a:ext uri="{FF2B5EF4-FFF2-40B4-BE49-F238E27FC236}">
-                <a16:creationId xmlns:a16="http://schemas.microsoft.com/office/drawing/2014/main" id="{AFE3E620-554C-48F1-9D06-EB11F7031C87}"/>
+                <a16:creationId xmlns:a16="http://schemas.microsoft.com/office/drawing/2014/main" id="{BF4E63BF-73E0-40A5-869A-F2E8AEA5DB4B}"/>
               </a:ext>
             </a:extLst>
           </p:cNvPr>
@@ -3509,7 +3509,7 @@
           <p:cNvPr id="10" name="">
             <a:extLst xmlns:a="http://schemas.openxmlformats.org/drawingml/2006/main">
               <a:ext uri="{FF2B5EF4-FFF2-40B4-BE49-F238E27FC236}">
-                <a16:creationId xmlns:a16="http://schemas.microsoft.com/office/drawing/2014/main" id="{8D347426-B1A5-43E6-AC08-6E828E26FE1A}"/>
+                <a16:creationId xmlns:a16="http://schemas.microsoft.com/office/drawing/2014/main" id="{2B8EC94C-3D45-4282-B568-4090CFE2448E}"/>
               </a:ext>
             </a:extLst>
           </p:cNvPr>
@@ -3577,7 +3577,7 @@
           <p:cNvPr id="11" name="">
             <a:extLst xmlns:a="http://schemas.openxmlformats.org/drawingml/2006/main">
               <a:ext uri="{FF2B5EF4-FFF2-40B4-BE49-F238E27FC236}">
-                <a16:creationId xmlns:a16="http://schemas.microsoft.com/office/drawing/2014/main" id="{A5EFDBAA-52F4-431D-ABB7-E7973F0C36D5}"/>
+                <a16:creationId xmlns:a16="http://schemas.microsoft.com/office/drawing/2014/main" id="{26764580-2665-4CCF-9282-811909A35BFA}"/>
               </a:ext>
             </a:extLst>
           </p:cNvPr>
@@ -3645,7 +3645,7 @@
           <p:cNvPr id="12" name="">
             <a:extLst xmlns:a="http://schemas.openxmlformats.org/drawingml/2006/main">
               <a:ext uri="{FF2B5EF4-FFF2-40B4-BE49-F238E27FC236}">
-                <a16:creationId xmlns:a16="http://schemas.microsoft.com/office/drawing/2014/main" id="{DEE0250D-14DE-48B6-85BF-8004946B7CBA}"/>
+                <a16:creationId xmlns:a16="http://schemas.microsoft.com/office/drawing/2014/main" id="{45FDF268-83F0-47B2-8846-8A08C167BCFC}"/>
               </a:ext>
             </a:extLst>
           </p:cNvPr>
@@ -3713,7 +3713,7 @@
           <p:cNvPr id="13" name="">
             <a:extLst xmlns:a="http://schemas.openxmlformats.org/drawingml/2006/main">
               <a:ext uri="{FF2B5EF4-FFF2-40B4-BE49-F238E27FC236}">
-                <a16:creationId xmlns:a16="http://schemas.microsoft.com/office/drawing/2014/main" id="{910F4571-F7AC-439F-90FF-0706AF59586D}"/>
+                <a16:creationId xmlns:a16="http://schemas.microsoft.com/office/drawing/2014/main" id="{5F26DBC6-E545-426D-AEAA-A747C2E88947}"/>
               </a:ext>
             </a:extLst>
           </p:cNvPr>
@@ -3781,7 +3781,7 @@
           <p:cNvPr id="14" name="">
             <a:extLst xmlns:a="http://schemas.openxmlformats.org/drawingml/2006/main">
               <a:ext uri="{FF2B5EF4-FFF2-40B4-BE49-F238E27FC236}">
-                <a16:creationId xmlns:a16="http://schemas.microsoft.com/office/drawing/2014/main" id="{6EBBB892-8F9F-422B-9387-EF57F49346A3}"/>
+                <a16:creationId xmlns:a16="http://schemas.microsoft.com/office/drawing/2014/main" id="{EC2F517E-79B9-499A-B2C8-18E7F3FD2777}"/>
               </a:ext>
             </a:extLst>
           </p:cNvPr>
@@ -3847,7 +3847,7 @@
     </p:spTree>
     <p:extLst>
       <p:ext uri="{BB962C8B-B14F-4D97-AF65-F5344CB8AC3E}">
-        <p14:creationId xmlns:p14="http://schemas.microsoft.com/office/powerpoint/2010/main" val="1635409300"/>
+        <p14:creationId xmlns:p14="http://schemas.microsoft.com/office/powerpoint/2010/main" val="506952383"/>
       </p:ext>
     </p:extLst>
   </p:cSld>
@@ -3878,7 +3878,7 @@
           <p:cNvPr id="9" name="">
             <a:extLst xmlns:a="http://schemas.openxmlformats.org/drawingml/2006/main">
               <a:ext uri="{FF2B5EF4-FFF2-40B4-BE49-F238E27FC236}">
-                <a16:creationId xmlns:a16="http://schemas.microsoft.com/office/drawing/2014/main" id="{FD161126-899E-4FC0-A3DC-C3FF2F37FB14}"/>
+                <a16:creationId xmlns:a16="http://schemas.microsoft.com/office/drawing/2014/main" id="{8127A033-B23F-406C-B060-EA8297CC23F1}"/>
               </a:ext>
             </a:extLst>
           </p:cNvPr>
@@ -3946,7 +3946,7 @@
           <p:cNvPr id="2" name="">
             <a:extLst xmlns:a="http://schemas.openxmlformats.org/drawingml/2006/main">
               <a:ext uri="{FF2B5EF4-FFF2-40B4-BE49-F238E27FC236}">
-                <a16:creationId xmlns:a16="http://schemas.microsoft.com/office/drawing/2014/main" id="{4DD24E0B-29C9-47EC-A9AD-67238F266E0B}"/>
+                <a16:creationId xmlns:a16="http://schemas.microsoft.com/office/drawing/2014/main" id="{779898CF-9CDF-4579-88FF-A66E1E6CF2C7}"/>
               </a:ext>
             </a:extLst>
           </p:cNvPr>
@@ -4014,7 +4014,7 @@
           <p:cNvPr id="3" name="">
             <a:extLst xmlns:a="http://schemas.openxmlformats.org/drawingml/2006/main">
               <a:ext uri="{FF2B5EF4-FFF2-40B4-BE49-F238E27FC236}">
-                <a16:creationId xmlns:a16="http://schemas.microsoft.com/office/drawing/2014/main" id="{EDA8114D-3B12-416D-B563-405760700000}"/>
+                <a16:creationId xmlns:a16="http://schemas.microsoft.com/office/drawing/2014/main" id="{5068C3AE-EA5C-4357-AE94-65A5DCD3DD12}"/>
               </a:ext>
             </a:extLst>
           </p:cNvPr>
@@ -4082,7 +4082,7 @@
           <p:cNvPr id="4" name="">
             <a:extLst xmlns:a="http://schemas.openxmlformats.org/drawingml/2006/main">
               <a:ext uri="{FF2B5EF4-FFF2-40B4-BE49-F238E27FC236}">
-                <a16:creationId xmlns:a16="http://schemas.microsoft.com/office/drawing/2014/main" id="{7B8CA8C1-AEEF-43C7-BC3F-53824E707CA5}"/>
+                <a16:creationId xmlns:a16="http://schemas.microsoft.com/office/drawing/2014/main" id="{1A01239D-7EE8-47DE-A39F-ED208DCD0D70}"/>
               </a:ext>
             </a:extLst>
           </p:cNvPr>
@@ -4178,7 +4178,7 @@
           <p:cNvPr id="5" name="">
             <a:extLst xmlns:a="http://schemas.openxmlformats.org/drawingml/2006/main">
               <a:ext uri="{FF2B5EF4-FFF2-40B4-BE49-F238E27FC236}">
-                <a16:creationId xmlns:a16="http://schemas.microsoft.com/office/drawing/2014/main" id="{4DC2C2B9-FC0C-4DEB-BD3F-7D8A7F555A69}"/>
+                <a16:creationId xmlns:a16="http://schemas.microsoft.com/office/drawing/2014/main" id="{08C930B4-D571-41C9-B1A6-341EBB797DF7}"/>
               </a:ext>
             </a:extLst>
           </p:cNvPr>
@@ -4292,7 +4292,7 @@
           <p:cNvPr id="6" name="">
             <a:extLst xmlns:a="http://schemas.openxmlformats.org/drawingml/2006/main">
               <a:ext uri="{FF2B5EF4-FFF2-40B4-BE49-F238E27FC236}">
-                <a16:creationId xmlns:a16="http://schemas.microsoft.com/office/drawing/2014/main" id="{8020D398-BE07-4165-BFC0-CDB2401502DD}"/>
+                <a16:creationId xmlns:a16="http://schemas.microsoft.com/office/drawing/2014/main" id="{FDB24098-E50C-4D1B-8A33-4328D8AEBBBD}"/>
               </a:ext>
             </a:extLst>
           </p:cNvPr>
@@ -4360,7 +4360,7 @@
           <p:cNvPr id="7" name="">
             <a:extLst xmlns:a="http://schemas.openxmlformats.org/drawingml/2006/main">
               <a:ext uri="{FF2B5EF4-FFF2-40B4-BE49-F238E27FC236}">
-                <a16:creationId xmlns:a16="http://schemas.microsoft.com/office/drawing/2014/main" id="{012477C9-20C7-4470-A44C-CB4D7DBF66A0}"/>
+                <a16:creationId xmlns:a16="http://schemas.microsoft.com/office/drawing/2014/main" id="{F4B7BDDB-0102-44DC-9E8B-418210E52FB1}"/>
               </a:ext>
             </a:extLst>
           </p:cNvPr>
@@ -4428,7 +4428,7 @@
           <p:cNvPr id="8" name="">
             <a:extLst xmlns:a="http://schemas.openxmlformats.org/drawingml/2006/main">
               <a:ext uri="{FF2B5EF4-FFF2-40B4-BE49-F238E27FC236}">
-                <a16:creationId xmlns:a16="http://schemas.microsoft.com/office/drawing/2014/main" id="{BCE48FB6-95A3-4ECD-86C8-191CFE0A8D14}"/>
+                <a16:creationId xmlns:a16="http://schemas.microsoft.com/office/drawing/2014/main" id="{F28E968A-3E8D-4177-83C5-173F8C4D48AE}"/>
               </a:ext>
             </a:extLst>
           </p:cNvPr>
@@ -4494,7 +4494,7 @@
     </p:spTree>
     <p:extLst>
       <p:ext uri="{BB962C8B-B14F-4D97-AF65-F5344CB8AC3E}">
-        <p14:creationId xmlns:p14="http://schemas.microsoft.com/office/powerpoint/2010/main" val="1188986536"/>
+        <p14:creationId xmlns:p14="http://schemas.microsoft.com/office/powerpoint/2010/main" val="2108096583"/>
       </p:ext>
     </p:extLst>
   </p:cSld>
@@ -4525,7 +4525,7 @@
           <p:cNvPr id="12" name="">
             <a:extLst xmlns:a="http://schemas.openxmlformats.org/drawingml/2006/main">
               <a:ext uri="{FF2B5EF4-FFF2-40B4-BE49-F238E27FC236}">
-                <a16:creationId xmlns:a16="http://schemas.microsoft.com/office/drawing/2014/main" id="{6F49246D-4CE8-4677-A522-68C2D18B34B0}"/>
+                <a16:creationId xmlns:a16="http://schemas.microsoft.com/office/drawing/2014/main" id="{39531F75-A950-4299-BEA7-BDCD4B352786}"/>
               </a:ext>
             </a:extLst>
           </p:cNvPr>
@@ -4593,7 +4593,7 @@
           <p:cNvPr id="2" name="">
             <a:extLst xmlns:a="http://schemas.openxmlformats.org/drawingml/2006/main">
               <a:ext uri="{FF2B5EF4-FFF2-40B4-BE49-F238E27FC236}">
-                <a16:creationId xmlns:a16="http://schemas.microsoft.com/office/drawing/2014/main" id="{9A1C87B0-ECDB-4A24-B1AB-E69434FD9BD5}"/>
+                <a16:creationId xmlns:a16="http://schemas.microsoft.com/office/drawing/2014/main" id="{EA66C464-6089-4974-A353-334FB0296DD5}"/>
               </a:ext>
             </a:extLst>
           </p:cNvPr>
@@ -4661,7 +4661,7 @@
           <p:cNvPr id="3" name="">
             <a:extLst xmlns:a="http://schemas.openxmlformats.org/drawingml/2006/main">
               <a:ext uri="{FF2B5EF4-FFF2-40B4-BE49-F238E27FC236}">
-                <a16:creationId xmlns:a16="http://schemas.microsoft.com/office/drawing/2014/main" id="{8E0E9E4B-BBE2-4C81-AF73-39FAD72D1902}"/>
+                <a16:creationId xmlns:a16="http://schemas.microsoft.com/office/drawing/2014/main" id="{1FE7D9C1-18A5-4DC1-949E-3B11D2E8FCA1}"/>
               </a:ext>
             </a:extLst>
           </p:cNvPr>
@@ -4729,7 +4729,7 @@
           <p:cNvPr id="4" name="">
             <a:extLst xmlns:a="http://schemas.openxmlformats.org/drawingml/2006/main">
               <a:ext uri="{FF2B5EF4-FFF2-40B4-BE49-F238E27FC236}">
-                <a16:creationId xmlns:a16="http://schemas.microsoft.com/office/drawing/2014/main" id="{4120606B-2884-46B8-A08C-9CC501CE7782}"/>
+                <a16:creationId xmlns:a16="http://schemas.microsoft.com/office/drawing/2014/main" id="{35487B5A-5A35-45D5-9B56-ADE79BD12D83}"/>
               </a:ext>
             </a:extLst>
           </p:cNvPr>
@@ -4853,7 +4853,7 @@
           <p:cNvPr id="5" name="">
             <a:extLst xmlns:a="http://schemas.openxmlformats.org/drawingml/2006/main">
               <a:ext uri="{FF2B5EF4-FFF2-40B4-BE49-F238E27FC236}">
-                <a16:creationId xmlns:a16="http://schemas.microsoft.com/office/drawing/2014/main" id="{E307F36B-2D76-44DD-AEA3-BA10C5DBED49}"/>
+                <a16:creationId xmlns:a16="http://schemas.microsoft.com/office/drawing/2014/main" id="{73980EF3-E21D-4316-9ABB-A6848110C197}"/>
               </a:ext>
             </a:extLst>
           </p:cNvPr>
@@ -4921,7 +4921,7 @@
           <p:cNvPr id="6" name="">
             <a:extLst xmlns:a="http://schemas.openxmlformats.org/drawingml/2006/main">
               <a:ext uri="{FF2B5EF4-FFF2-40B4-BE49-F238E27FC236}">
-                <a16:creationId xmlns:a16="http://schemas.microsoft.com/office/drawing/2014/main" id="{C0E439B0-F674-4F1A-863E-9BEE24B6C443}"/>
+                <a16:creationId xmlns:a16="http://schemas.microsoft.com/office/drawing/2014/main" id="{5AD38D46-9D1B-4D1E-A2D8-C40FD15F8D4B}"/>
               </a:ext>
             </a:extLst>
           </p:cNvPr>
@@ -4989,7 +4989,7 @@
           <p:cNvPr id="7" name="">
             <a:extLst xmlns:a="http://schemas.openxmlformats.org/drawingml/2006/main">
               <a:ext uri="{FF2B5EF4-FFF2-40B4-BE49-F238E27FC236}">
-                <a16:creationId xmlns:a16="http://schemas.microsoft.com/office/drawing/2014/main" id="{2673E7C0-B305-4823-B043-49A2F9BB4757}"/>
+                <a16:creationId xmlns:a16="http://schemas.microsoft.com/office/drawing/2014/main" id="{512A09EB-3204-4BC3-9A53-85FA96EF2EBC}"/>
               </a:ext>
             </a:extLst>
           </p:cNvPr>
@@ -5057,7 +5057,7 @@
           <p:cNvPr id="8" name="">
             <a:extLst xmlns:a="http://schemas.openxmlformats.org/drawingml/2006/main">
               <a:ext uri="{FF2B5EF4-FFF2-40B4-BE49-F238E27FC236}">
-                <a16:creationId xmlns:a16="http://schemas.microsoft.com/office/drawing/2014/main" id="{7CEB6524-7A45-4780-BB59-F299089EF725}"/>
+                <a16:creationId xmlns:a16="http://schemas.microsoft.com/office/drawing/2014/main" id="{81ABFC11-ED4C-4F24-B353-C5234EF150B7}"/>
               </a:ext>
             </a:extLst>
           </p:cNvPr>
@@ -5125,7 +5125,7 @@
           <p:cNvPr id="9" name="">
             <a:extLst xmlns:a="http://schemas.openxmlformats.org/drawingml/2006/main">
               <a:ext uri="{FF2B5EF4-FFF2-40B4-BE49-F238E27FC236}">
-                <a16:creationId xmlns:a16="http://schemas.microsoft.com/office/drawing/2014/main" id="{BA1D4BB8-215B-4AFA-ABBC-019D4A5AD2CB}"/>
+                <a16:creationId xmlns:a16="http://schemas.microsoft.com/office/drawing/2014/main" id="{30A5141C-1F5D-4FAD-A907-98958FC4A025}"/>
               </a:ext>
             </a:extLst>
           </p:cNvPr>
@@ -5193,7 +5193,7 @@
           <p:cNvPr id="10" name="">
             <a:extLst xmlns:a="http://schemas.openxmlformats.org/drawingml/2006/main">
               <a:ext uri="{FF2B5EF4-FFF2-40B4-BE49-F238E27FC236}">
-                <a16:creationId xmlns:a16="http://schemas.microsoft.com/office/drawing/2014/main" id="{7F458F21-4FA0-45B7-92B9-21A4D1D97377}"/>
+                <a16:creationId xmlns:a16="http://schemas.microsoft.com/office/drawing/2014/main" id="{0616CBC2-DE45-4193-B161-7D73D5C36CA6}"/>
               </a:ext>
             </a:extLst>
           </p:cNvPr>
@@ -5261,7 +5261,7 @@
           <p:cNvPr id="11" name="">
             <a:extLst xmlns:a="http://schemas.openxmlformats.org/drawingml/2006/main">
               <a:ext uri="{FF2B5EF4-FFF2-40B4-BE49-F238E27FC236}">
-                <a16:creationId xmlns:a16="http://schemas.microsoft.com/office/drawing/2014/main" id="{3A4F594A-CD67-491D-8B19-6E244FA66F12}"/>
+                <a16:creationId xmlns:a16="http://schemas.microsoft.com/office/drawing/2014/main" id="{9BD9D9FB-D621-4062-93BD-011BBEE1DB18}"/>
               </a:ext>
             </a:extLst>
           </p:cNvPr>
@@ -5327,7 +5327,7 @@
     </p:spTree>
     <p:extLst>
       <p:ext uri="{BB962C8B-B14F-4D97-AF65-F5344CB8AC3E}">
-        <p14:creationId xmlns:p14="http://schemas.microsoft.com/office/powerpoint/2010/main" val="154318173"/>
+        <p14:creationId xmlns:p14="http://schemas.microsoft.com/office/powerpoint/2010/main" val="1952412206"/>
       </p:ext>
     </p:extLst>
   </p:cSld>
@@ -5358,7 +5358,7 @@
           <p:cNvPr id="8" name="">
             <a:extLst xmlns:a="http://schemas.openxmlformats.org/drawingml/2006/main">
               <a:ext uri="{FF2B5EF4-FFF2-40B4-BE49-F238E27FC236}">
-                <a16:creationId xmlns:a16="http://schemas.microsoft.com/office/drawing/2014/main" id="{D19C2514-8B28-4027-AB22-BB2B74CB4174}"/>
+                <a16:creationId xmlns:a16="http://schemas.microsoft.com/office/drawing/2014/main" id="{500A5D3C-787D-4861-9E1F-8867FB98470F}"/>
               </a:ext>
             </a:extLst>
           </p:cNvPr>
@@ -5426,7 +5426,7 @@
           <p:cNvPr id="2" name="">
             <a:extLst xmlns:a="http://schemas.openxmlformats.org/drawingml/2006/main">
               <a:ext uri="{FF2B5EF4-FFF2-40B4-BE49-F238E27FC236}">
-                <a16:creationId xmlns:a16="http://schemas.microsoft.com/office/drawing/2014/main" id="{27837119-8C0E-4148-B367-652DE06F5F2E}"/>
+                <a16:creationId xmlns:a16="http://schemas.microsoft.com/office/drawing/2014/main" id="{7F1293DE-EF24-4496-BA2F-7FD1CBCB091B}"/>
               </a:ext>
             </a:extLst>
           </p:cNvPr>
@@ -5494,7 +5494,7 @@
           <p:cNvPr id="3" name="">
             <a:extLst xmlns:a="http://schemas.openxmlformats.org/drawingml/2006/main">
               <a:ext uri="{FF2B5EF4-FFF2-40B4-BE49-F238E27FC236}">
-                <a16:creationId xmlns:a16="http://schemas.microsoft.com/office/drawing/2014/main" id="{34E37C50-31BC-4D9B-AF63-D986344FA2ED}"/>
+                <a16:creationId xmlns:a16="http://schemas.microsoft.com/office/drawing/2014/main" id="{DDAAD593-6AE8-4B57-B943-0079DB4AFF0E}"/>
               </a:ext>
             </a:extLst>
           </p:cNvPr>
@@ -5562,7 +5562,7 @@
           <p:cNvPr id="4" name="">
             <a:extLst xmlns:a="http://schemas.openxmlformats.org/drawingml/2006/main">
               <a:ext uri="{FF2B5EF4-FFF2-40B4-BE49-F238E27FC236}">
-                <a16:creationId xmlns:a16="http://schemas.microsoft.com/office/drawing/2014/main" id="{57E43547-52A6-45D2-903B-5B66D2709E8E}"/>
+                <a16:creationId xmlns:a16="http://schemas.microsoft.com/office/drawing/2014/main" id="{6E179EF5-37FE-40AB-839F-FA70A74586BD}"/>
               </a:ext>
             </a:extLst>
           </p:cNvPr>
@@ -5686,7 +5686,7 @@
           <p:cNvPr id="5" name="">
             <a:extLst xmlns:a="http://schemas.openxmlformats.org/drawingml/2006/main">
               <a:ext uri="{FF2B5EF4-FFF2-40B4-BE49-F238E27FC236}">
-                <a16:creationId xmlns:a16="http://schemas.microsoft.com/office/drawing/2014/main" id="{3C635996-97B1-42A2-819D-E6EDCD4ADC3C}"/>
+                <a16:creationId xmlns:a16="http://schemas.microsoft.com/office/drawing/2014/main" id="{4BA7A842-D709-454E-BC99-8410C65B0839}"/>
               </a:ext>
             </a:extLst>
           </p:cNvPr>
@@ -5754,7 +5754,7 @@
           <p:cNvPr id="6" name="">
             <a:extLst xmlns:a="http://schemas.openxmlformats.org/drawingml/2006/main">
               <a:ext uri="{FF2B5EF4-FFF2-40B4-BE49-F238E27FC236}">
-                <a16:creationId xmlns:a16="http://schemas.microsoft.com/office/drawing/2014/main" id="{60801E96-3D81-4F65-B226-CC1613B5962C}"/>
+                <a16:creationId xmlns:a16="http://schemas.microsoft.com/office/drawing/2014/main" id="{4807904A-62D3-4F9B-9FFF-F19A087BB1B9}"/>
               </a:ext>
             </a:extLst>
           </p:cNvPr>
@@ -5822,7 +5822,7 @@
           <p:cNvPr id="7" name="">
             <a:extLst xmlns:a="http://schemas.openxmlformats.org/drawingml/2006/main">
               <a:ext uri="{FF2B5EF4-FFF2-40B4-BE49-F238E27FC236}">
-                <a16:creationId xmlns:a16="http://schemas.microsoft.com/office/drawing/2014/main" id="{24183C01-1534-42FD-A09D-3C6E643E51A1}"/>
+                <a16:creationId xmlns:a16="http://schemas.microsoft.com/office/drawing/2014/main" id="{06A4ECCE-A31B-426C-9C7A-0ED1A9DFE291}"/>
               </a:ext>
             </a:extLst>
           </p:cNvPr>
@@ -5888,7 +5888,7 @@
     </p:spTree>
     <p:extLst>
       <p:ext uri="{BB962C8B-B14F-4D97-AF65-F5344CB8AC3E}">
-        <p14:creationId xmlns:p14="http://schemas.microsoft.com/office/powerpoint/2010/main" val="1478658094"/>
+        <p14:creationId xmlns:p14="http://schemas.microsoft.com/office/powerpoint/2010/main" val="1846074831"/>
       </p:ext>
     </p:extLst>
   </p:cSld>
@@ -5919,7 +5919,7 @@
           <p:cNvPr id="11" name="">
             <a:extLst xmlns:a="http://schemas.openxmlformats.org/drawingml/2006/main">
               <a:ext uri="{FF2B5EF4-FFF2-40B4-BE49-F238E27FC236}">
-                <a16:creationId xmlns:a16="http://schemas.microsoft.com/office/drawing/2014/main" id="{C83B53A6-17C0-4412-848C-0AEB5BC75CAE}"/>
+                <a16:creationId xmlns:a16="http://schemas.microsoft.com/office/drawing/2014/main" id="{87C2D18F-9F3D-438B-8294-3FF7F3CC6EEF}"/>
               </a:ext>
             </a:extLst>
           </p:cNvPr>
@@ -5987,7 +5987,7 @@
           <p:cNvPr id="2" name="">
             <a:extLst xmlns:a="http://schemas.openxmlformats.org/drawingml/2006/main">
               <a:ext uri="{FF2B5EF4-FFF2-40B4-BE49-F238E27FC236}">
-                <a16:creationId xmlns:a16="http://schemas.microsoft.com/office/drawing/2014/main" id="{9C03310C-543C-4337-B015-AC24D91CA7A6}"/>
+                <a16:creationId xmlns:a16="http://schemas.microsoft.com/office/drawing/2014/main" id="{3FEB353D-C4A6-429C-8067-65F6C71B0E76}"/>
               </a:ext>
             </a:extLst>
           </p:cNvPr>
@@ -6055,7 +6055,7 @@
           <p:cNvPr id="3" name="">
             <a:extLst xmlns:a="http://schemas.openxmlformats.org/drawingml/2006/main">
               <a:ext uri="{FF2B5EF4-FFF2-40B4-BE49-F238E27FC236}">
-                <a16:creationId xmlns:a16="http://schemas.microsoft.com/office/drawing/2014/main" id="{D9E1E726-86BF-45A8-8D57-91C0449CB809}"/>
+                <a16:creationId xmlns:a16="http://schemas.microsoft.com/office/drawing/2014/main" id="{9BCD2C4F-9C4B-4216-B1A5-18B307637C4D}"/>
               </a:ext>
             </a:extLst>
           </p:cNvPr>
@@ -6123,7 +6123,7 @@
           <p:cNvPr id="4" name="">
             <a:extLst xmlns:a="http://schemas.openxmlformats.org/drawingml/2006/main">
               <a:ext uri="{FF2B5EF4-FFF2-40B4-BE49-F238E27FC236}">
-                <a16:creationId xmlns:a16="http://schemas.microsoft.com/office/drawing/2014/main" id="{84B8CF3B-CBF2-4A51-8B7F-91CAF08183C6}"/>
+                <a16:creationId xmlns:a16="http://schemas.microsoft.com/office/drawing/2014/main" id="{76FDB32A-F3F0-4202-971E-B5C21A97510B}"/>
               </a:ext>
             </a:extLst>
           </p:cNvPr>
@@ -6247,7 +6247,7 @@
           <p:cNvPr id="5" name="">
             <a:extLst xmlns:a="http://schemas.openxmlformats.org/drawingml/2006/main">
               <a:ext uri="{FF2B5EF4-FFF2-40B4-BE49-F238E27FC236}">
-                <a16:creationId xmlns:a16="http://schemas.microsoft.com/office/drawing/2014/main" id="{67142608-BEC1-48C9-AE76-B9F4436BEEC3}"/>
+                <a16:creationId xmlns:a16="http://schemas.microsoft.com/office/drawing/2014/main" id="{3E126D8B-5D37-4C5E-9C2E-8AA5966F3496}"/>
               </a:ext>
             </a:extLst>
           </p:cNvPr>
@@ -6315,7 +6315,7 @@
           <p:cNvPr id="6" name="">
             <a:extLst xmlns:a="http://schemas.openxmlformats.org/drawingml/2006/main">
               <a:ext uri="{FF2B5EF4-FFF2-40B4-BE49-F238E27FC236}">
-                <a16:creationId xmlns:a16="http://schemas.microsoft.com/office/drawing/2014/main" id="{B01C6668-E495-4826-96CF-9FEC93E84BCE}"/>
+                <a16:creationId xmlns:a16="http://schemas.microsoft.com/office/drawing/2014/main" id="{C6E40EAD-836C-4AA2-930A-B03AE2FC38CA}"/>
               </a:ext>
             </a:extLst>
           </p:cNvPr>
@@ -6383,7 +6383,7 @@
           <p:cNvPr id="7" name="">
             <a:extLst xmlns:a="http://schemas.openxmlformats.org/drawingml/2006/main">
               <a:ext uri="{FF2B5EF4-FFF2-40B4-BE49-F238E27FC236}">
-                <a16:creationId xmlns:a16="http://schemas.microsoft.com/office/drawing/2014/main" id="{9A5E148B-F04A-42B5-A578-46B94FD0E554}"/>
+                <a16:creationId xmlns:a16="http://schemas.microsoft.com/office/drawing/2014/main" id="{61A663C5-05E6-4D00-8667-C9E34149BDF4}"/>
               </a:ext>
             </a:extLst>
           </p:cNvPr>
@@ -6451,7 +6451,7 @@
           <p:cNvPr id="8" name="">
             <a:extLst xmlns:a="http://schemas.openxmlformats.org/drawingml/2006/main">
               <a:ext uri="{FF2B5EF4-FFF2-40B4-BE49-F238E27FC236}">
-                <a16:creationId xmlns:a16="http://schemas.microsoft.com/office/drawing/2014/main" id="{E2A76293-824C-4793-A2E0-66F38FE01970}"/>
+                <a16:creationId xmlns:a16="http://schemas.microsoft.com/office/drawing/2014/main" id="{98126D35-D9CA-4DCD-B056-BD8955325FD8}"/>
               </a:ext>
             </a:extLst>
           </p:cNvPr>
@@ -6519,7 +6519,7 @@
           <p:cNvPr id="9" name="">
             <a:extLst xmlns:a="http://schemas.openxmlformats.org/drawingml/2006/main">
               <a:ext uri="{FF2B5EF4-FFF2-40B4-BE49-F238E27FC236}">
-                <a16:creationId xmlns:a16="http://schemas.microsoft.com/office/drawing/2014/main" id="{D31161B3-75DB-46C5-9DAD-BC46F066017F}"/>
+                <a16:creationId xmlns:a16="http://schemas.microsoft.com/office/drawing/2014/main" id="{7A914C8B-741F-42B3-9F0B-D1C05488C79E}"/>
               </a:ext>
             </a:extLst>
           </p:cNvPr>
@@ -6587,7 +6587,7 @@
           <p:cNvPr id="10" name="">
             <a:extLst xmlns:a="http://schemas.openxmlformats.org/drawingml/2006/main">
               <a:ext uri="{FF2B5EF4-FFF2-40B4-BE49-F238E27FC236}">
-                <a16:creationId xmlns:a16="http://schemas.microsoft.com/office/drawing/2014/main" id="{C57C9EED-3D6B-4395-B384-A235A93783A2}"/>
+                <a16:creationId xmlns:a16="http://schemas.microsoft.com/office/drawing/2014/main" id="{1B77FF05-DF1A-4720-B162-180FA7DEFA13}"/>
               </a:ext>
             </a:extLst>
           </p:cNvPr>
@@ -6653,7 +6653,7 @@
     </p:spTree>
     <p:extLst>
       <p:ext uri="{BB962C8B-B14F-4D97-AF65-F5344CB8AC3E}">
-        <p14:creationId xmlns:p14="http://schemas.microsoft.com/office/powerpoint/2010/main" val="1969159751"/>
+        <p14:creationId xmlns:p14="http://schemas.microsoft.com/office/powerpoint/2010/main" val="138485540"/>
       </p:ext>
     </p:extLst>
   </p:cSld>
@@ -6684,7 +6684,7 @@
           <p:cNvPr id="6" name="">
             <a:extLst xmlns:a="http://schemas.openxmlformats.org/drawingml/2006/main">
               <a:ext uri="{FF2B5EF4-FFF2-40B4-BE49-F238E27FC236}">
-                <a16:creationId xmlns:a16="http://schemas.microsoft.com/office/drawing/2014/main" id="{CAFE85A9-AB66-4B7B-A666-A32811917981}"/>
+                <a16:creationId xmlns:a16="http://schemas.microsoft.com/office/drawing/2014/main" id="{9574343B-6DD0-4F0A-A59B-7A3DD85517D4}"/>
               </a:ext>
             </a:extLst>
           </p:cNvPr>
@@ -6752,7 +6752,7 @@
           <p:cNvPr id="2" name="">
             <a:extLst xmlns:a="http://schemas.openxmlformats.org/drawingml/2006/main">
               <a:ext uri="{FF2B5EF4-FFF2-40B4-BE49-F238E27FC236}">
-                <a16:creationId xmlns:a16="http://schemas.microsoft.com/office/drawing/2014/main" id="{6F20E1EA-A066-4C81-AF46-E97FFE59E65E}"/>
+                <a16:creationId xmlns:a16="http://schemas.microsoft.com/office/drawing/2014/main" id="{C6AA506D-C55E-46D4-9B58-D86DD1CA05E7}"/>
               </a:ext>
             </a:extLst>
           </p:cNvPr>
@@ -6820,7 +6820,7 @@
           <p:cNvPr id="3" name="">
             <a:extLst xmlns:a="http://schemas.openxmlformats.org/drawingml/2006/main">
               <a:ext uri="{FF2B5EF4-FFF2-40B4-BE49-F238E27FC236}">
-                <a16:creationId xmlns:a16="http://schemas.microsoft.com/office/drawing/2014/main" id="{8BF4E565-94A9-4B6A-8074-2465F61785EE}"/>
+                <a16:creationId xmlns:a16="http://schemas.microsoft.com/office/drawing/2014/main" id="{06240119-8C4D-4349-9F4C-113B3366DF80}"/>
               </a:ext>
             </a:extLst>
           </p:cNvPr>
@@ -6888,7 +6888,7 @@
           <p:cNvPr id="4" name="">
             <a:extLst xmlns:a="http://schemas.openxmlformats.org/drawingml/2006/main">
               <a:ext uri="{FF2B5EF4-FFF2-40B4-BE49-F238E27FC236}">
-                <a16:creationId xmlns:a16="http://schemas.microsoft.com/office/drawing/2014/main" id="{D688F3C3-709C-4526-9545-724D3D1622CD}"/>
+                <a16:creationId xmlns:a16="http://schemas.microsoft.com/office/drawing/2014/main" id="{1ED66507-169D-44B8-8B76-4B632D9B6830}"/>
               </a:ext>
             </a:extLst>
           </p:cNvPr>
@@ -7012,7 +7012,7 @@
           <p:cNvPr id="5" name="">
             <a:extLst xmlns:a="http://schemas.openxmlformats.org/drawingml/2006/main">
               <a:ext uri="{FF2B5EF4-FFF2-40B4-BE49-F238E27FC236}">
-                <a16:creationId xmlns:a16="http://schemas.microsoft.com/office/drawing/2014/main" id="{2BFEF468-E6C6-45A6-92C1-1DC2C0FEB804}"/>
+                <a16:creationId xmlns:a16="http://schemas.microsoft.com/office/drawing/2014/main" id="{7D19F08A-FC5A-4A97-A685-CEE8564F6E91}"/>
               </a:ext>
             </a:extLst>
           </p:cNvPr>
@@ -7078,7 +7078,7 @@
     </p:spTree>
     <p:extLst>
       <p:ext uri="{BB962C8B-B14F-4D97-AF65-F5344CB8AC3E}">
-        <p14:creationId xmlns:p14="http://schemas.microsoft.com/office/powerpoint/2010/main" val="1644650910"/>
+        <p14:creationId xmlns:p14="http://schemas.microsoft.com/office/powerpoint/2010/main" val="149329885"/>
       </p:ext>
     </p:extLst>
   </p:cSld>
@@ -7109,7 +7109,7 @@
           <p:cNvPr id="8" name="">
             <a:extLst xmlns:a="http://schemas.openxmlformats.org/drawingml/2006/main">
               <a:ext uri="{FF2B5EF4-FFF2-40B4-BE49-F238E27FC236}">
-                <a16:creationId xmlns:a16="http://schemas.microsoft.com/office/drawing/2014/main" id="{27B22081-F95A-466B-85A8-78542B6F6E2F}"/>
+                <a16:creationId xmlns:a16="http://schemas.microsoft.com/office/drawing/2014/main" id="{887D241D-EA6C-4795-9675-ADF805A747C2}"/>
               </a:ext>
             </a:extLst>
           </p:cNvPr>
@@ -7177,7 +7177,7 @@
           <p:cNvPr id="2" name="">
             <a:extLst xmlns:a="http://schemas.openxmlformats.org/drawingml/2006/main">
               <a:ext uri="{FF2B5EF4-FFF2-40B4-BE49-F238E27FC236}">
-                <a16:creationId xmlns:a16="http://schemas.microsoft.com/office/drawing/2014/main" id="{FC826D0C-D165-46EF-B665-5759ABCC9AA6}"/>
+                <a16:creationId xmlns:a16="http://schemas.microsoft.com/office/drawing/2014/main" id="{A9677206-97E1-4E5B-92A2-2BB56A75BF46}"/>
               </a:ext>
             </a:extLst>
           </p:cNvPr>
@@ -7245,7 +7245,7 @@
           <p:cNvPr id="3" name="">
             <a:extLst xmlns:a="http://schemas.openxmlformats.org/drawingml/2006/main">
               <a:ext uri="{FF2B5EF4-FFF2-40B4-BE49-F238E27FC236}">
-                <a16:creationId xmlns:a16="http://schemas.microsoft.com/office/drawing/2014/main" id="{BA8DABB8-B774-4571-B0A3-721AB2D8260A}"/>
+                <a16:creationId xmlns:a16="http://schemas.microsoft.com/office/drawing/2014/main" id="{29426998-F01F-478A-8BAB-4CAC9723D515}"/>
               </a:ext>
             </a:extLst>
           </p:cNvPr>
@@ -7313,7 +7313,7 @@
           <p:cNvPr id="4" name="">
             <a:extLst xmlns:a="http://schemas.openxmlformats.org/drawingml/2006/main">
               <a:ext uri="{FF2B5EF4-FFF2-40B4-BE49-F238E27FC236}">
-                <a16:creationId xmlns:a16="http://schemas.microsoft.com/office/drawing/2014/main" id="{1962C0DE-AA10-4741-8AD8-A09FF7E9AA56}"/>
+                <a16:creationId xmlns:a16="http://schemas.microsoft.com/office/drawing/2014/main" id="{224CE3ED-9F79-41FF-BB14-628811A79091}"/>
               </a:ext>
             </a:extLst>
           </p:cNvPr>
@@ -7381,7 +7381,7 @@
           <p:cNvPr id="5" name="">
             <a:extLst xmlns:a="http://schemas.openxmlformats.org/drawingml/2006/main">
               <a:ext uri="{FF2B5EF4-FFF2-40B4-BE49-F238E27FC236}">
-                <a16:creationId xmlns:a16="http://schemas.microsoft.com/office/drawing/2014/main" id="{520D0521-1183-4834-BAF0-7A8DFD8ACC2B}"/>
+                <a16:creationId xmlns:a16="http://schemas.microsoft.com/office/drawing/2014/main" id="{268A55B6-A1D5-4159-94C0-CEAA010161FE}"/>
               </a:ext>
             </a:extLst>
           </p:cNvPr>
@@ -7449,7 +7449,7 @@
           <p:cNvPr id="6" name="">
             <a:extLst xmlns:a="http://schemas.openxmlformats.org/drawingml/2006/main">
               <a:ext uri="{FF2B5EF4-FFF2-40B4-BE49-F238E27FC236}">
-                <a16:creationId xmlns:a16="http://schemas.microsoft.com/office/drawing/2014/main" id="{A5FB029F-F246-4533-9916-D0DE7CF423CC}"/>
+                <a16:creationId xmlns:a16="http://schemas.microsoft.com/office/drawing/2014/main" id="{E679E774-8A7F-4ADB-A200-DCBAE1A72477}"/>
               </a:ext>
             </a:extLst>
           </p:cNvPr>
@@ -7573,7 +7573,7 @@
           <p:cNvPr id="7" name="">
             <a:extLst xmlns:a="http://schemas.openxmlformats.org/drawingml/2006/main">
               <a:ext uri="{FF2B5EF4-FFF2-40B4-BE49-F238E27FC236}">
-                <a16:creationId xmlns:a16="http://schemas.microsoft.com/office/drawing/2014/main" id="{24E442BC-DF9B-4DFB-AD5E-D54BC98324E9}"/>
+                <a16:creationId xmlns:a16="http://schemas.microsoft.com/office/drawing/2014/main" id="{78238A65-3D5C-424C-9214-D012AD9B0381}"/>
               </a:ext>
             </a:extLst>
           </p:cNvPr>
@@ -7639,7 +7639,7 @@
     </p:spTree>
     <p:extLst>
       <p:ext uri="{BB962C8B-B14F-4D97-AF65-F5344CB8AC3E}">
-        <p14:creationId xmlns:p14="http://schemas.microsoft.com/office/powerpoint/2010/main" val="1361026460"/>
+        <p14:creationId xmlns:p14="http://schemas.microsoft.com/office/powerpoint/2010/main" val="1481255632"/>
       </p:ext>
     </p:extLst>
   </p:cSld>
@@ -7670,7 +7670,7 @@
           <p:cNvPr id="7" name="">
             <a:extLst xmlns:a="http://schemas.openxmlformats.org/drawingml/2006/main">
               <a:ext uri="{FF2B5EF4-FFF2-40B4-BE49-F238E27FC236}">
-                <a16:creationId xmlns:a16="http://schemas.microsoft.com/office/drawing/2014/main" id="{BAEC5D9A-C607-4341-9258-656CEAE5EF4F}"/>
+                <a16:creationId xmlns:a16="http://schemas.microsoft.com/office/drawing/2014/main" id="{442BC8BB-190F-45E9-A9B0-FA6083096F63}"/>
               </a:ext>
             </a:extLst>
           </p:cNvPr>
@@ -7738,7 +7738,7 @@
           <p:cNvPr id="2" name="">
             <a:extLst xmlns:a="http://schemas.openxmlformats.org/drawingml/2006/main">
               <a:ext uri="{FF2B5EF4-FFF2-40B4-BE49-F238E27FC236}">
-                <a16:creationId xmlns:a16="http://schemas.microsoft.com/office/drawing/2014/main" id="{9E5D3662-B7E3-425C-A949-79B3DF62702D}"/>
+                <a16:creationId xmlns:a16="http://schemas.microsoft.com/office/drawing/2014/main" id="{E9AB0529-52B4-4CCB-AD90-6BC6148535E9}"/>
               </a:ext>
             </a:extLst>
           </p:cNvPr>
@@ -7806,7 +7806,7 @@
           <p:cNvPr id="3" name="">
             <a:extLst xmlns:a="http://schemas.openxmlformats.org/drawingml/2006/main">
               <a:ext uri="{FF2B5EF4-FFF2-40B4-BE49-F238E27FC236}">
-                <a16:creationId xmlns:a16="http://schemas.microsoft.com/office/drawing/2014/main" id="{81D07F14-512B-47BD-B75D-6A2093656776}"/>
+                <a16:creationId xmlns:a16="http://schemas.microsoft.com/office/drawing/2014/main" id="{7A87DE3B-7941-4AD7-9837-501567DB13CF}"/>
               </a:ext>
             </a:extLst>
           </p:cNvPr>
@@ -7874,7 +7874,7 @@
           <p:cNvPr id="4" name="">
             <a:extLst xmlns:a="http://schemas.openxmlformats.org/drawingml/2006/main">
               <a:ext uri="{FF2B5EF4-FFF2-40B4-BE49-F238E27FC236}">
-                <a16:creationId xmlns:a16="http://schemas.microsoft.com/office/drawing/2014/main" id="{37897BCD-95A7-4343-8D0C-529F28FD2E7E}"/>
+                <a16:creationId xmlns:a16="http://schemas.microsoft.com/office/drawing/2014/main" id="{1830D3A5-C9EA-4AC4-A9FF-407E798B1A22}"/>
               </a:ext>
             </a:extLst>
           </p:cNvPr>
@@ -7998,7 +7998,7 @@
           <p:cNvPr id="5" name="">
             <a:extLst xmlns:a="http://schemas.openxmlformats.org/drawingml/2006/main">
               <a:ext uri="{FF2B5EF4-FFF2-40B4-BE49-F238E27FC236}">
-                <a16:creationId xmlns:a16="http://schemas.microsoft.com/office/drawing/2014/main" id="{8B8DE4C8-CBCB-4B4A-AB93-2653516E2940}"/>
+                <a16:creationId xmlns:a16="http://schemas.microsoft.com/office/drawing/2014/main" id="{6ABB4A15-A069-4372-939D-DF1115F6BDDE}"/>
               </a:ext>
             </a:extLst>
           </p:cNvPr>
@@ -8066,7 +8066,7 @@
           <p:cNvPr id="6" name="">
             <a:extLst xmlns:a="http://schemas.openxmlformats.org/drawingml/2006/main">
               <a:ext uri="{FF2B5EF4-FFF2-40B4-BE49-F238E27FC236}">
-                <a16:creationId xmlns:a16="http://schemas.microsoft.com/office/drawing/2014/main" id="{5AE9B229-F34C-4F40-B745-FA5836A4DB2E}"/>
+                <a16:creationId xmlns:a16="http://schemas.microsoft.com/office/drawing/2014/main" id="{4594AC1B-35CD-45BF-BEBE-A78280E69B8B}"/>
               </a:ext>
             </a:extLst>
           </p:cNvPr>
@@ -8132,7 +8132,7 @@
     </p:spTree>
     <p:extLst>
       <p:ext uri="{BB962C8B-B14F-4D97-AF65-F5344CB8AC3E}">
-        <p14:creationId xmlns:p14="http://schemas.microsoft.com/office/powerpoint/2010/main" val="869320740"/>
+        <p14:creationId xmlns:p14="http://schemas.microsoft.com/office/powerpoint/2010/main" val="550895560"/>
       </p:ext>
     </p:extLst>
   </p:cSld>
@@ -8163,7 +8163,7 @@
           <p:cNvPr id="6" name="">
             <a:extLst xmlns:a="http://schemas.openxmlformats.org/drawingml/2006/main">
               <a:ext uri="{FF2B5EF4-FFF2-40B4-BE49-F238E27FC236}">
-                <a16:creationId xmlns:a16="http://schemas.microsoft.com/office/drawing/2014/main" id="{882D0F9A-6BAF-4F19-847D-E8A337F7B792}"/>
+                <a16:creationId xmlns:a16="http://schemas.microsoft.com/office/drawing/2014/main" id="{ED8FB0BC-3E04-4959-9CE3-213D090B6AFE}"/>
               </a:ext>
             </a:extLst>
           </p:cNvPr>
@@ -8231,7 +8231,7 @@
           <p:cNvPr id="2" name="">
             <a:extLst xmlns:a="http://schemas.openxmlformats.org/drawingml/2006/main">
               <a:ext uri="{FF2B5EF4-FFF2-40B4-BE49-F238E27FC236}">
-                <a16:creationId xmlns:a16="http://schemas.microsoft.com/office/drawing/2014/main" id="{A41EAAC2-BA96-4A06-B3BF-254D43F73DDD}"/>
+                <a16:creationId xmlns:a16="http://schemas.microsoft.com/office/drawing/2014/main" id="{66502EB8-6F83-4E48-87FD-F971D7715600}"/>
               </a:ext>
             </a:extLst>
           </p:cNvPr>
@@ -8299,7 +8299,7 @@
           <p:cNvPr id="3" name="">
             <a:extLst xmlns:a="http://schemas.openxmlformats.org/drawingml/2006/main">
               <a:ext uri="{FF2B5EF4-FFF2-40B4-BE49-F238E27FC236}">
-                <a16:creationId xmlns:a16="http://schemas.microsoft.com/office/drawing/2014/main" id="{D5F5F872-1E2B-4484-B286-C5C811D4DC4A}"/>
+                <a16:creationId xmlns:a16="http://schemas.microsoft.com/office/drawing/2014/main" id="{7A07CA31-5FBC-48F5-A9B3-22963DC27E20}"/>
               </a:ext>
             </a:extLst>
           </p:cNvPr>
@@ -8367,7 +8367,7 @@
           <p:cNvPr id="4" name="">
             <a:extLst xmlns:a="http://schemas.openxmlformats.org/drawingml/2006/main">
               <a:ext uri="{FF2B5EF4-FFF2-40B4-BE49-F238E27FC236}">
-                <a16:creationId xmlns:a16="http://schemas.microsoft.com/office/drawing/2014/main" id="{B84A417B-F18A-422B-8AFA-A851B16A601E}"/>
+                <a16:creationId xmlns:a16="http://schemas.microsoft.com/office/drawing/2014/main" id="{C6AC3C25-3389-40AB-AB2C-B3209CD5EF24}"/>
               </a:ext>
             </a:extLst>
           </p:cNvPr>
@@ -8491,7 +8491,7 @@
           <p:cNvPr id="5" name="">
             <a:extLst xmlns:a="http://schemas.openxmlformats.org/drawingml/2006/main">
               <a:ext uri="{FF2B5EF4-FFF2-40B4-BE49-F238E27FC236}">
-                <a16:creationId xmlns:a16="http://schemas.microsoft.com/office/drawing/2014/main" id="{C7F26342-06D5-48CF-94F9-DB4E33B46F15}"/>
+                <a16:creationId xmlns:a16="http://schemas.microsoft.com/office/drawing/2014/main" id="{28F56F4B-FEE6-45AA-8333-54E1553E9855}"/>
               </a:ext>
             </a:extLst>
           </p:cNvPr>
@@ -8557,7 +8557,7 @@
     </p:spTree>
     <p:extLst>
       <p:ext uri="{BB962C8B-B14F-4D97-AF65-F5344CB8AC3E}">
-        <p14:creationId xmlns:p14="http://schemas.microsoft.com/office/powerpoint/2010/main" val="130659529"/>
+        <p14:creationId xmlns:p14="http://schemas.microsoft.com/office/powerpoint/2010/main" val="989532036"/>
       </p:ext>
     </p:extLst>
   </p:cSld>
@@ -8588,7 +8588,7 @@
           <p:cNvPr id="9" name="">
             <a:extLst xmlns:a="http://schemas.openxmlformats.org/drawingml/2006/main">
               <a:ext uri="{FF2B5EF4-FFF2-40B4-BE49-F238E27FC236}">
-                <a16:creationId xmlns:a16="http://schemas.microsoft.com/office/drawing/2014/main" id="{23104528-0CCC-46E5-AE78-680ED11B7329}"/>
+                <a16:creationId xmlns:a16="http://schemas.microsoft.com/office/drawing/2014/main" id="{78B3C602-2D18-4BDB-BF0F-E9346B669C74}"/>
               </a:ext>
             </a:extLst>
           </p:cNvPr>
@@ -8656,7 +8656,7 @@
           <p:cNvPr id="2" name="">
             <a:extLst xmlns:a="http://schemas.openxmlformats.org/drawingml/2006/main">
               <a:ext uri="{FF2B5EF4-FFF2-40B4-BE49-F238E27FC236}">
-                <a16:creationId xmlns:a16="http://schemas.microsoft.com/office/drawing/2014/main" id="{561D4B83-04AA-4963-BE41-B0059E44879C}"/>
+                <a16:creationId xmlns:a16="http://schemas.microsoft.com/office/drawing/2014/main" id="{391054C5-B731-4C74-9DFC-AE4BDC1D420F}"/>
               </a:ext>
             </a:extLst>
           </p:cNvPr>
@@ -8724,7 +8724,7 @@
           <p:cNvPr id="3" name="">
             <a:extLst xmlns:a="http://schemas.openxmlformats.org/drawingml/2006/main">
               <a:ext uri="{FF2B5EF4-FFF2-40B4-BE49-F238E27FC236}">
-                <a16:creationId xmlns:a16="http://schemas.microsoft.com/office/drawing/2014/main" id="{403DDF65-83B5-4C41-A222-166A03C9D0A1}"/>
+                <a16:creationId xmlns:a16="http://schemas.microsoft.com/office/drawing/2014/main" id="{45C114CD-88EC-4EBC-8620-565C90729FF6}"/>
               </a:ext>
             </a:extLst>
           </p:cNvPr>
@@ -8792,7 +8792,7 @@
           <p:cNvPr id="4" name="">
             <a:extLst xmlns:a="http://schemas.openxmlformats.org/drawingml/2006/main">
               <a:ext uri="{FF2B5EF4-FFF2-40B4-BE49-F238E27FC236}">
-                <a16:creationId xmlns:a16="http://schemas.microsoft.com/office/drawing/2014/main" id="{E0C479F0-9EE1-4B4F-B44C-EEF85329D70F}"/>
+                <a16:creationId xmlns:a16="http://schemas.microsoft.com/office/drawing/2014/main" id="{5263ABAF-6BAF-463F-8198-BF9945EC0E48}"/>
               </a:ext>
             </a:extLst>
           </p:cNvPr>
@@ -8916,7 +8916,7 @@
           <p:cNvPr id="5" name="">
             <a:extLst xmlns:a="http://schemas.openxmlformats.org/drawingml/2006/main">
               <a:ext uri="{FF2B5EF4-FFF2-40B4-BE49-F238E27FC236}">
-                <a16:creationId xmlns:a16="http://schemas.microsoft.com/office/drawing/2014/main" id="{9BFC878B-9549-4613-B0E1-3E9680A03864}"/>
+                <a16:creationId xmlns:a16="http://schemas.microsoft.com/office/drawing/2014/main" id="{0F8EF9E3-44EA-4BAE-B4E8-8A6CAF1374CD}"/>
               </a:ext>
             </a:extLst>
           </p:cNvPr>
@@ -8984,7 +8984,7 @@
           <p:cNvPr id="6" name="">
             <a:extLst xmlns:a="http://schemas.openxmlformats.org/drawingml/2006/main">
               <a:ext uri="{FF2B5EF4-FFF2-40B4-BE49-F238E27FC236}">
-                <a16:creationId xmlns:a16="http://schemas.microsoft.com/office/drawing/2014/main" id="{119C634B-9940-44DB-A793-BADA46DBA4B9}"/>
+                <a16:creationId xmlns:a16="http://schemas.microsoft.com/office/drawing/2014/main" id="{115F4E39-EA08-4F27-81E8-7ABFD4FBBCFC}"/>
               </a:ext>
             </a:extLst>
           </p:cNvPr>
@@ -9052,7 +9052,7 @@
           <p:cNvPr id="7" name="">
             <a:extLst xmlns:a="http://schemas.openxmlformats.org/drawingml/2006/main">
               <a:ext uri="{FF2B5EF4-FFF2-40B4-BE49-F238E27FC236}">
-                <a16:creationId xmlns:a16="http://schemas.microsoft.com/office/drawing/2014/main" id="{8E1420D3-07FC-4C8D-86B8-A6F3B6F933E0}"/>
+                <a16:creationId xmlns:a16="http://schemas.microsoft.com/office/drawing/2014/main" id="{ED3D4719-76A3-47F2-8993-AF881C4D19D9}"/>
               </a:ext>
             </a:extLst>
           </p:cNvPr>
@@ -9120,7 +9120,7 @@
           <p:cNvPr id="8" name="">
             <a:extLst xmlns:a="http://schemas.openxmlformats.org/drawingml/2006/main">
               <a:ext uri="{FF2B5EF4-FFF2-40B4-BE49-F238E27FC236}">
-                <a16:creationId xmlns:a16="http://schemas.microsoft.com/office/drawing/2014/main" id="{A1D11365-F75C-4A17-B03B-8CC5F9053DAE}"/>
+                <a16:creationId xmlns:a16="http://schemas.microsoft.com/office/drawing/2014/main" id="{A3210042-BE72-4A14-A89A-758F1FBDEA00}"/>
               </a:ext>
             </a:extLst>
           </p:cNvPr>
@@ -9186,7 +9186,7 @@
     </p:spTree>
     <p:extLst>
       <p:ext uri="{BB962C8B-B14F-4D97-AF65-F5344CB8AC3E}">
-        <p14:creationId xmlns:p14="http://schemas.microsoft.com/office/powerpoint/2010/main" val="823598089"/>
+        <p14:creationId xmlns:p14="http://schemas.microsoft.com/office/powerpoint/2010/main" val="205282092"/>
       </p:ext>
     </p:extLst>
   </p:cSld>
@@ -9217,7 +9217,7 @@
           <p:cNvPr id="12" name="">
             <a:extLst xmlns:a="http://schemas.openxmlformats.org/drawingml/2006/main">
               <a:ext uri="{FF2B5EF4-FFF2-40B4-BE49-F238E27FC236}">
-                <a16:creationId xmlns:a16="http://schemas.microsoft.com/office/drawing/2014/main" id="{C87BD2B0-01D3-419F-9A47-5EAF3DDB646B}"/>
+                <a16:creationId xmlns:a16="http://schemas.microsoft.com/office/drawing/2014/main" id="{3232AA30-4563-49AE-BA1C-6D890574225E}"/>
               </a:ext>
             </a:extLst>
           </p:cNvPr>
@@ -9285,7 +9285,7 @@
           <p:cNvPr id="2" name="">
             <a:extLst xmlns:a="http://schemas.openxmlformats.org/drawingml/2006/main">
               <a:ext uri="{FF2B5EF4-FFF2-40B4-BE49-F238E27FC236}">
-                <a16:creationId xmlns:a16="http://schemas.microsoft.com/office/drawing/2014/main" id="{AF9D11DD-A583-4278-888E-1AAD30D28DD1}"/>
+                <a16:creationId xmlns:a16="http://schemas.microsoft.com/office/drawing/2014/main" id="{28855756-76D0-4101-8283-78390AD34099}"/>
               </a:ext>
             </a:extLst>
           </p:cNvPr>
@@ -9353,7 +9353,7 @@
           <p:cNvPr id="3" name="">
             <a:extLst xmlns:a="http://schemas.openxmlformats.org/drawingml/2006/main">
               <a:ext uri="{FF2B5EF4-FFF2-40B4-BE49-F238E27FC236}">
-                <a16:creationId xmlns:a16="http://schemas.microsoft.com/office/drawing/2014/main" id="{127FD73B-E610-4EEA-9587-B931085EF895}"/>
+                <a16:creationId xmlns:a16="http://schemas.microsoft.com/office/drawing/2014/main" id="{9E1B0172-C146-4C1F-A2A6-F1AB5EB56BBA}"/>
               </a:ext>
             </a:extLst>
           </p:cNvPr>
@@ -9421,7 +9421,7 @@
           <p:cNvPr id="4" name="">
             <a:extLst xmlns:a="http://schemas.openxmlformats.org/drawingml/2006/main">
               <a:ext uri="{FF2B5EF4-FFF2-40B4-BE49-F238E27FC236}">
-                <a16:creationId xmlns:a16="http://schemas.microsoft.com/office/drawing/2014/main" id="{718EC5F6-7AB7-496F-B835-CD1FF43BACD9}"/>
+                <a16:creationId xmlns:a16="http://schemas.microsoft.com/office/drawing/2014/main" id="{F5DF2255-C1EF-4B5F-938E-4863528929A6}"/>
               </a:ext>
             </a:extLst>
           </p:cNvPr>
@@ -9545,7 +9545,7 @@
           <p:cNvPr id="5" name="">
             <a:extLst xmlns:a="http://schemas.openxmlformats.org/drawingml/2006/main">
               <a:ext uri="{FF2B5EF4-FFF2-40B4-BE49-F238E27FC236}">
-                <a16:creationId xmlns:a16="http://schemas.microsoft.com/office/drawing/2014/main" id="{9D7CEC2D-9E4B-4F69-94F0-3A648C182DB3}"/>
+                <a16:creationId xmlns:a16="http://schemas.microsoft.com/office/drawing/2014/main" id="{AF2AFEB2-88E2-4BE9-A02D-271E463DC7EC}"/>
               </a:ext>
             </a:extLst>
           </p:cNvPr>
@@ -9613,7 +9613,7 @@
           <p:cNvPr id="6" name="">
             <a:extLst xmlns:a="http://schemas.openxmlformats.org/drawingml/2006/main">
               <a:ext uri="{FF2B5EF4-FFF2-40B4-BE49-F238E27FC236}">
-                <a16:creationId xmlns:a16="http://schemas.microsoft.com/office/drawing/2014/main" id="{88190123-1B44-482A-95ED-17692929612E}"/>
+                <a16:creationId xmlns:a16="http://schemas.microsoft.com/office/drawing/2014/main" id="{E534A852-838E-4020-94C7-A2D648E4B7B4}"/>
               </a:ext>
             </a:extLst>
           </p:cNvPr>
@@ -9681,7 +9681,7 @@
           <p:cNvPr id="7" name="">
             <a:extLst xmlns:a="http://schemas.openxmlformats.org/drawingml/2006/main">
               <a:ext uri="{FF2B5EF4-FFF2-40B4-BE49-F238E27FC236}">
-                <a16:creationId xmlns:a16="http://schemas.microsoft.com/office/drawing/2014/main" id="{470B67A4-A697-4DB3-8275-07C74CB764C9}"/>
+                <a16:creationId xmlns:a16="http://schemas.microsoft.com/office/drawing/2014/main" id="{8FD0C43C-C2CC-4B55-9DDC-4B3014D42F3E}"/>
               </a:ext>
             </a:extLst>
           </p:cNvPr>
@@ -9749,7 +9749,7 @@
           <p:cNvPr id="8" name="">
             <a:extLst xmlns:a="http://schemas.openxmlformats.org/drawingml/2006/main">
               <a:ext uri="{FF2B5EF4-FFF2-40B4-BE49-F238E27FC236}">
-                <a16:creationId xmlns:a16="http://schemas.microsoft.com/office/drawing/2014/main" id="{270B71AE-C597-46E8-9DD9-400CCEE0DE43}"/>
+                <a16:creationId xmlns:a16="http://schemas.microsoft.com/office/drawing/2014/main" id="{9AC6FBAC-D849-4FE8-A82D-EEDE5A832BF5}"/>
               </a:ext>
             </a:extLst>
           </p:cNvPr>
@@ -9817,7 +9817,7 @@
           <p:cNvPr id="9" name="">
             <a:extLst xmlns:a="http://schemas.openxmlformats.org/drawingml/2006/main">
               <a:ext uri="{FF2B5EF4-FFF2-40B4-BE49-F238E27FC236}">
-                <a16:creationId xmlns:a16="http://schemas.microsoft.com/office/drawing/2014/main" id="{5979787E-5303-429F-A122-B39C3D640F55}"/>
+                <a16:creationId xmlns:a16="http://schemas.microsoft.com/office/drawing/2014/main" id="{274BF3BA-FF08-48B7-B564-21481E90B6BB}"/>
               </a:ext>
             </a:extLst>
           </p:cNvPr>
@@ -9885,7 +9885,7 @@
           <p:cNvPr id="10" name="">
             <a:extLst xmlns:a="http://schemas.openxmlformats.org/drawingml/2006/main">
               <a:ext uri="{FF2B5EF4-FFF2-40B4-BE49-F238E27FC236}">
-                <a16:creationId xmlns:a16="http://schemas.microsoft.com/office/drawing/2014/main" id="{21E82A24-5141-4777-898B-719FBEFEE13D}"/>
+                <a16:creationId xmlns:a16="http://schemas.microsoft.com/office/drawing/2014/main" id="{75A96AD1-5298-443C-8DB8-D52F194F7F5E}"/>
               </a:ext>
             </a:extLst>
           </p:cNvPr>
@@ -9953,7 +9953,7 @@
           <p:cNvPr id="11" name="">
             <a:extLst xmlns:a="http://schemas.openxmlformats.org/drawingml/2006/main">
               <a:ext uri="{FF2B5EF4-FFF2-40B4-BE49-F238E27FC236}">
-                <a16:creationId xmlns:a16="http://schemas.microsoft.com/office/drawing/2014/main" id="{9E37A255-4A5D-4652-94E5-78A2747920DF}"/>
+                <a16:creationId xmlns:a16="http://schemas.microsoft.com/office/drawing/2014/main" id="{6226729D-8A0F-40F0-9402-5A4A9359C594}"/>
               </a:ext>
             </a:extLst>
           </p:cNvPr>
@@ -10019,7 +10019,7 @@
     </p:spTree>
     <p:extLst>
       <p:ext uri="{BB962C8B-B14F-4D97-AF65-F5344CB8AC3E}">
-        <p14:creationId xmlns:p14="http://schemas.microsoft.com/office/powerpoint/2010/main" val="1311633853"/>
+        <p14:creationId xmlns:p14="http://schemas.microsoft.com/office/powerpoint/2010/main" val="796789145"/>
       </p:ext>
     </p:extLst>
   </p:cSld>
@@ -10050,7 +10050,7 @@
           <p:cNvPr id="7" name="">
             <a:extLst xmlns:a="http://schemas.openxmlformats.org/drawingml/2006/main">
               <a:ext uri="{FF2B5EF4-FFF2-40B4-BE49-F238E27FC236}">
-                <a16:creationId xmlns:a16="http://schemas.microsoft.com/office/drawing/2014/main" id="{188C8A0C-715B-41F8-AF32-31225FE314A8}"/>
+                <a16:creationId xmlns:a16="http://schemas.microsoft.com/office/drawing/2014/main" id="{A8B6D813-B580-40E0-9DB5-ED7CB1B71064}"/>
               </a:ext>
             </a:extLst>
           </p:cNvPr>
@@ -10118,7 +10118,7 @@
           <p:cNvPr id="2" name="">
             <a:extLst xmlns:a="http://schemas.openxmlformats.org/drawingml/2006/main">
               <a:ext uri="{FF2B5EF4-FFF2-40B4-BE49-F238E27FC236}">
-                <a16:creationId xmlns:a16="http://schemas.microsoft.com/office/drawing/2014/main" id="{531AD1A1-0CA2-4836-89D0-EFE5C49603C6}"/>
+                <a16:creationId xmlns:a16="http://schemas.microsoft.com/office/drawing/2014/main" id="{97CE3227-8BDC-4F03-A389-9CC1D09A853B}"/>
               </a:ext>
             </a:extLst>
           </p:cNvPr>
@@ -10186,7 +10186,7 @@
           <p:cNvPr id="3" name="">
             <a:extLst xmlns:a="http://schemas.openxmlformats.org/drawingml/2006/main">
               <a:ext uri="{FF2B5EF4-FFF2-40B4-BE49-F238E27FC236}">
-                <a16:creationId xmlns:a16="http://schemas.microsoft.com/office/drawing/2014/main" id="{9B46D181-D67A-40C7-B231-8F7E5DE3E547}"/>
+                <a16:creationId xmlns:a16="http://schemas.microsoft.com/office/drawing/2014/main" id="{E37FF64F-463A-44B4-BD20-D8EA761868CE}"/>
               </a:ext>
             </a:extLst>
           </p:cNvPr>
@@ -10254,7 +10254,7 @@
           <p:cNvPr id="4" name="">
             <a:extLst xmlns:a="http://schemas.openxmlformats.org/drawingml/2006/main">
               <a:ext uri="{FF2B5EF4-FFF2-40B4-BE49-F238E27FC236}">
-                <a16:creationId xmlns:a16="http://schemas.microsoft.com/office/drawing/2014/main" id="{1A2E3831-22C7-4DAE-9A71-281A7DABE2DD}"/>
+                <a16:creationId xmlns:a16="http://schemas.microsoft.com/office/drawing/2014/main" id="{8082A936-C8AF-4778-AF93-C37E6B9E1782}"/>
               </a:ext>
             </a:extLst>
           </p:cNvPr>
@@ -10378,7 +10378,7 @@
           <p:cNvPr id="5" name="">
             <a:extLst xmlns:a="http://schemas.openxmlformats.org/drawingml/2006/main">
               <a:ext uri="{FF2B5EF4-FFF2-40B4-BE49-F238E27FC236}">
-                <a16:creationId xmlns:a16="http://schemas.microsoft.com/office/drawing/2014/main" id="{FF15B779-1A04-4480-9C8F-A5B4EFE6D139}"/>
+                <a16:creationId xmlns:a16="http://schemas.microsoft.com/office/drawing/2014/main" id="{5A002B86-A0C7-479F-A9A7-EF4832E0BE15}"/>
               </a:ext>
             </a:extLst>
           </p:cNvPr>
@@ -10446,7 +10446,7 @@
           <p:cNvPr id="6" name="">
             <a:extLst xmlns:a="http://schemas.openxmlformats.org/drawingml/2006/main">
               <a:ext uri="{FF2B5EF4-FFF2-40B4-BE49-F238E27FC236}">
-                <a16:creationId xmlns:a16="http://schemas.microsoft.com/office/drawing/2014/main" id="{CD3C166B-B1FF-4A8F-BED0-AB72D850D31B}"/>
+                <a16:creationId xmlns:a16="http://schemas.microsoft.com/office/drawing/2014/main" id="{FAAC3654-4199-444B-AE4E-73CA6853EEE3}"/>
               </a:ext>
             </a:extLst>
           </p:cNvPr>
@@ -10512,7 +10512,7 @@
     </p:spTree>
     <p:extLst>
       <p:ext uri="{BB962C8B-B14F-4D97-AF65-F5344CB8AC3E}">
-        <p14:creationId xmlns:p14="http://schemas.microsoft.com/office/powerpoint/2010/main" val="1043575313"/>
+        <p14:creationId xmlns:p14="http://schemas.microsoft.com/office/powerpoint/2010/main" val="970495517"/>
       </p:ext>
     </p:extLst>
   </p:cSld>
@@ -10543,7 +10543,7 @@
           <p:cNvPr id="6" name="">
             <a:extLst xmlns:a="http://schemas.openxmlformats.org/drawingml/2006/main">
               <a:ext uri="{FF2B5EF4-FFF2-40B4-BE49-F238E27FC236}">
-                <a16:creationId xmlns:a16="http://schemas.microsoft.com/office/drawing/2014/main" id="{7A8F04AE-6075-4D98-93E1-AC7BF0A4A00D}"/>
+                <a16:creationId xmlns:a16="http://schemas.microsoft.com/office/drawing/2014/main" id="{42A277FE-1EB4-417B-A973-1F2CC3C18E70}"/>
               </a:ext>
             </a:extLst>
           </p:cNvPr>
@@ -10611,7 +10611,7 @@
           <p:cNvPr id="2" name="">
             <a:extLst xmlns:a="http://schemas.openxmlformats.org/drawingml/2006/main">
               <a:ext uri="{FF2B5EF4-FFF2-40B4-BE49-F238E27FC236}">
-                <a16:creationId xmlns:a16="http://schemas.microsoft.com/office/drawing/2014/main" id="{F44F0D21-702F-4A22-A13B-C67553929070}"/>
+                <a16:creationId xmlns:a16="http://schemas.microsoft.com/office/drawing/2014/main" id="{656E090A-7928-453A-8858-01904F7D6D69}"/>
               </a:ext>
             </a:extLst>
           </p:cNvPr>
@@ -10679,7 +10679,7 @@
           <p:cNvPr id="3" name="">
             <a:extLst xmlns:a="http://schemas.openxmlformats.org/drawingml/2006/main">
               <a:ext uri="{FF2B5EF4-FFF2-40B4-BE49-F238E27FC236}">
-                <a16:creationId xmlns:a16="http://schemas.microsoft.com/office/drawing/2014/main" id="{48DE5790-DF1E-4402-BD5B-1BE90D3B80B3}"/>
+                <a16:creationId xmlns:a16="http://schemas.microsoft.com/office/drawing/2014/main" id="{39D50ECA-919F-4F26-A456-D4ACE1A11C36}"/>
               </a:ext>
             </a:extLst>
           </p:cNvPr>
@@ -10747,7 +10747,7 @@
           <p:cNvPr id="4" name="">
             <a:extLst xmlns:a="http://schemas.openxmlformats.org/drawingml/2006/main">
               <a:ext uri="{FF2B5EF4-FFF2-40B4-BE49-F238E27FC236}">
-                <a16:creationId xmlns:a16="http://schemas.microsoft.com/office/drawing/2014/main" id="{C3AEC73C-EF6B-4FFD-8FF4-E7E64AE95BFF}"/>
+                <a16:creationId xmlns:a16="http://schemas.microsoft.com/office/drawing/2014/main" id="{689E212D-48C6-4B51-B576-67CA60E7F596}"/>
               </a:ext>
             </a:extLst>
           </p:cNvPr>
@@ -10757,7 +10757,7 @@
           <p:nvPr/>
         </p:nvPicPr>
         <p:blipFill>
-          <a:blip xmlns:r="http://schemas.openxmlformats.org/officeDocument/2006/relationships" xmlns:a="http://schemas.openxmlformats.org/drawingml/2006/main" r:embed="R007db8630c8c4614"/>
+          <a:blip xmlns:r="http://schemas.openxmlformats.org/officeDocument/2006/relationships" xmlns:a="http://schemas.openxmlformats.org/drawingml/2006/main" r:embed="Rfd1474f4b55641bb"/>
           <a:stretch xmlns:a="http://schemas.openxmlformats.org/drawingml/2006/main"/>
         </p:blipFill>
         <p:spPr>
@@ -10775,7 +10775,7 @@
           <p:cNvPr id="5" name="">
             <a:extLst xmlns:a="http://schemas.openxmlformats.org/drawingml/2006/main">
               <a:ext uri="{FF2B5EF4-FFF2-40B4-BE49-F238E27FC236}">
-                <a16:creationId xmlns:a16="http://schemas.microsoft.com/office/drawing/2014/main" id="{2D545A09-ECCB-4971-B12A-C9A4B024BCEF}"/>
+                <a16:creationId xmlns:a16="http://schemas.microsoft.com/office/drawing/2014/main" id="{109F8F30-2F38-4BE3-A4E0-AECD465876B5}"/>
               </a:ext>
             </a:extLst>
           </p:cNvPr>
@@ -10869,7 +10869,7 @@
     </p:spTree>
     <p:extLst>
       <p:ext uri="{BB962C8B-B14F-4D97-AF65-F5344CB8AC3E}">
-        <p14:creationId xmlns:p14="http://schemas.microsoft.com/office/powerpoint/2010/main" val="1170991700"/>
+        <p14:creationId xmlns:p14="http://schemas.microsoft.com/office/powerpoint/2010/main" val="58673776"/>
       </p:ext>
     </p:extLst>
   </p:cSld>
@@ -10900,7 +10900,7 @@
           <p:cNvPr id="13" name="">
             <a:extLst xmlns:a="http://schemas.openxmlformats.org/drawingml/2006/main">
               <a:ext uri="{FF2B5EF4-FFF2-40B4-BE49-F238E27FC236}">
-                <a16:creationId xmlns:a16="http://schemas.microsoft.com/office/drawing/2014/main" id="{EF259A1E-3660-4C45-9307-8D7E66F77801}"/>
+                <a16:creationId xmlns:a16="http://schemas.microsoft.com/office/drawing/2014/main" id="{B003D930-9B22-43D0-B457-C0E8D7039BC5}"/>
               </a:ext>
             </a:extLst>
           </p:cNvPr>
@@ -10968,7 +10968,7 @@
           <p:cNvPr id="2" name="">
             <a:extLst xmlns:a="http://schemas.openxmlformats.org/drawingml/2006/main">
               <a:ext uri="{FF2B5EF4-FFF2-40B4-BE49-F238E27FC236}">
-                <a16:creationId xmlns:a16="http://schemas.microsoft.com/office/drawing/2014/main" id="{67D0B8F1-FDC4-400B-B9F2-037EFC0501D3}"/>
+                <a16:creationId xmlns:a16="http://schemas.microsoft.com/office/drawing/2014/main" id="{AE452F05-4E5F-4F3B-BDCE-DA4909DDF93F}"/>
               </a:ext>
             </a:extLst>
           </p:cNvPr>
@@ -11036,7 +11036,7 @@
           <p:cNvPr id="3" name="">
             <a:extLst xmlns:a="http://schemas.openxmlformats.org/drawingml/2006/main">
               <a:ext uri="{FF2B5EF4-FFF2-40B4-BE49-F238E27FC236}">
-                <a16:creationId xmlns:a16="http://schemas.microsoft.com/office/drawing/2014/main" id="{2E6E0CFC-EDDB-4CA1-A024-CE1D204AD0AE}"/>
+                <a16:creationId xmlns:a16="http://schemas.microsoft.com/office/drawing/2014/main" id="{CDA80811-B454-4264-914C-B674CBA63CAB}"/>
               </a:ext>
             </a:extLst>
           </p:cNvPr>
@@ -11104,7 +11104,7 @@
           <p:cNvPr id="4" name="">
             <a:extLst xmlns:a="http://schemas.openxmlformats.org/drawingml/2006/main">
               <a:ext uri="{FF2B5EF4-FFF2-40B4-BE49-F238E27FC236}">
-                <a16:creationId xmlns:a16="http://schemas.microsoft.com/office/drawing/2014/main" id="{D91AE280-B5B1-4D80-B184-FFB5E2F760E2}"/>
+                <a16:creationId xmlns:a16="http://schemas.microsoft.com/office/drawing/2014/main" id="{0A50EEE8-D93F-4A11-B195-0C3F4508C1C6}"/>
               </a:ext>
             </a:extLst>
           </p:cNvPr>
@@ -11200,7 +11200,7 @@
           <p:cNvPr id="5" name="">
             <a:extLst xmlns:a="http://schemas.openxmlformats.org/drawingml/2006/main">
               <a:ext uri="{FF2B5EF4-FFF2-40B4-BE49-F238E27FC236}">
-                <a16:creationId xmlns:a16="http://schemas.microsoft.com/office/drawing/2014/main" id="{EA3E90CA-49CE-43F1-8F97-05BE4EFECC07}"/>
+                <a16:creationId xmlns:a16="http://schemas.microsoft.com/office/drawing/2014/main" id="{0D69BC31-1BC2-4108-B61E-4707EB59C355}"/>
               </a:ext>
             </a:extLst>
           </p:cNvPr>
@@ -11268,7 +11268,7 @@
           <p:cNvPr id="6" name="">
             <a:extLst xmlns:a="http://schemas.openxmlformats.org/drawingml/2006/main">
               <a:ext uri="{FF2B5EF4-FFF2-40B4-BE49-F238E27FC236}">
-                <a16:creationId xmlns:a16="http://schemas.microsoft.com/office/drawing/2014/main" id="{0B54419B-3F96-4A2C-9D08-46831CB08D95}"/>
+                <a16:creationId xmlns:a16="http://schemas.microsoft.com/office/drawing/2014/main" id="{2D948D21-39F2-4CC9-871E-1E09EBEF3419}"/>
               </a:ext>
             </a:extLst>
           </p:cNvPr>
@@ -11336,7 +11336,7 @@
           <p:cNvPr id="7" name="">
             <a:extLst xmlns:a="http://schemas.openxmlformats.org/drawingml/2006/main">
               <a:ext uri="{FF2B5EF4-FFF2-40B4-BE49-F238E27FC236}">
-                <a16:creationId xmlns:a16="http://schemas.microsoft.com/office/drawing/2014/main" id="{C8F784C1-CF23-4DCA-BAD4-5ABFF10DA5E8}"/>
+                <a16:creationId xmlns:a16="http://schemas.microsoft.com/office/drawing/2014/main" id="{55F29E41-8E11-499B-854C-F9DAE8B08490}"/>
               </a:ext>
             </a:extLst>
           </p:cNvPr>
@@ -11404,7 +11404,7 @@
           <p:cNvPr id="8" name="">
             <a:extLst xmlns:a="http://schemas.openxmlformats.org/drawingml/2006/main">
               <a:ext uri="{FF2B5EF4-FFF2-40B4-BE49-F238E27FC236}">
-                <a16:creationId xmlns:a16="http://schemas.microsoft.com/office/drawing/2014/main" id="{CFE57F7C-345B-4F5A-A29E-E3AAF5937660}"/>
+                <a16:creationId xmlns:a16="http://schemas.microsoft.com/office/drawing/2014/main" id="{9272AB2D-F7D6-4160-AD15-3A5C306D5ACD}"/>
               </a:ext>
             </a:extLst>
           </p:cNvPr>
@@ -11472,7 +11472,7 @@
           <p:cNvPr id="9" name="">
             <a:extLst xmlns:a="http://schemas.openxmlformats.org/drawingml/2006/main">
               <a:ext uri="{FF2B5EF4-FFF2-40B4-BE49-F238E27FC236}">
-                <a16:creationId xmlns:a16="http://schemas.microsoft.com/office/drawing/2014/main" id="{57ECEC10-6AAE-42AB-9B16-50EA5D0B15CB}"/>
+                <a16:creationId xmlns:a16="http://schemas.microsoft.com/office/drawing/2014/main" id="{0C5702D9-DC0D-467A-A788-D2A38496FC29}"/>
               </a:ext>
             </a:extLst>
           </p:cNvPr>
@@ -11540,7 +11540,7 @@
           <p:cNvPr id="10" name="">
             <a:extLst xmlns:a="http://schemas.openxmlformats.org/drawingml/2006/main">
               <a:ext uri="{FF2B5EF4-FFF2-40B4-BE49-F238E27FC236}">
-                <a16:creationId xmlns:a16="http://schemas.microsoft.com/office/drawing/2014/main" id="{8D87BBE2-A0E1-430E-B961-7020F939A186}"/>
+                <a16:creationId xmlns:a16="http://schemas.microsoft.com/office/drawing/2014/main" id="{2BEA2D4F-9AA8-4445-8FFD-1DF8F7E56C42}"/>
               </a:ext>
             </a:extLst>
           </p:cNvPr>
@@ -11608,7 +11608,7 @@
           <p:cNvPr id="11" name="">
             <a:extLst xmlns:a="http://schemas.openxmlformats.org/drawingml/2006/main">
               <a:ext uri="{FF2B5EF4-FFF2-40B4-BE49-F238E27FC236}">
-                <a16:creationId xmlns:a16="http://schemas.microsoft.com/office/drawing/2014/main" id="{F8F3ED67-2810-4600-92A8-8D49243050AE}"/>
+                <a16:creationId xmlns:a16="http://schemas.microsoft.com/office/drawing/2014/main" id="{67DD26D5-4364-4847-80A0-47AB9F65BC35}"/>
               </a:ext>
             </a:extLst>
           </p:cNvPr>
@@ -11676,7 +11676,7 @@
           <p:cNvPr id="12" name="">
             <a:extLst xmlns:a="http://schemas.openxmlformats.org/drawingml/2006/main">
               <a:ext uri="{FF2B5EF4-FFF2-40B4-BE49-F238E27FC236}">
-                <a16:creationId xmlns:a16="http://schemas.microsoft.com/office/drawing/2014/main" id="{C0E6A313-E6BA-48E4-AE53-3853D5556D7F}"/>
+                <a16:creationId xmlns:a16="http://schemas.microsoft.com/office/drawing/2014/main" id="{236EB603-DEB9-4868-B68C-E6D700AC88C4}"/>
               </a:ext>
             </a:extLst>
           </p:cNvPr>
@@ -11742,7 +11742,7 @@
     </p:spTree>
     <p:extLst>
       <p:ext uri="{BB962C8B-B14F-4D97-AF65-F5344CB8AC3E}">
-        <p14:creationId xmlns:p14="http://schemas.microsoft.com/office/powerpoint/2010/main" val="688131653"/>
+        <p14:creationId xmlns:p14="http://schemas.microsoft.com/office/powerpoint/2010/main" val="573968668"/>
       </p:ext>
     </p:extLst>
   </p:cSld>
@@ -11773,7 +11773,7 @@
           <p:cNvPr id="7" name="">
             <a:extLst xmlns:a="http://schemas.openxmlformats.org/drawingml/2006/main">
               <a:ext uri="{FF2B5EF4-FFF2-40B4-BE49-F238E27FC236}">
-                <a16:creationId xmlns:a16="http://schemas.microsoft.com/office/drawing/2014/main" id="{4233E4A4-7EC0-43E0-953F-707AEBB7BD01}"/>
+                <a16:creationId xmlns:a16="http://schemas.microsoft.com/office/drawing/2014/main" id="{7CD0B60F-A94B-4E78-939F-2531D947626F}"/>
               </a:ext>
             </a:extLst>
           </p:cNvPr>
@@ -11841,7 +11841,7 @@
           <p:cNvPr id="2" name="">
             <a:extLst xmlns:a="http://schemas.openxmlformats.org/drawingml/2006/main">
               <a:ext uri="{FF2B5EF4-FFF2-40B4-BE49-F238E27FC236}">
-                <a16:creationId xmlns:a16="http://schemas.microsoft.com/office/drawing/2014/main" id="{3C3E725C-1E01-401F-AEF0-5AF640F55368}"/>
+                <a16:creationId xmlns:a16="http://schemas.microsoft.com/office/drawing/2014/main" id="{99B51963-06FC-4404-8F12-83B42042355D}"/>
               </a:ext>
             </a:extLst>
           </p:cNvPr>
@@ -11909,7 +11909,7 @@
           <p:cNvPr id="3" name="">
             <a:extLst xmlns:a="http://schemas.openxmlformats.org/drawingml/2006/main">
               <a:ext uri="{FF2B5EF4-FFF2-40B4-BE49-F238E27FC236}">
-                <a16:creationId xmlns:a16="http://schemas.microsoft.com/office/drawing/2014/main" id="{8B98F908-2AF1-4122-AB0D-45E9D1BAAAB9}"/>
+                <a16:creationId xmlns:a16="http://schemas.microsoft.com/office/drawing/2014/main" id="{79EAC2D1-08FC-4CD7-9282-6132F3FE8863}"/>
               </a:ext>
             </a:extLst>
           </p:cNvPr>
@@ -11977,7 +11977,7 @@
           <p:cNvPr id="4" name="">
             <a:extLst xmlns:a="http://schemas.openxmlformats.org/drawingml/2006/main">
               <a:ext uri="{FF2B5EF4-FFF2-40B4-BE49-F238E27FC236}">
-                <a16:creationId xmlns:a16="http://schemas.microsoft.com/office/drawing/2014/main" id="{69E77CF0-447C-4033-8192-5F0C712C9B88}"/>
+                <a16:creationId xmlns:a16="http://schemas.microsoft.com/office/drawing/2014/main" id="{A2A5E04D-7E7E-4837-B6CB-4E298DFFADCC}"/>
               </a:ext>
             </a:extLst>
           </p:cNvPr>
@@ -12101,7 +12101,7 @@
           <p:cNvPr id="5" name="">
             <a:extLst xmlns:a="http://schemas.openxmlformats.org/drawingml/2006/main">
               <a:ext uri="{FF2B5EF4-FFF2-40B4-BE49-F238E27FC236}">
-                <a16:creationId xmlns:a16="http://schemas.microsoft.com/office/drawing/2014/main" id="{2C1218F9-A7ED-4267-AC75-406229DD8BED}"/>
+                <a16:creationId xmlns:a16="http://schemas.microsoft.com/office/drawing/2014/main" id="{65BA0320-1EF0-43C4-B32C-FF7243C6DA1E}"/>
               </a:ext>
             </a:extLst>
           </p:cNvPr>
@@ -12169,7 +12169,7 @@
           <p:cNvPr id="6" name="">
             <a:extLst xmlns:a="http://schemas.openxmlformats.org/drawingml/2006/main">
               <a:ext uri="{FF2B5EF4-FFF2-40B4-BE49-F238E27FC236}">
-                <a16:creationId xmlns:a16="http://schemas.microsoft.com/office/drawing/2014/main" id="{D28DB72A-12B4-487D-89E7-950ECCD27544}"/>
+                <a16:creationId xmlns:a16="http://schemas.microsoft.com/office/drawing/2014/main" id="{5AA6F01D-48E1-4486-B624-F8E250FCFF86}"/>
               </a:ext>
             </a:extLst>
           </p:cNvPr>
@@ -12235,7 +12235,7 @@
     </p:spTree>
     <p:extLst>
       <p:ext uri="{BB962C8B-B14F-4D97-AF65-F5344CB8AC3E}">
-        <p14:creationId xmlns:p14="http://schemas.microsoft.com/office/powerpoint/2010/main" val="1646737437"/>
+        <p14:creationId xmlns:p14="http://schemas.microsoft.com/office/powerpoint/2010/main" val="396865389"/>
       </p:ext>
     </p:extLst>
   </p:cSld>
@@ -12266,7 +12266,7 @@
           <p:cNvPr id="13" name="">
             <a:extLst xmlns:a="http://schemas.openxmlformats.org/drawingml/2006/main">
               <a:ext uri="{FF2B5EF4-FFF2-40B4-BE49-F238E27FC236}">
-                <a16:creationId xmlns:a16="http://schemas.microsoft.com/office/drawing/2014/main" id="{B2163244-C9B9-4225-8D70-0B01EFB1C649}"/>
+                <a16:creationId xmlns:a16="http://schemas.microsoft.com/office/drawing/2014/main" id="{A528FE1D-E0A6-4790-984B-2C6EAF26DBFA}"/>
               </a:ext>
             </a:extLst>
           </p:cNvPr>
@@ -12334,7 +12334,7 @@
           <p:cNvPr id="2" name="">
             <a:extLst xmlns:a="http://schemas.openxmlformats.org/drawingml/2006/main">
               <a:ext uri="{FF2B5EF4-FFF2-40B4-BE49-F238E27FC236}">
-                <a16:creationId xmlns:a16="http://schemas.microsoft.com/office/drawing/2014/main" id="{7BF77707-C9C6-4329-AD11-0BD63198403F}"/>
+                <a16:creationId xmlns:a16="http://schemas.microsoft.com/office/drawing/2014/main" id="{B8E45BEB-388A-436E-B830-C870306263F0}"/>
               </a:ext>
             </a:extLst>
           </p:cNvPr>
@@ -12402,7 +12402,7 @@
           <p:cNvPr id="3" name="">
             <a:extLst xmlns:a="http://schemas.openxmlformats.org/drawingml/2006/main">
               <a:ext uri="{FF2B5EF4-FFF2-40B4-BE49-F238E27FC236}">
-                <a16:creationId xmlns:a16="http://schemas.microsoft.com/office/drawing/2014/main" id="{123ED84D-2065-4185-91A3-E2A91C1F3B90}"/>
+                <a16:creationId xmlns:a16="http://schemas.microsoft.com/office/drawing/2014/main" id="{8EC24DB3-E188-4FCE-932A-14E02984E2CC}"/>
               </a:ext>
             </a:extLst>
           </p:cNvPr>
@@ -12470,7 +12470,7 @@
           <p:cNvPr id="4" name="">
             <a:extLst xmlns:a="http://schemas.openxmlformats.org/drawingml/2006/main">
               <a:ext uri="{FF2B5EF4-FFF2-40B4-BE49-F238E27FC236}">
-                <a16:creationId xmlns:a16="http://schemas.microsoft.com/office/drawing/2014/main" id="{336A1240-E20A-47E0-BD88-0E5B6F09DCB6}"/>
+                <a16:creationId xmlns:a16="http://schemas.microsoft.com/office/drawing/2014/main" id="{D2D0C013-CF20-4B87-8310-AED92509C975}"/>
               </a:ext>
             </a:extLst>
           </p:cNvPr>
@@ -12594,7 +12594,7 @@
           <p:cNvPr id="5" name="">
             <a:extLst xmlns:a="http://schemas.openxmlformats.org/drawingml/2006/main">
               <a:ext uri="{FF2B5EF4-FFF2-40B4-BE49-F238E27FC236}">
-                <a16:creationId xmlns:a16="http://schemas.microsoft.com/office/drawing/2014/main" id="{A72CA3CE-B469-4247-8A86-0CB46CDB80C4}"/>
+                <a16:creationId xmlns:a16="http://schemas.microsoft.com/office/drawing/2014/main" id="{57EF13A0-82DC-440B-AB6C-F6BC43FB330C}"/>
               </a:ext>
             </a:extLst>
           </p:cNvPr>
@@ -12662,7 +12662,7 @@
           <p:cNvPr id="6" name="">
             <a:extLst xmlns:a="http://schemas.openxmlformats.org/drawingml/2006/main">
               <a:ext uri="{FF2B5EF4-FFF2-40B4-BE49-F238E27FC236}">
-                <a16:creationId xmlns:a16="http://schemas.microsoft.com/office/drawing/2014/main" id="{11BEA854-8D0F-4F41-8EB4-DCED228C2AA9}"/>
+                <a16:creationId xmlns:a16="http://schemas.microsoft.com/office/drawing/2014/main" id="{9065CE0F-213D-4B98-B1EF-363ED4C1D1FA}"/>
               </a:ext>
             </a:extLst>
           </p:cNvPr>
@@ -12730,7 +12730,7 @@
           <p:cNvPr id="7" name="">
             <a:extLst xmlns:a="http://schemas.openxmlformats.org/drawingml/2006/main">
               <a:ext uri="{FF2B5EF4-FFF2-40B4-BE49-F238E27FC236}">
-                <a16:creationId xmlns:a16="http://schemas.microsoft.com/office/drawing/2014/main" id="{41C94C40-8F2C-482B-BEFD-FA8B296611C2}"/>
+                <a16:creationId xmlns:a16="http://schemas.microsoft.com/office/drawing/2014/main" id="{A3082520-C9ED-430B-A82B-3E5C93065DA5}"/>
               </a:ext>
             </a:extLst>
           </p:cNvPr>
@@ -12798,7 +12798,7 @@
           <p:cNvPr id="8" name="">
             <a:extLst xmlns:a="http://schemas.openxmlformats.org/drawingml/2006/main">
               <a:ext uri="{FF2B5EF4-FFF2-40B4-BE49-F238E27FC236}">
-                <a16:creationId xmlns:a16="http://schemas.microsoft.com/office/drawing/2014/main" id="{4DD3DCE0-9C0B-4868-A94F-56F7A173D2EA}"/>
+                <a16:creationId xmlns:a16="http://schemas.microsoft.com/office/drawing/2014/main" id="{66042313-CC72-462C-9372-3791AE69CD18}"/>
               </a:ext>
             </a:extLst>
           </p:cNvPr>
@@ -12866,7 +12866,7 @@
           <p:cNvPr id="9" name="">
             <a:extLst xmlns:a="http://schemas.openxmlformats.org/drawingml/2006/main">
               <a:ext uri="{FF2B5EF4-FFF2-40B4-BE49-F238E27FC236}">
-                <a16:creationId xmlns:a16="http://schemas.microsoft.com/office/drawing/2014/main" id="{05C632C9-A498-44D7-AC25-15F6A2D5E770}"/>
+                <a16:creationId xmlns:a16="http://schemas.microsoft.com/office/drawing/2014/main" id="{D95F5ECE-76CD-41DB-9654-88AF30E438EE}"/>
               </a:ext>
             </a:extLst>
           </p:cNvPr>
@@ -12934,7 +12934,7 @@
           <p:cNvPr id="10" name="">
             <a:extLst xmlns:a="http://schemas.openxmlformats.org/drawingml/2006/main">
               <a:ext uri="{FF2B5EF4-FFF2-40B4-BE49-F238E27FC236}">
-                <a16:creationId xmlns:a16="http://schemas.microsoft.com/office/drawing/2014/main" id="{CD77AF99-BA2B-4D76-954B-91FA1217300A}"/>
+                <a16:creationId xmlns:a16="http://schemas.microsoft.com/office/drawing/2014/main" id="{A9A094F7-67C4-4F65-A144-70880085AF8D}"/>
               </a:ext>
             </a:extLst>
           </p:cNvPr>
@@ -13002,7 +13002,7 @@
           <p:cNvPr id="11" name="">
             <a:extLst xmlns:a="http://schemas.openxmlformats.org/drawingml/2006/main">
               <a:ext uri="{FF2B5EF4-FFF2-40B4-BE49-F238E27FC236}">
-                <a16:creationId xmlns:a16="http://schemas.microsoft.com/office/drawing/2014/main" id="{5128D410-71DA-41CD-9A28-6E5F415BCECB}"/>
+                <a16:creationId xmlns:a16="http://schemas.microsoft.com/office/drawing/2014/main" id="{10ED630F-D969-4EE6-89CD-C5DE567F4FE4}"/>
               </a:ext>
             </a:extLst>
           </p:cNvPr>
@@ -13070,7 +13070,7 @@
           <p:cNvPr id="12" name="">
             <a:extLst xmlns:a="http://schemas.openxmlformats.org/drawingml/2006/main">
               <a:ext uri="{FF2B5EF4-FFF2-40B4-BE49-F238E27FC236}">
-                <a16:creationId xmlns:a16="http://schemas.microsoft.com/office/drawing/2014/main" id="{2E83CE15-F1C1-415B-ACF5-F2A478FE0168}"/>
+                <a16:creationId xmlns:a16="http://schemas.microsoft.com/office/drawing/2014/main" id="{09C626C9-2389-4E86-95AE-5681FC8184B4}"/>
               </a:ext>
             </a:extLst>
           </p:cNvPr>
@@ -13136,7 +13136,7 @@
     </p:spTree>
     <p:extLst>
       <p:ext uri="{BB962C8B-B14F-4D97-AF65-F5344CB8AC3E}">
-        <p14:creationId xmlns:p14="http://schemas.microsoft.com/office/powerpoint/2010/main" val="381721275"/>
+        <p14:creationId xmlns:p14="http://schemas.microsoft.com/office/powerpoint/2010/main" val="537550378"/>
       </p:ext>
     </p:extLst>
   </p:cSld>
@@ -13167,7 +13167,7 @@
           <p:cNvPr id="11" name="">
             <a:extLst xmlns:a="http://schemas.openxmlformats.org/drawingml/2006/main">
               <a:ext uri="{FF2B5EF4-FFF2-40B4-BE49-F238E27FC236}">
-                <a16:creationId xmlns:a16="http://schemas.microsoft.com/office/drawing/2014/main" id="{D7627308-4675-4649-9F8D-3C3C2CA0DDC1}"/>
+                <a16:creationId xmlns:a16="http://schemas.microsoft.com/office/drawing/2014/main" id="{F27458BD-D01F-4979-A2D6-7BCDBA8B9D69}"/>
               </a:ext>
             </a:extLst>
           </p:cNvPr>
@@ -13235,7 +13235,7 @@
           <p:cNvPr id="2" name="">
             <a:extLst xmlns:a="http://schemas.openxmlformats.org/drawingml/2006/main">
               <a:ext uri="{FF2B5EF4-FFF2-40B4-BE49-F238E27FC236}">
-                <a16:creationId xmlns:a16="http://schemas.microsoft.com/office/drawing/2014/main" id="{7B01C341-23B2-49E4-B815-12DEA25CFB49}"/>
+                <a16:creationId xmlns:a16="http://schemas.microsoft.com/office/drawing/2014/main" id="{E3D02E63-0F87-42C6-839D-93C77A3AED87}"/>
               </a:ext>
             </a:extLst>
           </p:cNvPr>
@@ -13303,7 +13303,7 @@
           <p:cNvPr id="3" name="">
             <a:extLst xmlns:a="http://schemas.openxmlformats.org/drawingml/2006/main">
               <a:ext uri="{FF2B5EF4-FFF2-40B4-BE49-F238E27FC236}">
-                <a16:creationId xmlns:a16="http://schemas.microsoft.com/office/drawing/2014/main" id="{C3217D09-2EE1-4000-B7B1-61007BACE098}"/>
+                <a16:creationId xmlns:a16="http://schemas.microsoft.com/office/drawing/2014/main" id="{83CAD14D-021F-4C92-B749-F67D13A7454B}"/>
               </a:ext>
             </a:extLst>
           </p:cNvPr>
@@ -13371,7 +13371,7 @@
           <p:cNvPr id="4" name="">
             <a:extLst xmlns:a="http://schemas.openxmlformats.org/drawingml/2006/main">
               <a:ext uri="{FF2B5EF4-FFF2-40B4-BE49-F238E27FC236}">
-                <a16:creationId xmlns:a16="http://schemas.microsoft.com/office/drawing/2014/main" id="{2FA96097-FDD6-4D5B-A9A8-1552A074155B}"/>
+                <a16:creationId xmlns:a16="http://schemas.microsoft.com/office/drawing/2014/main" id="{11BF36DC-AC73-4F67-B340-F0DC655AFB42}"/>
               </a:ext>
             </a:extLst>
           </p:cNvPr>
@@ -13495,7 +13495,7 @@
           <p:cNvPr id="5" name="">
             <a:extLst xmlns:a="http://schemas.openxmlformats.org/drawingml/2006/main">
               <a:ext uri="{FF2B5EF4-FFF2-40B4-BE49-F238E27FC236}">
-                <a16:creationId xmlns:a16="http://schemas.microsoft.com/office/drawing/2014/main" id="{31AEEF55-3057-44C3-ADB4-BA85513BDA0A}"/>
+                <a16:creationId xmlns:a16="http://schemas.microsoft.com/office/drawing/2014/main" id="{19F4746E-663B-4885-A32D-180035C911CB}"/>
               </a:ext>
             </a:extLst>
           </p:cNvPr>
@@ -13563,7 +13563,7 @@
           <p:cNvPr id="6" name="">
             <a:extLst xmlns:a="http://schemas.openxmlformats.org/drawingml/2006/main">
               <a:ext uri="{FF2B5EF4-FFF2-40B4-BE49-F238E27FC236}">
-                <a16:creationId xmlns:a16="http://schemas.microsoft.com/office/drawing/2014/main" id="{698C58DA-7F25-449A-AA22-F392857F31E8}"/>
+                <a16:creationId xmlns:a16="http://schemas.microsoft.com/office/drawing/2014/main" id="{27F724E1-81D1-4F9E-BF1F-D5696DC24685}"/>
               </a:ext>
             </a:extLst>
           </p:cNvPr>
@@ -13631,7 +13631,7 @@
           <p:cNvPr id="7" name="">
             <a:extLst xmlns:a="http://schemas.openxmlformats.org/drawingml/2006/main">
               <a:ext uri="{FF2B5EF4-FFF2-40B4-BE49-F238E27FC236}">
-                <a16:creationId xmlns:a16="http://schemas.microsoft.com/office/drawing/2014/main" id="{9DC0E8BE-5F92-47D9-8247-620DF1A86016}"/>
+                <a16:creationId xmlns:a16="http://schemas.microsoft.com/office/drawing/2014/main" id="{C7E6941A-E6E6-49D4-A06B-978ABAB5B33A}"/>
               </a:ext>
             </a:extLst>
           </p:cNvPr>
@@ -13699,7 +13699,7 @@
           <p:cNvPr id="8" name="">
             <a:extLst xmlns:a="http://schemas.openxmlformats.org/drawingml/2006/main">
               <a:ext uri="{FF2B5EF4-FFF2-40B4-BE49-F238E27FC236}">
-                <a16:creationId xmlns:a16="http://schemas.microsoft.com/office/drawing/2014/main" id="{5DE644C7-7B6C-459C-9D07-38114F466209}"/>
+                <a16:creationId xmlns:a16="http://schemas.microsoft.com/office/drawing/2014/main" id="{715DF19D-B54C-4B18-813B-C75AD30F548D}"/>
               </a:ext>
             </a:extLst>
           </p:cNvPr>
@@ -13767,7 +13767,7 @@
           <p:cNvPr id="9" name="">
             <a:extLst xmlns:a="http://schemas.openxmlformats.org/drawingml/2006/main">
               <a:ext uri="{FF2B5EF4-FFF2-40B4-BE49-F238E27FC236}">
-                <a16:creationId xmlns:a16="http://schemas.microsoft.com/office/drawing/2014/main" id="{BFE0D463-3554-4965-A4F5-51BE1D0D40F1}"/>
+                <a16:creationId xmlns:a16="http://schemas.microsoft.com/office/drawing/2014/main" id="{14A87FDB-ACC5-4723-8D60-23B12B0A09EC}"/>
               </a:ext>
             </a:extLst>
           </p:cNvPr>
@@ -13835,7 +13835,7 @@
           <p:cNvPr id="10" name="">
             <a:extLst xmlns:a="http://schemas.openxmlformats.org/drawingml/2006/main">
               <a:ext uri="{FF2B5EF4-FFF2-40B4-BE49-F238E27FC236}">
-                <a16:creationId xmlns:a16="http://schemas.microsoft.com/office/drawing/2014/main" id="{B44AEF53-E467-4937-B425-FAF4692DEB4A}"/>
+                <a16:creationId xmlns:a16="http://schemas.microsoft.com/office/drawing/2014/main" id="{657ED430-36A9-4AD6-A041-6281DEF73AAD}"/>
               </a:ext>
             </a:extLst>
           </p:cNvPr>
@@ -13901,7 +13901,7 @@
     </p:spTree>
     <p:extLst>
       <p:ext uri="{BB962C8B-B14F-4D97-AF65-F5344CB8AC3E}">
-        <p14:creationId xmlns:p14="http://schemas.microsoft.com/office/powerpoint/2010/main" val="1060895895"/>
+        <p14:creationId xmlns:p14="http://schemas.microsoft.com/office/powerpoint/2010/main" val="128137568"/>
       </p:ext>
     </p:extLst>
   </p:cSld>
@@ -13932,7 +13932,7 @@
           <p:cNvPr id="11" name="">
             <a:extLst xmlns:a="http://schemas.openxmlformats.org/drawingml/2006/main">
               <a:ext uri="{FF2B5EF4-FFF2-40B4-BE49-F238E27FC236}">
-                <a16:creationId xmlns:a16="http://schemas.microsoft.com/office/drawing/2014/main" id="{481A18D0-D30E-469A-88BE-CFAF16711257}"/>
+                <a16:creationId xmlns:a16="http://schemas.microsoft.com/office/drawing/2014/main" id="{FBA538C5-90B5-48B4-BDAB-11E7A275BA23}"/>
               </a:ext>
             </a:extLst>
           </p:cNvPr>
@@ -14000,7 +14000,7 @@
           <p:cNvPr id="2" name="">
             <a:extLst xmlns:a="http://schemas.openxmlformats.org/drawingml/2006/main">
               <a:ext uri="{FF2B5EF4-FFF2-40B4-BE49-F238E27FC236}">
-                <a16:creationId xmlns:a16="http://schemas.microsoft.com/office/drawing/2014/main" id="{D445895A-7A5A-4C5D-B5FC-238240FA35B8}"/>
+                <a16:creationId xmlns:a16="http://schemas.microsoft.com/office/drawing/2014/main" id="{DBC8B3BB-4F44-49E1-94E4-FFF76FFC9812}"/>
               </a:ext>
             </a:extLst>
           </p:cNvPr>
@@ -14068,7 +14068,7 @@
           <p:cNvPr id="3" name="">
             <a:extLst xmlns:a="http://schemas.openxmlformats.org/drawingml/2006/main">
               <a:ext uri="{FF2B5EF4-FFF2-40B4-BE49-F238E27FC236}">
-                <a16:creationId xmlns:a16="http://schemas.microsoft.com/office/drawing/2014/main" id="{A3726C8D-61D1-44FE-BCAA-7BA548FA3D76}"/>
+                <a16:creationId xmlns:a16="http://schemas.microsoft.com/office/drawing/2014/main" id="{E6074176-76AF-4B39-85AC-A15784E0F3E9}"/>
               </a:ext>
             </a:extLst>
           </p:cNvPr>
@@ -14136,7 +14136,7 @@
           <p:cNvPr id="4" name="">
             <a:extLst xmlns:a="http://schemas.openxmlformats.org/drawingml/2006/main">
               <a:ext uri="{FF2B5EF4-FFF2-40B4-BE49-F238E27FC236}">
-                <a16:creationId xmlns:a16="http://schemas.microsoft.com/office/drawing/2014/main" id="{CDA5F043-DFE6-40ED-BD72-9D43FBD39B60}"/>
+                <a16:creationId xmlns:a16="http://schemas.microsoft.com/office/drawing/2014/main" id="{E88D7399-7641-4B9E-968D-0876343923D6}"/>
               </a:ext>
             </a:extLst>
           </p:cNvPr>
@@ -14260,7 +14260,7 @@
           <p:cNvPr id="5" name="">
             <a:extLst xmlns:a="http://schemas.openxmlformats.org/drawingml/2006/main">
               <a:ext uri="{FF2B5EF4-FFF2-40B4-BE49-F238E27FC236}">
-                <a16:creationId xmlns:a16="http://schemas.microsoft.com/office/drawing/2014/main" id="{CBFF1830-C08D-404B-9B15-E6AFAFD29B92}"/>
+                <a16:creationId xmlns:a16="http://schemas.microsoft.com/office/drawing/2014/main" id="{EFE1CBFB-FAD5-4B2E-9F81-2461F91DD529}"/>
               </a:ext>
             </a:extLst>
           </p:cNvPr>
@@ -14328,7 +14328,7 @@
           <p:cNvPr id="6" name="">
             <a:extLst xmlns:a="http://schemas.openxmlformats.org/drawingml/2006/main">
               <a:ext uri="{FF2B5EF4-FFF2-40B4-BE49-F238E27FC236}">
-                <a16:creationId xmlns:a16="http://schemas.microsoft.com/office/drawing/2014/main" id="{21D245EF-9F87-4395-85C8-8980EDAC4EE6}"/>
+                <a16:creationId xmlns:a16="http://schemas.microsoft.com/office/drawing/2014/main" id="{2B09A0C4-0DBA-4D46-BC11-6891FB89B44E}"/>
               </a:ext>
             </a:extLst>
           </p:cNvPr>
@@ -14396,7 +14396,7 @@
           <p:cNvPr id="7" name="">
             <a:extLst xmlns:a="http://schemas.openxmlformats.org/drawingml/2006/main">
               <a:ext uri="{FF2B5EF4-FFF2-40B4-BE49-F238E27FC236}">
-                <a16:creationId xmlns:a16="http://schemas.microsoft.com/office/drawing/2014/main" id="{D64E1E76-B9A1-4745-AC43-06E7AAE107F7}"/>
+                <a16:creationId xmlns:a16="http://schemas.microsoft.com/office/drawing/2014/main" id="{C891C75C-28AB-48C7-81CA-F6EEAA03D563}"/>
               </a:ext>
             </a:extLst>
           </p:cNvPr>
@@ -14464,7 +14464,7 @@
           <p:cNvPr id="8" name="">
             <a:extLst xmlns:a="http://schemas.openxmlformats.org/drawingml/2006/main">
               <a:ext uri="{FF2B5EF4-FFF2-40B4-BE49-F238E27FC236}">
-                <a16:creationId xmlns:a16="http://schemas.microsoft.com/office/drawing/2014/main" id="{29771718-CD35-4D1C-9C80-6E2C55BAAF93}"/>
+                <a16:creationId xmlns:a16="http://schemas.microsoft.com/office/drawing/2014/main" id="{C021A7F5-EFB2-42D9-888C-040F068A128C}"/>
               </a:ext>
             </a:extLst>
           </p:cNvPr>
@@ -14532,7 +14532,7 @@
           <p:cNvPr id="9" name="">
             <a:extLst xmlns:a="http://schemas.openxmlformats.org/drawingml/2006/main">
               <a:ext uri="{FF2B5EF4-FFF2-40B4-BE49-F238E27FC236}">
-                <a16:creationId xmlns:a16="http://schemas.microsoft.com/office/drawing/2014/main" id="{181D7E07-B3B1-4DE1-8833-FCA70D9C3C35}"/>
+                <a16:creationId xmlns:a16="http://schemas.microsoft.com/office/drawing/2014/main" id="{39691B9D-C3BB-41F1-9EAB-88F3D104D277}"/>
               </a:ext>
             </a:extLst>
           </p:cNvPr>
@@ -14600,7 +14600,7 @@
           <p:cNvPr id="10" name="">
             <a:extLst xmlns:a="http://schemas.openxmlformats.org/drawingml/2006/main">
               <a:ext uri="{FF2B5EF4-FFF2-40B4-BE49-F238E27FC236}">
-                <a16:creationId xmlns:a16="http://schemas.microsoft.com/office/drawing/2014/main" id="{64A388A4-3E87-4B8D-B700-6FF4EF543156}"/>
+                <a16:creationId xmlns:a16="http://schemas.microsoft.com/office/drawing/2014/main" id="{D81FA325-95D1-4B49-96BA-4D7BCD640C90}"/>
               </a:ext>
             </a:extLst>
           </p:cNvPr>
@@ -14666,7 +14666,7 @@
     </p:spTree>
     <p:extLst>
       <p:ext uri="{BB962C8B-B14F-4D97-AF65-F5344CB8AC3E}">
-        <p14:creationId xmlns:p14="http://schemas.microsoft.com/office/powerpoint/2010/main" val="1477302243"/>
+        <p14:creationId xmlns:p14="http://schemas.microsoft.com/office/powerpoint/2010/main" val="105979203"/>
       </p:ext>
     </p:extLst>
   </p:cSld>
@@ -14697,7 +14697,7 @@
           <p:cNvPr id="8" name="">
             <a:extLst xmlns:a="http://schemas.openxmlformats.org/drawingml/2006/main">
               <a:ext uri="{FF2B5EF4-FFF2-40B4-BE49-F238E27FC236}">
-                <a16:creationId xmlns:a16="http://schemas.microsoft.com/office/drawing/2014/main" id="{03A3C2A6-1A3F-4861-9089-F8DFFC72E700}"/>
+                <a16:creationId xmlns:a16="http://schemas.microsoft.com/office/drawing/2014/main" id="{D845239A-D8E3-4435-8D4B-51C0B09B97D0}"/>
               </a:ext>
             </a:extLst>
           </p:cNvPr>
@@ -14765,7 +14765,7 @@
           <p:cNvPr id="2" name="">
             <a:extLst xmlns:a="http://schemas.openxmlformats.org/drawingml/2006/main">
               <a:ext uri="{FF2B5EF4-FFF2-40B4-BE49-F238E27FC236}">
-                <a16:creationId xmlns:a16="http://schemas.microsoft.com/office/drawing/2014/main" id="{16AC85F8-E16F-40E1-8A3C-D8BF5D695815}"/>
+                <a16:creationId xmlns:a16="http://schemas.microsoft.com/office/drawing/2014/main" id="{49DFC1E0-69CB-4BAE-BF04-DE6ACC64E4C7}"/>
               </a:ext>
             </a:extLst>
           </p:cNvPr>
@@ -14833,7 +14833,7 @@
           <p:cNvPr id="3" name="">
             <a:extLst xmlns:a="http://schemas.openxmlformats.org/drawingml/2006/main">
               <a:ext uri="{FF2B5EF4-FFF2-40B4-BE49-F238E27FC236}">
-                <a16:creationId xmlns:a16="http://schemas.microsoft.com/office/drawing/2014/main" id="{8E55828A-01C3-4ADE-B7D5-601A68675410}"/>
+                <a16:creationId xmlns:a16="http://schemas.microsoft.com/office/drawing/2014/main" id="{D08A4D66-9314-40D4-834A-1F4DED2F4119}"/>
               </a:ext>
             </a:extLst>
           </p:cNvPr>
@@ -14901,7 +14901,7 @@
           <p:cNvPr id="4" name="">
             <a:extLst xmlns:a="http://schemas.openxmlformats.org/drawingml/2006/main">
               <a:ext uri="{FF2B5EF4-FFF2-40B4-BE49-F238E27FC236}">
-                <a16:creationId xmlns:a16="http://schemas.microsoft.com/office/drawing/2014/main" id="{B2BDC7FA-3F2A-490C-8727-FDAE0B04CFC8}"/>
+                <a16:creationId xmlns:a16="http://schemas.microsoft.com/office/drawing/2014/main" id="{1BC7EE7D-FCFA-42A5-9A33-B4EA0A631A60}"/>
               </a:ext>
             </a:extLst>
           </p:cNvPr>
@@ -15323,7 +15323,7 @@
           <p:cNvPr id="5" name="">
             <a:extLst xmlns:a="http://schemas.openxmlformats.org/drawingml/2006/main">
               <a:ext uri="{FF2B5EF4-FFF2-40B4-BE49-F238E27FC236}">
-                <a16:creationId xmlns:a16="http://schemas.microsoft.com/office/drawing/2014/main" id="{52AC293D-C723-477E-A40C-26BFE2ACAF02}"/>
+                <a16:creationId xmlns:a16="http://schemas.microsoft.com/office/drawing/2014/main" id="{64E444CD-8241-4CEB-AAB4-493ED6328A21}"/>
               </a:ext>
             </a:extLst>
           </p:cNvPr>
@@ -15391,7 +15391,7 @@
           <p:cNvPr id="6" name="">
             <a:extLst xmlns:a="http://schemas.openxmlformats.org/drawingml/2006/main">
               <a:ext uri="{FF2B5EF4-FFF2-40B4-BE49-F238E27FC236}">
-                <a16:creationId xmlns:a16="http://schemas.microsoft.com/office/drawing/2014/main" id="{4354452D-A602-40BA-BD43-C829B1E2C915}"/>
+                <a16:creationId xmlns:a16="http://schemas.microsoft.com/office/drawing/2014/main" id="{ECD56AB4-33A4-4E1E-B48A-34D634B2EC41}"/>
               </a:ext>
             </a:extLst>
           </p:cNvPr>
@@ -15459,7 +15459,7 @@
           <p:cNvPr id="7" name="">
             <a:extLst xmlns:a="http://schemas.openxmlformats.org/drawingml/2006/main">
               <a:ext uri="{FF2B5EF4-FFF2-40B4-BE49-F238E27FC236}">
-                <a16:creationId xmlns:a16="http://schemas.microsoft.com/office/drawing/2014/main" id="{F777D265-14DA-4131-8F41-07BBDFDC7645}"/>
+                <a16:creationId xmlns:a16="http://schemas.microsoft.com/office/drawing/2014/main" id="{517807CC-AF0A-45F9-B828-3D0512547EE3}"/>
               </a:ext>
             </a:extLst>
           </p:cNvPr>
@@ -15525,7 +15525,7 @@
     </p:spTree>
     <p:extLst>
       <p:ext uri="{BB962C8B-B14F-4D97-AF65-F5344CB8AC3E}">
-        <p14:creationId xmlns:p14="http://schemas.microsoft.com/office/powerpoint/2010/main" val="1945066792"/>
+        <p14:creationId xmlns:p14="http://schemas.microsoft.com/office/powerpoint/2010/main" val="1205300107"/>
       </p:ext>
     </p:extLst>
   </p:cSld>

</xml_diff>

<commit_message>
Illustrate week 5 lab and require questions before answers (#50)
</commit_message>
<xml_diff>
--- a/lendet/2026-2027/mobile/lectures/ligjerata-05-hyrja-lejet-rideshare-2026.pptx
+++ b/lendet/2026-2027/mobile/lectures/ligjerata-05-hyrja-lejet-rideshare-2026.pptx
@@ -2,29 +2,29 @@
 <file path=ppt/presentation.xml><?xml version="1.0" encoding="utf-8"?>
 <p:presentation xmlns:p="http://schemas.openxmlformats.org/presentationml/2006/main">
   <p:sldMasterIdLst>
-    <p:sldMasterId xmlns:r="http://schemas.openxmlformats.org/officeDocument/2006/relationships" id="2147483648" r:id="R3824b92e73c74d38"/>
+    <p:sldMasterId xmlns:r="http://schemas.openxmlformats.org/officeDocument/2006/relationships" id="2147483648" r:id="Re6c0461688854029"/>
   </p:sldMasterIdLst>
   <p:sldIdLst>
-    <p:sldId xmlns:r="http://schemas.openxmlformats.org/officeDocument/2006/relationships" id="256" r:id="R5aeb9361a7744bae"/>
-    <p:sldId xmlns:r="http://schemas.openxmlformats.org/officeDocument/2006/relationships" id="257" r:id="R37856cd12ce84310"/>
-    <p:sldId xmlns:r="http://schemas.openxmlformats.org/officeDocument/2006/relationships" id="258" r:id="Rdbe8b0c7b2cf4ce8"/>
-    <p:sldId xmlns:r="http://schemas.openxmlformats.org/officeDocument/2006/relationships" id="259" r:id="R92370f7143204ac4"/>
-    <p:sldId xmlns:r="http://schemas.openxmlformats.org/officeDocument/2006/relationships" id="260" r:id="Rcb8c9e9110f6473b"/>
-    <p:sldId xmlns:r="http://schemas.openxmlformats.org/officeDocument/2006/relationships" id="261" r:id="R7c6766d6b8834c27"/>
-    <p:sldId xmlns:r="http://schemas.openxmlformats.org/officeDocument/2006/relationships" id="262" r:id="Rd0de3b64c82343bf"/>
-    <p:sldId xmlns:r="http://schemas.openxmlformats.org/officeDocument/2006/relationships" id="263" r:id="R2806beedc8814023"/>
-    <p:sldId xmlns:r="http://schemas.openxmlformats.org/officeDocument/2006/relationships" id="264" r:id="R1edcd3bbaa014ead"/>
-    <p:sldId xmlns:r="http://schemas.openxmlformats.org/officeDocument/2006/relationships" id="265" r:id="Rfdfe8ab1d65e4d2f"/>
-    <p:sldId xmlns:r="http://schemas.openxmlformats.org/officeDocument/2006/relationships" id="266" r:id="R7c0e9807e5b94a0c"/>
-    <p:sldId xmlns:r="http://schemas.openxmlformats.org/officeDocument/2006/relationships" id="267" r:id="R701df630cf7846b2"/>
-    <p:sldId xmlns:r="http://schemas.openxmlformats.org/officeDocument/2006/relationships" id="268" r:id="Rdb3554a159834d64"/>
-    <p:sldId xmlns:r="http://schemas.openxmlformats.org/officeDocument/2006/relationships" id="269" r:id="R9badbbc92e1f4910"/>
-    <p:sldId xmlns:r="http://schemas.openxmlformats.org/officeDocument/2006/relationships" id="270" r:id="Rbddf241b16164ce9"/>
-    <p:sldId xmlns:r="http://schemas.openxmlformats.org/officeDocument/2006/relationships" id="271" r:id="R924f6b720c5b460d"/>
-    <p:sldId xmlns:r="http://schemas.openxmlformats.org/officeDocument/2006/relationships" id="272" r:id="Ra7f50215da1e41eb"/>
-    <p:sldId xmlns:r="http://schemas.openxmlformats.org/officeDocument/2006/relationships" id="273" r:id="Raf8826742efb4821"/>
-    <p:sldId xmlns:r="http://schemas.openxmlformats.org/officeDocument/2006/relationships" id="274" r:id="Rb0e0e80c3e494609"/>
-    <p:sldId xmlns:r="http://schemas.openxmlformats.org/officeDocument/2006/relationships" id="275" r:id="R7f49de06340d45c4"/>
+    <p:sldId xmlns:r="http://schemas.openxmlformats.org/officeDocument/2006/relationships" id="256" r:id="R07da8900fdbd436d"/>
+    <p:sldId xmlns:r="http://schemas.openxmlformats.org/officeDocument/2006/relationships" id="257" r:id="R9affa4b292c34e47"/>
+    <p:sldId xmlns:r="http://schemas.openxmlformats.org/officeDocument/2006/relationships" id="258" r:id="R028e769b095d458d"/>
+    <p:sldId xmlns:r="http://schemas.openxmlformats.org/officeDocument/2006/relationships" id="259" r:id="Rb2fa812846094158"/>
+    <p:sldId xmlns:r="http://schemas.openxmlformats.org/officeDocument/2006/relationships" id="260" r:id="R96f5cfe992d44a52"/>
+    <p:sldId xmlns:r="http://schemas.openxmlformats.org/officeDocument/2006/relationships" id="261" r:id="R367f7d4167dc4299"/>
+    <p:sldId xmlns:r="http://schemas.openxmlformats.org/officeDocument/2006/relationships" id="262" r:id="Rfc6f0dc542c84f00"/>
+    <p:sldId xmlns:r="http://schemas.openxmlformats.org/officeDocument/2006/relationships" id="263" r:id="R5bb25875755d4a37"/>
+    <p:sldId xmlns:r="http://schemas.openxmlformats.org/officeDocument/2006/relationships" id="264" r:id="Rd259049c2c91400f"/>
+    <p:sldId xmlns:r="http://schemas.openxmlformats.org/officeDocument/2006/relationships" id="265" r:id="Rfec50c535a0a438b"/>
+    <p:sldId xmlns:r="http://schemas.openxmlformats.org/officeDocument/2006/relationships" id="266" r:id="R1278c3d84c40424e"/>
+    <p:sldId xmlns:r="http://schemas.openxmlformats.org/officeDocument/2006/relationships" id="267" r:id="R7da3158362434e8d"/>
+    <p:sldId xmlns:r="http://schemas.openxmlformats.org/officeDocument/2006/relationships" id="268" r:id="R93ed994579ff41a6"/>
+    <p:sldId xmlns:r="http://schemas.openxmlformats.org/officeDocument/2006/relationships" id="269" r:id="Rde186ae04867440b"/>
+    <p:sldId xmlns:r="http://schemas.openxmlformats.org/officeDocument/2006/relationships" id="270" r:id="R6e587f706f874a62"/>
+    <p:sldId xmlns:r="http://schemas.openxmlformats.org/officeDocument/2006/relationships" id="271" r:id="R1280b6c64a334d69"/>
+    <p:sldId xmlns:r="http://schemas.openxmlformats.org/officeDocument/2006/relationships" id="272" r:id="R88a714e39eba41ab"/>
+    <p:sldId xmlns:r="http://schemas.openxmlformats.org/officeDocument/2006/relationships" id="273" r:id="Rd5e52cb76bf74398"/>
+    <p:sldId xmlns:r="http://schemas.openxmlformats.org/officeDocument/2006/relationships" id="274" r:id="Rb7dbde05e3c0454e"/>
+    <p:sldId xmlns:r="http://schemas.openxmlformats.org/officeDocument/2006/relationships" id="275" r:id="R68851af7ea964f0d"/>
   </p:sldIdLst>
   <p:sldSz cx="12192000" cy="6858000"/>
   <p:notesSz cx="6858000" cy="9144000"/>
@@ -48,7 +48,7 @@
           <p:cNvPr id="3" name="Title">
             <a:extLst xmlns:a="http://schemas.openxmlformats.org/drawingml/2006/main">
               <a:ext uri="{FF2B5EF4-FFF2-40B4-BE49-F238E27FC236}">
-                <a16:creationId xmlns:a16="http://schemas.microsoft.com/office/drawing/2014/main" id="{CD110574-50CA-4AFB-A783-FBB57A260829}"/>
+                <a16:creationId xmlns:a16="http://schemas.microsoft.com/office/drawing/2014/main" id="{29B51D88-EED4-45C6-B81C-0393C6A51168}"/>
               </a:ext>
             </a:extLst>
           </p:cNvPr>
@@ -205,7 +205,7 @@
           <p:cNvPr id="2" name="Subtitle">
             <a:extLst xmlns:a="http://schemas.openxmlformats.org/drawingml/2006/main">
               <a:ext uri="{FF2B5EF4-FFF2-40B4-BE49-F238E27FC236}">
-                <a16:creationId xmlns:a16="http://schemas.microsoft.com/office/drawing/2014/main" id="{C13BAC9B-E722-45DA-9EB8-6F3F4C5ADC51}"/>
+                <a16:creationId xmlns:a16="http://schemas.microsoft.com/office/drawing/2014/main" id="{408FCA49-D2E2-43A3-A188-15A256324869}"/>
               </a:ext>
             </a:extLst>
           </p:cNvPr>
@@ -379,7 +379,7 @@
           <p:cNvPr id="2" name="Section title">
             <a:extLst xmlns:a="http://schemas.openxmlformats.org/drawingml/2006/main">
               <a:ext uri="{FF2B5EF4-FFF2-40B4-BE49-F238E27FC236}">
-                <a16:creationId xmlns:a16="http://schemas.microsoft.com/office/drawing/2014/main" id="{C114AB8B-8564-44E7-8993-1B24894E7186}"/>
+                <a16:creationId xmlns:a16="http://schemas.microsoft.com/office/drawing/2014/main" id="{74B70489-5E4C-4922-85E4-0E590D405378}"/>
               </a:ext>
             </a:extLst>
           </p:cNvPr>
@@ -553,7 +553,7 @@
           <p:cNvPr id="3" name="Title">
             <a:extLst xmlns:a="http://schemas.openxmlformats.org/drawingml/2006/main">
               <a:ext uri="{FF2B5EF4-FFF2-40B4-BE49-F238E27FC236}">
-                <a16:creationId xmlns:a16="http://schemas.microsoft.com/office/drawing/2014/main" id="{9B16612E-F743-43EE-9597-1B3596E4FE94}"/>
+                <a16:creationId xmlns:a16="http://schemas.microsoft.com/office/drawing/2014/main" id="{5D9DB8E1-FBE8-45E2-A9AE-C2EA4A3B20D8}"/>
               </a:ext>
             </a:extLst>
           </p:cNvPr>
@@ -710,7 +710,7 @@
           <p:cNvPr id="2" name="Body">
             <a:extLst xmlns:a="http://schemas.openxmlformats.org/drawingml/2006/main">
               <a:ext uri="{FF2B5EF4-FFF2-40B4-BE49-F238E27FC236}">
-                <a16:creationId xmlns:a16="http://schemas.microsoft.com/office/drawing/2014/main" id="{B5FA6B68-5181-4311-A1C7-897D602176F3}"/>
+                <a16:creationId xmlns:a16="http://schemas.microsoft.com/office/drawing/2014/main" id="{C35BB0BA-036D-485C-B418-8ED25506B259}"/>
               </a:ext>
             </a:extLst>
           </p:cNvPr>
@@ -884,7 +884,7 @@
           <p:cNvPr id="4" name="Title">
             <a:extLst xmlns:a="http://schemas.openxmlformats.org/drawingml/2006/main">
               <a:ext uri="{FF2B5EF4-FFF2-40B4-BE49-F238E27FC236}">
-                <a16:creationId xmlns:a16="http://schemas.microsoft.com/office/drawing/2014/main" id="{695182B6-0DAE-4208-9DBE-C7AF65DD73D6}"/>
+                <a16:creationId xmlns:a16="http://schemas.microsoft.com/office/drawing/2014/main" id="{C5A7F206-87B0-4110-A32D-FC039F09F26D}"/>
               </a:ext>
             </a:extLst>
           </p:cNvPr>
@@ -1041,7 +1041,7 @@
           <p:cNvPr id="2" name="Left column">
             <a:extLst xmlns:a="http://schemas.openxmlformats.org/drawingml/2006/main">
               <a:ext uri="{FF2B5EF4-FFF2-40B4-BE49-F238E27FC236}">
-                <a16:creationId xmlns:a16="http://schemas.microsoft.com/office/drawing/2014/main" id="{8FCF9555-5051-4249-9E0F-6A550D82159F}"/>
+                <a16:creationId xmlns:a16="http://schemas.microsoft.com/office/drawing/2014/main" id="{C11BCAFC-2FB1-4042-8C3B-BCF07742B16F}"/>
               </a:ext>
             </a:extLst>
           </p:cNvPr>
@@ -1198,7 +1198,7 @@
           <p:cNvPr id="3" name="Right column">
             <a:extLst xmlns:a="http://schemas.openxmlformats.org/drawingml/2006/main">
               <a:ext uri="{FF2B5EF4-FFF2-40B4-BE49-F238E27FC236}">
-                <a16:creationId xmlns:a16="http://schemas.microsoft.com/office/drawing/2014/main" id="{931124EA-B5EA-4CD8-B8E1-CE2D6FEDC133}"/>
+                <a16:creationId xmlns:a16="http://schemas.microsoft.com/office/drawing/2014/main" id="{F0D058A2-5EB0-4D0D-BC6A-75F455BD1010}"/>
               </a:ext>
             </a:extLst>
           </p:cNvPr>
@@ -1372,7 +1372,7 @@
           <p:cNvPr id="3" name="Title">
             <a:extLst xmlns:a="http://schemas.openxmlformats.org/drawingml/2006/main">
               <a:ext uri="{FF2B5EF4-FFF2-40B4-BE49-F238E27FC236}">
-                <a16:creationId xmlns:a16="http://schemas.microsoft.com/office/drawing/2014/main" id="{9BDB61CF-28A8-4429-8935-26ABCD977AF1}"/>
+                <a16:creationId xmlns:a16="http://schemas.microsoft.com/office/drawing/2014/main" id="{3DDDB6B8-6E1B-436D-8C71-E75B5B4B1C13}"/>
               </a:ext>
             </a:extLst>
           </p:cNvPr>
@@ -1529,7 +1529,7 @@
           <p:cNvPr id="2" name="Left column">
             <a:extLst xmlns:a="http://schemas.openxmlformats.org/drawingml/2006/main">
               <a:ext uri="{FF2B5EF4-FFF2-40B4-BE49-F238E27FC236}">
-                <a16:creationId xmlns:a16="http://schemas.microsoft.com/office/drawing/2014/main" id="{F6AF6C09-DF4A-442C-BDAC-F9C35B8C1E98}"/>
+                <a16:creationId xmlns:a16="http://schemas.microsoft.com/office/drawing/2014/main" id="{58DE0553-1398-4F53-854E-378733AD6EA9}"/>
               </a:ext>
             </a:extLst>
           </p:cNvPr>
@@ -1724,12 +1724,12 @@
   </p:cSld>
   <p:clrMap bg1="lt1" tx1="dk1" bg2="lt2" tx2="dk2" accent1="accent1" accent2="accent2" accent3="accent3" accent4="accent4" accent5="accent5" accent6="accent6" hlink="hlink" folHlink="folHlink"/>
   <p:sldLayoutIdLst>
-    <p:sldLayoutId xmlns:r="http://schemas.openxmlformats.org/officeDocument/2006/relationships" id="2147483649" r:id="Rdd3280250b85454d"/>
-    <p:sldLayoutId xmlns:r="http://schemas.openxmlformats.org/officeDocument/2006/relationships" id="2147483650" r:id="R434c3da4c8234310"/>
-    <p:sldLayoutId xmlns:r="http://schemas.openxmlformats.org/officeDocument/2006/relationships" id="2147483651" r:id="R56f3d5167ccd47b4"/>
-    <p:sldLayoutId xmlns:r="http://schemas.openxmlformats.org/officeDocument/2006/relationships" id="2147483652" r:id="R4b3c14d6b62a4e78"/>
-    <p:sldLayoutId xmlns:r="http://schemas.openxmlformats.org/officeDocument/2006/relationships" id="2147483653" r:id="R4d1669741fc14f7c"/>
-    <p:sldLayoutId xmlns:r="http://schemas.openxmlformats.org/officeDocument/2006/relationships" id="2147483654" r:id="R8223010e007143f1"/>
+    <p:sldLayoutId xmlns:r="http://schemas.openxmlformats.org/officeDocument/2006/relationships" id="2147483649" r:id="R988b826a36d14ac5"/>
+    <p:sldLayoutId xmlns:r="http://schemas.openxmlformats.org/officeDocument/2006/relationships" id="2147483650" r:id="R911df8b2aeb047c7"/>
+    <p:sldLayoutId xmlns:r="http://schemas.openxmlformats.org/officeDocument/2006/relationships" id="2147483651" r:id="R69ee2c8a129f4983"/>
+    <p:sldLayoutId xmlns:r="http://schemas.openxmlformats.org/officeDocument/2006/relationships" id="2147483652" r:id="R01c46ec46d8d4845"/>
+    <p:sldLayoutId xmlns:r="http://schemas.openxmlformats.org/officeDocument/2006/relationships" id="2147483653" r:id="R0f3c48cf3e004c6a"/>
+    <p:sldLayoutId xmlns:r="http://schemas.openxmlformats.org/officeDocument/2006/relationships" id="2147483654" r:id="R39437dc9bb0448c4"/>
   </p:sldLayoutIdLst>
   <p:txStyles>
     <p:titleStyle>
@@ -2280,7 +2280,7 @@
           <p:cNvPr id="9" name="">
             <a:extLst xmlns:a="http://schemas.openxmlformats.org/drawingml/2006/main">
               <a:ext uri="{FF2B5EF4-FFF2-40B4-BE49-F238E27FC236}">
-                <a16:creationId xmlns:a16="http://schemas.microsoft.com/office/drawing/2014/main" id="{73F71B9D-3E4B-4A1F-ADC1-4B4FDFABAA8C}"/>
+                <a16:creationId xmlns:a16="http://schemas.microsoft.com/office/drawing/2014/main" id="{B5638046-A4F6-48B3-8713-4D2DC4C1E533}"/>
               </a:ext>
             </a:extLst>
           </p:cNvPr>
@@ -2348,7 +2348,7 @@
           <p:cNvPr id="2" name="">
             <a:extLst xmlns:a="http://schemas.openxmlformats.org/drawingml/2006/main">
               <a:ext uri="{FF2B5EF4-FFF2-40B4-BE49-F238E27FC236}">
-                <a16:creationId xmlns:a16="http://schemas.microsoft.com/office/drawing/2014/main" id="{A69426D2-8B26-40BC-9707-FE7DB41F23FA}"/>
+                <a16:creationId xmlns:a16="http://schemas.microsoft.com/office/drawing/2014/main" id="{E6B150A4-5CEA-4BEC-96EC-1E0163391DF4}"/>
               </a:ext>
             </a:extLst>
           </p:cNvPr>
@@ -2416,7 +2416,7 @@
           <p:cNvPr id="3" name="">
             <a:extLst xmlns:a="http://schemas.openxmlformats.org/drawingml/2006/main">
               <a:ext uri="{FF2B5EF4-FFF2-40B4-BE49-F238E27FC236}">
-                <a16:creationId xmlns:a16="http://schemas.microsoft.com/office/drawing/2014/main" id="{B64E0458-317D-4DD9-A85B-E61E6DB0F421}"/>
+                <a16:creationId xmlns:a16="http://schemas.microsoft.com/office/drawing/2014/main" id="{DF84C3EE-B2B1-406A-B8D3-82658FEACC6A}"/>
               </a:ext>
             </a:extLst>
           </p:cNvPr>
@@ -2426,7 +2426,7 @@
           <p:nvPr/>
         </p:nvPicPr>
         <p:blipFill>
-          <a:blip xmlns:r="http://schemas.openxmlformats.org/officeDocument/2006/relationships" xmlns:a="http://schemas.openxmlformats.org/drawingml/2006/main" r:embed="R825d9c756e514b54"/>
+          <a:blip xmlns:r="http://schemas.openxmlformats.org/officeDocument/2006/relationships" xmlns:a="http://schemas.openxmlformats.org/drawingml/2006/main" r:embed="R742b510e16f94417"/>
           <a:stretch xmlns:a="http://schemas.openxmlformats.org/drawingml/2006/main"/>
         </p:blipFill>
         <p:spPr>
@@ -2444,7 +2444,7 @@
           <p:cNvPr id="4" name="">
             <a:extLst xmlns:a="http://schemas.openxmlformats.org/drawingml/2006/main">
               <a:ext uri="{FF2B5EF4-FFF2-40B4-BE49-F238E27FC236}">
-                <a16:creationId xmlns:a16="http://schemas.microsoft.com/office/drawing/2014/main" id="{CED6993B-5605-48FF-A003-D6D71671366D}"/>
+                <a16:creationId xmlns:a16="http://schemas.microsoft.com/office/drawing/2014/main" id="{2E616C75-08DF-42FD-888F-88FEE1AB7B79}"/>
               </a:ext>
             </a:extLst>
           </p:cNvPr>
@@ -2512,7 +2512,7 @@
           <p:cNvPr id="5" name="">
             <a:extLst xmlns:a="http://schemas.openxmlformats.org/drawingml/2006/main">
               <a:ext uri="{FF2B5EF4-FFF2-40B4-BE49-F238E27FC236}">
-                <a16:creationId xmlns:a16="http://schemas.microsoft.com/office/drawing/2014/main" id="{5D877D8F-048D-486D-9E27-B765069E7F06}"/>
+                <a16:creationId xmlns:a16="http://schemas.microsoft.com/office/drawing/2014/main" id="{F04C2224-8926-4962-9C6E-787119A68EC2}"/>
               </a:ext>
             </a:extLst>
           </p:cNvPr>
@@ -2608,7 +2608,7 @@
           <p:cNvPr id="6" name="">
             <a:extLst xmlns:a="http://schemas.openxmlformats.org/drawingml/2006/main">
               <a:ext uri="{FF2B5EF4-FFF2-40B4-BE49-F238E27FC236}">
-                <a16:creationId xmlns:a16="http://schemas.microsoft.com/office/drawing/2014/main" id="{8E91072E-1889-4B0A-9180-0446D62135DB}"/>
+                <a16:creationId xmlns:a16="http://schemas.microsoft.com/office/drawing/2014/main" id="{7D9AB602-DC2C-405F-9ECC-B1941F718278}"/>
               </a:ext>
             </a:extLst>
           </p:cNvPr>
@@ -2666,7 +2666,7 @@
                 <a:ea typeface="Arial"/>
                 <a:cs typeface="Arial"/>
               </a:rPr>
-              <a:t>Parashiko para demonstrimit</a:t>
+              <a:t>A mjafton hyrja me GitHub për ta ndryshuar orën?</a:t>
             </a:r>
           </a:p>
         </p:txBody>
@@ -2676,7 +2676,7 @@
           <p:cNvPr id="7" name="">
             <a:extLst xmlns:a="http://schemas.openxmlformats.org/drawingml/2006/main">
               <a:ext uri="{FF2B5EF4-FFF2-40B4-BE49-F238E27FC236}">
-                <a16:creationId xmlns:a16="http://schemas.microsoft.com/office/drawing/2014/main" id="{A5FB5E82-9946-47F8-B707-EA3E6F9F8819}"/>
+                <a16:creationId xmlns:a16="http://schemas.microsoft.com/office/drawing/2014/main" id="{E1B613FA-3BE0-42E0-8555-E8C76CBB7D75}"/>
               </a:ext>
             </a:extLst>
           </p:cNvPr>
@@ -2800,7 +2800,7 @@
           <p:cNvPr id="8" name="">
             <a:extLst xmlns:a="http://schemas.openxmlformats.org/drawingml/2006/main">
               <a:ext uri="{FF2B5EF4-FFF2-40B4-BE49-F238E27FC236}">
-                <a16:creationId xmlns:a16="http://schemas.microsoft.com/office/drawing/2014/main" id="{A013FC96-39C8-4491-A5D1-0C472616F8F0}"/>
+                <a16:creationId xmlns:a16="http://schemas.microsoft.com/office/drawing/2014/main" id="{D5DABB34-5C9A-4783-AD16-4297E852CFC0}"/>
               </a:ext>
             </a:extLst>
           </p:cNvPr>
@@ -2866,7 +2866,7 @@
     </p:spTree>
     <p:extLst>
       <p:ext uri="{BB962C8B-B14F-4D97-AF65-F5344CB8AC3E}">
-        <p14:creationId xmlns:p14="http://schemas.microsoft.com/office/powerpoint/2010/main" val="559278306"/>
+        <p14:creationId xmlns:p14="http://schemas.microsoft.com/office/powerpoint/2010/main" val="337439799"/>
       </p:ext>
     </p:extLst>
   </p:cSld>
@@ -2897,7 +2897,7 @@
           <p:cNvPr id="15" name="">
             <a:extLst xmlns:a="http://schemas.openxmlformats.org/drawingml/2006/main">
               <a:ext uri="{FF2B5EF4-FFF2-40B4-BE49-F238E27FC236}">
-                <a16:creationId xmlns:a16="http://schemas.microsoft.com/office/drawing/2014/main" id="{C4B50364-9408-470E-B7C9-22E97FC4F4F8}"/>
+                <a16:creationId xmlns:a16="http://schemas.microsoft.com/office/drawing/2014/main" id="{91BECA9E-4F12-4258-984F-F4C8060669AA}"/>
               </a:ext>
             </a:extLst>
           </p:cNvPr>
@@ -2965,7 +2965,7 @@
           <p:cNvPr id="2" name="">
             <a:extLst xmlns:a="http://schemas.openxmlformats.org/drawingml/2006/main">
               <a:ext uri="{FF2B5EF4-FFF2-40B4-BE49-F238E27FC236}">
-                <a16:creationId xmlns:a16="http://schemas.microsoft.com/office/drawing/2014/main" id="{B343983E-61D0-404F-916D-9968F969DB02}"/>
+                <a16:creationId xmlns:a16="http://schemas.microsoft.com/office/drawing/2014/main" id="{970F33CD-19C1-4E93-BB0E-8429B4E165C7}"/>
               </a:ext>
             </a:extLst>
           </p:cNvPr>
@@ -3033,7 +3033,7 @@
           <p:cNvPr id="3" name="">
             <a:extLst xmlns:a="http://schemas.openxmlformats.org/drawingml/2006/main">
               <a:ext uri="{FF2B5EF4-FFF2-40B4-BE49-F238E27FC236}">
-                <a16:creationId xmlns:a16="http://schemas.microsoft.com/office/drawing/2014/main" id="{A97FD746-5240-4BC7-973B-56995632D0ED}"/>
+                <a16:creationId xmlns:a16="http://schemas.microsoft.com/office/drawing/2014/main" id="{70662C05-E509-44EB-921C-B8BF4C3EDB26}"/>
               </a:ext>
             </a:extLst>
           </p:cNvPr>
@@ -3101,7 +3101,7 @@
           <p:cNvPr id="4" name="">
             <a:extLst xmlns:a="http://schemas.openxmlformats.org/drawingml/2006/main">
               <a:ext uri="{FF2B5EF4-FFF2-40B4-BE49-F238E27FC236}">
-                <a16:creationId xmlns:a16="http://schemas.microsoft.com/office/drawing/2014/main" id="{ECD6D15B-032B-47C8-A91E-BF6EB741F7D9}"/>
+                <a16:creationId xmlns:a16="http://schemas.microsoft.com/office/drawing/2014/main" id="{D71D037E-CB67-4E11-9C20-2FDCFF6015FC}"/>
               </a:ext>
             </a:extLst>
           </p:cNvPr>
@@ -3169,7 +3169,7 @@
           <p:cNvPr id="5" name="">
             <a:extLst xmlns:a="http://schemas.openxmlformats.org/drawingml/2006/main">
               <a:ext uri="{FF2B5EF4-FFF2-40B4-BE49-F238E27FC236}">
-                <a16:creationId xmlns:a16="http://schemas.microsoft.com/office/drawing/2014/main" id="{A65F5A87-0692-4D2B-8A61-769D0C61509F}"/>
+                <a16:creationId xmlns:a16="http://schemas.microsoft.com/office/drawing/2014/main" id="{03F251A9-1BCE-43B0-BD0F-E1C055FC3D3F}"/>
               </a:ext>
             </a:extLst>
           </p:cNvPr>
@@ -3237,7 +3237,7 @@
           <p:cNvPr id="6" name="">
             <a:extLst xmlns:a="http://schemas.openxmlformats.org/drawingml/2006/main">
               <a:ext uri="{FF2B5EF4-FFF2-40B4-BE49-F238E27FC236}">
-                <a16:creationId xmlns:a16="http://schemas.microsoft.com/office/drawing/2014/main" id="{20A872B2-AB07-4104-A6CD-700F4663CF37}"/>
+                <a16:creationId xmlns:a16="http://schemas.microsoft.com/office/drawing/2014/main" id="{523D9A20-232F-492C-9853-BBCEC1DC2AD4}"/>
               </a:ext>
             </a:extLst>
           </p:cNvPr>
@@ -3305,7 +3305,7 @@
           <p:cNvPr id="7" name="">
             <a:extLst xmlns:a="http://schemas.openxmlformats.org/drawingml/2006/main">
               <a:ext uri="{FF2B5EF4-FFF2-40B4-BE49-F238E27FC236}">
-                <a16:creationId xmlns:a16="http://schemas.microsoft.com/office/drawing/2014/main" id="{F32E3BBA-09B3-4572-ADFD-AF9FB45D2306}"/>
+                <a16:creationId xmlns:a16="http://schemas.microsoft.com/office/drawing/2014/main" id="{2F516993-E14E-45BB-8D7C-473DA3E8A46A}"/>
               </a:ext>
             </a:extLst>
           </p:cNvPr>
@@ -3373,7 +3373,7 @@
           <p:cNvPr id="8" name="">
             <a:extLst xmlns:a="http://schemas.openxmlformats.org/drawingml/2006/main">
               <a:ext uri="{FF2B5EF4-FFF2-40B4-BE49-F238E27FC236}">
-                <a16:creationId xmlns:a16="http://schemas.microsoft.com/office/drawing/2014/main" id="{3EE41DA5-6F8E-421C-A085-72BE87081D48}"/>
+                <a16:creationId xmlns:a16="http://schemas.microsoft.com/office/drawing/2014/main" id="{3E5B3A96-F171-49FD-A536-05D14BCF7473}"/>
               </a:ext>
             </a:extLst>
           </p:cNvPr>
@@ -3441,7 +3441,7 @@
           <p:cNvPr id="9" name="">
             <a:extLst xmlns:a="http://schemas.openxmlformats.org/drawingml/2006/main">
               <a:ext uri="{FF2B5EF4-FFF2-40B4-BE49-F238E27FC236}">
-                <a16:creationId xmlns:a16="http://schemas.microsoft.com/office/drawing/2014/main" id="{AFE3E620-554C-48F1-9D06-EB11F7031C87}"/>
+                <a16:creationId xmlns:a16="http://schemas.microsoft.com/office/drawing/2014/main" id="{BF4E63BF-73E0-40A5-869A-F2E8AEA5DB4B}"/>
               </a:ext>
             </a:extLst>
           </p:cNvPr>
@@ -3509,7 +3509,7 @@
           <p:cNvPr id="10" name="">
             <a:extLst xmlns:a="http://schemas.openxmlformats.org/drawingml/2006/main">
               <a:ext uri="{FF2B5EF4-FFF2-40B4-BE49-F238E27FC236}">
-                <a16:creationId xmlns:a16="http://schemas.microsoft.com/office/drawing/2014/main" id="{8D347426-B1A5-43E6-AC08-6E828E26FE1A}"/>
+                <a16:creationId xmlns:a16="http://schemas.microsoft.com/office/drawing/2014/main" id="{2B8EC94C-3D45-4282-B568-4090CFE2448E}"/>
               </a:ext>
             </a:extLst>
           </p:cNvPr>
@@ -3577,7 +3577,7 @@
           <p:cNvPr id="11" name="">
             <a:extLst xmlns:a="http://schemas.openxmlformats.org/drawingml/2006/main">
               <a:ext uri="{FF2B5EF4-FFF2-40B4-BE49-F238E27FC236}">
-                <a16:creationId xmlns:a16="http://schemas.microsoft.com/office/drawing/2014/main" id="{A5EFDBAA-52F4-431D-ABB7-E7973F0C36D5}"/>
+                <a16:creationId xmlns:a16="http://schemas.microsoft.com/office/drawing/2014/main" id="{26764580-2665-4CCF-9282-811909A35BFA}"/>
               </a:ext>
             </a:extLst>
           </p:cNvPr>
@@ -3645,7 +3645,7 @@
           <p:cNvPr id="12" name="">
             <a:extLst xmlns:a="http://schemas.openxmlformats.org/drawingml/2006/main">
               <a:ext uri="{FF2B5EF4-FFF2-40B4-BE49-F238E27FC236}">
-                <a16:creationId xmlns:a16="http://schemas.microsoft.com/office/drawing/2014/main" id="{DEE0250D-14DE-48B6-85BF-8004946B7CBA}"/>
+                <a16:creationId xmlns:a16="http://schemas.microsoft.com/office/drawing/2014/main" id="{45FDF268-83F0-47B2-8846-8A08C167BCFC}"/>
               </a:ext>
             </a:extLst>
           </p:cNvPr>
@@ -3713,7 +3713,7 @@
           <p:cNvPr id="13" name="">
             <a:extLst xmlns:a="http://schemas.openxmlformats.org/drawingml/2006/main">
               <a:ext uri="{FF2B5EF4-FFF2-40B4-BE49-F238E27FC236}">
-                <a16:creationId xmlns:a16="http://schemas.microsoft.com/office/drawing/2014/main" id="{910F4571-F7AC-439F-90FF-0706AF59586D}"/>
+                <a16:creationId xmlns:a16="http://schemas.microsoft.com/office/drawing/2014/main" id="{5F26DBC6-E545-426D-AEAA-A747C2E88947}"/>
               </a:ext>
             </a:extLst>
           </p:cNvPr>
@@ -3781,7 +3781,7 @@
           <p:cNvPr id="14" name="">
             <a:extLst xmlns:a="http://schemas.openxmlformats.org/drawingml/2006/main">
               <a:ext uri="{FF2B5EF4-FFF2-40B4-BE49-F238E27FC236}">
-                <a16:creationId xmlns:a16="http://schemas.microsoft.com/office/drawing/2014/main" id="{6EBBB892-8F9F-422B-9387-EF57F49346A3}"/>
+                <a16:creationId xmlns:a16="http://schemas.microsoft.com/office/drawing/2014/main" id="{EC2F517E-79B9-499A-B2C8-18E7F3FD2777}"/>
               </a:ext>
             </a:extLst>
           </p:cNvPr>
@@ -3847,7 +3847,7 @@
     </p:spTree>
     <p:extLst>
       <p:ext uri="{BB962C8B-B14F-4D97-AF65-F5344CB8AC3E}">
-        <p14:creationId xmlns:p14="http://schemas.microsoft.com/office/powerpoint/2010/main" val="1635409300"/>
+        <p14:creationId xmlns:p14="http://schemas.microsoft.com/office/powerpoint/2010/main" val="506952383"/>
       </p:ext>
     </p:extLst>
   </p:cSld>
@@ -3878,7 +3878,7 @@
           <p:cNvPr id="9" name="">
             <a:extLst xmlns:a="http://schemas.openxmlformats.org/drawingml/2006/main">
               <a:ext uri="{FF2B5EF4-FFF2-40B4-BE49-F238E27FC236}">
-                <a16:creationId xmlns:a16="http://schemas.microsoft.com/office/drawing/2014/main" id="{FD161126-899E-4FC0-A3DC-C3FF2F37FB14}"/>
+                <a16:creationId xmlns:a16="http://schemas.microsoft.com/office/drawing/2014/main" id="{8127A033-B23F-406C-B060-EA8297CC23F1}"/>
               </a:ext>
             </a:extLst>
           </p:cNvPr>
@@ -3946,7 +3946,7 @@
           <p:cNvPr id="2" name="">
             <a:extLst xmlns:a="http://schemas.openxmlformats.org/drawingml/2006/main">
               <a:ext uri="{FF2B5EF4-FFF2-40B4-BE49-F238E27FC236}">
-                <a16:creationId xmlns:a16="http://schemas.microsoft.com/office/drawing/2014/main" id="{4DD24E0B-29C9-47EC-A9AD-67238F266E0B}"/>
+                <a16:creationId xmlns:a16="http://schemas.microsoft.com/office/drawing/2014/main" id="{779898CF-9CDF-4579-88FF-A66E1E6CF2C7}"/>
               </a:ext>
             </a:extLst>
           </p:cNvPr>
@@ -4014,7 +4014,7 @@
           <p:cNvPr id="3" name="">
             <a:extLst xmlns:a="http://schemas.openxmlformats.org/drawingml/2006/main">
               <a:ext uri="{FF2B5EF4-FFF2-40B4-BE49-F238E27FC236}">
-                <a16:creationId xmlns:a16="http://schemas.microsoft.com/office/drawing/2014/main" id="{EDA8114D-3B12-416D-B563-405760700000}"/>
+                <a16:creationId xmlns:a16="http://schemas.microsoft.com/office/drawing/2014/main" id="{5068C3AE-EA5C-4357-AE94-65A5DCD3DD12}"/>
               </a:ext>
             </a:extLst>
           </p:cNvPr>
@@ -4082,7 +4082,7 @@
           <p:cNvPr id="4" name="">
             <a:extLst xmlns:a="http://schemas.openxmlformats.org/drawingml/2006/main">
               <a:ext uri="{FF2B5EF4-FFF2-40B4-BE49-F238E27FC236}">
-                <a16:creationId xmlns:a16="http://schemas.microsoft.com/office/drawing/2014/main" id="{7B8CA8C1-AEEF-43C7-BC3F-53824E707CA5}"/>
+                <a16:creationId xmlns:a16="http://schemas.microsoft.com/office/drawing/2014/main" id="{1A01239D-7EE8-47DE-A39F-ED208DCD0D70}"/>
               </a:ext>
             </a:extLst>
           </p:cNvPr>
@@ -4178,7 +4178,7 @@
           <p:cNvPr id="5" name="">
             <a:extLst xmlns:a="http://schemas.openxmlformats.org/drawingml/2006/main">
               <a:ext uri="{FF2B5EF4-FFF2-40B4-BE49-F238E27FC236}">
-                <a16:creationId xmlns:a16="http://schemas.microsoft.com/office/drawing/2014/main" id="{4DC2C2B9-FC0C-4DEB-BD3F-7D8A7F555A69}"/>
+                <a16:creationId xmlns:a16="http://schemas.microsoft.com/office/drawing/2014/main" id="{08C930B4-D571-41C9-B1A6-341EBB797DF7}"/>
               </a:ext>
             </a:extLst>
           </p:cNvPr>
@@ -4292,7 +4292,7 @@
           <p:cNvPr id="6" name="">
             <a:extLst xmlns:a="http://schemas.openxmlformats.org/drawingml/2006/main">
               <a:ext uri="{FF2B5EF4-FFF2-40B4-BE49-F238E27FC236}">
-                <a16:creationId xmlns:a16="http://schemas.microsoft.com/office/drawing/2014/main" id="{8020D398-BE07-4165-BFC0-CDB2401502DD}"/>
+                <a16:creationId xmlns:a16="http://schemas.microsoft.com/office/drawing/2014/main" id="{FDB24098-E50C-4D1B-8A33-4328D8AEBBBD}"/>
               </a:ext>
             </a:extLst>
           </p:cNvPr>
@@ -4360,7 +4360,7 @@
           <p:cNvPr id="7" name="">
             <a:extLst xmlns:a="http://schemas.openxmlformats.org/drawingml/2006/main">
               <a:ext uri="{FF2B5EF4-FFF2-40B4-BE49-F238E27FC236}">
-                <a16:creationId xmlns:a16="http://schemas.microsoft.com/office/drawing/2014/main" id="{012477C9-20C7-4470-A44C-CB4D7DBF66A0}"/>
+                <a16:creationId xmlns:a16="http://schemas.microsoft.com/office/drawing/2014/main" id="{F4B7BDDB-0102-44DC-9E8B-418210E52FB1}"/>
               </a:ext>
             </a:extLst>
           </p:cNvPr>
@@ -4428,7 +4428,7 @@
           <p:cNvPr id="8" name="">
             <a:extLst xmlns:a="http://schemas.openxmlformats.org/drawingml/2006/main">
               <a:ext uri="{FF2B5EF4-FFF2-40B4-BE49-F238E27FC236}">
-                <a16:creationId xmlns:a16="http://schemas.microsoft.com/office/drawing/2014/main" id="{BCE48FB6-95A3-4ECD-86C8-191CFE0A8D14}"/>
+                <a16:creationId xmlns:a16="http://schemas.microsoft.com/office/drawing/2014/main" id="{F28E968A-3E8D-4177-83C5-173F8C4D48AE}"/>
               </a:ext>
             </a:extLst>
           </p:cNvPr>
@@ -4494,7 +4494,7 @@
     </p:spTree>
     <p:extLst>
       <p:ext uri="{BB962C8B-B14F-4D97-AF65-F5344CB8AC3E}">
-        <p14:creationId xmlns:p14="http://schemas.microsoft.com/office/powerpoint/2010/main" val="1188986536"/>
+        <p14:creationId xmlns:p14="http://schemas.microsoft.com/office/powerpoint/2010/main" val="2108096583"/>
       </p:ext>
     </p:extLst>
   </p:cSld>
@@ -4525,7 +4525,7 @@
           <p:cNvPr id="12" name="">
             <a:extLst xmlns:a="http://schemas.openxmlformats.org/drawingml/2006/main">
               <a:ext uri="{FF2B5EF4-FFF2-40B4-BE49-F238E27FC236}">
-                <a16:creationId xmlns:a16="http://schemas.microsoft.com/office/drawing/2014/main" id="{6F49246D-4CE8-4677-A522-68C2D18B34B0}"/>
+                <a16:creationId xmlns:a16="http://schemas.microsoft.com/office/drawing/2014/main" id="{39531F75-A950-4299-BEA7-BDCD4B352786}"/>
               </a:ext>
             </a:extLst>
           </p:cNvPr>
@@ -4593,7 +4593,7 @@
           <p:cNvPr id="2" name="">
             <a:extLst xmlns:a="http://schemas.openxmlformats.org/drawingml/2006/main">
               <a:ext uri="{FF2B5EF4-FFF2-40B4-BE49-F238E27FC236}">
-                <a16:creationId xmlns:a16="http://schemas.microsoft.com/office/drawing/2014/main" id="{9A1C87B0-ECDB-4A24-B1AB-E69434FD9BD5}"/>
+                <a16:creationId xmlns:a16="http://schemas.microsoft.com/office/drawing/2014/main" id="{EA66C464-6089-4974-A353-334FB0296DD5}"/>
               </a:ext>
             </a:extLst>
           </p:cNvPr>
@@ -4661,7 +4661,7 @@
           <p:cNvPr id="3" name="">
             <a:extLst xmlns:a="http://schemas.openxmlformats.org/drawingml/2006/main">
               <a:ext uri="{FF2B5EF4-FFF2-40B4-BE49-F238E27FC236}">
-                <a16:creationId xmlns:a16="http://schemas.microsoft.com/office/drawing/2014/main" id="{8E0E9E4B-BBE2-4C81-AF73-39FAD72D1902}"/>
+                <a16:creationId xmlns:a16="http://schemas.microsoft.com/office/drawing/2014/main" id="{1FE7D9C1-18A5-4DC1-949E-3B11D2E8FCA1}"/>
               </a:ext>
             </a:extLst>
           </p:cNvPr>
@@ -4729,7 +4729,7 @@
           <p:cNvPr id="4" name="">
             <a:extLst xmlns:a="http://schemas.openxmlformats.org/drawingml/2006/main">
               <a:ext uri="{FF2B5EF4-FFF2-40B4-BE49-F238E27FC236}">
-                <a16:creationId xmlns:a16="http://schemas.microsoft.com/office/drawing/2014/main" id="{4120606B-2884-46B8-A08C-9CC501CE7782}"/>
+                <a16:creationId xmlns:a16="http://schemas.microsoft.com/office/drawing/2014/main" id="{35487B5A-5A35-45D5-9B56-ADE79BD12D83}"/>
               </a:ext>
             </a:extLst>
           </p:cNvPr>
@@ -4853,7 +4853,7 @@
           <p:cNvPr id="5" name="">
             <a:extLst xmlns:a="http://schemas.openxmlformats.org/drawingml/2006/main">
               <a:ext uri="{FF2B5EF4-FFF2-40B4-BE49-F238E27FC236}">
-                <a16:creationId xmlns:a16="http://schemas.microsoft.com/office/drawing/2014/main" id="{E307F36B-2D76-44DD-AEA3-BA10C5DBED49}"/>
+                <a16:creationId xmlns:a16="http://schemas.microsoft.com/office/drawing/2014/main" id="{73980EF3-E21D-4316-9ABB-A6848110C197}"/>
               </a:ext>
             </a:extLst>
           </p:cNvPr>
@@ -4921,7 +4921,7 @@
           <p:cNvPr id="6" name="">
             <a:extLst xmlns:a="http://schemas.openxmlformats.org/drawingml/2006/main">
               <a:ext uri="{FF2B5EF4-FFF2-40B4-BE49-F238E27FC236}">
-                <a16:creationId xmlns:a16="http://schemas.microsoft.com/office/drawing/2014/main" id="{C0E439B0-F674-4F1A-863E-9BEE24B6C443}"/>
+                <a16:creationId xmlns:a16="http://schemas.microsoft.com/office/drawing/2014/main" id="{5AD38D46-9D1B-4D1E-A2D8-C40FD15F8D4B}"/>
               </a:ext>
             </a:extLst>
           </p:cNvPr>
@@ -4989,7 +4989,7 @@
           <p:cNvPr id="7" name="">
             <a:extLst xmlns:a="http://schemas.openxmlformats.org/drawingml/2006/main">
               <a:ext uri="{FF2B5EF4-FFF2-40B4-BE49-F238E27FC236}">
-                <a16:creationId xmlns:a16="http://schemas.microsoft.com/office/drawing/2014/main" id="{2673E7C0-B305-4823-B043-49A2F9BB4757}"/>
+                <a16:creationId xmlns:a16="http://schemas.microsoft.com/office/drawing/2014/main" id="{512A09EB-3204-4BC3-9A53-85FA96EF2EBC}"/>
               </a:ext>
             </a:extLst>
           </p:cNvPr>
@@ -5057,7 +5057,7 @@
           <p:cNvPr id="8" name="">
             <a:extLst xmlns:a="http://schemas.openxmlformats.org/drawingml/2006/main">
               <a:ext uri="{FF2B5EF4-FFF2-40B4-BE49-F238E27FC236}">
-                <a16:creationId xmlns:a16="http://schemas.microsoft.com/office/drawing/2014/main" id="{7CEB6524-7A45-4780-BB59-F299089EF725}"/>
+                <a16:creationId xmlns:a16="http://schemas.microsoft.com/office/drawing/2014/main" id="{81ABFC11-ED4C-4F24-B353-C5234EF150B7}"/>
               </a:ext>
             </a:extLst>
           </p:cNvPr>
@@ -5125,7 +5125,7 @@
           <p:cNvPr id="9" name="">
             <a:extLst xmlns:a="http://schemas.openxmlformats.org/drawingml/2006/main">
               <a:ext uri="{FF2B5EF4-FFF2-40B4-BE49-F238E27FC236}">
-                <a16:creationId xmlns:a16="http://schemas.microsoft.com/office/drawing/2014/main" id="{BA1D4BB8-215B-4AFA-ABBC-019D4A5AD2CB}"/>
+                <a16:creationId xmlns:a16="http://schemas.microsoft.com/office/drawing/2014/main" id="{30A5141C-1F5D-4FAD-A907-98958FC4A025}"/>
               </a:ext>
             </a:extLst>
           </p:cNvPr>
@@ -5193,7 +5193,7 @@
           <p:cNvPr id="10" name="">
             <a:extLst xmlns:a="http://schemas.openxmlformats.org/drawingml/2006/main">
               <a:ext uri="{FF2B5EF4-FFF2-40B4-BE49-F238E27FC236}">
-                <a16:creationId xmlns:a16="http://schemas.microsoft.com/office/drawing/2014/main" id="{7F458F21-4FA0-45B7-92B9-21A4D1D97377}"/>
+                <a16:creationId xmlns:a16="http://schemas.microsoft.com/office/drawing/2014/main" id="{0616CBC2-DE45-4193-B161-7D73D5C36CA6}"/>
               </a:ext>
             </a:extLst>
           </p:cNvPr>
@@ -5261,7 +5261,7 @@
           <p:cNvPr id="11" name="">
             <a:extLst xmlns:a="http://schemas.openxmlformats.org/drawingml/2006/main">
               <a:ext uri="{FF2B5EF4-FFF2-40B4-BE49-F238E27FC236}">
-                <a16:creationId xmlns:a16="http://schemas.microsoft.com/office/drawing/2014/main" id="{3A4F594A-CD67-491D-8B19-6E244FA66F12}"/>
+                <a16:creationId xmlns:a16="http://schemas.microsoft.com/office/drawing/2014/main" id="{9BD9D9FB-D621-4062-93BD-011BBEE1DB18}"/>
               </a:ext>
             </a:extLst>
           </p:cNvPr>
@@ -5327,7 +5327,7 @@
     </p:spTree>
     <p:extLst>
       <p:ext uri="{BB962C8B-B14F-4D97-AF65-F5344CB8AC3E}">
-        <p14:creationId xmlns:p14="http://schemas.microsoft.com/office/powerpoint/2010/main" val="154318173"/>
+        <p14:creationId xmlns:p14="http://schemas.microsoft.com/office/powerpoint/2010/main" val="1952412206"/>
       </p:ext>
     </p:extLst>
   </p:cSld>
@@ -5358,7 +5358,7 @@
           <p:cNvPr id="8" name="">
             <a:extLst xmlns:a="http://schemas.openxmlformats.org/drawingml/2006/main">
               <a:ext uri="{FF2B5EF4-FFF2-40B4-BE49-F238E27FC236}">
-                <a16:creationId xmlns:a16="http://schemas.microsoft.com/office/drawing/2014/main" id="{D19C2514-8B28-4027-AB22-BB2B74CB4174}"/>
+                <a16:creationId xmlns:a16="http://schemas.microsoft.com/office/drawing/2014/main" id="{500A5D3C-787D-4861-9E1F-8867FB98470F}"/>
               </a:ext>
             </a:extLst>
           </p:cNvPr>
@@ -5426,7 +5426,7 @@
           <p:cNvPr id="2" name="">
             <a:extLst xmlns:a="http://schemas.openxmlformats.org/drawingml/2006/main">
               <a:ext uri="{FF2B5EF4-FFF2-40B4-BE49-F238E27FC236}">
-                <a16:creationId xmlns:a16="http://schemas.microsoft.com/office/drawing/2014/main" id="{27837119-8C0E-4148-B367-652DE06F5F2E}"/>
+                <a16:creationId xmlns:a16="http://schemas.microsoft.com/office/drawing/2014/main" id="{7F1293DE-EF24-4496-BA2F-7FD1CBCB091B}"/>
               </a:ext>
             </a:extLst>
           </p:cNvPr>
@@ -5494,7 +5494,7 @@
           <p:cNvPr id="3" name="">
             <a:extLst xmlns:a="http://schemas.openxmlformats.org/drawingml/2006/main">
               <a:ext uri="{FF2B5EF4-FFF2-40B4-BE49-F238E27FC236}">
-                <a16:creationId xmlns:a16="http://schemas.microsoft.com/office/drawing/2014/main" id="{34E37C50-31BC-4D9B-AF63-D986344FA2ED}"/>
+                <a16:creationId xmlns:a16="http://schemas.microsoft.com/office/drawing/2014/main" id="{DDAAD593-6AE8-4B57-B943-0079DB4AFF0E}"/>
               </a:ext>
             </a:extLst>
           </p:cNvPr>
@@ -5562,7 +5562,7 @@
           <p:cNvPr id="4" name="">
             <a:extLst xmlns:a="http://schemas.openxmlformats.org/drawingml/2006/main">
               <a:ext uri="{FF2B5EF4-FFF2-40B4-BE49-F238E27FC236}">
-                <a16:creationId xmlns:a16="http://schemas.microsoft.com/office/drawing/2014/main" id="{57E43547-52A6-45D2-903B-5B66D2709E8E}"/>
+                <a16:creationId xmlns:a16="http://schemas.microsoft.com/office/drawing/2014/main" id="{6E179EF5-37FE-40AB-839F-FA70A74586BD}"/>
               </a:ext>
             </a:extLst>
           </p:cNvPr>
@@ -5686,7 +5686,7 @@
           <p:cNvPr id="5" name="">
             <a:extLst xmlns:a="http://schemas.openxmlformats.org/drawingml/2006/main">
               <a:ext uri="{FF2B5EF4-FFF2-40B4-BE49-F238E27FC236}">
-                <a16:creationId xmlns:a16="http://schemas.microsoft.com/office/drawing/2014/main" id="{3C635996-97B1-42A2-819D-E6EDCD4ADC3C}"/>
+                <a16:creationId xmlns:a16="http://schemas.microsoft.com/office/drawing/2014/main" id="{4BA7A842-D709-454E-BC99-8410C65B0839}"/>
               </a:ext>
             </a:extLst>
           </p:cNvPr>
@@ -5754,7 +5754,7 @@
           <p:cNvPr id="6" name="">
             <a:extLst xmlns:a="http://schemas.openxmlformats.org/drawingml/2006/main">
               <a:ext uri="{FF2B5EF4-FFF2-40B4-BE49-F238E27FC236}">
-                <a16:creationId xmlns:a16="http://schemas.microsoft.com/office/drawing/2014/main" id="{60801E96-3D81-4F65-B226-CC1613B5962C}"/>
+                <a16:creationId xmlns:a16="http://schemas.microsoft.com/office/drawing/2014/main" id="{4807904A-62D3-4F9B-9FFF-F19A087BB1B9}"/>
               </a:ext>
             </a:extLst>
           </p:cNvPr>
@@ -5822,7 +5822,7 @@
           <p:cNvPr id="7" name="">
             <a:extLst xmlns:a="http://schemas.openxmlformats.org/drawingml/2006/main">
               <a:ext uri="{FF2B5EF4-FFF2-40B4-BE49-F238E27FC236}">
-                <a16:creationId xmlns:a16="http://schemas.microsoft.com/office/drawing/2014/main" id="{24183C01-1534-42FD-A09D-3C6E643E51A1}"/>
+                <a16:creationId xmlns:a16="http://schemas.microsoft.com/office/drawing/2014/main" id="{06A4ECCE-A31B-426C-9C7A-0ED1A9DFE291}"/>
               </a:ext>
             </a:extLst>
           </p:cNvPr>
@@ -5888,7 +5888,7 @@
     </p:spTree>
     <p:extLst>
       <p:ext uri="{BB962C8B-B14F-4D97-AF65-F5344CB8AC3E}">
-        <p14:creationId xmlns:p14="http://schemas.microsoft.com/office/powerpoint/2010/main" val="1478658094"/>
+        <p14:creationId xmlns:p14="http://schemas.microsoft.com/office/powerpoint/2010/main" val="1846074831"/>
       </p:ext>
     </p:extLst>
   </p:cSld>
@@ -5919,7 +5919,7 @@
           <p:cNvPr id="11" name="">
             <a:extLst xmlns:a="http://schemas.openxmlformats.org/drawingml/2006/main">
               <a:ext uri="{FF2B5EF4-FFF2-40B4-BE49-F238E27FC236}">
-                <a16:creationId xmlns:a16="http://schemas.microsoft.com/office/drawing/2014/main" id="{C83B53A6-17C0-4412-848C-0AEB5BC75CAE}"/>
+                <a16:creationId xmlns:a16="http://schemas.microsoft.com/office/drawing/2014/main" id="{87C2D18F-9F3D-438B-8294-3FF7F3CC6EEF}"/>
               </a:ext>
             </a:extLst>
           </p:cNvPr>
@@ -5987,7 +5987,7 @@
           <p:cNvPr id="2" name="">
             <a:extLst xmlns:a="http://schemas.openxmlformats.org/drawingml/2006/main">
               <a:ext uri="{FF2B5EF4-FFF2-40B4-BE49-F238E27FC236}">
-                <a16:creationId xmlns:a16="http://schemas.microsoft.com/office/drawing/2014/main" id="{9C03310C-543C-4337-B015-AC24D91CA7A6}"/>
+                <a16:creationId xmlns:a16="http://schemas.microsoft.com/office/drawing/2014/main" id="{3FEB353D-C4A6-429C-8067-65F6C71B0E76}"/>
               </a:ext>
             </a:extLst>
           </p:cNvPr>
@@ -6055,7 +6055,7 @@
           <p:cNvPr id="3" name="">
             <a:extLst xmlns:a="http://schemas.openxmlformats.org/drawingml/2006/main">
               <a:ext uri="{FF2B5EF4-FFF2-40B4-BE49-F238E27FC236}">
-                <a16:creationId xmlns:a16="http://schemas.microsoft.com/office/drawing/2014/main" id="{D9E1E726-86BF-45A8-8D57-91C0449CB809}"/>
+                <a16:creationId xmlns:a16="http://schemas.microsoft.com/office/drawing/2014/main" id="{9BCD2C4F-9C4B-4216-B1A5-18B307637C4D}"/>
               </a:ext>
             </a:extLst>
           </p:cNvPr>
@@ -6123,7 +6123,7 @@
           <p:cNvPr id="4" name="">
             <a:extLst xmlns:a="http://schemas.openxmlformats.org/drawingml/2006/main">
               <a:ext uri="{FF2B5EF4-FFF2-40B4-BE49-F238E27FC236}">
-                <a16:creationId xmlns:a16="http://schemas.microsoft.com/office/drawing/2014/main" id="{84B8CF3B-CBF2-4A51-8B7F-91CAF08183C6}"/>
+                <a16:creationId xmlns:a16="http://schemas.microsoft.com/office/drawing/2014/main" id="{76FDB32A-F3F0-4202-971E-B5C21A97510B}"/>
               </a:ext>
             </a:extLst>
           </p:cNvPr>
@@ -6247,7 +6247,7 @@
           <p:cNvPr id="5" name="">
             <a:extLst xmlns:a="http://schemas.openxmlformats.org/drawingml/2006/main">
               <a:ext uri="{FF2B5EF4-FFF2-40B4-BE49-F238E27FC236}">
-                <a16:creationId xmlns:a16="http://schemas.microsoft.com/office/drawing/2014/main" id="{67142608-BEC1-48C9-AE76-B9F4436BEEC3}"/>
+                <a16:creationId xmlns:a16="http://schemas.microsoft.com/office/drawing/2014/main" id="{3E126D8B-5D37-4C5E-9C2E-8AA5966F3496}"/>
               </a:ext>
             </a:extLst>
           </p:cNvPr>
@@ -6315,7 +6315,7 @@
           <p:cNvPr id="6" name="">
             <a:extLst xmlns:a="http://schemas.openxmlformats.org/drawingml/2006/main">
               <a:ext uri="{FF2B5EF4-FFF2-40B4-BE49-F238E27FC236}">
-                <a16:creationId xmlns:a16="http://schemas.microsoft.com/office/drawing/2014/main" id="{B01C6668-E495-4826-96CF-9FEC93E84BCE}"/>
+                <a16:creationId xmlns:a16="http://schemas.microsoft.com/office/drawing/2014/main" id="{C6E40EAD-836C-4AA2-930A-B03AE2FC38CA}"/>
               </a:ext>
             </a:extLst>
           </p:cNvPr>
@@ -6383,7 +6383,7 @@
           <p:cNvPr id="7" name="">
             <a:extLst xmlns:a="http://schemas.openxmlformats.org/drawingml/2006/main">
               <a:ext uri="{FF2B5EF4-FFF2-40B4-BE49-F238E27FC236}">
-                <a16:creationId xmlns:a16="http://schemas.microsoft.com/office/drawing/2014/main" id="{9A5E148B-F04A-42B5-A578-46B94FD0E554}"/>
+                <a16:creationId xmlns:a16="http://schemas.microsoft.com/office/drawing/2014/main" id="{61A663C5-05E6-4D00-8667-C9E34149BDF4}"/>
               </a:ext>
             </a:extLst>
           </p:cNvPr>
@@ -6451,7 +6451,7 @@
           <p:cNvPr id="8" name="">
             <a:extLst xmlns:a="http://schemas.openxmlformats.org/drawingml/2006/main">
               <a:ext uri="{FF2B5EF4-FFF2-40B4-BE49-F238E27FC236}">
-                <a16:creationId xmlns:a16="http://schemas.microsoft.com/office/drawing/2014/main" id="{E2A76293-824C-4793-A2E0-66F38FE01970}"/>
+                <a16:creationId xmlns:a16="http://schemas.microsoft.com/office/drawing/2014/main" id="{98126D35-D9CA-4DCD-B056-BD8955325FD8}"/>
               </a:ext>
             </a:extLst>
           </p:cNvPr>
@@ -6519,7 +6519,7 @@
           <p:cNvPr id="9" name="">
             <a:extLst xmlns:a="http://schemas.openxmlformats.org/drawingml/2006/main">
               <a:ext uri="{FF2B5EF4-FFF2-40B4-BE49-F238E27FC236}">
-                <a16:creationId xmlns:a16="http://schemas.microsoft.com/office/drawing/2014/main" id="{D31161B3-75DB-46C5-9DAD-BC46F066017F}"/>
+                <a16:creationId xmlns:a16="http://schemas.microsoft.com/office/drawing/2014/main" id="{7A914C8B-741F-42B3-9F0B-D1C05488C79E}"/>
               </a:ext>
             </a:extLst>
           </p:cNvPr>
@@ -6587,7 +6587,7 @@
           <p:cNvPr id="10" name="">
             <a:extLst xmlns:a="http://schemas.openxmlformats.org/drawingml/2006/main">
               <a:ext uri="{FF2B5EF4-FFF2-40B4-BE49-F238E27FC236}">
-                <a16:creationId xmlns:a16="http://schemas.microsoft.com/office/drawing/2014/main" id="{C57C9EED-3D6B-4395-B384-A235A93783A2}"/>
+                <a16:creationId xmlns:a16="http://schemas.microsoft.com/office/drawing/2014/main" id="{1B77FF05-DF1A-4720-B162-180FA7DEFA13}"/>
               </a:ext>
             </a:extLst>
           </p:cNvPr>
@@ -6653,7 +6653,7 @@
     </p:spTree>
     <p:extLst>
       <p:ext uri="{BB962C8B-B14F-4D97-AF65-F5344CB8AC3E}">
-        <p14:creationId xmlns:p14="http://schemas.microsoft.com/office/powerpoint/2010/main" val="1969159751"/>
+        <p14:creationId xmlns:p14="http://schemas.microsoft.com/office/powerpoint/2010/main" val="138485540"/>
       </p:ext>
     </p:extLst>
   </p:cSld>
@@ -6684,7 +6684,7 @@
           <p:cNvPr id="6" name="">
             <a:extLst xmlns:a="http://schemas.openxmlformats.org/drawingml/2006/main">
               <a:ext uri="{FF2B5EF4-FFF2-40B4-BE49-F238E27FC236}">
-                <a16:creationId xmlns:a16="http://schemas.microsoft.com/office/drawing/2014/main" id="{CAFE85A9-AB66-4B7B-A666-A32811917981}"/>
+                <a16:creationId xmlns:a16="http://schemas.microsoft.com/office/drawing/2014/main" id="{9574343B-6DD0-4F0A-A59B-7A3DD85517D4}"/>
               </a:ext>
             </a:extLst>
           </p:cNvPr>
@@ -6752,7 +6752,7 @@
           <p:cNvPr id="2" name="">
             <a:extLst xmlns:a="http://schemas.openxmlformats.org/drawingml/2006/main">
               <a:ext uri="{FF2B5EF4-FFF2-40B4-BE49-F238E27FC236}">
-                <a16:creationId xmlns:a16="http://schemas.microsoft.com/office/drawing/2014/main" id="{6F20E1EA-A066-4C81-AF46-E97FFE59E65E}"/>
+                <a16:creationId xmlns:a16="http://schemas.microsoft.com/office/drawing/2014/main" id="{C6AA506D-C55E-46D4-9B58-D86DD1CA05E7}"/>
               </a:ext>
             </a:extLst>
           </p:cNvPr>
@@ -6820,7 +6820,7 @@
           <p:cNvPr id="3" name="">
             <a:extLst xmlns:a="http://schemas.openxmlformats.org/drawingml/2006/main">
               <a:ext uri="{FF2B5EF4-FFF2-40B4-BE49-F238E27FC236}">
-                <a16:creationId xmlns:a16="http://schemas.microsoft.com/office/drawing/2014/main" id="{8BF4E565-94A9-4B6A-8074-2465F61785EE}"/>
+                <a16:creationId xmlns:a16="http://schemas.microsoft.com/office/drawing/2014/main" id="{06240119-8C4D-4349-9F4C-113B3366DF80}"/>
               </a:ext>
             </a:extLst>
           </p:cNvPr>
@@ -6888,7 +6888,7 @@
           <p:cNvPr id="4" name="">
             <a:extLst xmlns:a="http://schemas.openxmlformats.org/drawingml/2006/main">
               <a:ext uri="{FF2B5EF4-FFF2-40B4-BE49-F238E27FC236}">
-                <a16:creationId xmlns:a16="http://schemas.microsoft.com/office/drawing/2014/main" id="{D688F3C3-709C-4526-9545-724D3D1622CD}"/>
+                <a16:creationId xmlns:a16="http://schemas.microsoft.com/office/drawing/2014/main" id="{1ED66507-169D-44B8-8B76-4B632D9B6830}"/>
               </a:ext>
             </a:extLst>
           </p:cNvPr>
@@ -7012,7 +7012,7 @@
           <p:cNvPr id="5" name="">
             <a:extLst xmlns:a="http://schemas.openxmlformats.org/drawingml/2006/main">
               <a:ext uri="{FF2B5EF4-FFF2-40B4-BE49-F238E27FC236}">
-                <a16:creationId xmlns:a16="http://schemas.microsoft.com/office/drawing/2014/main" id="{2BFEF468-E6C6-45A6-92C1-1DC2C0FEB804}"/>
+                <a16:creationId xmlns:a16="http://schemas.microsoft.com/office/drawing/2014/main" id="{7D19F08A-FC5A-4A97-A685-CEE8564F6E91}"/>
               </a:ext>
             </a:extLst>
           </p:cNvPr>
@@ -7078,7 +7078,7 @@
     </p:spTree>
     <p:extLst>
       <p:ext uri="{BB962C8B-B14F-4D97-AF65-F5344CB8AC3E}">
-        <p14:creationId xmlns:p14="http://schemas.microsoft.com/office/powerpoint/2010/main" val="1644650910"/>
+        <p14:creationId xmlns:p14="http://schemas.microsoft.com/office/powerpoint/2010/main" val="149329885"/>
       </p:ext>
     </p:extLst>
   </p:cSld>
@@ -7109,7 +7109,7 @@
           <p:cNvPr id="8" name="">
             <a:extLst xmlns:a="http://schemas.openxmlformats.org/drawingml/2006/main">
               <a:ext uri="{FF2B5EF4-FFF2-40B4-BE49-F238E27FC236}">
-                <a16:creationId xmlns:a16="http://schemas.microsoft.com/office/drawing/2014/main" id="{27B22081-F95A-466B-85A8-78542B6F6E2F}"/>
+                <a16:creationId xmlns:a16="http://schemas.microsoft.com/office/drawing/2014/main" id="{887D241D-EA6C-4795-9675-ADF805A747C2}"/>
               </a:ext>
             </a:extLst>
           </p:cNvPr>
@@ -7177,7 +7177,7 @@
           <p:cNvPr id="2" name="">
             <a:extLst xmlns:a="http://schemas.openxmlformats.org/drawingml/2006/main">
               <a:ext uri="{FF2B5EF4-FFF2-40B4-BE49-F238E27FC236}">
-                <a16:creationId xmlns:a16="http://schemas.microsoft.com/office/drawing/2014/main" id="{FC826D0C-D165-46EF-B665-5759ABCC9AA6}"/>
+                <a16:creationId xmlns:a16="http://schemas.microsoft.com/office/drawing/2014/main" id="{A9677206-97E1-4E5B-92A2-2BB56A75BF46}"/>
               </a:ext>
             </a:extLst>
           </p:cNvPr>
@@ -7245,7 +7245,7 @@
           <p:cNvPr id="3" name="">
             <a:extLst xmlns:a="http://schemas.openxmlformats.org/drawingml/2006/main">
               <a:ext uri="{FF2B5EF4-FFF2-40B4-BE49-F238E27FC236}">
-                <a16:creationId xmlns:a16="http://schemas.microsoft.com/office/drawing/2014/main" id="{BA8DABB8-B774-4571-B0A3-721AB2D8260A}"/>
+                <a16:creationId xmlns:a16="http://schemas.microsoft.com/office/drawing/2014/main" id="{29426998-F01F-478A-8BAB-4CAC9723D515}"/>
               </a:ext>
             </a:extLst>
           </p:cNvPr>
@@ -7313,7 +7313,7 @@
           <p:cNvPr id="4" name="">
             <a:extLst xmlns:a="http://schemas.openxmlformats.org/drawingml/2006/main">
               <a:ext uri="{FF2B5EF4-FFF2-40B4-BE49-F238E27FC236}">
-                <a16:creationId xmlns:a16="http://schemas.microsoft.com/office/drawing/2014/main" id="{1962C0DE-AA10-4741-8AD8-A09FF7E9AA56}"/>
+                <a16:creationId xmlns:a16="http://schemas.microsoft.com/office/drawing/2014/main" id="{224CE3ED-9F79-41FF-BB14-628811A79091}"/>
               </a:ext>
             </a:extLst>
           </p:cNvPr>
@@ -7381,7 +7381,7 @@
           <p:cNvPr id="5" name="">
             <a:extLst xmlns:a="http://schemas.openxmlformats.org/drawingml/2006/main">
               <a:ext uri="{FF2B5EF4-FFF2-40B4-BE49-F238E27FC236}">
-                <a16:creationId xmlns:a16="http://schemas.microsoft.com/office/drawing/2014/main" id="{520D0521-1183-4834-BAF0-7A8DFD8ACC2B}"/>
+                <a16:creationId xmlns:a16="http://schemas.microsoft.com/office/drawing/2014/main" id="{268A55B6-A1D5-4159-94C0-CEAA010161FE}"/>
               </a:ext>
             </a:extLst>
           </p:cNvPr>
@@ -7449,7 +7449,7 @@
           <p:cNvPr id="6" name="">
             <a:extLst xmlns:a="http://schemas.openxmlformats.org/drawingml/2006/main">
               <a:ext uri="{FF2B5EF4-FFF2-40B4-BE49-F238E27FC236}">
-                <a16:creationId xmlns:a16="http://schemas.microsoft.com/office/drawing/2014/main" id="{A5FB029F-F246-4533-9916-D0DE7CF423CC}"/>
+                <a16:creationId xmlns:a16="http://schemas.microsoft.com/office/drawing/2014/main" id="{E679E774-8A7F-4ADB-A200-DCBAE1A72477}"/>
               </a:ext>
             </a:extLst>
           </p:cNvPr>
@@ -7573,7 +7573,7 @@
           <p:cNvPr id="7" name="">
             <a:extLst xmlns:a="http://schemas.openxmlformats.org/drawingml/2006/main">
               <a:ext uri="{FF2B5EF4-FFF2-40B4-BE49-F238E27FC236}">
-                <a16:creationId xmlns:a16="http://schemas.microsoft.com/office/drawing/2014/main" id="{24E442BC-DF9B-4DFB-AD5E-D54BC98324E9}"/>
+                <a16:creationId xmlns:a16="http://schemas.microsoft.com/office/drawing/2014/main" id="{78238A65-3D5C-424C-9214-D012AD9B0381}"/>
               </a:ext>
             </a:extLst>
           </p:cNvPr>
@@ -7639,7 +7639,7 @@
     </p:spTree>
     <p:extLst>
       <p:ext uri="{BB962C8B-B14F-4D97-AF65-F5344CB8AC3E}">
-        <p14:creationId xmlns:p14="http://schemas.microsoft.com/office/powerpoint/2010/main" val="1361026460"/>
+        <p14:creationId xmlns:p14="http://schemas.microsoft.com/office/powerpoint/2010/main" val="1481255632"/>
       </p:ext>
     </p:extLst>
   </p:cSld>
@@ -7670,7 +7670,7 @@
           <p:cNvPr id="7" name="">
             <a:extLst xmlns:a="http://schemas.openxmlformats.org/drawingml/2006/main">
               <a:ext uri="{FF2B5EF4-FFF2-40B4-BE49-F238E27FC236}">
-                <a16:creationId xmlns:a16="http://schemas.microsoft.com/office/drawing/2014/main" id="{BAEC5D9A-C607-4341-9258-656CEAE5EF4F}"/>
+                <a16:creationId xmlns:a16="http://schemas.microsoft.com/office/drawing/2014/main" id="{442BC8BB-190F-45E9-A9B0-FA6083096F63}"/>
               </a:ext>
             </a:extLst>
           </p:cNvPr>
@@ -7738,7 +7738,7 @@
           <p:cNvPr id="2" name="">
             <a:extLst xmlns:a="http://schemas.openxmlformats.org/drawingml/2006/main">
               <a:ext uri="{FF2B5EF4-FFF2-40B4-BE49-F238E27FC236}">
-                <a16:creationId xmlns:a16="http://schemas.microsoft.com/office/drawing/2014/main" id="{9E5D3662-B7E3-425C-A949-79B3DF62702D}"/>
+                <a16:creationId xmlns:a16="http://schemas.microsoft.com/office/drawing/2014/main" id="{E9AB0529-52B4-4CCB-AD90-6BC6148535E9}"/>
               </a:ext>
             </a:extLst>
           </p:cNvPr>
@@ -7806,7 +7806,7 @@
           <p:cNvPr id="3" name="">
             <a:extLst xmlns:a="http://schemas.openxmlformats.org/drawingml/2006/main">
               <a:ext uri="{FF2B5EF4-FFF2-40B4-BE49-F238E27FC236}">
-                <a16:creationId xmlns:a16="http://schemas.microsoft.com/office/drawing/2014/main" id="{81D07F14-512B-47BD-B75D-6A2093656776}"/>
+                <a16:creationId xmlns:a16="http://schemas.microsoft.com/office/drawing/2014/main" id="{7A87DE3B-7941-4AD7-9837-501567DB13CF}"/>
               </a:ext>
             </a:extLst>
           </p:cNvPr>
@@ -7874,7 +7874,7 @@
           <p:cNvPr id="4" name="">
             <a:extLst xmlns:a="http://schemas.openxmlformats.org/drawingml/2006/main">
               <a:ext uri="{FF2B5EF4-FFF2-40B4-BE49-F238E27FC236}">
-                <a16:creationId xmlns:a16="http://schemas.microsoft.com/office/drawing/2014/main" id="{37897BCD-95A7-4343-8D0C-529F28FD2E7E}"/>
+                <a16:creationId xmlns:a16="http://schemas.microsoft.com/office/drawing/2014/main" id="{1830D3A5-C9EA-4AC4-A9FF-407E798B1A22}"/>
               </a:ext>
             </a:extLst>
           </p:cNvPr>
@@ -7998,7 +7998,7 @@
           <p:cNvPr id="5" name="">
             <a:extLst xmlns:a="http://schemas.openxmlformats.org/drawingml/2006/main">
               <a:ext uri="{FF2B5EF4-FFF2-40B4-BE49-F238E27FC236}">
-                <a16:creationId xmlns:a16="http://schemas.microsoft.com/office/drawing/2014/main" id="{8B8DE4C8-CBCB-4B4A-AB93-2653516E2940}"/>
+                <a16:creationId xmlns:a16="http://schemas.microsoft.com/office/drawing/2014/main" id="{6ABB4A15-A069-4372-939D-DF1115F6BDDE}"/>
               </a:ext>
             </a:extLst>
           </p:cNvPr>
@@ -8066,7 +8066,7 @@
           <p:cNvPr id="6" name="">
             <a:extLst xmlns:a="http://schemas.openxmlformats.org/drawingml/2006/main">
               <a:ext uri="{FF2B5EF4-FFF2-40B4-BE49-F238E27FC236}">
-                <a16:creationId xmlns:a16="http://schemas.microsoft.com/office/drawing/2014/main" id="{5AE9B229-F34C-4F40-B745-FA5836A4DB2E}"/>
+                <a16:creationId xmlns:a16="http://schemas.microsoft.com/office/drawing/2014/main" id="{4594AC1B-35CD-45BF-BEBE-A78280E69B8B}"/>
               </a:ext>
             </a:extLst>
           </p:cNvPr>
@@ -8132,7 +8132,7 @@
     </p:spTree>
     <p:extLst>
       <p:ext uri="{BB962C8B-B14F-4D97-AF65-F5344CB8AC3E}">
-        <p14:creationId xmlns:p14="http://schemas.microsoft.com/office/powerpoint/2010/main" val="869320740"/>
+        <p14:creationId xmlns:p14="http://schemas.microsoft.com/office/powerpoint/2010/main" val="550895560"/>
       </p:ext>
     </p:extLst>
   </p:cSld>
@@ -8163,7 +8163,7 @@
           <p:cNvPr id="6" name="">
             <a:extLst xmlns:a="http://schemas.openxmlformats.org/drawingml/2006/main">
               <a:ext uri="{FF2B5EF4-FFF2-40B4-BE49-F238E27FC236}">
-                <a16:creationId xmlns:a16="http://schemas.microsoft.com/office/drawing/2014/main" id="{882D0F9A-6BAF-4F19-847D-E8A337F7B792}"/>
+                <a16:creationId xmlns:a16="http://schemas.microsoft.com/office/drawing/2014/main" id="{ED8FB0BC-3E04-4959-9CE3-213D090B6AFE}"/>
               </a:ext>
             </a:extLst>
           </p:cNvPr>
@@ -8231,7 +8231,7 @@
           <p:cNvPr id="2" name="">
             <a:extLst xmlns:a="http://schemas.openxmlformats.org/drawingml/2006/main">
               <a:ext uri="{FF2B5EF4-FFF2-40B4-BE49-F238E27FC236}">
-                <a16:creationId xmlns:a16="http://schemas.microsoft.com/office/drawing/2014/main" id="{A41EAAC2-BA96-4A06-B3BF-254D43F73DDD}"/>
+                <a16:creationId xmlns:a16="http://schemas.microsoft.com/office/drawing/2014/main" id="{66502EB8-6F83-4E48-87FD-F971D7715600}"/>
               </a:ext>
             </a:extLst>
           </p:cNvPr>
@@ -8299,7 +8299,7 @@
           <p:cNvPr id="3" name="">
             <a:extLst xmlns:a="http://schemas.openxmlformats.org/drawingml/2006/main">
               <a:ext uri="{FF2B5EF4-FFF2-40B4-BE49-F238E27FC236}">
-                <a16:creationId xmlns:a16="http://schemas.microsoft.com/office/drawing/2014/main" id="{D5F5F872-1E2B-4484-B286-C5C811D4DC4A}"/>
+                <a16:creationId xmlns:a16="http://schemas.microsoft.com/office/drawing/2014/main" id="{7A07CA31-5FBC-48F5-A9B3-22963DC27E20}"/>
               </a:ext>
             </a:extLst>
           </p:cNvPr>
@@ -8367,7 +8367,7 @@
           <p:cNvPr id="4" name="">
             <a:extLst xmlns:a="http://schemas.openxmlformats.org/drawingml/2006/main">
               <a:ext uri="{FF2B5EF4-FFF2-40B4-BE49-F238E27FC236}">
-                <a16:creationId xmlns:a16="http://schemas.microsoft.com/office/drawing/2014/main" id="{B84A417B-F18A-422B-8AFA-A851B16A601E}"/>
+                <a16:creationId xmlns:a16="http://schemas.microsoft.com/office/drawing/2014/main" id="{C6AC3C25-3389-40AB-AB2C-B3209CD5EF24}"/>
               </a:ext>
             </a:extLst>
           </p:cNvPr>
@@ -8491,7 +8491,7 @@
           <p:cNvPr id="5" name="">
             <a:extLst xmlns:a="http://schemas.openxmlformats.org/drawingml/2006/main">
               <a:ext uri="{FF2B5EF4-FFF2-40B4-BE49-F238E27FC236}">
-                <a16:creationId xmlns:a16="http://schemas.microsoft.com/office/drawing/2014/main" id="{C7F26342-06D5-48CF-94F9-DB4E33B46F15}"/>
+                <a16:creationId xmlns:a16="http://schemas.microsoft.com/office/drawing/2014/main" id="{28F56F4B-FEE6-45AA-8333-54E1553E9855}"/>
               </a:ext>
             </a:extLst>
           </p:cNvPr>
@@ -8557,7 +8557,7 @@
     </p:spTree>
     <p:extLst>
       <p:ext uri="{BB962C8B-B14F-4D97-AF65-F5344CB8AC3E}">
-        <p14:creationId xmlns:p14="http://schemas.microsoft.com/office/powerpoint/2010/main" val="130659529"/>
+        <p14:creationId xmlns:p14="http://schemas.microsoft.com/office/powerpoint/2010/main" val="989532036"/>
       </p:ext>
     </p:extLst>
   </p:cSld>
@@ -8588,7 +8588,7 @@
           <p:cNvPr id="9" name="">
             <a:extLst xmlns:a="http://schemas.openxmlformats.org/drawingml/2006/main">
               <a:ext uri="{FF2B5EF4-FFF2-40B4-BE49-F238E27FC236}">
-                <a16:creationId xmlns:a16="http://schemas.microsoft.com/office/drawing/2014/main" id="{23104528-0CCC-46E5-AE78-680ED11B7329}"/>
+                <a16:creationId xmlns:a16="http://schemas.microsoft.com/office/drawing/2014/main" id="{78B3C602-2D18-4BDB-BF0F-E9346B669C74}"/>
               </a:ext>
             </a:extLst>
           </p:cNvPr>
@@ -8656,7 +8656,7 @@
           <p:cNvPr id="2" name="">
             <a:extLst xmlns:a="http://schemas.openxmlformats.org/drawingml/2006/main">
               <a:ext uri="{FF2B5EF4-FFF2-40B4-BE49-F238E27FC236}">
-                <a16:creationId xmlns:a16="http://schemas.microsoft.com/office/drawing/2014/main" id="{561D4B83-04AA-4963-BE41-B0059E44879C}"/>
+                <a16:creationId xmlns:a16="http://schemas.microsoft.com/office/drawing/2014/main" id="{391054C5-B731-4C74-9DFC-AE4BDC1D420F}"/>
               </a:ext>
             </a:extLst>
           </p:cNvPr>
@@ -8724,7 +8724,7 @@
           <p:cNvPr id="3" name="">
             <a:extLst xmlns:a="http://schemas.openxmlformats.org/drawingml/2006/main">
               <a:ext uri="{FF2B5EF4-FFF2-40B4-BE49-F238E27FC236}">
-                <a16:creationId xmlns:a16="http://schemas.microsoft.com/office/drawing/2014/main" id="{403DDF65-83B5-4C41-A222-166A03C9D0A1}"/>
+                <a16:creationId xmlns:a16="http://schemas.microsoft.com/office/drawing/2014/main" id="{45C114CD-88EC-4EBC-8620-565C90729FF6}"/>
               </a:ext>
             </a:extLst>
           </p:cNvPr>
@@ -8792,7 +8792,7 @@
           <p:cNvPr id="4" name="">
             <a:extLst xmlns:a="http://schemas.openxmlformats.org/drawingml/2006/main">
               <a:ext uri="{FF2B5EF4-FFF2-40B4-BE49-F238E27FC236}">
-                <a16:creationId xmlns:a16="http://schemas.microsoft.com/office/drawing/2014/main" id="{E0C479F0-9EE1-4B4F-B44C-EEF85329D70F}"/>
+                <a16:creationId xmlns:a16="http://schemas.microsoft.com/office/drawing/2014/main" id="{5263ABAF-6BAF-463F-8198-BF9945EC0E48}"/>
               </a:ext>
             </a:extLst>
           </p:cNvPr>
@@ -8916,7 +8916,7 @@
           <p:cNvPr id="5" name="">
             <a:extLst xmlns:a="http://schemas.openxmlformats.org/drawingml/2006/main">
               <a:ext uri="{FF2B5EF4-FFF2-40B4-BE49-F238E27FC236}">
-                <a16:creationId xmlns:a16="http://schemas.microsoft.com/office/drawing/2014/main" id="{9BFC878B-9549-4613-B0E1-3E9680A03864}"/>
+                <a16:creationId xmlns:a16="http://schemas.microsoft.com/office/drawing/2014/main" id="{0F8EF9E3-44EA-4BAE-B4E8-8A6CAF1374CD}"/>
               </a:ext>
             </a:extLst>
           </p:cNvPr>
@@ -8984,7 +8984,7 @@
           <p:cNvPr id="6" name="">
             <a:extLst xmlns:a="http://schemas.openxmlformats.org/drawingml/2006/main">
               <a:ext uri="{FF2B5EF4-FFF2-40B4-BE49-F238E27FC236}">
-                <a16:creationId xmlns:a16="http://schemas.microsoft.com/office/drawing/2014/main" id="{119C634B-9940-44DB-A793-BADA46DBA4B9}"/>
+                <a16:creationId xmlns:a16="http://schemas.microsoft.com/office/drawing/2014/main" id="{115F4E39-EA08-4F27-81E8-7ABFD4FBBCFC}"/>
               </a:ext>
             </a:extLst>
           </p:cNvPr>
@@ -9052,7 +9052,7 @@
           <p:cNvPr id="7" name="">
             <a:extLst xmlns:a="http://schemas.openxmlformats.org/drawingml/2006/main">
               <a:ext uri="{FF2B5EF4-FFF2-40B4-BE49-F238E27FC236}">
-                <a16:creationId xmlns:a16="http://schemas.microsoft.com/office/drawing/2014/main" id="{8E1420D3-07FC-4C8D-86B8-A6F3B6F933E0}"/>
+                <a16:creationId xmlns:a16="http://schemas.microsoft.com/office/drawing/2014/main" id="{ED3D4719-76A3-47F2-8993-AF881C4D19D9}"/>
               </a:ext>
             </a:extLst>
           </p:cNvPr>
@@ -9120,7 +9120,7 @@
           <p:cNvPr id="8" name="">
             <a:extLst xmlns:a="http://schemas.openxmlformats.org/drawingml/2006/main">
               <a:ext uri="{FF2B5EF4-FFF2-40B4-BE49-F238E27FC236}">
-                <a16:creationId xmlns:a16="http://schemas.microsoft.com/office/drawing/2014/main" id="{A1D11365-F75C-4A17-B03B-8CC5F9053DAE}"/>
+                <a16:creationId xmlns:a16="http://schemas.microsoft.com/office/drawing/2014/main" id="{A3210042-BE72-4A14-A89A-758F1FBDEA00}"/>
               </a:ext>
             </a:extLst>
           </p:cNvPr>
@@ -9186,7 +9186,7 @@
     </p:spTree>
     <p:extLst>
       <p:ext uri="{BB962C8B-B14F-4D97-AF65-F5344CB8AC3E}">
-        <p14:creationId xmlns:p14="http://schemas.microsoft.com/office/powerpoint/2010/main" val="823598089"/>
+        <p14:creationId xmlns:p14="http://schemas.microsoft.com/office/powerpoint/2010/main" val="205282092"/>
       </p:ext>
     </p:extLst>
   </p:cSld>
@@ -9217,7 +9217,7 @@
           <p:cNvPr id="12" name="">
             <a:extLst xmlns:a="http://schemas.openxmlformats.org/drawingml/2006/main">
               <a:ext uri="{FF2B5EF4-FFF2-40B4-BE49-F238E27FC236}">
-                <a16:creationId xmlns:a16="http://schemas.microsoft.com/office/drawing/2014/main" id="{C87BD2B0-01D3-419F-9A47-5EAF3DDB646B}"/>
+                <a16:creationId xmlns:a16="http://schemas.microsoft.com/office/drawing/2014/main" id="{3232AA30-4563-49AE-BA1C-6D890574225E}"/>
               </a:ext>
             </a:extLst>
           </p:cNvPr>
@@ -9285,7 +9285,7 @@
           <p:cNvPr id="2" name="">
             <a:extLst xmlns:a="http://schemas.openxmlformats.org/drawingml/2006/main">
               <a:ext uri="{FF2B5EF4-FFF2-40B4-BE49-F238E27FC236}">
-                <a16:creationId xmlns:a16="http://schemas.microsoft.com/office/drawing/2014/main" id="{AF9D11DD-A583-4278-888E-1AAD30D28DD1}"/>
+                <a16:creationId xmlns:a16="http://schemas.microsoft.com/office/drawing/2014/main" id="{28855756-76D0-4101-8283-78390AD34099}"/>
               </a:ext>
             </a:extLst>
           </p:cNvPr>
@@ -9353,7 +9353,7 @@
           <p:cNvPr id="3" name="">
             <a:extLst xmlns:a="http://schemas.openxmlformats.org/drawingml/2006/main">
               <a:ext uri="{FF2B5EF4-FFF2-40B4-BE49-F238E27FC236}">
-                <a16:creationId xmlns:a16="http://schemas.microsoft.com/office/drawing/2014/main" id="{127FD73B-E610-4EEA-9587-B931085EF895}"/>
+                <a16:creationId xmlns:a16="http://schemas.microsoft.com/office/drawing/2014/main" id="{9E1B0172-C146-4C1F-A2A6-F1AB5EB56BBA}"/>
               </a:ext>
             </a:extLst>
           </p:cNvPr>
@@ -9421,7 +9421,7 @@
           <p:cNvPr id="4" name="">
             <a:extLst xmlns:a="http://schemas.openxmlformats.org/drawingml/2006/main">
               <a:ext uri="{FF2B5EF4-FFF2-40B4-BE49-F238E27FC236}">
-                <a16:creationId xmlns:a16="http://schemas.microsoft.com/office/drawing/2014/main" id="{718EC5F6-7AB7-496F-B835-CD1FF43BACD9}"/>
+                <a16:creationId xmlns:a16="http://schemas.microsoft.com/office/drawing/2014/main" id="{F5DF2255-C1EF-4B5F-938E-4863528929A6}"/>
               </a:ext>
             </a:extLst>
           </p:cNvPr>
@@ -9545,7 +9545,7 @@
           <p:cNvPr id="5" name="">
             <a:extLst xmlns:a="http://schemas.openxmlformats.org/drawingml/2006/main">
               <a:ext uri="{FF2B5EF4-FFF2-40B4-BE49-F238E27FC236}">
-                <a16:creationId xmlns:a16="http://schemas.microsoft.com/office/drawing/2014/main" id="{9D7CEC2D-9E4B-4F69-94F0-3A648C182DB3}"/>
+                <a16:creationId xmlns:a16="http://schemas.microsoft.com/office/drawing/2014/main" id="{AF2AFEB2-88E2-4BE9-A02D-271E463DC7EC}"/>
               </a:ext>
             </a:extLst>
           </p:cNvPr>
@@ -9613,7 +9613,7 @@
           <p:cNvPr id="6" name="">
             <a:extLst xmlns:a="http://schemas.openxmlformats.org/drawingml/2006/main">
               <a:ext uri="{FF2B5EF4-FFF2-40B4-BE49-F238E27FC236}">
-                <a16:creationId xmlns:a16="http://schemas.microsoft.com/office/drawing/2014/main" id="{88190123-1B44-482A-95ED-17692929612E}"/>
+                <a16:creationId xmlns:a16="http://schemas.microsoft.com/office/drawing/2014/main" id="{E534A852-838E-4020-94C7-A2D648E4B7B4}"/>
               </a:ext>
             </a:extLst>
           </p:cNvPr>
@@ -9681,7 +9681,7 @@
           <p:cNvPr id="7" name="">
             <a:extLst xmlns:a="http://schemas.openxmlformats.org/drawingml/2006/main">
               <a:ext uri="{FF2B5EF4-FFF2-40B4-BE49-F238E27FC236}">
-                <a16:creationId xmlns:a16="http://schemas.microsoft.com/office/drawing/2014/main" id="{470B67A4-A697-4DB3-8275-07C74CB764C9}"/>
+                <a16:creationId xmlns:a16="http://schemas.microsoft.com/office/drawing/2014/main" id="{8FD0C43C-C2CC-4B55-9DDC-4B3014D42F3E}"/>
               </a:ext>
             </a:extLst>
           </p:cNvPr>
@@ -9749,7 +9749,7 @@
           <p:cNvPr id="8" name="">
             <a:extLst xmlns:a="http://schemas.openxmlformats.org/drawingml/2006/main">
               <a:ext uri="{FF2B5EF4-FFF2-40B4-BE49-F238E27FC236}">
-                <a16:creationId xmlns:a16="http://schemas.microsoft.com/office/drawing/2014/main" id="{270B71AE-C597-46E8-9DD9-400CCEE0DE43}"/>
+                <a16:creationId xmlns:a16="http://schemas.microsoft.com/office/drawing/2014/main" id="{9AC6FBAC-D849-4FE8-A82D-EEDE5A832BF5}"/>
               </a:ext>
             </a:extLst>
           </p:cNvPr>
@@ -9817,7 +9817,7 @@
           <p:cNvPr id="9" name="">
             <a:extLst xmlns:a="http://schemas.openxmlformats.org/drawingml/2006/main">
               <a:ext uri="{FF2B5EF4-FFF2-40B4-BE49-F238E27FC236}">
-                <a16:creationId xmlns:a16="http://schemas.microsoft.com/office/drawing/2014/main" id="{5979787E-5303-429F-A122-B39C3D640F55}"/>
+                <a16:creationId xmlns:a16="http://schemas.microsoft.com/office/drawing/2014/main" id="{274BF3BA-FF08-48B7-B564-21481E90B6BB}"/>
               </a:ext>
             </a:extLst>
           </p:cNvPr>
@@ -9885,7 +9885,7 @@
           <p:cNvPr id="10" name="">
             <a:extLst xmlns:a="http://schemas.openxmlformats.org/drawingml/2006/main">
               <a:ext uri="{FF2B5EF4-FFF2-40B4-BE49-F238E27FC236}">
-                <a16:creationId xmlns:a16="http://schemas.microsoft.com/office/drawing/2014/main" id="{21E82A24-5141-4777-898B-719FBEFEE13D}"/>
+                <a16:creationId xmlns:a16="http://schemas.microsoft.com/office/drawing/2014/main" id="{75A96AD1-5298-443C-8DB8-D52F194F7F5E}"/>
               </a:ext>
             </a:extLst>
           </p:cNvPr>
@@ -9953,7 +9953,7 @@
           <p:cNvPr id="11" name="">
             <a:extLst xmlns:a="http://schemas.openxmlformats.org/drawingml/2006/main">
               <a:ext uri="{FF2B5EF4-FFF2-40B4-BE49-F238E27FC236}">
-                <a16:creationId xmlns:a16="http://schemas.microsoft.com/office/drawing/2014/main" id="{9E37A255-4A5D-4652-94E5-78A2747920DF}"/>
+                <a16:creationId xmlns:a16="http://schemas.microsoft.com/office/drawing/2014/main" id="{6226729D-8A0F-40F0-9402-5A4A9359C594}"/>
               </a:ext>
             </a:extLst>
           </p:cNvPr>
@@ -10019,7 +10019,7 @@
     </p:spTree>
     <p:extLst>
       <p:ext uri="{BB962C8B-B14F-4D97-AF65-F5344CB8AC3E}">
-        <p14:creationId xmlns:p14="http://schemas.microsoft.com/office/powerpoint/2010/main" val="1311633853"/>
+        <p14:creationId xmlns:p14="http://schemas.microsoft.com/office/powerpoint/2010/main" val="796789145"/>
       </p:ext>
     </p:extLst>
   </p:cSld>
@@ -10050,7 +10050,7 @@
           <p:cNvPr id="7" name="">
             <a:extLst xmlns:a="http://schemas.openxmlformats.org/drawingml/2006/main">
               <a:ext uri="{FF2B5EF4-FFF2-40B4-BE49-F238E27FC236}">
-                <a16:creationId xmlns:a16="http://schemas.microsoft.com/office/drawing/2014/main" id="{188C8A0C-715B-41F8-AF32-31225FE314A8}"/>
+                <a16:creationId xmlns:a16="http://schemas.microsoft.com/office/drawing/2014/main" id="{A8B6D813-B580-40E0-9DB5-ED7CB1B71064}"/>
               </a:ext>
             </a:extLst>
           </p:cNvPr>
@@ -10118,7 +10118,7 @@
           <p:cNvPr id="2" name="">
             <a:extLst xmlns:a="http://schemas.openxmlformats.org/drawingml/2006/main">
               <a:ext uri="{FF2B5EF4-FFF2-40B4-BE49-F238E27FC236}">
-                <a16:creationId xmlns:a16="http://schemas.microsoft.com/office/drawing/2014/main" id="{531AD1A1-0CA2-4836-89D0-EFE5C49603C6}"/>
+                <a16:creationId xmlns:a16="http://schemas.microsoft.com/office/drawing/2014/main" id="{97CE3227-8BDC-4F03-A389-9CC1D09A853B}"/>
               </a:ext>
             </a:extLst>
           </p:cNvPr>
@@ -10186,7 +10186,7 @@
           <p:cNvPr id="3" name="">
             <a:extLst xmlns:a="http://schemas.openxmlformats.org/drawingml/2006/main">
               <a:ext uri="{FF2B5EF4-FFF2-40B4-BE49-F238E27FC236}">
-                <a16:creationId xmlns:a16="http://schemas.microsoft.com/office/drawing/2014/main" id="{9B46D181-D67A-40C7-B231-8F7E5DE3E547}"/>
+                <a16:creationId xmlns:a16="http://schemas.microsoft.com/office/drawing/2014/main" id="{E37FF64F-463A-44B4-BD20-D8EA761868CE}"/>
               </a:ext>
             </a:extLst>
           </p:cNvPr>
@@ -10254,7 +10254,7 @@
           <p:cNvPr id="4" name="">
             <a:extLst xmlns:a="http://schemas.openxmlformats.org/drawingml/2006/main">
               <a:ext uri="{FF2B5EF4-FFF2-40B4-BE49-F238E27FC236}">
-                <a16:creationId xmlns:a16="http://schemas.microsoft.com/office/drawing/2014/main" id="{1A2E3831-22C7-4DAE-9A71-281A7DABE2DD}"/>
+                <a16:creationId xmlns:a16="http://schemas.microsoft.com/office/drawing/2014/main" id="{8082A936-C8AF-4778-AF93-C37E6B9E1782}"/>
               </a:ext>
             </a:extLst>
           </p:cNvPr>
@@ -10378,7 +10378,7 @@
           <p:cNvPr id="5" name="">
             <a:extLst xmlns:a="http://schemas.openxmlformats.org/drawingml/2006/main">
               <a:ext uri="{FF2B5EF4-FFF2-40B4-BE49-F238E27FC236}">
-                <a16:creationId xmlns:a16="http://schemas.microsoft.com/office/drawing/2014/main" id="{FF15B779-1A04-4480-9C8F-A5B4EFE6D139}"/>
+                <a16:creationId xmlns:a16="http://schemas.microsoft.com/office/drawing/2014/main" id="{5A002B86-A0C7-479F-A9A7-EF4832E0BE15}"/>
               </a:ext>
             </a:extLst>
           </p:cNvPr>
@@ -10446,7 +10446,7 @@
           <p:cNvPr id="6" name="">
             <a:extLst xmlns:a="http://schemas.openxmlformats.org/drawingml/2006/main">
               <a:ext uri="{FF2B5EF4-FFF2-40B4-BE49-F238E27FC236}">
-                <a16:creationId xmlns:a16="http://schemas.microsoft.com/office/drawing/2014/main" id="{CD3C166B-B1FF-4A8F-BED0-AB72D850D31B}"/>
+                <a16:creationId xmlns:a16="http://schemas.microsoft.com/office/drawing/2014/main" id="{FAAC3654-4199-444B-AE4E-73CA6853EEE3}"/>
               </a:ext>
             </a:extLst>
           </p:cNvPr>
@@ -10512,7 +10512,7 @@
     </p:spTree>
     <p:extLst>
       <p:ext uri="{BB962C8B-B14F-4D97-AF65-F5344CB8AC3E}">
-        <p14:creationId xmlns:p14="http://schemas.microsoft.com/office/powerpoint/2010/main" val="1043575313"/>
+        <p14:creationId xmlns:p14="http://schemas.microsoft.com/office/powerpoint/2010/main" val="970495517"/>
       </p:ext>
     </p:extLst>
   </p:cSld>
@@ -10543,7 +10543,7 @@
           <p:cNvPr id="6" name="">
             <a:extLst xmlns:a="http://schemas.openxmlformats.org/drawingml/2006/main">
               <a:ext uri="{FF2B5EF4-FFF2-40B4-BE49-F238E27FC236}">
-                <a16:creationId xmlns:a16="http://schemas.microsoft.com/office/drawing/2014/main" id="{7A8F04AE-6075-4D98-93E1-AC7BF0A4A00D}"/>
+                <a16:creationId xmlns:a16="http://schemas.microsoft.com/office/drawing/2014/main" id="{42A277FE-1EB4-417B-A973-1F2CC3C18E70}"/>
               </a:ext>
             </a:extLst>
           </p:cNvPr>
@@ -10611,7 +10611,7 @@
           <p:cNvPr id="2" name="">
             <a:extLst xmlns:a="http://schemas.openxmlformats.org/drawingml/2006/main">
               <a:ext uri="{FF2B5EF4-FFF2-40B4-BE49-F238E27FC236}">
-                <a16:creationId xmlns:a16="http://schemas.microsoft.com/office/drawing/2014/main" id="{F44F0D21-702F-4A22-A13B-C67553929070}"/>
+                <a16:creationId xmlns:a16="http://schemas.microsoft.com/office/drawing/2014/main" id="{656E090A-7928-453A-8858-01904F7D6D69}"/>
               </a:ext>
             </a:extLst>
           </p:cNvPr>
@@ -10679,7 +10679,7 @@
           <p:cNvPr id="3" name="">
             <a:extLst xmlns:a="http://schemas.openxmlformats.org/drawingml/2006/main">
               <a:ext uri="{FF2B5EF4-FFF2-40B4-BE49-F238E27FC236}">
-                <a16:creationId xmlns:a16="http://schemas.microsoft.com/office/drawing/2014/main" id="{48DE5790-DF1E-4402-BD5B-1BE90D3B80B3}"/>
+                <a16:creationId xmlns:a16="http://schemas.microsoft.com/office/drawing/2014/main" id="{39D50ECA-919F-4F26-A456-D4ACE1A11C36}"/>
               </a:ext>
             </a:extLst>
           </p:cNvPr>
@@ -10747,7 +10747,7 @@
           <p:cNvPr id="4" name="">
             <a:extLst xmlns:a="http://schemas.openxmlformats.org/drawingml/2006/main">
               <a:ext uri="{FF2B5EF4-FFF2-40B4-BE49-F238E27FC236}">
-                <a16:creationId xmlns:a16="http://schemas.microsoft.com/office/drawing/2014/main" id="{C3AEC73C-EF6B-4FFD-8FF4-E7E64AE95BFF}"/>
+                <a16:creationId xmlns:a16="http://schemas.microsoft.com/office/drawing/2014/main" id="{689E212D-48C6-4B51-B576-67CA60E7F596}"/>
               </a:ext>
             </a:extLst>
           </p:cNvPr>
@@ -10757,7 +10757,7 @@
           <p:nvPr/>
         </p:nvPicPr>
         <p:blipFill>
-          <a:blip xmlns:r="http://schemas.openxmlformats.org/officeDocument/2006/relationships" xmlns:a="http://schemas.openxmlformats.org/drawingml/2006/main" r:embed="R007db8630c8c4614"/>
+          <a:blip xmlns:r="http://schemas.openxmlformats.org/officeDocument/2006/relationships" xmlns:a="http://schemas.openxmlformats.org/drawingml/2006/main" r:embed="Rfd1474f4b55641bb"/>
           <a:stretch xmlns:a="http://schemas.openxmlformats.org/drawingml/2006/main"/>
         </p:blipFill>
         <p:spPr>
@@ -10775,7 +10775,7 @@
           <p:cNvPr id="5" name="">
             <a:extLst xmlns:a="http://schemas.openxmlformats.org/drawingml/2006/main">
               <a:ext uri="{FF2B5EF4-FFF2-40B4-BE49-F238E27FC236}">
-                <a16:creationId xmlns:a16="http://schemas.microsoft.com/office/drawing/2014/main" id="{2D545A09-ECCB-4971-B12A-C9A4B024BCEF}"/>
+                <a16:creationId xmlns:a16="http://schemas.microsoft.com/office/drawing/2014/main" id="{109F8F30-2F38-4BE3-A4E0-AECD465876B5}"/>
               </a:ext>
             </a:extLst>
           </p:cNvPr>
@@ -10869,7 +10869,7 @@
     </p:spTree>
     <p:extLst>
       <p:ext uri="{BB962C8B-B14F-4D97-AF65-F5344CB8AC3E}">
-        <p14:creationId xmlns:p14="http://schemas.microsoft.com/office/powerpoint/2010/main" val="1170991700"/>
+        <p14:creationId xmlns:p14="http://schemas.microsoft.com/office/powerpoint/2010/main" val="58673776"/>
       </p:ext>
     </p:extLst>
   </p:cSld>
@@ -10900,7 +10900,7 @@
           <p:cNvPr id="13" name="">
             <a:extLst xmlns:a="http://schemas.openxmlformats.org/drawingml/2006/main">
               <a:ext uri="{FF2B5EF4-FFF2-40B4-BE49-F238E27FC236}">
-                <a16:creationId xmlns:a16="http://schemas.microsoft.com/office/drawing/2014/main" id="{EF259A1E-3660-4C45-9307-8D7E66F77801}"/>
+                <a16:creationId xmlns:a16="http://schemas.microsoft.com/office/drawing/2014/main" id="{B003D930-9B22-43D0-B457-C0E8D7039BC5}"/>
               </a:ext>
             </a:extLst>
           </p:cNvPr>
@@ -10968,7 +10968,7 @@
           <p:cNvPr id="2" name="">
             <a:extLst xmlns:a="http://schemas.openxmlformats.org/drawingml/2006/main">
               <a:ext uri="{FF2B5EF4-FFF2-40B4-BE49-F238E27FC236}">
-                <a16:creationId xmlns:a16="http://schemas.microsoft.com/office/drawing/2014/main" id="{67D0B8F1-FDC4-400B-B9F2-037EFC0501D3}"/>
+                <a16:creationId xmlns:a16="http://schemas.microsoft.com/office/drawing/2014/main" id="{AE452F05-4E5F-4F3B-BDCE-DA4909DDF93F}"/>
               </a:ext>
             </a:extLst>
           </p:cNvPr>
@@ -11036,7 +11036,7 @@
           <p:cNvPr id="3" name="">
             <a:extLst xmlns:a="http://schemas.openxmlformats.org/drawingml/2006/main">
               <a:ext uri="{FF2B5EF4-FFF2-40B4-BE49-F238E27FC236}">
-                <a16:creationId xmlns:a16="http://schemas.microsoft.com/office/drawing/2014/main" id="{2E6E0CFC-EDDB-4CA1-A024-CE1D204AD0AE}"/>
+                <a16:creationId xmlns:a16="http://schemas.microsoft.com/office/drawing/2014/main" id="{CDA80811-B454-4264-914C-B674CBA63CAB}"/>
               </a:ext>
             </a:extLst>
           </p:cNvPr>
@@ -11104,7 +11104,7 @@
           <p:cNvPr id="4" name="">
             <a:extLst xmlns:a="http://schemas.openxmlformats.org/drawingml/2006/main">
               <a:ext uri="{FF2B5EF4-FFF2-40B4-BE49-F238E27FC236}">
-                <a16:creationId xmlns:a16="http://schemas.microsoft.com/office/drawing/2014/main" id="{D91AE280-B5B1-4D80-B184-FFB5E2F760E2}"/>
+                <a16:creationId xmlns:a16="http://schemas.microsoft.com/office/drawing/2014/main" id="{0A50EEE8-D93F-4A11-B195-0C3F4508C1C6}"/>
               </a:ext>
             </a:extLst>
           </p:cNvPr>
@@ -11200,7 +11200,7 @@
           <p:cNvPr id="5" name="">
             <a:extLst xmlns:a="http://schemas.openxmlformats.org/drawingml/2006/main">
               <a:ext uri="{FF2B5EF4-FFF2-40B4-BE49-F238E27FC236}">
-                <a16:creationId xmlns:a16="http://schemas.microsoft.com/office/drawing/2014/main" id="{EA3E90CA-49CE-43F1-8F97-05BE4EFECC07}"/>
+                <a16:creationId xmlns:a16="http://schemas.microsoft.com/office/drawing/2014/main" id="{0D69BC31-1BC2-4108-B61E-4707EB59C355}"/>
               </a:ext>
             </a:extLst>
           </p:cNvPr>
@@ -11268,7 +11268,7 @@
           <p:cNvPr id="6" name="">
             <a:extLst xmlns:a="http://schemas.openxmlformats.org/drawingml/2006/main">
               <a:ext uri="{FF2B5EF4-FFF2-40B4-BE49-F238E27FC236}">
-                <a16:creationId xmlns:a16="http://schemas.microsoft.com/office/drawing/2014/main" id="{0B54419B-3F96-4A2C-9D08-46831CB08D95}"/>
+                <a16:creationId xmlns:a16="http://schemas.microsoft.com/office/drawing/2014/main" id="{2D948D21-39F2-4CC9-871E-1E09EBEF3419}"/>
               </a:ext>
             </a:extLst>
           </p:cNvPr>
@@ -11336,7 +11336,7 @@
           <p:cNvPr id="7" name="">
             <a:extLst xmlns:a="http://schemas.openxmlformats.org/drawingml/2006/main">
               <a:ext uri="{FF2B5EF4-FFF2-40B4-BE49-F238E27FC236}">
-                <a16:creationId xmlns:a16="http://schemas.microsoft.com/office/drawing/2014/main" id="{C8F784C1-CF23-4DCA-BAD4-5ABFF10DA5E8}"/>
+                <a16:creationId xmlns:a16="http://schemas.microsoft.com/office/drawing/2014/main" id="{55F29E41-8E11-499B-854C-F9DAE8B08490}"/>
               </a:ext>
             </a:extLst>
           </p:cNvPr>
@@ -11404,7 +11404,7 @@
           <p:cNvPr id="8" name="">
             <a:extLst xmlns:a="http://schemas.openxmlformats.org/drawingml/2006/main">
               <a:ext uri="{FF2B5EF4-FFF2-40B4-BE49-F238E27FC236}">
-                <a16:creationId xmlns:a16="http://schemas.microsoft.com/office/drawing/2014/main" id="{CFE57F7C-345B-4F5A-A29E-E3AAF5937660}"/>
+                <a16:creationId xmlns:a16="http://schemas.microsoft.com/office/drawing/2014/main" id="{9272AB2D-F7D6-4160-AD15-3A5C306D5ACD}"/>
               </a:ext>
             </a:extLst>
           </p:cNvPr>
@@ -11472,7 +11472,7 @@
           <p:cNvPr id="9" name="">
             <a:extLst xmlns:a="http://schemas.openxmlformats.org/drawingml/2006/main">
               <a:ext uri="{FF2B5EF4-FFF2-40B4-BE49-F238E27FC236}">
-                <a16:creationId xmlns:a16="http://schemas.microsoft.com/office/drawing/2014/main" id="{57ECEC10-6AAE-42AB-9B16-50EA5D0B15CB}"/>
+                <a16:creationId xmlns:a16="http://schemas.microsoft.com/office/drawing/2014/main" id="{0C5702D9-DC0D-467A-A788-D2A38496FC29}"/>
               </a:ext>
             </a:extLst>
           </p:cNvPr>
@@ -11540,7 +11540,7 @@
           <p:cNvPr id="10" name="">
             <a:extLst xmlns:a="http://schemas.openxmlformats.org/drawingml/2006/main">
               <a:ext uri="{FF2B5EF4-FFF2-40B4-BE49-F238E27FC236}">
-                <a16:creationId xmlns:a16="http://schemas.microsoft.com/office/drawing/2014/main" id="{8D87BBE2-A0E1-430E-B961-7020F939A186}"/>
+                <a16:creationId xmlns:a16="http://schemas.microsoft.com/office/drawing/2014/main" id="{2BEA2D4F-9AA8-4445-8FFD-1DF8F7E56C42}"/>
               </a:ext>
             </a:extLst>
           </p:cNvPr>
@@ -11608,7 +11608,7 @@
           <p:cNvPr id="11" name="">
             <a:extLst xmlns:a="http://schemas.openxmlformats.org/drawingml/2006/main">
               <a:ext uri="{FF2B5EF4-FFF2-40B4-BE49-F238E27FC236}">
-                <a16:creationId xmlns:a16="http://schemas.microsoft.com/office/drawing/2014/main" id="{F8F3ED67-2810-4600-92A8-8D49243050AE}"/>
+                <a16:creationId xmlns:a16="http://schemas.microsoft.com/office/drawing/2014/main" id="{67DD26D5-4364-4847-80A0-47AB9F65BC35}"/>
               </a:ext>
             </a:extLst>
           </p:cNvPr>
@@ -11676,7 +11676,7 @@
           <p:cNvPr id="12" name="">
             <a:extLst xmlns:a="http://schemas.openxmlformats.org/drawingml/2006/main">
               <a:ext uri="{FF2B5EF4-FFF2-40B4-BE49-F238E27FC236}">
-                <a16:creationId xmlns:a16="http://schemas.microsoft.com/office/drawing/2014/main" id="{C0E6A313-E6BA-48E4-AE53-3853D5556D7F}"/>
+                <a16:creationId xmlns:a16="http://schemas.microsoft.com/office/drawing/2014/main" id="{236EB603-DEB9-4868-B68C-E6D700AC88C4}"/>
               </a:ext>
             </a:extLst>
           </p:cNvPr>
@@ -11742,7 +11742,7 @@
     </p:spTree>
     <p:extLst>
       <p:ext uri="{BB962C8B-B14F-4D97-AF65-F5344CB8AC3E}">
-        <p14:creationId xmlns:p14="http://schemas.microsoft.com/office/powerpoint/2010/main" val="688131653"/>
+        <p14:creationId xmlns:p14="http://schemas.microsoft.com/office/powerpoint/2010/main" val="573968668"/>
       </p:ext>
     </p:extLst>
   </p:cSld>
@@ -11773,7 +11773,7 @@
           <p:cNvPr id="7" name="">
             <a:extLst xmlns:a="http://schemas.openxmlformats.org/drawingml/2006/main">
               <a:ext uri="{FF2B5EF4-FFF2-40B4-BE49-F238E27FC236}">
-                <a16:creationId xmlns:a16="http://schemas.microsoft.com/office/drawing/2014/main" id="{4233E4A4-7EC0-43E0-953F-707AEBB7BD01}"/>
+                <a16:creationId xmlns:a16="http://schemas.microsoft.com/office/drawing/2014/main" id="{7CD0B60F-A94B-4E78-939F-2531D947626F}"/>
               </a:ext>
             </a:extLst>
           </p:cNvPr>
@@ -11841,7 +11841,7 @@
           <p:cNvPr id="2" name="">
             <a:extLst xmlns:a="http://schemas.openxmlformats.org/drawingml/2006/main">
               <a:ext uri="{FF2B5EF4-FFF2-40B4-BE49-F238E27FC236}">
-                <a16:creationId xmlns:a16="http://schemas.microsoft.com/office/drawing/2014/main" id="{3C3E725C-1E01-401F-AEF0-5AF640F55368}"/>
+                <a16:creationId xmlns:a16="http://schemas.microsoft.com/office/drawing/2014/main" id="{99B51963-06FC-4404-8F12-83B42042355D}"/>
               </a:ext>
             </a:extLst>
           </p:cNvPr>
@@ -11909,7 +11909,7 @@
           <p:cNvPr id="3" name="">
             <a:extLst xmlns:a="http://schemas.openxmlformats.org/drawingml/2006/main">
               <a:ext uri="{FF2B5EF4-FFF2-40B4-BE49-F238E27FC236}">
-                <a16:creationId xmlns:a16="http://schemas.microsoft.com/office/drawing/2014/main" id="{8B98F908-2AF1-4122-AB0D-45E9D1BAAAB9}"/>
+                <a16:creationId xmlns:a16="http://schemas.microsoft.com/office/drawing/2014/main" id="{79EAC2D1-08FC-4CD7-9282-6132F3FE8863}"/>
               </a:ext>
             </a:extLst>
           </p:cNvPr>
@@ -11977,7 +11977,7 @@
           <p:cNvPr id="4" name="">
             <a:extLst xmlns:a="http://schemas.openxmlformats.org/drawingml/2006/main">
               <a:ext uri="{FF2B5EF4-FFF2-40B4-BE49-F238E27FC236}">
-                <a16:creationId xmlns:a16="http://schemas.microsoft.com/office/drawing/2014/main" id="{69E77CF0-447C-4033-8192-5F0C712C9B88}"/>
+                <a16:creationId xmlns:a16="http://schemas.microsoft.com/office/drawing/2014/main" id="{A2A5E04D-7E7E-4837-B6CB-4E298DFFADCC}"/>
               </a:ext>
             </a:extLst>
           </p:cNvPr>
@@ -12101,7 +12101,7 @@
           <p:cNvPr id="5" name="">
             <a:extLst xmlns:a="http://schemas.openxmlformats.org/drawingml/2006/main">
               <a:ext uri="{FF2B5EF4-FFF2-40B4-BE49-F238E27FC236}">
-                <a16:creationId xmlns:a16="http://schemas.microsoft.com/office/drawing/2014/main" id="{2C1218F9-A7ED-4267-AC75-406229DD8BED}"/>
+                <a16:creationId xmlns:a16="http://schemas.microsoft.com/office/drawing/2014/main" id="{65BA0320-1EF0-43C4-B32C-FF7243C6DA1E}"/>
               </a:ext>
             </a:extLst>
           </p:cNvPr>
@@ -12169,7 +12169,7 @@
           <p:cNvPr id="6" name="">
             <a:extLst xmlns:a="http://schemas.openxmlformats.org/drawingml/2006/main">
               <a:ext uri="{FF2B5EF4-FFF2-40B4-BE49-F238E27FC236}">
-                <a16:creationId xmlns:a16="http://schemas.microsoft.com/office/drawing/2014/main" id="{D28DB72A-12B4-487D-89E7-950ECCD27544}"/>
+                <a16:creationId xmlns:a16="http://schemas.microsoft.com/office/drawing/2014/main" id="{5AA6F01D-48E1-4486-B624-F8E250FCFF86}"/>
               </a:ext>
             </a:extLst>
           </p:cNvPr>
@@ -12235,7 +12235,7 @@
     </p:spTree>
     <p:extLst>
       <p:ext uri="{BB962C8B-B14F-4D97-AF65-F5344CB8AC3E}">
-        <p14:creationId xmlns:p14="http://schemas.microsoft.com/office/powerpoint/2010/main" val="1646737437"/>
+        <p14:creationId xmlns:p14="http://schemas.microsoft.com/office/powerpoint/2010/main" val="396865389"/>
       </p:ext>
     </p:extLst>
   </p:cSld>
@@ -12266,7 +12266,7 @@
           <p:cNvPr id="13" name="">
             <a:extLst xmlns:a="http://schemas.openxmlformats.org/drawingml/2006/main">
               <a:ext uri="{FF2B5EF4-FFF2-40B4-BE49-F238E27FC236}">
-                <a16:creationId xmlns:a16="http://schemas.microsoft.com/office/drawing/2014/main" id="{B2163244-C9B9-4225-8D70-0B01EFB1C649}"/>
+                <a16:creationId xmlns:a16="http://schemas.microsoft.com/office/drawing/2014/main" id="{A528FE1D-E0A6-4790-984B-2C6EAF26DBFA}"/>
               </a:ext>
             </a:extLst>
           </p:cNvPr>
@@ -12334,7 +12334,7 @@
           <p:cNvPr id="2" name="">
             <a:extLst xmlns:a="http://schemas.openxmlformats.org/drawingml/2006/main">
               <a:ext uri="{FF2B5EF4-FFF2-40B4-BE49-F238E27FC236}">
-                <a16:creationId xmlns:a16="http://schemas.microsoft.com/office/drawing/2014/main" id="{7BF77707-C9C6-4329-AD11-0BD63198403F}"/>
+                <a16:creationId xmlns:a16="http://schemas.microsoft.com/office/drawing/2014/main" id="{B8E45BEB-388A-436E-B830-C870306263F0}"/>
               </a:ext>
             </a:extLst>
           </p:cNvPr>
@@ -12402,7 +12402,7 @@
           <p:cNvPr id="3" name="">
             <a:extLst xmlns:a="http://schemas.openxmlformats.org/drawingml/2006/main">
               <a:ext uri="{FF2B5EF4-FFF2-40B4-BE49-F238E27FC236}">
-                <a16:creationId xmlns:a16="http://schemas.microsoft.com/office/drawing/2014/main" id="{123ED84D-2065-4185-91A3-E2A91C1F3B90}"/>
+                <a16:creationId xmlns:a16="http://schemas.microsoft.com/office/drawing/2014/main" id="{8EC24DB3-E188-4FCE-932A-14E02984E2CC}"/>
               </a:ext>
             </a:extLst>
           </p:cNvPr>
@@ -12470,7 +12470,7 @@
           <p:cNvPr id="4" name="">
             <a:extLst xmlns:a="http://schemas.openxmlformats.org/drawingml/2006/main">
               <a:ext uri="{FF2B5EF4-FFF2-40B4-BE49-F238E27FC236}">
-                <a16:creationId xmlns:a16="http://schemas.microsoft.com/office/drawing/2014/main" id="{336A1240-E20A-47E0-BD88-0E5B6F09DCB6}"/>
+                <a16:creationId xmlns:a16="http://schemas.microsoft.com/office/drawing/2014/main" id="{D2D0C013-CF20-4B87-8310-AED92509C975}"/>
               </a:ext>
             </a:extLst>
           </p:cNvPr>
@@ -12594,7 +12594,7 @@
           <p:cNvPr id="5" name="">
             <a:extLst xmlns:a="http://schemas.openxmlformats.org/drawingml/2006/main">
               <a:ext uri="{FF2B5EF4-FFF2-40B4-BE49-F238E27FC236}">
-                <a16:creationId xmlns:a16="http://schemas.microsoft.com/office/drawing/2014/main" id="{A72CA3CE-B469-4247-8A86-0CB46CDB80C4}"/>
+                <a16:creationId xmlns:a16="http://schemas.microsoft.com/office/drawing/2014/main" id="{57EF13A0-82DC-440B-AB6C-F6BC43FB330C}"/>
               </a:ext>
             </a:extLst>
           </p:cNvPr>
@@ -12662,7 +12662,7 @@
           <p:cNvPr id="6" name="">
             <a:extLst xmlns:a="http://schemas.openxmlformats.org/drawingml/2006/main">
               <a:ext uri="{FF2B5EF4-FFF2-40B4-BE49-F238E27FC236}">
-                <a16:creationId xmlns:a16="http://schemas.microsoft.com/office/drawing/2014/main" id="{11BEA854-8D0F-4F41-8EB4-DCED228C2AA9}"/>
+                <a16:creationId xmlns:a16="http://schemas.microsoft.com/office/drawing/2014/main" id="{9065CE0F-213D-4B98-B1EF-363ED4C1D1FA}"/>
               </a:ext>
             </a:extLst>
           </p:cNvPr>
@@ -12730,7 +12730,7 @@
           <p:cNvPr id="7" name="">
             <a:extLst xmlns:a="http://schemas.openxmlformats.org/drawingml/2006/main">
               <a:ext uri="{FF2B5EF4-FFF2-40B4-BE49-F238E27FC236}">
-                <a16:creationId xmlns:a16="http://schemas.microsoft.com/office/drawing/2014/main" id="{41C94C40-8F2C-482B-BEFD-FA8B296611C2}"/>
+                <a16:creationId xmlns:a16="http://schemas.microsoft.com/office/drawing/2014/main" id="{A3082520-C9ED-430B-A82B-3E5C93065DA5}"/>
               </a:ext>
             </a:extLst>
           </p:cNvPr>
@@ -12798,7 +12798,7 @@
           <p:cNvPr id="8" name="">
             <a:extLst xmlns:a="http://schemas.openxmlformats.org/drawingml/2006/main">
               <a:ext uri="{FF2B5EF4-FFF2-40B4-BE49-F238E27FC236}">
-                <a16:creationId xmlns:a16="http://schemas.microsoft.com/office/drawing/2014/main" id="{4DD3DCE0-9C0B-4868-A94F-56F7A173D2EA}"/>
+                <a16:creationId xmlns:a16="http://schemas.microsoft.com/office/drawing/2014/main" id="{66042313-CC72-462C-9372-3791AE69CD18}"/>
               </a:ext>
             </a:extLst>
           </p:cNvPr>
@@ -12866,7 +12866,7 @@
           <p:cNvPr id="9" name="">
             <a:extLst xmlns:a="http://schemas.openxmlformats.org/drawingml/2006/main">
               <a:ext uri="{FF2B5EF4-FFF2-40B4-BE49-F238E27FC236}">
-                <a16:creationId xmlns:a16="http://schemas.microsoft.com/office/drawing/2014/main" id="{05C632C9-A498-44D7-AC25-15F6A2D5E770}"/>
+                <a16:creationId xmlns:a16="http://schemas.microsoft.com/office/drawing/2014/main" id="{D95F5ECE-76CD-41DB-9654-88AF30E438EE}"/>
               </a:ext>
             </a:extLst>
           </p:cNvPr>
@@ -12934,7 +12934,7 @@
           <p:cNvPr id="10" name="">
             <a:extLst xmlns:a="http://schemas.openxmlformats.org/drawingml/2006/main">
               <a:ext uri="{FF2B5EF4-FFF2-40B4-BE49-F238E27FC236}">
-                <a16:creationId xmlns:a16="http://schemas.microsoft.com/office/drawing/2014/main" id="{CD77AF99-BA2B-4D76-954B-91FA1217300A}"/>
+                <a16:creationId xmlns:a16="http://schemas.microsoft.com/office/drawing/2014/main" id="{A9A094F7-67C4-4F65-A144-70880085AF8D}"/>
               </a:ext>
             </a:extLst>
           </p:cNvPr>
@@ -13002,7 +13002,7 @@
           <p:cNvPr id="11" name="">
             <a:extLst xmlns:a="http://schemas.openxmlformats.org/drawingml/2006/main">
               <a:ext uri="{FF2B5EF4-FFF2-40B4-BE49-F238E27FC236}">
-                <a16:creationId xmlns:a16="http://schemas.microsoft.com/office/drawing/2014/main" id="{5128D410-71DA-41CD-9A28-6E5F415BCECB}"/>
+                <a16:creationId xmlns:a16="http://schemas.microsoft.com/office/drawing/2014/main" id="{10ED630F-D969-4EE6-89CD-C5DE567F4FE4}"/>
               </a:ext>
             </a:extLst>
           </p:cNvPr>
@@ -13070,7 +13070,7 @@
           <p:cNvPr id="12" name="">
             <a:extLst xmlns:a="http://schemas.openxmlformats.org/drawingml/2006/main">
               <a:ext uri="{FF2B5EF4-FFF2-40B4-BE49-F238E27FC236}">
-                <a16:creationId xmlns:a16="http://schemas.microsoft.com/office/drawing/2014/main" id="{2E83CE15-F1C1-415B-ACF5-F2A478FE0168}"/>
+                <a16:creationId xmlns:a16="http://schemas.microsoft.com/office/drawing/2014/main" id="{09C626C9-2389-4E86-95AE-5681FC8184B4}"/>
               </a:ext>
             </a:extLst>
           </p:cNvPr>
@@ -13136,7 +13136,7 @@
     </p:spTree>
     <p:extLst>
       <p:ext uri="{BB962C8B-B14F-4D97-AF65-F5344CB8AC3E}">
-        <p14:creationId xmlns:p14="http://schemas.microsoft.com/office/powerpoint/2010/main" val="381721275"/>
+        <p14:creationId xmlns:p14="http://schemas.microsoft.com/office/powerpoint/2010/main" val="537550378"/>
       </p:ext>
     </p:extLst>
   </p:cSld>
@@ -13167,7 +13167,7 @@
           <p:cNvPr id="11" name="">
             <a:extLst xmlns:a="http://schemas.openxmlformats.org/drawingml/2006/main">
               <a:ext uri="{FF2B5EF4-FFF2-40B4-BE49-F238E27FC236}">
-                <a16:creationId xmlns:a16="http://schemas.microsoft.com/office/drawing/2014/main" id="{D7627308-4675-4649-9F8D-3C3C2CA0DDC1}"/>
+                <a16:creationId xmlns:a16="http://schemas.microsoft.com/office/drawing/2014/main" id="{F27458BD-D01F-4979-A2D6-7BCDBA8B9D69}"/>
               </a:ext>
             </a:extLst>
           </p:cNvPr>
@@ -13235,7 +13235,7 @@
           <p:cNvPr id="2" name="">
             <a:extLst xmlns:a="http://schemas.openxmlformats.org/drawingml/2006/main">
               <a:ext uri="{FF2B5EF4-FFF2-40B4-BE49-F238E27FC236}">
-                <a16:creationId xmlns:a16="http://schemas.microsoft.com/office/drawing/2014/main" id="{7B01C341-23B2-49E4-B815-12DEA25CFB49}"/>
+                <a16:creationId xmlns:a16="http://schemas.microsoft.com/office/drawing/2014/main" id="{E3D02E63-0F87-42C6-839D-93C77A3AED87}"/>
               </a:ext>
             </a:extLst>
           </p:cNvPr>
@@ -13303,7 +13303,7 @@
           <p:cNvPr id="3" name="">
             <a:extLst xmlns:a="http://schemas.openxmlformats.org/drawingml/2006/main">
               <a:ext uri="{FF2B5EF4-FFF2-40B4-BE49-F238E27FC236}">
-                <a16:creationId xmlns:a16="http://schemas.microsoft.com/office/drawing/2014/main" id="{C3217D09-2EE1-4000-B7B1-61007BACE098}"/>
+                <a16:creationId xmlns:a16="http://schemas.microsoft.com/office/drawing/2014/main" id="{83CAD14D-021F-4C92-B749-F67D13A7454B}"/>
               </a:ext>
             </a:extLst>
           </p:cNvPr>
@@ -13371,7 +13371,7 @@
           <p:cNvPr id="4" name="">
             <a:extLst xmlns:a="http://schemas.openxmlformats.org/drawingml/2006/main">
               <a:ext uri="{FF2B5EF4-FFF2-40B4-BE49-F238E27FC236}">
-                <a16:creationId xmlns:a16="http://schemas.microsoft.com/office/drawing/2014/main" id="{2FA96097-FDD6-4D5B-A9A8-1552A074155B}"/>
+                <a16:creationId xmlns:a16="http://schemas.microsoft.com/office/drawing/2014/main" id="{11BF36DC-AC73-4F67-B340-F0DC655AFB42}"/>
               </a:ext>
             </a:extLst>
           </p:cNvPr>
@@ -13495,7 +13495,7 @@
           <p:cNvPr id="5" name="">
             <a:extLst xmlns:a="http://schemas.openxmlformats.org/drawingml/2006/main">
               <a:ext uri="{FF2B5EF4-FFF2-40B4-BE49-F238E27FC236}">
-                <a16:creationId xmlns:a16="http://schemas.microsoft.com/office/drawing/2014/main" id="{31AEEF55-3057-44C3-ADB4-BA85513BDA0A}"/>
+                <a16:creationId xmlns:a16="http://schemas.microsoft.com/office/drawing/2014/main" id="{19F4746E-663B-4885-A32D-180035C911CB}"/>
               </a:ext>
             </a:extLst>
           </p:cNvPr>
@@ -13563,7 +13563,7 @@
           <p:cNvPr id="6" name="">
             <a:extLst xmlns:a="http://schemas.openxmlformats.org/drawingml/2006/main">
               <a:ext uri="{FF2B5EF4-FFF2-40B4-BE49-F238E27FC236}">
-                <a16:creationId xmlns:a16="http://schemas.microsoft.com/office/drawing/2014/main" id="{698C58DA-7F25-449A-AA22-F392857F31E8}"/>
+                <a16:creationId xmlns:a16="http://schemas.microsoft.com/office/drawing/2014/main" id="{27F724E1-81D1-4F9E-BF1F-D5696DC24685}"/>
               </a:ext>
             </a:extLst>
           </p:cNvPr>
@@ -13631,7 +13631,7 @@
           <p:cNvPr id="7" name="">
             <a:extLst xmlns:a="http://schemas.openxmlformats.org/drawingml/2006/main">
               <a:ext uri="{FF2B5EF4-FFF2-40B4-BE49-F238E27FC236}">
-                <a16:creationId xmlns:a16="http://schemas.microsoft.com/office/drawing/2014/main" id="{9DC0E8BE-5F92-47D9-8247-620DF1A86016}"/>
+                <a16:creationId xmlns:a16="http://schemas.microsoft.com/office/drawing/2014/main" id="{C7E6941A-E6E6-49D4-A06B-978ABAB5B33A}"/>
               </a:ext>
             </a:extLst>
           </p:cNvPr>
@@ -13699,7 +13699,7 @@
           <p:cNvPr id="8" name="">
             <a:extLst xmlns:a="http://schemas.openxmlformats.org/drawingml/2006/main">
               <a:ext uri="{FF2B5EF4-FFF2-40B4-BE49-F238E27FC236}">
-                <a16:creationId xmlns:a16="http://schemas.microsoft.com/office/drawing/2014/main" id="{5DE644C7-7B6C-459C-9D07-38114F466209}"/>
+                <a16:creationId xmlns:a16="http://schemas.microsoft.com/office/drawing/2014/main" id="{715DF19D-B54C-4B18-813B-C75AD30F548D}"/>
               </a:ext>
             </a:extLst>
           </p:cNvPr>
@@ -13767,7 +13767,7 @@
           <p:cNvPr id="9" name="">
             <a:extLst xmlns:a="http://schemas.openxmlformats.org/drawingml/2006/main">
               <a:ext uri="{FF2B5EF4-FFF2-40B4-BE49-F238E27FC236}">
-                <a16:creationId xmlns:a16="http://schemas.microsoft.com/office/drawing/2014/main" id="{BFE0D463-3554-4965-A4F5-51BE1D0D40F1}"/>
+                <a16:creationId xmlns:a16="http://schemas.microsoft.com/office/drawing/2014/main" id="{14A87FDB-ACC5-4723-8D60-23B12B0A09EC}"/>
               </a:ext>
             </a:extLst>
           </p:cNvPr>
@@ -13835,7 +13835,7 @@
           <p:cNvPr id="10" name="">
             <a:extLst xmlns:a="http://schemas.openxmlformats.org/drawingml/2006/main">
               <a:ext uri="{FF2B5EF4-FFF2-40B4-BE49-F238E27FC236}">
-                <a16:creationId xmlns:a16="http://schemas.microsoft.com/office/drawing/2014/main" id="{B44AEF53-E467-4937-B425-FAF4692DEB4A}"/>
+                <a16:creationId xmlns:a16="http://schemas.microsoft.com/office/drawing/2014/main" id="{657ED430-36A9-4AD6-A041-6281DEF73AAD}"/>
               </a:ext>
             </a:extLst>
           </p:cNvPr>
@@ -13901,7 +13901,7 @@
     </p:spTree>
     <p:extLst>
       <p:ext uri="{BB962C8B-B14F-4D97-AF65-F5344CB8AC3E}">
-        <p14:creationId xmlns:p14="http://schemas.microsoft.com/office/powerpoint/2010/main" val="1060895895"/>
+        <p14:creationId xmlns:p14="http://schemas.microsoft.com/office/powerpoint/2010/main" val="128137568"/>
       </p:ext>
     </p:extLst>
   </p:cSld>
@@ -13932,7 +13932,7 @@
           <p:cNvPr id="11" name="">
             <a:extLst xmlns:a="http://schemas.openxmlformats.org/drawingml/2006/main">
               <a:ext uri="{FF2B5EF4-FFF2-40B4-BE49-F238E27FC236}">
-                <a16:creationId xmlns:a16="http://schemas.microsoft.com/office/drawing/2014/main" id="{481A18D0-D30E-469A-88BE-CFAF16711257}"/>
+                <a16:creationId xmlns:a16="http://schemas.microsoft.com/office/drawing/2014/main" id="{FBA538C5-90B5-48B4-BDAB-11E7A275BA23}"/>
               </a:ext>
             </a:extLst>
           </p:cNvPr>
@@ -14000,7 +14000,7 @@
           <p:cNvPr id="2" name="">
             <a:extLst xmlns:a="http://schemas.openxmlformats.org/drawingml/2006/main">
               <a:ext uri="{FF2B5EF4-FFF2-40B4-BE49-F238E27FC236}">
-                <a16:creationId xmlns:a16="http://schemas.microsoft.com/office/drawing/2014/main" id="{D445895A-7A5A-4C5D-B5FC-238240FA35B8}"/>
+                <a16:creationId xmlns:a16="http://schemas.microsoft.com/office/drawing/2014/main" id="{DBC8B3BB-4F44-49E1-94E4-FFF76FFC9812}"/>
               </a:ext>
             </a:extLst>
           </p:cNvPr>
@@ -14068,7 +14068,7 @@
           <p:cNvPr id="3" name="">
             <a:extLst xmlns:a="http://schemas.openxmlformats.org/drawingml/2006/main">
               <a:ext uri="{FF2B5EF4-FFF2-40B4-BE49-F238E27FC236}">
-                <a16:creationId xmlns:a16="http://schemas.microsoft.com/office/drawing/2014/main" id="{A3726C8D-61D1-44FE-BCAA-7BA548FA3D76}"/>
+                <a16:creationId xmlns:a16="http://schemas.microsoft.com/office/drawing/2014/main" id="{E6074176-76AF-4B39-85AC-A15784E0F3E9}"/>
               </a:ext>
             </a:extLst>
           </p:cNvPr>
@@ -14136,7 +14136,7 @@
           <p:cNvPr id="4" name="">
             <a:extLst xmlns:a="http://schemas.openxmlformats.org/drawingml/2006/main">
               <a:ext uri="{FF2B5EF4-FFF2-40B4-BE49-F238E27FC236}">
-                <a16:creationId xmlns:a16="http://schemas.microsoft.com/office/drawing/2014/main" id="{CDA5F043-DFE6-40ED-BD72-9D43FBD39B60}"/>
+                <a16:creationId xmlns:a16="http://schemas.microsoft.com/office/drawing/2014/main" id="{E88D7399-7641-4B9E-968D-0876343923D6}"/>
               </a:ext>
             </a:extLst>
           </p:cNvPr>
@@ -14260,7 +14260,7 @@
           <p:cNvPr id="5" name="">
             <a:extLst xmlns:a="http://schemas.openxmlformats.org/drawingml/2006/main">
               <a:ext uri="{FF2B5EF4-FFF2-40B4-BE49-F238E27FC236}">
-                <a16:creationId xmlns:a16="http://schemas.microsoft.com/office/drawing/2014/main" id="{CBFF1830-C08D-404B-9B15-E6AFAFD29B92}"/>
+                <a16:creationId xmlns:a16="http://schemas.microsoft.com/office/drawing/2014/main" id="{EFE1CBFB-FAD5-4B2E-9F81-2461F91DD529}"/>
               </a:ext>
             </a:extLst>
           </p:cNvPr>
@@ -14328,7 +14328,7 @@
           <p:cNvPr id="6" name="">
             <a:extLst xmlns:a="http://schemas.openxmlformats.org/drawingml/2006/main">
               <a:ext uri="{FF2B5EF4-FFF2-40B4-BE49-F238E27FC236}">
-                <a16:creationId xmlns:a16="http://schemas.microsoft.com/office/drawing/2014/main" id="{21D245EF-9F87-4395-85C8-8980EDAC4EE6}"/>
+                <a16:creationId xmlns:a16="http://schemas.microsoft.com/office/drawing/2014/main" id="{2B09A0C4-0DBA-4D46-BC11-6891FB89B44E}"/>
               </a:ext>
             </a:extLst>
           </p:cNvPr>
@@ -14396,7 +14396,7 @@
           <p:cNvPr id="7" name="">
             <a:extLst xmlns:a="http://schemas.openxmlformats.org/drawingml/2006/main">
               <a:ext uri="{FF2B5EF4-FFF2-40B4-BE49-F238E27FC236}">
-                <a16:creationId xmlns:a16="http://schemas.microsoft.com/office/drawing/2014/main" id="{D64E1E76-B9A1-4745-AC43-06E7AAE107F7}"/>
+                <a16:creationId xmlns:a16="http://schemas.microsoft.com/office/drawing/2014/main" id="{C891C75C-28AB-48C7-81CA-F6EEAA03D563}"/>
               </a:ext>
             </a:extLst>
           </p:cNvPr>
@@ -14464,7 +14464,7 @@
           <p:cNvPr id="8" name="">
             <a:extLst xmlns:a="http://schemas.openxmlformats.org/drawingml/2006/main">
               <a:ext uri="{FF2B5EF4-FFF2-40B4-BE49-F238E27FC236}">
-                <a16:creationId xmlns:a16="http://schemas.microsoft.com/office/drawing/2014/main" id="{29771718-CD35-4D1C-9C80-6E2C55BAAF93}"/>
+                <a16:creationId xmlns:a16="http://schemas.microsoft.com/office/drawing/2014/main" id="{C021A7F5-EFB2-42D9-888C-040F068A128C}"/>
               </a:ext>
             </a:extLst>
           </p:cNvPr>
@@ -14532,7 +14532,7 @@
           <p:cNvPr id="9" name="">
             <a:extLst xmlns:a="http://schemas.openxmlformats.org/drawingml/2006/main">
               <a:ext uri="{FF2B5EF4-FFF2-40B4-BE49-F238E27FC236}">
-                <a16:creationId xmlns:a16="http://schemas.microsoft.com/office/drawing/2014/main" id="{181D7E07-B3B1-4DE1-8833-FCA70D9C3C35}"/>
+                <a16:creationId xmlns:a16="http://schemas.microsoft.com/office/drawing/2014/main" id="{39691B9D-C3BB-41F1-9EAB-88F3D104D277}"/>
               </a:ext>
             </a:extLst>
           </p:cNvPr>
@@ -14600,7 +14600,7 @@
           <p:cNvPr id="10" name="">
             <a:extLst xmlns:a="http://schemas.openxmlformats.org/drawingml/2006/main">
               <a:ext uri="{FF2B5EF4-FFF2-40B4-BE49-F238E27FC236}">
-                <a16:creationId xmlns:a16="http://schemas.microsoft.com/office/drawing/2014/main" id="{64A388A4-3E87-4B8D-B700-6FF4EF543156}"/>
+                <a16:creationId xmlns:a16="http://schemas.microsoft.com/office/drawing/2014/main" id="{D81FA325-95D1-4B49-96BA-4D7BCD640C90}"/>
               </a:ext>
             </a:extLst>
           </p:cNvPr>
@@ -14666,7 +14666,7 @@
     </p:spTree>
     <p:extLst>
       <p:ext uri="{BB962C8B-B14F-4D97-AF65-F5344CB8AC3E}">
-        <p14:creationId xmlns:p14="http://schemas.microsoft.com/office/powerpoint/2010/main" val="1477302243"/>
+        <p14:creationId xmlns:p14="http://schemas.microsoft.com/office/powerpoint/2010/main" val="105979203"/>
       </p:ext>
     </p:extLst>
   </p:cSld>
@@ -14697,7 +14697,7 @@
           <p:cNvPr id="8" name="">
             <a:extLst xmlns:a="http://schemas.openxmlformats.org/drawingml/2006/main">
               <a:ext uri="{FF2B5EF4-FFF2-40B4-BE49-F238E27FC236}">
-                <a16:creationId xmlns:a16="http://schemas.microsoft.com/office/drawing/2014/main" id="{03A3C2A6-1A3F-4861-9089-F8DFFC72E700}"/>
+                <a16:creationId xmlns:a16="http://schemas.microsoft.com/office/drawing/2014/main" id="{D845239A-D8E3-4435-8D4B-51C0B09B97D0}"/>
               </a:ext>
             </a:extLst>
           </p:cNvPr>
@@ -14765,7 +14765,7 @@
           <p:cNvPr id="2" name="">
             <a:extLst xmlns:a="http://schemas.openxmlformats.org/drawingml/2006/main">
               <a:ext uri="{FF2B5EF4-FFF2-40B4-BE49-F238E27FC236}">
-                <a16:creationId xmlns:a16="http://schemas.microsoft.com/office/drawing/2014/main" id="{16AC85F8-E16F-40E1-8A3C-D8BF5D695815}"/>
+                <a16:creationId xmlns:a16="http://schemas.microsoft.com/office/drawing/2014/main" id="{49DFC1E0-69CB-4BAE-BF04-DE6ACC64E4C7}"/>
               </a:ext>
             </a:extLst>
           </p:cNvPr>
@@ -14833,7 +14833,7 @@
           <p:cNvPr id="3" name="">
             <a:extLst xmlns:a="http://schemas.openxmlformats.org/drawingml/2006/main">
               <a:ext uri="{FF2B5EF4-FFF2-40B4-BE49-F238E27FC236}">
-                <a16:creationId xmlns:a16="http://schemas.microsoft.com/office/drawing/2014/main" id="{8E55828A-01C3-4ADE-B7D5-601A68675410}"/>
+                <a16:creationId xmlns:a16="http://schemas.microsoft.com/office/drawing/2014/main" id="{D08A4D66-9314-40D4-834A-1F4DED2F4119}"/>
               </a:ext>
             </a:extLst>
           </p:cNvPr>
@@ -14901,7 +14901,7 @@
           <p:cNvPr id="4" name="">
             <a:extLst xmlns:a="http://schemas.openxmlformats.org/drawingml/2006/main">
               <a:ext uri="{FF2B5EF4-FFF2-40B4-BE49-F238E27FC236}">
-                <a16:creationId xmlns:a16="http://schemas.microsoft.com/office/drawing/2014/main" id="{B2BDC7FA-3F2A-490C-8727-FDAE0B04CFC8}"/>
+                <a16:creationId xmlns:a16="http://schemas.microsoft.com/office/drawing/2014/main" id="{1BC7EE7D-FCFA-42A5-9A33-B4EA0A631A60}"/>
               </a:ext>
             </a:extLst>
           </p:cNvPr>
@@ -15323,7 +15323,7 @@
           <p:cNvPr id="5" name="">
             <a:extLst xmlns:a="http://schemas.openxmlformats.org/drawingml/2006/main">
               <a:ext uri="{FF2B5EF4-FFF2-40B4-BE49-F238E27FC236}">
-                <a16:creationId xmlns:a16="http://schemas.microsoft.com/office/drawing/2014/main" id="{52AC293D-C723-477E-A40C-26BFE2ACAF02}"/>
+                <a16:creationId xmlns:a16="http://schemas.microsoft.com/office/drawing/2014/main" id="{64E444CD-8241-4CEB-AAB4-493ED6328A21}"/>
               </a:ext>
             </a:extLst>
           </p:cNvPr>
@@ -15391,7 +15391,7 @@
           <p:cNvPr id="6" name="">
             <a:extLst xmlns:a="http://schemas.openxmlformats.org/drawingml/2006/main">
               <a:ext uri="{FF2B5EF4-FFF2-40B4-BE49-F238E27FC236}">
-                <a16:creationId xmlns:a16="http://schemas.microsoft.com/office/drawing/2014/main" id="{4354452D-A602-40BA-BD43-C829B1E2C915}"/>
+                <a16:creationId xmlns:a16="http://schemas.microsoft.com/office/drawing/2014/main" id="{ECD56AB4-33A4-4E1E-B48A-34D634B2EC41}"/>
               </a:ext>
             </a:extLst>
           </p:cNvPr>
@@ -15459,7 +15459,7 @@
           <p:cNvPr id="7" name="">
             <a:extLst xmlns:a="http://schemas.openxmlformats.org/drawingml/2006/main">
               <a:ext uri="{FF2B5EF4-FFF2-40B4-BE49-F238E27FC236}">
-                <a16:creationId xmlns:a16="http://schemas.microsoft.com/office/drawing/2014/main" id="{F777D265-14DA-4131-8F41-07BBDFDC7645}"/>
+                <a16:creationId xmlns:a16="http://schemas.microsoft.com/office/drawing/2014/main" id="{517807CC-AF0A-45F9-B828-3D0512547EE3}"/>
               </a:ext>
             </a:extLst>
           </p:cNvPr>
@@ -15525,7 +15525,7 @@
     </p:spTree>
     <p:extLst>
       <p:ext uri="{BB962C8B-B14F-4D97-AF65-F5344CB8AC3E}">
-        <p14:creationId xmlns:p14="http://schemas.microsoft.com/office/powerpoint/2010/main" val="1945066792"/>
+        <p14:creationId xmlns:p14="http://schemas.microsoft.com/office/powerpoint/2010/main" val="1205300107"/>
       </p:ext>
     </p:extLst>
   </p:cSld>

</xml_diff>

<commit_message>
Fit week 5 lab into 90 minutes and limit QR check-in to 60 seconds
</commit_message>
<xml_diff>
--- a/lendet/2026-2027/mobile/lectures/ligjerata-05-hyrja-lejet-rideshare-2026.pptx
+++ b/lendet/2026-2027/mobile/lectures/ligjerata-05-hyrja-lejet-rideshare-2026.pptx
@@ -2,29 +2,29 @@
 <file path=ppt/presentation.xml><?xml version="1.0" encoding="utf-8"?>
 <p:presentation xmlns:p="http://schemas.openxmlformats.org/presentationml/2006/main">
   <p:sldMasterIdLst>
-    <p:sldMasterId xmlns:r="http://schemas.openxmlformats.org/officeDocument/2006/relationships" id="2147483648" r:id="Re6c0461688854029"/>
+    <p:sldMasterId xmlns:r="http://schemas.openxmlformats.org/officeDocument/2006/relationships" id="2147483648" r:id="Rd2249f5c8f5045fd"/>
   </p:sldMasterIdLst>
   <p:sldIdLst>
-    <p:sldId xmlns:r="http://schemas.openxmlformats.org/officeDocument/2006/relationships" id="256" r:id="R07da8900fdbd436d"/>
-    <p:sldId xmlns:r="http://schemas.openxmlformats.org/officeDocument/2006/relationships" id="257" r:id="R9affa4b292c34e47"/>
-    <p:sldId xmlns:r="http://schemas.openxmlformats.org/officeDocument/2006/relationships" id="258" r:id="R028e769b095d458d"/>
-    <p:sldId xmlns:r="http://schemas.openxmlformats.org/officeDocument/2006/relationships" id="259" r:id="Rb2fa812846094158"/>
-    <p:sldId xmlns:r="http://schemas.openxmlformats.org/officeDocument/2006/relationships" id="260" r:id="R96f5cfe992d44a52"/>
-    <p:sldId xmlns:r="http://schemas.openxmlformats.org/officeDocument/2006/relationships" id="261" r:id="R367f7d4167dc4299"/>
-    <p:sldId xmlns:r="http://schemas.openxmlformats.org/officeDocument/2006/relationships" id="262" r:id="Rfc6f0dc542c84f00"/>
-    <p:sldId xmlns:r="http://schemas.openxmlformats.org/officeDocument/2006/relationships" id="263" r:id="R5bb25875755d4a37"/>
-    <p:sldId xmlns:r="http://schemas.openxmlformats.org/officeDocument/2006/relationships" id="264" r:id="Rd259049c2c91400f"/>
-    <p:sldId xmlns:r="http://schemas.openxmlformats.org/officeDocument/2006/relationships" id="265" r:id="Rfec50c535a0a438b"/>
-    <p:sldId xmlns:r="http://schemas.openxmlformats.org/officeDocument/2006/relationships" id="266" r:id="R1278c3d84c40424e"/>
-    <p:sldId xmlns:r="http://schemas.openxmlformats.org/officeDocument/2006/relationships" id="267" r:id="R7da3158362434e8d"/>
-    <p:sldId xmlns:r="http://schemas.openxmlformats.org/officeDocument/2006/relationships" id="268" r:id="R93ed994579ff41a6"/>
-    <p:sldId xmlns:r="http://schemas.openxmlformats.org/officeDocument/2006/relationships" id="269" r:id="Rde186ae04867440b"/>
-    <p:sldId xmlns:r="http://schemas.openxmlformats.org/officeDocument/2006/relationships" id="270" r:id="R6e587f706f874a62"/>
-    <p:sldId xmlns:r="http://schemas.openxmlformats.org/officeDocument/2006/relationships" id="271" r:id="R1280b6c64a334d69"/>
-    <p:sldId xmlns:r="http://schemas.openxmlformats.org/officeDocument/2006/relationships" id="272" r:id="R88a714e39eba41ab"/>
-    <p:sldId xmlns:r="http://schemas.openxmlformats.org/officeDocument/2006/relationships" id="273" r:id="Rd5e52cb76bf74398"/>
-    <p:sldId xmlns:r="http://schemas.openxmlformats.org/officeDocument/2006/relationships" id="274" r:id="Rb7dbde05e3c0454e"/>
-    <p:sldId xmlns:r="http://schemas.openxmlformats.org/officeDocument/2006/relationships" id="275" r:id="R68851af7ea964f0d"/>
+    <p:sldId xmlns:r="http://schemas.openxmlformats.org/officeDocument/2006/relationships" id="256" r:id="Rb32bafd86f3b4d99"/>
+    <p:sldId xmlns:r="http://schemas.openxmlformats.org/officeDocument/2006/relationships" id="257" r:id="Rc836b2b09e014b0e"/>
+    <p:sldId xmlns:r="http://schemas.openxmlformats.org/officeDocument/2006/relationships" id="258" r:id="R45d3643ca76c4aff"/>
+    <p:sldId xmlns:r="http://schemas.openxmlformats.org/officeDocument/2006/relationships" id="259" r:id="R15daa455807a450a"/>
+    <p:sldId xmlns:r="http://schemas.openxmlformats.org/officeDocument/2006/relationships" id="260" r:id="Re067d31cf23e4203"/>
+    <p:sldId xmlns:r="http://schemas.openxmlformats.org/officeDocument/2006/relationships" id="261" r:id="Ra153e502984345b0"/>
+    <p:sldId xmlns:r="http://schemas.openxmlformats.org/officeDocument/2006/relationships" id="262" r:id="R7606ab05393b4653"/>
+    <p:sldId xmlns:r="http://schemas.openxmlformats.org/officeDocument/2006/relationships" id="263" r:id="Rbc938c25c9ce4f2c"/>
+    <p:sldId xmlns:r="http://schemas.openxmlformats.org/officeDocument/2006/relationships" id="264" r:id="R80bcb2a9d07b4701"/>
+    <p:sldId xmlns:r="http://schemas.openxmlformats.org/officeDocument/2006/relationships" id="265" r:id="R0eaba9ec2de44eff"/>
+    <p:sldId xmlns:r="http://schemas.openxmlformats.org/officeDocument/2006/relationships" id="266" r:id="R87ec5e3bab6c475b"/>
+    <p:sldId xmlns:r="http://schemas.openxmlformats.org/officeDocument/2006/relationships" id="267" r:id="R3fab61f2869a452d"/>
+    <p:sldId xmlns:r="http://schemas.openxmlformats.org/officeDocument/2006/relationships" id="268" r:id="R70ae99f373c1465f"/>
+    <p:sldId xmlns:r="http://schemas.openxmlformats.org/officeDocument/2006/relationships" id="269" r:id="Red9406ccb8164ae8"/>
+    <p:sldId xmlns:r="http://schemas.openxmlformats.org/officeDocument/2006/relationships" id="270" r:id="Rdc473cf2349a436a"/>
+    <p:sldId xmlns:r="http://schemas.openxmlformats.org/officeDocument/2006/relationships" id="271" r:id="R92a80840a2e94767"/>
+    <p:sldId xmlns:r="http://schemas.openxmlformats.org/officeDocument/2006/relationships" id="272" r:id="R98ce78c9b42f4186"/>
+    <p:sldId xmlns:r="http://schemas.openxmlformats.org/officeDocument/2006/relationships" id="273" r:id="Reaa10e639dfa4b6f"/>
+    <p:sldId xmlns:r="http://schemas.openxmlformats.org/officeDocument/2006/relationships" id="274" r:id="R3060c776e1c74c02"/>
+    <p:sldId xmlns:r="http://schemas.openxmlformats.org/officeDocument/2006/relationships" id="275" r:id="R6ae58fb2072d4142"/>
   </p:sldIdLst>
   <p:sldSz cx="12192000" cy="6858000"/>
   <p:notesSz cx="6858000" cy="9144000"/>
@@ -48,7 +48,7 @@
           <p:cNvPr id="3" name="Title">
             <a:extLst xmlns:a="http://schemas.openxmlformats.org/drawingml/2006/main">
               <a:ext uri="{FF2B5EF4-FFF2-40B4-BE49-F238E27FC236}">
-                <a16:creationId xmlns:a16="http://schemas.microsoft.com/office/drawing/2014/main" id="{29B51D88-EED4-45C6-B81C-0393C6A51168}"/>
+                <a16:creationId xmlns:a16="http://schemas.microsoft.com/office/drawing/2014/main" id="{73452BA2-1E5D-4CEB-ADBB-7E3FEBF1620C}"/>
               </a:ext>
             </a:extLst>
           </p:cNvPr>
@@ -205,7 +205,7 @@
           <p:cNvPr id="2" name="Subtitle">
             <a:extLst xmlns:a="http://schemas.openxmlformats.org/drawingml/2006/main">
               <a:ext uri="{FF2B5EF4-FFF2-40B4-BE49-F238E27FC236}">
-                <a16:creationId xmlns:a16="http://schemas.microsoft.com/office/drawing/2014/main" id="{408FCA49-D2E2-43A3-A188-15A256324869}"/>
+                <a16:creationId xmlns:a16="http://schemas.microsoft.com/office/drawing/2014/main" id="{1AA6D0F0-C4FE-42EA-9AC2-38BCF3772807}"/>
               </a:ext>
             </a:extLst>
           </p:cNvPr>
@@ -379,7 +379,7 @@
           <p:cNvPr id="2" name="Section title">
             <a:extLst xmlns:a="http://schemas.openxmlformats.org/drawingml/2006/main">
               <a:ext uri="{FF2B5EF4-FFF2-40B4-BE49-F238E27FC236}">
-                <a16:creationId xmlns:a16="http://schemas.microsoft.com/office/drawing/2014/main" id="{74B70489-5E4C-4922-85E4-0E590D405378}"/>
+                <a16:creationId xmlns:a16="http://schemas.microsoft.com/office/drawing/2014/main" id="{19E1F7D3-5D0F-4915-9D40-FF40B2CA1DBF}"/>
               </a:ext>
             </a:extLst>
           </p:cNvPr>
@@ -553,7 +553,7 @@
           <p:cNvPr id="3" name="Title">
             <a:extLst xmlns:a="http://schemas.openxmlformats.org/drawingml/2006/main">
               <a:ext uri="{FF2B5EF4-FFF2-40B4-BE49-F238E27FC236}">
-                <a16:creationId xmlns:a16="http://schemas.microsoft.com/office/drawing/2014/main" id="{5D9DB8E1-FBE8-45E2-A9AE-C2EA4A3B20D8}"/>
+                <a16:creationId xmlns:a16="http://schemas.microsoft.com/office/drawing/2014/main" id="{3D531294-A85A-4D95-9ABA-0FF90424B89C}"/>
               </a:ext>
             </a:extLst>
           </p:cNvPr>
@@ -710,7 +710,7 @@
           <p:cNvPr id="2" name="Body">
             <a:extLst xmlns:a="http://schemas.openxmlformats.org/drawingml/2006/main">
               <a:ext uri="{FF2B5EF4-FFF2-40B4-BE49-F238E27FC236}">
-                <a16:creationId xmlns:a16="http://schemas.microsoft.com/office/drawing/2014/main" id="{C35BB0BA-036D-485C-B418-8ED25506B259}"/>
+                <a16:creationId xmlns:a16="http://schemas.microsoft.com/office/drawing/2014/main" id="{CA7AC7B1-DAD5-4882-8B17-7FBDB404ADF4}"/>
               </a:ext>
             </a:extLst>
           </p:cNvPr>
@@ -884,7 +884,7 @@
           <p:cNvPr id="4" name="Title">
             <a:extLst xmlns:a="http://schemas.openxmlformats.org/drawingml/2006/main">
               <a:ext uri="{FF2B5EF4-FFF2-40B4-BE49-F238E27FC236}">
-                <a16:creationId xmlns:a16="http://schemas.microsoft.com/office/drawing/2014/main" id="{C5A7F206-87B0-4110-A32D-FC039F09F26D}"/>
+                <a16:creationId xmlns:a16="http://schemas.microsoft.com/office/drawing/2014/main" id="{ABDEAE51-7053-42C2-B937-DFC62DF934EA}"/>
               </a:ext>
             </a:extLst>
           </p:cNvPr>
@@ -1041,7 +1041,7 @@
           <p:cNvPr id="2" name="Left column">
             <a:extLst xmlns:a="http://schemas.openxmlformats.org/drawingml/2006/main">
               <a:ext uri="{FF2B5EF4-FFF2-40B4-BE49-F238E27FC236}">
-                <a16:creationId xmlns:a16="http://schemas.microsoft.com/office/drawing/2014/main" id="{C11BCAFC-2FB1-4042-8C3B-BCF07742B16F}"/>
+                <a16:creationId xmlns:a16="http://schemas.microsoft.com/office/drawing/2014/main" id="{583D5AE6-63D9-406F-8209-E8C0608DD774}"/>
               </a:ext>
             </a:extLst>
           </p:cNvPr>
@@ -1198,7 +1198,7 @@
           <p:cNvPr id="3" name="Right column">
             <a:extLst xmlns:a="http://schemas.openxmlformats.org/drawingml/2006/main">
               <a:ext uri="{FF2B5EF4-FFF2-40B4-BE49-F238E27FC236}">
-                <a16:creationId xmlns:a16="http://schemas.microsoft.com/office/drawing/2014/main" id="{F0D058A2-5EB0-4D0D-BC6A-75F455BD1010}"/>
+                <a16:creationId xmlns:a16="http://schemas.microsoft.com/office/drawing/2014/main" id="{652B1E9F-C45A-4CE8-8DFC-48A169655D6B}"/>
               </a:ext>
             </a:extLst>
           </p:cNvPr>
@@ -1372,7 +1372,7 @@
           <p:cNvPr id="3" name="Title">
             <a:extLst xmlns:a="http://schemas.openxmlformats.org/drawingml/2006/main">
               <a:ext uri="{FF2B5EF4-FFF2-40B4-BE49-F238E27FC236}">
-                <a16:creationId xmlns:a16="http://schemas.microsoft.com/office/drawing/2014/main" id="{3DDDB6B8-6E1B-436D-8C71-E75B5B4B1C13}"/>
+                <a16:creationId xmlns:a16="http://schemas.microsoft.com/office/drawing/2014/main" id="{28E1A03F-6DF2-416E-9F1A-81655E69A1F8}"/>
               </a:ext>
             </a:extLst>
           </p:cNvPr>
@@ -1529,7 +1529,7 @@
           <p:cNvPr id="2" name="Left column">
             <a:extLst xmlns:a="http://schemas.openxmlformats.org/drawingml/2006/main">
               <a:ext uri="{FF2B5EF4-FFF2-40B4-BE49-F238E27FC236}">
-                <a16:creationId xmlns:a16="http://schemas.microsoft.com/office/drawing/2014/main" id="{58DE0553-1398-4F53-854E-378733AD6EA9}"/>
+                <a16:creationId xmlns:a16="http://schemas.microsoft.com/office/drawing/2014/main" id="{6E1A128D-382F-48BB-8170-4D23C8127B95}"/>
               </a:ext>
             </a:extLst>
           </p:cNvPr>
@@ -1724,12 +1724,12 @@
   </p:cSld>
   <p:clrMap bg1="lt1" tx1="dk1" bg2="lt2" tx2="dk2" accent1="accent1" accent2="accent2" accent3="accent3" accent4="accent4" accent5="accent5" accent6="accent6" hlink="hlink" folHlink="folHlink"/>
   <p:sldLayoutIdLst>
-    <p:sldLayoutId xmlns:r="http://schemas.openxmlformats.org/officeDocument/2006/relationships" id="2147483649" r:id="R988b826a36d14ac5"/>
-    <p:sldLayoutId xmlns:r="http://schemas.openxmlformats.org/officeDocument/2006/relationships" id="2147483650" r:id="R911df8b2aeb047c7"/>
-    <p:sldLayoutId xmlns:r="http://schemas.openxmlformats.org/officeDocument/2006/relationships" id="2147483651" r:id="R69ee2c8a129f4983"/>
-    <p:sldLayoutId xmlns:r="http://schemas.openxmlformats.org/officeDocument/2006/relationships" id="2147483652" r:id="R01c46ec46d8d4845"/>
-    <p:sldLayoutId xmlns:r="http://schemas.openxmlformats.org/officeDocument/2006/relationships" id="2147483653" r:id="R0f3c48cf3e004c6a"/>
-    <p:sldLayoutId xmlns:r="http://schemas.openxmlformats.org/officeDocument/2006/relationships" id="2147483654" r:id="R39437dc9bb0448c4"/>
+    <p:sldLayoutId xmlns:r="http://schemas.openxmlformats.org/officeDocument/2006/relationships" id="2147483649" r:id="R9814ff39a8864072"/>
+    <p:sldLayoutId xmlns:r="http://schemas.openxmlformats.org/officeDocument/2006/relationships" id="2147483650" r:id="R55091ff2d72144aa"/>
+    <p:sldLayoutId xmlns:r="http://schemas.openxmlformats.org/officeDocument/2006/relationships" id="2147483651" r:id="R04c61c24105b44d1"/>
+    <p:sldLayoutId xmlns:r="http://schemas.openxmlformats.org/officeDocument/2006/relationships" id="2147483652" r:id="R9db5b7ae381e4ad5"/>
+    <p:sldLayoutId xmlns:r="http://schemas.openxmlformats.org/officeDocument/2006/relationships" id="2147483653" r:id="R89aa0603cf4a4433"/>
+    <p:sldLayoutId xmlns:r="http://schemas.openxmlformats.org/officeDocument/2006/relationships" id="2147483654" r:id="R94e6f2e34bfe494c"/>
   </p:sldLayoutIdLst>
   <p:txStyles>
     <p:titleStyle>
@@ -2280,7 +2280,7 @@
           <p:cNvPr id="9" name="">
             <a:extLst xmlns:a="http://schemas.openxmlformats.org/drawingml/2006/main">
               <a:ext uri="{FF2B5EF4-FFF2-40B4-BE49-F238E27FC236}">
-                <a16:creationId xmlns:a16="http://schemas.microsoft.com/office/drawing/2014/main" id="{B5638046-A4F6-48B3-8713-4D2DC4C1E533}"/>
+                <a16:creationId xmlns:a16="http://schemas.microsoft.com/office/drawing/2014/main" id="{11E91AA9-8DED-4B3A-A35E-04F4AE2D0A4D}"/>
               </a:ext>
             </a:extLst>
           </p:cNvPr>
@@ -2348,7 +2348,7 @@
           <p:cNvPr id="2" name="">
             <a:extLst xmlns:a="http://schemas.openxmlformats.org/drawingml/2006/main">
               <a:ext uri="{FF2B5EF4-FFF2-40B4-BE49-F238E27FC236}">
-                <a16:creationId xmlns:a16="http://schemas.microsoft.com/office/drawing/2014/main" id="{E6B150A4-5CEA-4BEC-96EC-1E0163391DF4}"/>
+                <a16:creationId xmlns:a16="http://schemas.microsoft.com/office/drawing/2014/main" id="{38BF6656-E6DD-4AE2-8DEF-CB535D4FC22A}"/>
               </a:ext>
             </a:extLst>
           </p:cNvPr>
@@ -2416,7 +2416,7 @@
           <p:cNvPr id="3" name="">
             <a:extLst xmlns:a="http://schemas.openxmlformats.org/drawingml/2006/main">
               <a:ext uri="{FF2B5EF4-FFF2-40B4-BE49-F238E27FC236}">
-                <a16:creationId xmlns:a16="http://schemas.microsoft.com/office/drawing/2014/main" id="{DF84C3EE-B2B1-406A-B8D3-82658FEACC6A}"/>
+                <a16:creationId xmlns:a16="http://schemas.microsoft.com/office/drawing/2014/main" id="{695D46DE-821A-4F47-B0D4-8BCB1E8CCEC3}"/>
               </a:ext>
             </a:extLst>
           </p:cNvPr>
@@ -2426,7 +2426,7 @@
           <p:nvPr/>
         </p:nvPicPr>
         <p:blipFill>
-          <a:blip xmlns:r="http://schemas.openxmlformats.org/officeDocument/2006/relationships" xmlns:a="http://schemas.openxmlformats.org/drawingml/2006/main" r:embed="R742b510e16f94417"/>
+          <a:blip xmlns:r="http://schemas.openxmlformats.org/officeDocument/2006/relationships" xmlns:a="http://schemas.openxmlformats.org/drawingml/2006/main" r:embed="Ra3c845112bde465b"/>
           <a:stretch xmlns:a="http://schemas.openxmlformats.org/drawingml/2006/main"/>
         </p:blipFill>
         <p:spPr>
@@ -2444,7 +2444,7 @@
           <p:cNvPr id="4" name="">
             <a:extLst xmlns:a="http://schemas.openxmlformats.org/drawingml/2006/main">
               <a:ext uri="{FF2B5EF4-FFF2-40B4-BE49-F238E27FC236}">
-                <a16:creationId xmlns:a16="http://schemas.microsoft.com/office/drawing/2014/main" id="{2E616C75-08DF-42FD-888F-88FEE1AB7B79}"/>
+                <a16:creationId xmlns:a16="http://schemas.microsoft.com/office/drawing/2014/main" id="{6B3ECCF7-C118-4E97-BFC2-60DF5002AAE4}"/>
               </a:ext>
             </a:extLst>
           </p:cNvPr>
@@ -2512,7 +2512,7 @@
           <p:cNvPr id="5" name="">
             <a:extLst xmlns:a="http://schemas.openxmlformats.org/drawingml/2006/main">
               <a:ext uri="{FF2B5EF4-FFF2-40B4-BE49-F238E27FC236}">
-                <a16:creationId xmlns:a16="http://schemas.microsoft.com/office/drawing/2014/main" id="{F04C2224-8926-4962-9C6E-787119A68EC2}"/>
+                <a16:creationId xmlns:a16="http://schemas.microsoft.com/office/drawing/2014/main" id="{D28E297E-0287-462C-97CF-39D53BC34D1C}"/>
               </a:ext>
             </a:extLst>
           </p:cNvPr>
@@ -2608,7 +2608,7 @@
           <p:cNvPr id="6" name="">
             <a:extLst xmlns:a="http://schemas.openxmlformats.org/drawingml/2006/main">
               <a:ext uri="{FF2B5EF4-FFF2-40B4-BE49-F238E27FC236}">
-                <a16:creationId xmlns:a16="http://schemas.microsoft.com/office/drawing/2014/main" id="{7D9AB602-DC2C-405F-9ECC-B1941F718278}"/>
+                <a16:creationId xmlns:a16="http://schemas.microsoft.com/office/drawing/2014/main" id="{2E1056B7-1184-4739-A10F-D8BCB7FEDDEC}"/>
               </a:ext>
             </a:extLst>
           </p:cNvPr>
@@ -2676,7 +2676,7 @@
           <p:cNvPr id="7" name="">
             <a:extLst xmlns:a="http://schemas.openxmlformats.org/drawingml/2006/main">
               <a:ext uri="{FF2B5EF4-FFF2-40B4-BE49-F238E27FC236}">
-                <a16:creationId xmlns:a16="http://schemas.microsoft.com/office/drawing/2014/main" id="{E1B613FA-3BE0-42E0-8555-E8C76CBB7D75}"/>
+                <a16:creationId xmlns:a16="http://schemas.microsoft.com/office/drawing/2014/main" id="{02AB4300-8538-4C56-B650-05AFCB76A304}"/>
               </a:ext>
             </a:extLst>
           </p:cNvPr>
@@ -2800,7 +2800,7 @@
           <p:cNvPr id="8" name="">
             <a:extLst xmlns:a="http://schemas.openxmlformats.org/drawingml/2006/main">
               <a:ext uri="{FF2B5EF4-FFF2-40B4-BE49-F238E27FC236}">
-                <a16:creationId xmlns:a16="http://schemas.microsoft.com/office/drawing/2014/main" id="{D5DABB34-5C9A-4783-AD16-4297E852CFC0}"/>
+                <a16:creationId xmlns:a16="http://schemas.microsoft.com/office/drawing/2014/main" id="{FA06D15A-9380-47C9-850E-93909C38881A}"/>
               </a:ext>
             </a:extLst>
           </p:cNvPr>
@@ -2866,7 +2866,7 @@
     </p:spTree>
     <p:extLst>
       <p:ext uri="{BB962C8B-B14F-4D97-AF65-F5344CB8AC3E}">
-        <p14:creationId xmlns:p14="http://schemas.microsoft.com/office/powerpoint/2010/main" val="337439799"/>
+        <p14:creationId xmlns:p14="http://schemas.microsoft.com/office/powerpoint/2010/main" val="916182287"/>
       </p:ext>
     </p:extLst>
   </p:cSld>
@@ -2897,7 +2897,7 @@
           <p:cNvPr id="15" name="">
             <a:extLst xmlns:a="http://schemas.openxmlformats.org/drawingml/2006/main">
               <a:ext uri="{FF2B5EF4-FFF2-40B4-BE49-F238E27FC236}">
-                <a16:creationId xmlns:a16="http://schemas.microsoft.com/office/drawing/2014/main" id="{91BECA9E-4F12-4258-984F-F4C8060669AA}"/>
+                <a16:creationId xmlns:a16="http://schemas.microsoft.com/office/drawing/2014/main" id="{2BE0E49B-ADA9-466E-9362-A402105A2EFB}"/>
               </a:ext>
             </a:extLst>
           </p:cNvPr>
@@ -2965,7 +2965,7 @@
           <p:cNvPr id="2" name="">
             <a:extLst xmlns:a="http://schemas.openxmlformats.org/drawingml/2006/main">
               <a:ext uri="{FF2B5EF4-FFF2-40B4-BE49-F238E27FC236}">
-                <a16:creationId xmlns:a16="http://schemas.microsoft.com/office/drawing/2014/main" id="{970F33CD-19C1-4E93-BB0E-8429B4E165C7}"/>
+                <a16:creationId xmlns:a16="http://schemas.microsoft.com/office/drawing/2014/main" id="{2B8C14A3-6396-4F20-8828-50D0337C428C}"/>
               </a:ext>
             </a:extLst>
           </p:cNvPr>
@@ -3033,7 +3033,7 @@
           <p:cNvPr id="3" name="">
             <a:extLst xmlns:a="http://schemas.openxmlformats.org/drawingml/2006/main">
               <a:ext uri="{FF2B5EF4-FFF2-40B4-BE49-F238E27FC236}">
-                <a16:creationId xmlns:a16="http://schemas.microsoft.com/office/drawing/2014/main" id="{70662C05-E509-44EB-921C-B8BF4C3EDB26}"/>
+                <a16:creationId xmlns:a16="http://schemas.microsoft.com/office/drawing/2014/main" id="{D2BCBA24-787D-4A22-96FA-BC2D6AD0F818}"/>
               </a:ext>
             </a:extLst>
           </p:cNvPr>
@@ -3101,7 +3101,7 @@
           <p:cNvPr id="4" name="">
             <a:extLst xmlns:a="http://schemas.openxmlformats.org/drawingml/2006/main">
               <a:ext uri="{FF2B5EF4-FFF2-40B4-BE49-F238E27FC236}">
-                <a16:creationId xmlns:a16="http://schemas.microsoft.com/office/drawing/2014/main" id="{D71D037E-CB67-4E11-9C20-2FDCFF6015FC}"/>
+                <a16:creationId xmlns:a16="http://schemas.microsoft.com/office/drawing/2014/main" id="{B6DBFAA3-AE43-4E9E-9BE6-30E48E7EE29E}"/>
               </a:ext>
             </a:extLst>
           </p:cNvPr>
@@ -3169,7 +3169,7 @@
           <p:cNvPr id="5" name="">
             <a:extLst xmlns:a="http://schemas.openxmlformats.org/drawingml/2006/main">
               <a:ext uri="{FF2B5EF4-FFF2-40B4-BE49-F238E27FC236}">
-                <a16:creationId xmlns:a16="http://schemas.microsoft.com/office/drawing/2014/main" id="{03F251A9-1BCE-43B0-BD0F-E1C055FC3D3F}"/>
+                <a16:creationId xmlns:a16="http://schemas.microsoft.com/office/drawing/2014/main" id="{B394F263-309D-4064-B330-B7FEC52CE335}"/>
               </a:ext>
             </a:extLst>
           </p:cNvPr>
@@ -3237,7 +3237,7 @@
           <p:cNvPr id="6" name="">
             <a:extLst xmlns:a="http://schemas.openxmlformats.org/drawingml/2006/main">
               <a:ext uri="{FF2B5EF4-FFF2-40B4-BE49-F238E27FC236}">
-                <a16:creationId xmlns:a16="http://schemas.microsoft.com/office/drawing/2014/main" id="{523D9A20-232F-492C-9853-BBCEC1DC2AD4}"/>
+                <a16:creationId xmlns:a16="http://schemas.microsoft.com/office/drawing/2014/main" id="{07FE06EC-F8AB-4BB7-A438-EC6F9522469F}"/>
               </a:ext>
             </a:extLst>
           </p:cNvPr>
@@ -3305,7 +3305,7 @@
           <p:cNvPr id="7" name="">
             <a:extLst xmlns:a="http://schemas.openxmlformats.org/drawingml/2006/main">
               <a:ext uri="{FF2B5EF4-FFF2-40B4-BE49-F238E27FC236}">
-                <a16:creationId xmlns:a16="http://schemas.microsoft.com/office/drawing/2014/main" id="{2F516993-E14E-45BB-8D7C-473DA3E8A46A}"/>
+                <a16:creationId xmlns:a16="http://schemas.microsoft.com/office/drawing/2014/main" id="{C730B3E4-8D5F-4F9E-ADA1-0B21CDF502FB}"/>
               </a:ext>
             </a:extLst>
           </p:cNvPr>
@@ -3373,7 +3373,7 @@
           <p:cNvPr id="8" name="">
             <a:extLst xmlns:a="http://schemas.openxmlformats.org/drawingml/2006/main">
               <a:ext uri="{FF2B5EF4-FFF2-40B4-BE49-F238E27FC236}">
-                <a16:creationId xmlns:a16="http://schemas.microsoft.com/office/drawing/2014/main" id="{3E5B3A96-F171-49FD-A536-05D14BCF7473}"/>
+                <a16:creationId xmlns:a16="http://schemas.microsoft.com/office/drawing/2014/main" id="{F7DACCEF-AEAF-4FDA-AA7F-04D8E0C80550}"/>
               </a:ext>
             </a:extLst>
           </p:cNvPr>
@@ -3441,7 +3441,7 @@
           <p:cNvPr id="9" name="">
             <a:extLst xmlns:a="http://schemas.openxmlformats.org/drawingml/2006/main">
               <a:ext uri="{FF2B5EF4-FFF2-40B4-BE49-F238E27FC236}">
-                <a16:creationId xmlns:a16="http://schemas.microsoft.com/office/drawing/2014/main" id="{BF4E63BF-73E0-40A5-869A-F2E8AEA5DB4B}"/>
+                <a16:creationId xmlns:a16="http://schemas.microsoft.com/office/drawing/2014/main" id="{964FA6B0-BE3F-40DC-9300-0565CC1AC6D4}"/>
               </a:ext>
             </a:extLst>
           </p:cNvPr>
@@ -3509,7 +3509,7 @@
           <p:cNvPr id="10" name="">
             <a:extLst xmlns:a="http://schemas.openxmlformats.org/drawingml/2006/main">
               <a:ext uri="{FF2B5EF4-FFF2-40B4-BE49-F238E27FC236}">
-                <a16:creationId xmlns:a16="http://schemas.microsoft.com/office/drawing/2014/main" id="{2B8EC94C-3D45-4282-B568-4090CFE2448E}"/>
+                <a16:creationId xmlns:a16="http://schemas.microsoft.com/office/drawing/2014/main" id="{9DB9D2D1-26E1-46C4-B441-9D72AD18CC9E}"/>
               </a:ext>
             </a:extLst>
           </p:cNvPr>
@@ -3577,7 +3577,7 @@
           <p:cNvPr id="11" name="">
             <a:extLst xmlns:a="http://schemas.openxmlformats.org/drawingml/2006/main">
               <a:ext uri="{FF2B5EF4-FFF2-40B4-BE49-F238E27FC236}">
-                <a16:creationId xmlns:a16="http://schemas.microsoft.com/office/drawing/2014/main" id="{26764580-2665-4CCF-9282-811909A35BFA}"/>
+                <a16:creationId xmlns:a16="http://schemas.microsoft.com/office/drawing/2014/main" id="{F1B2E9FF-58D3-4138-8179-9A7AA295DED7}"/>
               </a:ext>
             </a:extLst>
           </p:cNvPr>
@@ -3645,7 +3645,7 @@
           <p:cNvPr id="12" name="">
             <a:extLst xmlns:a="http://schemas.openxmlformats.org/drawingml/2006/main">
               <a:ext uri="{FF2B5EF4-FFF2-40B4-BE49-F238E27FC236}">
-                <a16:creationId xmlns:a16="http://schemas.microsoft.com/office/drawing/2014/main" id="{45FDF268-83F0-47B2-8846-8A08C167BCFC}"/>
+                <a16:creationId xmlns:a16="http://schemas.microsoft.com/office/drawing/2014/main" id="{0F3B52A3-226B-46F6-8045-FA36D9BA5AF3}"/>
               </a:ext>
             </a:extLst>
           </p:cNvPr>
@@ -3713,7 +3713,7 @@
           <p:cNvPr id="13" name="">
             <a:extLst xmlns:a="http://schemas.openxmlformats.org/drawingml/2006/main">
               <a:ext uri="{FF2B5EF4-FFF2-40B4-BE49-F238E27FC236}">
-                <a16:creationId xmlns:a16="http://schemas.microsoft.com/office/drawing/2014/main" id="{5F26DBC6-E545-426D-AEAA-A747C2E88947}"/>
+                <a16:creationId xmlns:a16="http://schemas.microsoft.com/office/drawing/2014/main" id="{8F423A72-8427-4672-9125-597E0CF3262A}"/>
               </a:ext>
             </a:extLst>
           </p:cNvPr>
@@ -3781,7 +3781,7 @@
           <p:cNvPr id="14" name="">
             <a:extLst xmlns:a="http://schemas.openxmlformats.org/drawingml/2006/main">
               <a:ext uri="{FF2B5EF4-FFF2-40B4-BE49-F238E27FC236}">
-                <a16:creationId xmlns:a16="http://schemas.microsoft.com/office/drawing/2014/main" id="{EC2F517E-79B9-499A-B2C8-18E7F3FD2777}"/>
+                <a16:creationId xmlns:a16="http://schemas.microsoft.com/office/drawing/2014/main" id="{DC1C7BCD-89FE-434D-97ED-05ECFE9163C0}"/>
               </a:ext>
             </a:extLst>
           </p:cNvPr>
@@ -3847,7 +3847,7 @@
     </p:spTree>
     <p:extLst>
       <p:ext uri="{BB962C8B-B14F-4D97-AF65-F5344CB8AC3E}">
-        <p14:creationId xmlns:p14="http://schemas.microsoft.com/office/powerpoint/2010/main" val="506952383"/>
+        <p14:creationId xmlns:p14="http://schemas.microsoft.com/office/powerpoint/2010/main" val="1438687122"/>
       </p:ext>
     </p:extLst>
   </p:cSld>
@@ -3878,7 +3878,7 @@
           <p:cNvPr id="9" name="">
             <a:extLst xmlns:a="http://schemas.openxmlformats.org/drawingml/2006/main">
               <a:ext uri="{FF2B5EF4-FFF2-40B4-BE49-F238E27FC236}">
-                <a16:creationId xmlns:a16="http://schemas.microsoft.com/office/drawing/2014/main" id="{8127A033-B23F-406C-B060-EA8297CC23F1}"/>
+                <a16:creationId xmlns:a16="http://schemas.microsoft.com/office/drawing/2014/main" id="{103C2DB9-1476-4D98-BA03-845B62CD9D0C}"/>
               </a:ext>
             </a:extLst>
           </p:cNvPr>
@@ -3946,7 +3946,7 @@
           <p:cNvPr id="2" name="">
             <a:extLst xmlns:a="http://schemas.openxmlformats.org/drawingml/2006/main">
               <a:ext uri="{FF2B5EF4-FFF2-40B4-BE49-F238E27FC236}">
-                <a16:creationId xmlns:a16="http://schemas.microsoft.com/office/drawing/2014/main" id="{779898CF-9CDF-4579-88FF-A66E1E6CF2C7}"/>
+                <a16:creationId xmlns:a16="http://schemas.microsoft.com/office/drawing/2014/main" id="{CAAFDDFE-B0FC-4077-84B6-3FD2350E089C}"/>
               </a:ext>
             </a:extLst>
           </p:cNvPr>
@@ -4014,7 +4014,7 @@
           <p:cNvPr id="3" name="">
             <a:extLst xmlns:a="http://schemas.openxmlformats.org/drawingml/2006/main">
               <a:ext uri="{FF2B5EF4-FFF2-40B4-BE49-F238E27FC236}">
-                <a16:creationId xmlns:a16="http://schemas.microsoft.com/office/drawing/2014/main" id="{5068C3AE-EA5C-4357-AE94-65A5DCD3DD12}"/>
+                <a16:creationId xmlns:a16="http://schemas.microsoft.com/office/drawing/2014/main" id="{2FD045EF-F368-4CB3-BE57-27ADFCA3F72D}"/>
               </a:ext>
             </a:extLst>
           </p:cNvPr>
@@ -4082,7 +4082,7 @@
           <p:cNvPr id="4" name="">
             <a:extLst xmlns:a="http://schemas.openxmlformats.org/drawingml/2006/main">
               <a:ext uri="{FF2B5EF4-FFF2-40B4-BE49-F238E27FC236}">
-                <a16:creationId xmlns:a16="http://schemas.microsoft.com/office/drawing/2014/main" id="{1A01239D-7EE8-47DE-A39F-ED208DCD0D70}"/>
+                <a16:creationId xmlns:a16="http://schemas.microsoft.com/office/drawing/2014/main" id="{B6825481-E05F-4A99-8987-7BE4EF7A857A}"/>
               </a:ext>
             </a:extLst>
           </p:cNvPr>
@@ -4178,7 +4178,7 @@
           <p:cNvPr id="5" name="">
             <a:extLst xmlns:a="http://schemas.openxmlformats.org/drawingml/2006/main">
               <a:ext uri="{FF2B5EF4-FFF2-40B4-BE49-F238E27FC236}">
-                <a16:creationId xmlns:a16="http://schemas.microsoft.com/office/drawing/2014/main" id="{08C930B4-D571-41C9-B1A6-341EBB797DF7}"/>
+                <a16:creationId xmlns:a16="http://schemas.microsoft.com/office/drawing/2014/main" id="{1AC9E94B-90D6-4974-8B76-DC601DE31177}"/>
               </a:ext>
             </a:extLst>
           </p:cNvPr>
@@ -4292,7 +4292,7 @@
           <p:cNvPr id="6" name="">
             <a:extLst xmlns:a="http://schemas.openxmlformats.org/drawingml/2006/main">
               <a:ext uri="{FF2B5EF4-FFF2-40B4-BE49-F238E27FC236}">
-                <a16:creationId xmlns:a16="http://schemas.microsoft.com/office/drawing/2014/main" id="{FDB24098-E50C-4D1B-8A33-4328D8AEBBBD}"/>
+                <a16:creationId xmlns:a16="http://schemas.microsoft.com/office/drawing/2014/main" id="{C56A9422-FB9B-4147-B7E0-9C82DD5CB63E}"/>
               </a:ext>
             </a:extLst>
           </p:cNvPr>
@@ -4360,7 +4360,7 @@
           <p:cNvPr id="7" name="">
             <a:extLst xmlns:a="http://schemas.openxmlformats.org/drawingml/2006/main">
               <a:ext uri="{FF2B5EF4-FFF2-40B4-BE49-F238E27FC236}">
-                <a16:creationId xmlns:a16="http://schemas.microsoft.com/office/drawing/2014/main" id="{F4B7BDDB-0102-44DC-9E8B-418210E52FB1}"/>
+                <a16:creationId xmlns:a16="http://schemas.microsoft.com/office/drawing/2014/main" id="{7F318361-9226-4FC2-8B05-444B5DEF6F8F}"/>
               </a:ext>
             </a:extLst>
           </p:cNvPr>
@@ -4428,7 +4428,7 @@
           <p:cNvPr id="8" name="">
             <a:extLst xmlns:a="http://schemas.openxmlformats.org/drawingml/2006/main">
               <a:ext uri="{FF2B5EF4-FFF2-40B4-BE49-F238E27FC236}">
-                <a16:creationId xmlns:a16="http://schemas.microsoft.com/office/drawing/2014/main" id="{F28E968A-3E8D-4177-83C5-173F8C4D48AE}"/>
+                <a16:creationId xmlns:a16="http://schemas.microsoft.com/office/drawing/2014/main" id="{11342302-CCCF-4BD3-98BA-CD2F757F0560}"/>
               </a:ext>
             </a:extLst>
           </p:cNvPr>
@@ -4494,7 +4494,7 @@
     </p:spTree>
     <p:extLst>
       <p:ext uri="{BB962C8B-B14F-4D97-AF65-F5344CB8AC3E}">
-        <p14:creationId xmlns:p14="http://schemas.microsoft.com/office/powerpoint/2010/main" val="2108096583"/>
+        <p14:creationId xmlns:p14="http://schemas.microsoft.com/office/powerpoint/2010/main" val="1691976152"/>
       </p:ext>
     </p:extLst>
   </p:cSld>
@@ -4525,7 +4525,7 @@
           <p:cNvPr id="12" name="">
             <a:extLst xmlns:a="http://schemas.openxmlformats.org/drawingml/2006/main">
               <a:ext uri="{FF2B5EF4-FFF2-40B4-BE49-F238E27FC236}">
-                <a16:creationId xmlns:a16="http://schemas.microsoft.com/office/drawing/2014/main" id="{39531F75-A950-4299-BEA7-BDCD4B352786}"/>
+                <a16:creationId xmlns:a16="http://schemas.microsoft.com/office/drawing/2014/main" id="{5F3DCDE6-47A2-4B3A-AA36-6EADF69FDA80}"/>
               </a:ext>
             </a:extLst>
           </p:cNvPr>
@@ -4593,7 +4593,7 @@
           <p:cNvPr id="2" name="">
             <a:extLst xmlns:a="http://schemas.openxmlformats.org/drawingml/2006/main">
               <a:ext uri="{FF2B5EF4-FFF2-40B4-BE49-F238E27FC236}">
-                <a16:creationId xmlns:a16="http://schemas.microsoft.com/office/drawing/2014/main" id="{EA66C464-6089-4974-A353-334FB0296DD5}"/>
+                <a16:creationId xmlns:a16="http://schemas.microsoft.com/office/drawing/2014/main" id="{F6E9D861-6E08-4820-8C82-2979E238F508}"/>
               </a:ext>
             </a:extLst>
           </p:cNvPr>
@@ -4661,7 +4661,7 @@
           <p:cNvPr id="3" name="">
             <a:extLst xmlns:a="http://schemas.openxmlformats.org/drawingml/2006/main">
               <a:ext uri="{FF2B5EF4-FFF2-40B4-BE49-F238E27FC236}">
-                <a16:creationId xmlns:a16="http://schemas.microsoft.com/office/drawing/2014/main" id="{1FE7D9C1-18A5-4DC1-949E-3B11D2E8FCA1}"/>
+                <a16:creationId xmlns:a16="http://schemas.microsoft.com/office/drawing/2014/main" id="{01F1BFCA-F918-4C96-BACC-F9CBFBBE8CDB}"/>
               </a:ext>
             </a:extLst>
           </p:cNvPr>
@@ -4729,7 +4729,7 @@
           <p:cNvPr id="4" name="">
             <a:extLst xmlns:a="http://schemas.openxmlformats.org/drawingml/2006/main">
               <a:ext uri="{FF2B5EF4-FFF2-40B4-BE49-F238E27FC236}">
-                <a16:creationId xmlns:a16="http://schemas.microsoft.com/office/drawing/2014/main" id="{35487B5A-5A35-45D5-9B56-ADE79BD12D83}"/>
+                <a16:creationId xmlns:a16="http://schemas.microsoft.com/office/drawing/2014/main" id="{F00C055B-FBE9-41D6-924C-1AAF016E5EFE}"/>
               </a:ext>
             </a:extLst>
           </p:cNvPr>
@@ -4853,7 +4853,7 @@
           <p:cNvPr id="5" name="">
             <a:extLst xmlns:a="http://schemas.openxmlformats.org/drawingml/2006/main">
               <a:ext uri="{FF2B5EF4-FFF2-40B4-BE49-F238E27FC236}">
-                <a16:creationId xmlns:a16="http://schemas.microsoft.com/office/drawing/2014/main" id="{73980EF3-E21D-4316-9ABB-A6848110C197}"/>
+                <a16:creationId xmlns:a16="http://schemas.microsoft.com/office/drawing/2014/main" id="{D197D049-821A-4D5E-9258-F70354725495}"/>
               </a:ext>
             </a:extLst>
           </p:cNvPr>
@@ -4921,7 +4921,7 @@
           <p:cNvPr id="6" name="">
             <a:extLst xmlns:a="http://schemas.openxmlformats.org/drawingml/2006/main">
               <a:ext uri="{FF2B5EF4-FFF2-40B4-BE49-F238E27FC236}">
-                <a16:creationId xmlns:a16="http://schemas.microsoft.com/office/drawing/2014/main" id="{5AD38D46-9D1B-4D1E-A2D8-C40FD15F8D4B}"/>
+                <a16:creationId xmlns:a16="http://schemas.microsoft.com/office/drawing/2014/main" id="{108038C8-8820-4897-8B2F-33C7AF90DF81}"/>
               </a:ext>
             </a:extLst>
           </p:cNvPr>
@@ -4989,7 +4989,7 @@
           <p:cNvPr id="7" name="">
             <a:extLst xmlns:a="http://schemas.openxmlformats.org/drawingml/2006/main">
               <a:ext uri="{FF2B5EF4-FFF2-40B4-BE49-F238E27FC236}">
-                <a16:creationId xmlns:a16="http://schemas.microsoft.com/office/drawing/2014/main" id="{512A09EB-3204-4BC3-9A53-85FA96EF2EBC}"/>
+                <a16:creationId xmlns:a16="http://schemas.microsoft.com/office/drawing/2014/main" id="{535C7807-5B2D-4E88-A9B4-3C7C409B003D}"/>
               </a:ext>
             </a:extLst>
           </p:cNvPr>
@@ -5057,7 +5057,7 @@
           <p:cNvPr id="8" name="">
             <a:extLst xmlns:a="http://schemas.openxmlformats.org/drawingml/2006/main">
               <a:ext uri="{FF2B5EF4-FFF2-40B4-BE49-F238E27FC236}">
-                <a16:creationId xmlns:a16="http://schemas.microsoft.com/office/drawing/2014/main" id="{81ABFC11-ED4C-4F24-B353-C5234EF150B7}"/>
+                <a16:creationId xmlns:a16="http://schemas.microsoft.com/office/drawing/2014/main" id="{4A16976B-BDAA-494C-A318-691C8D288BF7}"/>
               </a:ext>
             </a:extLst>
           </p:cNvPr>
@@ -5125,7 +5125,7 @@
           <p:cNvPr id="9" name="">
             <a:extLst xmlns:a="http://schemas.openxmlformats.org/drawingml/2006/main">
               <a:ext uri="{FF2B5EF4-FFF2-40B4-BE49-F238E27FC236}">
-                <a16:creationId xmlns:a16="http://schemas.microsoft.com/office/drawing/2014/main" id="{30A5141C-1F5D-4FAD-A907-98958FC4A025}"/>
+                <a16:creationId xmlns:a16="http://schemas.microsoft.com/office/drawing/2014/main" id="{70DCF80F-F08E-4780-9EA1-8C0AB8E2CC44}"/>
               </a:ext>
             </a:extLst>
           </p:cNvPr>
@@ -5193,7 +5193,7 @@
           <p:cNvPr id="10" name="">
             <a:extLst xmlns:a="http://schemas.openxmlformats.org/drawingml/2006/main">
               <a:ext uri="{FF2B5EF4-FFF2-40B4-BE49-F238E27FC236}">
-                <a16:creationId xmlns:a16="http://schemas.microsoft.com/office/drawing/2014/main" id="{0616CBC2-DE45-4193-B161-7D73D5C36CA6}"/>
+                <a16:creationId xmlns:a16="http://schemas.microsoft.com/office/drawing/2014/main" id="{A5DA9A7F-0A1C-4C3E-A159-0DAF22C293FC}"/>
               </a:ext>
             </a:extLst>
           </p:cNvPr>
@@ -5261,7 +5261,7 @@
           <p:cNvPr id="11" name="">
             <a:extLst xmlns:a="http://schemas.openxmlformats.org/drawingml/2006/main">
               <a:ext uri="{FF2B5EF4-FFF2-40B4-BE49-F238E27FC236}">
-                <a16:creationId xmlns:a16="http://schemas.microsoft.com/office/drawing/2014/main" id="{9BD9D9FB-D621-4062-93BD-011BBEE1DB18}"/>
+                <a16:creationId xmlns:a16="http://schemas.microsoft.com/office/drawing/2014/main" id="{D6FDE86B-7B53-4641-ACF2-B8D61FD93043}"/>
               </a:ext>
             </a:extLst>
           </p:cNvPr>
@@ -5327,7 +5327,7 @@
     </p:spTree>
     <p:extLst>
       <p:ext uri="{BB962C8B-B14F-4D97-AF65-F5344CB8AC3E}">
-        <p14:creationId xmlns:p14="http://schemas.microsoft.com/office/powerpoint/2010/main" val="1952412206"/>
+        <p14:creationId xmlns:p14="http://schemas.microsoft.com/office/powerpoint/2010/main" val="936520205"/>
       </p:ext>
     </p:extLst>
   </p:cSld>
@@ -5358,7 +5358,7 @@
           <p:cNvPr id="8" name="">
             <a:extLst xmlns:a="http://schemas.openxmlformats.org/drawingml/2006/main">
               <a:ext uri="{FF2B5EF4-FFF2-40B4-BE49-F238E27FC236}">
-                <a16:creationId xmlns:a16="http://schemas.microsoft.com/office/drawing/2014/main" id="{500A5D3C-787D-4861-9E1F-8867FB98470F}"/>
+                <a16:creationId xmlns:a16="http://schemas.microsoft.com/office/drawing/2014/main" id="{9595D7C0-F91E-4F86-BA76-FD09CADE4DD4}"/>
               </a:ext>
             </a:extLst>
           </p:cNvPr>
@@ -5426,7 +5426,7 @@
           <p:cNvPr id="2" name="">
             <a:extLst xmlns:a="http://schemas.openxmlformats.org/drawingml/2006/main">
               <a:ext uri="{FF2B5EF4-FFF2-40B4-BE49-F238E27FC236}">
-                <a16:creationId xmlns:a16="http://schemas.microsoft.com/office/drawing/2014/main" id="{7F1293DE-EF24-4496-BA2F-7FD1CBCB091B}"/>
+                <a16:creationId xmlns:a16="http://schemas.microsoft.com/office/drawing/2014/main" id="{A0202CCA-E782-4FAC-A299-E2DCA8EB894D}"/>
               </a:ext>
             </a:extLst>
           </p:cNvPr>
@@ -5494,7 +5494,7 @@
           <p:cNvPr id="3" name="">
             <a:extLst xmlns:a="http://schemas.openxmlformats.org/drawingml/2006/main">
               <a:ext uri="{FF2B5EF4-FFF2-40B4-BE49-F238E27FC236}">
-                <a16:creationId xmlns:a16="http://schemas.microsoft.com/office/drawing/2014/main" id="{DDAAD593-6AE8-4B57-B943-0079DB4AFF0E}"/>
+                <a16:creationId xmlns:a16="http://schemas.microsoft.com/office/drawing/2014/main" id="{866DBFA9-124E-4E3B-981B-5940A7AAA3D1}"/>
               </a:ext>
             </a:extLst>
           </p:cNvPr>
@@ -5562,7 +5562,7 @@
           <p:cNvPr id="4" name="">
             <a:extLst xmlns:a="http://schemas.openxmlformats.org/drawingml/2006/main">
               <a:ext uri="{FF2B5EF4-FFF2-40B4-BE49-F238E27FC236}">
-                <a16:creationId xmlns:a16="http://schemas.microsoft.com/office/drawing/2014/main" id="{6E179EF5-37FE-40AB-839F-FA70A74586BD}"/>
+                <a16:creationId xmlns:a16="http://schemas.microsoft.com/office/drawing/2014/main" id="{5FA7872D-89A0-4BD6-AF44-DF3D1AB4AE70}"/>
               </a:ext>
             </a:extLst>
           </p:cNvPr>
@@ -5686,7 +5686,7 @@
           <p:cNvPr id="5" name="">
             <a:extLst xmlns:a="http://schemas.openxmlformats.org/drawingml/2006/main">
               <a:ext uri="{FF2B5EF4-FFF2-40B4-BE49-F238E27FC236}">
-                <a16:creationId xmlns:a16="http://schemas.microsoft.com/office/drawing/2014/main" id="{4BA7A842-D709-454E-BC99-8410C65B0839}"/>
+                <a16:creationId xmlns:a16="http://schemas.microsoft.com/office/drawing/2014/main" id="{85240716-8BE0-4C20-AF85-034457EF82B9}"/>
               </a:ext>
             </a:extLst>
           </p:cNvPr>
@@ -5754,7 +5754,7 @@
           <p:cNvPr id="6" name="">
             <a:extLst xmlns:a="http://schemas.openxmlformats.org/drawingml/2006/main">
               <a:ext uri="{FF2B5EF4-FFF2-40B4-BE49-F238E27FC236}">
-                <a16:creationId xmlns:a16="http://schemas.microsoft.com/office/drawing/2014/main" id="{4807904A-62D3-4F9B-9FFF-F19A087BB1B9}"/>
+                <a16:creationId xmlns:a16="http://schemas.microsoft.com/office/drawing/2014/main" id="{0056A028-8781-487E-8D22-8483382792CA}"/>
               </a:ext>
             </a:extLst>
           </p:cNvPr>
@@ -5822,7 +5822,7 @@
           <p:cNvPr id="7" name="">
             <a:extLst xmlns:a="http://schemas.openxmlformats.org/drawingml/2006/main">
               <a:ext uri="{FF2B5EF4-FFF2-40B4-BE49-F238E27FC236}">
-                <a16:creationId xmlns:a16="http://schemas.microsoft.com/office/drawing/2014/main" id="{06A4ECCE-A31B-426C-9C7A-0ED1A9DFE291}"/>
+                <a16:creationId xmlns:a16="http://schemas.microsoft.com/office/drawing/2014/main" id="{50E14199-702B-486D-B1AE-7C6FAA839C63}"/>
               </a:ext>
             </a:extLst>
           </p:cNvPr>
@@ -5888,7 +5888,7 @@
     </p:spTree>
     <p:extLst>
       <p:ext uri="{BB962C8B-B14F-4D97-AF65-F5344CB8AC3E}">
-        <p14:creationId xmlns:p14="http://schemas.microsoft.com/office/powerpoint/2010/main" val="1846074831"/>
+        <p14:creationId xmlns:p14="http://schemas.microsoft.com/office/powerpoint/2010/main" val="1576188701"/>
       </p:ext>
     </p:extLst>
   </p:cSld>
@@ -5919,7 +5919,7 @@
           <p:cNvPr id="11" name="">
             <a:extLst xmlns:a="http://schemas.openxmlformats.org/drawingml/2006/main">
               <a:ext uri="{FF2B5EF4-FFF2-40B4-BE49-F238E27FC236}">
-                <a16:creationId xmlns:a16="http://schemas.microsoft.com/office/drawing/2014/main" id="{87C2D18F-9F3D-438B-8294-3FF7F3CC6EEF}"/>
+                <a16:creationId xmlns:a16="http://schemas.microsoft.com/office/drawing/2014/main" id="{21C59AEC-27A3-4116-92C7-3AE7E26176C8}"/>
               </a:ext>
             </a:extLst>
           </p:cNvPr>
@@ -5987,7 +5987,7 @@
           <p:cNvPr id="2" name="">
             <a:extLst xmlns:a="http://schemas.openxmlformats.org/drawingml/2006/main">
               <a:ext uri="{FF2B5EF4-FFF2-40B4-BE49-F238E27FC236}">
-                <a16:creationId xmlns:a16="http://schemas.microsoft.com/office/drawing/2014/main" id="{3FEB353D-C4A6-429C-8067-65F6C71B0E76}"/>
+                <a16:creationId xmlns:a16="http://schemas.microsoft.com/office/drawing/2014/main" id="{6915AB24-BC8C-4FF1-BB49-DB07F39F2FEB}"/>
               </a:ext>
             </a:extLst>
           </p:cNvPr>
@@ -6055,7 +6055,7 @@
           <p:cNvPr id="3" name="">
             <a:extLst xmlns:a="http://schemas.openxmlformats.org/drawingml/2006/main">
               <a:ext uri="{FF2B5EF4-FFF2-40B4-BE49-F238E27FC236}">
-                <a16:creationId xmlns:a16="http://schemas.microsoft.com/office/drawing/2014/main" id="{9BCD2C4F-9C4B-4216-B1A5-18B307637C4D}"/>
+                <a16:creationId xmlns:a16="http://schemas.microsoft.com/office/drawing/2014/main" id="{EFA9F9FC-6B61-4BFC-80E0-4D7FC813E3B1}"/>
               </a:ext>
             </a:extLst>
           </p:cNvPr>
@@ -6123,7 +6123,7 @@
           <p:cNvPr id="4" name="">
             <a:extLst xmlns:a="http://schemas.openxmlformats.org/drawingml/2006/main">
               <a:ext uri="{FF2B5EF4-FFF2-40B4-BE49-F238E27FC236}">
-                <a16:creationId xmlns:a16="http://schemas.microsoft.com/office/drawing/2014/main" id="{76FDB32A-F3F0-4202-971E-B5C21A97510B}"/>
+                <a16:creationId xmlns:a16="http://schemas.microsoft.com/office/drawing/2014/main" id="{794355EA-C209-4F81-A6F1-AB710E649EF5}"/>
               </a:ext>
             </a:extLst>
           </p:cNvPr>
@@ -6247,7 +6247,7 @@
           <p:cNvPr id="5" name="">
             <a:extLst xmlns:a="http://schemas.openxmlformats.org/drawingml/2006/main">
               <a:ext uri="{FF2B5EF4-FFF2-40B4-BE49-F238E27FC236}">
-                <a16:creationId xmlns:a16="http://schemas.microsoft.com/office/drawing/2014/main" id="{3E126D8B-5D37-4C5E-9C2E-8AA5966F3496}"/>
+                <a16:creationId xmlns:a16="http://schemas.microsoft.com/office/drawing/2014/main" id="{E9BA2D2A-7ACD-4383-A8A7-A3065FDFAC2E}"/>
               </a:ext>
             </a:extLst>
           </p:cNvPr>
@@ -6315,7 +6315,7 @@
           <p:cNvPr id="6" name="">
             <a:extLst xmlns:a="http://schemas.openxmlformats.org/drawingml/2006/main">
               <a:ext uri="{FF2B5EF4-FFF2-40B4-BE49-F238E27FC236}">
-                <a16:creationId xmlns:a16="http://schemas.microsoft.com/office/drawing/2014/main" id="{C6E40EAD-836C-4AA2-930A-B03AE2FC38CA}"/>
+                <a16:creationId xmlns:a16="http://schemas.microsoft.com/office/drawing/2014/main" id="{E2DBCE4C-8F30-4E31-8545-3086BF94FCBE}"/>
               </a:ext>
             </a:extLst>
           </p:cNvPr>
@@ -6383,7 +6383,7 @@
           <p:cNvPr id="7" name="">
             <a:extLst xmlns:a="http://schemas.openxmlformats.org/drawingml/2006/main">
               <a:ext uri="{FF2B5EF4-FFF2-40B4-BE49-F238E27FC236}">
-                <a16:creationId xmlns:a16="http://schemas.microsoft.com/office/drawing/2014/main" id="{61A663C5-05E6-4D00-8667-C9E34149BDF4}"/>
+                <a16:creationId xmlns:a16="http://schemas.microsoft.com/office/drawing/2014/main" id="{E1E53BBE-9A66-4427-A724-44683424AE0E}"/>
               </a:ext>
             </a:extLst>
           </p:cNvPr>
@@ -6451,7 +6451,7 @@
           <p:cNvPr id="8" name="">
             <a:extLst xmlns:a="http://schemas.openxmlformats.org/drawingml/2006/main">
               <a:ext uri="{FF2B5EF4-FFF2-40B4-BE49-F238E27FC236}">
-                <a16:creationId xmlns:a16="http://schemas.microsoft.com/office/drawing/2014/main" id="{98126D35-D9CA-4DCD-B056-BD8955325FD8}"/>
+                <a16:creationId xmlns:a16="http://schemas.microsoft.com/office/drawing/2014/main" id="{2C14B68F-C5F9-4761-B21C-DB88960B8068}"/>
               </a:ext>
             </a:extLst>
           </p:cNvPr>
@@ -6519,7 +6519,7 @@
           <p:cNvPr id="9" name="">
             <a:extLst xmlns:a="http://schemas.openxmlformats.org/drawingml/2006/main">
               <a:ext uri="{FF2B5EF4-FFF2-40B4-BE49-F238E27FC236}">
-                <a16:creationId xmlns:a16="http://schemas.microsoft.com/office/drawing/2014/main" id="{7A914C8B-741F-42B3-9F0B-D1C05488C79E}"/>
+                <a16:creationId xmlns:a16="http://schemas.microsoft.com/office/drawing/2014/main" id="{7D2CE9D6-6AE2-4FC3-9388-0AF458CD4F67}"/>
               </a:ext>
             </a:extLst>
           </p:cNvPr>
@@ -6587,7 +6587,7 @@
           <p:cNvPr id="10" name="">
             <a:extLst xmlns:a="http://schemas.openxmlformats.org/drawingml/2006/main">
               <a:ext uri="{FF2B5EF4-FFF2-40B4-BE49-F238E27FC236}">
-                <a16:creationId xmlns:a16="http://schemas.microsoft.com/office/drawing/2014/main" id="{1B77FF05-DF1A-4720-B162-180FA7DEFA13}"/>
+                <a16:creationId xmlns:a16="http://schemas.microsoft.com/office/drawing/2014/main" id="{B10013D1-8777-48EE-93C6-B4FC8C1F2A8E}"/>
               </a:ext>
             </a:extLst>
           </p:cNvPr>
@@ -6653,7 +6653,7 @@
     </p:spTree>
     <p:extLst>
       <p:ext uri="{BB962C8B-B14F-4D97-AF65-F5344CB8AC3E}">
-        <p14:creationId xmlns:p14="http://schemas.microsoft.com/office/powerpoint/2010/main" val="138485540"/>
+        <p14:creationId xmlns:p14="http://schemas.microsoft.com/office/powerpoint/2010/main" val="1884406580"/>
       </p:ext>
     </p:extLst>
   </p:cSld>
@@ -6684,7 +6684,7 @@
           <p:cNvPr id="6" name="">
             <a:extLst xmlns:a="http://schemas.openxmlformats.org/drawingml/2006/main">
               <a:ext uri="{FF2B5EF4-FFF2-40B4-BE49-F238E27FC236}">
-                <a16:creationId xmlns:a16="http://schemas.microsoft.com/office/drawing/2014/main" id="{9574343B-6DD0-4F0A-A59B-7A3DD85517D4}"/>
+                <a16:creationId xmlns:a16="http://schemas.microsoft.com/office/drawing/2014/main" id="{39BF2B73-646F-4B7B-9A52-A25F871D0572}"/>
               </a:ext>
             </a:extLst>
           </p:cNvPr>
@@ -6752,7 +6752,7 @@
           <p:cNvPr id="2" name="">
             <a:extLst xmlns:a="http://schemas.openxmlformats.org/drawingml/2006/main">
               <a:ext uri="{FF2B5EF4-FFF2-40B4-BE49-F238E27FC236}">
-                <a16:creationId xmlns:a16="http://schemas.microsoft.com/office/drawing/2014/main" id="{C6AA506D-C55E-46D4-9B58-D86DD1CA05E7}"/>
+                <a16:creationId xmlns:a16="http://schemas.microsoft.com/office/drawing/2014/main" id="{147AB6CE-CA49-43DE-AEF4-61EC93EF3D22}"/>
               </a:ext>
             </a:extLst>
           </p:cNvPr>
@@ -6820,7 +6820,7 @@
           <p:cNvPr id="3" name="">
             <a:extLst xmlns:a="http://schemas.openxmlformats.org/drawingml/2006/main">
               <a:ext uri="{FF2B5EF4-FFF2-40B4-BE49-F238E27FC236}">
-                <a16:creationId xmlns:a16="http://schemas.microsoft.com/office/drawing/2014/main" id="{06240119-8C4D-4349-9F4C-113B3366DF80}"/>
+                <a16:creationId xmlns:a16="http://schemas.microsoft.com/office/drawing/2014/main" id="{2C7C2570-432B-4857-9D30-F91443F06A72}"/>
               </a:ext>
             </a:extLst>
           </p:cNvPr>
@@ -6888,7 +6888,7 @@
           <p:cNvPr id="4" name="">
             <a:extLst xmlns:a="http://schemas.openxmlformats.org/drawingml/2006/main">
               <a:ext uri="{FF2B5EF4-FFF2-40B4-BE49-F238E27FC236}">
-                <a16:creationId xmlns:a16="http://schemas.microsoft.com/office/drawing/2014/main" id="{1ED66507-169D-44B8-8B76-4B632D9B6830}"/>
+                <a16:creationId xmlns:a16="http://schemas.microsoft.com/office/drawing/2014/main" id="{26CDB80A-46EF-4FCB-9550-32D707EFC26A}"/>
               </a:ext>
             </a:extLst>
           </p:cNvPr>
@@ -7012,7 +7012,7 @@
           <p:cNvPr id="5" name="">
             <a:extLst xmlns:a="http://schemas.openxmlformats.org/drawingml/2006/main">
               <a:ext uri="{FF2B5EF4-FFF2-40B4-BE49-F238E27FC236}">
-                <a16:creationId xmlns:a16="http://schemas.microsoft.com/office/drawing/2014/main" id="{7D19F08A-FC5A-4A97-A685-CEE8564F6E91}"/>
+                <a16:creationId xmlns:a16="http://schemas.microsoft.com/office/drawing/2014/main" id="{0F2AD11D-D42E-4617-B66C-045A610B48AB}"/>
               </a:ext>
             </a:extLst>
           </p:cNvPr>
@@ -7078,7 +7078,7 @@
     </p:spTree>
     <p:extLst>
       <p:ext uri="{BB962C8B-B14F-4D97-AF65-F5344CB8AC3E}">
-        <p14:creationId xmlns:p14="http://schemas.microsoft.com/office/powerpoint/2010/main" val="149329885"/>
+        <p14:creationId xmlns:p14="http://schemas.microsoft.com/office/powerpoint/2010/main" val="1267913163"/>
       </p:ext>
     </p:extLst>
   </p:cSld>
@@ -7109,7 +7109,7 @@
           <p:cNvPr id="8" name="">
             <a:extLst xmlns:a="http://schemas.openxmlformats.org/drawingml/2006/main">
               <a:ext uri="{FF2B5EF4-FFF2-40B4-BE49-F238E27FC236}">
-                <a16:creationId xmlns:a16="http://schemas.microsoft.com/office/drawing/2014/main" id="{887D241D-EA6C-4795-9675-ADF805A747C2}"/>
+                <a16:creationId xmlns:a16="http://schemas.microsoft.com/office/drawing/2014/main" id="{215EF884-8383-4304-92DC-F84A6A56608A}"/>
               </a:ext>
             </a:extLst>
           </p:cNvPr>
@@ -7177,7 +7177,7 @@
           <p:cNvPr id="2" name="">
             <a:extLst xmlns:a="http://schemas.openxmlformats.org/drawingml/2006/main">
               <a:ext uri="{FF2B5EF4-FFF2-40B4-BE49-F238E27FC236}">
-                <a16:creationId xmlns:a16="http://schemas.microsoft.com/office/drawing/2014/main" id="{A9677206-97E1-4E5B-92A2-2BB56A75BF46}"/>
+                <a16:creationId xmlns:a16="http://schemas.microsoft.com/office/drawing/2014/main" id="{F03D5954-EF23-419F-AD2F-137BB235490C}"/>
               </a:ext>
             </a:extLst>
           </p:cNvPr>
@@ -7245,7 +7245,7 @@
           <p:cNvPr id="3" name="">
             <a:extLst xmlns:a="http://schemas.openxmlformats.org/drawingml/2006/main">
               <a:ext uri="{FF2B5EF4-FFF2-40B4-BE49-F238E27FC236}">
-                <a16:creationId xmlns:a16="http://schemas.microsoft.com/office/drawing/2014/main" id="{29426998-F01F-478A-8BAB-4CAC9723D515}"/>
+                <a16:creationId xmlns:a16="http://schemas.microsoft.com/office/drawing/2014/main" id="{191353F2-ED26-42A5-8A2F-18F9257A6FC7}"/>
               </a:ext>
             </a:extLst>
           </p:cNvPr>
@@ -7313,7 +7313,7 @@
           <p:cNvPr id="4" name="">
             <a:extLst xmlns:a="http://schemas.openxmlformats.org/drawingml/2006/main">
               <a:ext uri="{FF2B5EF4-FFF2-40B4-BE49-F238E27FC236}">
-                <a16:creationId xmlns:a16="http://schemas.microsoft.com/office/drawing/2014/main" id="{224CE3ED-9F79-41FF-BB14-628811A79091}"/>
+                <a16:creationId xmlns:a16="http://schemas.microsoft.com/office/drawing/2014/main" id="{FD219D06-B454-45C3-A917-202B1572D008}"/>
               </a:ext>
             </a:extLst>
           </p:cNvPr>
@@ -7381,7 +7381,7 @@
           <p:cNvPr id="5" name="">
             <a:extLst xmlns:a="http://schemas.openxmlformats.org/drawingml/2006/main">
               <a:ext uri="{FF2B5EF4-FFF2-40B4-BE49-F238E27FC236}">
-                <a16:creationId xmlns:a16="http://schemas.microsoft.com/office/drawing/2014/main" id="{268A55B6-A1D5-4159-94C0-CEAA010161FE}"/>
+                <a16:creationId xmlns:a16="http://schemas.microsoft.com/office/drawing/2014/main" id="{001148AE-7EA3-42A5-BF87-43EBD665D36E}"/>
               </a:ext>
             </a:extLst>
           </p:cNvPr>
@@ -7449,7 +7449,7 @@
           <p:cNvPr id="6" name="">
             <a:extLst xmlns:a="http://schemas.openxmlformats.org/drawingml/2006/main">
               <a:ext uri="{FF2B5EF4-FFF2-40B4-BE49-F238E27FC236}">
-                <a16:creationId xmlns:a16="http://schemas.microsoft.com/office/drawing/2014/main" id="{E679E774-8A7F-4ADB-A200-DCBAE1A72477}"/>
+                <a16:creationId xmlns:a16="http://schemas.microsoft.com/office/drawing/2014/main" id="{4ED47A59-5F4E-47F2-A856-AFA684FA3EDE}"/>
               </a:ext>
             </a:extLst>
           </p:cNvPr>
@@ -7573,7 +7573,7 @@
           <p:cNvPr id="7" name="">
             <a:extLst xmlns:a="http://schemas.openxmlformats.org/drawingml/2006/main">
               <a:ext uri="{FF2B5EF4-FFF2-40B4-BE49-F238E27FC236}">
-                <a16:creationId xmlns:a16="http://schemas.microsoft.com/office/drawing/2014/main" id="{78238A65-3D5C-424C-9214-D012AD9B0381}"/>
+                <a16:creationId xmlns:a16="http://schemas.microsoft.com/office/drawing/2014/main" id="{40BBCBE6-8FA8-4AF1-9039-715C9E4F1A5E}"/>
               </a:ext>
             </a:extLst>
           </p:cNvPr>
@@ -7639,7 +7639,7 @@
     </p:spTree>
     <p:extLst>
       <p:ext uri="{BB962C8B-B14F-4D97-AF65-F5344CB8AC3E}">
-        <p14:creationId xmlns:p14="http://schemas.microsoft.com/office/powerpoint/2010/main" val="1481255632"/>
+        <p14:creationId xmlns:p14="http://schemas.microsoft.com/office/powerpoint/2010/main" val="1873264818"/>
       </p:ext>
     </p:extLst>
   </p:cSld>
@@ -7670,7 +7670,7 @@
           <p:cNvPr id="7" name="">
             <a:extLst xmlns:a="http://schemas.openxmlformats.org/drawingml/2006/main">
               <a:ext uri="{FF2B5EF4-FFF2-40B4-BE49-F238E27FC236}">
-                <a16:creationId xmlns:a16="http://schemas.microsoft.com/office/drawing/2014/main" id="{442BC8BB-190F-45E9-A9B0-FA6083096F63}"/>
+                <a16:creationId xmlns:a16="http://schemas.microsoft.com/office/drawing/2014/main" id="{283717C1-E00F-4DCD-B23C-3CA7E605ACFB}"/>
               </a:ext>
             </a:extLst>
           </p:cNvPr>
@@ -7738,7 +7738,7 @@
           <p:cNvPr id="2" name="">
             <a:extLst xmlns:a="http://schemas.openxmlformats.org/drawingml/2006/main">
               <a:ext uri="{FF2B5EF4-FFF2-40B4-BE49-F238E27FC236}">
-                <a16:creationId xmlns:a16="http://schemas.microsoft.com/office/drawing/2014/main" id="{E9AB0529-52B4-4CCB-AD90-6BC6148535E9}"/>
+                <a16:creationId xmlns:a16="http://schemas.microsoft.com/office/drawing/2014/main" id="{DED7678D-85A7-4985-A57D-645F13C34B0C}"/>
               </a:ext>
             </a:extLst>
           </p:cNvPr>
@@ -7806,7 +7806,7 @@
           <p:cNvPr id="3" name="">
             <a:extLst xmlns:a="http://schemas.openxmlformats.org/drawingml/2006/main">
               <a:ext uri="{FF2B5EF4-FFF2-40B4-BE49-F238E27FC236}">
-                <a16:creationId xmlns:a16="http://schemas.microsoft.com/office/drawing/2014/main" id="{7A87DE3B-7941-4AD7-9837-501567DB13CF}"/>
+                <a16:creationId xmlns:a16="http://schemas.microsoft.com/office/drawing/2014/main" id="{B798803A-EA3D-47C2-98B5-847CCFBF3048}"/>
               </a:ext>
             </a:extLst>
           </p:cNvPr>
@@ -7874,7 +7874,7 @@
           <p:cNvPr id="4" name="">
             <a:extLst xmlns:a="http://schemas.openxmlformats.org/drawingml/2006/main">
               <a:ext uri="{FF2B5EF4-FFF2-40B4-BE49-F238E27FC236}">
-                <a16:creationId xmlns:a16="http://schemas.microsoft.com/office/drawing/2014/main" id="{1830D3A5-C9EA-4AC4-A9FF-407E798B1A22}"/>
+                <a16:creationId xmlns:a16="http://schemas.microsoft.com/office/drawing/2014/main" id="{732CC931-FDFD-468C-853D-A4C2F39D4BF6}"/>
               </a:ext>
             </a:extLst>
           </p:cNvPr>
@@ -7998,7 +7998,7 @@
           <p:cNvPr id="5" name="">
             <a:extLst xmlns:a="http://schemas.openxmlformats.org/drawingml/2006/main">
               <a:ext uri="{FF2B5EF4-FFF2-40B4-BE49-F238E27FC236}">
-                <a16:creationId xmlns:a16="http://schemas.microsoft.com/office/drawing/2014/main" id="{6ABB4A15-A069-4372-939D-DF1115F6BDDE}"/>
+                <a16:creationId xmlns:a16="http://schemas.microsoft.com/office/drawing/2014/main" id="{D32AE706-C0D2-459E-9100-388732A57C93}"/>
               </a:ext>
             </a:extLst>
           </p:cNvPr>
@@ -8066,7 +8066,7 @@
           <p:cNvPr id="6" name="">
             <a:extLst xmlns:a="http://schemas.openxmlformats.org/drawingml/2006/main">
               <a:ext uri="{FF2B5EF4-FFF2-40B4-BE49-F238E27FC236}">
-                <a16:creationId xmlns:a16="http://schemas.microsoft.com/office/drawing/2014/main" id="{4594AC1B-35CD-45BF-BEBE-A78280E69B8B}"/>
+                <a16:creationId xmlns:a16="http://schemas.microsoft.com/office/drawing/2014/main" id="{7D9D8958-A825-41D9-BC02-1155DBA64CAE}"/>
               </a:ext>
             </a:extLst>
           </p:cNvPr>
@@ -8132,7 +8132,7 @@
     </p:spTree>
     <p:extLst>
       <p:ext uri="{BB962C8B-B14F-4D97-AF65-F5344CB8AC3E}">
-        <p14:creationId xmlns:p14="http://schemas.microsoft.com/office/powerpoint/2010/main" val="550895560"/>
+        <p14:creationId xmlns:p14="http://schemas.microsoft.com/office/powerpoint/2010/main" val="2050969808"/>
       </p:ext>
     </p:extLst>
   </p:cSld>
@@ -8163,7 +8163,7 @@
           <p:cNvPr id="6" name="">
             <a:extLst xmlns:a="http://schemas.openxmlformats.org/drawingml/2006/main">
               <a:ext uri="{FF2B5EF4-FFF2-40B4-BE49-F238E27FC236}">
-                <a16:creationId xmlns:a16="http://schemas.microsoft.com/office/drawing/2014/main" id="{ED8FB0BC-3E04-4959-9CE3-213D090B6AFE}"/>
+                <a16:creationId xmlns:a16="http://schemas.microsoft.com/office/drawing/2014/main" id="{8DFFB5C6-D2F5-46F0-B024-BFB6710B78AA}"/>
               </a:ext>
             </a:extLst>
           </p:cNvPr>
@@ -8231,7 +8231,7 @@
           <p:cNvPr id="2" name="">
             <a:extLst xmlns:a="http://schemas.openxmlformats.org/drawingml/2006/main">
               <a:ext uri="{FF2B5EF4-FFF2-40B4-BE49-F238E27FC236}">
-                <a16:creationId xmlns:a16="http://schemas.microsoft.com/office/drawing/2014/main" id="{66502EB8-6F83-4E48-87FD-F971D7715600}"/>
+                <a16:creationId xmlns:a16="http://schemas.microsoft.com/office/drawing/2014/main" id="{65BE8FB4-546F-49BF-BBEE-46F06508ECBD}"/>
               </a:ext>
             </a:extLst>
           </p:cNvPr>
@@ -8299,7 +8299,7 @@
           <p:cNvPr id="3" name="">
             <a:extLst xmlns:a="http://schemas.openxmlformats.org/drawingml/2006/main">
               <a:ext uri="{FF2B5EF4-FFF2-40B4-BE49-F238E27FC236}">
-                <a16:creationId xmlns:a16="http://schemas.microsoft.com/office/drawing/2014/main" id="{7A07CA31-5FBC-48F5-A9B3-22963DC27E20}"/>
+                <a16:creationId xmlns:a16="http://schemas.microsoft.com/office/drawing/2014/main" id="{D215E5E2-9935-464D-A55E-CB60A88B2AB1}"/>
               </a:ext>
             </a:extLst>
           </p:cNvPr>
@@ -8367,7 +8367,7 @@
           <p:cNvPr id="4" name="">
             <a:extLst xmlns:a="http://schemas.openxmlformats.org/drawingml/2006/main">
               <a:ext uri="{FF2B5EF4-FFF2-40B4-BE49-F238E27FC236}">
-                <a16:creationId xmlns:a16="http://schemas.microsoft.com/office/drawing/2014/main" id="{C6AC3C25-3389-40AB-AB2C-B3209CD5EF24}"/>
+                <a16:creationId xmlns:a16="http://schemas.microsoft.com/office/drawing/2014/main" id="{70963F17-D41F-49D8-9857-986B37D5FBC2}"/>
               </a:ext>
             </a:extLst>
           </p:cNvPr>
@@ -8481,7 +8481,7 @@
                 <a:ea typeface="Arial"/>
                 <a:cs typeface="Arial"/>
               </a:rPr>
-              <a:t>Tri prova në java-05.md; dorëzim në minutën 70 dhe kohë për korrigjime.</a:t>
+              <a:t>Tri prova në java-05.md; nis dorëzimin në minutën 65 dhe lër 25 minuta për përgjigjen e korrigjimet.</a:t>
             </a:r>
           </a:p>
         </p:txBody>
@@ -8491,7 +8491,7 @@
           <p:cNvPr id="5" name="">
             <a:extLst xmlns:a="http://schemas.openxmlformats.org/drawingml/2006/main">
               <a:ext uri="{FF2B5EF4-FFF2-40B4-BE49-F238E27FC236}">
-                <a16:creationId xmlns:a16="http://schemas.microsoft.com/office/drawing/2014/main" id="{28F56F4B-FEE6-45AA-8333-54E1553E9855}"/>
+                <a16:creationId xmlns:a16="http://schemas.microsoft.com/office/drawing/2014/main" id="{5450F279-CE68-45E5-B141-E3E0529DC30D}"/>
               </a:ext>
             </a:extLst>
           </p:cNvPr>
@@ -8557,7 +8557,7 @@
     </p:spTree>
     <p:extLst>
       <p:ext uri="{BB962C8B-B14F-4D97-AF65-F5344CB8AC3E}">
-        <p14:creationId xmlns:p14="http://schemas.microsoft.com/office/powerpoint/2010/main" val="989532036"/>
+        <p14:creationId xmlns:p14="http://schemas.microsoft.com/office/powerpoint/2010/main" val="1226196408"/>
       </p:ext>
     </p:extLst>
   </p:cSld>
@@ -8588,7 +8588,7 @@
           <p:cNvPr id="9" name="">
             <a:extLst xmlns:a="http://schemas.openxmlformats.org/drawingml/2006/main">
               <a:ext uri="{FF2B5EF4-FFF2-40B4-BE49-F238E27FC236}">
-                <a16:creationId xmlns:a16="http://schemas.microsoft.com/office/drawing/2014/main" id="{78B3C602-2D18-4BDB-BF0F-E9346B669C74}"/>
+                <a16:creationId xmlns:a16="http://schemas.microsoft.com/office/drawing/2014/main" id="{7933376D-C192-4B73-87F4-FF17CEC2E2B8}"/>
               </a:ext>
             </a:extLst>
           </p:cNvPr>
@@ -8656,7 +8656,7 @@
           <p:cNvPr id="2" name="">
             <a:extLst xmlns:a="http://schemas.openxmlformats.org/drawingml/2006/main">
               <a:ext uri="{FF2B5EF4-FFF2-40B4-BE49-F238E27FC236}">
-                <a16:creationId xmlns:a16="http://schemas.microsoft.com/office/drawing/2014/main" id="{391054C5-B731-4C74-9DFC-AE4BDC1D420F}"/>
+                <a16:creationId xmlns:a16="http://schemas.microsoft.com/office/drawing/2014/main" id="{40FA98D0-A30D-4C98-A9C1-23E08B37A66A}"/>
               </a:ext>
             </a:extLst>
           </p:cNvPr>
@@ -8724,7 +8724,7 @@
           <p:cNvPr id="3" name="">
             <a:extLst xmlns:a="http://schemas.openxmlformats.org/drawingml/2006/main">
               <a:ext uri="{FF2B5EF4-FFF2-40B4-BE49-F238E27FC236}">
-                <a16:creationId xmlns:a16="http://schemas.microsoft.com/office/drawing/2014/main" id="{45C114CD-88EC-4EBC-8620-565C90729FF6}"/>
+                <a16:creationId xmlns:a16="http://schemas.microsoft.com/office/drawing/2014/main" id="{8B238266-E9B8-4EFC-A81F-72D7D98532ED}"/>
               </a:ext>
             </a:extLst>
           </p:cNvPr>
@@ -8792,7 +8792,7 @@
           <p:cNvPr id="4" name="">
             <a:extLst xmlns:a="http://schemas.openxmlformats.org/drawingml/2006/main">
               <a:ext uri="{FF2B5EF4-FFF2-40B4-BE49-F238E27FC236}">
-                <a16:creationId xmlns:a16="http://schemas.microsoft.com/office/drawing/2014/main" id="{5263ABAF-6BAF-463F-8198-BF9945EC0E48}"/>
+                <a16:creationId xmlns:a16="http://schemas.microsoft.com/office/drawing/2014/main" id="{F024C339-CF0E-4BBA-9A1B-173DF1CB4FFF}"/>
               </a:ext>
             </a:extLst>
           </p:cNvPr>
@@ -8916,7 +8916,7 @@
           <p:cNvPr id="5" name="">
             <a:extLst xmlns:a="http://schemas.openxmlformats.org/drawingml/2006/main">
               <a:ext uri="{FF2B5EF4-FFF2-40B4-BE49-F238E27FC236}">
-                <a16:creationId xmlns:a16="http://schemas.microsoft.com/office/drawing/2014/main" id="{0F8EF9E3-44EA-4BAE-B4E8-8A6CAF1374CD}"/>
+                <a16:creationId xmlns:a16="http://schemas.microsoft.com/office/drawing/2014/main" id="{597CE977-E70F-487C-AB32-3B537CACDACD}"/>
               </a:ext>
             </a:extLst>
           </p:cNvPr>
@@ -8984,7 +8984,7 @@
           <p:cNvPr id="6" name="">
             <a:extLst xmlns:a="http://schemas.openxmlformats.org/drawingml/2006/main">
               <a:ext uri="{FF2B5EF4-FFF2-40B4-BE49-F238E27FC236}">
-                <a16:creationId xmlns:a16="http://schemas.microsoft.com/office/drawing/2014/main" id="{115F4E39-EA08-4F27-81E8-7ABFD4FBBCFC}"/>
+                <a16:creationId xmlns:a16="http://schemas.microsoft.com/office/drawing/2014/main" id="{2A4F3C19-F676-4AAD-8679-CE3C2F4FF3AD}"/>
               </a:ext>
             </a:extLst>
           </p:cNvPr>
@@ -9052,7 +9052,7 @@
           <p:cNvPr id="7" name="">
             <a:extLst xmlns:a="http://schemas.openxmlformats.org/drawingml/2006/main">
               <a:ext uri="{FF2B5EF4-FFF2-40B4-BE49-F238E27FC236}">
-                <a16:creationId xmlns:a16="http://schemas.microsoft.com/office/drawing/2014/main" id="{ED3D4719-76A3-47F2-8993-AF881C4D19D9}"/>
+                <a16:creationId xmlns:a16="http://schemas.microsoft.com/office/drawing/2014/main" id="{632B697E-24B3-4A4A-825E-EDFC26F97A6D}"/>
               </a:ext>
             </a:extLst>
           </p:cNvPr>
@@ -9120,7 +9120,7 @@
           <p:cNvPr id="8" name="">
             <a:extLst xmlns:a="http://schemas.openxmlformats.org/drawingml/2006/main">
               <a:ext uri="{FF2B5EF4-FFF2-40B4-BE49-F238E27FC236}">
-                <a16:creationId xmlns:a16="http://schemas.microsoft.com/office/drawing/2014/main" id="{A3210042-BE72-4A14-A89A-758F1FBDEA00}"/>
+                <a16:creationId xmlns:a16="http://schemas.microsoft.com/office/drawing/2014/main" id="{E10D99EB-F344-40A2-8680-B30A5967B0B7}"/>
               </a:ext>
             </a:extLst>
           </p:cNvPr>
@@ -9186,7 +9186,7 @@
     </p:spTree>
     <p:extLst>
       <p:ext uri="{BB962C8B-B14F-4D97-AF65-F5344CB8AC3E}">
-        <p14:creationId xmlns:p14="http://schemas.microsoft.com/office/powerpoint/2010/main" val="205282092"/>
+        <p14:creationId xmlns:p14="http://schemas.microsoft.com/office/powerpoint/2010/main" val="430292564"/>
       </p:ext>
     </p:extLst>
   </p:cSld>
@@ -9217,7 +9217,7 @@
           <p:cNvPr id="12" name="">
             <a:extLst xmlns:a="http://schemas.openxmlformats.org/drawingml/2006/main">
               <a:ext uri="{FF2B5EF4-FFF2-40B4-BE49-F238E27FC236}">
-                <a16:creationId xmlns:a16="http://schemas.microsoft.com/office/drawing/2014/main" id="{3232AA30-4563-49AE-BA1C-6D890574225E}"/>
+                <a16:creationId xmlns:a16="http://schemas.microsoft.com/office/drawing/2014/main" id="{B13F1884-2CF1-439B-B17E-06151E4BA86D}"/>
               </a:ext>
             </a:extLst>
           </p:cNvPr>
@@ -9285,7 +9285,7 @@
           <p:cNvPr id="2" name="">
             <a:extLst xmlns:a="http://schemas.openxmlformats.org/drawingml/2006/main">
               <a:ext uri="{FF2B5EF4-FFF2-40B4-BE49-F238E27FC236}">
-                <a16:creationId xmlns:a16="http://schemas.microsoft.com/office/drawing/2014/main" id="{28855756-76D0-4101-8283-78390AD34099}"/>
+                <a16:creationId xmlns:a16="http://schemas.microsoft.com/office/drawing/2014/main" id="{C69F7E25-9BA2-42AC-86B6-20F7768DD2E4}"/>
               </a:ext>
             </a:extLst>
           </p:cNvPr>
@@ -9353,7 +9353,7 @@
           <p:cNvPr id="3" name="">
             <a:extLst xmlns:a="http://schemas.openxmlformats.org/drawingml/2006/main">
               <a:ext uri="{FF2B5EF4-FFF2-40B4-BE49-F238E27FC236}">
-                <a16:creationId xmlns:a16="http://schemas.microsoft.com/office/drawing/2014/main" id="{9E1B0172-C146-4C1F-A2A6-F1AB5EB56BBA}"/>
+                <a16:creationId xmlns:a16="http://schemas.microsoft.com/office/drawing/2014/main" id="{973CFCB2-985F-42A8-A6CC-19DC685278FC}"/>
               </a:ext>
             </a:extLst>
           </p:cNvPr>
@@ -9421,7 +9421,7 @@
           <p:cNvPr id="4" name="">
             <a:extLst xmlns:a="http://schemas.openxmlformats.org/drawingml/2006/main">
               <a:ext uri="{FF2B5EF4-FFF2-40B4-BE49-F238E27FC236}">
-                <a16:creationId xmlns:a16="http://schemas.microsoft.com/office/drawing/2014/main" id="{F5DF2255-C1EF-4B5F-938E-4863528929A6}"/>
+                <a16:creationId xmlns:a16="http://schemas.microsoft.com/office/drawing/2014/main" id="{1A5ADDED-581D-412F-A159-067D2C575937}"/>
               </a:ext>
             </a:extLst>
           </p:cNvPr>
@@ -9545,7 +9545,7 @@
           <p:cNvPr id="5" name="">
             <a:extLst xmlns:a="http://schemas.openxmlformats.org/drawingml/2006/main">
               <a:ext uri="{FF2B5EF4-FFF2-40B4-BE49-F238E27FC236}">
-                <a16:creationId xmlns:a16="http://schemas.microsoft.com/office/drawing/2014/main" id="{AF2AFEB2-88E2-4BE9-A02D-271E463DC7EC}"/>
+                <a16:creationId xmlns:a16="http://schemas.microsoft.com/office/drawing/2014/main" id="{6BC40B09-FF7C-4A9E-8C13-B34000F366FF}"/>
               </a:ext>
             </a:extLst>
           </p:cNvPr>
@@ -9613,7 +9613,7 @@
           <p:cNvPr id="6" name="">
             <a:extLst xmlns:a="http://schemas.openxmlformats.org/drawingml/2006/main">
               <a:ext uri="{FF2B5EF4-FFF2-40B4-BE49-F238E27FC236}">
-                <a16:creationId xmlns:a16="http://schemas.microsoft.com/office/drawing/2014/main" id="{E534A852-838E-4020-94C7-A2D648E4B7B4}"/>
+                <a16:creationId xmlns:a16="http://schemas.microsoft.com/office/drawing/2014/main" id="{CA97A870-291F-420A-BEB6-CDF667FE99B1}"/>
               </a:ext>
             </a:extLst>
           </p:cNvPr>
@@ -9681,7 +9681,7 @@
           <p:cNvPr id="7" name="">
             <a:extLst xmlns:a="http://schemas.openxmlformats.org/drawingml/2006/main">
               <a:ext uri="{FF2B5EF4-FFF2-40B4-BE49-F238E27FC236}">
-                <a16:creationId xmlns:a16="http://schemas.microsoft.com/office/drawing/2014/main" id="{8FD0C43C-C2CC-4B55-9DDC-4B3014D42F3E}"/>
+                <a16:creationId xmlns:a16="http://schemas.microsoft.com/office/drawing/2014/main" id="{C9F30AED-0157-4918-BAA0-6325454211F2}"/>
               </a:ext>
             </a:extLst>
           </p:cNvPr>
@@ -9749,7 +9749,7 @@
           <p:cNvPr id="8" name="">
             <a:extLst xmlns:a="http://schemas.openxmlformats.org/drawingml/2006/main">
               <a:ext uri="{FF2B5EF4-FFF2-40B4-BE49-F238E27FC236}">
-                <a16:creationId xmlns:a16="http://schemas.microsoft.com/office/drawing/2014/main" id="{9AC6FBAC-D849-4FE8-A82D-EEDE5A832BF5}"/>
+                <a16:creationId xmlns:a16="http://schemas.microsoft.com/office/drawing/2014/main" id="{4C7396EF-3BBB-48C4-8845-1848B7729709}"/>
               </a:ext>
             </a:extLst>
           </p:cNvPr>
@@ -9817,7 +9817,7 @@
           <p:cNvPr id="9" name="">
             <a:extLst xmlns:a="http://schemas.openxmlformats.org/drawingml/2006/main">
               <a:ext uri="{FF2B5EF4-FFF2-40B4-BE49-F238E27FC236}">
-                <a16:creationId xmlns:a16="http://schemas.microsoft.com/office/drawing/2014/main" id="{274BF3BA-FF08-48B7-B564-21481E90B6BB}"/>
+                <a16:creationId xmlns:a16="http://schemas.microsoft.com/office/drawing/2014/main" id="{79AF57EC-7108-436B-AFBE-7B076D39270B}"/>
               </a:ext>
             </a:extLst>
           </p:cNvPr>
@@ -9885,7 +9885,7 @@
           <p:cNvPr id="10" name="">
             <a:extLst xmlns:a="http://schemas.openxmlformats.org/drawingml/2006/main">
               <a:ext uri="{FF2B5EF4-FFF2-40B4-BE49-F238E27FC236}">
-                <a16:creationId xmlns:a16="http://schemas.microsoft.com/office/drawing/2014/main" id="{75A96AD1-5298-443C-8DB8-D52F194F7F5E}"/>
+                <a16:creationId xmlns:a16="http://schemas.microsoft.com/office/drawing/2014/main" id="{F491EBBC-8C8A-4A84-8703-54F929467E22}"/>
               </a:ext>
             </a:extLst>
           </p:cNvPr>
@@ -9953,7 +9953,7 @@
           <p:cNvPr id="11" name="">
             <a:extLst xmlns:a="http://schemas.openxmlformats.org/drawingml/2006/main">
               <a:ext uri="{FF2B5EF4-FFF2-40B4-BE49-F238E27FC236}">
-                <a16:creationId xmlns:a16="http://schemas.microsoft.com/office/drawing/2014/main" id="{6226729D-8A0F-40F0-9402-5A4A9359C594}"/>
+                <a16:creationId xmlns:a16="http://schemas.microsoft.com/office/drawing/2014/main" id="{FB982330-0119-424D-B9A7-C2469631CC9E}"/>
               </a:ext>
             </a:extLst>
           </p:cNvPr>
@@ -10019,7 +10019,7 @@
     </p:spTree>
     <p:extLst>
       <p:ext uri="{BB962C8B-B14F-4D97-AF65-F5344CB8AC3E}">
-        <p14:creationId xmlns:p14="http://schemas.microsoft.com/office/powerpoint/2010/main" val="796789145"/>
+        <p14:creationId xmlns:p14="http://schemas.microsoft.com/office/powerpoint/2010/main" val="1281501583"/>
       </p:ext>
     </p:extLst>
   </p:cSld>
@@ -10050,7 +10050,7 @@
           <p:cNvPr id="7" name="">
             <a:extLst xmlns:a="http://schemas.openxmlformats.org/drawingml/2006/main">
               <a:ext uri="{FF2B5EF4-FFF2-40B4-BE49-F238E27FC236}">
-                <a16:creationId xmlns:a16="http://schemas.microsoft.com/office/drawing/2014/main" id="{A8B6D813-B580-40E0-9DB5-ED7CB1B71064}"/>
+                <a16:creationId xmlns:a16="http://schemas.microsoft.com/office/drawing/2014/main" id="{FE106447-3787-44CA-8F46-EA5A4B8CEE2F}"/>
               </a:ext>
             </a:extLst>
           </p:cNvPr>
@@ -10118,7 +10118,7 @@
           <p:cNvPr id="2" name="">
             <a:extLst xmlns:a="http://schemas.openxmlformats.org/drawingml/2006/main">
               <a:ext uri="{FF2B5EF4-FFF2-40B4-BE49-F238E27FC236}">
-                <a16:creationId xmlns:a16="http://schemas.microsoft.com/office/drawing/2014/main" id="{97CE3227-8BDC-4F03-A389-9CC1D09A853B}"/>
+                <a16:creationId xmlns:a16="http://schemas.microsoft.com/office/drawing/2014/main" id="{4269A628-B9DC-4AA1-A442-F725C951E037}"/>
               </a:ext>
             </a:extLst>
           </p:cNvPr>
@@ -10186,7 +10186,7 @@
           <p:cNvPr id="3" name="">
             <a:extLst xmlns:a="http://schemas.openxmlformats.org/drawingml/2006/main">
               <a:ext uri="{FF2B5EF4-FFF2-40B4-BE49-F238E27FC236}">
-                <a16:creationId xmlns:a16="http://schemas.microsoft.com/office/drawing/2014/main" id="{E37FF64F-463A-44B4-BD20-D8EA761868CE}"/>
+                <a16:creationId xmlns:a16="http://schemas.microsoft.com/office/drawing/2014/main" id="{E35B341E-8603-4C47-8EE6-634487B67564}"/>
               </a:ext>
             </a:extLst>
           </p:cNvPr>
@@ -10254,7 +10254,7 @@
           <p:cNvPr id="4" name="">
             <a:extLst xmlns:a="http://schemas.openxmlformats.org/drawingml/2006/main">
               <a:ext uri="{FF2B5EF4-FFF2-40B4-BE49-F238E27FC236}">
-                <a16:creationId xmlns:a16="http://schemas.microsoft.com/office/drawing/2014/main" id="{8082A936-C8AF-4778-AF93-C37E6B9E1782}"/>
+                <a16:creationId xmlns:a16="http://schemas.microsoft.com/office/drawing/2014/main" id="{5D827311-F904-4F63-BA1D-51751D08B89E}"/>
               </a:ext>
             </a:extLst>
           </p:cNvPr>
@@ -10378,7 +10378,7 @@
           <p:cNvPr id="5" name="">
             <a:extLst xmlns:a="http://schemas.openxmlformats.org/drawingml/2006/main">
               <a:ext uri="{FF2B5EF4-FFF2-40B4-BE49-F238E27FC236}">
-                <a16:creationId xmlns:a16="http://schemas.microsoft.com/office/drawing/2014/main" id="{5A002B86-A0C7-479F-A9A7-EF4832E0BE15}"/>
+                <a16:creationId xmlns:a16="http://schemas.microsoft.com/office/drawing/2014/main" id="{6AFFE6FE-1D53-4324-8210-67DFB95F7202}"/>
               </a:ext>
             </a:extLst>
           </p:cNvPr>
@@ -10446,7 +10446,7 @@
           <p:cNvPr id="6" name="">
             <a:extLst xmlns:a="http://schemas.openxmlformats.org/drawingml/2006/main">
               <a:ext uri="{FF2B5EF4-FFF2-40B4-BE49-F238E27FC236}">
-                <a16:creationId xmlns:a16="http://schemas.microsoft.com/office/drawing/2014/main" id="{FAAC3654-4199-444B-AE4E-73CA6853EEE3}"/>
+                <a16:creationId xmlns:a16="http://schemas.microsoft.com/office/drawing/2014/main" id="{30E792D5-AECC-44C2-849F-A8413B81D142}"/>
               </a:ext>
             </a:extLst>
           </p:cNvPr>
@@ -10512,7 +10512,7 @@
     </p:spTree>
     <p:extLst>
       <p:ext uri="{BB962C8B-B14F-4D97-AF65-F5344CB8AC3E}">
-        <p14:creationId xmlns:p14="http://schemas.microsoft.com/office/powerpoint/2010/main" val="970495517"/>
+        <p14:creationId xmlns:p14="http://schemas.microsoft.com/office/powerpoint/2010/main" val="1170949418"/>
       </p:ext>
     </p:extLst>
   </p:cSld>
@@ -10543,7 +10543,7 @@
           <p:cNvPr id="6" name="">
             <a:extLst xmlns:a="http://schemas.openxmlformats.org/drawingml/2006/main">
               <a:ext uri="{FF2B5EF4-FFF2-40B4-BE49-F238E27FC236}">
-                <a16:creationId xmlns:a16="http://schemas.microsoft.com/office/drawing/2014/main" id="{42A277FE-1EB4-417B-A973-1F2CC3C18E70}"/>
+                <a16:creationId xmlns:a16="http://schemas.microsoft.com/office/drawing/2014/main" id="{71429453-9437-4802-8337-5A395D078D45}"/>
               </a:ext>
             </a:extLst>
           </p:cNvPr>
@@ -10611,7 +10611,7 @@
           <p:cNvPr id="2" name="">
             <a:extLst xmlns:a="http://schemas.openxmlformats.org/drawingml/2006/main">
               <a:ext uri="{FF2B5EF4-FFF2-40B4-BE49-F238E27FC236}">
-                <a16:creationId xmlns:a16="http://schemas.microsoft.com/office/drawing/2014/main" id="{656E090A-7928-453A-8858-01904F7D6D69}"/>
+                <a16:creationId xmlns:a16="http://schemas.microsoft.com/office/drawing/2014/main" id="{331986B5-615D-4A7F-9060-14B5CA999631}"/>
               </a:ext>
             </a:extLst>
           </p:cNvPr>
@@ -10679,7 +10679,7 @@
           <p:cNvPr id="3" name="">
             <a:extLst xmlns:a="http://schemas.openxmlformats.org/drawingml/2006/main">
               <a:ext uri="{FF2B5EF4-FFF2-40B4-BE49-F238E27FC236}">
-                <a16:creationId xmlns:a16="http://schemas.microsoft.com/office/drawing/2014/main" id="{39D50ECA-919F-4F26-A456-D4ACE1A11C36}"/>
+                <a16:creationId xmlns:a16="http://schemas.microsoft.com/office/drawing/2014/main" id="{FDA81A3E-C3EE-4D72-ADD8-F78050B04BC7}"/>
               </a:ext>
             </a:extLst>
           </p:cNvPr>
@@ -10747,7 +10747,7 @@
           <p:cNvPr id="4" name="">
             <a:extLst xmlns:a="http://schemas.openxmlformats.org/drawingml/2006/main">
               <a:ext uri="{FF2B5EF4-FFF2-40B4-BE49-F238E27FC236}">
-                <a16:creationId xmlns:a16="http://schemas.microsoft.com/office/drawing/2014/main" id="{689E212D-48C6-4B51-B576-67CA60E7F596}"/>
+                <a16:creationId xmlns:a16="http://schemas.microsoft.com/office/drawing/2014/main" id="{9E0146DB-C7FF-4C27-A5A1-42146CD5D451}"/>
               </a:ext>
             </a:extLst>
           </p:cNvPr>
@@ -10757,7 +10757,7 @@
           <p:nvPr/>
         </p:nvPicPr>
         <p:blipFill>
-          <a:blip xmlns:r="http://schemas.openxmlformats.org/officeDocument/2006/relationships" xmlns:a="http://schemas.openxmlformats.org/drawingml/2006/main" r:embed="Rfd1474f4b55641bb"/>
+          <a:blip xmlns:r="http://schemas.openxmlformats.org/officeDocument/2006/relationships" xmlns:a="http://schemas.openxmlformats.org/drawingml/2006/main" r:embed="R7d8d6dea4398458f"/>
           <a:stretch xmlns:a="http://schemas.openxmlformats.org/drawingml/2006/main"/>
         </p:blipFill>
         <p:spPr>
@@ -10775,7 +10775,7 @@
           <p:cNvPr id="5" name="">
             <a:extLst xmlns:a="http://schemas.openxmlformats.org/drawingml/2006/main">
               <a:ext uri="{FF2B5EF4-FFF2-40B4-BE49-F238E27FC236}">
-                <a16:creationId xmlns:a16="http://schemas.microsoft.com/office/drawing/2014/main" id="{109F8F30-2F38-4BE3-A4E0-AECD465876B5}"/>
+                <a16:creationId xmlns:a16="http://schemas.microsoft.com/office/drawing/2014/main" id="{4293B6CF-5179-4356-8DEA-55882BDF3260}"/>
               </a:ext>
             </a:extLst>
           </p:cNvPr>
@@ -10869,7 +10869,7 @@
     </p:spTree>
     <p:extLst>
       <p:ext uri="{BB962C8B-B14F-4D97-AF65-F5344CB8AC3E}">
-        <p14:creationId xmlns:p14="http://schemas.microsoft.com/office/powerpoint/2010/main" val="58673776"/>
+        <p14:creationId xmlns:p14="http://schemas.microsoft.com/office/powerpoint/2010/main" val="1180680312"/>
       </p:ext>
     </p:extLst>
   </p:cSld>
@@ -10900,7 +10900,7 @@
           <p:cNvPr id="13" name="">
             <a:extLst xmlns:a="http://schemas.openxmlformats.org/drawingml/2006/main">
               <a:ext uri="{FF2B5EF4-FFF2-40B4-BE49-F238E27FC236}">
-                <a16:creationId xmlns:a16="http://schemas.microsoft.com/office/drawing/2014/main" id="{B003D930-9B22-43D0-B457-C0E8D7039BC5}"/>
+                <a16:creationId xmlns:a16="http://schemas.microsoft.com/office/drawing/2014/main" id="{F5E9552E-2517-43FC-B894-D8A8B7192F32}"/>
               </a:ext>
             </a:extLst>
           </p:cNvPr>
@@ -10968,7 +10968,7 @@
           <p:cNvPr id="2" name="">
             <a:extLst xmlns:a="http://schemas.openxmlformats.org/drawingml/2006/main">
               <a:ext uri="{FF2B5EF4-FFF2-40B4-BE49-F238E27FC236}">
-                <a16:creationId xmlns:a16="http://schemas.microsoft.com/office/drawing/2014/main" id="{AE452F05-4E5F-4F3B-BDCE-DA4909DDF93F}"/>
+                <a16:creationId xmlns:a16="http://schemas.microsoft.com/office/drawing/2014/main" id="{B0C408D2-5794-449A-8EC9-FFE7318A5749}"/>
               </a:ext>
             </a:extLst>
           </p:cNvPr>
@@ -11036,7 +11036,7 @@
           <p:cNvPr id="3" name="">
             <a:extLst xmlns:a="http://schemas.openxmlformats.org/drawingml/2006/main">
               <a:ext uri="{FF2B5EF4-FFF2-40B4-BE49-F238E27FC236}">
-                <a16:creationId xmlns:a16="http://schemas.microsoft.com/office/drawing/2014/main" id="{CDA80811-B454-4264-914C-B674CBA63CAB}"/>
+                <a16:creationId xmlns:a16="http://schemas.microsoft.com/office/drawing/2014/main" id="{D47450FF-BE9E-4AAF-9AE8-7C0EFA966FAC}"/>
               </a:ext>
             </a:extLst>
           </p:cNvPr>
@@ -11104,7 +11104,7 @@
           <p:cNvPr id="4" name="">
             <a:extLst xmlns:a="http://schemas.openxmlformats.org/drawingml/2006/main">
               <a:ext uri="{FF2B5EF4-FFF2-40B4-BE49-F238E27FC236}">
-                <a16:creationId xmlns:a16="http://schemas.microsoft.com/office/drawing/2014/main" id="{0A50EEE8-D93F-4A11-B195-0C3F4508C1C6}"/>
+                <a16:creationId xmlns:a16="http://schemas.microsoft.com/office/drawing/2014/main" id="{7253028E-AD87-4970-9DE7-1088E99FD332}"/>
               </a:ext>
             </a:extLst>
           </p:cNvPr>
@@ -11200,7 +11200,7 @@
           <p:cNvPr id="5" name="">
             <a:extLst xmlns:a="http://schemas.openxmlformats.org/drawingml/2006/main">
               <a:ext uri="{FF2B5EF4-FFF2-40B4-BE49-F238E27FC236}">
-                <a16:creationId xmlns:a16="http://schemas.microsoft.com/office/drawing/2014/main" id="{0D69BC31-1BC2-4108-B61E-4707EB59C355}"/>
+                <a16:creationId xmlns:a16="http://schemas.microsoft.com/office/drawing/2014/main" id="{75F0DAC0-6737-485F-A811-E1A79A8567EF}"/>
               </a:ext>
             </a:extLst>
           </p:cNvPr>
@@ -11268,7 +11268,7 @@
           <p:cNvPr id="6" name="">
             <a:extLst xmlns:a="http://schemas.openxmlformats.org/drawingml/2006/main">
               <a:ext uri="{FF2B5EF4-FFF2-40B4-BE49-F238E27FC236}">
-                <a16:creationId xmlns:a16="http://schemas.microsoft.com/office/drawing/2014/main" id="{2D948D21-39F2-4CC9-871E-1E09EBEF3419}"/>
+                <a16:creationId xmlns:a16="http://schemas.microsoft.com/office/drawing/2014/main" id="{97536179-4268-45AB-A866-9A899EA13D5B}"/>
               </a:ext>
             </a:extLst>
           </p:cNvPr>
@@ -11336,7 +11336,7 @@
           <p:cNvPr id="7" name="">
             <a:extLst xmlns:a="http://schemas.openxmlformats.org/drawingml/2006/main">
               <a:ext uri="{FF2B5EF4-FFF2-40B4-BE49-F238E27FC236}">
-                <a16:creationId xmlns:a16="http://schemas.microsoft.com/office/drawing/2014/main" id="{55F29E41-8E11-499B-854C-F9DAE8B08490}"/>
+                <a16:creationId xmlns:a16="http://schemas.microsoft.com/office/drawing/2014/main" id="{BE8366B6-4A8D-4C6B-80AA-61872FC9E1D9}"/>
               </a:ext>
             </a:extLst>
           </p:cNvPr>
@@ -11404,7 +11404,7 @@
           <p:cNvPr id="8" name="">
             <a:extLst xmlns:a="http://schemas.openxmlformats.org/drawingml/2006/main">
               <a:ext uri="{FF2B5EF4-FFF2-40B4-BE49-F238E27FC236}">
-                <a16:creationId xmlns:a16="http://schemas.microsoft.com/office/drawing/2014/main" id="{9272AB2D-F7D6-4160-AD15-3A5C306D5ACD}"/>
+                <a16:creationId xmlns:a16="http://schemas.microsoft.com/office/drawing/2014/main" id="{DF8EF74D-1A20-4C5B-AE6E-ED2E0B4C2682}"/>
               </a:ext>
             </a:extLst>
           </p:cNvPr>
@@ -11472,7 +11472,7 @@
           <p:cNvPr id="9" name="">
             <a:extLst xmlns:a="http://schemas.openxmlformats.org/drawingml/2006/main">
               <a:ext uri="{FF2B5EF4-FFF2-40B4-BE49-F238E27FC236}">
-                <a16:creationId xmlns:a16="http://schemas.microsoft.com/office/drawing/2014/main" id="{0C5702D9-DC0D-467A-A788-D2A38496FC29}"/>
+                <a16:creationId xmlns:a16="http://schemas.microsoft.com/office/drawing/2014/main" id="{F77E0414-525E-4A27-A4B8-8C5D87908423}"/>
               </a:ext>
             </a:extLst>
           </p:cNvPr>
@@ -11540,7 +11540,7 @@
           <p:cNvPr id="10" name="">
             <a:extLst xmlns:a="http://schemas.openxmlformats.org/drawingml/2006/main">
               <a:ext uri="{FF2B5EF4-FFF2-40B4-BE49-F238E27FC236}">
-                <a16:creationId xmlns:a16="http://schemas.microsoft.com/office/drawing/2014/main" id="{2BEA2D4F-9AA8-4445-8FFD-1DF8F7E56C42}"/>
+                <a16:creationId xmlns:a16="http://schemas.microsoft.com/office/drawing/2014/main" id="{B4B407DE-021B-4825-ADE7-63FDDBEA972C}"/>
               </a:ext>
             </a:extLst>
           </p:cNvPr>
@@ -11608,7 +11608,7 @@
           <p:cNvPr id="11" name="">
             <a:extLst xmlns:a="http://schemas.openxmlformats.org/drawingml/2006/main">
               <a:ext uri="{FF2B5EF4-FFF2-40B4-BE49-F238E27FC236}">
-                <a16:creationId xmlns:a16="http://schemas.microsoft.com/office/drawing/2014/main" id="{67DD26D5-4364-4847-80A0-47AB9F65BC35}"/>
+                <a16:creationId xmlns:a16="http://schemas.microsoft.com/office/drawing/2014/main" id="{034D38F3-2B5A-4F69-B3B4-ADADF656AC8C}"/>
               </a:ext>
             </a:extLst>
           </p:cNvPr>
@@ -11676,7 +11676,7 @@
           <p:cNvPr id="12" name="">
             <a:extLst xmlns:a="http://schemas.openxmlformats.org/drawingml/2006/main">
               <a:ext uri="{FF2B5EF4-FFF2-40B4-BE49-F238E27FC236}">
-                <a16:creationId xmlns:a16="http://schemas.microsoft.com/office/drawing/2014/main" id="{236EB603-DEB9-4868-B68C-E6D700AC88C4}"/>
+                <a16:creationId xmlns:a16="http://schemas.microsoft.com/office/drawing/2014/main" id="{9F8A5EA7-79D3-4552-90FA-5D9BD24C7E87}"/>
               </a:ext>
             </a:extLst>
           </p:cNvPr>
@@ -11742,7 +11742,7 @@
     </p:spTree>
     <p:extLst>
       <p:ext uri="{BB962C8B-B14F-4D97-AF65-F5344CB8AC3E}">
-        <p14:creationId xmlns:p14="http://schemas.microsoft.com/office/powerpoint/2010/main" val="573968668"/>
+        <p14:creationId xmlns:p14="http://schemas.microsoft.com/office/powerpoint/2010/main" val="1318434696"/>
       </p:ext>
     </p:extLst>
   </p:cSld>
@@ -11773,7 +11773,7 @@
           <p:cNvPr id="7" name="">
             <a:extLst xmlns:a="http://schemas.openxmlformats.org/drawingml/2006/main">
               <a:ext uri="{FF2B5EF4-FFF2-40B4-BE49-F238E27FC236}">
-                <a16:creationId xmlns:a16="http://schemas.microsoft.com/office/drawing/2014/main" id="{7CD0B60F-A94B-4E78-939F-2531D947626F}"/>
+                <a16:creationId xmlns:a16="http://schemas.microsoft.com/office/drawing/2014/main" id="{BA51A858-D4F8-417B-93D2-B46885BE0D5B}"/>
               </a:ext>
             </a:extLst>
           </p:cNvPr>
@@ -11841,7 +11841,7 @@
           <p:cNvPr id="2" name="">
             <a:extLst xmlns:a="http://schemas.openxmlformats.org/drawingml/2006/main">
               <a:ext uri="{FF2B5EF4-FFF2-40B4-BE49-F238E27FC236}">
-                <a16:creationId xmlns:a16="http://schemas.microsoft.com/office/drawing/2014/main" id="{99B51963-06FC-4404-8F12-83B42042355D}"/>
+                <a16:creationId xmlns:a16="http://schemas.microsoft.com/office/drawing/2014/main" id="{B3620DA0-7805-4557-AC22-B218329520C9}"/>
               </a:ext>
             </a:extLst>
           </p:cNvPr>
@@ -11909,7 +11909,7 @@
           <p:cNvPr id="3" name="">
             <a:extLst xmlns:a="http://schemas.openxmlformats.org/drawingml/2006/main">
               <a:ext uri="{FF2B5EF4-FFF2-40B4-BE49-F238E27FC236}">
-                <a16:creationId xmlns:a16="http://schemas.microsoft.com/office/drawing/2014/main" id="{79EAC2D1-08FC-4CD7-9282-6132F3FE8863}"/>
+                <a16:creationId xmlns:a16="http://schemas.microsoft.com/office/drawing/2014/main" id="{18FA4639-84A5-463C-8F1E-E836C4DCD48C}"/>
               </a:ext>
             </a:extLst>
           </p:cNvPr>
@@ -11977,7 +11977,7 @@
           <p:cNvPr id="4" name="">
             <a:extLst xmlns:a="http://schemas.openxmlformats.org/drawingml/2006/main">
               <a:ext uri="{FF2B5EF4-FFF2-40B4-BE49-F238E27FC236}">
-                <a16:creationId xmlns:a16="http://schemas.microsoft.com/office/drawing/2014/main" id="{A2A5E04D-7E7E-4837-B6CB-4E298DFFADCC}"/>
+                <a16:creationId xmlns:a16="http://schemas.microsoft.com/office/drawing/2014/main" id="{D8FE4618-9EFA-4F63-83C7-88381EDE7FD9}"/>
               </a:ext>
             </a:extLst>
           </p:cNvPr>
@@ -12101,7 +12101,7 @@
           <p:cNvPr id="5" name="">
             <a:extLst xmlns:a="http://schemas.openxmlformats.org/drawingml/2006/main">
               <a:ext uri="{FF2B5EF4-FFF2-40B4-BE49-F238E27FC236}">
-                <a16:creationId xmlns:a16="http://schemas.microsoft.com/office/drawing/2014/main" id="{65BA0320-1EF0-43C4-B32C-FF7243C6DA1E}"/>
+                <a16:creationId xmlns:a16="http://schemas.microsoft.com/office/drawing/2014/main" id="{02F6328F-2850-4F29-A6D2-A49A983FC05C}"/>
               </a:ext>
             </a:extLst>
           </p:cNvPr>
@@ -12169,7 +12169,7 @@
           <p:cNvPr id="6" name="">
             <a:extLst xmlns:a="http://schemas.openxmlformats.org/drawingml/2006/main">
               <a:ext uri="{FF2B5EF4-FFF2-40B4-BE49-F238E27FC236}">
-                <a16:creationId xmlns:a16="http://schemas.microsoft.com/office/drawing/2014/main" id="{5AA6F01D-48E1-4486-B624-F8E250FCFF86}"/>
+                <a16:creationId xmlns:a16="http://schemas.microsoft.com/office/drawing/2014/main" id="{53BE7E2E-B67B-4D70-8E8C-1415D26EEDE1}"/>
               </a:ext>
             </a:extLst>
           </p:cNvPr>
@@ -12235,7 +12235,7 @@
     </p:spTree>
     <p:extLst>
       <p:ext uri="{BB962C8B-B14F-4D97-AF65-F5344CB8AC3E}">
-        <p14:creationId xmlns:p14="http://schemas.microsoft.com/office/powerpoint/2010/main" val="396865389"/>
+        <p14:creationId xmlns:p14="http://schemas.microsoft.com/office/powerpoint/2010/main" val="272195121"/>
       </p:ext>
     </p:extLst>
   </p:cSld>
@@ -12266,7 +12266,7 @@
           <p:cNvPr id="13" name="">
             <a:extLst xmlns:a="http://schemas.openxmlformats.org/drawingml/2006/main">
               <a:ext uri="{FF2B5EF4-FFF2-40B4-BE49-F238E27FC236}">
-                <a16:creationId xmlns:a16="http://schemas.microsoft.com/office/drawing/2014/main" id="{A528FE1D-E0A6-4790-984B-2C6EAF26DBFA}"/>
+                <a16:creationId xmlns:a16="http://schemas.microsoft.com/office/drawing/2014/main" id="{620B4E25-8509-4C8A-B67F-4BBB8A2E32E5}"/>
               </a:ext>
             </a:extLst>
           </p:cNvPr>
@@ -12334,7 +12334,7 @@
           <p:cNvPr id="2" name="">
             <a:extLst xmlns:a="http://schemas.openxmlformats.org/drawingml/2006/main">
               <a:ext uri="{FF2B5EF4-FFF2-40B4-BE49-F238E27FC236}">
-                <a16:creationId xmlns:a16="http://schemas.microsoft.com/office/drawing/2014/main" id="{B8E45BEB-388A-436E-B830-C870306263F0}"/>
+                <a16:creationId xmlns:a16="http://schemas.microsoft.com/office/drawing/2014/main" id="{7184CAB3-4FC8-4A02-9B34-83B1038EC88C}"/>
               </a:ext>
             </a:extLst>
           </p:cNvPr>
@@ -12402,7 +12402,7 @@
           <p:cNvPr id="3" name="">
             <a:extLst xmlns:a="http://schemas.openxmlformats.org/drawingml/2006/main">
               <a:ext uri="{FF2B5EF4-FFF2-40B4-BE49-F238E27FC236}">
-                <a16:creationId xmlns:a16="http://schemas.microsoft.com/office/drawing/2014/main" id="{8EC24DB3-E188-4FCE-932A-14E02984E2CC}"/>
+                <a16:creationId xmlns:a16="http://schemas.microsoft.com/office/drawing/2014/main" id="{E527F78E-6459-409D-B353-06700158A39E}"/>
               </a:ext>
             </a:extLst>
           </p:cNvPr>
@@ -12470,7 +12470,7 @@
           <p:cNvPr id="4" name="">
             <a:extLst xmlns:a="http://schemas.openxmlformats.org/drawingml/2006/main">
               <a:ext uri="{FF2B5EF4-FFF2-40B4-BE49-F238E27FC236}">
-                <a16:creationId xmlns:a16="http://schemas.microsoft.com/office/drawing/2014/main" id="{D2D0C013-CF20-4B87-8310-AED92509C975}"/>
+                <a16:creationId xmlns:a16="http://schemas.microsoft.com/office/drawing/2014/main" id="{99EFDA12-35EF-4885-8F9E-735B617FE173}"/>
               </a:ext>
             </a:extLst>
           </p:cNvPr>
@@ -12594,7 +12594,7 @@
           <p:cNvPr id="5" name="">
             <a:extLst xmlns:a="http://schemas.openxmlformats.org/drawingml/2006/main">
               <a:ext uri="{FF2B5EF4-FFF2-40B4-BE49-F238E27FC236}">
-                <a16:creationId xmlns:a16="http://schemas.microsoft.com/office/drawing/2014/main" id="{57EF13A0-82DC-440B-AB6C-F6BC43FB330C}"/>
+                <a16:creationId xmlns:a16="http://schemas.microsoft.com/office/drawing/2014/main" id="{5A034EDA-DADA-4C6F-AE6F-AFCE3A39C096}"/>
               </a:ext>
             </a:extLst>
           </p:cNvPr>
@@ -12662,7 +12662,7 @@
           <p:cNvPr id="6" name="">
             <a:extLst xmlns:a="http://schemas.openxmlformats.org/drawingml/2006/main">
               <a:ext uri="{FF2B5EF4-FFF2-40B4-BE49-F238E27FC236}">
-                <a16:creationId xmlns:a16="http://schemas.microsoft.com/office/drawing/2014/main" id="{9065CE0F-213D-4B98-B1EF-363ED4C1D1FA}"/>
+                <a16:creationId xmlns:a16="http://schemas.microsoft.com/office/drawing/2014/main" id="{41BBB377-DC1A-4275-A06B-C71A9F2A97DF}"/>
               </a:ext>
             </a:extLst>
           </p:cNvPr>
@@ -12730,7 +12730,7 @@
           <p:cNvPr id="7" name="">
             <a:extLst xmlns:a="http://schemas.openxmlformats.org/drawingml/2006/main">
               <a:ext uri="{FF2B5EF4-FFF2-40B4-BE49-F238E27FC236}">
-                <a16:creationId xmlns:a16="http://schemas.microsoft.com/office/drawing/2014/main" id="{A3082520-C9ED-430B-A82B-3E5C93065DA5}"/>
+                <a16:creationId xmlns:a16="http://schemas.microsoft.com/office/drawing/2014/main" id="{A84D3869-A59E-49B0-BE60-9324DF280D3F}"/>
               </a:ext>
             </a:extLst>
           </p:cNvPr>
@@ -12798,7 +12798,7 @@
           <p:cNvPr id="8" name="">
             <a:extLst xmlns:a="http://schemas.openxmlformats.org/drawingml/2006/main">
               <a:ext uri="{FF2B5EF4-FFF2-40B4-BE49-F238E27FC236}">
-                <a16:creationId xmlns:a16="http://schemas.microsoft.com/office/drawing/2014/main" id="{66042313-CC72-462C-9372-3791AE69CD18}"/>
+                <a16:creationId xmlns:a16="http://schemas.microsoft.com/office/drawing/2014/main" id="{5D13C688-DE7A-4172-8D45-28EE69D7ED20}"/>
               </a:ext>
             </a:extLst>
           </p:cNvPr>
@@ -12866,7 +12866,7 @@
           <p:cNvPr id="9" name="">
             <a:extLst xmlns:a="http://schemas.openxmlformats.org/drawingml/2006/main">
               <a:ext uri="{FF2B5EF4-FFF2-40B4-BE49-F238E27FC236}">
-                <a16:creationId xmlns:a16="http://schemas.microsoft.com/office/drawing/2014/main" id="{D95F5ECE-76CD-41DB-9654-88AF30E438EE}"/>
+                <a16:creationId xmlns:a16="http://schemas.microsoft.com/office/drawing/2014/main" id="{E0A02E1A-C968-4612-BDFC-76B0235E74D1}"/>
               </a:ext>
             </a:extLst>
           </p:cNvPr>
@@ -12934,7 +12934,7 @@
           <p:cNvPr id="10" name="">
             <a:extLst xmlns:a="http://schemas.openxmlformats.org/drawingml/2006/main">
               <a:ext uri="{FF2B5EF4-FFF2-40B4-BE49-F238E27FC236}">
-                <a16:creationId xmlns:a16="http://schemas.microsoft.com/office/drawing/2014/main" id="{A9A094F7-67C4-4F65-A144-70880085AF8D}"/>
+                <a16:creationId xmlns:a16="http://schemas.microsoft.com/office/drawing/2014/main" id="{0A5CF926-2EEC-42C8-B059-D60E9BA0E604}"/>
               </a:ext>
             </a:extLst>
           </p:cNvPr>
@@ -13002,7 +13002,7 @@
           <p:cNvPr id="11" name="">
             <a:extLst xmlns:a="http://schemas.openxmlformats.org/drawingml/2006/main">
               <a:ext uri="{FF2B5EF4-FFF2-40B4-BE49-F238E27FC236}">
-                <a16:creationId xmlns:a16="http://schemas.microsoft.com/office/drawing/2014/main" id="{10ED630F-D969-4EE6-89CD-C5DE567F4FE4}"/>
+                <a16:creationId xmlns:a16="http://schemas.microsoft.com/office/drawing/2014/main" id="{B177C3BA-2DD1-42A7-85EC-5F2D844D28D0}"/>
               </a:ext>
             </a:extLst>
           </p:cNvPr>
@@ -13070,7 +13070,7 @@
           <p:cNvPr id="12" name="">
             <a:extLst xmlns:a="http://schemas.openxmlformats.org/drawingml/2006/main">
               <a:ext uri="{FF2B5EF4-FFF2-40B4-BE49-F238E27FC236}">
-                <a16:creationId xmlns:a16="http://schemas.microsoft.com/office/drawing/2014/main" id="{09C626C9-2389-4E86-95AE-5681FC8184B4}"/>
+                <a16:creationId xmlns:a16="http://schemas.microsoft.com/office/drawing/2014/main" id="{9F14B02D-AC3F-4A61-8660-73878780B7B2}"/>
               </a:ext>
             </a:extLst>
           </p:cNvPr>
@@ -13136,7 +13136,7 @@
     </p:spTree>
     <p:extLst>
       <p:ext uri="{BB962C8B-B14F-4D97-AF65-F5344CB8AC3E}">
-        <p14:creationId xmlns:p14="http://schemas.microsoft.com/office/powerpoint/2010/main" val="537550378"/>
+        <p14:creationId xmlns:p14="http://schemas.microsoft.com/office/powerpoint/2010/main" val="1884389725"/>
       </p:ext>
     </p:extLst>
   </p:cSld>
@@ -13167,7 +13167,7 @@
           <p:cNvPr id="11" name="">
             <a:extLst xmlns:a="http://schemas.openxmlformats.org/drawingml/2006/main">
               <a:ext uri="{FF2B5EF4-FFF2-40B4-BE49-F238E27FC236}">
-                <a16:creationId xmlns:a16="http://schemas.microsoft.com/office/drawing/2014/main" id="{F27458BD-D01F-4979-A2D6-7BCDBA8B9D69}"/>
+                <a16:creationId xmlns:a16="http://schemas.microsoft.com/office/drawing/2014/main" id="{3E3A73E6-144E-4F20-AF29-99742B152642}"/>
               </a:ext>
             </a:extLst>
           </p:cNvPr>
@@ -13235,7 +13235,7 @@
           <p:cNvPr id="2" name="">
             <a:extLst xmlns:a="http://schemas.openxmlformats.org/drawingml/2006/main">
               <a:ext uri="{FF2B5EF4-FFF2-40B4-BE49-F238E27FC236}">
-                <a16:creationId xmlns:a16="http://schemas.microsoft.com/office/drawing/2014/main" id="{E3D02E63-0F87-42C6-839D-93C77A3AED87}"/>
+                <a16:creationId xmlns:a16="http://schemas.microsoft.com/office/drawing/2014/main" id="{E21C9F26-11AA-411E-AC36-06AEED4875B3}"/>
               </a:ext>
             </a:extLst>
           </p:cNvPr>
@@ -13303,7 +13303,7 @@
           <p:cNvPr id="3" name="">
             <a:extLst xmlns:a="http://schemas.openxmlformats.org/drawingml/2006/main">
               <a:ext uri="{FF2B5EF4-FFF2-40B4-BE49-F238E27FC236}">
-                <a16:creationId xmlns:a16="http://schemas.microsoft.com/office/drawing/2014/main" id="{83CAD14D-021F-4C92-B749-F67D13A7454B}"/>
+                <a16:creationId xmlns:a16="http://schemas.microsoft.com/office/drawing/2014/main" id="{95934B1B-51AB-4950-94A6-63B20FDB538C}"/>
               </a:ext>
             </a:extLst>
           </p:cNvPr>
@@ -13371,7 +13371,7 @@
           <p:cNvPr id="4" name="">
             <a:extLst xmlns:a="http://schemas.openxmlformats.org/drawingml/2006/main">
               <a:ext uri="{FF2B5EF4-FFF2-40B4-BE49-F238E27FC236}">
-                <a16:creationId xmlns:a16="http://schemas.microsoft.com/office/drawing/2014/main" id="{11BF36DC-AC73-4F67-B340-F0DC655AFB42}"/>
+                <a16:creationId xmlns:a16="http://schemas.microsoft.com/office/drawing/2014/main" id="{F10BA976-1ED2-489D-BEB6-919FE45C0310}"/>
               </a:ext>
             </a:extLst>
           </p:cNvPr>
@@ -13495,7 +13495,7 @@
           <p:cNvPr id="5" name="">
             <a:extLst xmlns:a="http://schemas.openxmlformats.org/drawingml/2006/main">
               <a:ext uri="{FF2B5EF4-FFF2-40B4-BE49-F238E27FC236}">
-                <a16:creationId xmlns:a16="http://schemas.microsoft.com/office/drawing/2014/main" id="{19F4746E-663B-4885-A32D-180035C911CB}"/>
+                <a16:creationId xmlns:a16="http://schemas.microsoft.com/office/drawing/2014/main" id="{478E12BB-CD4B-41CC-8B43-84F96944F8FB}"/>
               </a:ext>
             </a:extLst>
           </p:cNvPr>
@@ -13563,7 +13563,7 @@
           <p:cNvPr id="6" name="">
             <a:extLst xmlns:a="http://schemas.openxmlformats.org/drawingml/2006/main">
               <a:ext uri="{FF2B5EF4-FFF2-40B4-BE49-F238E27FC236}">
-                <a16:creationId xmlns:a16="http://schemas.microsoft.com/office/drawing/2014/main" id="{27F724E1-81D1-4F9E-BF1F-D5696DC24685}"/>
+                <a16:creationId xmlns:a16="http://schemas.microsoft.com/office/drawing/2014/main" id="{A0C77C49-DE46-4FE5-8D4A-F45F0E911C85}"/>
               </a:ext>
             </a:extLst>
           </p:cNvPr>
@@ -13631,7 +13631,7 @@
           <p:cNvPr id="7" name="">
             <a:extLst xmlns:a="http://schemas.openxmlformats.org/drawingml/2006/main">
               <a:ext uri="{FF2B5EF4-FFF2-40B4-BE49-F238E27FC236}">
-                <a16:creationId xmlns:a16="http://schemas.microsoft.com/office/drawing/2014/main" id="{C7E6941A-E6E6-49D4-A06B-978ABAB5B33A}"/>
+                <a16:creationId xmlns:a16="http://schemas.microsoft.com/office/drawing/2014/main" id="{91D6C2CB-E38C-4F60-93F9-583B01B0E284}"/>
               </a:ext>
             </a:extLst>
           </p:cNvPr>
@@ -13699,7 +13699,7 @@
           <p:cNvPr id="8" name="">
             <a:extLst xmlns:a="http://schemas.openxmlformats.org/drawingml/2006/main">
               <a:ext uri="{FF2B5EF4-FFF2-40B4-BE49-F238E27FC236}">
-                <a16:creationId xmlns:a16="http://schemas.microsoft.com/office/drawing/2014/main" id="{715DF19D-B54C-4B18-813B-C75AD30F548D}"/>
+                <a16:creationId xmlns:a16="http://schemas.microsoft.com/office/drawing/2014/main" id="{7CC2ED0B-610C-4FCE-B408-0CC0533C4E3C}"/>
               </a:ext>
             </a:extLst>
           </p:cNvPr>
@@ -13767,7 +13767,7 @@
           <p:cNvPr id="9" name="">
             <a:extLst xmlns:a="http://schemas.openxmlformats.org/drawingml/2006/main">
               <a:ext uri="{FF2B5EF4-FFF2-40B4-BE49-F238E27FC236}">
-                <a16:creationId xmlns:a16="http://schemas.microsoft.com/office/drawing/2014/main" id="{14A87FDB-ACC5-4723-8D60-23B12B0A09EC}"/>
+                <a16:creationId xmlns:a16="http://schemas.microsoft.com/office/drawing/2014/main" id="{E5F68A65-CE0F-4FD6-96DA-C0C3B96EA1E2}"/>
               </a:ext>
             </a:extLst>
           </p:cNvPr>
@@ -13835,7 +13835,7 @@
           <p:cNvPr id="10" name="">
             <a:extLst xmlns:a="http://schemas.openxmlformats.org/drawingml/2006/main">
               <a:ext uri="{FF2B5EF4-FFF2-40B4-BE49-F238E27FC236}">
-                <a16:creationId xmlns:a16="http://schemas.microsoft.com/office/drawing/2014/main" id="{657ED430-36A9-4AD6-A041-6281DEF73AAD}"/>
+                <a16:creationId xmlns:a16="http://schemas.microsoft.com/office/drawing/2014/main" id="{95CBD2F6-10D2-458B-BD67-411C65600D10}"/>
               </a:ext>
             </a:extLst>
           </p:cNvPr>
@@ -13901,7 +13901,7 @@
     </p:spTree>
     <p:extLst>
       <p:ext uri="{BB962C8B-B14F-4D97-AF65-F5344CB8AC3E}">
-        <p14:creationId xmlns:p14="http://schemas.microsoft.com/office/powerpoint/2010/main" val="128137568"/>
+        <p14:creationId xmlns:p14="http://schemas.microsoft.com/office/powerpoint/2010/main" val="1481213039"/>
       </p:ext>
     </p:extLst>
   </p:cSld>
@@ -13932,7 +13932,7 @@
           <p:cNvPr id="11" name="">
             <a:extLst xmlns:a="http://schemas.openxmlformats.org/drawingml/2006/main">
               <a:ext uri="{FF2B5EF4-FFF2-40B4-BE49-F238E27FC236}">
-                <a16:creationId xmlns:a16="http://schemas.microsoft.com/office/drawing/2014/main" id="{FBA538C5-90B5-48B4-BDAB-11E7A275BA23}"/>
+                <a16:creationId xmlns:a16="http://schemas.microsoft.com/office/drawing/2014/main" id="{BCD30695-78C6-4E22-A738-E15DD3CBE257}"/>
               </a:ext>
             </a:extLst>
           </p:cNvPr>
@@ -14000,7 +14000,7 @@
           <p:cNvPr id="2" name="">
             <a:extLst xmlns:a="http://schemas.openxmlformats.org/drawingml/2006/main">
               <a:ext uri="{FF2B5EF4-FFF2-40B4-BE49-F238E27FC236}">
-                <a16:creationId xmlns:a16="http://schemas.microsoft.com/office/drawing/2014/main" id="{DBC8B3BB-4F44-49E1-94E4-FFF76FFC9812}"/>
+                <a16:creationId xmlns:a16="http://schemas.microsoft.com/office/drawing/2014/main" id="{C0CA073E-4944-4C82-A4A0-BD1C52021888}"/>
               </a:ext>
             </a:extLst>
           </p:cNvPr>
@@ -14068,7 +14068,7 @@
           <p:cNvPr id="3" name="">
             <a:extLst xmlns:a="http://schemas.openxmlformats.org/drawingml/2006/main">
               <a:ext uri="{FF2B5EF4-FFF2-40B4-BE49-F238E27FC236}">
-                <a16:creationId xmlns:a16="http://schemas.microsoft.com/office/drawing/2014/main" id="{E6074176-76AF-4B39-85AC-A15784E0F3E9}"/>
+                <a16:creationId xmlns:a16="http://schemas.microsoft.com/office/drawing/2014/main" id="{C2B324A0-103B-4A30-B2DD-43D1CCF5A11E}"/>
               </a:ext>
             </a:extLst>
           </p:cNvPr>
@@ -14136,7 +14136,7 @@
           <p:cNvPr id="4" name="">
             <a:extLst xmlns:a="http://schemas.openxmlformats.org/drawingml/2006/main">
               <a:ext uri="{FF2B5EF4-FFF2-40B4-BE49-F238E27FC236}">
-                <a16:creationId xmlns:a16="http://schemas.microsoft.com/office/drawing/2014/main" id="{E88D7399-7641-4B9E-968D-0876343923D6}"/>
+                <a16:creationId xmlns:a16="http://schemas.microsoft.com/office/drawing/2014/main" id="{E416F339-6DA5-4091-A668-4FFB388C937D}"/>
               </a:ext>
             </a:extLst>
           </p:cNvPr>
@@ -14260,7 +14260,7 @@
           <p:cNvPr id="5" name="">
             <a:extLst xmlns:a="http://schemas.openxmlformats.org/drawingml/2006/main">
               <a:ext uri="{FF2B5EF4-FFF2-40B4-BE49-F238E27FC236}">
-                <a16:creationId xmlns:a16="http://schemas.microsoft.com/office/drawing/2014/main" id="{EFE1CBFB-FAD5-4B2E-9F81-2461F91DD529}"/>
+                <a16:creationId xmlns:a16="http://schemas.microsoft.com/office/drawing/2014/main" id="{2018E319-1667-4058-8B55-97CB19EF8574}"/>
               </a:ext>
             </a:extLst>
           </p:cNvPr>
@@ -14328,7 +14328,7 @@
           <p:cNvPr id="6" name="">
             <a:extLst xmlns:a="http://schemas.openxmlformats.org/drawingml/2006/main">
               <a:ext uri="{FF2B5EF4-FFF2-40B4-BE49-F238E27FC236}">
-                <a16:creationId xmlns:a16="http://schemas.microsoft.com/office/drawing/2014/main" id="{2B09A0C4-0DBA-4D46-BC11-6891FB89B44E}"/>
+                <a16:creationId xmlns:a16="http://schemas.microsoft.com/office/drawing/2014/main" id="{AF8B15D9-1C3B-4402-9566-16184D736655}"/>
               </a:ext>
             </a:extLst>
           </p:cNvPr>
@@ -14396,7 +14396,7 @@
           <p:cNvPr id="7" name="">
             <a:extLst xmlns:a="http://schemas.openxmlformats.org/drawingml/2006/main">
               <a:ext uri="{FF2B5EF4-FFF2-40B4-BE49-F238E27FC236}">
-                <a16:creationId xmlns:a16="http://schemas.microsoft.com/office/drawing/2014/main" id="{C891C75C-28AB-48C7-81CA-F6EEAA03D563}"/>
+                <a16:creationId xmlns:a16="http://schemas.microsoft.com/office/drawing/2014/main" id="{0EEEBEB7-5995-4D3E-9750-AC592CE6CF99}"/>
               </a:ext>
             </a:extLst>
           </p:cNvPr>
@@ -14464,7 +14464,7 @@
           <p:cNvPr id="8" name="">
             <a:extLst xmlns:a="http://schemas.openxmlformats.org/drawingml/2006/main">
               <a:ext uri="{FF2B5EF4-FFF2-40B4-BE49-F238E27FC236}">
-                <a16:creationId xmlns:a16="http://schemas.microsoft.com/office/drawing/2014/main" id="{C021A7F5-EFB2-42D9-888C-040F068A128C}"/>
+                <a16:creationId xmlns:a16="http://schemas.microsoft.com/office/drawing/2014/main" id="{E99D5FDB-2C8D-4CEB-9FE6-B06610760F76}"/>
               </a:ext>
             </a:extLst>
           </p:cNvPr>
@@ -14532,7 +14532,7 @@
           <p:cNvPr id="9" name="">
             <a:extLst xmlns:a="http://schemas.openxmlformats.org/drawingml/2006/main">
               <a:ext uri="{FF2B5EF4-FFF2-40B4-BE49-F238E27FC236}">
-                <a16:creationId xmlns:a16="http://schemas.microsoft.com/office/drawing/2014/main" id="{39691B9D-C3BB-41F1-9EAB-88F3D104D277}"/>
+                <a16:creationId xmlns:a16="http://schemas.microsoft.com/office/drawing/2014/main" id="{79A55C15-02EE-4B40-93F9-3CF48C4AEF57}"/>
               </a:ext>
             </a:extLst>
           </p:cNvPr>
@@ -14600,7 +14600,7 @@
           <p:cNvPr id="10" name="">
             <a:extLst xmlns:a="http://schemas.openxmlformats.org/drawingml/2006/main">
               <a:ext uri="{FF2B5EF4-FFF2-40B4-BE49-F238E27FC236}">
-                <a16:creationId xmlns:a16="http://schemas.microsoft.com/office/drawing/2014/main" id="{D81FA325-95D1-4B49-96BA-4D7BCD640C90}"/>
+                <a16:creationId xmlns:a16="http://schemas.microsoft.com/office/drawing/2014/main" id="{0A9E46DA-66DE-473F-A099-486F33911204}"/>
               </a:ext>
             </a:extLst>
           </p:cNvPr>
@@ -14666,7 +14666,7 @@
     </p:spTree>
     <p:extLst>
       <p:ext uri="{BB962C8B-B14F-4D97-AF65-F5344CB8AC3E}">
-        <p14:creationId xmlns:p14="http://schemas.microsoft.com/office/powerpoint/2010/main" val="105979203"/>
+        <p14:creationId xmlns:p14="http://schemas.microsoft.com/office/powerpoint/2010/main" val="1092042961"/>
       </p:ext>
     </p:extLst>
   </p:cSld>
@@ -14697,7 +14697,7 @@
           <p:cNvPr id="8" name="">
             <a:extLst xmlns:a="http://schemas.openxmlformats.org/drawingml/2006/main">
               <a:ext uri="{FF2B5EF4-FFF2-40B4-BE49-F238E27FC236}">
-                <a16:creationId xmlns:a16="http://schemas.microsoft.com/office/drawing/2014/main" id="{D845239A-D8E3-4435-8D4B-51C0B09B97D0}"/>
+                <a16:creationId xmlns:a16="http://schemas.microsoft.com/office/drawing/2014/main" id="{F204EF40-323F-4F13-87B7-FF9C0CF5B5B8}"/>
               </a:ext>
             </a:extLst>
           </p:cNvPr>
@@ -14765,7 +14765,7 @@
           <p:cNvPr id="2" name="">
             <a:extLst xmlns:a="http://schemas.openxmlformats.org/drawingml/2006/main">
               <a:ext uri="{FF2B5EF4-FFF2-40B4-BE49-F238E27FC236}">
-                <a16:creationId xmlns:a16="http://schemas.microsoft.com/office/drawing/2014/main" id="{49DFC1E0-69CB-4BAE-BF04-DE6ACC64E4C7}"/>
+                <a16:creationId xmlns:a16="http://schemas.microsoft.com/office/drawing/2014/main" id="{372E59BE-AC17-421F-9DFA-D9EBB98A9794}"/>
               </a:ext>
             </a:extLst>
           </p:cNvPr>
@@ -14833,7 +14833,7 @@
           <p:cNvPr id="3" name="">
             <a:extLst xmlns:a="http://schemas.openxmlformats.org/drawingml/2006/main">
               <a:ext uri="{FF2B5EF4-FFF2-40B4-BE49-F238E27FC236}">
-                <a16:creationId xmlns:a16="http://schemas.microsoft.com/office/drawing/2014/main" id="{D08A4D66-9314-40D4-834A-1F4DED2F4119}"/>
+                <a16:creationId xmlns:a16="http://schemas.microsoft.com/office/drawing/2014/main" id="{53EEB264-84F3-48FA-B1C2-372DA88F94AF}"/>
               </a:ext>
             </a:extLst>
           </p:cNvPr>
@@ -14901,7 +14901,7 @@
           <p:cNvPr id="4" name="">
             <a:extLst xmlns:a="http://schemas.openxmlformats.org/drawingml/2006/main">
               <a:ext uri="{FF2B5EF4-FFF2-40B4-BE49-F238E27FC236}">
-                <a16:creationId xmlns:a16="http://schemas.microsoft.com/office/drawing/2014/main" id="{1BC7EE7D-FCFA-42A5-9A33-B4EA0A631A60}"/>
+                <a16:creationId xmlns:a16="http://schemas.microsoft.com/office/drawing/2014/main" id="{07C58342-6F7E-4717-9764-76073DE680D6}"/>
               </a:ext>
             </a:extLst>
           </p:cNvPr>
@@ -15323,7 +15323,7 @@
           <p:cNvPr id="5" name="">
             <a:extLst xmlns:a="http://schemas.openxmlformats.org/drawingml/2006/main">
               <a:ext uri="{FF2B5EF4-FFF2-40B4-BE49-F238E27FC236}">
-                <a16:creationId xmlns:a16="http://schemas.microsoft.com/office/drawing/2014/main" id="{64E444CD-8241-4CEB-AAB4-493ED6328A21}"/>
+                <a16:creationId xmlns:a16="http://schemas.microsoft.com/office/drawing/2014/main" id="{10332312-62BE-48C9-A05F-3C89D2E2D062}"/>
               </a:ext>
             </a:extLst>
           </p:cNvPr>
@@ -15391,7 +15391,7 @@
           <p:cNvPr id="6" name="">
             <a:extLst xmlns:a="http://schemas.openxmlformats.org/drawingml/2006/main">
               <a:ext uri="{FF2B5EF4-FFF2-40B4-BE49-F238E27FC236}">
-                <a16:creationId xmlns:a16="http://schemas.microsoft.com/office/drawing/2014/main" id="{ECD56AB4-33A4-4E1E-B48A-34D634B2EC41}"/>
+                <a16:creationId xmlns:a16="http://schemas.microsoft.com/office/drawing/2014/main" id="{7AF993A9-5121-4A28-8C49-0DF3B438D825}"/>
               </a:ext>
             </a:extLst>
           </p:cNvPr>
@@ -15459,7 +15459,7 @@
           <p:cNvPr id="7" name="">
             <a:extLst xmlns:a="http://schemas.openxmlformats.org/drawingml/2006/main">
               <a:ext uri="{FF2B5EF4-FFF2-40B4-BE49-F238E27FC236}">
-                <a16:creationId xmlns:a16="http://schemas.microsoft.com/office/drawing/2014/main" id="{517807CC-AF0A-45F9-B828-3D0512547EE3}"/>
+                <a16:creationId xmlns:a16="http://schemas.microsoft.com/office/drawing/2014/main" id="{0CDFAE51-3469-4D38-B444-029918A23CC8}"/>
               </a:ext>
             </a:extLst>
           </p:cNvPr>
@@ -15525,7 +15525,7 @@
     </p:spTree>
     <p:extLst>
       <p:ext uri="{BB962C8B-B14F-4D97-AF65-F5344CB8AC3E}">
-        <p14:creationId xmlns:p14="http://schemas.microsoft.com/office/powerpoint/2010/main" val="1205300107"/>
+        <p14:creationId xmlns:p14="http://schemas.microsoft.com/office/powerpoint/2010/main" val="1572109705"/>
       </p:ext>
     </p:extLst>
   </p:cSld>

</xml_diff>

<commit_message>
Fit week 5 lab into 90 minutes and limit QR check-in to 60 seconds (#51)
</commit_message>
<xml_diff>
--- a/lendet/2026-2027/mobile/lectures/ligjerata-05-hyrja-lejet-rideshare-2026.pptx
+++ b/lendet/2026-2027/mobile/lectures/ligjerata-05-hyrja-lejet-rideshare-2026.pptx
@@ -2,29 +2,29 @@
 <file path=ppt/presentation.xml><?xml version="1.0" encoding="utf-8"?>
 <p:presentation xmlns:p="http://schemas.openxmlformats.org/presentationml/2006/main">
   <p:sldMasterIdLst>
-    <p:sldMasterId xmlns:r="http://schemas.openxmlformats.org/officeDocument/2006/relationships" id="2147483648" r:id="Re6c0461688854029"/>
+    <p:sldMasterId xmlns:r="http://schemas.openxmlformats.org/officeDocument/2006/relationships" id="2147483648" r:id="Rd2249f5c8f5045fd"/>
   </p:sldMasterIdLst>
   <p:sldIdLst>
-    <p:sldId xmlns:r="http://schemas.openxmlformats.org/officeDocument/2006/relationships" id="256" r:id="R07da8900fdbd436d"/>
-    <p:sldId xmlns:r="http://schemas.openxmlformats.org/officeDocument/2006/relationships" id="257" r:id="R9affa4b292c34e47"/>
-    <p:sldId xmlns:r="http://schemas.openxmlformats.org/officeDocument/2006/relationships" id="258" r:id="R028e769b095d458d"/>
-    <p:sldId xmlns:r="http://schemas.openxmlformats.org/officeDocument/2006/relationships" id="259" r:id="Rb2fa812846094158"/>
-    <p:sldId xmlns:r="http://schemas.openxmlformats.org/officeDocument/2006/relationships" id="260" r:id="R96f5cfe992d44a52"/>
-    <p:sldId xmlns:r="http://schemas.openxmlformats.org/officeDocument/2006/relationships" id="261" r:id="R367f7d4167dc4299"/>
-    <p:sldId xmlns:r="http://schemas.openxmlformats.org/officeDocument/2006/relationships" id="262" r:id="Rfc6f0dc542c84f00"/>
-    <p:sldId xmlns:r="http://schemas.openxmlformats.org/officeDocument/2006/relationships" id="263" r:id="R5bb25875755d4a37"/>
-    <p:sldId xmlns:r="http://schemas.openxmlformats.org/officeDocument/2006/relationships" id="264" r:id="Rd259049c2c91400f"/>
-    <p:sldId xmlns:r="http://schemas.openxmlformats.org/officeDocument/2006/relationships" id="265" r:id="Rfec50c535a0a438b"/>
-    <p:sldId xmlns:r="http://schemas.openxmlformats.org/officeDocument/2006/relationships" id="266" r:id="R1278c3d84c40424e"/>
-    <p:sldId xmlns:r="http://schemas.openxmlformats.org/officeDocument/2006/relationships" id="267" r:id="R7da3158362434e8d"/>
-    <p:sldId xmlns:r="http://schemas.openxmlformats.org/officeDocument/2006/relationships" id="268" r:id="R93ed994579ff41a6"/>
-    <p:sldId xmlns:r="http://schemas.openxmlformats.org/officeDocument/2006/relationships" id="269" r:id="Rde186ae04867440b"/>
-    <p:sldId xmlns:r="http://schemas.openxmlformats.org/officeDocument/2006/relationships" id="270" r:id="R6e587f706f874a62"/>
-    <p:sldId xmlns:r="http://schemas.openxmlformats.org/officeDocument/2006/relationships" id="271" r:id="R1280b6c64a334d69"/>
-    <p:sldId xmlns:r="http://schemas.openxmlformats.org/officeDocument/2006/relationships" id="272" r:id="R88a714e39eba41ab"/>
-    <p:sldId xmlns:r="http://schemas.openxmlformats.org/officeDocument/2006/relationships" id="273" r:id="Rd5e52cb76bf74398"/>
-    <p:sldId xmlns:r="http://schemas.openxmlformats.org/officeDocument/2006/relationships" id="274" r:id="Rb7dbde05e3c0454e"/>
-    <p:sldId xmlns:r="http://schemas.openxmlformats.org/officeDocument/2006/relationships" id="275" r:id="R68851af7ea964f0d"/>
+    <p:sldId xmlns:r="http://schemas.openxmlformats.org/officeDocument/2006/relationships" id="256" r:id="Rb32bafd86f3b4d99"/>
+    <p:sldId xmlns:r="http://schemas.openxmlformats.org/officeDocument/2006/relationships" id="257" r:id="Rc836b2b09e014b0e"/>
+    <p:sldId xmlns:r="http://schemas.openxmlformats.org/officeDocument/2006/relationships" id="258" r:id="R45d3643ca76c4aff"/>
+    <p:sldId xmlns:r="http://schemas.openxmlformats.org/officeDocument/2006/relationships" id="259" r:id="R15daa455807a450a"/>
+    <p:sldId xmlns:r="http://schemas.openxmlformats.org/officeDocument/2006/relationships" id="260" r:id="Re067d31cf23e4203"/>
+    <p:sldId xmlns:r="http://schemas.openxmlformats.org/officeDocument/2006/relationships" id="261" r:id="Ra153e502984345b0"/>
+    <p:sldId xmlns:r="http://schemas.openxmlformats.org/officeDocument/2006/relationships" id="262" r:id="R7606ab05393b4653"/>
+    <p:sldId xmlns:r="http://schemas.openxmlformats.org/officeDocument/2006/relationships" id="263" r:id="Rbc938c25c9ce4f2c"/>
+    <p:sldId xmlns:r="http://schemas.openxmlformats.org/officeDocument/2006/relationships" id="264" r:id="R80bcb2a9d07b4701"/>
+    <p:sldId xmlns:r="http://schemas.openxmlformats.org/officeDocument/2006/relationships" id="265" r:id="R0eaba9ec2de44eff"/>
+    <p:sldId xmlns:r="http://schemas.openxmlformats.org/officeDocument/2006/relationships" id="266" r:id="R87ec5e3bab6c475b"/>
+    <p:sldId xmlns:r="http://schemas.openxmlformats.org/officeDocument/2006/relationships" id="267" r:id="R3fab61f2869a452d"/>
+    <p:sldId xmlns:r="http://schemas.openxmlformats.org/officeDocument/2006/relationships" id="268" r:id="R70ae99f373c1465f"/>
+    <p:sldId xmlns:r="http://schemas.openxmlformats.org/officeDocument/2006/relationships" id="269" r:id="Red9406ccb8164ae8"/>
+    <p:sldId xmlns:r="http://schemas.openxmlformats.org/officeDocument/2006/relationships" id="270" r:id="Rdc473cf2349a436a"/>
+    <p:sldId xmlns:r="http://schemas.openxmlformats.org/officeDocument/2006/relationships" id="271" r:id="R92a80840a2e94767"/>
+    <p:sldId xmlns:r="http://schemas.openxmlformats.org/officeDocument/2006/relationships" id="272" r:id="R98ce78c9b42f4186"/>
+    <p:sldId xmlns:r="http://schemas.openxmlformats.org/officeDocument/2006/relationships" id="273" r:id="Reaa10e639dfa4b6f"/>
+    <p:sldId xmlns:r="http://schemas.openxmlformats.org/officeDocument/2006/relationships" id="274" r:id="R3060c776e1c74c02"/>
+    <p:sldId xmlns:r="http://schemas.openxmlformats.org/officeDocument/2006/relationships" id="275" r:id="R6ae58fb2072d4142"/>
   </p:sldIdLst>
   <p:sldSz cx="12192000" cy="6858000"/>
   <p:notesSz cx="6858000" cy="9144000"/>
@@ -48,7 +48,7 @@
           <p:cNvPr id="3" name="Title">
             <a:extLst xmlns:a="http://schemas.openxmlformats.org/drawingml/2006/main">
               <a:ext uri="{FF2B5EF4-FFF2-40B4-BE49-F238E27FC236}">
-                <a16:creationId xmlns:a16="http://schemas.microsoft.com/office/drawing/2014/main" id="{29B51D88-EED4-45C6-B81C-0393C6A51168}"/>
+                <a16:creationId xmlns:a16="http://schemas.microsoft.com/office/drawing/2014/main" id="{73452BA2-1E5D-4CEB-ADBB-7E3FEBF1620C}"/>
               </a:ext>
             </a:extLst>
           </p:cNvPr>
@@ -205,7 +205,7 @@
           <p:cNvPr id="2" name="Subtitle">
             <a:extLst xmlns:a="http://schemas.openxmlformats.org/drawingml/2006/main">
               <a:ext uri="{FF2B5EF4-FFF2-40B4-BE49-F238E27FC236}">
-                <a16:creationId xmlns:a16="http://schemas.microsoft.com/office/drawing/2014/main" id="{408FCA49-D2E2-43A3-A188-15A256324869}"/>
+                <a16:creationId xmlns:a16="http://schemas.microsoft.com/office/drawing/2014/main" id="{1AA6D0F0-C4FE-42EA-9AC2-38BCF3772807}"/>
               </a:ext>
             </a:extLst>
           </p:cNvPr>
@@ -379,7 +379,7 @@
           <p:cNvPr id="2" name="Section title">
             <a:extLst xmlns:a="http://schemas.openxmlformats.org/drawingml/2006/main">
               <a:ext uri="{FF2B5EF4-FFF2-40B4-BE49-F238E27FC236}">
-                <a16:creationId xmlns:a16="http://schemas.microsoft.com/office/drawing/2014/main" id="{74B70489-5E4C-4922-85E4-0E590D405378}"/>
+                <a16:creationId xmlns:a16="http://schemas.microsoft.com/office/drawing/2014/main" id="{19E1F7D3-5D0F-4915-9D40-FF40B2CA1DBF}"/>
               </a:ext>
             </a:extLst>
           </p:cNvPr>
@@ -553,7 +553,7 @@
           <p:cNvPr id="3" name="Title">
             <a:extLst xmlns:a="http://schemas.openxmlformats.org/drawingml/2006/main">
               <a:ext uri="{FF2B5EF4-FFF2-40B4-BE49-F238E27FC236}">
-                <a16:creationId xmlns:a16="http://schemas.microsoft.com/office/drawing/2014/main" id="{5D9DB8E1-FBE8-45E2-A9AE-C2EA4A3B20D8}"/>
+                <a16:creationId xmlns:a16="http://schemas.microsoft.com/office/drawing/2014/main" id="{3D531294-A85A-4D95-9ABA-0FF90424B89C}"/>
               </a:ext>
             </a:extLst>
           </p:cNvPr>
@@ -710,7 +710,7 @@
           <p:cNvPr id="2" name="Body">
             <a:extLst xmlns:a="http://schemas.openxmlformats.org/drawingml/2006/main">
               <a:ext uri="{FF2B5EF4-FFF2-40B4-BE49-F238E27FC236}">
-                <a16:creationId xmlns:a16="http://schemas.microsoft.com/office/drawing/2014/main" id="{C35BB0BA-036D-485C-B418-8ED25506B259}"/>
+                <a16:creationId xmlns:a16="http://schemas.microsoft.com/office/drawing/2014/main" id="{CA7AC7B1-DAD5-4882-8B17-7FBDB404ADF4}"/>
               </a:ext>
             </a:extLst>
           </p:cNvPr>
@@ -884,7 +884,7 @@
           <p:cNvPr id="4" name="Title">
             <a:extLst xmlns:a="http://schemas.openxmlformats.org/drawingml/2006/main">
               <a:ext uri="{FF2B5EF4-FFF2-40B4-BE49-F238E27FC236}">
-                <a16:creationId xmlns:a16="http://schemas.microsoft.com/office/drawing/2014/main" id="{C5A7F206-87B0-4110-A32D-FC039F09F26D}"/>
+                <a16:creationId xmlns:a16="http://schemas.microsoft.com/office/drawing/2014/main" id="{ABDEAE51-7053-42C2-B937-DFC62DF934EA}"/>
               </a:ext>
             </a:extLst>
           </p:cNvPr>
@@ -1041,7 +1041,7 @@
           <p:cNvPr id="2" name="Left column">
             <a:extLst xmlns:a="http://schemas.openxmlformats.org/drawingml/2006/main">
               <a:ext uri="{FF2B5EF4-FFF2-40B4-BE49-F238E27FC236}">
-                <a16:creationId xmlns:a16="http://schemas.microsoft.com/office/drawing/2014/main" id="{C11BCAFC-2FB1-4042-8C3B-BCF07742B16F}"/>
+                <a16:creationId xmlns:a16="http://schemas.microsoft.com/office/drawing/2014/main" id="{583D5AE6-63D9-406F-8209-E8C0608DD774}"/>
               </a:ext>
             </a:extLst>
           </p:cNvPr>
@@ -1198,7 +1198,7 @@
           <p:cNvPr id="3" name="Right column">
             <a:extLst xmlns:a="http://schemas.openxmlformats.org/drawingml/2006/main">
               <a:ext uri="{FF2B5EF4-FFF2-40B4-BE49-F238E27FC236}">
-                <a16:creationId xmlns:a16="http://schemas.microsoft.com/office/drawing/2014/main" id="{F0D058A2-5EB0-4D0D-BC6A-75F455BD1010}"/>
+                <a16:creationId xmlns:a16="http://schemas.microsoft.com/office/drawing/2014/main" id="{652B1E9F-C45A-4CE8-8DFC-48A169655D6B}"/>
               </a:ext>
             </a:extLst>
           </p:cNvPr>
@@ -1372,7 +1372,7 @@
           <p:cNvPr id="3" name="Title">
             <a:extLst xmlns:a="http://schemas.openxmlformats.org/drawingml/2006/main">
               <a:ext uri="{FF2B5EF4-FFF2-40B4-BE49-F238E27FC236}">
-                <a16:creationId xmlns:a16="http://schemas.microsoft.com/office/drawing/2014/main" id="{3DDDB6B8-6E1B-436D-8C71-E75B5B4B1C13}"/>
+                <a16:creationId xmlns:a16="http://schemas.microsoft.com/office/drawing/2014/main" id="{28E1A03F-6DF2-416E-9F1A-81655E69A1F8}"/>
               </a:ext>
             </a:extLst>
           </p:cNvPr>
@@ -1529,7 +1529,7 @@
           <p:cNvPr id="2" name="Left column">
             <a:extLst xmlns:a="http://schemas.openxmlformats.org/drawingml/2006/main">
               <a:ext uri="{FF2B5EF4-FFF2-40B4-BE49-F238E27FC236}">
-                <a16:creationId xmlns:a16="http://schemas.microsoft.com/office/drawing/2014/main" id="{58DE0553-1398-4F53-854E-378733AD6EA9}"/>
+                <a16:creationId xmlns:a16="http://schemas.microsoft.com/office/drawing/2014/main" id="{6E1A128D-382F-48BB-8170-4D23C8127B95}"/>
               </a:ext>
             </a:extLst>
           </p:cNvPr>
@@ -1724,12 +1724,12 @@
   </p:cSld>
   <p:clrMap bg1="lt1" tx1="dk1" bg2="lt2" tx2="dk2" accent1="accent1" accent2="accent2" accent3="accent3" accent4="accent4" accent5="accent5" accent6="accent6" hlink="hlink" folHlink="folHlink"/>
   <p:sldLayoutIdLst>
-    <p:sldLayoutId xmlns:r="http://schemas.openxmlformats.org/officeDocument/2006/relationships" id="2147483649" r:id="R988b826a36d14ac5"/>
-    <p:sldLayoutId xmlns:r="http://schemas.openxmlformats.org/officeDocument/2006/relationships" id="2147483650" r:id="R911df8b2aeb047c7"/>
-    <p:sldLayoutId xmlns:r="http://schemas.openxmlformats.org/officeDocument/2006/relationships" id="2147483651" r:id="R69ee2c8a129f4983"/>
-    <p:sldLayoutId xmlns:r="http://schemas.openxmlformats.org/officeDocument/2006/relationships" id="2147483652" r:id="R01c46ec46d8d4845"/>
-    <p:sldLayoutId xmlns:r="http://schemas.openxmlformats.org/officeDocument/2006/relationships" id="2147483653" r:id="R0f3c48cf3e004c6a"/>
-    <p:sldLayoutId xmlns:r="http://schemas.openxmlformats.org/officeDocument/2006/relationships" id="2147483654" r:id="R39437dc9bb0448c4"/>
+    <p:sldLayoutId xmlns:r="http://schemas.openxmlformats.org/officeDocument/2006/relationships" id="2147483649" r:id="R9814ff39a8864072"/>
+    <p:sldLayoutId xmlns:r="http://schemas.openxmlformats.org/officeDocument/2006/relationships" id="2147483650" r:id="R55091ff2d72144aa"/>
+    <p:sldLayoutId xmlns:r="http://schemas.openxmlformats.org/officeDocument/2006/relationships" id="2147483651" r:id="R04c61c24105b44d1"/>
+    <p:sldLayoutId xmlns:r="http://schemas.openxmlformats.org/officeDocument/2006/relationships" id="2147483652" r:id="R9db5b7ae381e4ad5"/>
+    <p:sldLayoutId xmlns:r="http://schemas.openxmlformats.org/officeDocument/2006/relationships" id="2147483653" r:id="R89aa0603cf4a4433"/>
+    <p:sldLayoutId xmlns:r="http://schemas.openxmlformats.org/officeDocument/2006/relationships" id="2147483654" r:id="R94e6f2e34bfe494c"/>
   </p:sldLayoutIdLst>
   <p:txStyles>
     <p:titleStyle>
@@ -2280,7 +2280,7 @@
           <p:cNvPr id="9" name="">
             <a:extLst xmlns:a="http://schemas.openxmlformats.org/drawingml/2006/main">
               <a:ext uri="{FF2B5EF4-FFF2-40B4-BE49-F238E27FC236}">
-                <a16:creationId xmlns:a16="http://schemas.microsoft.com/office/drawing/2014/main" id="{B5638046-A4F6-48B3-8713-4D2DC4C1E533}"/>
+                <a16:creationId xmlns:a16="http://schemas.microsoft.com/office/drawing/2014/main" id="{11E91AA9-8DED-4B3A-A35E-04F4AE2D0A4D}"/>
               </a:ext>
             </a:extLst>
           </p:cNvPr>
@@ -2348,7 +2348,7 @@
           <p:cNvPr id="2" name="">
             <a:extLst xmlns:a="http://schemas.openxmlformats.org/drawingml/2006/main">
               <a:ext uri="{FF2B5EF4-FFF2-40B4-BE49-F238E27FC236}">
-                <a16:creationId xmlns:a16="http://schemas.microsoft.com/office/drawing/2014/main" id="{E6B150A4-5CEA-4BEC-96EC-1E0163391DF4}"/>
+                <a16:creationId xmlns:a16="http://schemas.microsoft.com/office/drawing/2014/main" id="{38BF6656-E6DD-4AE2-8DEF-CB535D4FC22A}"/>
               </a:ext>
             </a:extLst>
           </p:cNvPr>
@@ -2416,7 +2416,7 @@
           <p:cNvPr id="3" name="">
             <a:extLst xmlns:a="http://schemas.openxmlformats.org/drawingml/2006/main">
               <a:ext uri="{FF2B5EF4-FFF2-40B4-BE49-F238E27FC236}">
-                <a16:creationId xmlns:a16="http://schemas.microsoft.com/office/drawing/2014/main" id="{DF84C3EE-B2B1-406A-B8D3-82658FEACC6A}"/>
+                <a16:creationId xmlns:a16="http://schemas.microsoft.com/office/drawing/2014/main" id="{695D46DE-821A-4F47-B0D4-8BCB1E8CCEC3}"/>
               </a:ext>
             </a:extLst>
           </p:cNvPr>
@@ -2426,7 +2426,7 @@
           <p:nvPr/>
         </p:nvPicPr>
         <p:blipFill>
-          <a:blip xmlns:r="http://schemas.openxmlformats.org/officeDocument/2006/relationships" xmlns:a="http://schemas.openxmlformats.org/drawingml/2006/main" r:embed="R742b510e16f94417"/>
+          <a:blip xmlns:r="http://schemas.openxmlformats.org/officeDocument/2006/relationships" xmlns:a="http://schemas.openxmlformats.org/drawingml/2006/main" r:embed="Ra3c845112bde465b"/>
           <a:stretch xmlns:a="http://schemas.openxmlformats.org/drawingml/2006/main"/>
         </p:blipFill>
         <p:spPr>
@@ -2444,7 +2444,7 @@
           <p:cNvPr id="4" name="">
             <a:extLst xmlns:a="http://schemas.openxmlformats.org/drawingml/2006/main">
               <a:ext uri="{FF2B5EF4-FFF2-40B4-BE49-F238E27FC236}">
-                <a16:creationId xmlns:a16="http://schemas.microsoft.com/office/drawing/2014/main" id="{2E616C75-08DF-42FD-888F-88FEE1AB7B79}"/>
+                <a16:creationId xmlns:a16="http://schemas.microsoft.com/office/drawing/2014/main" id="{6B3ECCF7-C118-4E97-BFC2-60DF5002AAE4}"/>
               </a:ext>
             </a:extLst>
           </p:cNvPr>
@@ -2512,7 +2512,7 @@
           <p:cNvPr id="5" name="">
             <a:extLst xmlns:a="http://schemas.openxmlformats.org/drawingml/2006/main">
               <a:ext uri="{FF2B5EF4-FFF2-40B4-BE49-F238E27FC236}">
-                <a16:creationId xmlns:a16="http://schemas.microsoft.com/office/drawing/2014/main" id="{F04C2224-8926-4962-9C6E-787119A68EC2}"/>
+                <a16:creationId xmlns:a16="http://schemas.microsoft.com/office/drawing/2014/main" id="{D28E297E-0287-462C-97CF-39D53BC34D1C}"/>
               </a:ext>
             </a:extLst>
           </p:cNvPr>
@@ -2608,7 +2608,7 @@
           <p:cNvPr id="6" name="">
             <a:extLst xmlns:a="http://schemas.openxmlformats.org/drawingml/2006/main">
               <a:ext uri="{FF2B5EF4-FFF2-40B4-BE49-F238E27FC236}">
-                <a16:creationId xmlns:a16="http://schemas.microsoft.com/office/drawing/2014/main" id="{7D9AB602-DC2C-405F-9ECC-B1941F718278}"/>
+                <a16:creationId xmlns:a16="http://schemas.microsoft.com/office/drawing/2014/main" id="{2E1056B7-1184-4739-A10F-D8BCB7FEDDEC}"/>
               </a:ext>
             </a:extLst>
           </p:cNvPr>
@@ -2676,7 +2676,7 @@
           <p:cNvPr id="7" name="">
             <a:extLst xmlns:a="http://schemas.openxmlformats.org/drawingml/2006/main">
               <a:ext uri="{FF2B5EF4-FFF2-40B4-BE49-F238E27FC236}">
-                <a16:creationId xmlns:a16="http://schemas.microsoft.com/office/drawing/2014/main" id="{E1B613FA-3BE0-42E0-8555-E8C76CBB7D75}"/>
+                <a16:creationId xmlns:a16="http://schemas.microsoft.com/office/drawing/2014/main" id="{02AB4300-8538-4C56-B650-05AFCB76A304}"/>
               </a:ext>
             </a:extLst>
           </p:cNvPr>
@@ -2800,7 +2800,7 @@
           <p:cNvPr id="8" name="">
             <a:extLst xmlns:a="http://schemas.openxmlformats.org/drawingml/2006/main">
               <a:ext uri="{FF2B5EF4-FFF2-40B4-BE49-F238E27FC236}">
-                <a16:creationId xmlns:a16="http://schemas.microsoft.com/office/drawing/2014/main" id="{D5DABB34-5C9A-4783-AD16-4297E852CFC0}"/>
+                <a16:creationId xmlns:a16="http://schemas.microsoft.com/office/drawing/2014/main" id="{FA06D15A-9380-47C9-850E-93909C38881A}"/>
               </a:ext>
             </a:extLst>
           </p:cNvPr>
@@ -2866,7 +2866,7 @@
     </p:spTree>
     <p:extLst>
       <p:ext uri="{BB962C8B-B14F-4D97-AF65-F5344CB8AC3E}">
-        <p14:creationId xmlns:p14="http://schemas.microsoft.com/office/powerpoint/2010/main" val="337439799"/>
+        <p14:creationId xmlns:p14="http://schemas.microsoft.com/office/powerpoint/2010/main" val="916182287"/>
       </p:ext>
     </p:extLst>
   </p:cSld>
@@ -2897,7 +2897,7 @@
           <p:cNvPr id="15" name="">
             <a:extLst xmlns:a="http://schemas.openxmlformats.org/drawingml/2006/main">
               <a:ext uri="{FF2B5EF4-FFF2-40B4-BE49-F238E27FC236}">
-                <a16:creationId xmlns:a16="http://schemas.microsoft.com/office/drawing/2014/main" id="{91BECA9E-4F12-4258-984F-F4C8060669AA}"/>
+                <a16:creationId xmlns:a16="http://schemas.microsoft.com/office/drawing/2014/main" id="{2BE0E49B-ADA9-466E-9362-A402105A2EFB}"/>
               </a:ext>
             </a:extLst>
           </p:cNvPr>
@@ -2965,7 +2965,7 @@
           <p:cNvPr id="2" name="">
             <a:extLst xmlns:a="http://schemas.openxmlformats.org/drawingml/2006/main">
               <a:ext uri="{FF2B5EF4-FFF2-40B4-BE49-F238E27FC236}">
-                <a16:creationId xmlns:a16="http://schemas.microsoft.com/office/drawing/2014/main" id="{970F33CD-19C1-4E93-BB0E-8429B4E165C7}"/>
+                <a16:creationId xmlns:a16="http://schemas.microsoft.com/office/drawing/2014/main" id="{2B8C14A3-6396-4F20-8828-50D0337C428C}"/>
               </a:ext>
             </a:extLst>
           </p:cNvPr>
@@ -3033,7 +3033,7 @@
           <p:cNvPr id="3" name="">
             <a:extLst xmlns:a="http://schemas.openxmlformats.org/drawingml/2006/main">
               <a:ext uri="{FF2B5EF4-FFF2-40B4-BE49-F238E27FC236}">
-                <a16:creationId xmlns:a16="http://schemas.microsoft.com/office/drawing/2014/main" id="{70662C05-E509-44EB-921C-B8BF4C3EDB26}"/>
+                <a16:creationId xmlns:a16="http://schemas.microsoft.com/office/drawing/2014/main" id="{D2BCBA24-787D-4A22-96FA-BC2D6AD0F818}"/>
               </a:ext>
             </a:extLst>
           </p:cNvPr>
@@ -3101,7 +3101,7 @@
           <p:cNvPr id="4" name="">
             <a:extLst xmlns:a="http://schemas.openxmlformats.org/drawingml/2006/main">
               <a:ext uri="{FF2B5EF4-FFF2-40B4-BE49-F238E27FC236}">
-                <a16:creationId xmlns:a16="http://schemas.microsoft.com/office/drawing/2014/main" id="{D71D037E-CB67-4E11-9C20-2FDCFF6015FC}"/>
+                <a16:creationId xmlns:a16="http://schemas.microsoft.com/office/drawing/2014/main" id="{B6DBFAA3-AE43-4E9E-9BE6-30E48E7EE29E}"/>
               </a:ext>
             </a:extLst>
           </p:cNvPr>
@@ -3169,7 +3169,7 @@
           <p:cNvPr id="5" name="">
             <a:extLst xmlns:a="http://schemas.openxmlformats.org/drawingml/2006/main">
               <a:ext uri="{FF2B5EF4-FFF2-40B4-BE49-F238E27FC236}">
-                <a16:creationId xmlns:a16="http://schemas.microsoft.com/office/drawing/2014/main" id="{03F251A9-1BCE-43B0-BD0F-E1C055FC3D3F}"/>
+                <a16:creationId xmlns:a16="http://schemas.microsoft.com/office/drawing/2014/main" id="{B394F263-309D-4064-B330-B7FEC52CE335}"/>
               </a:ext>
             </a:extLst>
           </p:cNvPr>
@@ -3237,7 +3237,7 @@
           <p:cNvPr id="6" name="">
             <a:extLst xmlns:a="http://schemas.openxmlformats.org/drawingml/2006/main">
               <a:ext uri="{FF2B5EF4-FFF2-40B4-BE49-F238E27FC236}">
-                <a16:creationId xmlns:a16="http://schemas.microsoft.com/office/drawing/2014/main" id="{523D9A20-232F-492C-9853-BBCEC1DC2AD4}"/>
+                <a16:creationId xmlns:a16="http://schemas.microsoft.com/office/drawing/2014/main" id="{07FE06EC-F8AB-4BB7-A438-EC6F9522469F}"/>
               </a:ext>
             </a:extLst>
           </p:cNvPr>
@@ -3305,7 +3305,7 @@
           <p:cNvPr id="7" name="">
             <a:extLst xmlns:a="http://schemas.openxmlformats.org/drawingml/2006/main">
               <a:ext uri="{FF2B5EF4-FFF2-40B4-BE49-F238E27FC236}">
-                <a16:creationId xmlns:a16="http://schemas.microsoft.com/office/drawing/2014/main" id="{2F516993-E14E-45BB-8D7C-473DA3E8A46A}"/>
+                <a16:creationId xmlns:a16="http://schemas.microsoft.com/office/drawing/2014/main" id="{C730B3E4-8D5F-4F9E-ADA1-0B21CDF502FB}"/>
               </a:ext>
             </a:extLst>
           </p:cNvPr>
@@ -3373,7 +3373,7 @@
           <p:cNvPr id="8" name="">
             <a:extLst xmlns:a="http://schemas.openxmlformats.org/drawingml/2006/main">
               <a:ext uri="{FF2B5EF4-FFF2-40B4-BE49-F238E27FC236}">
-                <a16:creationId xmlns:a16="http://schemas.microsoft.com/office/drawing/2014/main" id="{3E5B3A96-F171-49FD-A536-05D14BCF7473}"/>
+                <a16:creationId xmlns:a16="http://schemas.microsoft.com/office/drawing/2014/main" id="{F7DACCEF-AEAF-4FDA-AA7F-04D8E0C80550}"/>
               </a:ext>
             </a:extLst>
           </p:cNvPr>
@@ -3441,7 +3441,7 @@
           <p:cNvPr id="9" name="">
             <a:extLst xmlns:a="http://schemas.openxmlformats.org/drawingml/2006/main">
               <a:ext uri="{FF2B5EF4-FFF2-40B4-BE49-F238E27FC236}">
-                <a16:creationId xmlns:a16="http://schemas.microsoft.com/office/drawing/2014/main" id="{BF4E63BF-73E0-40A5-869A-F2E8AEA5DB4B}"/>
+                <a16:creationId xmlns:a16="http://schemas.microsoft.com/office/drawing/2014/main" id="{964FA6B0-BE3F-40DC-9300-0565CC1AC6D4}"/>
               </a:ext>
             </a:extLst>
           </p:cNvPr>
@@ -3509,7 +3509,7 @@
           <p:cNvPr id="10" name="">
             <a:extLst xmlns:a="http://schemas.openxmlformats.org/drawingml/2006/main">
               <a:ext uri="{FF2B5EF4-FFF2-40B4-BE49-F238E27FC236}">
-                <a16:creationId xmlns:a16="http://schemas.microsoft.com/office/drawing/2014/main" id="{2B8EC94C-3D45-4282-B568-4090CFE2448E}"/>
+                <a16:creationId xmlns:a16="http://schemas.microsoft.com/office/drawing/2014/main" id="{9DB9D2D1-26E1-46C4-B441-9D72AD18CC9E}"/>
               </a:ext>
             </a:extLst>
           </p:cNvPr>
@@ -3577,7 +3577,7 @@
           <p:cNvPr id="11" name="">
             <a:extLst xmlns:a="http://schemas.openxmlformats.org/drawingml/2006/main">
               <a:ext uri="{FF2B5EF4-FFF2-40B4-BE49-F238E27FC236}">
-                <a16:creationId xmlns:a16="http://schemas.microsoft.com/office/drawing/2014/main" id="{26764580-2665-4CCF-9282-811909A35BFA}"/>
+                <a16:creationId xmlns:a16="http://schemas.microsoft.com/office/drawing/2014/main" id="{F1B2E9FF-58D3-4138-8179-9A7AA295DED7}"/>
               </a:ext>
             </a:extLst>
           </p:cNvPr>
@@ -3645,7 +3645,7 @@
           <p:cNvPr id="12" name="">
             <a:extLst xmlns:a="http://schemas.openxmlformats.org/drawingml/2006/main">
               <a:ext uri="{FF2B5EF4-FFF2-40B4-BE49-F238E27FC236}">
-                <a16:creationId xmlns:a16="http://schemas.microsoft.com/office/drawing/2014/main" id="{45FDF268-83F0-47B2-8846-8A08C167BCFC}"/>
+                <a16:creationId xmlns:a16="http://schemas.microsoft.com/office/drawing/2014/main" id="{0F3B52A3-226B-46F6-8045-FA36D9BA5AF3}"/>
               </a:ext>
             </a:extLst>
           </p:cNvPr>
@@ -3713,7 +3713,7 @@
           <p:cNvPr id="13" name="">
             <a:extLst xmlns:a="http://schemas.openxmlformats.org/drawingml/2006/main">
               <a:ext uri="{FF2B5EF4-FFF2-40B4-BE49-F238E27FC236}">
-                <a16:creationId xmlns:a16="http://schemas.microsoft.com/office/drawing/2014/main" id="{5F26DBC6-E545-426D-AEAA-A747C2E88947}"/>
+                <a16:creationId xmlns:a16="http://schemas.microsoft.com/office/drawing/2014/main" id="{8F423A72-8427-4672-9125-597E0CF3262A}"/>
               </a:ext>
             </a:extLst>
           </p:cNvPr>
@@ -3781,7 +3781,7 @@
           <p:cNvPr id="14" name="">
             <a:extLst xmlns:a="http://schemas.openxmlformats.org/drawingml/2006/main">
               <a:ext uri="{FF2B5EF4-FFF2-40B4-BE49-F238E27FC236}">
-                <a16:creationId xmlns:a16="http://schemas.microsoft.com/office/drawing/2014/main" id="{EC2F517E-79B9-499A-B2C8-18E7F3FD2777}"/>
+                <a16:creationId xmlns:a16="http://schemas.microsoft.com/office/drawing/2014/main" id="{DC1C7BCD-89FE-434D-97ED-05ECFE9163C0}"/>
               </a:ext>
             </a:extLst>
           </p:cNvPr>
@@ -3847,7 +3847,7 @@
     </p:spTree>
     <p:extLst>
       <p:ext uri="{BB962C8B-B14F-4D97-AF65-F5344CB8AC3E}">
-        <p14:creationId xmlns:p14="http://schemas.microsoft.com/office/powerpoint/2010/main" val="506952383"/>
+        <p14:creationId xmlns:p14="http://schemas.microsoft.com/office/powerpoint/2010/main" val="1438687122"/>
       </p:ext>
     </p:extLst>
   </p:cSld>
@@ -3878,7 +3878,7 @@
           <p:cNvPr id="9" name="">
             <a:extLst xmlns:a="http://schemas.openxmlformats.org/drawingml/2006/main">
               <a:ext uri="{FF2B5EF4-FFF2-40B4-BE49-F238E27FC236}">
-                <a16:creationId xmlns:a16="http://schemas.microsoft.com/office/drawing/2014/main" id="{8127A033-B23F-406C-B060-EA8297CC23F1}"/>
+                <a16:creationId xmlns:a16="http://schemas.microsoft.com/office/drawing/2014/main" id="{103C2DB9-1476-4D98-BA03-845B62CD9D0C}"/>
               </a:ext>
             </a:extLst>
           </p:cNvPr>
@@ -3946,7 +3946,7 @@
           <p:cNvPr id="2" name="">
             <a:extLst xmlns:a="http://schemas.openxmlformats.org/drawingml/2006/main">
               <a:ext uri="{FF2B5EF4-FFF2-40B4-BE49-F238E27FC236}">
-                <a16:creationId xmlns:a16="http://schemas.microsoft.com/office/drawing/2014/main" id="{779898CF-9CDF-4579-88FF-A66E1E6CF2C7}"/>
+                <a16:creationId xmlns:a16="http://schemas.microsoft.com/office/drawing/2014/main" id="{CAAFDDFE-B0FC-4077-84B6-3FD2350E089C}"/>
               </a:ext>
             </a:extLst>
           </p:cNvPr>
@@ -4014,7 +4014,7 @@
           <p:cNvPr id="3" name="">
             <a:extLst xmlns:a="http://schemas.openxmlformats.org/drawingml/2006/main">
               <a:ext uri="{FF2B5EF4-FFF2-40B4-BE49-F238E27FC236}">
-                <a16:creationId xmlns:a16="http://schemas.microsoft.com/office/drawing/2014/main" id="{5068C3AE-EA5C-4357-AE94-65A5DCD3DD12}"/>
+                <a16:creationId xmlns:a16="http://schemas.microsoft.com/office/drawing/2014/main" id="{2FD045EF-F368-4CB3-BE57-27ADFCA3F72D}"/>
               </a:ext>
             </a:extLst>
           </p:cNvPr>
@@ -4082,7 +4082,7 @@
           <p:cNvPr id="4" name="">
             <a:extLst xmlns:a="http://schemas.openxmlformats.org/drawingml/2006/main">
               <a:ext uri="{FF2B5EF4-FFF2-40B4-BE49-F238E27FC236}">
-                <a16:creationId xmlns:a16="http://schemas.microsoft.com/office/drawing/2014/main" id="{1A01239D-7EE8-47DE-A39F-ED208DCD0D70}"/>
+                <a16:creationId xmlns:a16="http://schemas.microsoft.com/office/drawing/2014/main" id="{B6825481-E05F-4A99-8987-7BE4EF7A857A}"/>
               </a:ext>
             </a:extLst>
           </p:cNvPr>
@@ -4178,7 +4178,7 @@
           <p:cNvPr id="5" name="">
             <a:extLst xmlns:a="http://schemas.openxmlformats.org/drawingml/2006/main">
               <a:ext uri="{FF2B5EF4-FFF2-40B4-BE49-F238E27FC236}">
-                <a16:creationId xmlns:a16="http://schemas.microsoft.com/office/drawing/2014/main" id="{08C930B4-D571-41C9-B1A6-341EBB797DF7}"/>
+                <a16:creationId xmlns:a16="http://schemas.microsoft.com/office/drawing/2014/main" id="{1AC9E94B-90D6-4974-8B76-DC601DE31177}"/>
               </a:ext>
             </a:extLst>
           </p:cNvPr>
@@ -4292,7 +4292,7 @@
           <p:cNvPr id="6" name="">
             <a:extLst xmlns:a="http://schemas.openxmlformats.org/drawingml/2006/main">
               <a:ext uri="{FF2B5EF4-FFF2-40B4-BE49-F238E27FC236}">
-                <a16:creationId xmlns:a16="http://schemas.microsoft.com/office/drawing/2014/main" id="{FDB24098-E50C-4D1B-8A33-4328D8AEBBBD}"/>
+                <a16:creationId xmlns:a16="http://schemas.microsoft.com/office/drawing/2014/main" id="{C56A9422-FB9B-4147-B7E0-9C82DD5CB63E}"/>
               </a:ext>
             </a:extLst>
           </p:cNvPr>
@@ -4360,7 +4360,7 @@
           <p:cNvPr id="7" name="">
             <a:extLst xmlns:a="http://schemas.openxmlformats.org/drawingml/2006/main">
               <a:ext uri="{FF2B5EF4-FFF2-40B4-BE49-F238E27FC236}">
-                <a16:creationId xmlns:a16="http://schemas.microsoft.com/office/drawing/2014/main" id="{F4B7BDDB-0102-44DC-9E8B-418210E52FB1}"/>
+                <a16:creationId xmlns:a16="http://schemas.microsoft.com/office/drawing/2014/main" id="{7F318361-9226-4FC2-8B05-444B5DEF6F8F}"/>
               </a:ext>
             </a:extLst>
           </p:cNvPr>
@@ -4428,7 +4428,7 @@
           <p:cNvPr id="8" name="">
             <a:extLst xmlns:a="http://schemas.openxmlformats.org/drawingml/2006/main">
               <a:ext uri="{FF2B5EF4-FFF2-40B4-BE49-F238E27FC236}">
-                <a16:creationId xmlns:a16="http://schemas.microsoft.com/office/drawing/2014/main" id="{F28E968A-3E8D-4177-83C5-173F8C4D48AE}"/>
+                <a16:creationId xmlns:a16="http://schemas.microsoft.com/office/drawing/2014/main" id="{11342302-CCCF-4BD3-98BA-CD2F757F0560}"/>
               </a:ext>
             </a:extLst>
           </p:cNvPr>
@@ -4494,7 +4494,7 @@
     </p:spTree>
     <p:extLst>
       <p:ext uri="{BB962C8B-B14F-4D97-AF65-F5344CB8AC3E}">
-        <p14:creationId xmlns:p14="http://schemas.microsoft.com/office/powerpoint/2010/main" val="2108096583"/>
+        <p14:creationId xmlns:p14="http://schemas.microsoft.com/office/powerpoint/2010/main" val="1691976152"/>
       </p:ext>
     </p:extLst>
   </p:cSld>
@@ -4525,7 +4525,7 @@
           <p:cNvPr id="12" name="">
             <a:extLst xmlns:a="http://schemas.openxmlformats.org/drawingml/2006/main">
               <a:ext uri="{FF2B5EF4-FFF2-40B4-BE49-F238E27FC236}">
-                <a16:creationId xmlns:a16="http://schemas.microsoft.com/office/drawing/2014/main" id="{39531F75-A950-4299-BEA7-BDCD4B352786}"/>
+                <a16:creationId xmlns:a16="http://schemas.microsoft.com/office/drawing/2014/main" id="{5F3DCDE6-47A2-4B3A-AA36-6EADF69FDA80}"/>
               </a:ext>
             </a:extLst>
           </p:cNvPr>
@@ -4593,7 +4593,7 @@
           <p:cNvPr id="2" name="">
             <a:extLst xmlns:a="http://schemas.openxmlformats.org/drawingml/2006/main">
               <a:ext uri="{FF2B5EF4-FFF2-40B4-BE49-F238E27FC236}">
-                <a16:creationId xmlns:a16="http://schemas.microsoft.com/office/drawing/2014/main" id="{EA66C464-6089-4974-A353-334FB0296DD5}"/>
+                <a16:creationId xmlns:a16="http://schemas.microsoft.com/office/drawing/2014/main" id="{F6E9D861-6E08-4820-8C82-2979E238F508}"/>
               </a:ext>
             </a:extLst>
           </p:cNvPr>
@@ -4661,7 +4661,7 @@
           <p:cNvPr id="3" name="">
             <a:extLst xmlns:a="http://schemas.openxmlformats.org/drawingml/2006/main">
               <a:ext uri="{FF2B5EF4-FFF2-40B4-BE49-F238E27FC236}">
-                <a16:creationId xmlns:a16="http://schemas.microsoft.com/office/drawing/2014/main" id="{1FE7D9C1-18A5-4DC1-949E-3B11D2E8FCA1}"/>
+                <a16:creationId xmlns:a16="http://schemas.microsoft.com/office/drawing/2014/main" id="{01F1BFCA-F918-4C96-BACC-F9CBFBBE8CDB}"/>
               </a:ext>
             </a:extLst>
           </p:cNvPr>
@@ -4729,7 +4729,7 @@
           <p:cNvPr id="4" name="">
             <a:extLst xmlns:a="http://schemas.openxmlformats.org/drawingml/2006/main">
               <a:ext uri="{FF2B5EF4-FFF2-40B4-BE49-F238E27FC236}">
-                <a16:creationId xmlns:a16="http://schemas.microsoft.com/office/drawing/2014/main" id="{35487B5A-5A35-45D5-9B56-ADE79BD12D83}"/>
+                <a16:creationId xmlns:a16="http://schemas.microsoft.com/office/drawing/2014/main" id="{F00C055B-FBE9-41D6-924C-1AAF016E5EFE}"/>
               </a:ext>
             </a:extLst>
           </p:cNvPr>
@@ -4853,7 +4853,7 @@
           <p:cNvPr id="5" name="">
             <a:extLst xmlns:a="http://schemas.openxmlformats.org/drawingml/2006/main">
               <a:ext uri="{FF2B5EF4-FFF2-40B4-BE49-F238E27FC236}">
-                <a16:creationId xmlns:a16="http://schemas.microsoft.com/office/drawing/2014/main" id="{73980EF3-E21D-4316-9ABB-A6848110C197}"/>
+                <a16:creationId xmlns:a16="http://schemas.microsoft.com/office/drawing/2014/main" id="{D197D049-821A-4D5E-9258-F70354725495}"/>
               </a:ext>
             </a:extLst>
           </p:cNvPr>
@@ -4921,7 +4921,7 @@
           <p:cNvPr id="6" name="">
             <a:extLst xmlns:a="http://schemas.openxmlformats.org/drawingml/2006/main">
               <a:ext uri="{FF2B5EF4-FFF2-40B4-BE49-F238E27FC236}">
-                <a16:creationId xmlns:a16="http://schemas.microsoft.com/office/drawing/2014/main" id="{5AD38D46-9D1B-4D1E-A2D8-C40FD15F8D4B}"/>
+                <a16:creationId xmlns:a16="http://schemas.microsoft.com/office/drawing/2014/main" id="{108038C8-8820-4897-8B2F-33C7AF90DF81}"/>
               </a:ext>
             </a:extLst>
           </p:cNvPr>
@@ -4989,7 +4989,7 @@
           <p:cNvPr id="7" name="">
             <a:extLst xmlns:a="http://schemas.openxmlformats.org/drawingml/2006/main">
               <a:ext uri="{FF2B5EF4-FFF2-40B4-BE49-F238E27FC236}">
-                <a16:creationId xmlns:a16="http://schemas.microsoft.com/office/drawing/2014/main" id="{512A09EB-3204-4BC3-9A53-85FA96EF2EBC}"/>
+                <a16:creationId xmlns:a16="http://schemas.microsoft.com/office/drawing/2014/main" id="{535C7807-5B2D-4E88-A9B4-3C7C409B003D}"/>
               </a:ext>
             </a:extLst>
           </p:cNvPr>
@@ -5057,7 +5057,7 @@
           <p:cNvPr id="8" name="">
             <a:extLst xmlns:a="http://schemas.openxmlformats.org/drawingml/2006/main">
               <a:ext uri="{FF2B5EF4-FFF2-40B4-BE49-F238E27FC236}">
-                <a16:creationId xmlns:a16="http://schemas.microsoft.com/office/drawing/2014/main" id="{81ABFC11-ED4C-4F24-B353-C5234EF150B7}"/>
+                <a16:creationId xmlns:a16="http://schemas.microsoft.com/office/drawing/2014/main" id="{4A16976B-BDAA-494C-A318-691C8D288BF7}"/>
               </a:ext>
             </a:extLst>
           </p:cNvPr>
@@ -5125,7 +5125,7 @@
           <p:cNvPr id="9" name="">
             <a:extLst xmlns:a="http://schemas.openxmlformats.org/drawingml/2006/main">
               <a:ext uri="{FF2B5EF4-FFF2-40B4-BE49-F238E27FC236}">
-                <a16:creationId xmlns:a16="http://schemas.microsoft.com/office/drawing/2014/main" id="{30A5141C-1F5D-4FAD-A907-98958FC4A025}"/>
+                <a16:creationId xmlns:a16="http://schemas.microsoft.com/office/drawing/2014/main" id="{70DCF80F-F08E-4780-9EA1-8C0AB8E2CC44}"/>
               </a:ext>
             </a:extLst>
           </p:cNvPr>
@@ -5193,7 +5193,7 @@
           <p:cNvPr id="10" name="">
             <a:extLst xmlns:a="http://schemas.openxmlformats.org/drawingml/2006/main">
               <a:ext uri="{FF2B5EF4-FFF2-40B4-BE49-F238E27FC236}">
-                <a16:creationId xmlns:a16="http://schemas.microsoft.com/office/drawing/2014/main" id="{0616CBC2-DE45-4193-B161-7D73D5C36CA6}"/>
+                <a16:creationId xmlns:a16="http://schemas.microsoft.com/office/drawing/2014/main" id="{A5DA9A7F-0A1C-4C3E-A159-0DAF22C293FC}"/>
               </a:ext>
             </a:extLst>
           </p:cNvPr>
@@ -5261,7 +5261,7 @@
           <p:cNvPr id="11" name="">
             <a:extLst xmlns:a="http://schemas.openxmlformats.org/drawingml/2006/main">
               <a:ext uri="{FF2B5EF4-FFF2-40B4-BE49-F238E27FC236}">
-                <a16:creationId xmlns:a16="http://schemas.microsoft.com/office/drawing/2014/main" id="{9BD9D9FB-D621-4062-93BD-011BBEE1DB18}"/>
+                <a16:creationId xmlns:a16="http://schemas.microsoft.com/office/drawing/2014/main" id="{D6FDE86B-7B53-4641-ACF2-B8D61FD93043}"/>
               </a:ext>
             </a:extLst>
           </p:cNvPr>
@@ -5327,7 +5327,7 @@
     </p:spTree>
     <p:extLst>
       <p:ext uri="{BB962C8B-B14F-4D97-AF65-F5344CB8AC3E}">
-        <p14:creationId xmlns:p14="http://schemas.microsoft.com/office/powerpoint/2010/main" val="1952412206"/>
+        <p14:creationId xmlns:p14="http://schemas.microsoft.com/office/powerpoint/2010/main" val="936520205"/>
       </p:ext>
     </p:extLst>
   </p:cSld>
@@ -5358,7 +5358,7 @@
           <p:cNvPr id="8" name="">
             <a:extLst xmlns:a="http://schemas.openxmlformats.org/drawingml/2006/main">
               <a:ext uri="{FF2B5EF4-FFF2-40B4-BE49-F238E27FC236}">
-                <a16:creationId xmlns:a16="http://schemas.microsoft.com/office/drawing/2014/main" id="{500A5D3C-787D-4861-9E1F-8867FB98470F}"/>
+                <a16:creationId xmlns:a16="http://schemas.microsoft.com/office/drawing/2014/main" id="{9595D7C0-F91E-4F86-BA76-FD09CADE4DD4}"/>
               </a:ext>
             </a:extLst>
           </p:cNvPr>
@@ -5426,7 +5426,7 @@
           <p:cNvPr id="2" name="">
             <a:extLst xmlns:a="http://schemas.openxmlformats.org/drawingml/2006/main">
               <a:ext uri="{FF2B5EF4-FFF2-40B4-BE49-F238E27FC236}">
-                <a16:creationId xmlns:a16="http://schemas.microsoft.com/office/drawing/2014/main" id="{7F1293DE-EF24-4496-BA2F-7FD1CBCB091B}"/>
+                <a16:creationId xmlns:a16="http://schemas.microsoft.com/office/drawing/2014/main" id="{A0202CCA-E782-4FAC-A299-E2DCA8EB894D}"/>
               </a:ext>
             </a:extLst>
           </p:cNvPr>
@@ -5494,7 +5494,7 @@
           <p:cNvPr id="3" name="">
             <a:extLst xmlns:a="http://schemas.openxmlformats.org/drawingml/2006/main">
               <a:ext uri="{FF2B5EF4-FFF2-40B4-BE49-F238E27FC236}">
-                <a16:creationId xmlns:a16="http://schemas.microsoft.com/office/drawing/2014/main" id="{DDAAD593-6AE8-4B57-B943-0079DB4AFF0E}"/>
+                <a16:creationId xmlns:a16="http://schemas.microsoft.com/office/drawing/2014/main" id="{866DBFA9-124E-4E3B-981B-5940A7AAA3D1}"/>
               </a:ext>
             </a:extLst>
           </p:cNvPr>
@@ -5562,7 +5562,7 @@
           <p:cNvPr id="4" name="">
             <a:extLst xmlns:a="http://schemas.openxmlformats.org/drawingml/2006/main">
               <a:ext uri="{FF2B5EF4-FFF2-40B4-BE49-F238E27FC236}">
-                <a16:creationId xmlns:a16="http://schemas.microsoft.com/office/drawing/2014/main" id="{6E179EF5-37FE-40AB-839F-FA70A74586BD}"/>
+                <a16:creationId xmlns:a16="http://schemas.microsoft.com/office/drawing/2014/main" id="{5FA7872D-89A0-4BD6-AF44-DF3D1AB4AE70}"/>
               </a:ext>
             </a:extLst>
           </p:cNvPr>
@@ -5686,7 +5686,7 @@
           <p:cNvPr id="5" name="">
             <a:extLst xmlns:a="http://schemas.openxmlformats.org/drawingml/2006/main">
               <a:ext uri="{FF2B5EF4-FFF2-40B4-BE49-F238E27FC236}">
-                <a16:creationId xmlns:a16="http://schemas.microsoft.com/office/drawing/2014/main" id="{4BA7A842-D709-454E-BC99-8410C65B0839}"/>
+                <a16:creationId xmlns:a16="http://schemas.microsoft.com/office/drawing/2014/main" id="{85240716-8BE0-4C20-AF85-034457EF82B9}"/>
               </a:ext>
             </a:extLst>
           </p:cNvPr>
@@ -5754,7 +5754,7 @@
           <p:cNvPr id="6" name="">
             <a:extLst xmlns:a="http://schemas.openxmlformats.org/drawingml/2006/main">
               <a:ext uri="{FF2B5EF4-FFF2-40B4-BE49-F238E27FC236}">
-                <a16:creationId xmlns:a16="http://schemas.microsoft.com/office/drawing/2014/main" id="{4807904A-62D3-4F9B-9FFF-F19A087BB1B9}"/>
+                <a16:creationId xmlns:a16="http://schemas.microsoft.com/office/drawing/2014/main" id="{0056A028-8781-487E-8D22-8483382792CA}"/>
               </a:ext>
             </a:extLst>
           </p:cNvPr>
@@ -5822,7 +5822,7 @@
           <p:cNvPr id="7" name="">
             <a:extLst xmlns:a="http://schemas.openxmlformats.org/drawingml/2006/main">
               <a:ext uri="{FF2B5EF4-FFF2-40B4-BE49-F238E27FC236}">
-                <a16:creationId xmlns:a16="http://schemas.microsoft.com/office/drawing/2014/main" id="{06A4ECCE-A31B-426C-9C7A-0ED1A9DFE291}"/>
+                <a16:creationId xmlns:a16="http://schemas.microsoft.com/office/drawing/2014/main" id="{50E14199-702B-486D-B1AE-7C6FAA839C63}"/>
               </a:ext>
             </a:extLst>
           </p:cNvPr>
@@ -5888,7 +5888,7 @@
     </p:spTree>
     <p:extLst>
       <p:ext uri="{BB962C8B-B14F-4D97-AF65-F5344CB8AC3E}">
-        <p14:creationId xmlns:p14="http://schemas.microsoft.com/office/powerpoint/2010/main" val="1846074831"/>
+        <p14:creationId xmlns:p14="http://schemas.microsoft.com/office/powerpoint/2010/main" val="1576188701"/>
       </p:ext>
     </p:extLst>
   </p:cSld>
@@ -5919,7 +5919,7 @@
           <p:cNvPr id="11" name="">
             <a:extLst xmlns:a="http://schemas.openxmlformats.org/drawingml/2006/main">
               <a:ext uri="{FF2B5EF4-FFF2-40B4-BE49-F238E27FC236}">
-                <a16:creationId xmlns:a16="http://schemas.microsoft.com/office/drawing/2014/main" id="{87C2D18F-9F3D-438B-8294-3FF7F3CC6EEF}"/>
+                <a16:creationId xmlns:a16="http://schemas.microsoft.com/office/drawing/2014/main" id="{21C59AEC-27A3-4116-92C7-3AE7E26176C8}"/>
               </a:ext>
             </a:extLst>
           </p:cNvPr>
@@ -5987,7 +5987,7 @@
           <p:cNvPr id="2" name="">
             <a:extLst xmlns:a="http://schemas.openxmlformats.org/drawingml/2006/main">
               <a:ext uri="{FF2B5EF4-FFF2-40B4-BE49-F238E27FC236}">
-                <a16:creationId xmlns:a16="http://schemas.microsoft.com/office/drawing/2014/main" id="{3FEB353D-C4A6-429C-8067-65F6C71B0E76}"/>
+                <a16:creationId xmlns:a16="http://schemas.microsoft.com/office/drawing/2014/main" id="{6915AB24-BC8C-4FF1-BB49-DB07F39F2FEB}"/>
               </a:ext>
             </a:extLst>
           </p:cNvPr>
@@ -6055,7 +6055,7 @@
           <p:cNvPr id="3" name="">
             <a:extLst xmlns:a="http://schemas.openxmlformats.org/drawingml/2006/main">
               <a:ext uri="{FF2B5EF4-FFF2-40B4-BE49-F238E27FC236}">
-                <a16:creationId xmlns:a16="http://schemas.microsoft.com/office/drawing/2014/main" id="{9BCD2C4F-9C4B-4216-B1A5-18B307637C4D}"/>
+                <a16:creationId xmlns:a16="http://schemas.microsoft.com/office/drawing/2014/main" id="{EFA9F9FC-6B61-4BFC-80E0-4D7FC813E3B1}"/>
               </a:ext>
             </a:extLst>
           </p:cNvPr>
@@ -6123,7 +6123,7 @@
           <p:cNvPr id="4" name="">
             <a:extLst xmlns:a="http://schemas.openxmlformats.org/drawingml/2006/main">
               <a:ext uri="{FF2B5EF4-FFF2-40B4-BE49-F238E27FC236}">
-                <a16:creationId xmlns:a16="http://schemas.microsoft.com/office/drawing/2014/main" id="{76FDB32A-F3F0-4202-971E-B5C21A97510B}"/>
+                <a16:creationId xmlns:a16="http://schemas.microsoft.com/office/drawing/2014/main" id="{794355EA-C209-4F81-A6F1-AB710E649EF5}"/>
               </a:ext>
             </a:extLst>
           </p:cNvPr>
@@ -6247,7 +6247,7 @@
           <p:cNvPr id="5" name="">
             <a:extLst xmlns:a="http://schemas.openxmlformats.org/drawingml/2006/main">
               <a:ext uri="{FF2B5EF4-FFF2-40B4-BE49-F238E27FC236}">
-                <a16:creationId xmlns:a16="http://schemas.microsoft.com/office/drawing/2014/main" id="{3E126D8B-5D37-4C5E-9C2E-8AA5966F3496}"/>
+                <a16:creationId xmlns:a16="http://schemas.microsoft.com/office/drawing/2014/main" id="{E9BA2D2A-7ACD-4383-A8A7-A3065FDFAC2E}"/>
               </a:ext>
             </a:extLst>
           </p:cNvPr>
@@ -6315,7 +6315,7 @@
           <p:cNvPr id="6" name="">
             <a:extLst xmlns:a="http://schemas.openxmlformats.org/drawingml/2006/main">
               <a:ext uri="{FF2B5EF4-FFF2-40B4-BE49-F238E27FC236}">
-                <a16:creationId xmlns:a16="http://schemas.microsoft.com/office/drawing/2014/main" id="{C6E40EAD-836C-4AA2-930A-B03AE2FC38CA}"/>
+                <a16:creationId xmlns:a16="http://schemas.microsoft.com/office/drawing/2014/main" id="{E2DBCE4C-8F30-4E31-8545-3086BF94FCBE}"/>
               </a:ext>
             </a:extLst>
           </p:cNvPr>
@@ -6383,7 +6383,7 @@
           <p:cNvPr id="7" name="">
             <a:extLst xmlns:a="http://schemas.openxmlformats.org/drawingml/2006/main">
               <a:ext uri="{FF2B5EF4-FFF2-40B4-BE49-F238E27FC236}">
-                <a16:creationId xmlns:a16="http://schemas.microsoft.com/office/drawing/2014/main" id="{61A663C5-05E6-4D00-8667-C9E34149BDF4}"/>
+                <a16:creationId xmlns:a16="http://schemas.microsoft.com/office/drawing/2014/main" id="{E1E53BBE-9A66-4427-A724-44683424AE0E}"/>
               </a:ext>
             </a:extLst>
           </p:cNvPr>
@@ -6451,7 +6451,7 @@
           <p:cNvPr id="8" name="">
             <a:extLst xmlns:a="http://schemas.openxmlformats.org/drawingml/2006/main">
               <a:ext uri="{FF2B5EF4-FFF2-40B4-BE49-F238E27FC236}">
-                <a16:creationId xmlns:a16="http://schemas.microsoft.com/office/drawing/2014/main" id="{98126D35-D9CA-4DCD-B056-BD8955325FD8}"/>
+                <a16:creationId xmlns:a16="http://schemas.microsoft.com/office/drawing/2014/main" id="{2C14B68F-C5F9-4761-B21C-DB88960B8068}"/>
               </a:ext>
             </a:extLst>
           </p:cNvPr>
@@ -6519,7 +6519,7 @@
           <p:cNvPr id="9" name="">
             <a:extLst xmlns:a="http://schemas.openxmlformats.org/drawingml/2006/main">
               <a:ext uri="{FF2B5EF4-FFF2-40B4-BE49-F238E27FC236}">
-                <a16:creationId xmlns:a16="http://schemas.microsoft.com/office/drawing/2014/main" id="{7A914C8B-741F-42B3-9F0B-D1C05488C79E}"/>
+                <a16:creationId xmlns:a16="http://schemas.microsoft.com/office/drawing/2014/main" id="{7D2CE9D6-6AE2-4FC3-9388-0AF458CD4F67}"/>
               </a:ext>
             </a:extLst>
           </p:cNvPr>
@@ -6587,7 +6587,7 @@
           <p:cNvPr id="10" name="">
             <a:extLst xmlns:a="http://schemas.openxmlformats.org/drawingml/2006/main">
               <a:ext uri="{FF2B5EF4-FFF2-40B4-BE49-F238E27FC236}">
-                <a16:creationId xmlns:a16="http://schemas.microsoft.com/office/drawing/2014/main" id="{1B77FF05-DF1A-4720-B162-180FA7DEFA13}"/>
+                <a16:creationId xmlns:a16="http://schemas.microsoft.com/office/drawing/2014/main" id="{B10013D1-8777-48EE-93C6-B4FC8C1F2A8E}"/>
               </a:ext>
             </a:extLst>
           </p:cNvPr>
@@ -6653,7 +6653,7 @@
     </p:spTree>
     <p:extLst>
       <p:ext uri="{BB962C8B-B14F-4D97-AF65-F5344CB8AC3E}">
-        <p14:creationId xmlns:p14="http://schemas.microsoft.com/office/powerpoint/2010/main" val="138485540"/>
+        <p14:creationId xmlns:p14="http://schemas.microsoft.com/office/powerpoint/2010/main" val="1884406580"/>
       </p:ext>
     </p:extLst>
   </p:cSld>
@@ -6684,7 +6684,7 @@
           <p:cNvPr id="6" name="">
             <a:extLst xmlns:a="http://schemas.openxmlformats.org/drawingml/2006/main">
               <a:ext uri="{FF2B5EF4-FFF2-40B4-BE49-F238E27FC236}">
-                <a16:creationId xmlns:a16="http://schemas.microsoft.com/office/drawing/2014/main" id="{9574343B-6DD0-4F0A-A59B-7A3DD85517D4}"/>
+                <a16:creationId xmlns:a16="http://schemas.microsoft.com/office/drawing/2014/main" id="{39BF2B73-646F-4B7B-9A52-A25F871D0572}"/>
               </a:ext>
             </a:extLst>
           </p:cNvPr>
@@ -6752,7 +6752,7 @@
           <p:cNvPr id="2" name="">
             <a:extLst xmlns:a="http://schemas.openxmlformats.org/drawingml/2006/main">
               <a:ext uri="{FF2B5EF4-FFF2-40B4-BE49-F238E27FC236}">
-                <a16:creationId xmlns:a16="http://schemas.microsoft.com/office/drawing/2014/main" id="{C6AA506D-C55E-46D4-9B58-D86DD1CA05E7}"/>
+                <a16:creationId xmlns:a16="http://schemas.microsoft.com/office/drawing/2014/main" id="{147AB6CE-CA49-43DE-AEF4-61EC93EF3D22}"/>
               </a:ext>
             </a:extLst>
           </p:cNvPr>
@@ -6820,7 +6820,7 @@
           <p:cNvPr id="3" name="">
             <a:extLst xmlns:a="http://schemas.openxmlformats.org/drawingml/2006/main">
               <a:ext uri="{FF2B5EF4-FFF2-40B4-BE49-F238E27FC236}">
-                <a16:creationId xmlns:a16="http://schemas.microsoft.com/office/drawing/2014/main" id="{06240119-8C4D-4349-9F4C-113B3366DF80}"/>
+                <a16:creationId xmlns:a16="http://schemas.microsoft.com/office/drawing/2014/main" id="{2C7C2570-432B-4857-9D30-F91443F06A72}"/>
               </a:ext>
             </a:extLst>
           </p:cNvPr>
@@ -6888,7 +6888,7 @@
           <p:cNvPr id="4" name="">
             <a:extLst xmlns:a="http://schemas.openxmlformats.org/drawingml/2006/main">
               <a:ext uri="{FF2B5EF4-FFF2-40B4-BE49-F238E27FC236}">
-                <a16:creationId xmlns:a16="http://schemas.microsoft.com/office/drawing/2014/main" id="{1ED66507-169D-44B8-8B76-4B632D9B6830}"/>
+                <a16:creationId xmlns:a16="http://schemas.microsoft.com/office/drawing/2014/main" id="{26CDB80A-46EF-4FCB-9550-32D707EFC26A}"/>
               </a:ext>
             </a:extLst>
           </p:cNvPr>
@@ -7012,7 +7012,7 @@
           <p:cNvPr id="5" name="">
             <a:extLst xmlns:a="http://schemas.openxmlformats.org/drawingml/2006/main">
               <a:ext uri="{FF2B5EF4-FFF2-40B4-BE49-F238E27FC236}">
-                <a16:creationId xmlns:a16="http://schemas.microsoft.com/office/drawing/2014/main" id="{7D19F08A-FC5A-4A97-A685-CEE8564F6E91}"/>
+                <a16:creationId xmlns:a16="http://schemas.microsoft.com/office/drawing/2014/main" id="{0F2AD11D-D42E-4617-B66C-045A610B48AB}"/>
               </a:ext>
             </a:extLst>
           </p:cNvPr>
@@ -7078,7 +7078,7 @@
     </p:spTree>
     <p:extLst>
       <p:ext uri="{BB962C8B-B14F-4D97-AF65-F5344CB8AC3E}">
-        <p14:creationId xmlns:p14="http://schemas.microsoft.com/office/powerpoint/2010/main" val="149329885"/>
+        <p14:creationId xmlns:p14="http://schemas.microsoft.com/office/powerpoint/2010/main" val="1267913163"/>
       </p:ext>
     </p:extLst>
   </p:cSld>
@@ -7109,7 +7109,7 @@
           <p:cNvPr id="8" name="">
             <a:extLst xmlns:a="http://schemas.openxmlformats.org/drawingml/2006/main">
               <a:ext uri="{FF2B5EF4-FFF2-40B4-BE49-F238E27FC236}">
-                <a16:creationId xmlns:a16="http://schemas.microsoft.com/office/drawing/2014/main" id="{887D241D-EA6C-4795-9675-ADF805A747C2}"/>
+                <a16:creationId xmlns:a16="http://schemas.microsoft.com/office/drawing/2014/main" id="{215EF884-8383-4304-92DC-F84A6A56608A}"/>
               </a:ext>
             </a:extLst>
           </p:cNvPr>
@@ -7177,7 +7177,7 @@
           <p:cNvPr id="2" name="">
             <a:extLst xmlns:a="http://schemas.openxmlformats.org/drawingml/2006/main">
               <a:ext uri="{FF2B5EF4-FFF2-40B4-BE49-F238E27FC236}">
-                <a16:creationId xmlns:a16="http://schemas.microsoft.com/office/drawing/2014/main" id="{A9677206-97E1-4E5B-92A2-2BB56A75BF46}"/>
+                <a16:creationId xmlns:a16="http://schemas.microsoft.com/office/drawing/2014/main" id="{F03D5954-EF23-419F-AD2F-137BB235490C}"/>
               </a:ext>
             </a:extLst>
           </p:cNvPr>
@@ -7245,7 +7245,7 @@
           <p:cNvPr id="3" name="">
             <a:extLst xmlns:a="http://schemas.openxmlformats.org/drawingml/2006/main">
               <a:ext uri="{FF2B5EF4-FFF2-40B4-BE49-F238E27FC236}">
-                <a16:creationId xmlns:a16="http://schemas.microsoft.com/office/drawing/2014/main" id="{29426998-F01F-478A-8BAB-4CAC9723D515}"/>
+                <a16:creationId xmlns:a16="http://schemas.microsoft.com/office/drawing/2014/main" id="{191353F2-ED26-42A5-8A2F-18F9257A6FC7}"/>
               </a:ext>
             </a:extLst>
           </p:cNvPr>
@@ -7313,7 +7313,7 @@
           <p:cNvPr id="4" name="">
             <a:extLst xmlns:a="http://schemas.openxmlformats.org/drawingml/2006/main">
               <a:ext uri="{FF2B5EF4-FFF2-40B4-BE49-F238E27FC236}">
-                <a16:creationId xmlns:a16="http://schemas.microsoft.com/office/drawing/2014/main" id="{224CE3ED-9F79-41FF-BB14-628811A79091}"/>
+                <a16:creationId xmlns:a16="http://schemas.microsoft.com/office/drawing/2014/main" id="{FD219D06-B454-45C3-A917-202B1572D008}"/>
               </a:ext>
             </a:extLst>
           </p:cNvPr>
@@ -7381,7 +7381,7 @@
           <p:cNvPr id="5" name="">
             <a:extLst xmlns:a="http://schemas.openxmlformats.org/drawingml/2006/main">
               <a:ext uri="{FF2B5EF4-FFF2-40B4-BE49-F238E27FC236}">
-                <a16:creationId xmlns:a16="http://schemas.microsoft.com/office/drawing/2014/main" id="{268A55B6-A1D5-4159-94C0-CEAA010161FE}"/>
+                <a16:creationId xmlns:a16="http://schemas.microsoft.com/office/drawing/2014/main" id="{001148AE-7EA3-42A5-BF87-43EBD665D36E}"/>
               </a:ext>
             </a:extLst>
           </p:cNvPr>
@@ -7449,7 +7449,7 @@
           <p:cNvPr id="6" name="">
             <a:extLst xmlns:a="http://schemas.openxmlformats.org/drawingml/2006/main">
               <a:ext uri="{FF2B5EF4-FFF2-40B4-BE49-F238E27FC236}">
-                <a16:creationId xmlns:a16="http://schemas.microsoft.com/office/drawing/2014/main" id="{E679E774-8A7F-4ADB-A200-DCBAE1A72477}"/>
+                <a16:creationId xmlns:a16="http://schemas.microsoft.com/office/drawing/2014/main" id="{4ED47A59-5F4E-47F2-A856-AFA684FA3EDE}"/>
               </a:ext>
             </a:extLst>
           </p:cNvPr>
@@ -7573,7 +7573,7 @@
           <p:cNvPr id="7" name="">
             <a:extLst xmlns:a="http://schemas.openxmlformats.org/drawingml/2006/main">
               <a:ext uri="{FF2B5EF4-FFF2-40B4-BE49-F238E27FC236}">
-                <a16:creationId xmlns:a16="http://schemas.microsoft.com/office/drawing/2014/main" id="{78238A65-3D5C-424C-9214-D012AD9B0381}"/>
+                <a16:creationId xmlns:a16="http://schemas.microsoft.com/office/drawing/2014/main" id="{40BBCBE6-8FA8-4AF1-9039-715C9E4F1A5E}"/>
               </a:ext>
             </a:extLst>
           </p:cNvPr>
@@ -7639,7 +7639,7 @@
     </p:spTree>
     <p:extLst>
       <p:ext uri="{BB962C8B-B14F-4D97-AF65-F5344CB8AC3E}">
-        <p14:creationId xmlns:p14="http://schemas.microsoft.com/office/powerpoint/2010/main" val="1481255632"/>
+        <p14:creationId xmlns:p14="http://schemas.microsoft.com/office/powerpoint/2010/main" val="1873264818"/>
       </p:ext>
     </p:extLst>
   </p:cSld>
@@ -7670,7 +7670,7 @@
           <p:cNvPr id="7" name="">
             <a:extLst xmlns:a="http://schemas.openxmlformats.org/drawingml/2006/main">
               <a:ext uri="{FF2B5EF4-FFF2-40B4-BE49-F238E27FC236}">
-                <a16:creationId xmlns:a16="http://schemas.microsoft.com/office/drawing/2014/main" id="{442BC8BB-190F-45E9-A9B0-FA6083096F63}"/>
+                <a16:creationId xmlns:a16="http://schemas.microsoft.com/office/drawing/2014/main" id="{283717C1-E00F-4DCD-B23C-3CA7E605ACFB}"/>
               </a:ext>
             </a:extLst>
           </p:cNvPr>
@@ -7738,7 +7738,7 @@
           <p:cNvPr id="2" name="">
             <a:extLst xmlns:a="http://schemas.openxmlformats.org/drawingml/2006/main">
               <a:ext uri="{FF2B5EF4-FFF2-40B4-BE49-F238E27FC236}">
-                <a16:creationId xmlns:a16="http://schemas.microsoft.com/office/drawing/2014/main" id="{E9AB0529-52B4-4CCB-AD90-6BC6148535E9}"/>
+                <a16:creationId xmlns:a16="http://schemas.microsoft.com/office/drawing/2014/main" id="{DED7678D-85A7-4985-A57D-645F13C34B0C}"/>
               </a:ext>
             </a:extLst>
           </p:cNvPr>
@@ -7806,7 +7806,7 @@
           <p:cNvPr id="3" name="">
             <a:extLst xmlns:a="http://schemas.openxmlformats.org/drawingml/2006/main">
               <a:ext uri="{FF2B5EF4-FFF2-40B4-BE49-F238E27FC236}">
-                <a16:creationId xmlns:a16="http://schemas.microsoft.com/office/drawing/2014/main" id="{7A87DE3B-7941-4AD7-9837-501567DB13CF}"/>
+                <a16:creationId xmlns:a16="http://schemas.microsoft.com/office/drawing/2014/main" id="{B798803A-EA3D-47C2-98B5-847CCFBF3048}"/>
               </a:ext>
             </a:extLst>
           </p:cNvPr>
@@ -7874,7 +7874,7 @@
           <p:cNvPr id="4" name="">
             <a:extLst xmlns:a="http://schemas.openxmlformats.org/drawingml/2006/main">
               <a:ext uri="{FF2B5EF4-FFF2-40B4-BE49-F238E27FC236}">
-                <a16:creationId xmlns:a16="http://schemas.microsoft.com/office/drawing/2014/main" id="{1830D3A5-C9EA-4AC4-A9FF-407E798B1A22}"/>
+                <a16:creationId xmlns:a16="http://schemas.microsoft.com/office/drawing/2014/main" id="{732CC931-FDFD-468C-853D-A4C2F39D4BF6}"/>
               </a:ext>
             </a:extLst>
           </p:cNvPr>
@@ -7998,7 +7998,7 @@
           <p:cNvPr id="5" name="">
             <a:extLst xmlns:a="http://schemas.openxmlformats.org/drawingml/2006/main">
               <a:ext uri="{FF2B5EF4-FFF2-40B4-BE49-F238E27FC236}">
-                <a16:creationId xmlns:a16="http://schemas.microsoft.com/office/drawing/2014/main" id="{6ABB4A15-A069-4372-939D-DF1115F6BDDE}"/>
+                <a16:creationId xmlns:a16="http://schemas.microsoft.com/office/drawing/2014/main" id="{D32AE706-C0D2-459E-9100-388732A57C93}"/>
               </a:ext>
             </a:extLst>
           </p:cNvPr>
@@ -8066,7 +8066,7 @@
           <p:cNvPr id="6" name="">
             <a:extLst xmlns:a="http://schemas.openxmlformats.org/drawingml/2006/main">
               <a:ext uri="{FF2B5EF4-FFF2-40B4-BE49-F238E27FC236}">
-                <a16:creationId xmlns:a16="http://schemas.microsoft.com/office/drawing/2014/main" id="{4594AC1B-35CD-45BF-BEBE-A78280E69B8B}"/>
+                <a16:creationId xmlns:a16="http://schemas.microsoft.com/office/drawing/2014/main" id="{7D9D8958-A825-41D9-BC02-1155DBA64CAE}"/>
               </a:ext>
             </a:extLst>
           </p:cNvPr>
@@ -8132,7 +8132,7 @@
     </p:spTree>
     <p:extLst>
       <p:ext uri="{BB962C8B-B14F-4D97-AF65-F5344CB8AC3E}">
-        <p14:creationId xmlns:p14="http://schemas.microsoft.com/office/powerpoint/2010/main" val="550895560"/>
+        <p14:creationId xmlns:p14="http://schemas.microsoft.com/office/powerpoint/2010/main" val="2050969808"/>
       </p:ext>
     </p:extLst>
   </p:cSld>
@@ -8163,7 +8163,7 @@
           <p:cNvPr id="6" name="">
             <a:extLst xmlns:a="http://schemas.openxmlformats.org/drawingml/2006/main">
               <a:ext uri="{FF2B5EF4-FFF2-40B4-BE49-F238E27FC236}">
-                <a16:creationId xmlns:a16="http://schemas.microsoft.com/office/drawing/2014/main" id="{ED8FB0BC-3E04-4959-9CE3-213D090B6AFE}"/>
+                <a16:creationId xmlns:a16="http://schemas.microsoft.com/office/drawing/2014/main" id="{8DFFB5C6-D2F5-46F0-B024-BFB6710B78AA}"/>
               </a:ext>
             </a:extLst>
           </p:cNvPr>
@@ -8231,7 +8231,7 @@
           <p:cNvPr id="2" name="">
             <a:extLst xmlns:a="http://schemas.openxmlformats.org/drawingml/2006/main">
               <a:ext uri="{FF2B5EF4-FFF2-40B4-BE49-F238E27FC236}">
-                <a16:creationId xmlns:a16="http://schemas.microsoft.com/office/drawing/2014/main" id="{66502EB8-6F83-4E48-87FD-F971D7715600}"/>
+                <a16:creationId xmlns:a16="http://schemas.microsoft.com/office/drawing/2014/main" id="{65BE8FB4-546F-49BF-BBEE-46F06508ECBD}"/>
               </a:ext>
             </a:extLst>
           </p:cNvPr>
@@ -8299,7 +8299,7 @@
           <p:cNvPr id="3" name="">
             <a:extLst xmlns:a="http://schemas.openxmlformats.org/drawingml/2006/main">
               <a:ext uri="{FF2B5EF4-FFF2-40B4-BE49-F238E27FC236}">
-                <a16:creationId xmlns:a16="http://schemas.microsoft.com/office/drawing/2014/main" id="{7A07CA31-5FBC-48F5-A9B3-22963DC27E20}"/>
+                <a16:creationId xmlns:a16="http://schemas.microsoft.com/office/drawing/2014/main" id="{D215E5E2-9935-464D-A55E-CB60A88B2AB1}"/>
               </a:ext>
             </a:extLst>
           </p:cNvPr>
@@ -8367,7 +8367,7 @@
           <p:cNvPr id="4" name="">
             <a:extLst xmlns:a="http://schemas.openxmlformats.org/drawingml/2006/main">
               <a:ext uri="{FF2B5EF4-FFF2-40B4-BE49-F238E27FC236}">
-                <a16:creationId xmlns:a16="http://schemas.microsoft.com/office/drawing/2014/main" id="{C6AC3C25-3389-40AB-AB2C-B3209CD5EF24}"/>
+                <a16:creationId xmlns:a16="http://schemas.microsoft.com/office/drawing/2014/main" id="{70963F17-D41F-49D8-9857-986B37D5FBC2}"/>
               </a:ext>
             </a:extLst>
           </p:cNvPr>
@@ -8481,7 +8481,7 @@
                 <a:ea typeface="Arial"/>
                 <a:cs typeface="Arial"/>
               </a:rPr>
-              <a:t>Tri prova në java-05.md; dorëzim në minutën 70 dhe kohë për korrigjime.</a:t>
+              <a:t>Tri prova në java-05.md; nis dorëzimin në minutën 65 dhe lër 25 minuta për përgjigjen e korrigjimet.</a:t>
             </a:r>
           </a:p>
         </p:txBody>
@@ -8491,7 +8491,7 @@
           <p:cNvPr id="5" name="">
             <a:extLst xmlns:a="http://schemas.openxmlformats.org/drawingml/2006/main">
               <a:ext uri="{FF2B5EF4-FFF2-40B4-BE49-F238E27FC236}">
-                <a16:creationId xmlns:a16="http://schemas.microsoft.com/office/drawing/2014/main" id="{28F56F4B-FEE6-45AA-8333-54E1553E9855}"/>
+                <a16:creationId xmlns:a16="http://schemas.microsoft.com/office/drawing/2014/main" id="{5450F279-CE68-45E5-B141-E3E0529DC30D}"/>
               </a:ext>
             </a:extLst>
           </p:cNvPr>
@@ -8557,7 +8557,7 @@
     </p:spTree>
     <p:extLst>
       <p:ext uri="{BB962C8B-B14F-4D97-AF65-F5344CB8AC3E}">
-        <p14:creationId xmlns:p14="http://schemas.microsoft.com/office/powerpoint/2010/main" val="989532036"/>
+        <p14:creationId xmlns:p14="http://schemas.microsoft.com/office/powerpoint/2010/main" val="1226196408"/>
       </p:ext>
     </p:extLst>
   </p:cSld>
@@ -8588,7 +8588,7 @@
           <p:cNvPr id="9" name="">
             <a:extLst xmlns:a="http://schemas.openxmlformats.org/drawingml/2006/main">
               <a:ext uri="{FF2B5EF4-FFF2-40B4-BE49-F238E27FC236}">
-                <a16:creationId xmlns:a16="http://schemas.microsoft.com/office/drawing/2014/main" id="{78B3C602-2D18-4BDB-BF0F-E9346B669C74}"/>
+                <a16:creationId xmlns:a16="http://schemas.microsoft.com/office/drawing/2014/main" id="{7933376D-C192-4B73-87F4-FF17CEC2E2B8}"/>
               </a:ext>
             </a:extLst>
           </p:cNvPr>
@@ -8656,7 +8656,7 @@
           <p:cNvPr id="2" name="">
             <a:extLst xmlns:a="http://schemas.openxmlformats.org/drawingml/2006/main">
               <a:ext uri="{FF2B5EF4-FFF2-40B4-BE49-F238E27FC236}">
-                <a16:creationId xmlns:a16="http://schemas.microsoft.com/office/drawing/2014/main" id="{391054C5-B731-4C74-9DFC-AE4BDC1D420F}"/>
+                <a16:creationId xmlns:a16="http://schemas.microsoft.com/office/drawing/2014/main" id="{40FA98D0-A30D-4C98-A9C1-23E08B37A66A}"/>
               </a:ext>
             </a:extLst>
           </p:cNvPr>
@@ -8724,7 +8724,7 @@
           <p:cNvPr id="3" name="">
             <a:extLst xmlns:a="http://schemas.openxmlformats.org/drawingml/2006/main">
               <a:ext uri="{FF2B5EF4-FFF2-40B4-BE49-F238E27FC236}">
-                <a16:creationId xmlns:a16="http://schemas.microsoft.com/office/drawing/2014/main" id="{45C114CD-88EC-4EBC-8620-565C90729FF6}"/>
+                <a16:creationId xmlns:a16="http://schemas.microsoft.com/office/drawing/2014/main" id="{8B238266-E9B8-4EFC-A81F-72D7D98532ED}"/>
               </a:ext>
             </a:extLst>
           </p:cNvPr>
@@ -8792,7 +8792,7 @@
           <p:cNvPr id="4" name="">
             <a:extLst xmlns:a="http://schemas.openxmlformats.org/drawingml/2006/main">
               <a:ext uri="{FF2B5EF4-FFF2-40B4-BE49-F238E27FC236}">
-                <a16:creationId xmlns:a16="http://schemas.microsoft.com/office/drawing/2014/main" id="{5263ABAF-6BAF-463F-8198-BF9945EC0E48}"/>
+                <a16:creationId xmlns:a16="http://schemas.microsoft.com/office/drawing/2014/main" id="{F024C339-CF0E-4BBA-9A1B-173DF1CB4FFF}"/>
               </a:ext>
             </a:extLst>
           </p:cNvPr>
@@ -8916,7 +8916,7 @@
           <p:cNvPr id="5" name="">
             <a:extLst xmlns:a="http://schemas.openxmlformats.org/drawingml/2006/main">
               <a:ext uri="{FF2B5EF4-FFF2-40B4-BE49-F238E27FC236}">
-                <a16:creationId xmlns:a16="http://schemas.microsoft.com/office/drawing/2014/main" id="{0F8EF9E3-44EA-4BAE-B4E8-8A6CAF1374CD}"/>
+                <a16:creationId xmlns:a16="http://schemas.microsoft.com/office/drawing/2014/main" id="{597CE977-E70F-487C-AB32-3B537CACDACD}"/>
               </a:ext>
             </a:extLst>
           </p:cNvPr>
@@ -8984,7 +8984,7 @@
           <p:cNvPr id="6" name="">
             <a:extLst xmlns:a="http://schemas.openxmlformats.org/drawingml/2006/main">
               <a:ext uri="{FF2B5EF4-FFF2-40B4-BE49-F238E27FC236}">
-                <a16:creationId xmlns:a16="http://schemas.microsoft.com/office/drawing/2014/main" id="{115F4E39-EA08-4F27-81E8-7ABFD4FBBCFC}"/>
+                <a16:creationId xmlns:a16="http://schemas.microsoft.com/office/drawing/2014/main" id="{2A4F3C19-F676-4AAD-8679-CE3C2F4FF3AD}"/>
               </a:ext>
             </a:extLst>
           </p:cNvPr>
@@ -9052,7 +9052,7 @@
           <p:cNvPr id="7" name="">
             <a:extLst xmlns:a="http://schemas.openxmlformats.org/drawingml/2006/main">
               <a:ext uri="{FF2B5EF4-FFF2-40B4-BE49-F238E27FC236}">
-                <a16:creationId xmlns:a16="http://schemas.microsoft.com/office/drawing/2014/main" id="{ED3D4719-76A3-47F2-8993-AF881C4D19D9}"/>
+                <a16:creationId xmlns:a16="http://schemas.microsoft.com/office/drawing/2014/main" id="{632B697E-24B3-4A4A-825E-EDFC26F97A6D}"/>
               </a:ext>
             </a:extLst>
           </p:cNvPr>
@@ -9120,7 +9120,7 @@
           <p:cNvPr id="8" name="">
             <a:extLst xmlns:a="http://schemas.openxmlformats.org/drawingml/2006/main">
               <a:ext uri="{FF2B5EF4-FFF2-40B4-BE49-F238E27FC236}">
-                <a16:creationId xmlns:a16="http://schemas.microsoft.com/office/drawing/2014/main" id="{A3210042-BE72-4A14-A89A-758F1FBDEA00}"/>
+                <a16:creationId xmlns:a16="http://schemas.microsoft.com/office/drawing/2014/main" id="{E10D99EB-F344-40A2-8680-B30A5967B0B7}"/>
               </a:ext>
             </a:extLst>
           </p:cNvPr>
@@ -9186,7 +9186,7 @@
     </p:spTree>
     <p:extLst>
       <p:ext uri="{BB962C8B-B14F-4D97-AF65-F5344CB8AC3E}">
-        <p14:creationId xmlns:p14="http://schemas.microsoft.com/office/powerpoint/2010/main" val="205282092"/>
+        <p14:creationId xmlns:p14="http://schemas.microsoft.com/office/powerpoint/2010/main" val="430292564"/>
       </p:ext>
     </p:extLst>
   </p:cSld>
@@ -9217,7 +9217,7 @@
           <p:cNvPr id="12" name="">
             <a:extLst xmlns:a="http://schemas.openxmlformats.org/drawingml/2006/main">
               <a:ext uri="{FF2B5EF4-FFF2-40B4-BE49-F238E27FC236}">
-                <a16:creationId xmlns:a16="http://schemas.microsoft.com/office/drawing/2014/main" id="{3232AA30-4563-49AE-BA1C-6D890574225E}"/>
+                <a16:creationId xmlns:a16="http://schemas.microsoft.com/office/drawing/2014/main" id="{B13F1884-2CF1-439B-B17E-06151E4BA86D}"/>
               </a:ext>
             </a:extLst>
           </p:cNvPr>
@@ -9285,7 +9285,7 @@
           <p:cNvPr id="2" name="">
             <a:extLst xmlns:a="http://schemas.openxmlformats.org/drawingml/2006/main">
               <a:ext uri="{FF2B5EF4-FFF2-40B4-BE49-F238E27FC236}">
-                <a16:creationId xmlns:a16="http://schemas.microsoft.com/office/drawing/2014/main" id="{28855756-76D0-4101-8283-78390AD34099}"/>
+                <a16:creationId xmlns:a16="http://schemas.microsoft.com/office/drawing/2014/main" id="{C69F7E25-9BA2-42AC-86B6-20F7768DD2E4}"/>
               </a:ext>
             </a:extLst>
           </p:cNvPr>
@@ -9353,7 +9353,7 @@
           <p:cNvPr id="3" name="">
             <a:extLst xmlns:a="http://schemas.openxmlformats.org/drawingml/2006/main">
               <a:ext uri="{FF2B5EF4-FFF2-40B4-BE49-F238E27FC236}">
-                <a16:creationId xmlns:a16="http://schemas.microsoft.com/office/drawing/2014/main" id="{9E1B0172-C146-4C1F-A2A6-F1AB5EB56BBA}"/>
+                <a16:creationId xmlns:a16="http://schemas.microsoft.com/office/drawing/2014/main" id="{973CFCB2-985F-42A8-A6CC-19DC685278FC}"/>
               </a:ext>
             </a:extLst>
           </p:cNvPr>
@@ -9421,7 +9421,7 @@
           <p:cNvPr id="4" name="">
             <a:extLst xmlns:a="http://schemas.openxmlformats.org/drawingml/2006/main">
               <a:ext uri="{FF2B5EF4-FFF2-40B4-BE49-F238E27FC236}">
-                <a16:creationId xmlns:a16="http://schemas.microsoft.com/office/drawing/2014/main" id="{F5DF2255-C1EF-4B5F-938E-4863528929A6}"/>
+                <a16:creationId xmlns:a16="http://schemas.microsoft.com/office/drawing/2014/main" id="{1A5ADDED-581D-412F-A159-067D2C575937}"/>
               </a:ext>
             </a:extLst>
           </p:cNvPr>
@@ -9545,7 +9545,7 @@
           <p:cNvPr id="5" name="">
             <a:extLst xmlns:a="http://schemas.openxmlformats.org/drawingml/2006/main">
               <a:ext uri="{FF2B5EF4-FFF2-40B4-BE49-F238E27FC236}">
-                <a16:creationId xmlns:a16="http://schemas.microsoft.com/office/drawing/2014/main" id="{AF2AFEB2-88E2-4BE9-A02D-271E463DC7EC}"/>
+                <a16:creationId xmlns:a16="http://schemas.microsoft.com/office/drawing/2014/main" id="{6BC40B09-FF7C-4A9E-8C13-B34000F366FF}"/>
               </a:ext>
             </a:extLst>
           </p:cNvPr>
@@ -9613,7 +9613,7 @@
           <p:cNvPr id="6" name="">
             <a:extLst xmlns:a="http://schemas.openxmlformats.org/drawingml/2006/main">
               <a:ext uri="{FF2B5EF4-FFF2-40B4-BE49-F238E27FC236}">
-                <a16:creationId xmlns:a16="http://schemas.microsoft.com/office/drawing/2014/main" id="{E534A852-838E-4020-94C7-A2D648E4B7B4}"/>
+                <a16:creationId xmlns:a16="http://schemas.microsoft.com/office/drawing/2014/main" id="{CA97A870-291F-420A-BEB6-CDF667FE99B1}"/>
               </a:ext>
             </a:extLst>
           </p:cNvPr>
@@ -9681,7 +9681,7 @@
           <p:cNvPr id="7" name="">
             <a:extLst xmlns:a="http://schemas.openxmlformats.org/drawingml/2006/main">
               <a:ext uri="{FF2B5EF4-FFF2-40B4-BE49-F238E27FC236}">
-                <a16:creationId xmlns:a16="http://schemas.microsoft.com/office/drawing/2014/main" id="{8FD0C43C-C2CC-4B55-9DDC-4B3014D42F3E}"/>
+                <a16:creationId xmlns:a16="http://schemas.microsoft.com/office/drawing/2014/main" id="{C9F30AED-0157-4918-BAA0-6325454211F2}"/>
               </a:ext>
             </a:extLst>
           </p:cNvPr>
@@ -9749,7 +9749,7 @@
           <p:cNvPr id="8" name="">
             <a:extLst xmlns:a="http://schemas.openxmlformats.org/drawingml/2006/main">
               <a:ext uri="{FF2B5EF4-FFF2-40B4-BE49-F238E27FC236}">
-                <a16:creationId xmlns:a16="http://schemas.microsoft.com/office/drawing/2014/main" id="{9AC6FBAC-D849-4FE8-A82D-EEDE5A832BF5}"/>
+                <a16:creationId xmlns:a16="http://schemas.microsoft.com/office/drawing/2014/main" id="{4C7396EF-3BBB-48C4-8845-1848B7729709}"/>
               </a:ext>
             </a:extLst>
           </p:cNvPr>
@@ -9817,7 +9817,7 @@
           <p:cNvPr id="9" name="">
             <a:extLst xmlns:a="http://schemas.openxmlformats.org/drawingml/2006/main">
               <a:ext uri="{FF2B5EF4-FFF2-40B4-BE49-F238E27FC236}">
-                <a16:creationId xmlns:a16="http://schemas.microsoft.com/office/drawing/2014/main" id="{274BF3BA-FF08-48B7-B564-21481E90B6BB}"/>
+                <a16:creationId xmlns:a16="http://schemas.microsoft.com/office/drawing/2014/main" id="{79AF57EC-7108-436B-AFBE-7B076D39270B}"/>
               </a:ext>
             </a:extLst>
           </p:cNvPr>
@@ -9885,7 +9885,7 @@
           <p:cNvPr id="10" name="">
             <a:extLst xmlns:a="http://schemas.openxmlformats.org/drawingml/2006/main">
               <a:ext uri="{FF2B5EF4-FFF2-40B4-BE49-F238E27FC236}">
-                <a16:creationId xmlns:a16="http://schemas.microsoft.com/office/drawing/2014/main" id="{75A96AD1-5298-443C-8DB8-D52F194F7F5E}"/>
+                <a16:creationId xmlns:a16="http://schemas.microsoft.com/office/drawing/2014/main" id="{F491EBBC-8C8A-4A84-8703-54F929467E22}"/>
               </a:ext>
             </a:extLst>
           </p:cNvPr>
@@ -9953,7 +9953,7 @@
           <p:cNvPr id="11" name="">
             <a:extLst xmlns:a="http://schemas.openxmlformats.org/drawingml/2006/main">
               <a:ext uri="{FF2B5EF4-FFF2-40B4-BE49-F238E27FC236}">
-                <a16:creationId xmlns:a16="http://schemas.microsoft.com/office/drawing/2014/main" id="{6226729D-8A0F-40F0-9402-5A4A9359C594}"/>
+                <a16:creationId xmlns:a16="http://schemas.microsoft.com/office/drawing/2014/main" id="{FB982330-0119-424D-B9A7-C2469631CC9E}"/>
               </a:ext>
             </a:extLst>
           </p:cNvPr>
@@ -10019,7 +10019,7 @@
     </p:spTree>
     <p:extLst>
       <p:ext uri="{BB962C8B-B14F-4D97-AF65-F5344CB8AC3E}">
-        <p14:creationId xmlns:p14="http://schemas.microsoft.com/office/powerpoint/2010/main" val="796789145"/>
+        <p14:creationId xmlns:p14="http://schemas.microsoft.com/office/powerpoint/2010/main" val="1281501583"/>
       </p:ext>
     </p:extLst>
   </p:cSld>
@@ -10050,7 +10050,7 @@
           <p:cNvPr id="7" name="">
             <a:extLst xmlns:a="http://schemas.openxmlformats.org/drawingml/2006/main">
               <a:ext uri="{FF2B5EF4-FFF2-40B4-BE49-F238E27FC236}">
-                <a16:creationId xmlns:a16="http://schemas.microsoft.com/office/drawing/2014/main" id="{A8B6D813-B580-40E0-9DB5-ED7CB1B71064}"/>
+                <a16:creationId xmlns:a16="http://schemas.microsoft.com/office/drawing/2014/main" id="{FE106447-3787-44CA-8F46-EA5A4B8CEE2F}"/>
               </a:ext>
             </a:extLst>
           </p:cNvPr>
@@ -10118,7 +10118,7 @@
           <p:cNvPr id="2" name="">
             <a:extLst xmlns:a="http://schemas.openxmlformats.org/drawingml/2006/main">
               <a:ext uri="{FF2B5EF4-FFF2-40B4-BE49-F238E27FC236}">
-                <a16:creationId xmlns:a16="http://schemas.microsoft.com/office/drawing/2014/main" id="{97CE3227-8BDC-4F03-A389-9CC1D09A853B}"/>
+                <a16:creationId xmlns:a16="http://schemas.microsoft.com/office/drawing/2014/main" id="{4269A628-B9DC-4AA1-A442-F725C951E037}"/>
               </a:ext>
             </a:extLst>
           </p:cNvPr>
@@ -10186,7 +10186,7 @@
           <p:cNvPr id="3" name="">
             <a:extLst xmlns:a="http://schemas.openxmlformats.org/drawingml/2006/main">
               <a:ext uri="{FF2B5EF4-FFF2-40B4-BE49-F238E27FC236}">
-                <a16:creationId xmlns:a16="http://schemas.microsoft.com/office/drawing/2014/main" id="{E37FF64F-463A-44B4-BD20-D8EA761868CE}"/>
+                <a16:creationId xmlns:a16="http://schemas.microsoft.com/office/drawing/2014/main" id="{E35B341E-8603-4C47-8EE6-634487B67564}"/>
               </a:ext>
             </a:extLst>
           </p:cNvPr>
@@ -10254,7 +10254,7 @@
           <p:cNvPr id="4" name="">
             <a:extLst xmlns:a="http://schemas.openxmlformats.org/drawingml/2006/main">
               <a:ext uri="{FF2B5EF4-FFF2-40B4-BE49-F238E27FC236}">
-                <a16:creationId xmlns:a16="http://schemas.microsoft.com/office/drawing/2014/main" id="{8082A936-C8AF-4778-AF93-C37E6B9E1782}"/>
+                <a16:creationId xmlns:a16="http://schemas.microsoft.com/office/drawing/2014/main" id="{5D827311-F904-4F63-BA1D-51751D08B89E}"/>
               </a:ext>
             </a:extLst>
           </p:cNvPr>
@@ -10378,7 +10378,7 @@
           <p:cNvPr id="5" name="">
             <a:extLst xmlns:a="http://schemas.openxmlformats.org/drawingml/2006/main">
               <a:ext uri="{FF2B5EF4-FFF2-40B4-BE49-F238E27FC236}">
-                <a16:creationId xmlns:a16="http://schemas.microsoft.com/office/drawing/2014/main" id="{5A002B86-A0C7-479F-A9A7-EF4832E0BE15}"/>
+                <a16:creationId xmlns:a16="http://schemas.microsoft.com/office/drawing/2014/main" id="{6AFFE6FE-1D53-4324-8210-67DFB95F7202}"/>
               </a:ext>
             </a:extLst>
           </p:cNvPr>
@@ -10446,7 +10446,7 @@
           <p:cNvPr id="6" name="">
             <a:extLst xmlns:a="http://schemas.openxmlformats.org/drawingml/2006/main">
               <a:ext uri="{FF2B5EF4-FFF2-40B4-BE49-F238E27FC236}">
-                <a16:creationId xmlns:a16="http://schemas.microsoft.com/office/drawing/2014/main" id="{FAAC3654-4199-444B-AE4E-73CA6853EEE3}"/>
+                <a16:creationId xmlns:a16="http://schemas.microsoft.com/office/drawing/2014/main" id="{30E792D5-AECC-44C2-849F-A8413B81D142}"/>
               </a:ext>
             </a:extLst>
           </p:cNvPr>
@@ -10512,7 +10512,7 @@
     </p:spTree>
     <p:extLst>
       <p:ext uri="{BB962C8B-B14F-4D97-AF65-F5344CB8AC3E}">
-        <p14:creationId xmlns:p14="http://schemas.microsoft.com/office/powerpoint/2010/main" val="970495517"/>
+        <p14:creationId xmlns:p14="http://schemas.microsoft.com/office/powerpoint/2010/main" val="1170949418"/>
       </p:ext>
     </p:extLst>
   </p:cSld>
@@ -10543,7 +10543,7 @@
           <p:cNvPr id="6" name="">
             <a:extLst xmlns:a="http://schemas.openxmlformats.org/drawingml/2006/main">
               <a:ext uri="{FF2B5EF4-FFF2-40B4-BE49-F238E27FC236}">
-                <a16:creationId xmlns:a16="http://schemas.microsoft.com/office/drawing/2014/main" id="{42A277FE-1EB4-417B-A973-1F2CC3C18E70}"/>
+                <a16:creationId xmlns:a16="http://schemas.microsoft.com/office/drawing/2014/main" id="{71429453-9437-4802-8337-5A395D078D45}"/>
               </a:ext>
             </a:extLst>
           </p:cNvPr>
@@ -10611,7 +10611,7 @@
           <p:cNvPr id="2" name="">
             <a:extLst xmlns:a="http://schemas.openxmlformats.org/drawingml/2006/main">
               <a:ext uri="{FF2B5EF4-FFF2-40B4-BE49-F238E27FC236}">
-                <a16:creationId xmlns:a16="http://schemas.microsoft.com/office/drawing/2014/main" id="{656E090A-7928-453A-8858-01904F7D6D69}"/>
+                <a16:creationId xmlns:a16="http://schemas.microsoft.com/office/drawing/2014/main" id="{331986B5-615D-4A7F-9060-14B5CA999631}"/>
               </a:ext>
             </a:extLst>
           </p:cNvPr>
@@ -10679,7 +10679,7 @@
           <p:cNvPr id="3" name="">
             <a:extLst xmlns:a="http://schemas.openxmlformats.org/drawingml/2006/main">
               <a:ext uri="{FF2B5EF4-FFF2-40B4-BE49-F238E27FC236}">
-                <a16:creationId xmlns:a16="http://schemas.microsoft.com/office/drawing/2014/main" id="{39D50ECA-919F-4F26-A456-D4ACE1A11C36}"/>
+                <a16:creationId xmlns:a16="http://schemas.microsoft.com/office/drawing/2014/main" id="{FDA81A3E-C3EE-4D72-ADD8-F78050B04BC7}"/>
               </a:ext>
             </a:extLst>
           </p:cNvPr>
@@ -10747,7 +10747,7 @@
           <p:cNvPr id="4" name="">
             <a:extLst xmlns:a="http://schemas.openxmlformats.org/drawingml/2006/main">
               <a:ext uri="{FF2B5EF4-FFF2-40B4-BE49-F238E27FC236}">
-                <a16:creationId xmlns:a16="http://schemas.microsoft.com/office/drawing/2014/main" id="{689E212D-48C6-4B51-B576-67CA60E7F596}"/>
+                <a16:creationId xmlns:a16="http://schemas.microsoft.com/office/drawing/2014/main" id="{9E0146DB-C7FF-4C27-A5A1-42146CD5D451}"/>
               </a:ext>
             </a:extLst>
           </p:cNvPr>
@@ -10757,7 +10757,7 @@
           <p:nvPr/>
         </p:nvPicPr>
         <p:blipFill>
-          <a:blip xmlns:r="http://schemas.openxmlformats.org/officeDocument/2006/relationships" xmlns:a="http://schemas.openxmlformats.org/drawingml/2006/main" r:embed="Rfd1474f4b55641bb"/>
+          <a:blip xmlns:r="http://schemas.openxmlformats.org/officeDocument/2006/relationships" xmlns:a="http://schemas.openxmlformats.org/drawingml/2006/main" r:embed="R7d8d6dea4398458f"/>
           <a:stretch xmlns:a="http://schemas.openxmlformats.org/drawingml/2006/main"/>
         </p:blipFill>
         <p:spPr>
@@ -10775,7 +10775,7 @@
           <p:cNvPr id="5" name="">
             <a:extLst xmlns:a="http://schemas.openxmlformats.org/drawingml/2006/main">
               <a:ext uri="{FF2B5EF4-FFF2-40B4-BE49-F238E27FC236}">
-                <a16:creationId xmlns:a16="http://schemas.microsoft.com/office/drawing/2014/main" id="{109F8F30-2F38-4BE3-A4E0-AECD465876B5}"/>
+                <a16:creationId xmlns:a16="http://schemas.microsoft.com/office/drawing/2014/main" id="{4293B6CF-5179-4356-8DEA-55882BDF3260}"/>
               </a:ext>
             </a:extLst>
           </p:cNvPr>
@@ -10869,7 +10869,7 @@
     </p:spTree>
     <p:extLst>
       <p:ext uri="{BB962C8B-B14F-4D97-AF65-F5344CB8AC3E}">
-        <p14:creationId xmlns:p14="http://schemas.microsoft.com/office/powerpoint/2010/main" val="58673776"/>
+        <p14:creationId xmlns:p14="http://schemas.microsoft.com/office/powerpoint/2010/main" val="1180680312"/>
       </p:ext>
     </p:extLst>
   </p:cSld>
@@ -10900,7 +10900,7 @@
           <p:cNvPr id="13" name="">
             <a:extLst xmlns:a="http://schemas.openxmlformats.org/drawingml/2006/main">
               <a:ext uri="{FF2B5EF4-FFF2-40B4-BE49-F238E27FC236}">
-                <a16:creationId xmlns:a16="http://schemas.microsoft.com/office/drawing/2014/main" id="{B003D930-9B22-43D0-B457-C0E8D7039BC5}"/>
+                <a16:creationId xmlns:a16="http://schemas.microsoft.com/office/drawing/2014/main" id="{F5E9552E-2517-43FC-B894-D8A8B7192F32}"/>
               </a:ext>
             </a:extLst>
           </p:cNvPr>
@@ -10968,7 +10968,7 @@
           <p:cNvPr id="2" name="">
             <a:extLst xmlns:a="http://schemas.openxmlformats.org/drawingml/2006/main">
               <a:ext uri="{FF2B5EF4-FFF2-40B4-BE49-F238E27FC236}">
-                <a16:creationId xmlns:a16="http://schemas.microsoft.com/office/drawing/2014/main" id="{AE452F05-4E5F-4F3B-BDCE-DA4909DDF93F}"/>
+                <a16:creationId xmlns:a16="http://schemas.microsoft.com/office/drawing/2014/main" id="{B0C408D2-5794-449A-8EC9-FFE7318A5749}"/>
               </a:ext>
             </a:extLst>
           </p:cNvPr>
@@ -11036,7 +11036,7 @@
           <p:cNvPr id="3" name="">
             <a:extLst xmlns:a="http://schemas.openxmlformats.org/drawingml/2006/main">
               <a:ext uri="{FF2B5EF4-FFF2-40B4-BE49-F238E27FC236}">
-                <a16:creationId xmlns:a16="http://schemas.microsoft.com/office/drawing/2014/main" id="{CDA80811-B454-4264-914C-B674CBA63CAB}"/>
+                <a16:creationId xmlns:a16="http://schemas.microsoft.com/office/drawing/2014/main" id="{D47450FF-BE9E-4AAF-9AE8-7C0EFA966FAC}"/>
               </a:ext>
             </a:extLst>
           </p:cNvPr>
@@ -11104,7 +11104,7 @@
           <p:cNvPr id="4" name="">
             <a:extLst xmlns:a="http://schemas.openxmlformats.org/drawingml/2006/main">
               <a:ext uri="{FF2B5EF4-FFF2-40B4-BE49-F238E27FC236}">
-                <a16:creationId xmlns:a16="http://schemas.microsoft.com/office/drawing/2014/main" id="{0A50EEE8-D93F-4A11-B195-0C3F4508C1C6}"/>
+                <a16:creationId xmlns:a16="http://schemas.microsoft.com/office/drawing/2014/main" id="{7253028E-AD87-4970-9DE7-1088E99FD332}"/>
               </a:ext>
             </a:extLst>
           </p:cNvPr>
@@ -11200,7 +11200,7 @@
           <p:cNvPr id="5" name="">
             <a:extLst xmlns:a="http://schemas.openxmlformats.org/drawingml/2006/main">
               <a:ext uri="{FF2B5EF4-FFF2-40B4-BE49-F238E27FC236}">
-                <a16:creationId xmlns:a16="http://schemas.microsoft.com/office/drawing/2014/main" id="{0D69BC31-1BC2-4108-B61E-4707EB59C355}"/>
+                <a16:creationId xmlns:a16="http://schemas.microsoft.com/office/drawing/2014/main" id="{75F0DAC0-6737-485F-A811-E1A79A8567EF}"/>
               </a:ext>
             </a:extLst>
           </p:cNvPr>
@@ -11268,7 +11268,7 @@
           <p:cNvPr id="6" name="">
             <a:extLst xmlns:a="http://schemas.openxmlformats.org/drawingml/2006/main">
               <a:ext uri="{FF2B5EF4-FFF2-40B4-BE49-F238E27FC236}">
-                <a16:creationId xmlns:a16="http://schemas.microsoft.com/office/drawing/2014/main" id="{2D948D21-39F2-4CC9-871E-1E09EBEF3419}"/>
+                <a16:creationId xmlns:a16="http://schemas.microsoft.com/office/drawing/2014/main" id="{97536179-4268-45AB-A866-9A899EA13D5B}"/>
               </a:ext>
             </a:extLst>
           </p:cNvPr>
@@ -11336,7 +11336,7 @@
           <p:cNvPr id="7" name="">
             <a:extLst xmlns:a="http://schemas.openxmlformats.org/drawingml/2006/main">
               <a:ext uri="{FF2B5EF4-FFF2-40B4-BE49-F238E27FC236}">
-                <a16:creationId xmlns:a16="http://schemas.microsoft.com/office/drawing/2014/main" id="{55F29E41-8E11-499B-854C-F9DAE8B08490}"/>
+                <a16:creationId xmlns:a16="http://schemas.microsoft.com/office/drawing/2014/main" id="{BE8366B6-4A8D-4C6B-80AA-61872FC9E1D9}"/>
               </a:ext>
             </a:extLst>
           </p:cNvPr>
@@ -11404,7 +11404,7 @@
           <p:cNvPr id="8" name="">
             <a:extLst xmlns:a="http://schemas.openxmlformats.org/drawingml/2006/main">
               <a:ext uri="{FF2B5EF4-FFF2-40B4-BE49-F238E27FC236}">
-                <a16:creationId xmlns:a16="http://schemas.microsoft.com/office/drawing/2014/main" id="{9272AB2D-F7D6-4160-AD15-3A5C306D5ACD}"/>
+                <a16:creationId xmlns:a16="http://schemas.microsoft.com/office/drawing/2014/main" id="{DF8EF74D-1A20-4C5B-AE6E-ED2E0B4C2682}"/>
               </a:ext>
             </a:extLst>
           </p:cNvPr>
@@ -11472,7 +11472,7 @@
           <p:cNvPr id="9" name="">
             <a:extLst xmlns:a="http://schemas.openxmlformats.org/drawingml/2006/main">
               <a:ext uri="{FF2B5EF4-FFF2-40B4-BE49-F238E27FC236}">
-                <a16:creationId xmlns:a16="http://schemas.microsoft.com/office/drawing/2014/main" id="{0C5702D9-DC0D-467A-A788-D2A38496FC29}"/>
+                <a16:creationId xmlns:a16="http://schemas.microsoft.com/office/drawing/2014/main" id="{F77E0414-525E-4A27-A4B8-8C5D87908423}"/>
               </a:ext>
             </a:extLst>
           </p:cNvPr>
@@ -11540,7 +11540,7 @@
           <p:cNvPr id="10" name="">
             <a:extLst xmlns:a="http://schemas.openxmlformats.org/drawingml/2006/main">
               <a:ext uri="{FF2B5EF4-FFF2-40B4-BE49-F238E27FC236}">
-                <a16:creationId xmlns:a16="http://schemas.microsoft.com/office/drawing/2014/main" id="{2BEA2D4F-9AA8-4445-8FFD-1DF8F7E56C42}"/>
+                <a16:creationId xmlns:a16="http://schemas.microsoft.com/office/drawing/2014/main" id="{B4B407DE-021B-4825-ADE7-63FDDBEA972C}"/>
               </a:ext>
             </a:extLst>
           </p:cNvPr>
@@ -11608,7 +11608,7 @@
           <p:cNvPr id="11" name="">
             <a:extLst xmlns:a="http://schemas.openxmlformats.org/drawingml/2006/main">
               <a:ext uri="{FF2B5EF4-FFF2-40B4-BE49-F238E27FC236}">
-                <a16:creationId xmlns:a16="http://schemas.microsoft.com/office/drawing/2014/main" id="{67DD26D5-4364-4847-80A0-47AB9F65BC35}"/>
+                <a16:creationId xmlns:a16="http://schemas.microsoft.com/office/drawing/2014/main" id="{034D38F3-2B5A-4F69-B3B4-ADADF656AC8C}"/>
               </a:ext>
             </a:extLst>
           </p:cNvPr>
@@ -11676,7 +11676,7 @@
           <p:cNvPr id="12" name="">
             <a:extLst xmlns:a="http://schemas.openxmlformats.org/drawingml/2006/main">
               <a:ext uri="{FF2B5EF4-FFF2-40B4-BE49-F238E27FC236}">
-                <a16:creationId xmlns:a16="http://schemas.microsoft.com/office/drawing/2014/main" id="{236EB603-DEB9-4868-B68C-E6D700AC88C4}"/>
+                <a16:creationId xmlns:a16="http://schemas.microsoft.com/office/drawing/2014/main" id="{9F8A5EA7-79D3-4552-90FA-5D9BD24C7E87}"/>
               </a:ext>
             </a:extLst>
           </p:cNvPr>
@@ -11742,7 +11742,7 @@
     </p:spTree>
     <p:extLst>
       <p:ext uri="{BB962C8B-B14F-4D97-AF65-F5344CB8AC3E}">
-        <p14:creationId xmlns:p14="http://schemas.microsoft.com/office/powerpoint/2010/main" val="573968668"/>
+        <p14:creationId xmlns:p14="http://schemas.microsoft.com/office/powerpoint/2010/main" val="1318434696"/>
       </p:ext>
     </p:extLst>
   </p:cSld>
@@ -11773,7 +11773,7 @@
           <p:cNvPr id="7" name="">
             <a:extLst xmlns:a="http://schemas.openxmlformats.org/drawingml/2006/main">
               <a:ext uri="{FF2B5EF4-FFF2-40B4-BE49-F238E27FC236}">
-                <a16:creationId xmlns:a16="http://schemas.microsoft.com/office/drawing/2014/main" id="{7CD0B60F-A94B-4E78-939F-2531D947626F}"/>
+                <a16:creationId xmlns:a16="http://schemas.microsoft.com/office/drawing/2014/main" id="{BA51A858-D4F8-417B-93D2-B46885BE0D5B}"/>
               </a:ext>
             </a:extLst>
           </p:cNvPr>
@@ -11841,7 +11841,7 @@
           <p:cNvPr id="2" name="">
             <a:extLst xmlns:a="http://schemas.openxmlformats.org/drawingml/2006/main">
               <a:ext uri="{FF2B5EF4-FFF2-40B4-BE49-F238E27FC236}">
-                <a16:creationId xmlns:a16="http://schemas.microsoft.com/office/drawing/2014/main" id="{99B51963-06FC-4404-8F12-83B42042355D}"/>
+                <a16:creationId xmlns:a16="http://schemas.microsoft.com/office/drawing/2014/main" id="{B3620DA0-7805-4557-AC22-B218329520C9}"/>
               </a:ext>
             </a:extLst>
           </p:cNvPr>
@@ -11909,7 +11909,7 @@
           <p:cNvPr id="3" name="">
             <a:extLst xmlns:a="http://schemas.openxmlformats.org/drawingml/2006/main">
               <a:ext uri="{FF2B5EF4-FFF2-40B4-BE49-F238E27FC236}">
-                <a16:creationId xmlns:a16="http://schemas.microsoft.com/office/drawing/2014/main" id="{79EAC2D1-08FC-4CD7-9282-6132F3FE8863}"/>
+                <a16:creationId xmlns:a16="http://schemas.microsoft.com/office/drawing/2014/main" id="{18FA4639-84A5-463C-8F1E-E836C4DCD48C}"/>
               </a:ext>
             </a:extLst>
           </p:cNvPr>
@@ -11977,7 +11977,7 @@
           <p:cNvPr id="4" name="">
             <a:extLst xmlns:a="http://schemas.openxmlformats.org/drawingml/2006/main">
               <a:ext uri="{FF2B5EF4-FFF2-40B4-BE49-F238E27FC236}">
-                <a16:creationId xmlns:a16="http://schemas.microsoft.com/office/drawing/2014/main" id="{A2A5E04D-7E7E-4837-B6CB-4E298DFFADCC}"/>
+                <a16:creationId xmlns:a16="http://schemas.microsoft.com/office/drawing/2014/main" id="{D8FE4618-9EFA-4F63-83C7-88381EDE7FD9}"/>
               </a:ext>
             </a:extLst>
           </p:cNvPr>
@@ -12101,7 +12101,7 @@
           <p:cNvPr id="5" name="">
             <a:extLst xmlns:a="http://schemas.openxmlformats.org/drawingml/2006/main">
               <a:ext uri="{FF2B5EF4-FFF2-40B4-BE49-F238E27FC236}">
-                <a16:creationId xmlns:a16="http://schemas.microsoft.com/office/drawing/2014/main" id="{65BA0320-1EF0-43C4-B32C-FF7243C6DA1E}"/>
+                <a16:creationId xmlns:a16="http://schemas.microsoft.com/office/drawing/2014/main" id="{02F6328F-2850-4F29-A6D2-A49A983FC05C}"/>
               </a:ext>
             </a:extLst>
           </p:cNvPr>
@@ -12169,7 +12169,7 @@
           <p:cNvPr id="6" name="">
             <a:extLst xmlns:a="http://schemas.openxmlformats.org/drawingml/2006/main">
               <a:ext uri="{FF2B5EF4-FFF2-40B4-BE49-F238E27FC236}">
-                <a16:creationId xmlns:a16="http://schemas.microsoft.com/office/drawing/2014/main" id="{5AA6F01D-48E1-4486-B624-F8E250FCFF86}"/>
+                <a16:creationId xmlns:a16="http://schemas.microsoft.com/office/drawing/2014/main" id="{53BE7E2E-B67B-4D70-8E8C-1415D26EEDE1}"/>
               </a:ext>
             </a:extLst>
           </p:cNvPr>
@@ -12235,7 +12235,7 @@
     </p:spTree>
     <p:extLst>
       <p:ext uri="{BB962C8B-B14F-4D97-AF65-F5344CB8AC3E}">
-        <p14:creationId xmlns:p14="http://schemas.microsoft.com/office/powerpoint/2010/main" val="396865389"/>
+        <p14:creationId xmlns:p14="http://schemas.microsoft.com/office/powerpoint/2010/main" val="272195121"/>
       </p:ext>
     </p:extLst>
   </p:cSld>
@@ -12266,7 +12266,7 @@
           <p:cNvPr id="13" name="">
             <a:extLst xmlns:a="http://schemas.openxmlformats.org/drawingml/2006/main">
               <a:ext uri="{FF2B5EF4-FFF2-40B4-BE49-F238E27FC236}">
-                <a16:creationId xmlns:a16="http://schemas.microsoft.com/office/drawing/2014/main" id="{A528FE1D-E0A6-4790-984B-2C6EAF26DBFA}"/>
+                <a16:creationId xmlns:a16="http://schemas.microsoft.com/office/drawing/2014/main" id="{620B4E25-8509-4C8A-B67F-4BBB8A2E32E5}"/>
               </a:ext>
             </a:extLst>
           </p:cNvPr>
@@ -12334,7 +12334,7 @@
           <p:cNvPr id="2" name="">
             <a:extLst xmlns:a="http://schemas.openxmlformats.org/drawingml/2006/main">
               <a:ext uri="{FF2B5EF4-FFF2-40B4-BE49-F238E27FC236}">
-                <a16:creationId xmlns:a16="http://schemas.microsoft.com/office/drawing/2014/main" id="{B8E45BEB-388A-436E-B830-C870306263F0}"/>
+                <a16:creationId xmlns:a16="http://schemas.microsoft.com/office/drawing/2014/main" id="{7184CAB3-4FC8-4A02-9B34-83B1038EC88C}"/>
               </a:ext>
             </a:extLst>
           </p:cNvPr>
@@ -12402,7 +12402,7 @@
           <p:cNvPr id="3" name="">
             <a:extLst xmlns:a="http://schemas.openxmlformats.org/drawingml/2006/main">
               <a:ext uri="{FF2B5EF4-FFF2-40B4-BE49-F238E27FC236}">
-                <a16:creationId xmlns:a16="http://schemas.microsoft.com/office/drawing/2014/main" id="{8EC24DB3-E188-4FCE-932A-14E02984E2CC}"/>
+                <a16:creationId xmlns:a16="http://schemas.microsoft.com/office/drawing/2014/main" id="{E527F78E-6459-409D-B353-06700158A39E}"/>
               </a:ext>
             </a:extLst>
           </p:cNvPr>
@@ -12470,7 +12470,7 @@
           <p:cNvPr id="4" name="">
             <a:extLst xmlns:a="http://schemas.openxmlformats.org/drawingml/2006/main">
               <a:ext uri="{FF2B5EF4-FFF2-40B4-BE49-F238E27FC236}">
-                <a16:creationId xmlns:a16="http://schemas.microsoft.com/office/drawing/2014/main" id="{D2D0C013-CF20-4B87-8310-AED92509C975}"/>
+                <a16:creationId xmlns:a16="http://schemas.microsoft.com/office/drawing/2014/main" id="{99EFDA12-35EF-4885-8F9E-735B617FE173}"/>
               </a:ext>
             </a:extLst>
           </p:cNvPr>
@@ -12594,7 +12594,7 @@
           <p:cNvPr id="5" name="">
             <a:extLst xmlns:a="http://schemas.openxmlformats.org/drawingml/2006/main">
               <a:ext uri="{FF2B5EF4-FFF2-40B4-BE49-F238E27FC236}">
-                <a16:creationId xmlns:a16="http://schemas.microsoft.com/office/drawing/2014/main" id="{57EF13A0-82DC-440B-AB6C-F6BC43FB330C}"/>
+                <a16:creationId xmlns:a16="http://schemas.microsoft.com/office/drawing/2014/main" id="{5A034EDA-DADA-4C6F-AE6F-AFCE3A39C096}"/>
               </a:ext>
             </a:extLst>
           </p:cNvPr>
@@ -12662,7 +12662,7 @@
           <p:cNvPr id="6" name="">
             <a:extLst xmlns:a="http://schemas.openxmlformats.org/drawingml/2006/main">
               <a:ext uri="{FF2B5EF4-FFF2-40B4-BE49-F238E27FC236}">
-                <a16:creationId xmlns:a16="http://schemas.microsoft.com/office/drawing/2014/main" id="{9065CE0F-213D-4B98-B1EF-363ED4C1D1FA}"/>
+                <a16:creationId xmlns:a16="http://schemas.microsoft.com/office/drawing/2014/main" id="{41BBB377-DC1A-4275-A06B-C71A9F2A97DF}"/>
               </a:ext>
             </a:extLst>
           </p:cNvPr>
@@ -12730,7 +12730,7 @@
           <p:cNvPr id="7" name="">
             <a:extLst xmlns:a="http://schemas.openxmlformats.org/drawingml/2006/main">
               <a:ext uri="{FF2B5EF4-FFF2-40B4-BE49-F238E27FC236}">
-                <a16:creationId xmlns:a16="http://schemas.microsoft.com/office/drawing/2014/main" id="{A3082520-C9ED-430B-A82B-3E5C93065DA5}"/>
+                <a16:creationId xmlns:a16="http://schemas.microsoft.com/office/drawing/2014/main" id="{A84D3869-A59E-49B0-BE60-9324DF280D3F}"/>
               </a:ext>
             </a:extLst>
           </p:cNvPr>
@@ -12798,7 +12798,7 @@
           <p:cNvPr id="8" name="">
             <a:extLst xmlns:a="http://schemas.openxmlformats.org/drawingml/2006/main">
               <a:ext uri="{FF2B5EF4-FFF2-40B4-BE49-F238E27FC236}">
-                <a16:creationId xmlns:a16="http://schemas.microsoft.com/office/drawing/2014/main" id="{66042313-CC72-462C-9372-3791AE69CD18}"/>
+                <a16:creationId xmlns:a16="http://schemas.microsoft.com/office/drawing/2014/main" id="{5D13C688-DE7A-4172-8D45-28EE69D7ED20}"/>
               </a:ext>
             </a:extLst>
           </p:cNvPr>
@@ -12866,7 +12866,7 @@
           <p:cNvPr id="9" name="">
             <a:extLst xmlns:a="http://schemas.openxmlformats.org/drawingml/2006/main">
               <a:ext uri="{FF2B5EF4-FFF2-40B4-BE49-F238E27FC236}">
-                <a16:creationId xmlns:a16="http://schemas.microsoft.com/office/drawing/2014/main" id="{D95F5ECE-76CD-41DB-9654-88AF30E438EE}"/>
+                <a16:creationId xmlns:a16="http://schemas.microsoft.com/office/drawing/2014/main" id="{E0A02E1A-C968-4612-BDFC-76B0235E74D1}"/>
               </a:ext>
             </a:extLst>
           </p:cNvPr>
@@ -12934,7 +12934,7 @@
           <p:cNvPr id="10" name="">
             <a:extLst xmlns:a="http://schemas.openxmlformats.org/drawingml/2006/main">
               <a:ext uri="{FF2B5EF4-FFF2-40B4-BE49-F238E27FC236}">
-                <a16:creationId xmlns:a16="http://schemas.microsoft.com/office/drawing/2014/main" id="{A9A094F7-67C4-4F65-A144-70880085AF8D}"/>
+                <a16:creationId xmlns:a16="http://schemas.microsoft.com/office/drawing/2014/main" id="{0A5CF926-2EEC-42C8-B059-D60E9BA0E604}"/>
               </a:ext>
             </a:extLst>
           </p:cNvPr>
@@ -13002,7 +13002,7 @@
           <p:cNvPr id="11" name="">
             <a:extLst xmlns:a="http://schemas.openxmlformats.org/drawingml/2006/main">
               <a:ext uri="{FF2B5EF4-FFF2-40B4-BE49-F238E27FC236}">
-                <a16:creationId xmlns:a16="http://schemas.microsoft.com/office/drawing/2014/main" id="{10ED630F-D969-4EE6-89CD-C5DE567F4FE4}"/>
+                <a16:creationId xmlns:a16="http://schemas.microsoft.com/office/drawing/2014/main" id="{B177C3BA-2DD1-42A7-85EC-5F2D844D28D0}"/>
               </a:ext>
             </a:extLst>
           </p:cNvPr>
@@ -13070,7 +13070,7 @@
           <p:cNvPr id="12" name="">
             <a:extLst xmlns:a="http://schemas.openxmlformats.org/drawingml/2006/main">
               <a:ext uri="{FF2B5EF4-FFF2-40B4-BE49-F238E27FC236}">
-                <a16:creationId xmlns:a16="http://schemas.microsoft.com/office/drawing/2014/main" id="{09C626C9-2389-4E86-95AE-5681FC8184B4}"/>
+                <a16:creationId xmlns:a16="http://schemas.microsoft.com/office/drawing/2014/main" id="{9F14B02D-AC3F-4A61-8660-73878780B7B2}"/>
               </a:ext>
             </a:extLst>
           </p:cNvPr>
@@ -13136,7 +13136,7 @@
     </p:spTree>
     <p:extLst>
       <p:ext uri="{BB962C8B-B14F-4D97-AF65-F5344CB8AC3E}">
-        <p14:creationId xmlns:p14="http://schemas.microsoft.com/office/powerpoint/2010/main" val="537550378"/>
+        <p14:creationId xmlns:p14="http://schemas.microsoft.com/office/powerpoint/2010/main" val="1884389725"/>
       </p:ext>
     </p:extLst>
   </p:cSld>
@@ -13167,7 +13167,7 @@
           <p:cNvPr id="11" name="">
             <a:extLst xmlns:a="http://schemas.openxmlformats.org/drawingml/2006/main">
               <a:ext uri="{FF2B5EF4-FFF2-40B4-BE49-F238E27FC236}">
-                <a16:creationId xmlns:a16="http://schemas.microsoft.com/office/drawing/2014/main" id="{F27458BD-D01F-4979-A2D6-7BCDBA8B9D69}"/>
+                <a16:creationId xmlns:a16="http://schemas.microsoft.com/office/drawing/2014/main" id="{3E3A73E6-144E-4F20-AF29-99742B152642}"/>
               </a:ext>
             </a:extLst>
           </p:cNvPr>
@@ -13235,7 +13235,7 @@
           <p:cNvPr id="2" name="">
             <a:extLst xmlns:a="http://schemas.openxmlformats.org/drawingml/2006/main">
               <a:ext uri="{FF2B5EF4-FFF2-40B4-BE49-F238E27FC236}">
-                <a16:creationId xmlns:a16="http://schemas.microsoft.com/office/drawing/2014/main" id="{E3D02E63-0F87-42C6-839D-93C77A3AED87}"/>
+                <a16:creationId xmlns:a16="http://schemas.microsoft.com/office/drawing/2014/main" id="{E21C9F26-11AA-411E-AC36-06AEED4875B3}"/>
               </a:ext>
             </a:extLst>
           </p:cNvPr>
@@ -13303,7 +13303,7 @@
           <p:cNvPr id="3" name="">
             <a:extLst xmlns:a="http://schemas.openxmlformats.org/drawingml/2006/main">
               <a:ext uri="{FF2B5EF4-FFF2-40B4-BE49-F238E27FC236}">
-                <a16:creationId xmlns:a16="http://schemas.microsoft.com/office/drawing/2014/main" id="{83CAD14D-021F-4C92-B749-F67D13A7454B}"/>
+                <a16:creationId xmlns:a16="http://schemas.microsoft.com/office/drawing/2014/main" id="{95934B1B-51AB-4950-94A6-63B20FDB538C}"/>
               </a:ext>
             </a:extLst>
           </p:cNvPr>
@@ -13371,7 +13371,7 @@
           <p:cNvPr id="4" name="">
             <a:extLst xmlns:a="http://schemas.openxmlformats.org/drawingml/2006/main">
               <a:ext uri="{FF2B5EF4-FFF2-40B4-BE49-F238E27FC236}">
-                <a16:creationId xmlns:a16="http://schemas.microsoft.com/office/drawing/2014/main" id="{11BF36DC-AC73-4F67-B340-F0DC655AFB42}"/>
+                <a16:creationId xmlns:a16="http://schemas.microsoft.com/office/drawing/2014/main" id="{F10BA976-1ED2-489D-BEB6-919FE45C0310}"/>
               </a:ext>
             </a:extLst>
           </p:cNvPr>
@@ -13495,7 +13495,7 @@
           <p:cNvPr id="5" name="">
             <a:extLst xmlns:a="http://schemas.openxmlformats.org/drawingml/2006/main">
               <a:ext uri="{FF2B5EF4-FFF2-40B4-BE49-F238E27FC236}">
-                <a16:creationId xmlns:a16="http://schemas.microsoft.com/office/drawing/2014/main" id="{19F4746E-663B-4885-A32D-180035C911CB}"/>
+                <a16:creationId xmlns:a16="http://schemas.microsoft.com/office/drawing/2014/main" id="{478E12BB-CD4B-41CC-8B43-84F96944F8FB}"/>
               </a:ext>
             </a:extLst>
           </p:cNvPr>
@@ -13563,7 +13563,7 @@
           <p:cNvPr id="6" name="">
             <a:extLst xmlns:a="http://schemas.openxmlformats.org/drawingml/2006/main">
               <a:ext uri="{FF2B5EF4-FFF2-40B4-BE49-F238E27FC236}">
-                <a16:creationId xmlns:a16="http://schemas.microsoft.com/office/drawing/2014/main" id="{27F724E1-81D1-4F9E-BF1F-D5696DC24685}"/>
+                <a16:creationId xmlns:a16="http://schemas.microsoft.com/office/drawing/2014/main" id="{A0C77C49-DE46-4FE5-8D4A-F45F0E911C85}"/>
               </a:ext>
             </a:extLst>
           </p:cNvPr>
@@ -13631,7 +13631,7 @@
           <p:cNvPr id="7" name="">
             <a:extLst xmlns:a="http://schemas.openxmlformats.org/drawingml/2006/main">
               <a:ext uri="{FF2B5EF4-FFF2-40B4-BE49-F238E27FC236}">
-                <a16:creationId xmlns:a16="http://schemas.microsoft.com/office/drawing/2014/main" id="{C7E6941A-E6E6-49D4-A06B-978ABAB5B33A}"/>
+                <a16:creationId xmlns:a16="http://schemas.microsoft.com/office/drawing/2014/main" id="{91D6C2CB-E38C-4F60-93F9-583B01B0E284}"/>
               </a:ext>
             </a:extLst>
           </p:cNvPr>
@@ -13699,7 +13699,7 @@
           <p:cNvPr id="8" name="">
             <a:extLst xmlns:a="http://schemas.openxmlformats.org/drawingml/2006/main">
               <a:ext uri="{FF2B5EF4-FFF2-40B4-BE49-F238E27FC236}">
-                <a16:creationId xmlns:a16="http://schemas.microsoft.com/office/drawing/2014/main" id="{715DF19D-B54C-4B18-813B-C75AD30F548D}"/>
+                <a16:creationId xmlns:a16="http://schemas.microsoft.com/office/drawing/2014/main" id="{7CC2ED0B-610C-4FCE-B408-0CC0533C4E3C}"/>
               </a:ext>
             </a:extLst>
           </p:cNvPr>
@@ -13767,7 +13767,7 @@
           <p:cNvPr id="9" name="">
             <a:extLst xmlns:a="http://schemas.openxmlformats.org/drawingml/2006/main">
               <a:ext uri="{FF2B5EF4-FFF2-40B4-BE49-F238E27FC236}">
-                <a16:creationId xmlns:a16="http://schemas.microsoft.com/office/drawing/2014/main" id="{14A87FDB-ACC5-4723-8D60-23B12B0A09EC}"/>
+                <a16:creationId xmlns:a16="http://schemas.microsoft.com/office/drawing/2014/main" id="{E5F68A65-CE0F-4FD6-96DA-C0C3B96EA1E2}"/>
               </a:ext>
             </a:extLst>
           </p:cNvPr>
@@ -13835,7 +13835,7 @@
           <p:cNvPr id="10" name="">
             <a:extLst xmlns:a="http://schemas.openxmlformats.org/drawingml/2006/main">
               <a:ext uri="{FF2B5EF4-FFF2-40B4-BE49-F238E27FC236}">
-                <a16:creationId xmlns:a16="http://schemas.microsoft.com/office/drawing/2014/main" id="{657ED430-36A9-4AD6-A041-6281DEF73AAD}"/>
+                <a16:creationId xmlns:a16="http://schemas.microsoft.com/office/drawing/2014/main" id="{95CBD2F6-10D2-458B-BD67-411C65600D10}"/>
               </a:ext>
             </a:extLst>
           </p:cNvPr>
@@ -13901,7 +13901,7 @@
     </p:spTree>
     <p:extLst>
       <p:ext uri="{BB962C8B-B14F-4D97-AF65-F5344CB8AC3E}">
-        <p14:creationId xmlns:p14="http://schemas.microsoft.com/office/powerpoint/2010/main" val="128137568"/>
+        <p14:creationId xmlns:p14="http://schemas.microsoft.com/office/powerpoint/2010/main" val="1481213039"/>
       </p:ext>
     </p:extLst>
   </p:cSld>
@@ -13932,7 +13932,7 @@
           <p:cNvPr id="11" name="">
             <a:extLst xmlns:a="http://schemas.openxmlformats.org/drawingml/2006/main">
               <a:ext uri="{FF2B5EF4-FFF2-40B4-BE49-F238E27FC236}">
-                <a16:creationId xmlns:a16="http://schemas.microsoft.com/office/drawing/2014/main" id="{FBA538C5-90B5-48B4-BDAB-11E7A275BA23}"/>
+                <a16:creationId xmlns:a16="http://schemas.microsoft.com/office/drawing/2014/main" id="{BCD30695-78C6-4E22-A738-E15DD3CBE257}"/>
               </a:ext>
             </a:extLst>
           </p:cNvPr>
@@ -14000,7 +14000,7 @@
           <p:cNvPr id="2" name="">
             <a:extLst xmlns:a="http://schemas.openxmlformats.org/drawingml/2006/main">
               <a:ext uri="{FF2B5EF4-FFF2-40B4-BE49-F238E27FC236}">
-                <a16:creationId xmlns:a16="http://schemas.microsoft.com/office/drawing/2014/main" id="{DBC8B3BB-4F44-49E1-94E4-FFF76FFC9812}"/>
+                <a16:creationId xmlns:a16="http://schemas.microsoft.com/office/drawing/2014/main" id="{C0CA073E-4944-4C82-A4A0-BD1C52021888}"/>
               </a:ext>
             </a:extLst>
           </p:cNvPr>
@@ -14068,7 +14068,7 @@
           <p:cNvPr id="3" name="">
             <a:extLst xmlns:a="http://schemas.openxmlformats.org/drawingml/2006/main">
               <a:ext uri="{FF2B5EF4-FFF2-40B4-BE49-F238E27FC236}">
-                <a16:creationId xmlns:a16="http://schemas.microsoft.com/office/drawing/2014/main" id="{E6074176-76AF-4B39-85AC-A15784E0F3E9}"/>
+                <a16:creationId xmlns:a16="http://schemas.microsoft.com/office/drawing/2014/main" id="{C2B324A0-103B-4A30-B2DD-43D1CCF5A11E}"/>
               </a:ext>
             </a:extLst>
           </p:cNvPr>
@@ -14136,7 +14136,7 @@
           <p:cNvPr id="4" name="">
             <a:extLst xmlns:a="http://schemas.openxmlformats.org/drawingml/2006/main">
               <a:ext uri="{FF2B5EF4-FFF2-40B4-BE49-F238E27FC236}">
-                <a16:creationId xmlns:a16="http://schemas.microsoft.com/office/drawing/2014/main" id="{E88D7399-7641-4B9E-968D-0876343923D6}"/>
+                <a16:creationId xmlns:a16="http://schemas.microsoft.com/office/drawing/2014/main" id="{E416F339-6DA5-4091-A668-4FFB388C937D}"/>
               </a:ext>
             </a:extLst>
           </p:cNvPr>
@@ -14260,7 +14260,7 @@
           <p:cNvPr id="5" name="">
             <a:extLst xmlns:a="http://schemas.openxmlformats.org/drawingml/2006/main">
               <a:ext uri="{FF2B5EF4-FFF2-40B4-BE49-F238E27FC236}">
-                <a16:creationId xmlns:a16="http://schemas.microsoft.com/office/drawing/2014/main" id="{EFE1CBFB-FAD5-4B2E-9F81-2461F91DD529}"/>
+                <a16:creationId xmlns:a16="http://schemas.microsoft.com/office/drawing/2014/main" id="{2018E319-1667-4058-8B55-97CB19EF8574}"/>
               </a:ext>
             </a:extLst>
           </p:cNvPr>
@@ -14328,7 +14328,7 @@
           <p:cNvPr id="6" name="">
             <a:extLst xmlns:a="http://schemas.openxmlformats.org/drawingml/2006/main">
               <a:ext uri="{FF2B5EF4-FFF2-40B4-BE49-F238E27FC236}">
-                <a16:creationId xmlns:a16="http://schemas.microsoft.com/office/drawing/2014/main" id="{2B09A0C4-0DBA-4D46-BC11-6891FB89B44E}"/>
+                <a16:creationId xmlns:a16="http://schemas.microsoft.com/office/drawing/2014/main" id="{AF8B15D9-1C3B-4402-9566-16184D736655}"/>
               </a:ext>
             </a:extLst>
           </p:cNvPr>
@@ -14396,7 +14396,7 @@
           <p:cNvPr id="7" name="">
             <a:extLst xmlns:a="http://schemas.openxmlformats.org/drawingml/2006/main">
               <a:ext uri="{FF2B5EF4-FFF2-40B4-BE49-F238E27FC236}">
-                <a16:creationId xmlns:a16="http://schemas.microsoft.com/office/drawing/2014/main" id="{C891C75C-28AB-48C7-81CA-F6EEAA03D563}"/>
+                <a16:creationId xmlns:a16="http://schemas.microsoft.com/office/drawing/2014/main" id="{0EEEBEB7-5995-4D3E-9750-AC592CE6CF99}"/>
               </a:ext>
             </a:extLst>
           </p:cNvPr>
@@ -14464,7 +14464,7 @@
           <p:cNvPr id="8" name="">
             <a:extLst xmlns:a="http://schemas.openxmlformats.org/drawingml/2006/main">
               <a:ext uri="{FF2B5EF4-FFF2-40B4-BE49-F238E27FC236}">
-                <a16:creationId xmlns:a16="http://schemas.microsoft.com/office/drawing/2014/main" id="{C021A7F5-EFB2-42D9-888C-040F068A128C}"/>
+                <a16:creationId xmlns:a16="http://schemas.microsoft.com/office/drawing/2014/main" id="{E99D5FDB-2C8D-4CEB-9FE6-B06610760F76}"/>
               </a:ext>
             </a:extLst>
           </p:cNvPr>
@@ -14532,7 +14532,7 @@
           <p:cNvPr id="9" name="">
             <a:extLst xmlns:a="http://schemas.openxmlformats.org/drawingml/2006/main">
               <a:ext uri="{FF2B5EF4-FFF2-40B4-BE49-F238E27FC236}">
-                <a16:creationId xmlns:a16="http://schemas.microsoft.com/office/drawing/2014/main" id="{39691B9D-C3BB-41F1-9EAB-88F3D104D277}"/>
+                <a16:creationId xmlns:a16="http://schemas.microsoft.com/office/drawing/2014/main" id="{79A55C15-02EE-4B40-93F9-3CF48C4AEF57}"/>
               </a:ext>
             </a:extLst>
           </p:cNvPr>
@@ -14600,7 +14600,7 @@
           <p:cNvPr id="10" name="">
             <a:extLst xmlns:a="http://schemas.openxmlformats.org/drawingml/2006/main">
               <a:ext uri="{FF2B5EF4-FFF2-40B4-BE49-F238E27FC236}">
-                <a16:creationId xmlns:a16="http://schemas.microsoft.com/office/drawing/2014/main" id="{D81FA325-95D1-4B49-96BA-4D7BCD640C90}"/>
+                <a16:creationId xmlns:a16="http://schemas.microsoft.com/office/drawing/2014/main" id="{0A9E46DA-66DE-473F-A099-486F33911204}"/>
               </a:ext>
             </a:extLst>
           </p:cNvPr>
@@ -14666,7 +14666,7 @@
     </p:spTree>
     <p:extLst>
       <p:ext uri="{BB962C8B-B14F-4D97-AF65-F5344CB8AC3E}">
-        <p14:creationId xmlns:p14="http://schemas.microsoft.com/office/powerpoint/2010/main" val="105979203"/>
+        <p14:creationId xmlns:p14="http://schemas.microsoft.com/office/powerpoint/2010/main" val="1092042961"/>
       </p:ext>
     </p:extLst>
   </p:cSld>
@@ -14697,7 +14697,7 @@
           <p:cNvPr id="8" name="">
             <a:extLst xmlns:a="http://schemas.openxmlformats.org/drawingml/2006/main">
               <a:ext uri="{FF2B5EF4-FFF2-40B4-BE49-F238E27FC236}">
-                <a16:creationId xmlns:a16="http://schemas.microsoft.com/office/drawing/2014/main" id="{D845239A-D8E3-4435-8D4B-51C0B09B97D0}"/>
+                <a16:creationId xmlns:a16="http://schemas.microsoft.com/office/drawing/2014/main" id="{F204EF40-323F-4F13-87B7-FF9C0CF5B5B8}"/>
               </a:ext>
             </a:extLst>
           </p:cNvPr>
@@ -14765,7 +14765,7 @@
           <p:cNvPr id="2" name="">
             <a:extLst xmlns:a="http://schemas.openxmlformats.org/drawingml/2006/main">
               <a:ext uri="{FF2B5EF4-FFF2-40B4-BE49-F238E27FC236}">
-                <a16:creationId xmlns:a16="http://schemas.microsoft.com/office/drawing/2014/main" id="{49DFC1E0-69CB-4BAE-BF04-DE6ACC64E4C7}"/>
+                <a16:creationId xmlns:a16="http://schemas.microsoft.com/office/drawing/2014/main" id="{372E59BE-AC17-421F-9DFA-D9EBB98A9794}"/>
               </a:ext>
             </a:extLst>
           </p:cNvPr>
@@ -14833,7 +14833,7 @@
           <p:cNvPr id="3" name="">
             <a:extLst xmlns:a="http://schemas.openxmlformats.org/drawingml/2006/main">
               <a:ext uri="{FF2B5EF4-FFF2-40B4-BE49-F238E27FC236}">
-                <a16:creationId xmlns:a16="http://schemas.microsoft.com/office/drawing/2014/main" id="{D08A4D66-9314-40D4-834A-1F4DED2F4119}"/>
+                <a16:creationId xmlns:a16="http://schemas.microsoft.com/office/drawing/2014/main" id="{53EEB264-84F3-48FA-B1C2-372DA88F94AF}"/>
               </a:ext>
             </a:extLst>
           </p:cNvPr>
@@ -14901,7 +14901,7 @@
           <p:cNvPr id="4" name="">
             <a:extLst xmlns:a="http://schemas.openxmlformats.org/drawingml/2006/main">
               <a:ext uri="{FF2B5EF4-FFF2-40B4-BE49-F238E27FC236}">
-                <a16:creationId xmlns:a16="http://schemas.microsoft.com/office/drawing/2014/main" id="{1BC7EE7D-FCFA-42A5-9A33-B4EA0A631A60}"/>
+                <a16:creationId xmlns:a16="http://schemas.microsoft.com/office/drawing/2014/main" id="{07C58342-6F7E-4717-9764-76073DE680D6}"/>
               </a:ext>
             </a:extLst>
           </p:cNvPr>
@@ -15323,7 +15323,7 @@
           <p:cNvPr id="5" name="">
             <a:extLst xmlns:a="http://schemas.openxmlformats.org/drawingml/2006/main">
               <a:ext uri="{FF2B5EF4-FFF2-40B4-BE49-F238E27FC236}">
-                <a16:creationId xmlns:a16="http://schemas.microsoft.com/office/drawing/2014/main" id="{64E444CD-8241-4CEB-AAB4-493ED6328A21}"/>
+                <a16:creationId xmlns:a16="http://schemas.microsoft.com/office/drawing/2014/main" id="{10332312-62BE-48C9-A05F-3C89D2E2D062}"/>
               </a:ext>
             </a:extLst>
           </p:cNvPr>
@@ -15391,7 +15391,7 @@
           <p:cNvPr id="6" name="">
             <a:extLst xmlns:a="http://schemas.openxmlformats.org/drawingml/2006/main">
               <a:ext uri="{FF2B5EF4-FFF2-40B4-BE49-F238E27FC236}">
-                <a16:creationId xmlns:a16="http://schemas.microsoft.com/office/drawing/2014/main" id="{ECD56AB4-33A4-4E1E-B48A-34D634B2EC41}"/>
+                <a16:creationId xmlns:a16="http://schemas.microsoft.com/office/drawing/2014/main" id="{7AF993A9-5121-4A28-8C49-0DF3B438D825}"/>
               </a:ext>
             </a:extLst>
           </p:cNvPr>
@@ -15459,7 +15459,7 @@
           <p:cNvPr id="7" name="">
             <a:extLst xmlns:a="http://schemas.openxmlformats.org/drawingml/2006/main">
               <a:ext uri="{FF2B5EF4-FFF2-40B4-BE49-F238E27FC236}">
-                <a16:creationId xmlns:a16="http://schemas.microsoft.com/office/drawing/2014/main" id="{517807CC-AF0A-45F9-B828-3D0512547EE3}"/>
+                <a16:creationId xmlns:a16="http://schemas.microsoft.com/office/drawing/2014/main" id="{0CDFAE51-3469-4D38-B444-029918A23CC8}"/>
               </a:ext>
             </a:extLst>
           </p:cNvPr>
@@ -15525,7 +15525,7 @@
     </p:spTree>
     <p:extLst>
       <p:ext uri="{BB962C8B-B14F-4D97-AF65-F5344CB8AC3E}">
-        <p14:creationId xmlns:p14="http://schemas.microsoft.com/office/powerpoint/2010/main" val="1205300107"/>
+        <p14:creationId xmlns:p14="http://schemas.microsoft.com/office/powerpoint/2010/main" val="1572109705"/>
       </p:ext>
     </p:extLst>
   </p:cSld>

</xml_diff>